<commit_message>
Final versions of week 10 materials, plus removal of attendance codes from slides
</commit_message>
<xml_diff>
--- a/slides/ECS8052 Week 7 2025-11-03.pptx
+++ b/slides/ECS8052 Week 7 2025-11-03.pptx
@@ -5,28 +5,27 @@
     <p:sldMasterId id="2147483660" r:id="rId1"/>
   </p:sldMasterIdLst>
   <p:notesMasterIdLst>
-    <p:notesMasterId r:id="rId18"/>
+    <p:notesMasterId r:id="rId17"/>
   </p:notesMasterIdLst>
   <p:handoutMasterIdLst>
-    <p:handoutMasterId r:id="rId19"/>
+    <p:handoutMasterId r:id="rId18"/>
   </p:handoutMasterIdLst>
   <p:sldIdLst>
-    <p:sldId id="322" r:id="rId2"/>
-    <p:sldId id="369" r:id="rId3"/>
-    <p:sldId id="320" r:id="rId4"/>
-    <p:sldId id="323" r:id="rId5"/>
-    <p:sldId id="324" r:id="rId6"/>
-    <p:sldId id="325" r:id="rId7"/>
-    <p:sldId id="326" r:id="rId8"/>
-    <p:sldId id="329" r:id="rId9"/>
-    <p:sldId id="330" r:id="rId10"/>
-    <p:sldId id="327" r:id="rId11"/>
-    <p:sldId id="328" r:id="rId12"/>
-    <p:sldId id="331" r:id="rId13"/>
-    <p:sldId id="364" r:id="rId14"/>
-    <p:sldId id="365" r:id="rId15"/>
-    <p:sldId id="366" r:id="rId16"/>
-    <p:sldId id="367" r:id="rId17"/>
+    <p:sldId id="369" r:id="rId2"/>
+    <p:sldId id="320" r:id="rId3"/>
+    <p:sldId id="323" r:id="rId4"/>
+    <p:sldId id="324" r:id="rId5"/>
+    <p:sldId id="325" r:id="rId6"/>
+    <p:sldId id="326" r:id="rId7"/>
+    <p:sldId id="329" r:id="rId8"/>
+    <p:sldId id="330" r:id="rId9"/>
+    <p:sldId id="327" r:id="rId10"/>
+    <p:sldId id="328" r:id="rId11"/>
+    <p:sldId id="331" r:id="rId12"/>
+    <p:sldId id="364" r:id="rId13"/>
+    <p:sldId id="365" r:id="rId14"/>
+    <p:sldId id="366" r:id="rId15"/>
+    <p:sldId id="367" r:id="rId16"/>
   </p:sldIdLst>
   <p:sldSz cx="12192000" cy="6858000"/>
   <p:notesSz cx="6858000" cy="9144000"/>
@@ -158,142 +157,21 @@
 </p:presentation>
 </file>
 
-<file path=ppt/revisionInfo.xml><?xml version="1.0" encoding="utf-8"?>
-<p1510:revInfo xmlns:a="http://schemas.openxmlformats.org/drawingml/2006/main" xmlns:r="http://schemas.openxmlformats.org/officeDocument/2006/relationships" xmlns:p1510="http://schemas.microsoft.com/office/powerpoint/2015/10/main">
-  <p1510:revLst>
-    <p1510:client id="{408C390D-C9AD-E44F-A86A-EA9EEFC4BC0F}" v="3" dt="2025-11-03T15:59:09.569"/>
-  </p1510:revLst>
-</p1510:revInfo>
-</file>
-
 <file path=ppt/changesInfos/changesInfo1.xml><?xml version="1.0" encoding="utf-8"?>
 <pc:chgInfo xmlns:a="http://schemas.openxmlformats.org/drawingml/2006/main" xmlns:r="http://schemas.openxmlformats.org/officeDocument/2006/relationships" xmlns:ac="http://schemas.microsoft.com/office/drawing/2013/main/command" xmlns:pc="http://schemas.microsoft.com/office/powerpoint/2013/main/command">
   <pc:docChgLst>
     <pc:chgData name="Iain Styles" userId="befbdaae-53f8-4d26-a8dc-3366b09f768a" providerId="ADAL" clId="{5E0D2633-D8F6-500D-A7FC-C9CB56BC4BFB}"/>
     <pc:docChg chg="custSel addSld delSld modSld">
-      <pc:chgData name="Iain Styles" userId="befbdaae-53f8-4d26-a8dc-3366b09f768a" providerId="ADAL" clId="{5E0D2633-D8F6-500D-A7FC-C9CB56BC4BFB}" dt="2025-11-03T15:59:09.567" v="90"/>
+      <pc:chgData name="Iain Styles" userId="befbdaae-53f8-4d26-a8dc-3366b09f768a" providerId="ADAL" clId="{5E0D2633-D8F6-500D-A7FC-C9CB56BC4BFB}" dt="2025-11-20T07:13:25.493" v="91" actId="2696"/>
       <pc:docMkLst>
         <pc:docMk/>
       </pc:docMkLst>
-      <pc:sldChg chg="del">
-        <pc:chgData name="Iain Styles" userId="befbdaae-53f8-4d26-a8dc-3366b09f768a" providerId="ADAL" clId="{5E0D2633-D8F6-500D-A7FC-C9CB56BC4BFB}" dt="2025-11-02T20:36:54.621" v="68" actId="2696"/>
-        <pc:sldMkLst>
-          <pc:docMk/>
-          <pc:sldMk cId="4150415409" sldId="291"/>
-        </pc:sldMkLst>
-      </pc:sldChg>
-      <pc:sldChg chg="del">
-        <pc:chgData name="Iain Styles" userId="befbdaae-53f8-4d26-a8dc-3366b09f768a" providerId="ADAL" clId="{5E0D2633-D8F6-500D-A7FC-C9CB56BC4BFB}" dt="2025-11-02T20:36:54.610" v="63" actId="2696"/>
-        <pc:sldMkLst>
-          <pc:docMk/>
-          <pc:sldMk cId="1421539638" sldId="292"/>
-        </pc:sldMkLst>
-      </pc:sldChg>
-      <pc:sldChg chg="del">
-        <pc:chgData name="Iain Styles" userId="befbdaae-53f8-4d26-a8dc-3366b09f768a" providerId="ADAL" clId="{5E0D2633-D8F6-500D-A7FC-C9CB56BC4BFB}" dt="2025-11-02T20:36:54.623" v="69" actId="2696"/>
-        <pc:sldMkLst>
-          <pc:docMk/>
-          <pc:sldMk cId="1470489183" sldId="293"/>
-        </pc:sldMkLst>
-      </pc:sldChg>
-      <pc:sldChg chg="del">
-        <pc:chgData name="Iain Styles" userId="befbdaae-53f8-4d26-a8dc-3366b09f768a" providerId="ADAL" clId="{5E0D2633-D8F6-500D-A7FC-C9CB56BC4BFB}" dt="2025-11-02T20:36:54.596" v="57" actId="2696"/>
-        <pc:sldMkLst>
-          <pc:docMk/>
-          <pc:sldMk cId="398589300" sldId="294"/>
-        </pc:sldMkLst>
-      </pc:sldChg>
-      <pc:sldChg chg="del">
-        <pc:chgData name="Iain Styles" userId="befbdaae-53f8-4d26-a8dc-3366b09f768a" providerId="ADAL" clId="{5E0D2633-D8F6-500D-A7FC-C9CB56BC4BFB}" dt="2025-11-02T20:36:54.643" v="73" actId="2696"/>
-        <pc:sldMkLst>
-          <pc:docMk/>
-          <pc:sldMk cId="1411185995" sldId="295"/>
-        </pc:sldMkLst>
-      </pc:sldChg>
-      <pc:sldChg chg="del">
-        <pc:chgData name="Iain Styles" userId="befbdaae-53f8-4d26-a8dc-3366b09f768a" providerId="ADAL" clId="{5E0D2633-D8F6-500D-A7FC-C9CB56BC4BFB}" dt="2025-11-02T20:36:54.665" v="84" actId="2696"/>
-        <pc:sldMkLst>
-          <pc:docMk/>
-          <pc:sldMk cId="1032005304" sldId="296"/>
-        </pc:sldMkLst>
-      </pc:sldChg>
-      <pc:sldChg chg="del">
-        <pc:chgData name="Iain Styles" userId="befbdaae-53f8-4d26-a8dc-3366b09f768a" providerId="ADAL" clId="{5E0D2633-D8F6-500D-A7FC-C9CB56BC4BFB}" dt="2025-11-02T20:36:54.653" v="75" actId="2696"/>
-        <pc:sldMkLst>
-          <pc:docMk/>
-          <pc:sldMk cId="2457757937" sldId="297"/>
-        </pc:sldMkLst>
-      </pc:sldChg>
-      <pc:sldChg chg="del">
-        <pc:chgData name="Iain Styles" userId="befbdaae-53f8-4d26-a8dc-3366b09f768a" providerId="ADAL" clId="{5E0D2633-D8F6-500D-A7FC-C9CB56BC4BFB}" dt="2025-11-02T20:36:54.612" v="64" actId="2696"/>
-        <pc:sldMkLst>
-          <pc:docMk/>
-          <pc:sldMk cId="4015322719" sldId="298"/>
-        </pc:sldMkLst>
-      </pc:sldChg>
-      <pc:sldChg chg="del">
-        <pc:chgData name="Iain Styles" userId="befbdaae-53f8-4d26-a8dc-3366b09f768a" providerId="ADAL" clId="{5E0D2633-D8F6-500D-A7FC-C9CB56BC4BFB}" dt="2025-11-02T20:36:54.650" v="74" actId="2696"/>
-        <pc:sldMkLst>
-          <pc:docMk/>
-          <pc:sldMk cId="3755702930" sldId="299"/>
-        </pc:sldMkLst>
-      </pc:sldChg>
-      <pc:sldChg chg="del">
-        <pc:chgData name="Iain Styles" userId="befbdaae-53f8-4d26-a8dc-3366b09f768a" providerId="ADAL" clId="{5E0D2633-D8F6-500D-A7FC-C9CB56BC4BFB}" dt="2025-11-02T20:36:54.624" v="70" actId="2696"/>
-        <pc:sldMkLst>
-          <pc:docMk/>
-          <pc:sldMk cId="3481623430" sldId="300"/>
-        </pc:sldMkLst>
-      </pc:sldChg>
-      <pc:sldChg chg="del">
-        <pc:chgData name="Iain Styles" userId="befbdaae-53f8-4d26-a8dc-3366b09f768a" providerId="ADAL" clId="{5E0D2633-D8F6-500D-A7FC-C9CB56BC4BFB}" dt="2025-11-02T20:36:54.660" v="82" actId="2696"/>
-        <pc:sldMkLst>
-          <pc:docMk/>
-          <pc:sldMk cId="3634755612" sldId="301"/>
-        </pc:sldMkLst>
-      </pc:sldChg>
-      <pc:sldChg chg="del">
-        <pc:chgData name="Iain Styles" userId="befbdaae-53f8-4d26-a8dc-3366b09f768a" providerId="ADAL" clId="{5E0D2633-D8F6-500D-A7FC-C9CB56BC4BFB}" dt="2025-11-02T20:36:54.657" v="79" actId="2696"/>
-        <pc:sldMkLst>
-          <pc:docMk/>
-          <pc:sldMk cId="1003291711" sldId="302"/>
-        </pc:sldMkLst>
-      </pc:sldChg>
-      <pc:sldChg chg="del">
-        <pc:chgData name="Iain Styles" userId="befbdaae-53f8-4d26-a8dc-3366b09f768a" providerId="ADAL" clId="{5E0D2633-D8F6-500D-A7FC-C9CB56BC4BFB}" dt="2025-11-02T20:36:54.601" v="59" actId="2696"/>
-        <pc:sldMkLst>
-          <pc:docMk/>
-          <pc:sldMk cId="1927035365" sldId="303"/>
-        </pc:sldMkLst>
-      </pc:sldChg>
-      <pc:sldChg chg="del">
-        <pc:chgData name="Iain Styles" userId="befbdaae-53f8-4d26-a8dc-3366b09f768a" providerId="ADAL" clId="{5E0D2633-D8F6-500D-A7FC-C9CB56BC4BFB}" dt="2025-11-02T20:36:54.624" v="71" actId="2696"/>
-        <pc:sldMkLst>
-          <pc:docMk/>
-          <pc:sldMk cId="3598441698" sldId="305"/>
-        </pc:sldMkLst>
-      </pc:sldChg>
-      <pc:sldChg chg="del">
-        <pc:chgData name="Iain Styles" userId="befbdaae-53f8-4d26-a8dc-3366b09f768a" providerId="ADAL" clId="{5E0D2633-D8F6-500D-A7FC-C9CB56BC4BFB}" dt="2025-11-02T20:36:54.586" v="53" actId="2696"/>
-        <pc:sldMkLst>
-          <pc:docMk/>
-          <pc:sldMk cId="532022837" sldId="306"/>
-        </pc:sldMkLst>
-      </pc:sldChg>
-      <pc:sldChg chg="addSp delSp modSp mod chgLayout">
-        <pc:chgData name="Iain Styles" userId="befbdaae-53f8-4d26-a8dc-3366b09f768a" providerId="ADAL" clId="{5E0D2633-D8F6-500D-A7FC-C9CB56BC4BFB}" dt="2025-11-01T17:00:50.820" v="14" actId="1076"/>
+      <pc:sldChg chg="addSp delSp modSp del mod chgLayout">
+        <pc:chgData name="Iain Styles" userId="befbdaae-53f8-4d26-a8dc-3366b09f768a" providerId="ADAL" clId="{5E0D2633-D8F6-500D-A7FC-C9CB56BC4BFB}" dt="2025-11-20T07:13:25.493" v="91" actId="2696"/>
         <pc:sldMkLst>
           <pc:docMk/>
           <pc:sldMk cId="1861590098" sldId="322"/>
         </pc:sldMkLst>
-        <pc:picChg chg="add mod">
-          <ac:chgData name="Iain Styles" userId="befbdaae-53f8-4d26-a8dc-3366b09f768a" providerId="ADAL" clId="{5E0D2633-D8F6-500D-A7FC-C9CB56BC4BFB}" dt="2025-11-01T17:00:50.820" v="14" actId="1076"/>
-          <ac:picMkLst>
-            <pc:docMk/>
-            <pc:sldMk cId="1861590098" sldId="322"/>
-            <ac:picMk id="9" creationId="{1EE68711-7769-3453-19DD-2CCC9433D1AE}"/>
-          </ac:picMkLst>
-        </pc:picChg>
       </pc:sldChg>
       <pc:sldChg chg="addSp delSp mod">
         <pc:chgData name="Iain Styles" userId="befbdaae-53f8-4d26-a8dc-3366b09f768a" providerId="ADAL" clId="{5E0D2633-D8F6-500D-A7FC-C9CB56BC4BFB}" dt="2025-11-03T15:04:40.549" v="88"/>
@@ -307,14 +185,6 @@
             <pc:docMk/>
             <pc:sldMk cId="3396066720" sldId="324"/>
             <ac:inkMk id="3" creationId="{40EC0CE9-5C6D-17BD-79B7-F6C9AD32A760}"/>
-          </ac:inkMkLst>
-        </pc:inkChg>
-        <pc:inkChg chg="del">
-          <ac:chgData name="Iain Styles" userId="befbdaae-53f8-4d26-a8dc-3366b09f768a" providerId="ADAL" clId="{5E0D2633-D8F6-500D-A7FC-C9CB56BC4BFB}" dt="2025-11-02T20:33:27.108" v="17" actId="478"/>
-          <ac:inkMkLst>
-            <pc:docMk/>
-            <pc:sldMk cId="3396066720" sldId="324"/>
-            <ac:inkMk id="5" creationId="{AB61A209-D56E-A634-7407-B1A080371D24}"/>
           </ac:inkMkLst>
         </pc:inkChg>
       </pc:sldChg>
@@ -332,14 +202,6 @@
             <ac:inkMk id="5" creationId="{8251D983-96E4-1FD8-7CFE-E515FB702ADE}"/>
           </ac:inkMkLst>
         </pc:inkChg>
-        <pc:inkChg chg="del">
-          <ac:chgData name="Iain Styles" userId="befbdaae-53f8-4d26-a8dc-3366b09f768a" providerId="ADAL" clId="{5E0D2633-D8F6-500D-A7FC-C9CB56BC4BFB}" dt="2025-11-02T20:33:33.504" v="18" actId="478"/>
-          <ac:inkMkLst>
-            <pc:docMk/>
-            <pc:sldMk cId="44866960" sldId="325"/>
-            <ac:inkMk id="6" creationId="{20B9ECA3-4D75-7FDE-CB75-398E0BDB61A6}"/>
-          </ac:inkMkLst>
-        </pc:inkChg>
       </pc:sldChg>
       <pc:sldChg chg="addSp delSp mod">
         <pc:chgData name="Iain Styles" userId="befbdaae-53f8-4d26-a8dc-3366b09f768a" providerId="ADAL" clId="{5E0D2633-D8F6-500D-A7FC-C9CB56BC4BFB}" dt="2025-11-03T15:04:40.549" v="88"/>
@@ -355,14 +217,6 @@
             <ac:inkMk id="5" creationId="{E0CF74BA-808A-FDD6-CFBF-33E3B642E341}"/>
           </ac:inkMkLst>
         </pc:inkChg>
-        <pc:inkChg chg="del">
-          <ac:chgData name="Iain Styles" userId="befbdaae-53f8-4d26-a8dc-3366b09f768a" providerId="ADAL" clId="{5E0D2633-D8F6-500D-A7FC-C9CB56BC4BFB}" dt="2025-11-02T20:33:36.838" v="19" actId="478"/>
-          <ac:inkMkLst>
-            <pc:docMk/>
-            <pc:sldMk cId="1108801280" sldId="326"/>
-            <ac:inkMk id="6" creationId="{EE7D725C-01E8-4256-502F-3E068787260E}"/>
-          </ac:inkMkLst>
-        </pc:inkChg>
       </pc:sldChg>
       <pc:sldChg chg="addSp delSp mod">
         <pc:chgData name="Iain Styles" userId="befbdaae-53f8-4d26-a8dc-3366b09f768a" providerId="ADAL" clId="{5E0D2633-D8F6-500D-A7FC-C9CB56BC4BFB}" dt="2025-11-03T15:04:40.549" v="88"/>
@@ -376,14 +230,6 @@
             <pc:docMk/>
             <pc:sldMk cId="2465979426" sldId="327"/>
             <ac:inkMk id="5" creationId="{50E4995C-95F0-54EA-EB36-A5B2F5038B7E}"/>
-          </ac:inkMkLst>
-        </pc:inkChg>
-        <pc:inkChg chg="del">
-          <ac:chgData name="Iain Styles" userId="befbdaae-53f8-4d26-a8dc-3366b09f768a" providerId="ADAL" clId="{5E0D2633-D8F6-500D-A7FC-C9CB56BC4BFB}" dt="2025-11-02T20:33:44.932" v="22" actId="478"/>
-          <ac:inkMkLst>
-            <pc:docMk/>
-            <pc:sldMk cId="2465979426" sldId="327"/>
-            <ac:inkMk id="6" creationId="{AA0CA238-874E-E6C7-EDF7-F81916DD1B42}"/>
           </ac:inkMkLst>
         </pc:inkChg>
       </pc:sldChg>
@@ -416,14 +262,6 @@
             <ac:inkMk id="5" creationId="{EFE1B52C-88EE-A635-227B-F1CF5FB2EF1C}"/>
           </ac:inkMkLst>
         </pc:inkChg>
-        <pc:inkChg chg="del">
-          <ac:chgData name="Iain Styles" userId="befbdaae-53f8-4d26-a8dc-3366b09f768a" providerId="ADAL" clId="{5E0D2633-D8F6-500D-A7FC-C9CB56BC4BFB}" dt="2025-11-02T20:33:39.807" v="20" actId="478"/>
-          <ac:inkMkLst>
-            <pc:docMk/>
-            <pc:sldMk cId="531585526" sldId="329"/>
-            <ac:inkMk id="6" creationId="{37740E3D-886F-AB15-842B-B66BDA22411C}"/>
-          </ac:inkMkLst>
-        </pc:inkChg>
       </pc:sldChg>
       <pc:sldChg chg="addSp delSp mod">
         <pc:chgData name="Iain Styles" userId="befbdaae-53f8-4d26-a8dc-3366b09f768a" providerId="ADAL" clId="{5E0D2633-D8F6-500D-A7FC-C9CB56BC4BFB}" dt="2025-11-03T15:04:40.549" v="88"/>
@@ -439,225 +277,12 @@
             <ac:inkMk id="5" creationId="{6096DA8E-B4CE-70DA-2C74-A094A935BDF0}"/>
           </ac:inkMkLst>
         </pc:inkChg>
-        <pc:inkChg chg="del">
-          <ac:chgData name="Iain Styles" userId="befbdaae-53f8-4d26-a8dc-3366b09f768a" providerId="ADAL" clId="{5E0D2633-D8F6-500D-A7FC-C9CB56BC4BFB}" dt="2025-11-02T20:33:42.150" v="21" actId="478"/>
-          <ac:inkMkLst>
-            <pc:docMk/>
-            <pc:sldMk cId="528797184" sldId="330"/>
-            <ac:inkMk id="6" creationId="{89807593-A13F-8843-D698-B7ED9C4127CC}"/>
-          </ac:inkMkLst>
-        </pc:inkChg>
       </pc:sldChg>
       <pc:sldChg chg="delSp mod">
         <pc:chgData name="Iain Styles" userId="befbdaae-53f8-4d26-a8dc-3366b09f768a" providerId="ADAL" clId="{5E0D2633-D8F6-500D-A7FC-C9CB56BC4BFB}" dt="2025-11-02T20:36:07.302" v="39" actId="478"/>
         <pc:sldMkLst>
           <pc:docMk/>
           <pc:sldMk cId="2239609288" sldId="331"/>
-        </pc:sldMkLst>
-        <pc:inkChg chg="del">
-          <ac:chgData name="Iain Styles" userId="befbdaae-53f8-4d26-a8dc-3366b09f768a" providerId="ADAL" clId="{5E0D2633-D8F6-500D-A7FC-C9CB56BC4BFB}" dt="2025-11-02T20:36:07.302" v="39" actId="478"/>
-          <ac:inkMkLst>
-            <pc:docMk/>
-            <pc:sldMk cId="2239609288" sldId="331"/>
-            <ac:inkMk id="5" creationId="{F8306DE7-B616-C615-C089-AE1DD4CBF2AE}"/>
-          </ac:inkMkLst>
-        </pc:inkChg>
-      </pc:sldChg>
-      <pc:sldChg chg="del">
-        <pc:chgData name="Iain Styles" userId="befbdaae-53f8-4d26-a8dc-3366b09f768a" providerId="ADAL" clId="{5E0D2633-D8F6-500D-A7FC-C9CB56BC4BFB}" dt="2025-11-02T20:36:54.597" v="58" actId="2696"/>
-        <pc:sldMkLst>
-          <pc:docMk/>
-          <pc:sldMk cId="1295137677" sldId="332"/>
-        </pc:sldMkLst>
-      </pc:sldChg>
-      <pc:sldChg chg="del">
-        <pc:chgData name="Iain Styles" userId="befbdaae-53f8-4d26-a8dc-3366b09f768a" providerId="ADAL" clId="{5E0D2633-D8F6-500D-A7FC-C9CB56BC4BFB}" dt="2025-11-02T20:36:54.583" v="49" actId="2696"/>
-        <pc:sldMkLst>
-          <pc:docMk/>
-          <pc:sldMk cId="2893750671" sldId="333"/>
-        </pc:sldMkLst>
-      </pc:sldChg>
-      <pc:sldChg chg="del">
-        <pc:chgData name="Iain Styles" userId="befbdaae-53f8-4d26-a8dc-3366b09f768a" providerId="ADAL" clId="{5E0D2633-D8F6-500D-A7FC-C9CB56BC4BFB}" dt="2025-11-02T20:36:54.654" v="76" actId="2696"/>
-        <pc:sldMkLst>
-          <pc:docMk/>
-          <pc:sldMk cId="706825791" sldId="334"/>
-        </pc:sldMkLst>
-      </pc:sldChg>
-      <pc:sldChg chg="del">
-        <pc:chgData name="Iain Styles" userId="befbdaae-53f8-4d26-a8dc-3366b09f768a" providerId="ADAL" clId="{5E0D2633-D8F6-500D-A7FC-C9CB56BC4BFB}" dt="2025-11-02T20:36:54.620" v="66" actId="2696"/>
-        <pc:sldMkLst>
-          <pc:docMk/>
-          <pc:sldMk cId="1108906673" sldId="335"/>
-        </pc:sldMkLst>
-      </pc:sldChg>
-      <pc:sldChg chg="modSp del mod">
-        <pc:chgData name="Iain Styles" userId="befbdaae-53f8-4d26-a8dc-3366b09f768a" providerId="ADAL" clId="{5E0D2633-D8F6-500D-A7FC-C9CB56BC4BFB}" dt="2025-11-02T20:36:54.602" v="60" actId="2696"/>
-        <pc:sldMkLst>
-          <pc:docMk/>
-          <pc:sldMk cId="1192690409" sldId="336"/>
-        </pc:sldMkLst>
-        <pc:spChg chg="mod">
-          <ac:chgData name="Iain Styles" userId="befbdaae-53f8-4d26-a8dc-3366b09f768a" providerId="ADAL" clId="{5E0D2633-D8F6-500D-A7FC-C9CB56BC4BFB}" dt="2025-11-02T14:49:06.382" v="15" actId="20577"/>
-          <ac:spMkLst>
-            <pc:docMk/>
-            <pc:sldMk cId="1192690409" sldId="336"/>
-            <ac:spMk id="3" creationId="{D9FB5485-AE59-70D4-983D-02F6DCB751E6}"/>
-          </ac:spMkLst>
-        </pc:spChg>
-      </pc:sldChg>
-      <pc:sldChg chg="del">
-        <pc:chgData name="Iain Styles" userId="befbdaae-53f8-4d26-a8dc-3366b09f768a" providerId="ADAL" clId="{5E0D2633-D8F6-500D-A7FC-C9CB56BC4BFB}" dt="2025-11-02T20:36:54.656" v="78" actId="2696"/>
-        <pc:sldMkLst>
-          <pc:docMk/>
-          <pc:sldMk cId="1391420118" sldId="337"/>
-        </pc:sldMkLst>
-      </pc:sldChg>
-      <pc:sldChg chg="del">
-        <pc:chgData name="Iain Styles" userId="befbdaae-53f8-4d26-a8dc-3366b09f768a" providerId="ADAL" clId="{5E0D2633-D8F6-500D-A7FC-C9CB56BC4BFB}" dt="2025-11-02T20:36:54.658" v="80" actId="2696"/>
-        <pc:sldMkLst>
-          <pc:docMk/>
-          <pc:sldMk cId="3348058539" sldId="339"/>
-        </pc:sldMkLst>
-      </pc:sldChg>
-      <pc:sldChg chg="del">
-        <pc:chgData name="Iain Styles" userId="befbdaae-53f8-4d26-a8dc-3366b09f768a" providerId="ADAL" clId="{5E0D2633-D8F6-500D-A7FC-C9CB56BC4BFB}" dt="2025-11-02T20:36:54.585" v="52" actId="2696"/>
-        <pc:sldMkLst>
-          <pc:docMk/>
-          <pc:sldMk cId="2023637604" sldId="340"/>
-        </pc:sldMkLst>
-      </pc:sldChg>
-      <pc:sldChg chg="del">
-        <pc:chgData name="Iain Styles" userId="befbdaae-53f8-4d26-a8dc-3366b09f768a" providerId="ADAL" clId="{5E0D2633-D8F6-500D-A7FC-C9CB56BC4BFB}" dt="2025-11-02T20:36:54.664" v="83" actId="2696"/>
-        <pc:sldMkLst>
-          <pc:docMk/>
-          <pc:sldMk cId="1416495267" sldId="341"/>
-        </pc:sldMkLst>
-      </pc:sldChg>
-      <pc:sldChg chg="del">
-        <pc:chgData name="Iain Styles" userId="befbdaae-53f8-4d26-a8dc-3366b09f768a" providerId="ADAL" clId="{5E0D2633-D8F6-500D-A7FC-C9CB56BC4BFB}" dt="2025-11-02T20:36:54.656" v="77" actId="2696"/>
-        <pc:sldMkLst>
-          <pc:docMk/>
-          <pc:sldMk cId="375445054" sldId="342"/>
-        </pc:sldMkLst>
-      </pc:sldChg>
-      <pc:sldChg chg="del">
-        <pc:chgData name="Iain Styles" userId="befbdaae-53f8-4d26-a8dc-3366b09f768a" providerId="ADAL" clId="{5E0D2633-D8F6-500D-A7FC-C9CB56BC4BFB}" dt="2025-11-02T20:36:54.659" v="81" actId="2696"/>
-        <pc:sldMkLst>
-          <pc:docMk/>
-          <pc:sldMk cId="244596629" sldId="343"/>
-        </pc:sldMkLst>
-      </pc:sldChg>
-      <pc:sldChg chg="del">
-        <pc:chgData name="Iain Styles" userId="befbdaae-53f8-4d26-a8dc-3366b09f768a" providerId="ADAL" clId="{5E0D2633-D8F6-500D-A7FC-C9CB56BC4BFB}" dt="2025-11-02T20:36:54.624" v="72" actId="2696"/>
-        <pc:sldMkLst>
-          <pc:docMk/>
-          <pc:sldMk cId="1594239815" sldId="344"/>
-        </pc:sldMkLst>
-      </pc:sldChg>
-      <pc:sldChg chg="del">
-        <pc:chgData name="Iain Styles" userId="befbdaae-53f8-4d26-a8dc-3366b09f768a" providerId="ADAL" clId="{5E0D2633-D8F6-500D-A7FC-C9CB56BC4BFB}" dt="2025-11-02T20:36:54.596" v="56" actId="2696"/>
-        <pc:sldMkLst>
-          <pc:docMk/>
-          <pc:sldMk cId="2668555977" sldId="345"/>
-        </pc:sldMkLst>
-      </pc:sldChg>
-      <pc:sldChg chg="del">
-        <pc:chgData name="Iain Styles" userId="befbdaae-53f8-4d26-a8dc-3366b09f768a" providerId="ADAL" clId="{5E0D2633-D8F6-500D-A7FC-C9CB56BC4BFB}" dt="2025-11-02T20:36:54.586" v="54" actId="2696"/>
-        <pc:sldMkLst>
-          <pc:docMk/>
-          <pc:sldMk cId="1020247238" sldId="346"/>
-        </pc:sldMkLst>
-      </pc:sldChg>
-      <pc:sldChg chg="del">
-        <pc:chgData name="Iain Styles" userId="befbdaae-53f8-4d26-a8dc-3366b09f768a" providerId="ADAL" clId="{5E0D2633-D8F6-500D-A7FC-C9CB56BC4BFB}" dt="2025-11-02T20:36:54.621" v="67" actId="2696"/>
-        <pc:sldMkLst>
-          <pc:docMk/>
-          <pc:sldMk cId="1681669975" sldId="347"/>
-        </pc:sldMkLst>
-      </pc:sldChg>
-      <pc:sldChg chg="del">
-        <pc:chgData name="Iain Styles" userId="befbdaae-53f8-4d26-a8dc-3366b09f768a" providerId="ADAL" clId="{5E0D2633-D8F6-500D-A7FC-C9CB56BC4BFB}" dt="2025-11-02T20:36:54.584" v="50" actId="2696"/>
-        <pc:sldMkLst>
-          <pc:docMk/>
-          <pc:sldMk cId="1352793453" sldId="348"/>
-        </pc:sldMkLst>
-      </pc:sldChg>
-      <pc:sldChg chg="del">
-        <pc:chgData name="Iain Styles" userId="befbdaae-53f8-4d26-a8dc-3366b09f768a" providerId="ADAL" clId="{5E0D2633-D8F6-500D-A7FC-C9CB56BC4BFB}" dt="2025-11-02T20:36:54.610" v="62" actId="2696"/>
-        <pc:sldMkLst>
-          <pc:docMk/>
-          <pc:sldMk cId="2108666997" sldId="349"/>
-        </pc:sldMkLst>
-      </pc:sldChg>
-      <pc:sldChg chg="del">
-        <pc:chgData name="Iain Styles" userId="befbdaae-53f8-4d26-a8dc-3366b09f768a" providerId="ADAL" clId="{5E0D2633-D8F6-500D-A7FC-C9CB56BC4BFB}" dt="2025-11-02T20:35:28.550" v="29" actId="2696"/>
-        <pc:sldMkLst>
-          <pc:docMk/>
-          <pc:sldMk cId="582384582" sldId="354"/>
-        </pc:sldMkLst>
-      </pc:sldChg>
-      <pc:sldChg chg="del">
-        <pc:chgData name="Iain Styles" userId="befbdaae-53f8-4d26-a8dc-3366b09f768a" providerId="ADAL" clId="{5E0D2633-D8F6-500D-A7FC-C9CB56BC4BFB}" dt="2025-11-02T20:36:03.778" v="38" actId="2696"/>
-        <pc:sldMkLst>
-          <pc:docMk/>
-          <pc:sldMk cId="3429086437" sldId="355"/>
-        </pc:sldMkLst>
-      </pc:sldChg>
-      <pc:sldChg chg="del">
-        <pc:chgData name="Iain Styles" userId="befbdaae-53f8-4d26-a8dc-3366b09f768a" providerId="ADAL" clId="{5E0D2633-D8F6-500D-A7FC-C9CB56BC4BFB}" dt="2025-11-02T20:36:03.777" v="37" actId="2696"/>
-        <pc:sldMkLst>
-          <pc:docMk/>
-          <pc:sldMk cId="715396262" sldId="356"/>
-        </pc:sldMkLst>
-      </pc:sldChg>
-      <pc:sldChg chg="del">
-        <pc:chgData name="Iain Styles" userId="befbdaae-53f8-4d26-a8dc-3366b09f768a" providerId="ADAL" clId="{5E0D2633-D8F6-500D-A7FC-C9CB56BC4BFB}" dt="2025-11-02T20:36:03.777" v="36" actId="2696"/>
-        <pc:sldMkLst>
-          <pc:docMk/>
-          <pc:sldMk cId="321988716" sldId="357"/>
-        </pc:sldMkLst>
-      </pc:sldChg>
-      <pc:sldChg chg="del">
-        <pc:chgData name="Iain Styles" userId="befbdaae-53f8-4d26-a8dc-3366b09f768a" providerId="ADAL" clId="{5E0D2633-D8F6-500D-A7FC-C9CB56BC4BFB}" dt="2025-11-02T20:36:03.776" v="35" actId="2696"/>
-        <pc:sldMkLst>
-          <pc:docMk/>
-          <pc:sldMk cId="1516791949" sldId="358"/>
-        </pc:sldMkLst>
-      </pc:sldChg>
-      <pc:sldChg chg="del">
-        <pc:chgData name="Iain Styles" userId="befbdaae-53f8-4d26-a8dc-3366b09f768a" providerId="ADAL" clId="{5E0D2633-D8F6-500D-A7FC-C9CB56BC4BFB}" dt="2025-11-02T20:36:03.776" v="34" actId="2696"/>
-        <pc:sldMkLst>
-          <pc:docMk/>
-          <pc:sldMk cId="2439280951" sldId="359"/>
-        </pc:sldMkLst>
-      </pc:sldChg>
-      <pc:sldChg chg="del">
-        <pc:chgData name="Iain Styles" userId="befbdaae-53f8-4d26-a8dc-3366b09f768a" providerId="ADAL" clId="{5E0D2633-D8F6-500D-A7FC-C9CB56BC4BFB}" dt="2025-11-02T20:36:03.775" v="33" actId="2696"/>
-        <pc:sldMkLst>
-          <pc:docMk/>
-          <pc:sldMk cId="1793932802" sldId="360"/>
-        </pc:sldMkLst>
-      </pc:sldChg>
-      <pc:sldChg chg="del">
-        <pc:chgData name="Iain Styles" userId="befbdaae-53f8-4d26-a8dc-3366b09f768a" providerId="ADAL" clId="{5E0D2633-D8F6-500D-A7FC-C9CB56BC4BFB}" dt="2025-11-02T20:36:03.774" v="32" actId="2696"/>
-        <pc:sldMkLst>
-          <pc:docMk/>
-          <pc:sldMk cId="3594010606" sldId="361"/>
-        </pc:sldMkLst>
-      </pc:sldChg>
-      <pc:sldChg chg="del">
-        <pc:chgData name="Iain Styles" userId="befbdaae-53f8-4d26-a8dc-3366b09f768a" providerId="ADAL" clId="{5E0D2633-D8F6-500D-A7FC-C9CB56BC4BFB}" dt="2025-11-02T20:36:03.773" v="31" actId="2696"/>
-        <pc:sldMkLst>
-          <pc:docMk/>
-          <pc:sldMk cId="1931697778" sldId="362"/>
-        </pc:sldMkLst>
-      </pc:sldChg>
-      <pc:sldChg chg="del">
-        <pc:chgData name="Iain Styles" userId="befbdaae-53f8-4d26-a8dc-3366b09f768a" providerId="ADAL" clId="{5E0D2633-D8F6-500D-A7FC-C9CB56BC4BFB}" dt="2025-11-02T20:36:03.764" v="30" actId="2696"/>
-        <pc:sldMkLst>
-          <pc:docMk/>
-          <pc:sldMk cId="4047013406" sldId="363"/>
         </pc:sldMkLst>
       </pc:sldChg>
       <pc:sldChg chg="addSp delSp mod">
@@ -674,14 +299,6 @@
             <ac:inkMk id="5" creationId="{09C86ECE-B9F9-2B85-B43B-8A2EB7D621C4}"/>
           </ac:inkMkLst>
         </pc:inkChg>
-        <pc:inkChg chg="del">
-          <ac:chgData name="Iain Styles" userId="befbdaae-53f8-4d26-a8dc-3366b09f768a" providerId="ADAL" clId="{5E0D2633-D8F6-500D-A7FC-C9CB56BC4BFB}" dt="2025-11-02T20:36:11.575" v="40" actId="478"/>
-          <ac:inkMkLst>
-            <pc:docMk/>
-            <pc:sldMk cId="3530703905" sldId="364"/>
-            <ac:inkMk id="5" creationId="{F7EEC25B-9390-27A4-3B01-3141ECBE70C1}"/>
-          </ac:inkMkLst>
-        </pc:inkChg>
       </pc:sldChg>
       <pc:sldChg chg="addSp delSp mod">
         <pc:chgData name="Iain Styles" userId="befbdaae-53f8-4d26-a8dc-3366b09f768a" providerId="ADAL" clId="{5E0D2633-D8F6-500D-A7FC-C9CB56BC4BFB}" dt="2025-11-03T15:59:09.567" v="90"/>
@@ -689,14 +306,6 @@
           <pc:docMk/>
           <pc:sldMk cId="1232992466" sldId="365"/>
         </pc:sldMkLst>
-        <pc:inkChg chg="del">
-          <ac:chgData name="Iain Styles" userId="befbdaae-53f8-4d26-a8dc-3366b09f768a" providerId="ADAL" clId="{5E0D2633-D8F6-500D-A7FC-C9CB56BC4BFB}" dt="2025-11-02T20:36:15.204" v="41" actId="478"/>
-          <ac:inkMkLst>
-            <pc:docMk/>
-            <pc:sldMk cId="1232992466" sldId="365"/>
-            <ac:inkMk id="5" creationId="{75AE293A-5434-DCDE-EDDC-B85B8C8C4877}"/>
-          </ac:inkMkLst>
-        </pc:inkChg>
         <pc:inkChg chg="add">
           <ac:chgData name="Iain Styles" userId="befbdaae-53f8-4d26-a8dc-3366b09f768a" providerId="ADAL" clId="{5E0D2633-D8F6-500D-A7FC-C9CB56BC4BFB}" dt="2025-11-03T15:59:09.567" v="90"/>
           <ac:inkMkLst>
@@ -712,14 +321,6 @@
           <pc:docMk/>
           <pc:sldMk cId="652876146" sldId="366"/>
         </pc:sldMkLst>
-        <pc:inkChg chg="del">
-          <ac:chgData name="Iain Styles" userId="befbdaae-53f8-4d26-a8dc-3366b09f768a" providerId="ADAL" clId="{5E0D2633-D8F6-500D-A7FC-C9CB56BC4BFB}" dt="2025-11-02T20:36:19.066" v="42" actId="478"/>
-          <ac:inkMkLst>
-            <pc:docMk/>
-            <pc:sldMk cId="652876146" sldId="366"/>
-            <ac:inkMk id="5" creationId="{1002D7ED-FBD7-AEFA-9963-1BD035D14931}"/>
-          </ac:inkMkLst>
-        </pc:inkChg>
       </pc:sldChg>
       <pc:sldChg chg="modSp mod">
         <pc:chgData name="Iain Styles" userId="befbdaae-53f8-4d26-a8dc-3366b09f768a" providerId="ADAL" clId="{5E0D2633-D8F6-500D-A7FC-C9CB56BC4BFB}" dt="2025-11-02T20:36:46.073" v="47" actId="207"/>
@@ -736,27 +337,6 @@
           </ac:spMkLst>
         </pc:spChg>
       </pc:sldChg>
-      <pc:sldChg chg="del">
-        <pc:chgData name="Iain Styles" userId="befbdaae-53f8-4d26-a8dc-3366b09f768a" providerId="ADAL" clId="{5E0D2633-D8F6-500D-A7FC-C9CB56BC4BFB}" dt="2025-11-02T20:36:54.576" v="48" actId="2696"/>
-        <pc:sldMkLst>
-          <pc:docMk/>
-          <pc:sldMk cId="1977200179" sldId="368"/>
-        </pc:sldMkLst>
-      </pc:sldChg>
-      <pc:sldChg chg="new del">
-        <pc:chgData name="Iain Styles" userId="befbdaae-53f8-4d26-a8dc-3366b09f768a" providerId="ADAL" clId="{5E0D2633-D8F6-500D-A7FC-C9CB56BC4BFB}" dt="2025-11-02T20:37:40.901" v="87" actId="2696"/>
-        <pc:sldMkLst>
-          <pc:docMk/>
-          <pc:sldMk cId="3355490996" sldId="368"/>
-        </pc:sldMkLst>
-      </pc:sldChg>
-      <pc:sldChg chg="del">
-        <pc:chgData name="Iain Styles" userId="befbdaae-53f8-4d26-a8dc-3366b09f768a" providerId="ADAL" clId="{5E0D2633-D8F6-500D-A7FC-C9CB56BC4BFB}" dt="2025-11-02T20:36:54.584" v="51" actId="2696"/>
-        <pc:sldMkLst>
-          <pc:docMk/>
-          <pc:sldMk cId="1325017611" sldId="369"/>
-        </pc:sldMkLst>
-      </pc:sldChg>
       <pc:sldChg chg="modSp new mod">
         <pc:chgData name="Iain Styles" userId="befbdaae-53f8-4d26-a8dc-3366b09f768a" providerId="ADAL" clId="{5E0D2633-D8F6-500D-A7FC-C9CB56BC4BFB}" dt="2025-11-03T15:04:40.738" v="89" actId="27636"/>
         <pc:sldMkLst>
@@ -771,34 +351,6 @@
             <ac:spMk id="3" creationId="{A43D44EA-7AFB-5579-4377-75C08919BACF}"/>
           </ac:spMkLst>
         </pc:spChg>
-      </pc:sldChg>
-      <pc:sldChg chg="del">
-        <pc:chgData name="Iain Styles" userId="befbdaae-53f8-4d26-a8dc-3366b09f768a" providerId="ADAL" clId="{5E0D2633-D8F6-500D-A7FC-C9CB56BC4BFB}" dt="2025-11-02T20:36:54.595" v="55" actId="2696"/>
-        <pc:sldMkLst>
-          <pc:docMk/>
-          <pc:sldMk cId="2217844794" sldId="370"/>
-        </pc:sldMkLst>
-      </pc:sldChg>
-      <pc:sldChg chg="del">
-        <pc:chgData name="Iain Styles" userId="befbdaae-53f8-4d26-a8dc-3366b09f768a" providerId="ADAL" clId="{5E0D2633-D8F6-500D-A7FC-C9CB56BC4BFB}" dt="2025-11-02T20:36:54.620" v="65" actId="2696"/>
-        <pc:sldMkLst>
-          <pc:docMk/>
-          <pc:sldMk cId="12916658" sldId="371"/>
-        </pc:sldMkLst>
-      </pc:sldChg>
-      <pc:sldChg chg="del">
-        <pc:chgData name="Iain Styles" userId="befbdaae-53f8-4d26-a8dc-3366b09f768a" providerId="ADAL" clId="{5E0D2633-D8F6-500D-A7FC-C9CB56BC4BFB}" dt="2025-11-02T20:36:54.604" v="61" actId="2696"/>
-        <pc:sldMkLst>
-          <pc:docMk/>
-          <pc:sldMk cId="1232051905" sldId="372"/>
-        </pc:sldMkLst>
-      </pc:sldChg>
-      <pc:sldChg chg="modSp new del mod">
-        <pc:chgData name="Iain Styles" userId="befbdaae-53f8-4d26-a8dc-3366b09f768a" providerId="ADAL" clId="{5E0D2633-D8F6-500D-A7FC-C9CB56BC4BFB}" dt="2025-11-02T18:04:42.624" v="16" actId="2696"/>
-        <pc:sldMkLst>
-          <pc:docMk/>
-          <pc:sldMk cId="3320252646" sldId="373"/>
-        </pc:sldMkLst>
       </pc:sldChg>
     </pc:docChg>
   </pc:docChgLst>
@@ -899,7 +451,7 @@
           <a:p>
             <a:fld id="{4B7ADF77-2023-D74B-9A03-BFA0C5C7CE1A}" type="datetimeFigureOut">
               <a:rPr lang="en-US" smtClean="0"/>
-              <a:t>11/3/25</a:t>
+              <a:t>11/20/25</a:t>
             </a:fld>
             <a:endParaRPr lang="en-US"/>
           </a:p>
@@ -1214,27 +766,27 @@
   <inkml:trace contextRef="#ctx0" brushRef="#br0" timeOffset="200034">24710 14534 7533,'-39'28'3276,"27"-10"-2891,29-5 1,14-3-1166,2-6 1,5-5 0,2 2-121,7 4 1,2 1-1,1-1 689,-2-2 1,1 0-1,-1-2 1,-3 0 0,-1-1-1,-2 1 1,7 3-1,1 0 1</inkml:trace>
   <inkml:trace contextRef="#ctx0" brushRef="#br0" timeOffset="200684">25991 14217 7533,'5'-35'3276,"18"-8"-2441,4 13 1,6-1-477,-3 3 1,2-2 0,0 0-333,-3 4 0,0-1 0,0-1 0,-2 1 242,7-9 1,-2-1 0,-4 2-45,3-4 0,-7 5-414,-2 9-171,-20 43 1,-4 15 269,-1 7 0,-1 9 0,0 1-253,1-5 0,-1 2 1,1 2-1,0 2 268,0-5 0,-1 4 0,1 2 0,0 0 0,0-3 1,0-4-84,-1 1 1,1-4-1,0-1 1,1 3-239,0 2 0,0 4 1,1 1-1,0-5 0,1-6-369,2 2 1,2-4 179,-2 12 1,2-4-1125,3-3 1709,-2-27 0,-5-39 0,0-7 0</inkml:trace>
   <inkml:trace contextRef="#ctx0" brushRef="#br0" timeOffset="200906">25978 14993 7533,'-26'0'3276,"41"0"-2184,13 2 0,11 1 0,1 0-1208,3 0 1,1 0 0,5 1-541,-7-1 1,4 1-1,1-1 1,-2 1 0,-4-1 290,1 1 1,-4-1 0,0 0 0,7 2 0,1 0 0,-8 1 0,-12-1 0,-1 0 0</inkml:trace>
-  <inkml:trace contextRef="#ctx0" brushRef="#br1" timeOffset="273117">1552 17163 10599,'-37'-10'-30,"27"41"1,16-6 0,0-1 0</inkml:trace>
-  <inkml:trace contextRef="#ctx0" brushRef="#br2" timeOffset="285751">21351 2663 5914,'7'-17'3058,"-7"-1"-2249,-7-7-449,0-3 360,-4 1-91,10-6-269,-5 21-270,1-4-90,4 16-180,-5 0 360,12 24-90,-3-1 0,0 7 329,4 3 1,2 5 0,-1 4-695,-2 2 0,-1 4 0,0 2 0,0 0 239,-1-7 0,0 1 0,0 0 0,0 0 0,-1 1 107,-1 0 1,1 0 0,-2 0 0,0-1 0,-3 0 72,-1-3 0,-2 1 1,-1-2-1,-1-1 0,-1-3 336,-3 10 0,-2-4 0,-2-2-211,-2-6 1,-1-1 0,-4-4-225,-11 1 0,-4-9-270,-8-16 0,-2-9 135,4-2 1,0-7-151,8-2 0,0-3 0,4-2-615,-4-6 1,6-3-361,8-1 1,4-1-2063,1-14 3208,28 2 1,9 14-1,5-1 1,3-2 0,0 0-1</inkml:trace>
-  <inkml:trace contextRef="#ctx0" brushRef="#br2" timeOffset="286084">20895 2752 7533,'-23'-13'1638,"0"0"0,-17-6 393,-4 1-1312,31 10 451,60 8-721,-1-2 1,7-4-822,-14 0 1,2-3 0,3 0 0,0 0 29,-5 1 0,2 1 0,0-1 1,1 0-1,-1 0-314,3-1 1,1-1-1,-1 0 1,0 1 0,-3 2 390,0 0 0,-1 2 0,-2 1 0,-2 2 0,17 3 0,-12 8 0,-21 18 0</inkml:trace>
-  <inkml:trace contextRef="#ctx0" brushRef="#br2" timeOffset="286434">22028 2840 7533,'-25'-8'3148,"6"22"-2833,9 7 0,2 9-375,1 10 0,2 8 0,0 3-452,1-14 0,2 3 0,-1 1 0,1 0 0,-1 0 278,0-1 0,0 2 0,0-1 0,1-1 1,1-1 30,1 3 1,1-1-1,1-2 1,0-5 0,1 10 0,2-11-1148,7-16 1350,-6-18 0,-12-41 0,-1-5 0</inkml:trace>
-  <inkml:trace contextRef="#ctx0" brushRef="#br2" timeOffset="286806">21918 2734 7533,'-6'-43'2428,"5"-2"-179,11 8-1529,22 19-451,-3 27 1,6 13 0,1 4-203,-8-4 1,0 3-1,0 1 1,0 3-381,-1-2 0,0 3 1,0 0-1,-1 2 1,-2 2 240,-1 1 0,-1 3 0,-1 1 0,-4 0 0,-2 0 27,-4 6 0,-3 1 0,-4 0 0,0-3 195,-1 2 0,-1-1 0,-6-2 30,-8 4 0,-6-1 0,-5-6 123,-3-14 1,-3-5 0,-1-1-304,0 2 0,0-1 0,-2-4-480,-6-3 0,-2-5 1,3-3-106,3-4 0,2-6-1034,-8-15 0,7-1 1619,15 7 0,7-10 0,32 24 0</inkml:trace>
-  <inkml:trace contextRef="#ctx0" brushRef="#br2" timeOffset="287618">22877 3334 8072,'-7'-20'720,"1"4"629,6 16 1350,0 0-2160,0-7 361,22-3-675,8 4 0,6 2-285,3 1 0,6 0 0,1 1-306,-5 2 1,2 0-1,1 0 1,-1 0 207,0 0 1,0 0 0,0 0-1,-3 0-232,6 2 1,-2 1-1,-5 0-285,1 1 1,-7 2-1845,-3 4 360,-14 5 2159,-9-13 0,-11-2 0,-5-10 0</inkml:trace>
-  <inkml:trace contextRef="#ctx0" brushRef="#br2" timeOffset="288068">23418 3104 7533,'-32'-17'3276,"3"7"-616,39 2-1490,32 16-946,-4-4 1,6 2-492,-9 0 0,2 3 0,2 0 1,0 0 400,5 0 1,0 0 0,0 1 0,1-1 22,1 2 1,1 0-1,-1 1 1,-2-1-38,5 4 0,-2-1 0,-6 1 172,-4-2 1,-9 1-23,-13 11-420,-38-5 1,-15 2-421,11 0 0,-1 2 1,-2 0 179,-9 2 0,-2-1 0,1 1-703,5 0 1,1 1 0,3-2 762,-2-2 1,6-3 0,10-2 0,18-10 0</inkml:trace>
-  <inkml:trace contextRef="#ctx0" brushRef="#br2" timeOffset="289951">25178 2734 7533,'-5'-18'1259,"4"-7"-449,1-3-541,7 1-89,5 9 270,0 11-270,-5 7 450,-1 7-271,-17 27-404,0-1 0,-3 4-165,-1-3 0,-1 2 1,-2 2-125,1-1 1,-2 2 0,0 1 0,0 1 279,1-5 0,-1 2 0,0 0 0,0 0 0,1-2 211,-2 3 0,0-2 1,1 0-1,0 1-22,-1 3 0,-1 1 0,1-2 0,4-4 438,0 3 0,5-4-483,1 2 0,9-5 270,36-5-1,-3-13 1,5-4-240,1-7 0,4-4 0,-1 1-508,-3 0 0,-1 0 1,1 0-3,7 0 0,1-1 0,-6 0 640,-9-3 0,-2 0-250,9 3 0,-9 2 0,-23-1 0,8 0 0</inkml:trace>
-  <inkml:trace contextRef="#ctx0" brushRef="#br2" timeOffset="290191">25129 3351 7533,'-24'-27'3276,"4"-6"-2055,19 21-951,42-12-675,-5 18 0,5 3-225,-5-2 1,2 2 0,0 1-1,-3 3 0,-1 2 1,-2 1 629,6-1 0,-8 5 0,-12 18 0,-33-9 0</inkml:trace>
-  <inkml:trace contextRef="#ctx0" brushRef="#br2" timeOffset="290400">25141 2628 7533,'-4'-26'1092,"0"-1"0,21 3 0,11 3 0,4 4 0,7 3 0,2 2-1878,-5 5 1,2 1 0,1 2 0,3 1 785,2 1 0,4 1 0,1 0 0,-1 3 0,-5 0 0,6 5 0,-4 3 0,1 1 0,-6 0 0,1 0 0,-1 1 0,0-1 0</inkml:trace>
-  <inkml:trace contextRef="#ctx0" brushRef="#br2" timeOffset="291151">25929 3387 7533,'-24'-18'2428,"4"8"-2068,8 2-450,7 8 810,10 24-360,13 13-46,-4-6 1,3 1 225,4 0 0,2-1 314,-1-7 1,0-3-136,9 4-89,3-56-720,-21-1 0,-3-8 0,-1 0-450,0 6 0,0 1 1,0-4-136,-1-4 0,0-4 1,-1 1-1,-1 8-314,-3 3 0,0 5 539,3-7 0,-1 13 450,-3 22 0,9 33 0,-4 14 0</inkml:trace>
-  <inkml:trace contextRef="#ctx0" brushRef="#br2" timeOffset="292254">26286 3457 7533,'-11'-27'3276,"9"1"-1335,7 9-1851,21 7-180,4 2 0,5 0-225,3 0 0,1-1 225,6-7 0,-3-4 405,-7 0 0,-6-5-90,-12-1 0,-10-1-1035,-26-10 630,-10 12-495,1 28 1,-2 9 44,-9 18-135,12 4 1,5 8 449,10 2 1,9 2-104,6-8 1,5 2 0,6-2 147,5-3 0,5-1 1,2-3 269,1-4 0,1-2 0,1-7 359,9-4 1,-3-10 1169,2-16 180,-32-15-899,-12 9-360,-17 10-540,16 8 82,-3 0-82,22-15 90,14-5 225,-2-4 0,3-3-46,2 0 1,1-1 45,6 0 0,-2 1-180,-13 8 0,-1 3 135,15 0 180,-27 16 0,-2 0-91,-5 0-988,-5 16 179,4 4-90,0 4 1,2 3 179,11 20 135,3-20 0,5-1 450,9-4 0,4-9 180,0-19 0,0-10 0,3-9 0,-5-7-226,-13 4 1,-5-4 360,1-27 0,-6 22-990,-7 50 450,2 20 0,0 13 180,-2-5 0,-1 6 0,-1 4 0,1 2-468,-2-8 1,1 4 0,-1 1-1,0 0 1,-1 0 0,2-2 359,-1 3 0,2 0 0,-1-1 0,-1-1 0,-1-1 215,-2-2 1,0 0 0,-2-1 0,-1-3 0,-2-6 581,-2 0 1,-2-5 0,-3-7-331,-10-7 1,-4-11-630,-8-22 0,0-13 315,6-4 0,2-7-1228,4 3 1,0-5 0,4 2-1,7 7 1,3 1 0,0 1 985,-8-11 0,8 4 0,22 7 0,9 7 0,23 4 0</inkml:trace>
-  <inkml:trace contextRef="#ctx0" brushRef="#br2" timeOffset="293551">27664 2663 7533,'0'-25'449,"0"5"1,0-5-180,0 15 630,0 18-631,0 20 1,0 11-180,2 0 0,0 6 0,0 4-469,-1-8 1,-1 4 0,0 2 0,0 1-1,0 0 214,0-4 0,-1 2 0,0 0 0,0 0 1,0-1-1,0-1 111,-1 1 0,1-1 0,-1-1 0,1-1 0,-2-3 324,0 16 0,-1-3 0,-1-16 539,-1-20-944,6-38 0,0-17-90,0-8 1,0-6 313,3 9 1,2-2 0,-2 3-135,-3-1 1,3 2 433,7 4 1,4 0 0,6 10-570,13 17 0,2 4 225,-1-12 0,2-1 75,-2 14 0,3 4 0,-4-6 194,1-14 1,-4-7-75,-7 5 0,-2-4 0,-2-2 307,0-8 0,-3-4 0,-3-1-517,-4-1 0,-3-1 0,-2 0-180,1 2 0,-2 1 1,0 2 238,-2-4 1,-2 6-719,-4-4-720,-8 84 1259,4-2 0,0 10 126,2-14 0,1 4 0,-1 4 0,1-1 0,1 0-292,0 4 0,1 0 1,1 1-1,0 2 331,2-9 0,-1 3 0,1 1 0,1 0 0,1-3 0,2-3-8,2 2 1,2-2-1,2-4 1,1-1 174,5 6 0,1-3 0,4-10-63,7-8 1,2-14-45,2-24 0,-2-13-105,-9 4 0,-1-3 0,-1 0 180,1-3 0,0 0 0,-2 0 194,3-14 1,-1 8-764,4 12-901,-12 56 136,-5 8 0,0 8 584,0-12 0,0 1 1,2 2-331,6 11 0,3 2 1,-2-5 725,-3-5 1,1-3 0,8 3 0,3-12 0,-5-28 0</inkml:trace>
-  <inkml:trace contextRef="#ctx0" brushRef="#br2" timeOffset="293758">28785 3228 7533,'-14'-18'2428,"-3"8"-1978,16 18-630,-5 20-765,10 0 1,3 5-1,2 3 1,1 0 944,2-3 0,2-1 0,3-5 0,2-3 0,12 1 0</inkml:trace>
-  <inkml:trace contextRef="#ctx0" brushRef="#br2" timeOffset="294172">28993 3404 7083,'0'-27'3276,"0"9"-975,0 18-2031,0 18-900,6 9-359,1 9 539,16-25 540,3-28 0,11-15 269,-18-7 1,-1-4-45,-2 17 0,-1 1-135,-2-3 0,-1 3-360,0 9-90,-7 58-989,-5-1 134,2 4 1,2 2 89,1-13 1,2-1 1034,0 9 0,5-6 0,24-15 0,3-17 0</inkml:trace>
-  <inkml:trace contextRef="#ctx0" brushRef="#br2" timeOffset="294652">29523 3193 7533,'-18'-18'2878,"-2"32"-2788,2 23-315,11 8 0,6 6-105,3-15 0,2 2 1,3-2 59,4-1 0,3 0 0,3-5 495,7 2 0,4-11 0,6-23 0,0-14-45,-4-15 0,-5-11-31,-8 8 1,-3-3 0,-1 1 749,1-9 1,-4 5-360,-4 5-675,-11 53 0,-2 17 135,-1 4 0,0 6 0,-1 4-322,3-10 1,0 3 0,0 1 0,-1 1-1,1 0 382,-1-3 0,0 0 0,0 2 0,-1-1 0,1 0 0,0 0-96,0 6 0,1 0 0,0 0 0,-1-1 0,0-3 171,-1 1 0,0-1 0,-1-3 0,-1-2-375,-2-2 0,-1-2 0,-3-7 330,-5-7 0,-3-7-1394,-12-10 0,-1-6 674,-10-10 630,22 4 0,3-4 0,-1-19 0,4 11 0</inkml:trace>
-  <inkml:trace contextRef="#ctx0" brushRef="#br2" timeOffset="294851">28723 2769 7533,'-25'-15'247,"11"11"0,36-12 1,19 16-1</inkml:trace>
-  <inkml:trace contextRef="#ctx0" brushRef="#br2" timeOffset="295652">30323 3440 7353,'-14'-10'1619,"25"-6"-1439,10 10 0,7 2 44,14-7 1,4-3-45,-11 3 0,1-1 0,-1 0 30,-2-2 0,0 0 0,-4-4-75,6-13 0,-9-6 134,-15 1 1,-10-1-180,-5 8 0,-7 2-180,-12-5 0,-7 7 180,0 11 0,-3 8-45,-5 5 0,1 8-90,0 10 0,5 11 45,13 2 0,5 7 0,3 2-144,3 4 1,3 3 0,6 0-7,7 2 0,5 1 0,7-3-188,1-10 1,6-1 0,1-3 0,0-4 67,-1-2 0,0-3 0,5-5 270,8-1 0,6-2 0,-1-6 0,-6-11 0,0-25 0,-3-10 0,-5 15 0,0 1 0,0-1 0,0 0 0</inkml:trace>
-  <inkml:trace contextRef="#ctx0" brushRef="#br2" timeOffset="295985">31073 2381 7533,'-22'-12'764,"0"-1"1,-9 9 224,13 45-659,14-6 0,3 7 0,1 4-794,0-8 0,1 2 1,0 2-1,1 1 1,-1 0 523,1 0 0,0 1 0,0 1 0,0 0 0,0 0 0,1 0-30,-1-2 0,1-1 0,0 1 0,0-1 0,0 0 0,1-1 71,2 3 0,-1 0 0,1-2 0,1 0 1,0-3-507,0 1 0,0-1 0,1-2 0,1-6 0,6 5 1,2-7-666,13 10 1070,0-47 0,1-9 0,6-11 0</inkml:trace>
-  <inkml:trace contextRef="#ctx0" brushRef="#br2" timeOffset="296703">31664 3263 7533,'-21'-29'1092,"1"-1"0,1 9 0,-2 1-662,-8-5 1,-2 7-611,-14 26 180,24 14 0,5 9-135,2 11 1,5 6-58,5-11 0,3 2 0,-1 1-48,-3 8 0,-2 3 1,3-3 508,3-11 1,1-2 0,-2-2 284,-7 17 1,1-13 434,7-29-359,-5-38-450,12-15-1080,12 2-359,13 8 1082,-4 20 1,7 2 146,0 4 0,5 1 0,1 0 149,-2-2 1,1-1 0,3-2-174,2 0 1,5-1-1,-1-2 1,-5-1 562,-2-3 1,-3-2 0,-2-3-330,-3-2 0,1-3 0,-3-1 0,-5 1 134,-1-5 1,-11 0 315,-9-7 0,-15 7-1,-27 27 1,-11 15-181,8 3 1,-2 5 0,1 5-659,7-3 0,1 2 1,1 3-1,3 2-361,-6 13 1,3 5-1,15 0-390,17-2 1,10-1 0,5 0-121,2-1 1,4-1 0,6-4 1079,7-2 0,7-5 0,2-5 0,2-7 0,3-6 0,0-2 0,-1-4 0,-1 0 0,1 0 0</inkml:trace>
-  <inkml:trace contextRef="#ctx0" brushRef="#br2" timeOffset="296810">32439 3687 7533,'48'-8'3276,"-3"14"-2457,-1-4 0,-30 31 0,-17 4 0</inkml:trace>
+  <inkml:trace contextRef="#ctx0" brushRef="#br1" timeOffset="-156379.73">1552 17163 10599,'-37'-10'-30,"27"41"1,16-6 0,0-1 0</inkml:trace>
+  <inkml:trace contextRef="#ctx0" brushRef="#br2" timeOffset="-143745.73">21351 2663 5914,'7'-17'3058,"-7"-1"-2249,-7-7-449,0-3 360,-4 1-91,10-6-269,-5 21-270,1-4-90,4 16-180,-5 0 360,12 24-90,-3-1 0,0 7 329,4 3 1,2 5 0,-1 4-695,-2 2 0,-1 4 0,0 2 0,0 0 239,-1-7 0,0 1 0,0 0 0,0 0 0,-1 1 107,-1 0 1,1 0 0,-2 0 0,0-1 0,-3 0 72,-1-3 0,-2 1 1,-1-2-1,-1-1 0,-1-3 336,-3 10 0,-2-4 0,-2-2-211,-2-6 1,-1-1 0,-4-4-225,-11 1 0,-4-9-270,-8-16 0,-2-9 135,4-2 1,0-7-151,8-2 0,0-3 0,4-2-615,-4-6 1,6-3-361,8-1 1,4-1-2063,1-14 3208,28 2 1,9 14-1,5-1 1,3-2 0,0 0-1</inkml:trace>
+  <inkml:trace contextRef="#ctx0" brushRef="#br2" timeOffset="-143412.73">20895 2752 7533,'-23'-13'1638,"0"0"0,-17-6 393,-4 1-1312,31 10 451,60 8-721,-1-2 1,7-4-822,-14 0 1,2-3 0,3 0 0,0 0 29,-5 1 0,2 1 0,0-1 1,1 0-1,-1 0-314,3-1 1,1-1-1,-1 0 1,0 1 0,-3 2 390,0 0 0,-1 2 0,-2 1 0,-2 2 0,17 3 0,-12 8 0,-21 18 0</inkml:trace>
+  <inkml:trace contextRef="#ctx0" brushRef="#br2" timeOffset="-143062.73">22028 2840 7533,'-25'-8'3148,"6"22"-2833,9 7 0,2 9-375,1 10 0,2 8 0,0 3-452,1-14 0,2 3 0,-1 1 0,1 0 0,-1 0 278,0-1 0,0 2 0,0-1 0,1-1 1,1-1 30,1 3 1,1-1-1,1-2 1,0-5 0,1 10 0,2-11-1148,7-16 1350,-6-18 0,-12-41 0,-1-5 0</inkml:trace>
+  <inkml:trace contextRef="#ctx0" brushRef="#br2" timeOffset="-142690.73">21918 2734 7533,'-6'-43'2428,"5"-2"-179,11 8-1529,22 19-451,-3 27 1,6 13 0,1 4-203,-8-4 1,0 3-1,0 1 1,0 3-381,-1-2 0,0 3 1,0 0-1,-1 2 1,-2 2 240,-1 1 0,-1 3 0,-1 1 0,-4 0 0,-2 0 27,-4 6 0,-3 1 0,-4 0 0,0-3 195,-1 2 0,-1-1 0,-6-2 30,-8 4 0,-6-1 0,-5-6 123,-3-14 1,-3-5 0,-1-1-304,0 2 0,0-1 0,-2-4-480,-6-3 0,-2-5 1,3-3-106,3-4 0,2-6-1034,-8-15 0,7-1 1619,15 7 0,7-10 0,32 24 0</inkml:trace>
+  <inkml:trace contextRef="#ctx0" brushRef="#br2" timeOffset="-141878.73">22877 3334 8072,'-7'-20'720,"1"4"629,6 16 1350,0 0-2160,0-7 361,22-3-675,8 4 0,6 2-285,3 1 0,6 0 0,1 1-306,-5 2 1,2 0-1,1 0 1,-1 0 207,0 0 1,0 0 0,0 0-1,-3 0-232,6 2 1,-2 1-1,-5 0-285,1 1 1,-7 2-1845,-3 4 360,-14 5 2159,-9-13 0,-11-2 0,-5-10 0</inkml:trace>
+  <inkml:trace contextRef="#ctx0" brushRef="#br2" timeOffset="-141428.73">23418 3104 7533,'-32'-17'3276,"3"7"-616,39 2-1490,32 16-946,-4-4 1,6 2-492,-9 0 0,2 3 0,2 0 1,0 0 400,5 0 1,0 0 0,0 1 0,1-1 22,1 2 1,1 0-1,-1 1 1,-2-1-38,5 4 0,-2-1 0,-6 1 172,-4-2 1,-9 1-23,-13 11-420,-38-5 1,-15 2-421,11 0 0,-1 2 1,-2 0 179,-9 2 0,-2-1 0,1 1-703,5 0 1,1 1 0,3-2 762,-2-2 1,6-3 0,10-2 0,18-10 0</inkml:trace>
+  <inkml:trace contextRef="#ctx0" brushRef="#br2" timeOffset="-139545.73">25178 2734 7533,'-5'-18'1259,"4"-7"-449,1-3-541,7 1-89,5 9 270,0 11-270,-5 7 450,-1 7-271,-17 27-404,0-1 0,-3 4-165,-1-3 0,-1 2 1,-2 2-125,1-1 1,-2 2 0,0 1 0,0 1 279,1-5 0,-1 2 0,0 0 0,0 0 0,1-2 211,-2 3 0,0-2 1,1 0-1,0 1-22,-1 3 0,-1 1 0,1-2 0,4-4 438,0 3 0,5-4-483,1 2 0,9-5 270,36-5-1,-3-13 1,5-4-240,1-7 0,4-4 0,-1 1-508,-3 0 0,-1 0 1,1 0-3,7 0 0,1-1 0,-6 0 640,-9-3 0,-2 0-250,9 3 0,-9 2 0,-23-1 0,8 0 0</inkml:trace>
+  <inkml:trace contextRef="#ctx0" brushRef="#br2" timeOffset="-139305.73">25129 3351 7533,'-24'-27'3276,"4"-6"-2055,19 21-951,42-12-675,-5 18 0,5 3-225,-5-2 1,2 2 0,0 1-1,-3 3 0,-1 2 1,-2 1 629,6-1 0,-8 5 0,-12 18 0,-33-9 0</inkml:trace>
+  <inkml:trace contextRef="#ctx0" brushRef="#br2" timeOffset="-139096.73">25141 2628 7533,'-4'-26'1092,"0"-1"0,21 3 0,11 3 0,4 4 0,7 3 0,2 2-1878,-5 5 1,2 1 0,1 2 0,3 1 785,2 1 0,4 1 0,1 0 0,-1 3 0,-5 0 0,6 5 0,-4 3 0,1 1 0,-6 0 0,1 0 0,-1 1 0,0-1 0</inkml:trace>
+  <inkml:trace contextRef="#ctx0" brushRef="#br2" timeOffset="-138345.73">25929 3387 7533,'-24'-18'2428,"4"8"-2068,8 2-450,7 8 810,10 24-360,13 13-46,-4-6 1,3 1 225,4 0 0,2-1 314,-1-7 1,0-3-136,9 4-89,3-56-720,-21-1 0,-3-8 0,-1 0-450,0 6 0,0 1 1,0-4-136,-1-4 0,0-4 1,-1 1-1,-1 8-314,-3 3 0,0 5 539,3-7 0,-1 13 450,-3 22 0,9 33 0,-4 14 0</inkml:trace>
+  <inkml:trace contextRef="#ctx0" brushRef="#br2" timeOffset="-137242.73">26286 3457 7533,'-11'-27'3276,"9"1"-1335,7 9-1851,21 7-180,4 2 0,5 0-225,3 0 0,1-1 225,6-7 0,-3-4 405,-7 0 0,-6-5-90,-12-1 0,-10-1-1035,-26-10 630,-10 12-495,1 28 1,-2 9 44,-9 18-135,12 4 1,5 8 449,10 2 1,9 2-104,6-8 1,5 2 0,6-2 147,5-3 0,5-1 1,2-3 269,1-4 0,1-2 0,1-7 359,9-4 1,-3-10 1169,2-16 180,-32-15-899,-12 9-360,-17 10-540,16 8 82,-3 0-82,22-15 90,14-5 225,-2-4 0,3-3-46,2 0 1,1-1 45,6 0 0,-2 1-180,-13 8 0,-1 3 135,15 0 180,-27 16 0,-2 0-91,-5 0-988,-5 16 179,4 4-90,0 4 1,2 3 179,11 20 135,3-20 0,5-1 450,9-4 0,4-9 180,0-19 0,0-10 0,3-9 0,-5-7-226,-13 4 1,-5-4 360,1-27 0,-6 22-990,-7 50 450,2 20 0,0 13 180,-2-5 0,-1 6 0,-1 4 0,1 2-468,-2-8 1,1 4 0,-1 1-1,0 0 1,-1 0 0,2-2 359,-1 3 0,2 0 0,-1-1 0,-1-1 0,-1-1 215,-2-2 1,0 0 0,-2-1 0,-1-3 0,-2-6 581,-2 0 1,-2-5 0,-3-7-331,-10-7 1,-4-11-630,-8-22 0,0-13 315,6-4 0,2-7-1228,4 3 1,0-5 0,4 2-1,7 7 1,3 1 0,0 1 985,-8-11 0,8 4 0,22 7 0,9 7 0,23 4 0</inkml:trace>
+  <inkml:trace contextRef="#ctx0" brushRef="#br2" timeOffset="-135945.73">27664 2663 7533,'0'-25'449,"0"5"1,0-5-180,0 15 630,0 18-631,0 20 1,0 11-180,2 0 0,0 6 0,0 4-469,-1-8 1,-1 4 0,0 2 0,0 1-1,0 0 214,0-4 0,-1 2 0,0 0 0,0 0 1,0-1-1,0-1 111,-1 1 0,1-1 0,-1-1 0,1-1 0,-2-3 324,0 16 0,-1-3 0,-1-16 539,-1-20-944,6-38 0,0-17-90,0-8 1,0-6 313,3 9 1,2-2 0,-2 3-135,-3-1 1,3 2 433,7 4 1,4 0 0,6 10-570,13 17 0,2 4 225,-1-12 0,2-1 75,-2 14 0,3 4 0,-4-6 194,1-14 1,-4-7-75,-7 5 0,-2-4 0,-2-2 307,0-8 0,-3-4 0,-3-1-517,-4-1 0,-3-1 0,-2 0-180,1 2 0,-2 1 1,0 2 238,-2-4 1,-2 6-719,-4-4-720,-8 84 1259,4-2 0,0 10 126,2-14 0,1 4 0,-1 4 0,1-1 0,1 0-292,0 4 0,1 0 1,1 1-1,0 2 331,2-9 0,-1 3 0,1 1 0,1 0 0,1-3 0,2-3-8,2 2 1,2-2-1,2-4 1,1-1 174,5 6 0,1-3 0,4-10-63,7-8 1,2-14-45,2-24 0,-2-13-105,-9 4 0,-1-3 0,-1 0 180,1-3 0,0 0 0,-2 0 194,3-14 1,-1 8-764,4 12-901,-12 56 136,-5 8 0,0 8 584,0-12 0,0 1 1,2 2-331,6 11 0,3 2 1,-2-5 725,-3-5 1,1-3 0,8 3 0,3-12 0,-5-28 0</inkml:trace>
+  <inkml:trace contextRef="#ctx0" brushRef="#br2" timeOffset="-135738.73">28785 3228 7533,'-14'-18'2428,"-3"8"-1978,16 18-630,-5 20-765,10 0 1,3 5-1,2 3 1,1 0 944,2-3 0,2-1 0,3-5 0,2-3 0,12 1 0</inkml:trace>
+  <inkml:trace contextRef="#ctx0" brushRef="#br2" timeOffset="-135324.73">28993 3404 7083,'0'-27'3276,"0"9"-975,0 18-2031,0 18-900,6 9-359,1 9 539,16-25 540,3-28 0,11-15 269,-18-7 1,-1-4-45,-2 17 0,-1 1-135,-2-3 0,-1 3-360,0 9-90,-7 58-989,-5-1 134,2 4 1,2 2 89,1-13 1,2-1 1034,0 9 0,5-6 0,24-15 0,3-17 0</inkml:trace>
+  <inkml:trace contextRef="#ctx0" brushRef="#br2" timeOffset="-134844.73">29523 3193 7533,'-18'-18'2878,"-2"32"-2788,2 23-315,11 8 0,6 6-105,3-15 0,2 2 1,3-2 59,4-1 0,3 0 0,3-5 495,7 2 0,4-11 0,6-23 0,0-14-45,-4-15 0,-5-11-31,-8 8 1,-3-3 0,-1 1 749,1-9 1,-4 5-360,-4 5-675,-11 53 0,-2 17 135,-1 4 0,0 6 0,-1 4-322,3-10 1,0 3 0,0 1 0,-1 1-1,1 0 382,-1-3 0,0 0 0,0 2 0,-1-1 0,1 0 0,0 0-96,0 6 0,1 0 0,0 0 0,-1-1 0,0-3 171,-1 1 0,0-1 0,-1-3 0,-1-2-375,-2-2 0,-1-2 0,-3-7 330,-5-7 0,-3-7-1394,-12-10 0,-1-6 674,-10-10 630,22 4 0,3-4 0,-1-19 0,4 11 0</inkml:trace>
+  <inkml:trace contextRef="#ctx0" brushRef="#br2" timeOffset="-134645.73">28723 2769 7533,'-25'-15'247,"11"11"0,36-12 1,19 16-1</inkml:trace>
+  <inkml:trace contextRef="#ctx0" brushRef="#br2" timeOffset="-133844.73">30323 3440 7353,'-14'-10'1619,"25"-6"-1439,10 10 0,7 2 44,14-7 1,4-3-45,-11 3 0,1-1 0,-1 0 30,-2-2 0,0 0 0,-4-4-75,6-13 0,-9-6 134,-15 1 1,-10-1-180,-5 8 0,-7 2-180,-12-5 0,-7 7 180,0 11 0,-3 8-45,-5 5 0,1 8-90,0 10 0,5 11 45,13 2 0,5 7 0,3 2-144,3 4 1,3 3 0,6 0-7,7 2 0,5 1 0,7-3-188,1-10 1,6-1 0,1-3 0,0-4 67,-1-2 0,0-3 0,5-5 270,8-1 0,6-2 0,-1-6 0,-6-11 0,0-25 0,-3-10 0,-5 15 0,0 1 0,0-1 0,0 0 0</inkml:trace>
+  <inkml:trace contextRef="#ctx0" brushRef="#br2" timeOffset="-133511.73">31073 2381 7533,'-22'-12'764,"0"-1"1,-9 9 224,13 45-659,14-6 0,3 7 0,1 4-794,0-8 0,1 2 1,0 2-1,1 1 1,-1 0 523,1 0 0,0 1 0,0 1 0,0 0 0,0 0 0,1 0-30,-1-2 0,1-1 0,0 1 0,0-1 0,0 0 0,1-1 71,2 3 0,-1 0 0,1-2 0,1 0 1,0-3-507,0 1 0,0-1 0,1-2 0,1-6 0,6 5 1,2-7-666,13 10 1070,0-47 0,1-9 0,6-11 0</inkml:trace>
+  <inkml:trace contextRef="#ctx0" brushRef="#br2" timeOffset="-132793.73">31664 3263 7533,'-21'-29'1092,"1"-1"0,1 9 0,-2 1-662,-8-5 1,-2 7-611,-14 26 180,24 14 0,5 9-135,2 11 1,5 6-58,5-11 0,3 2 0,-1 1-48,-3 8 0,-2 3 1,3-3 508,3-11 1,1-2 0,-2-2 284,-7 17 1,1-13 434,7-29-359,-5-38-450,12-15-1080,12 2-359,13 8 1082,-4 20 1,7 2 146,0 4 0,5 1 0,1 0 149,-2-2 1,1-1 0,3-2-174,2 0 1,5-1-1,-1-2 1,-5-1 562,-2-3 1,-3-2 0,-2-3-330,-3-2 0,1-3 0,-3-1 0,-5 1 134,-1-5 1,-11 0 315,-9-7 0,-15 7-1,-27 27 1,-11 15-181,8 3 1,-2 5 0,1 5-659,7-3 0,1 2 1,1 3-1,3 2-361,-6 13 1,3 5-1,15 0-390,17-2 1,10-1 0,5 0-121,2-1 1,4-1 0,6-4 1079,7-2 0,7-5 0,2-5 0,2-7 0,3-6 0,0-2 0,-1-4 0,-1 0 0,1 0 0</inkml:trace>
+  <inkml:trace contextRef="#ctx0" brushRef="#br2" timeOffset="-132686.73">32439 3687 7533,'48'-8'3276,"-3"14"-2457,-1-4 0,-30 31 0,-17 4 0</inkml:trace>
 </inkml:ink>
 </file>
 
@@ -1574,49 +1126,49 @@
   <inkml:trace contextRef="#ctx0" brushRef="#br0" timeOffset="212735">8946 13776 7533,'-5'-27'2878,"-2"-7"-2698,-16 22-360,-14-3-135,5 15 0,-3 8 405,-8 9 0,-1 7 90,11-5 0,1 2 0,2 3 30,4 6 0,2 4 0,4 0-61,5-2 1,4 1 0,7 0-120,12 6 0,7 0 0,3-5-120,0-5 0,4-5 0,5-2 0,6-1 1,-1-9 358,0-15 1,0-10 225,4-9 0,-2-7-181,-4-6 1,-6-4-135,-6-6 0,-6 0 225,-7 11 0,-3 5-405,-3-4-180,-6 48 90,1 7-270,14 6 0,6 3 270,14 8 270,-3-22 0,4-7-90,0-10 0,-1-9-30,-2-13 0,0-9 0,0-1 0,-2 1 0,0 0 0,-1-3 419,-1-5 1,-1-2 0,-2 6-31,0 0 1,-2 15 90,-1 29-945,-5 33 1,2 13-689,8-13 1,5 2 0,-2-1 727,-7-4 1,-1-1 0,4-3 0,9-6 0,3-3 0,-1-7 0,-6-11 0,0 0 0</inkml:trace>
   <inkml:trace contextRef="#ctx0" brushRef="#br0" timeOffset="213968">10842 13899 7533,'-18'-9'3148,"-1"1"-2788,-6 31-90,1 15-226,16-12 1,2 2-135,-2 2 1,5-7-1,19-11 270,16-39-46,-12-6 1,0-7-45,-5 9 0,-1-3 0,-1 1 225,-2-13 0,-3 2 89,0 10 1,-5 13-405,-14 29-90,8 16 1,3 9-91,-1 0 0,0 4 0,3-1 0,5-2 0,4 0 0,2-2-225,9 12 1,6-8 538,-1-17 1,3-11 180,2-15 0,-3-13-90,-5-16 0,-5-8-105,-5 11 0,-2 0 0,-1-1-90,-1-2 0,-2-1 0,-1 4 734,0 0 1,-2 9 494,-5 16-899,-7 55-1755,3-1 1,1 4 524,3-16 1,2-1 0,2 0-31,5 15 1,7-6-496,8-11 1,6-9 1214,5-12 1,0-12 179,-2-16 0,-2-7 0,-2 6 0,-5-3 494,-8-18 1,-7-3 1143,-2 18 0,-1 1-83,-2-3 0,-3 2-205,-6-1-1080,3 18-810,-3 32-1079,5 21 494,6-6 1,4 2 269,0 2 1,6-3 584,14-4 0,6-10 315,-4-15 0,1-12 554,-4-12 1,1-10 0,-4-2 164,3-12 1,-6-4-315,-9 9 0,-2-1 0,-3 2 1188,1-5 0,-9 11-417,-12 21-2030,9 41-830,2-5 1,5 3 1582,9 10 0,9-4 1,3-19-1,5-5 0,2-1 1,5 1-1,1 0 0,-1 0 1</inkml:trace>
   <inkml:trace contextRef="#ctx0" brushRef="#br0" timeOffset="214510">12380 13300 7533,'0'-36'3276,"0"17"-2055,0 27-816,0 23 0,0 14-316,-2-8 1,-1 5 0,0 2 0,0 0-611,1 3 1,0 2 0,0 0-1,0 2 143,-1-5 0,0 3 1,0 0-1,0-2 0,2-3-402,1 6 1,2-4 0,2-3 70,2 12 1,7-18 708,13-37 0,4-37 0,-18 6 0,0-1 0</inkml:trace>
-  <inkml:trace contextRef="#ctx0" brushRef="#br0" timeOffset="214785">12799 13494 7533,'3'-27'1638,"0"1"0,3-4-237,-6 15-1446,0 35 0,0 17-405,-3 6 1,0 6-371,3-13 1,0 4 0,-1 1 0,1 0 14,-1 5 0,-1 2 0,1-1 0,0-1 805,1 6 0,0-2 0,0-3 0,-4 6 0,-3-10 0,-7-14 0</inkml:trace>
-  <inkml:trace contextRef="#ctx0" brushRef="#br0" timeOffset="214951">12724 13935 7533,'-6'-49'1092,"0"0"0,4 15 0,3 3 2184,17-10-2273,31 41-2053,-10 4 1,7 3 0,-1 0 1049,-6-1 0,-1 1 0,3-1 0,2-1 0,4 0 0,1-1 0,-3 0 0,3-2 0,0 1 0,-1 0 0</inkml:trace>
-  <inkml:trace contextRef="#ctx0" brushRef="#br0" timeOffset="215517">13598 13935 8612,'7'-28'2519,"-1"11"-1800,-1 1-809,-3 30-449,3 21-361,-4-1 1,-2 4 899,2-4 0,0 2 0,3 0 0,3 2 0,3 1 0,1 0 0,2 2 0,1 0 0,-1 0 0</inkml:trace>
-  <inkml:trace contextRef="#ctx0" brushRef="#br0" timeOffset="216051">13832 14005 7533,'-37'-19'2608,"6"50"-2473,19 3 0,5 7-135,2-2 0,1 4 0,2 0 30,2 2 0,2 0 0,1-2-480,2 6 1,3-6 628,0-10 1,3-15 810,13-59-661,-15 10 1,-4-6 0,0-3-218,-1 1 1,-1-3-1,0-3 1,0 1-769,0 4 1,0-2-1,1 0 1,-1 1 0,0 2 848,-1-13 1,0 2-1,2 3-13,3 3 0,1 1 0,6 12 290,23 12-650,8 38-120,-22 3 0,-1 6 0,-1 1 165,1 8 0,-3 2 165,-4-5 0,-1 2 0,-2-4-75,-3-6 0,-6-3 315,-25 18-809,4-41 2586,-28-17-3936,25-3 1889,4-5 0,33 4 0,11 0 0,4-2 0,0-1 0</inkml:trace>
-  <inkml:trace contextRef="#ctx0" brushRef="#br0" timeOffset="216519">14509 13247 7533,'-37'-30'3276,"0"30"-2756,15 18 1,2 9-581,7 1 0,3 5 0,0 3 60,0-2 0,0 3 0,1 1 0,2 1-476,2 7 0,2 1 0,2 1 1,2 0 295,1 1 0,1 2 0,2-1 0,3-2 0,0-5 0,1-1 0,3-2 0,4-5 252,5 1 1,4-6 0,3-8-118,12-6 0,0-16 375,-11-13 0,-2-9 0,-2-4 59,0-1 1,-2-4 0,-3-3-139,-2-8 1,-4-3-1,-2 1 19,-1 6 0,-2 1 0,-5 2 674,-10-11 1,-11 12 404,-28 32-1574,12 24 0,2 13-645,11-3 1,3 5 0,4 2-66,4 1 0,5 2 0,4-1 275,6-3 1,4-2-1,0-2 132,0 1 1,3-6 0,26 3 0,-25-42 0</inkml:trace>
-  <inkml:trace contextRef="#ctx0" brushRef="#br0" timeOffset="216691">13709 13458 7533,'-39'-9'468,"37"1"0,30 6 0,17 4 0,-7-2 0,1 0 0,0 0 0</inkml:trace>
-  <inkml:trace contextRef="#ctx0" brushRef="#br0" timeOffset="217317">15690 13723 8252,'-31'-2'3276,"1"20"-2441,20 8 1,6 8-506,2 2 0,2 3 0,2 0-270,2-3 0,2-1 0,3 0 90,8 9 0,5 0 0,3-12 524,7-18 1,4-13-181,11-14 1,-3-13-450,-15-1 0,-6-9-90,-6 4 0,-2-6 0,-1-2 0,-4 5-945,0-7 1,-3 2 59,1 4 1,0-2 0,-1 6-2348,4-3 3193,-4 39 1,4 17-1,1 9 1,1-3 0,0 1-1</inkml:trace>
-  <inkml:trace contextRef="#ctx0" brushRef="#br0" timeOffset="218300">16405 13917 7533,'-3'-26'1638,"0"-1"0,-4-18 303,-11 10-1581,-1 17-181,-6 10-718,-5 16 89,-1 10 90,7 1 0,0 5 855,1 6 0,1 3-181,-1 2 1,2 2 90,4 6 0,4 0-450,6-1 0,7-3-270,8-9 0,7-3-180,8-2 1,5-9-226,6-19 1,1-10-316,6-6 1,-2-7 404,-5-9 1,-5-3 449,-5 6 0,-4 0 360,-9 1 0,-5 3 719,-7 8 91,-12 13-91,6 32-179,2 20-451,4-18 1,2 1 90,3 7 0,3-1 0,7 5 0,11-6-181,5-64-359,-12 4 1,1-3 149,-4 1 0,1-2 0,2 1 60,3-1 0,1 1 0,2 3-255,12-7 0,3 5 180,4 5 0,0 5 0,-5 9 0,-1 2 899,-5 0 1,-2 0 1484,7-1-1350,-30-25-719,-37 13-90,3 2 0,-4 4-270,-6 15 0,-1 6-855,7 1 1,4 6 89,5 14 1,9 7 179,16 5 1,11 2 464,-2-11 0,4 0 0,1 0 240,3 5 0,2 1 0,0-3 105,10 5 0,-3-1 359,-11-5 1,-4-4 45,-4-2-990,-21-18-2608,2-8 3058,4 7 0,39-5 0,13 6 0</inkml:trace>
-  <inkml:trace contextRef="#ctx0" brushRef="#br0" timeOffset="218434">17290 14252 7533,'-12'-19'819,"5"3"0,2 32 0,5 3 0</inkml:trace>
-  <inkml:trace contextRef="#ctx0" brushRef="#br0" timeOffset="220484">6547 15946 9062,'-3'37'652,"0"0"0,1 0 0,0 4 0,0 5-592,0-10 0,-1 5 0,1 3 0,0 0 0,0 0 0,0-3-475,1 3 1,1 0 0,0-2 0,1 1 0,-2 0 324,0 3 0,0 2 0,0-1 0,0-3 0,1-6 315,3 19 0,0-27 273,-3-38-993,0-26 0,0-13 202,-2 14 1,-1-5 0,0-1 0,0-1-182,0 0 0,1-1 0,-1-1 1,0-2-1,0-1 474,-1-1 0,-1-2 0,-1-2 0,1 1 0,-1 0 0,2 3 413,-1 0 1,0 1 0,1 1 0,0 1 0,1-1-91,-1 0 1,1-2 0,0 1 0,2 4 0,5 6 429,9-10 0,9 11-349,15 12 1,7 11-375,-4 11 0,2 7 0,1 2 0,-2 0 0,0 2 0,-2 6 90,3 9 0,-1 6 0,-9 4 87,-10 0 1,-7 4-1,-5 1-207,-4 4 0,-6 1 0,-7-1-135,-6-11 0,-5 1 0,-3-3 0,-1-2-15,-6 1 0,-2-3 1,-4-5 89,-5-3 0,-3-5 0,3-7-120,3-5 0,4-8-1304,0-6 0,13-5-315,35-11 1799,1 9 0,6 2 0,6 8 0,7 2 0,0 1 0,2-4 0,0 1 0,1-1 0</inkml:trace>
-  <inkml:trace contextRef="#ctx0" brushRef="#br0" timeOffset="220887">7569 15681 7533,'-7'-45'3276,"-4"10"0,4 17-2453,-28 18-1003,11 23 1,-2 11 119,-4-2 0,-4 3 0,1 6-457,8-6 0,-1 4 0,1 2 0,0 2 0,1 0 772,3-3 0,0 2 0,0 0 0,1 1 0,0 0 0,2-2 50,-3 6 1,1-2 0,1 1 0,3 0 0,4 0-199,4-1 1,2 1 0,3 0 0,4-2 0,3-4-816,6 7 1,6-5-1,4-3 108,2-4 1,4-2-1,3-5-450,3-10 1,4-4 0,-3-3 1049,-4 0 0,-2-7 0,7-15 0,-5-9 0,-4-19 0</inkml:trace>
-  <inkml:trace contextRef="#ctx0" brushRef="#br0" timeOffset="221670">7753 16122 7533,'-20'-18'2248,"-3"-7"-808,10 5 269,1 3-1170,6 9 91,17 39-181,0 2 1,3 5-240,-1-6 0,2 2 0,1 2-451,0 6 0,0 3 0,2-1-179,4 0 1,3 0-1,-1-1-210,-4-5 1,-1-2-1,1 0-30,0-2 1,2-2-1,-3-2-105,1-2 1,-3-3-1305,7 8 2069,-17-15 0,-13-8 0,-8-2 0</inkml:trace>
-  <inkml:trace contextRef="#ctx0" brushRef="#br0" timeOffset="222020">7777 16863 7533,'-42'-8'3276,"20"-2"-526,17-23-1761,25 1 1,13-5-473,-10 11 0,3-3 1,1-1-1,2 0-809,0-1 1,1 0 0,2-1-1,1-1 1,0-1 96,-1 1 0,1-1 0,1-1 0,0 0 1,-2 2-1,-1 1 127,3-4 1,-1 2-1,-2 2 1,0-1-753,0 0 1,1 0 0,-3 2 0,-8 4-2229,-1-16 1969,-4 8-1260,-15 15 2339,4 5 0,-10 22 0,-1 3 0</inkml:trace>
-  <inkml:trace contextRef="#ctx0" brushRef="#br0" timeOffset="222451">8836 15804 7533,'-6'-27'3276,"5"17"-1335,1 51-1312,0-8 1,1 5 0,-1 5-1097,1-5 0,-1 3 0,0 2 0,0 1 1,-1 2 451,1-2 0,-1 2 0,0 1 0,-1 1 0,1-1 0,-1-1-60,1-2 0,-1 0 0,-1-1 0,1 0 0,0-1 0,0-1-19,0 11 0,0-2 0,1-2 0,-1-6-221,-1 6 1,1-12-237,2-20 551,0-50 0,9 5 0,4-4 0,0-12 0,1 0 0</inkml:trace>
-  <inkml:trace contextRef="#ctx0" brushRef="#br0" timeOffset="223168">9340 15998 7083,'-19'-17'3058,"1"-1"-2428,6 8-180,5-5 179,-3 13 181,8-6 269,-3 16-89,15 17-676,6 7 1,4 5-615,-1-10 0,2 1 1,2 1-352,4 9 1,3 1 0,0-2-443,-1-7 1,0-3 0,1-2-547,11 4 1,-3-5 1635,2 0 0,-13-40 0,-27-4 0</inkml:trace>
-  <inkml:trace contextRef="#ctx0" brushRef="#br0" timeOffset="223486">9869 15981 7533,'0'-18'3276,"-5"-7"0,-2 21-2453,-11 21-823,7 8 0,-1 9 0,0 2-180,-1-2 0,-1 3 1,0 3-1,-1 1-367,2-4 1,0 2 0,0 1 0,-1 1 0,0 0 0,0-1 331,-3 5 1,-1 0-1,0-1 1,0 0-1,2-1 327,-2 6 1,2 0-1,0-3 1,1-4 47,-1-3 1,1-4-1,5-7-3437,10-2 1337,31-36 1940,3-18 0,-1 4 0,4-3 0,-5 0 0,0 0 0</inkml:trace>
-  <inkml:trace contextRef="#ctx0" brushRef="#br0" timeOffset="223684">10017 16651 13020,'-5'26'-420,"-1"-1"0,-7 17 0,-4 2-330,3-12 1,-2-1 0,1 0 749,-4 14 0,-2-7 0,-13-5 0,22-45 0</inkml:trace>
-  <inkml:trace contextRef="#ctx0" brushRef="#br0" timeOffset="224624">10436 16157 7533,'-37'-19'2608,"10"-13"-1888,9 28-1,18-19 91,24 13 89,20 0-314,-9 6 0,4 0-46,9 3 1,2 2-450,-14 1 0,0 1 0,-1 0-30,-1 0 0,0-1 0,-2 3-15,8 5 0,-7 6 45,-1 19-990,-50 10 570,0-16 0,-7 3 1,0-1 239,0-3 0,-2 0 0,0 2-242,-1 2 1,-2 3 0,2 0-1,2 0 392,-1 7 0,4 1 0,0-2 120,-1-4 0,1 0 0,3-1 0,2 9 0,6-4-90,7-6 180,28-19 269,26-16-494,-13-7 0,3-2-765,-5 1 1,2-1-1,-2-1 0,9-5 1,-1 0-855,-1 1 0,-4 3 1815,-6 3 1,-36 16-1,-22 2 1</inkml:trace>
-  <inkml:trace contextRef="#ctx0" brushRef="#br0" timeOffset="224902">10423 16492 7533,'-32'-8'1638,"-1"-1"0,-8-1 1638,58 10-2100,8 4 1,7 2-1297,0-2 0,3-1 0,1 0-335,3-3 0,2 0 1,0 0-639,4-1 1,0 1 0,0-1-1,-6-2 1,-1 0 0,-3 1 1017,2 1 1,-4 2 0,7-1-1,-35 0 1</inkml:trace>
-  <inkml:trace contextRef="#ctx0" brushRef="#br0" timeOffset="225284">11161 15646 7533,'28'-14'1638,"-4"19"0,2 10-546,5 12 0,1 10 0,-1 2-964,-7-8 1,-1 1-1,0 3 1,-3 5-129,-4 1 0,-1 4 0,-2 4 0,-1 2 0,-2 0 0,-3-2-161,-1-4 0,-3 0 1,-1 1-1,-2-1 0,-1 1 1,0 1-213,0-1 0,-1 1 1,-1 1-1,-1 0 0,-1 0 1,-1-2-1,-2-2-92,-3 1 0,-1-1 1,-2-1-1,-1-1 0,-1-2 1,-1-1-38,-1 2 0,-2-1 1,0-1-1,-1-2 1,0-2 501,-1 2 0,0-2 0,0-2 0,-2-2 0,-7 4 0,-1-3 0,1-3 0,-3 0 0,-1 0 0</inkml:trace>
-  <inkml:trace contextRef="#ctx0" brushRef="#br0" timeOffset="228017">12294 16016 7533,'-12'-45'3238,"5"10"-2878,1 9-91,6 16-179,-5 34-90,4 11 0,0 8-68,-1-7 1,-1 4 0,0 1 0,0 1-238,2 3 0,1 1 0,0 0 0,0 1 89,0-5 0,-1 1 0,1 0 0,0-1 0,1-2 36,1 11 0,0-2 1,1-4-1,1-7 0,0-3 0,0-4-809,3 12-990,-1-66 1979,-6 13 0,-4-29 0,-3-8 0,0 17 0,0 1 0</inkml:trace>
-  <inkml:trace contextRef="#ctx0" brushRef="#br0" timeOffset="228336">12207 16034 7533,'6'-36'787,"0"0"0,0 0 0,12-11 0,6 6-248,1 9 1,7 11 135,15 17 0,3 14-436,-17 1 1,-1 4 0,-1 6-150,3 9 0,-2 7 0,-5 2-518,-5 1 1,-5 2 0,-6 1 157,-5-3 0,-6-1 1,-6 0 89,-5-2 0,-6-1 0,-5-6-450,-17-2 1,-4-8 89,7-2 0,1-5-494,-3-11 0,6-4 1034,10 2 0,38-24 0,8 10 0,0-1 0</inkml:trace>
-  <inkml:trace contextRef="#ctx0" brushRef="#br0" timeOffset="229068">13290 15804 7533,'-5'-45'2069,"-7"10"-1800,-7 10-89,-17 38-45,9 9 0,0 9-165,4 5 0,1 5 0,2 6-390,7-9 0,0 4 0,1 1 0,2 1 0,1-2 397,-1 4 1,3-1-1,1 0 1,4 2-104,3-4 0,3 4 0,3-1 0,1-2 0,2-5-243,7 5 0,3-6 0,2 0 369,1-1 0,1-2 0,-1-3 0,1-4 0,-4-3 0,2 8 0</inkml:trace>
-  <inkml:trace contextRef="#ctx0" brushRef="#br0" timeOffset="229417">13352 16087 8162,'-13'0'3276,"23"31"-2845,7-9 0,5 3-791,-1 1 0,2 1 1,1 0-271,-2-1 0,1-2 1,2-1-451,4-3 1,3-3 0,-4-1 1079,-6 1 0,0-9 0,8-21 0,-4-13 0,-17-3 0,1-1 0</inkml:trace>
-  <inkml:trace contextRef="#ctx0" brushRef="#br0" timeOffset="229636">13869 15963 7533,'0'-33'3276,"-11"19"-436,-14 22-2705,6 25 0,0 12-165,2-3 0,0 4 0,2 2-512,4-11 0,1 1 0,1 1 1,1 1-279,-2 9 1,2 2 0,0-1 0,3-4-274,3-1 1,2-4 0,1-1 1054,-2 0 0,0-1 1,6-6-1,7-9 0,5-7 1,9-9-1</inkml:trace>
-  <inkml:trace contextRef="#ctx0" brushRef="#br0" timeOffset="229858">14066 16581 10051,'-14'-2'1889,"-2"35"-3148,9 8 1259,3-8 0,-4 3 0,-10 2 0,-4 0 0,-1 3 0,-1 0 0</inkml:trace>
-  <inkml:trace contextRef="#ctx0" brushRef="#br0" timeOffset="230767">14399 16069 8702,'-28'-10'3276,"17"-13"-1425,30 11-1312,22-1 1,10 0-360,-8 4 0,4 1-30,-3 3 0,2 1 0,-2 3-330,2 2 0,-5 6 315,-12 4 0,-8 5-135,-16 9 0,-10 3-270,-13 7 0,-8 1 180,3-5 0,-2 1 1,-2 1-141,-6 3 0,-1 0 0,2 0 380,6-3 0,3 0 0,0 1 120,-1 0 0,1 1 0,5-3-46,6-2 1,5-3-90,7 0 0,6-3 315,20 2-225,1-20 0,6-2-540,6 1 0,3-3-765,2-4 1,1-3-555,-6 0 0,-3 0 1634,12-5 0,-58-14 0,-18 5 0</inkml:trace>
-  <inkml:trace contextRef="#ctx0" brushRef="#br0" timeOffset="230968">14472 16404 7533,'-44'-10'3276,"24"-5"0,38 13-3224,7-2 0,7 0-1267,16 3 1,2 2 674,-5-1 1,0 0 478,2 0 1,-4 0 0,-13 0 0,-3 0 0,21 0 0</inkml:trace>
-  <inkml:trace contextRef="#ctx0" brushRef="#br0" timeOffset="231318">14853 15734 7533,'-8'-12'3276,"31"30"-1638,7 9 0,3 8-1364,-2 0 1,1 3-1,0 3-857,-6-6 1,1 2-1,-2 2 1,-4 1 537,-2 4 0,-4 3 0,-3 1 0,-4-1 0,-4-1 0,-5-1 0,-2 1 0,-4-2-184,-4-3 1,-2 1-1,-4-3 1,-2-3-252,-8 3 0,-3-3 1,-1-5-540,-4 2 1,2-5 1018,8-11 0,8-1 0,15 2 0,18 0 0</inkml:trace>
-  <inkml:trace contextRef="#ctx0" brushRef="#br0" timeOffset="231819">16293 16228 8342,'-13'0'1529,"7"0"-899,25 3 0,13 2-406,-3-4 1,3 0-375,6 1 0,4 1 1,-1-1-631,-6-1 0,-1-1 1,-1-1 779,18-1 0,-20 4 0,-55 22 0,-15-9 0,0-1 0</inkml:trace>
-  <inkml:trace contextRef="#ctx0" brushRef="#br0" timeOffset="232017">16182 16528 9871,'28'-1'390,"0"0"0,12-3 0,5 2-840,-5 2 0,5 2 0,1 1 1,-3 0 175,0 0 1,-1 0 0,2-2 0,-1-1 0,4-2 0,-1 0 0,-1 1 0,-7 0 0,-1 1 0,1-1 0,0 1 0</inkml:trace>
-  <inkml:trace contextRef="#ctx0" brushRef="#br0" timeOffset="232751">18251 16087 7533,'-38'0'989,"21"15"1,3 9-901,2 13 1,4 6 90,3-1 0,2 5 0,0-1-203,2 3 0,1 0 0,1-2-7,1-3 0,-1-2 1,2-4 97,0 2 1,1-17 381,-3-39-630,3-27-113,-6 4 1,-2-11 0,-2-5-1,2 3-356,1 5 1,1 0 0,0-1 0,0-2 618,1 5 0,0-2 0,0-2 0,1 0 0,0 1 0,2 4 344,2-8 1,1 2 0,2 3 0,2 4 15,0-1 0,3 3 0,6 14 344,19 15 1,3 18-435,-11 15 0,-2 11 0,-1 1-121,0-5 1,-1 1 0,-3 2 0,2 12 0,-2 4 0,-10-1-180,-11-9 0,-7-1 0,-3-2 2,-2-1 0,-2-3 0,-5 0-242,-10 1 0,-6-2 1,0-5-241,-11-6 1,-1-7-1,1 0 0,4-6-629,-3-15 481,39 0 688,42-5 0,-3 6 0,5 0 0,9-5 0,-1 1 0</inkml:trace>
-  <inkml:trace contextRef="#ctx0" brushRef="#br0" timeOffset="233035">19026 15752 7533,'-22'-24'1092,"1"0"0,-6 11 0,-1 9 328,-3 20 0,-1 11-1330,4-3 0,-1 3 0,2 4-889,5 2 1,2 4 0,2 2 0,1-1 910,0-2 1,1 0-1,2 0 1,4 3-383,1 9 0,3 3 0,4 1 0,6-5-116,5-9 0,3-2 0,4-2 0,2-1-334,2 1 1,4-2-1,1-1 1,1-6 638,4-3 0,1-5 0,0-5 0,14-4 0,-2-8 0,-19-5 0,1 0 0</inkml:trace>
-  <inkml:trace contextRef="#ctx0" brushRef="#br0" timeOffset="233654">19370 15928 7533,'-11'-26'3276,"8"7"-1425,-8 33-1357,14 9 1,5 8-375,-2 4 0,0 5 0,1 1-188,4 6 0,1 1 0,2 0-540,0-8 1,1 1 0,1-1 0,0-2-293,1 2 1,0-3 0,1-2 383,10 7 0,-1-8-1643,3-10 2159,-17-24 0,-46-8 0,-15-2 0</inkml:trace>
-  <inkml:trace contextRef="#ctx0" brushRef="#br0" timeOffset="233903">19185 16669 7533,'-20'-28'1638,"32"-6"0,14-4-546,3 8 0,5 0 0,4-2-1145,-5 1 1,2-2 0,2-1 0,1-1 0,0 1-83,-7 6 0,1 1 0,0-1 0,0 1 1,0 0-1,-1-1-369,3-3 0,1 0 0,-1 0 1,-1 2-1,-3 1-589,7-7 1,-4 3 0,-4 3 32,-3 1 0,-6 5 1060,-9 5 0,-11 18 0,0 10 0</inkml:trace>
-  <inkml:trace contextRef="#ctx0" brushRef="#br0" timeOffset="234101">20084 16369 7533,'-5'43'1638,"-5"-14"0,-4 3-2287,-4 8 1,-2 0 648,0-2 0,0-1 0,-1-2 0,1-2 0,-5 10 0</inkml:trace>
-  <inkml:trace contextRef="#ctx0" brushRef="#br0" timeOffset="234951">20514 15946 7533,'-24'0'3276,"16"7"-1245,25 27-2346,6-11 0,5 1-435,0-1 1,3 2-1,2-3-343,0-2 1,1-1 0,0-3 623,7 6 1,1-9 0,5-19 0,-2-11 0,-13-8 0,0 1 0</inkml:trace>
-  <inkml:trace contextRef="#ctx0" brushRef="#br0" timeOffset="235186">21191 15804 7533,'-42'-2'3276,"3"20"-2566,20 6 0,-1 9 0,1 5 0,2-2-1048,3-1 1,1 1 0,2 1 0,-1 2-319,-1 3 1,0 3-1,0 1 1,1-1 0,2-3-438,0 8 1,2-3 0,3 1 272,4-7 1,2 1 0,2-2 0,-1-6 407,1-4 1,3-3-1,8 13 1,6-8-1,13-24 1</inkml:trace>
-  <inkml:trace contextRef="#ctx0" brushRef="#br0" timeOffset="235344">21302 16581 9691,'-25'0'1484,"7"15"1,1 9-1485,-3 6 0,1 4 0,9-2 0,1 2 0,1 0 0,1 4 0,-1 0 0,1 0 0</inkml:trace>
-  <inkml:trace contextRef="#ctx0" brushRef="#br0" timeOffset="236167">21782 16087 7533,'-21'-28'3276,"27"-5"-2531,15 22 1,7 2-207,16-4 1,5 1-330,-9 7 0,2 2 0,1 1-180,1-1 0,1 0 0,-3 1-120,8 1 0,-4 2 45,-10 1 0,-13 4-315,-40 20 45,-8-2 1,-7 4 284,-1 0 0,-3 2 0,-1 1-125,9-6 0,-1 2 1,1 0-1,0 1 155,-1 2 0,-1 1 0,3 1 0,2-1 90,0 5 0,3 0 0,5 0 62,0 9 0,10-2 28,11-14 0,8-5 0,8-9 0,7-5 404,13-3 1,3-6-630,5-4 0,2-2-826,-13 2 1,2 0 0,-3-1-120,4 0 1,-5-1-2288,12-3 3206,-40 8 0,-47 0 1,10 0-1,-1 0 1</inkml:trace>
-  <inkml:trace contextRef="#ctx0" brushRef="#br0" timeOffset="236429">21843 16334 7533,'-30'-20'3276,"15"4"0,26 16-2010,11 4 1,7 0-1357,15 1 0,5 0-630,-11 0 0,1 2 1,1-1-374,2-1 1,0 1 0,-1 0 761,-3 1 0,-2 0 0,-3-3 0,-4-5 0,-6-4 0,-5-7 0</inkml:trace>
-  <inkml:trace contextRef="#ctx0" brushRef="#br0" timeOffset="236754">22495 15681 7533,'31'-37'3276,"11"27"-2666,-9 29 1,1 13-937,-3 1 1,1 6 0,-2 5 379,-9-11 0,-1 4 0,-1 1 0,0 1 0,-2 0-108,0-1 0,-1 1 0,-1 0 0,-2 1 0,-4 4-21,-4 2 0,-3 4 0,-3 1 0,-3 1 0,-1-2 0,-2-3 3,-2-4 0,-3-1 0,-2-2 0,-1 0 0,-2 0 102,1 0 0,-1 2 0,-1-1 0,-2 0 0,0-5 0,-2-4-690,-15 4 1,-2-7-1,4-4 480,1 3 1,3-9 315,-9-19 1,63-32 0,-6 13 0,0-1 0</inkml:trace>
-  <inkml:trace contextRef="#ctx0" brushRef="#br0" timeOffset="236894">23222 16951 7533,'-36'0'0,"20"16"0,-6 3 0</inkml:trace>
+  <inkml:trace contextRef="#ctx0" brushRef="#br0" timeOffset="-214711.73">12799 13494 7533,'3'-27'1638,"0"1"0,3-4-237,-6 15-1446,0 35 0,0 17-405,-3 6 1,0 6-371,3-13 1,0 4 0,-1 1 0,1 0 14,-1 5 0,-1 2 0,1-1 0,0-1 805,1 6 0,0-2 0,0-3 0,-4 6 0,-3-10 0,-7-14 0</inkml:trace>
+  <inkml:trace contextRef="#ctx0" brushRef="#br0" timeOffset="-214545.73">12724 13935 7533,'-6'-49'1092,"0"0"0,4 15 0,3 3 2184,17-10-2273,31 41-2053,-10 4 1,7 3 0,-1 0 1049,-6-1 0,-1 1 0,3-1 0,2-1 0,4 0 0,1-1 0,-3 0 0,3-2 0,0 1 0,-1 0 0</inkml:trace>
+  <inkml:trace contextRef="#ctx0" brushRef="#br0" timeOffset="-213979.73">13598 13935 8612,'7'-28'2519,"-1"11"-1800,-1 1-809,-3 30-449,3 21-361,-4-1 1,-2 4 899,2-4 0,0 2 0,3 0 0,3 2 0,3 1 0,1 0 0,2 2 0,1 0 0,-1 0 0</inkml:trace>
+  <inkml:trace contextRef="#ctx0" brushRef="#br0" timeOffset="-213445.73">13832 14005 7533,'-37'-19'2608,"6"50"-2473,19 3 0,5 7-135,2-2 0,1 4 0,2 0 30,2 2 0,2 0 0,1-2-480,2 6 1,3-6 628,0-10 1,3-15 810,13-59-661,-15 10 1,-4-6 0,0-3-218,-1 1 1,-1-3-1,0-3 1,0 1-769,0 4 1,0-2-1,1 0 1,-1 1 0,0 2 848,-1-13 1,0 2-1,2 3-13,3 3 0,1 1 0,6 12 290,23 12-650,8 38-120,-22 3 0,-1 6 0,-1 1 165,1 8 0,-3 2 165,-4-5 0,-1 2 0,-2-4-75,-3-6 0,-6-3 315,-25 18-809,4-41 2586,-28-17-3936,25-3 1889,4-5 0,33 4 0,11 0 0,4-2 0,0-1 0</inkml:trace>
+  <inkml:trace contextRef="#ctx0" brushRef="#br0" timeOffset="-212977.73">14509 13247 7533,'-37'-30'3276,"0"30"-2756,15 18 1,2 9-581,7 1 0,3 5 0,0 3 60,0-2 0,0 3 0,1 1 0,2 1-476,2 7 0,2 1 0,2 1 1,2 0 295,1 1 0,1 2 0,2-1 0,3-2 0,0-5 0,1-1 0,3-2 0,4-5 252,5 1 1,4-6 0,3-8-118,12-6 0,0-16 375,-11-13 0,-2-9 0,-2-4 59,0-1 1,-2-4 0,-3-3-139,-2-8 1,-4-3-1,-2 1 19,-1 6 0,-2 1 0,-5 2 674,-10-11 1,-11 12 404,-28 32-1574,12 24 0,2 13-645,11-3 1,3 5 0,4 2-66,4 1 0,5 2 0,4-1 275,6-3 1,4-2-1,0-2 132,0 1 1,3-6 0,26 3 0,-25-42 0</inkml:trace>
+  <inkml:trace contextRef="#ctx0" brushRef="#br0" timeOffset="-212805.73">13709 13458 7533,'-39'-9'468,"37"1"0,30 6 0,17 4 0,-7-2 0,1 0 0,0 0 0</inkml:trace>
+  <inkml:trace contextRef="#ctx0" brushRef="#br0" timeOffset="-212179.73">15690 13723 8252,'-31'-2'3276,"1"20"-2441,20 8 1,6 8-506,2 2 0,2 3 0,2 0-270,2-3 0,2-1 0,3 0 90,8 9 0,5 0 0,3-12 524,7-18 1,4-13-181,11-14 1,-3-13-450,-15-1 0,-6-9-90,-6 4 0,-2-6 0,-1-2 0,-4 5-945,0-7 1,-3 2 59,1 4 1,0-2 0,-1 6-2348,4-3 3193,-4 39 1,4 17-1,1 9 1,1-3 0,0 1-1</inkml:trace>
+  <inkml:trace contextRef="#ctx0" brushRef="#br0" timeOffset="-211196.73">16405 13917 7533,'-3'-26'1638,"0"-1"0,-4-18 303,-11 10-1581,-1 17-181,-6 10-718,-5 16 89,-1 10 90,7 1 0,0 5 855,1 6 0,1 3-181,-1 2 1,2 2 90,4 6 0,4 0-450,6-1 0,7-3-270,8-9 0,7-3-180,8-2 1,5-9-226,6-19 1,1-10-316,6-6 1,-2-7 404,-5-9 1,-5-3 449,-5 6 0,-4 0 360,-9 1 0,-5 3 719,-7 8 91,-12 13-91,6 32-179,2 20-451,4-18 1,2 1 90,3 7 0,3-1 0,7 5 0,11-6-181,5-64-359,-12 4 1,1-3 149,-4 1 0,1-2 0,2 1 60,3-1 0,1 1 0,2 3-255,12-7 0,3 5 180,4 5 0,0 5 0,-5 9 0,-1 2 899,-5 0 1,-2 0 1484,7-1-1350,-30-25-719,-37 13-90,3 2 0,-4 4-270,-6 15 0,-1 6-855,7 1 1,4 6 89,5 14 1,9 7 179,16 5 1,11 2 464,-2-11 0,4 0 0,1 0 240,3 5 0,2 1 0,0-3 105,10 5 0,-3-1 359,-11-5 1,-4-4 45,-4-2-990,-21-18-2608,2-8 3058,4 7 0,39-5 0,13 6 0</inkml:trace>
+  <inkml:trace contextRef="#ctx0" brushRef="#br0" timeOffset="-211062.73">17290 14252 7533,'-12'-19'819,"5"3"0,2 32 0,5 3 0</inkml:trace>
+  <inkml:trace contextRef="#ctx0" brushRef="#br0" timeOffset="-209012.73">6547 15946 9062,'-3'37'652,"0"0"0,1 0 0,0 4 0,0 5-592,0-10 0,-1 5 0,1 3 0,0 0 0,0 0 0,0-3-475,1 3 1,1 0 0,0-2 0,1 1 0,-2 0 324,0 3 0,0 2 0,0-1 0,0-3 0,1-6 315,3 19 0,0-27 273,-3-38-993,0-26 0,0-13 202,-2 14 1,-1-5 0,0-1 0,0-1-182,0 0 0,1-1 0,-1-1 1,0-2-1,0-1 474,-1-1 0,-1-2 0,-1-2 0,1 1 0,-1 0 0,2 3 413,-1 0 1,0 1 0,1 1 0,0 1 0,1-1-91,-1 0 1,1-2 0,0 1 0,2 4 0,5 6 429,9-10 0,9 11-349,15 12 1,7 11-375,-4 11 0,2 7 0,1 2 0,-2 0 0,0 2 0,-2 6 90,3 9 0,-1 6 0,-9 4 87,-10 0 1,-7 4-1,-5 1-207,-4 4 0,-6 1 0,-7-1-135,-6-11 0,-5 1 0,-3-3 0,-1-2-15,-6 1 0,-2-3 1,-4-5 89,-5-3 0,-3-5 0,3-7-120,3-5 0,4-8-1304,0-6 0,13-5-315,35-11 1799,1 9 0,6 2 0,6 8 0,7 2 0,0 1 0,2-4 0,0 1 0,1-1 0</inkml:trace>
+  <inkml:trace contextRef="#ctx0" brushRef="#br0" timeOffset="-208609.73">7569 15681 7533,'-7'-45'3276,"-4"10"0,4 17-2453,-28 18-1003,11 23 1,-2 11 119,-4-2 0,-4 3 0,1 6-457,8-6 0,-1 4 0,1 2 0,0 2 0,1 0 772,3-3 0,0 2 0,0 0 0,1 1 0,0 0 0,2-2 50,-3 6 1,1-2 0,1 1 0,3 0 0,4 0-199,4-1 1,2 1 0,3 0 0,4-2 0,3-4-816,6 7 1,6-5-1,4-3 108,2-4 1,4-2-1,3-5-450,3-10 1,4-4 0,-3-3 1049,-4 0 0,-2-7 0,7-15 0,-5-9 0,-4-19 0</inkml:trace>
+  <inkml:trace contextRef="#ctx0" brushRef="#br0" timeOffset="-207826.73">7753 16122 7533,'-20'-18'2248,"-3"-7"-808,10 5 269,1 3-1170,6 9 91,17 39-181,0 2 1,3 5-240,-1-6 0,2 2 0,1 2-451,0 6 0,0 3 0,2-1-179,4 0 1,3 0-1,-1-1-210,-4-5 1,-1-2-1,1 0-30,0-2 1,2-2-1,-3-2-105,1-2 1,-3-3-1305,7 8 2069,-17-15 0,-13-8 0,-8-2 0</inkml:trace>
+  <inkml:trace contextRef="#ctx0" brushRef="#br0" timeOffset="-207476.73">7777 16863 7533,'-42'-8'3276,"20"-2"-526,17-23-1761,25 1 1,13-5-473,-10 11 0,3-3 1,1-1-1,2 0-809,0-1 1,1 0 0,2-1-1,1-1 1,0-1 96,-1 1 0,1-1 0,1-1 0,0 0 1,-2 2-1,-1 1 127,3-4 1,-1 2-1,-2 2 1,0-1-753,0 0 1,1 0 0,-3 2 0,-8 4-2229,-1-16 1969,-4 8-1260,-15 15 2339,4 5 0,-10 22 0,-1 3 0</inkml:trace>
+  <inkml:trace contextRef="#ctx0" brushRef="#br0" timeOffset="-207045.73">8836 15804 7533,'-6'-27'3276,"5"17"-1335,1 51-1312,0-8 1,1 5 0,-1 5-1097,1-5 0,-1 3 0,0 2 0,0 1 1,-1 2 451,1-2 0,-1 2 0,0 1 0,-1 1 0,1-1 0,-1-1-60,1-2 0,-1 0 0,-1-1 0,1 0 0,0-1 0,0-1-19,0 11 0,0-2 0,1-2 0,-1-6-221,-1 6 1,1-12-237,2-20 551,0-50 0,9 5 0,4-4 0,0-12 0,1 0 0</inkml:trace>
+  <inkml:trace contextRef="#ctx0" brushRef="#br0" timeOffset="-206328.73">9340 15998 7083,'-19'-17'3058,"1"-1"-2428,6 8-180,5-5 179,-3 13 181,8-6 269,-3 16-89,15 17-676,6 7 1,4 5-615,-1-10 0,2 1 1,2 1-352,4 9 1,3 1 0,0-2-443,-1-7 1,0-3 0,1-2-547,11 4 1,-3-5 1635,2 0 0,-13-40 0,-27-4 0</inkml:trace>
+  <inkml:trace contextRef="#ctx0" brushRef="#br0" timeOffset="-206010.73">9869 15981 7533,'0'-18'3276,"-5"-7"0,-2 21-2453,-11 21-823,7 8 0,-1 9 0,0 2-180,-1-2 0,-1 3 1,0 3-1,-1 1-367,2-4 1,0 2 0,0 1 0,-1 1 0,0 0 0,0-1 331,-3 5 1,-1 0-1,0-1 1,0 0-1,2-1 327,-2 6 1,2 0-1,0-3 1,1-4 47,-1-3 1,1-4-1,5-7-3437,10-2 1337,31-36 1940,3-18 0,-1 4 0,4-3 0,-5 0 0,0 0 0</inkml:trace>
+  <inkml:trace contextRef="#ctx0" brushRef="#br0" timeOffset="-205812.73">10017 16651 13020,'-5'26'-420,"-1"-1"0,-7 17 0,-4 2-330,3-12 1,-2-1 0,1 0 749,-4 14 0,-2-7 0,-13-5 0,22-45 0</inkml:trace>
+  <inkml:trace contextRef="#ctx0" brushRef="#br0" timeOffset="-204872.73">10436 16157 7533,'-37'-19'2608,"10"-13"-1888,9 28-1,18-19 91,24 13 89,20 0-314,-9 6 0,4 0-46,9 3 1,2 2-450,-14 1 0,0 1 0,-1 0-30,-1 0 0,0-1 0,-2 3-15,8 5 0,-7 6 45,-1 19-990,-50 10 570,0-16 0,-7 3 1,0-1 239,0-3 0,-2 0 0,0 2-242,-1 2 1,-2 3 0,2 0-1,2 0 392,-1 7 0,4 1 0,0-2 120,-1-4 0,1 0 0,3-1 0,2 9 0,6-4-90,7-6 180,28-19 269,26-16-494,-13-7 0,3-2-765,-5 1 1,2-1-1,-2-1 0,9-5 1,-1 0-855,-1 1 0,-4 3 1815,-6 3 1,-36 16-1,-22 2 1</inkml:trace>
+  <inkml:trace contextRef="#ctx0" brushRef="#br0" timeOffset="-204594.73">10423 16492 7533,'-32'-8'1638,"-1"-1"0,-8-1 1638,58 10-2100,8 4 1,7 2-1297,0-2 0,3-1 0,1 0-335,3-3 0,2 0 1,0 0-639,4-1 1,0 1 0,0-1-1,-6-2 1,-1 0 0,-3 1 1017,2 1 1,-4 2 0,7-1-1,-35 0 1</inkml:trace>
+  <inkml:trace contextRef="#ctx0" brushRef="#br0" timeOffset="-204212.73">11161 15646 7533,'28'-14'1638,"-4"19"0,2 10-546,5 12 0,1 10 0,-1 2-964,-7-8 1,-1 1-1,0 3 1,-3 5-129,-4 1 0,-1 4 0,-2 4 0,-1 2 0,-2 0 0,-3-2-161,-1-4 0,-3 0 1,-1 1-1,-2-1 0,-1 1 1,0 1-213,0-1 0,-1 1 1,-1 1-1,-1 0 0,-1 0 1,-1-2-1,-2-2-92,-3 1 0,-1-1 1,-2-1-1,-1-1 0,-1-2 1,-1-1-38,-1 2 0,-2-1 1,0-1-1,-1-2 1,0-2 501,-1 2 0,0-2 0,0-2 0,-2-2 0,-7 4 0,-1-3 0,1-3 0,-3 0 0,-1 0 0</inkml:trace>
+  <inkml:trace contextRef="#ctx0" brushRef="#br0" timeOffset="-201479.73">12294 16016 7533,'-12'-45'3238,"5"10"-2878,1 9-91,6 16-179,-5 34-90,4 11 0,0 8-68,-1-7 1,-1 4 0,0 1 0,0 1-238,2 3 0,1 1 0,0 0 0,0 1 89,0-5 0,-1 1 0,1 0 0,0-1 0,1-2 36,1 11 0,0-2 1,1-4-1,1-7 0,0-3 0,0-4-809,3 12-990,-1-66 1979,-6 13 0,-4-29 0,-3-8 0,0 17 0,0 1 0</inkml:trace>
+  <inkml:trace contextRef="#ctx0" brushRef="#br0" timeOffset="-201160.73">12207 16034 7533,'6'-36'787,"0"0"0,0 0 0,12-11 0,6 6-248,1 9 1,7 11 135,15 17 0,3 14-436,-17 1 1,-1 4 0,-1 6-150,3 9 0,-2 7 0,-5 2-518,-5 1 1,-5 2 0,-6 1 157,-5-3 0,-6-1 1,-6 0 89,-5-2 0,-6-1 0,-5-6-450,-17-2 1,-4-8 89,7-2 0,1-5-494,-3-11 0,6-4 1034,10 2 0,38-24 0,8 10 0,0-1 0</inkml:trace>
+  <inkml:trace contextRef="#ctx0" brushRef="#br0" timeOffset="-200428.73">13290 15804 7533,'-5'-45'2069,"-7"10"-1800,-7 10-89,-17 38-45,9 9 0,0 9-165,4 5 0,1 5 0,2 6-390,7-9 0,0 4 0,1 1 0,2 1 0,1-2 397,-1 4 1,3-1-1,1 0 1,4 2-104,3-4 0,3 4 0,3-1 0,1-2 0,2-5-243,7 5 0,3-6 0,2 0 369,1-1 0,1-2 0,-1-3 0,1-4 0,-4-3 0,2 8 0</inkml:trace>
+  <inkml:trace contextRef="#ctx0" brushRef="#br0" timeOffset="-200079.73">13352 16087 8162,'-13'0'3276,"23"31"-2845,7-9 0,5 3-791,-1 1 0,2 1 1,1 0-271,-2-1 0,1-2 1,2-1-451,4-3 1,3-3 0,-4-1 1079,-6 1 0,0-9 0,8-21 0,-4-13 0,-17-3 0,1-1 0</inkml:trace>
+  <inkml:trace contextRef="#ctx0" brushRef="#br0" timeOffset="-199860.73">13869 15963 7533,'0'-33'3276,"-11"19"-436,-14 22-2705,6 25 0,0 12-165,2-3 0,0 4 0,2 2-512,4-11 0,1 1 0,1 1 1,1 1-279,-2 9 1,2 2 0,0-1 0,3-4-274,3-1 1,2-4 0,1-1 1054,-2 0 0,0-1 1,6-6-1,7-9 0,5-7 1,9-9-1</inkml:trace>
+  <inkml:trace contextRef="#ctx0" brushRef="#br0" timeOffset="-199638.73">14066 16581 10051,'-14'-2'1889,"-2"35"-3148,9 8 1259,3-8 0,-4 3 0,-10 2 0,-4 0 0,-1 3 0,-1 0 0</inkml:trace>
+  <inkml:trace contextRef="#ctx0" brushRef="#br0" timeOffset="-198729.73">14399 16069 8702,'-28'-10'3276,"17"-13"-1425,30 11-1312,22-1 1,10 0-360,-8 4 0,4 1-30,-3 3 0,2 1 0,-2 3-330,2 2 0,-5 6 315,-12 4 0,-8 5-135,-16 9 0,-10 3-270,-13 7 0,-8 1 180,3-5 0,-2 1 1,-2 1-141,-6 3 0,-1 0 0,2 0 380,6-3 0,3 0 0,0 1 120,-1 0 0,1 1 0,5-3-46,6-2 1,5-3-90,7 0 0,6-3 315,20 2-225,1-20 0,6-2-540,6 1 0,3-3-765,2-4 1,1-3-555,-6 0 0,-3 0 1634,12-5 0,-58-14 0,-18 5 0</inkml:trace>
+  <inkml:trace contextRef="#ctx0" brushRef="#br0" timeOffset="-198528.73">14472 16404 7533,'-44'-10'3276,"24"-5"0,38 13-3224,7-2 0,7 0-1267,16 3 1,2 2 674,-5-1 1,0 0 478,2 0 1,-4 0 0,-13 0 0,-3 0 0,21 0 0</inkml:trace>
+  <inkml:trace contextRef="#ctx0" brushRef="#br0" timeOffset="-198178.73">14853 15734 7533,'-8'-12'3276,"31"30"-1638,7 9 0,3 8-1364,-2 0 1,1 3-1,0 3-857,-6-6 1,1 2-1,-2 2 1,-4 1 537,-2 4 0,-4 3 0,-3 1 0,-4-1 0,-4-1 0,-5-1 0,-2 1 0,-4-2-184,-4-3 1,-2 1-1,-4-3 1,-2-3-252,-8 3 0,-3-3 1,-1-5-540,-4 2 1,2-5 1018,8-11 0,8-1 0,15 2 0,18 0 0</inkml:trace>
+  <inkml:trace contextRef="#ctx0" brushRef="#br0" timeOffset="-197677.73">16293 16228 8342,'-13'0'1529,"7"0"-899,25 3 0,13 2-406,-3-4 1,3 0-375,6 1 0,4 1 1,-1-1-631,-6-1 0,-1-1 1,-1-1 779,18-1 0,-20 4 0,-55 22 0,-15-9 0,0-1 0</inkml:trace>
+  <inkml:trace contextRef="#ctx0" brushRef="#br0" timeOffset="-197479.73">16182 16528 9871,'28'-1'390,"0"0"0,12-3 0,5 2-840,-5 2 0,5 2 0,1 1 1,-3 0 175,0 0 1,-1 0 0,2-2 0,-1-1 0,4-2 0,-1 0 0,-1 1 0,-7 0 0,-1 1 0,1-1 0,0 1 0</inkml:trace>
+  <inkml:trace contextRef="#ctx0" brushRef="#br0" timeOffset="-196745.73">18251 16087 7533,'-38'0'989,"21"15"1,3 9-901,2 13 1,4 6 90,3-1 0,2 5 0,0-1-203,2 3 0,1 0 0,1-2-7,1-3 0,-1-2 1,2-4 97,0 2 1,1-17 381,-3-39-630,3-27-113,-6 4 1,-2-11 0,-2-5-1,2 3-356,1 5 1,1 0 0,0-1 0,0-2 618,1 5 0,0-2 0,0-2 0,1 0 0,0 1 0,2 4 344,2-8 1,1 2 0,2 3 0,2 4 15,0-1 0,3 3 0,6 14 344,19 15 1,3 18-435,-11 15 0,-2 11 0,-1 1-121,0-5 1,-1 1 0,-3 2 0,2 12 0,-2 4 0,-10-1-180,-11-9 0,-7-1 0,-3-2 2,-2-1 0,-2-3 0,-5 0-242,-10 1 0,-6-2 1,0-5-241,-11-6 1,-1-7-1,1 0 0,4-6-629,-3-15 481,39 0 688,42-5 0,-3 6 0,5 0 0,9-5 0,-1 1 0</inkml:trace>
+  <inkml:trace contextRef="#ctx0" brushRef="#br0" timeOffset="-196461.73">19026 15752 7533,'-22'-24'1092,"1"0"0,-6 11 0,-1 9 328,-3 20 0,-1 11-1330,4-3 0,-1 3 0,2 4-889,5 2 1,2 4 0,2 2 0,1-1 910,0-2 1,1 0-1,2 0 1,4 3-383,1 9 0,3 3 0,4 1 0,6-5-116,5-9 0,3-2 0,4-2 0,2-1-334,2 1 1,4-2-1,1-1 1,1-6 638,4-3 0,1-5 0,0-5 0,14-4 0,-2-8 0,-19-5 0,1 0 0</inkml:trace>
+  <inkml:trace contextRef="#ctx0" brushRef="#br0" timeOffset="-195842.73">19370 15928 7533,'-11'-26'3276,"8"7"-1425,-8 33-1357,14 9 1,5 8-375,-2 4 0,0 5 0,1 1-188,4 6 0,1 1 0,2 0-540,0-8 1,1 1 0,1-1 0,0-2-293,1 2 1,0-3 0,1-2 383,10 7 0,-1-8-1643,3-10 2159,-17-24 0,-46-8 0,-15-2 0</inkml:trace>
+  <inkml:trace contextRef="#ctx0" brushRef="#br0" timeOffset="-195593.73">19185 16669 7533,'-20'-28'1638,"32"-6"0,14-4-546,3 8 0,5 0 0,4-2-1145,-5 1 1,2-2 0,2-1 0,1-1 0,0 1-83,-7 6 0,1 1 0,0-1 0,0 1 1,0 0-1,-1-1-369,3-3 0,1 0 0,-1 0 1,-1 2-1,-3 1-589,7-7 1,-4 3 0,-4 3 32,-3 1 0,-6 5 1060,-9 5 0,-11 18 0,0 10 0</inkml:trace>
+  <inkml:trace contextRef="#ctx0" brushRef="#br0" timeOffset="-195395.73">20084 16369 7533,'-5'43'1638,"-5"-14"0,-4 3-2287,-4 8 1,-2 0 648,0-2 0,0-1 0,-1-2 0,1-2 0,-5 10 0</inkml:trace>
+  <inkml:trace contextRef="#ctx0" brushRef="#br0" timeOffset="-194545.73">20514 15946 7533,'-24'0'3276,"16"7"-1245,25 27-2346,6-11 0,5 1-435,0-1 1,3 2-1,2-3-343,0-2 1,1-1 0,0-3 623,7 6 1,1-9 0,5-19 0,-2-11 0,-13-8 0,0 1 0</inkml:trace>
+  <inkml:trace contextRef="#ctx0" brushRef="#br0" timeOffset="-194310.73">21191 15804 7533,'-42'-2'3276,"3"20"-2566,20 6 0,-1 9 0,1 5 0,2-2-1048,3-1 1,1 1 0,2 1 0,-1 2-319,-1 3 1,0 3-1,0 1 1,1-1 0,2-3-438,0 8 1,2-3 0,3 1 272,4-7 1,2 1 0,2-2 0,-1-6 407,1-4 1,3-3-1,8 13 1,6-8-1,13-24 1</inkml:trace>
+  <inkml:trace contextRef="#ctx0" brushRef="#br0" timeOffset="-194152.73">21302 16581 9691,'-25'0'1484,"7"15"1,1 9-1485,-3 6 0,1 4 0,9-2 0,1 2 0,1 0 0,1 4 0,-1 0 0,1 0 0</inkml:trace>
+  <inkml:trace contextRef="#ctx0" brushRef="#br0" timeOffset="-193329.73">21782 16087 7533,'-21'-28'3276,"27"-5"-2531,15 22 1,7 2-207,16-4 1,5 1-330,-9 7 0,2 2 0,1 1-180,1-1 0,1 0 0,-3 1-120,8 1 0,-4 2 45,-10 1 0,-13 4-315,-40 20 45,-8-2 1,-7 4 284,-1 0 0,-3 2 0,-1 1-125,9-6 0,-1 2 1,1 0-1,0 1 155,-1 2 0,-1 1 0,3 1 0,2-1 90,0 5 0,3 0 0,5 0 62,0 9 0,10-2 28,11-14 0,8-5 0,8-9 0,7-5 404,13-3 1,3-6-630,5-4 0,2-2-826,-13 2 1,2 0 0,-3-1-120,4 0 1,-5-1-2288,12-3 3206,-40 8 0,-47 0 1,10 0-1,-1 0 1</inkml:trace>
+  <inkml:trace contextRef="#ctx0" brushRef="#br0" timeOffset="-193067.73">21843 16334 7533,'-30'-20'3276,"15"4"0,26 16-2010,11 4 1,7 0-1357,15 1 0,5 0-630,-11 0 0,1 2 1,1-1-374,2-1 1,0 1 0,-1 0 761,-3 1 0,-2 0 0,-3-3 0,-4-5 0,-6-4 0,-5-7 0</inkml:trace>
+  <inkml:trace contextRef="#ctx0" brushRef="#br0" timeOffset="-192742.73">22495 15681 7533,'31'-37'3276,"11"27"-2666,-9 29 1,1 13-937,-3 1 1,1 6 0,-2 5 379,-9-11 0,-1 4 0,-1 1 0,0 1 0,-2 0-108,0-1 0,-1 1 0,-1 0 0,-2 1 0,-4 4-21,-4 2 0,-3 4 0,-3 1 0,-3 1 0,-1-2 0,-2-3 3,-2-4 0,-3-1 0,-2-2 0,-1 0 0,-2 0 102,1 0 0,-1 2 0,-1-1 0,-2 0 0,0-5 0,-2-4-690,-15 4 1,-2-7-1,4-4 480,1 3 1,3-9 315,-9-19 1,63-32 0,-6 13 0,0-1 0</inkml:trace>
+  <inkml:trace contextRef="#ctx0" brushRef="#br0" timeOffset="-192602.73">23222 16951 7533,'-36'0'0,"20"16"0,-6 3 0</inkml:trace>
 </inkml:ink>
 </file>
 
@@ -2081,136 +1633,136 @@
   <inkml:trace contextRef="#ctx0" brushRef="#br0" timeOffset="210301">3052 9754 7533,'-30'-12'1638,"1"-1"0,-12 1-1520,5-11 0,54 5 1,5 4-1,1 0 0</inkml:trace>
   <inkml:trace contextRef="#ctx0" brushRef="#br0" timeOffset="213219">2928 11324 7083,'-10'-10'270,"2"-5"-90,1 13 90,5-6 539,-6 0-539,8-2 270,0-7-1,0 7-269,0 2-90,0 8-270,0 16 0,0 11 135,-1 8 0,2 7 15,1-6 0,1 2 0,0 3-222,-1-3 0,0 3 1,0 0-1,1 0 184,1-1 1,0 1 0,1 0-1,0 0-22,1 0 0,1 1 0,0-1 0,-1-1-30,-2 8 0,-1-1 0,1-1 0,4-1 0,1-1 0,-2 1 30,-3 3 0,-1 1 0,0 1 120,0-3 0,0 1 0,0 0 15,0-11 0,-1-1 0,0 2 0,-1 2 62,0-2 1,-1 3 0,0 1 0,-1-1 0,1 0-108,0 7 0,0-1 0,0 1 0,0 3-577,1-5 1,0 4 0,1 0 0,0 1 0,-1-2 0,0-3 508,0 5 0,-1-4 1,0 0-1,1 2-22,1-6 0,0 2 0,1 1 0,0 0 0,0-2 0,0-3-246,-1 3 0,0-4 1,1 0-1,0 3 228,0-2 0,0 2 0,1 1 0,0 1 0,-1-1-54,1 3 0,0 1 0,-1 0 0,1-1 0,-1-2 27,0 3 0,-1-2 0,0 0 1,1 2 44,-1-2 0,2 2 0,-1 1 0,0-1 0,0-3 157,0-1 0,-1-1 1,1-1-1,-1 1-121,0-3 0,0 0 0,0 1 0,0 0 0,0-1 31,2 9 1,0-1-1,0 1 1,0-1-203,-3-1 0,-1 0 0,0-1 0,1 0 112,0-3 1,2-1 0,-1 0-1,-1 0 90,0 1 1,-1 0-1,0 0 1,-1 0 179,0 3 1,-1 1-1,-1-1 1,2-1-226,0-2 0,1-1 1,0-1-1,-1 0-119,-3-1 1,0-1 0,0 0 0,0 0-114,1 10 0,1-1 0,-3-2 30,-3-8 0,-1-1 1,1 0-31,3 2 0,2 1 0,-1-4 30,-5 1 0,2-3-3097,7 15 3129,0-37 0,16 3 1,3-15-1</inkml:trace>
   <inkml:trace contextRef="#ctx0" brushRef="#br0" timeOffset="214320">3016 17004 8702,'-19'0'900,"3"0"-271,32 8-179,27-6-225,-6 2 0,6 0-46,-4-4 1,2 0 0,3 0-174,-5 0 1,2 0 0,1 0 0,2 0-43,-2 0 0,1 0 0,2 1 0,0-2 0,0 1-349,1-3 0,1 0 0,0-1 1,1 0-1,-1 2 385,0 1 0,1 0 0,0 1 0,0 0 0,0-2 30,-6-1 0,1-1 0,0 0 0,0-1 0,0 1 0,0 0-140,-1 2 0,0 0 1,0 0-1,0 0 1,1 1-1,0 1 155,1 0 0,1 0 0,0 1 0,0 0 0,0 1 0,-1-1-15,1 1 0,0-1 0,0 0 0,0 1 0,-1 0 0,0 2-84,6 3 0,-1 1 0,0 2 0,-1 0 0,0-2 54,0 0 0,-1 0 0,-1-1 0,1 0 0,0 1 18,1-1 0,0 0 0,-1 1 0,1-1 0,1-1-18,-6-1 0,1-1 0,1 0 0,-1 0 0,-1 0 0,-1 0 0,0 1 0,-2 1 0,0 0 0,0-1 0,0-1 18,4-1 0,0-2 0,0 0 0,0 2 0,-1 1 0,-3 2 0,0 3 0,0 0 0,-1-1 0,0-1-128,8-2 1,-1-2-1,1-1 1,1 2 145,-4 0 0,0 2 0,2 0 0,-1-1 0,0-1-36,-2-1 0,0-1 0,0-1 0,-1 0 0,0 0 0,8 0 0,-1-1 0,0 0 0,-1-1 0,-3-1 0,0 0 0,-1 0 0,1 0 112,3 1 0,0 1 1,0 0-1,-3-1-52,-2-2 0,-2 0 0,2 1 30,0 3 0,2 1 0,0 0 0,-2 1 139,2 0 0,-1 0 0,0 1-274,-7 0 0,2 1 0,-1-1 0,1 0 0,1 0 0,1-2 0,-1 0 0,-2 0 45,2 1 0,-3 0 0,3-1 202,-2-1 1,3-1-1,-1-1 1,-3 1-23,-1 0 0,-2 1 0,1-2 343,11-1 0,2-1 0,-2 0-493,-9 3 0,-2-1 0,0 0 544,0-1 0,-1-1 0,-1 0-169,6 4 0,-3-2-270,-5-2 0,0-1 575,1-1 1,0 0-981,-6 0 0,0 0 565,2-3 1,0 0-656,20 6-211,-6-5-509,-14 14-1346,11-5 2426,-18 6 0,9-8 0,-6 0 0</inkml:trace>
-  <inkml:trace contextRef="#ctx0" brushRef="#br0" timeOffset="216108">10091 17445 6813,'-12'-10'900,"5"2"-631,2 8-89,5-8 450,0 6 539,0-5-269,0-1 269,0 14-179,10-4-406,5 24 1,1 12-465,-1-7 0,2 3 0,1 1-517,-1 1 0,2 3 1,0 1-1,0-2 149,-3-3 1,0 1 0,0-2 0,0-2-23,3 3 0,0-2 0,-2-5-449,7 13-91,-13-33-359,-11-8-720,0-15 1889,0 3 0,-5-6 0,-2 10 0</inkml:trace>
-  <inkml:trace contextRef="#ctx0" brushRef="#br0" timeOffset="216867">10005 18009 6633,'-14'0'-90,"3"8"360,11-6 989,0 6-629,0-8-450,0 0 270,0 8-1,0-6 1,0 6 1529,0-8 270,28-40-1830,-6 14 1,6-5 0,0 0-365,0-2 1,0-2-1,5-3-40,-7 10 0,4-4 0,1-1 0,1 1 0,-3 1 0,-2 3-645,2-5 1,-2 3-1,0-1-330,9-7 1,1-1 0,-8 8-30,-5 6 989,-17 9 0,-2 6 0,-5-7 0</inkml:trace>
-  <inkml:trace contextRef="#ctx0" brushRef="#br0" timeOffset="218386">1923 11007 7263,'-20'-8'1529,"4"6"-1259,16-14 0,0 14 449,0 2 271,0 10-1,0 23-449,16 12-765,-8-14 0,4 1 90,11 8 0,5-1-180,-6-10 1,3-2-901,9 1 1,0-5 1214,5 3 0,-5-16 0,-26-3 0</inkml:trace>
-  <inkml:trace contextRef="#ctx0" brushRef="#br0" timeOffset="218834">2417 10936 9152,'-10'-10'1439,"2"10"-450,-8 26-854,0 11 0,-3 10-90,2-13 0,-2 3 0,-2 2 0,0 2-492,2-6 0,0 2 0,-1 1 0,0 1 0,0-1 0,2-2 303,-1 2 0,2-1 0,-1-1 0,1-1 1,0 0-82,-5 5 0,-1 1 0,1-3 0,6-6-214,5-4 0,5-5-1989,6-6 2428,2-9 0,21-24 0,-3-3 0</inkml:trace>
-  <inkml:trace contextRef="#ctx0" brushRef="#br0" timeOffset="225319">9451 9790 7533,'-19'0'3276,"1"-8"-1155,12 6-5398,0-6 3174,6 8 0,22 8 0,5 2 1</inkml:trace>
-  <inkml:trace contextRef="#ctx0" brushRef="#br0" timeOffset="225500">9353 10054 7533,'-20'-10'3276,"2"-5"-1335,12 13-1941,11-14 0,25 22 0,16-4 0</inkml:trace>
-  <inkml:trace contextRef="#ctx0" brushRef="#br0" timeOffset="229684">10522 9402 7713,'-14'0'1529,"-3"-8"-720,16 6 451,-10-14-181,10 14-180,-4-6-449,5 8 360,5 8-451,2 10-269,5 2 0,4 3-450,3 7 1,1 3-271,4 3 1,2 0-361,2 0 1,-1-1-406,-2-8 1,-1-1 629,-4-3 1,-1-3 764,10-1 0,-16-19 0,-8-19 0</inkml:trace>
-  <inkml:trace contextRef="#ctx0" brushRef="#br0" timeOffset="230087">10940 9454 7533,'-19'-37'3276,"6"4"-346,2 23-3110,3 28 0,-1 11-45,-9 10 1,-1 6 201,7-9 1,-1 4-1,1 2 1,-1-1-224,-2 1 0,-1 1 0,0 0 1,1 0 312,0 0 0,1 0 1,1 0-1,-1-4 113,-1 0 0,0-3 0,1-1-121,-2 12 0,2-12-508,2-23-361,7-14-1259,16-25-809,2-1 2878,6 3 0,15 7 0,-1 0 0</inkml:trace>
-  <inkml:trace contextRef="#ctx0" brushRef="#br0" timeOffset="230417">10977 9878 8162,'-12'-35'3276,"5"15"-255,2-4-2302,5 22-89,27-5-720,12 7-270,-1-1 0,4 2-629,1 2 0,1 1 224,-5-3 0,-1 0-719,0 3 0,-5 0 1484,-5 4 0,-34 14 0,-11 5 0,-10 6 0,-1 1 0</inkml:trace>
-  <inkml:trace contextRef="#ctx0" brushRef="#br0" timeOffset="230651">11038 10072 7533,'-38'-16'3276,"20"4"0,40-13-1638,2 15 0,4 2-1560,11 2 0,3 2-1171,-8 1 1,1 0 0,-2 2 623,10-1 1,-1 4 0,2 4 0,-3 3 0,-11 1 0,0 0 0</inkml:trace>
-  <inkml:trace contextRef="#ctx0" brushRef="#br0" timeOffset="233683">12122 10019 6813,'0'19'1259,"0"5"-809,-6-14-180,5 7 629,-5 1 181,6 0 89,0-8 360,0-3-449,0-7-181,0-7 1,0-11-361,-5-25-269,-1-1 0,-1-6-210,3 9 0,-1-1 0,0-3 153,1 6 1,-1-1 0,1-1-1,0 1 147,1-9 0,1 0 0,0 4-270,1 7 0,1 3 0,1 2-45,3-4 0,5 5-225,6 5 0,5 3-90,1 5 0,3 1-495,6-5 1,2 3 134,-4 9 1,0 2-271,-1-1 1,0 5-181,-1 10 1,-2 5-1305,14 18 945,-21-7 0,-4 3 1439,-1 21 0,-20-12 0,-6 0 0,-3 0 0,0-1 0</inkml:trace>
-  <inkml:trace contextRef="#ctx0" brushRef="#br0" timeOffset="233950">12072 9825 7533,'-41'16'3276,"13"3"-346,-3 1-2210,42-5-181,22-22-539,-1 1 0,3 2-1639,10-1 1,2 0-1,-1 0 1,-2 2 1471,-6 2 0,-1 2 0,-1 2 0,-4 2 1,13 5-1</inkml:trace>
-  <inkml:trace contextRef="#ctx0" brushRef="#br0" timeOffset="234327">12872 9366 7533,'-11'-35'2878,"3"15"-719,-31 13-1979,10 32-90,2 2 0,0 7-60,11-6 0,2 2 0,0 2-46,1 2 0,0 2 1,1 2 104,3-2 1,1 4 0,1-1 0,1-1-390,2 1 0,1-2 1,3 2-241,2 10 0,4 1 1,4-4-511,4-13 1,3-3 0,1-3 1049,8 13 0,2-9 0,-1-17 0,0-8 0,9-10 0</inkml:trace>
-  <inkml:trace contextRef="#ctx0" brushRef="#br0" timeOffset="234717">13020 9613 7533,'-14'-2'3276,"14"28"-1638,10-5 0,5 5-1514,1 5 1,2 5 0,2-1-665,1-6 0,1-1 1,0 1-429,3 8 1,0 2 0,-1-3 67,2-3 1,-2-2 931,-1 4 0,-10-3 0,-23-3 0,-12 5 0</inkml:trace>
-  <inkml:trace contextRef="#ctx0" brushRef="#br0" timeOffset="235019">12995 10178 7533,'-37'-18'3276,"12"0"0,18 1-474,31-17-2592,-1 13 0,7-2 0,0-1-390,2-1 0,1 0 0,1-2-241,3-4 1,1-2-1,-1 1-672,-4 5 1,0 1 0,-3 1-547,3-8 1,-3 3 1455,-6 11 1,-4 1 0,-8-13 0,-20 21-1</inkml:trace>
-  <inkml:trace contextRef="#ctx0" brushRef="#br0" timeOffset="235368">13598 9243 9332,'-6'-28'3276,"6"11"-1676,16 30 0,7 13-1465,1 4 0,0 7-90,-5-7 0,0 5 0,0 2 0,-2 0-502,-2 1 0,-1 2 1,-2 1-1,-2 0 97,-3 3 0,-3 2 1,-2-1-1,-2-1 337,-3-5 1,-2 0-1,-3-1 1,-2-1 124,-2-1 0,-3 0 1,-2-2-1,-2-3-312,-6-1 0,-3-3 0,1-2-330,-7 7 1,3-3 539,7-12 0,6-1 0,12 10 0,20 1 0</inkml:trace>
-  <inkml:trace contextRef="#ctx0" brushRef="#br0" timeOffset="236834">14386 9772 7533,'-19'0'1349,"1"0"-90,0 8-359,4-6-451,2 6 721,28-1-631,23 3-584,4-5 1,4 0-496,-4 3 0,1 0-390,-7-7 1,3-2 0,-4 3-421,-2 6 1,-2-1 1349,0-7 0,-11 2 0,-25 6 0,-18-8 0</inkml:trace>
-  <inkml:trace contextRef="#ctx0" brushRef="#br0" timeOffset="237167">14386 10054 7533,'-37'0'3276,"11"0"-166,3 0-1041,32 0-630,29-8-1304,-9 7 0,5 0-585,2-3 0,4-3 1,-2 3-1190,12 2 1,-2 2 1389,3-4 1,-3 0-1,-19 4 1,-3 0 0,3 0-1</inkml:trace>
-  <inkml:trace contextRef="#ctx0" brushRef="#br0" timeOffset="244635">16072 9701 9691,'7'-9'2429,"-2"1"-1529,-5 0-271,0 6-89,0-14-630,0 14-180,0-6 180,0 8 0,0-7 90,0 5-180,-5-14 180,-2 14-270,-6-6-179,-10 8 359,-8 0 0,-13 8 135,20-1 0,-1 4 0,-3 9 0,1 3 45,1-5 0,1 3 224,0 12 1,1 1-90,7-11 0,3 1-45,3 6 0,4 0 0,2 15 90,16-1-136,2-21 1,4-3 45,23 1 135,-6-13 0,2-8-135,-8-10 0,-2-7-90,10-14 0,-1-7-135,-8-2 0,-3-2 90,-4 1 0,-2-1 0,-3-2 0,-7 4 45,-19 9 359,-4-1-674,-5 42 1,-1 12 224,6 7 0,3 5-45,-2-5 0,3 2 134,2 19 1,7-2-90,9-23 0,3-1 0,-2 11 0,4-1-765,8-10 1,3-3-2513,15 6 0,-2-11 3139,-11-16 0,-13-16 0,-6-3 0</inkml:trace>
-  <inkml:trace contextRef="#ctx0" brushRef="#br0" timeOffset="244967">16305 9948 10051,'0'-19'3148,"0"3"-809,0 16-2429,6 47-2518,1-4 2608,-1-4 0,0 1 0,1 5 0,-1-12 0</inkml:trace>
-  <inkml:trace contextRef="#ctx0" brushRef="#br0" timeOffset="246654">16638 9419 6993,'-12'0'2339,"5"0"359,1-8-899,39 46-1349,-11-12 0,3 4-450,-5-2 0,1 3 0,2 2 0,-1-1-105,0 0 0,0-1 0,0 1 0,-1 0-195,6 10 0,-2 1 1,-2-4-601,4 3 1,-4-4-245,-6-7 0,-5-3 1144,-11-1 0,-8-9 0,-12-10 0</inkml:trace>
-  <inkml:trace contextRef="#ctx0" brushRef="#br0" timeOffset="246952">16674 10160 8252,'-11'-10'720,"4"-13"809,9-1 0,7-3-630,7-5 1,7-4 0,2-2-987,-5 7 1,2-3 0,1 0-1,1-1 1,0 0 284,3-1 0,1-1 0,1 0 0,0 1 0,-1 0-234,0 3 0,0 0 0,0 0 0,-1 2 0,-2 0-254,6-9 1,-3 3 0,-1 3-1350,1 0 1,-3 7 1422,0-1 1,-7 13 0,-6 15 0</inkml:trace>
-  <inkml:trace contextRef="#ctx0" brushRef="#br0" timeOffset="247600">17844 9613 7533,'0'-19'2069,"0"-5"-900,0 14 0,0 32-899,0 25-180,0-15 0,0 4 0,0 2-794,2 1 0,-1 0 0,1 0-16,0-2 0,0-1 1,1-1 719,4 11 0,-2-6 0,-4-2 0,-2-15 0</inkml:trace>
-  <inkml:trace contextRef="#ctx0" brushRef="#br0" timeOffset="247834">17672 9931 7533,'-24'-26'3276,"15"7"0,14-15-1283,23 23-2053,4 2 0,9 1 0,1 1-1033,-6 3 1,-1 1 0,3 0 1021,10 0 0,3 0 0,-3-1 1,-9 0-1,-3-2 0,-1 1 1,8 0-1,-1 0 0</inkml:trace>
-  <inkml:trace contextRef="#ctx0" brushRef="#br0" timeOffset="250268">19062 9701 9062,'-7'-17'3276,"1"-1"-2684,1 8-412,-1 2-360,-12 8 180,-18 0-90,-3 0 135,4 7 0,-2 2-90,8-4 0,0 2 45,-13 11 0,0 5 269,9-2 1,2 3 315,-7 5 0,3 5-226,13 4 1,5 2-135,-2-4 0,9 1-90,18 7 0,11-2-270,7-11 0,6-5-225,10 0 0,5-9 270,2-15 1,0-12 178,-9-7 1,-1-6 0,-4-5-47,-5-6 0,-4-4 0,-1 0 256,1-2 1,-1 0 0,-4 0-180,-7 7 0,-4 0 0,-5 3 1049,-8-4 0,-5 9-809,-7 21-135,-3 18 0,0 8-765,6 5 1,4 5-136,-3 14 0,4 2-404,7-7 0,5-2-226,9-2 1,2-2 89,-1-2 1,5-5 1297,8-9 1,3-10 0,8-25 0,-15-4-1,0 1 1</inkml:trace>
-  <inkml:trace contextRef="#ctx0" brushRef="#br0" timeOffset="250633">19370 9984 10591,'-7'0'3276,"-4"-8"-1875,4-2-861,-11 16 359,-1 6-854,6 14 0,2 6-135,2-8 1,4 1-181,9 15 0,8-3-180,23-6 900,-6-22 0,3-10-46,-2-20 1,-4-11-225,-7-3 0,-5-4-90,-4-10 0,-9 2-1619,-13 12 0,-6 5 1529,-11-5 0,3 45 0,0 13 0,7 10 0,0 1 0</inkml:trace>
-  <inkml:trace contextRef="#ctx0" brushRef="#br0" timeOffset="267270">22274 9984 6633,'-14'0'1529,"-2"0"-1349,15 0 90,-5 0 180,6 0 269,6 0-449,-5 0 180,4 0-90,-5-8-90,0 6 449,0-6 1,0 16-1,0 9-269,-2 10 0,-1 5-315,2 0 0,1 3-285,-4 5 0,0 5 0,0-3 150,1 2 0,0 0 120,0 4 0,1 5 0,0-5-437,-4 1 0,1-2 437,3-5 0,1 2 0,-3 0 149,-4 4 1,-2 0 0,0 1-240,2-3 0,1 0 0,0 1 37,0-8 1,1 0 0,0 1-1,0 1-22,1 6 0,0 2 0,1 0 0,1 0-68,2-3 1,1-1-1,0 1 1,0 1-329,-1-5 1,0 1 0,0 0 0,-1 0 0,2 0 260,-1 5 0,1 0 0,0-1 0,1 2-18,-1-7 0,0 1 0,0 1 0,0-1 0,0-2 130,0 4 1,0-2 0,0 1-1,0 3 23,-1-6 0,0 3 0,0 2 0,0 0 0,0-2 0,0-3-90,1 4 0,-1-3 0,1-1 0,0 4-9,-1 1 0,0 4 0,-1 0 0,1 0 0,0-3-191,1 0 1,0-3-1,0 1 1,0 1 280,0-2 0,1 1 0,-1 1 0,0 0 0,-1 0-1,0 0 1,-1-1 0,0 1 0,-1 0 0,1 1 9,-1-3 0,0 1 0,0 1 0,0 0 0,0-1 0,-2-1-153,0 3 1,-1-1-1,0-1 1,-1 1-1,0 1 183,1-2 0,0 1 0,0 0 0,-1 1 0,1-2 0,0-1-57,0 0 0,-1-1 0,1 0 0,0-1 0,0 1-36,-1 4 0,1 0 0,0 1 0,0 0 0,1 0-18,-1 1 0,1 0 0,0 1 0,1-1 0,-1-1 0,1-7 0,0-1 0,1-1 0,-1 1 0,0 1-54,-1 8 0,0 1 0,0 1 0,1-2 0,0-3 22,0-4 1,1-2 0,-1-2 0,1 3-77,-2 1 0,0 2 0,0 0 0,1-1 0,0-4 177,1 2 0,0-4 0,1 0-243,-2 9 0,0 0 1,1-4-511,3-4 1,0-4 213,0-1 1,0-3-1115,0 13 1883,0-17 1,5-17-1,1-1 1</inkml:trace>
-  <inkml:trace contextRef="#ctx0" brushRef="#br0" timeOffset="268502">21770 16404 7263,'-19'0'899,"-5"0"-449,10 0 270,2 0 269,12 0 630,12 0-899,13 0-136,5 1 1,4-2-540,6-2 0,4-2-428,-1 2 0,5 1 0,0-2 158,-6-2 0,1 0 0,0-1 0,2 0-115,-7 2 0,2-1 0,0 1 0,1 0 1,-1-1 428,2-1 1,1 0 0,-1-1 0,0 1 0,0 0 90,6 0 0,-1 0 0,1 0 0,0 1 17,-4 1 1,1 2 0,0-1 0,-1 1 0,-1 0-86,0 1 1,-2-1-1,1 2 1,2-1-113,-4 2 0,3 0 0,0 0 0,2 0 0,-1 0 0,0 0 60,-3 0 0,1 0 0,-1 0 0,1 0 0,-1 0 0,2 0-383,2 0 1,2 0 0,-1 0 0,1 0-1,-1 0 1,0 0 307,-1 0 0,-1 0 0,0 0 0,0 0 0,0 0 0,-1 0 15,0 0 0,-1 0 0,0-1 0,0 1 0,0 0 0,-1 1-197,5 2 0,-2 0 1,1 0-1,0 1 1,1-1 210,-4-1 1,0 0 0,1 0 0,1 0 0,-1 0 0,0 0-45,-1 0 0,1 1 0,-1 0 0,1 0 0,-1 1 1,-1-2 29,5 2 0,-1-1 0,-1 0 0,1 0 0,0 0 35,4-1 1,0 0 0,0 0 0,0 0 0,0 0-15,0 1 1,0 1-1,0-1 1,0 1-1,1 0 39,-5-1 0,2 0 0,0 0 0,0 0 0,-2 0 0,-1-1-78,-2 0 0,-3 0 0,0 0 0,1 0 0,2 0 33,5 1 0,4 1 0,1 1 0,-1-1 0,-2 0 0,-6 0 15,8-1 0,-6 1 0,6 0-5,-13 0 1,4 1 0,3 0 0,1 1 0,0-1-1,-1 0 1,-3-1-26,8-1 0,-3-1 0,0 0 0,0 0 0,3 0-26,-8 1 0,2-1 1,1 1-1,0-1 0,0 1 1,-2-1-1,-1-1-38,4 0 1,-2-1-1,-1 0 1,0-1-1,2 1 34,-1 0 0,1 0 0,1 0 0,-1 0 0,-1 0 0,-2 0 120,5 0 0,-3 0 0,-1 0 0,3 0 36,-1 0 0,2 0 0,0 0 0,1 0 0,-2 0-18,-2 0 0,-1-1 0,1 1 0,-2 0 0,1 1-73,-2 1 1,0 2 0,0 0 0,-1-1 0,0 0 233,10-2 1,-1 0 0,0-1 0,-1 2-338,-2 1 1,-1 2-1,-1-1 1,0-1 201,-3-2 1,0-1-1,-1 0 1,-1-1-105,12 1 0,-2 0 0,-2 0 196,-11 0 1,-3 0 0,-1 0-227,7 0 0,-5 0 736,-4 0-2176,-19 8 1677,-11 2 1,-17 0 0,-3-2 0</inkml:trace>
-  <inkml:trace contextRef="#ctx0" brushRef="#br0" timeOffset="274987">30642 16334 7353,'-6'-10'1529,"-5"-6"-1079,10 14-1,-5-6 181,6 0-270,6-1-180,-5-1 0,5 2 0,-6 0-91,0 6-178,0-6-91,0 8 180,-11 0 0,-3 8-180,-22 10 180,-2 1-90,14-7 0,-2 2 180,-4 6 0,1 1 134,2-6 1,1 1 0,0 11 0,3 5 180,3 7 0,4-1-585,3 7 270,12-7 0,7-4-90,15-14 90,6-5 0,4-5 0,-2-14 0,2-5-1,11-3 1,0-6-135,-8-14 1,-3-6 14,-6 7 0,0-2 0,-4 1 75,-5-11 0,-4 1-1,7 4 1,-11 6 675,-35 6-450,-1 52-180,3-1 0,0 5-180,5 0 0,3 4-270,3 12 0,9 1-854,15-9 0,8-2 584,-2-2 0,4-3-359,10-7 0,2-7 989,16-9 0,-6-16 0,2-2 0</inkml:trace>
-  <inkml:trace contextRef="#ctx0" brushRef="#br0" timeOffset="275617">31000 16598 7353,'-20'0'1889,"2"-8"-990,6 6-359,0-5 359,-1-1-449,1 6 0,-6-6-180,0 24-360,-7 11 135,13-3 0,4 5-225,2 10 0,5 0 45,4-7 0,7-5 180,22-1 0,6-9 135,4-11 45,2-17 0,-3-11 179,-24-11 1,-7-3-90,3 10 0,-7-1-270,-16-14 0,-14 8-630,-7 27 0,-3 8 585,-3-3 0,7 6 0,10 14 0,50-3 0</inkml:trace>
-  <inkml:trace contextRef="#ctx0" brushRef="#br0" timeOffset="277886">21795 9490 7533,'-20'-10'539,"8"-6"-89,1 14 90,10-6-450,-11 8 270,11-7-91,-4 5 181,5-14 90,0 6 89,-6-7-539,5-1 360,-10 0-360,4 8-90,-6-5 270,-4 13-180,-2-6-90,-6 8 0,-5 16-180,-1 3 135,15 1 0,0 3 0,-2 3 0,1 1 45,6 0 0,1 1 180,-2 6 0,1 1 45,5 0 0,5 0-90,5-2 0,3-1-135,1 4 0,5-3 0,6-12 0,4-5 0,4-7 0,1-8 89,-2-11 1,-1-8 0,7-14 0,-3-6 45,-5-2 0,-5-3 75,-6 7 0,-3-2 0,-1 1 149,2-7 1,-4 3 135,-5 4 0,-4 4-135,-10-1-540,-8 34-270,1 26-90,1 19 270,13-11 1,3 3-496,6 7 0,3 0 270,1-6 1,5-2-1145,9-3 1,4-5 893,-7-9 0,2-5 745,15-4 0,-12-26 0,-12-13 0</inkml:trace>
-  <inkml:trace contextRef="#ctx0" brushRef="#br0" timeOffset="278174">22151 9648 7533,'-12'-19'3276,"5"3"0,-4 16-3082,10 32-3471,-5 15 3238,6 2 1,4-6-1,3 2 1,0-12-1,0 0 1</inkml:trace>
-  <inkml:trace contextRef="#ctx0" brushRef="#br0" timeOffset="337121">13230 10918 6813,'-13'-19'1169,"6"3"-359,2 8-90,5 6 269,-6-13-359,5 13-810,-5-6 180,6 24 629,0 19-539,0-3 0,0 6 150,0 1 0,0 2 0,0 1-550,0-1 0,0-1 1,0 0 369,0 0 0,0-1 0,0-2-15,0 5 0,0-7-855,0-8-89,0-11 179,0-16-2518,6-24 3238,-5 3 0,4-14 0,1-5 0,-2 3 0,-1 0 0</inkml:trace>
-  <inkml:trace contextRef="#ctx0" brushRef="#br0" timeOffset="337569">13205 10901 7533,'-25'-26'2788,"6"15"-2428,6-5 90,13 39 179,13 15-449,-5-9 0,3 4-90,1 2 0,2 3 0,1-1 90,4 8 0,2-2-90,-3-9 0,3 0 0,-1-6 134,2-2 1,2-9 135,3-7 0,-1-12 224,-5-18 1,-3-9-495,1 2 0,-2-4-120,-6-6 0,-3-4 0,-2-1-540,-1 2 1,-1 1-1,-1 0 150,-2 4 0,-2 1 1,1 1-436,0-5 1,-1 8-1845,-5 14 2699,1 18 0,3 45 0,-3 2 0</inkml:trace>
-  <inkml:trace contextRef="#ctx0" brushRef="#br0" timeOffset="338017">13709 11183 7533,'-18'-18'3058,"4"-7"-2698,2 5-450,1-5 270,5 23-450,-12 20 720,-1 27-136,8-8 1,3 4-135,1 0 0,7 0-270,8-2 0,7-5 90,5-7 0,5-11 405,6-22 0,1-12-495,-7-3 0,-5-7-135,-4-14 0,-9-4 0,-14 4 0,-9 4-1414,-5 12 1,-3 5 1466,-17-3 0,19 36 0,4 10 0,6 25 0</inkml:trace>
-  <inkml:trace contextRef="#ctx0" brushRef="#br0" timeOffset="339137">14399 10918 7533,'-6'-17'629,"5"-16"541,-10 3 89,9-5-899,-3 25 0,5 43-316,0 1 1,0 5-15,-1 0 0,1 3 0,1 0-196,0 1 1,1 0 0,0-1 374,0-2 1,1-1 0,-1-3-120,1 8 0,1-9 810,2-16-1170,-29-30-180,8-17 0,-2-5 360,-7 3 0,-3 3 90,3 3 0,-1 3 720,-17-3 179,10 40-291,20 7 1,5 5-384,4 8 0,6 3-225,7 2 0,4 0-360,1-9 0,3-3-1034,10-6 0,3-5 269,-6-10 1,2-4 1124,4-1 0,-1-6 0,-4-12 0,-2-6 0,-3-6 0,0-1 0</inkml:trace>
-  <inkml:trace contextRef="#ctx0" brushRef="#br0" timeOffset="339566">14607 11254 7533,'-5'-26'3276,"-2"7"-526,-6-7-2120,-4 16-540,-13 26-1349,-3 21 539,13 0 0,3 5 540,2-1 1,6 0 224,5-8 0,6-1 134,2-4 1,6-7 450,27-27-270,-15-5 0,-1-6-181,8-12 1,-3-4-45,-5-4 0,-2 1 225,-1 6 0,-6 5 90,-12 7-990,-3 38-360,-2 9 1,-1 3 539,6 1-1279,14 5 1,5-5 1449,6-25 1,3-5 0,3-6-1,-9-17 1,0 0 0</inkml:trace>
-  <inkml:trace contextRef="#ctx0" brushRef="#br0" timeOffset="339850">14853 10883 7533,'-19'-8'3276,"7"22"-2954,7 21-277,9 6 0,3 7-225,-5-13 0,1 1 0,0 2-314,0 0 0,2 1 0,-1 1 0,1-2-256,1 4 1,1-2 0,-2 0 419,-2-3 0,-1-1 0,1-4 330,5 1 0,-5-15 0,-14-41 0,4-2 0,1 1 0</inkml:trace>
-  <inkml:trace contextRef="#ctx0" brushRef="#br0" timeOffset="340024">14780 11201 7533,'-8'-36'3276,"25"9"0,17 9-3629,14 9 0,3 3 353,-25 1 0,3 0 0,15-1 0,8 0 0,-2 0 0,-13 0 0,0 0 0,1 1 0</inkml:trace>
-  <inkml:trace contextRef="#ctx0" brushRef="#br0" timeOffset="341287">15309 11324 7533,'-7'-8'2788,"2"6"-2428,5-13-180,0 13 180,0-14-990,0 6 360,-6-7 0,-1 7 360,-16 2 270,-14 8-225,12 13 0,-1 5 90,0-4 0,2 4-91,3 14 1,5 4-225,4 11 360,30-4-270,4-30 0,5-8 45,-1-6 0,1-6 45,13-15 0,-3-7 135,-18 4 0,-3-1 45,7-6 0,-11 11 449,-29 29-1258,1 39-946,3-8 1,6 3 1484,13 2 0,11-8 0,16-27 0,8-10 0,-5-5 0,0 0 0,0 0 0</inkml:trace>
-  <inkml:trace contextRef="#ctx0" brushRef="#br0" timeOffset="341817">15740 11183 7533,'-19'-18'3276,"12"1"-796,30-1-2120,0 12 0,5 2-1620,11 0 1,2 1-135,-3 1 0,1 4 1394,3 4 0,-6 3 0,-13 3 0,-10 13 0</inkml:trace>
-  <inkml:trace contextRef="#ctx0" brushRef="#br0" timeOffset="342051">15789 11324 7533,'-25'0'3276,"1"0"-975,10 0-952,36 0-1304,4-3 0,5-2-1305,15 0 1,3 1 1047,-16 0 1,1 0 0,-2 2-1,10 4 1,-3 4 0,-6 3-1,-1 1 1</inkml:trace>
-  <inkml:trace contextRef="#ctx0" brushRef="#br0" timeOffset="344419">16774 10795 6453,'-14'-18'2069,"3"9"-2069,11 1 720,0 0-360,0 6-91,-6-6-179,5 8 270,-10 8-180,4-6-90,-5 21 180,-6-3 0,4 23-180,3-14 0,-1 3-90,2 11 0,1 2 44,2-3 1,0 0 45,2-6 0,1 2 0,2-2-90,7 6 0,1-2 45,-1 2 0,4-3-45,6-11 0,6-3 45,2-5 0,3-7 0,2-13 0,1-6 0,-1 3 0,0-6 0,8-20 0,-2-8-45,-9 5 0,-2-3-30,-3 5 0,1-3 0,-2 0 30,2-11 0,-5 0 90,-5-1 0,-3 2 180,-4 10 0,-3 1 134,-5-4 1,-4 5-405,-6 10 0,-3-3-449,10 24 89,2 0 540,5 8-90,0 25 314,0 0 1,0 5-315,-2-6 0,0 1 0,0 2-142,1 5 0,1 2 0,0-1 262,-2-1 0,1-1 0,4-2-360,5-2 0,5-2 0,0-3-300,0 1 1,4-7-586,14-8 1,2-9-2204,12-9 3238,-12-13 0,-17 13 0,-23-6 0</inkml:trace>
-  <inkml:trace contextRef="#ctx0" brushRef="#br0" timeOffset="344867">17574 10777 7533,'0'-25'2698,"0"13"-2428,-6-4-270,-1 32 450,-11 4-181,6 3 1,-1 5 225,-7 2 0,-2 2-106,7 1 1,0 2 0,0 1-342,-2 2 0,-1 1 0,4 2-168,1 5 0,4 3 0,4-3-510,5-8 1,3 0-1,5-4-360,14 9 1,7-8 989,3-14 0,2-9 0,-2-9 0,-2-6 0,11-6 0</inkml:trace>
-  <inkml:trace contextRef="#ctx0" brushRef="#br0" timeOffset="346225">17943 11201 6723,'0'-10'1080,"0"-6"-91,0 14-90,0-21-179,0 11-180,0-6 359,-6 3-629,-12 5-540,-8 0-269,-22 18 628,22 3 1,1 5 0,-1 9 0,2 3 180,4-1 0,3 1-90,5 2 0,7 1-135,9 0 0,8-1 0,5-9 0,4-3 90,6-2 0,3-7-1,2-9 1,-2-9 0,0-21 0,-5-7 45,-7 11 0,-3-1 90,0-20 0,-7 2 539,-8 6-539,-12 13-270,-7 44-180,8 6 0,2 5 0,2-2 1,2 3-361,2 16 0,6 0-719,7-16 0,3-2 44,-1 1 1,3-5 1214,28 0 0,-6-55 0,-19 11 0,1 0 0</inkml:trace>
-  <inkml:trace contextRef="#ctx0" brushRef="#br0" timeOffset="346833">18238 11342 7173,'-14'-8'2429,"-2"6"-1800,9-6-89,0 8-180,-4 0 179,4 0-359,-5 8 180,-6 17-90,10 13-405,2-12 0,6 1-180,14-3 0,6-3 90,2-8 1,3-7 179,9-9 0,1-11 404,-4-13 1,-7-9 90,-5-8 0,-11-2-360,-14 7 0,-6 3-90,-3 7 0,-5 7-450,-8 17 0,1 10-2068,-5 31 2518,31 11 0,18-20 0,8-1 0,11-5 0,-1 1 0</inkml:trace>
-  <inkml:trace contextRef="#ctx0" brushRef="#br0" timeOffset="347117">18607 11289 8342,'-5'-18'3276,"3"8"-1515,13 34-2390,9 15 89,-3-9 0,-2 3-360,-3 2 1,-5-2-1259,-18 15 1708,-5-21 0,-6-4 180,-3-7 0,-2-4 270,1-2 0,3-2 0,-2-1 0,15-7 0</inkml:trace>
-  <inkml:trace contextRef="#ctx0" brushRef="#br0" timeOffset="348202">19197 11201 7533,'0'-20'719,"0"-3"-179,-5 13-90,3-8 89,-8 8-179,9 3 90,-10-1-270,4 6-270,-11-6-90,-1 8 180,-6 0 0,-10 8 270,2 2-270,-10 15 90,6 2 90,20-2 0,3 1-90,-5 14 44,11-12 1,5 2-45,14 2 0,5-3 180,13 4-225,-1-9 0,4-8 135,-1-23 0,0-10 135,1-3 0,-2-5-181,-5-5 1,-4-5 195,-8 5 0,-1-3 0,-3 2-195,-4 5 0,-3 1 449,-3-9 1,-4 12-315,-14 35-990,-1 9 90,9 9 1,4 6-810,5 0 0,4-1 719,7-3 0,5-1-135,3 0 1,5-6 854,1-12 0,4-8 0,3-14 0,0-8 0,-2-8 0,0-1 0</inkml:trace>
-  <inkml:trace contextRef="#ctx0" brushRef="#br0" timeOffset="348619">19481 11324 7353,'-7'-17'3276,"-4"7"-1785,9 2-951,-3 16-180,5 9-1620,11 26-2017,2 5 2994,7-3 1,3-4-1,-4-14 1</inkml:trace>
-  <inkml:trace contextRef="#ctx0" brushRef="#br0" timeOffset="349236">19739 10636 7533,'0'-17'2158,"0"7"-1438,5 2 359,24 39-809,-7 1 0,1 7-68,-7-8 1,1 5-1,-1 1 1,-1 0-398,-1-1 0,-1 0 0,0 1 0,-3 3 231,-3 2 0,-2 4 0,-1 1 0,-2-3 0,-1-4-96,-1 1 0,-3-5 0,-2 1 15,-3 2 0,-3 4 0,-2-3 0,-3-7-165,-12-2 1,-2-5-511,2 6 1,-1-3-451,3-14 1,4-3 1169,8 4 0,16-8 0,17 1 0</inkml:trace>
-  <inkml:trace contextRef="#ctx0" brushRef="#br1" timeOffset="387236">4480 15363 6903,'-10'-9'540,"-5"-7"-360,13 14 269,-6-6 181,0 8-90,6 0 89,-13 0 1,13 0-90,-6 0-91,8 8-89,0 2-90,0 0 90,0-3 180,0 1-181,0 2 1,0 8-90,15-1-270,-6 7 0,2 1-90,12-1 0,5 1 0,-5 7 0,1 4 0,0-2 90,-3-8 0,1-1 0,1 1 30,5 8 0,2 2 0,-4-4 150,-1-6 0,-3-3 90,-3 0 0,-2-5 359,-2-10-179,-15-16-270,0 6-1080,0-6-1168,0 8-1209,0 0 2994,0-8 0,0-2 1,0-7-1</inkml:trace>
-  <inkml:trace contextRef="#ctx0" brushRef="#br1" timeOffset="388005">4410 15928 6004,'-28'8'449,"3"2"-89,7-1 540,8 7 449,3-14-180,7 6 0,0-8 271,0-8-721,15-10 1,9-5-181,-5-1 1,3-4 0,1-1-696,4 0 0,2-3 1,1 0-1,0 0 66,0 0 0,-1 0 0,1 0 0,-1 1-113,-4 1 1,1 1 0,-2 0 0,0 3-1437,13-11 1,-4 3 623,-15 12 0,-2 1-874,13-12 1889,-15 21 0,-7-3 0,-9 15 0</inkml:trace>
-  <inkml:trace contextRef="#ctx0" brushRef="#br1" timeOffset="430452">2134 15752 6183,'0'-28'2609,"0"3"-2609,0 7-540,0 0-1259,24 16 1799,-10-4 0,13 9 0,11 4 0,0-1 0,-2-3 0,-1 1 0,0-1 0</inkml:trace>
-  <inkml:trace contextRef="#ctx0" brushRef="#br1" timeOffset="430641">3122 15804 7533,'10'0'539,"37"0"-1439,-9 1 1,4-2 899,5-2 0,2-1 0,-7 1 0,2 0 0,-2-1 0,7-5 0,0 0 0</inkml:trace>
-  <inkml:trace contextRef="#ctx0" brushRef="#br1" timeOffset="430817">4374 15716 7533,'47'-9'30,"-1"1"0,-1-2 0,4 2-150,-5 4 0,4 1 0,-1 0-112,-6 0 0,-1 0 1,0 1-1,-5 4 1,-1 1-1,0 0 0,8 2 1,1 0-1</inkml:trace>
-  <inkml:trace contextRef="#ctx0" brushRef="#br1" timeOffset="431000">5673 15752 7533,'39'0'299,"0"0"1,6 0 0,3 0-660,-4 0 0,4 0 1,-1 0 31,-1-2 0,-1-1 0,0 0 1,-1 0-1,0 0 0,-2-1 1,-9-2-1,1 0 0,0 0 1</inkml:trace>
-  <inkml:trace contextRef="#ctx0" brushRef="#br1" timeOffset="431166">7186 15769 7533,'25'0'-360,"7"0"0,5 0 1349,1 0 1,3 0-1170,-4 0 0,2 0 0,2 0-21,-3 2 1,2 0 0,0 0-1,-3 0 1,2-1 0,-2-1 0,2 1-1,8 2 1,1-1 0,-1 1-1</inkml:trace>
-  <inkml:trace contextRef="#ctx0" brushRef="#br1" timeOffset="431342">8848 15769 7533,'41'-9'30,"0"1"0,5-2 0,4 2-450,-3 4 0,4 1 0,-3 0 55,-7 0 1,-2 0 0,-1 1 0,-1 2 0,0 0 0,-3 0 0,-2 0 0,1 0 0</inkml:trace>
-  <inkml:trace contextRef="#ctx0" brushRef="#br1" timeOffset="431483">9771 15752 7533,'36'-8'629,"2"6"-809,-9-6 1,2 0 179,-2 7 0,0 0 0,-4-3 0,0 0 0,16 4 0</inkml:trace>
-  <inkml:trace contextRef="#ctx0" brushRef="#br1" timeOffset="432300">2716 17762 7533,'-9'-33'1079,"-7"11"-2878,22-19 1799,4 30 0,9-18 0,5-5 0,3 4 0,1 1 0</inkml:trace>
-  <inkml:trace contextRef="#ctx0" brushRef="#br1" timeOffset="432467">3351 16986 7533,'11'-33'-72,"1"0"0,-1-1 0,4 4 0,3 2 0,2 0-288,2 1 0,3 1 1,0 3 120,11-6 0,1 1 1,-11 3-1,-1-1 0,0 0 1,6-5-1,1 0 1</inkml:trace>
-  <inkml:trace contextRef="#ctx0" brushRef="#br1" timeOffset="432666">4304 16051 7533,'13'-22'659,"-1"-1"1,1 1 0,2 1-1110,5 3 0,3 1-675,3-5 1,1 1 1124,12-9 0,-6 3 0,7-7 0,-1-1 0,-4 3 0,0 0 0,1 0 0</inkml:trace>
-  <inkml:trace contextRef="#ctx0" brushRef="#br1" timeOffset="432800">5132 15275 7533,'29'-34'-18,"1"-1"0,0 0 0,2 2 0,1 0 0,3-1-72,-2 4 0,1-1 0,1 1 0,0 0-238,-5 4 0,0 0 0,-1 2 1,-1 0-1,7-4 0,-1 1 1,-2 2-1,2-5 0,1 1 1</inkml:trace>
-  <inkml:trace contextRef="#ctx0" brushRef="#br1" timeOffset="433000">6817 13723 7533,'14'-41'809,"0"0"1,8 6-1,6-1-1574,-4 7 1,4-2-1,1 0 1,0 3 646,5-1 1,0 3-1,3-2 1,-7 4 0,2-2-1,1-2 1,0 0-1,-2 1 1,4-5 0,0-1-1,0 1 1,0 0-1</inkml:trace>
-  <inkml:trace contextRef="#ctx0" brushRef="#br1" timeOffset="433184">8221 12294 7533,'23'-28'-270,"1"-1"0,0 0 0,3-1 0,2 0 0,2 0 180,-3 4 0,1-1 0,1 0 1,1 1-209,0 1 0,1 0 0,-1 1 0,0 0 0,2-3 0,-2 0 0,0 1 0,-4 3 1,0 0-1,1 0 0</inkml:trace>
-  <inkml:trace contextRef="#ctx0" brushRef="#br1" timeOffset="433284">9008 11589 7533,'32'-36'314,"-17"11"1,-1 0-495,6-7 180,-8-1 0,-12 33 0,-7 10 0</inkml:trace>
-  <inkml:trace contextRef="#ctx0" brushRef="#br1" timeOffset="434067">5846 18274 7533,'-11'-43'1529,"2"13"-2878,-8 5 1349,10 17 0,-10-8 0,3-3 0</inkml:trace>
-  <inkml:trace contextRef="#ctx0" brushRef="#br1" timeOffset="434266">5587 17604 7533,'-16'-32'539,"0"1"1,0 0 0,-6-12-1,-1 1-1289,7 10 1,-1 0 0,1 0 749,-5-7 0,-1 0 0,5 6 0,-1-1 0,0-1 0,-1-2 0,0 1 0,0-1 0</inkml:trace>
-  <inkml:trace contextRef="#ctx0" brushRef="#br1" timeOffset="434468">5082 16528 7533,'-17'-26'479,"-1"0"1,-4-6 0,-1 0-480,2 5 0,1 1 0,-2-3-143,0-4 1,-1-2 0,1-1 0,0 3 232,-3-1 0,2 2 0,2 0-570,6-3 0,3 0 1,1 1 479,-4-11 0,4-1 0,6-1 0,3-2 0,2 5 0,0 0 0</inkml:trace>
-  <inkml:trace contextRef="#ctx0" brushRef="#br1" timeOffset="434633">4374 15187 7533,'-33'-25'1079,"7"-3"0,-1-3-719,-1 2 0,-1-1-720,8 2 0,0-1 1,3 0 359,2-3 0,4 1 0,-1-3 0,3-1 0,5 4 0,0 0 0</inkml:trace>
-  <inkml:trace contextRef="#ctx0" brushRef="#br1" timeOffset="434808">3933 14164 7533,'-26'-30'929,"0"-1"1,-5-8-1,1 0-1199,6 6 0,1-1 270,-3-7 0,1-2 0,3 4 0,1 0 0,6 9 0,0-1 0,0 1 0</inkml:trace>
-  <inkml:trace contextRef="#ctx0" brushRef="#br1" timeOffset="434983">3351 13123 7533,'-20'-28'427,"0"0"0,0 0 0,-4-6 1,1-1-548,3 3 0,-1-3 0,3 1 120,-1-11 0,1 1 0,-4 7 0,0 0 0,5-1 0,-1-1 0</inkml:trace>
-  <inkml:trace contextRef="#ctx0" brushRef="#br1" timeOffset="435166">2434 11942 7533,'-24'-25'809,"0"0"1,0 0-1,-4-1 1,1-1-810,1 2 0,-2-2 0,3 3 0,3 1 0,3 3 0,2-16 0</inkml:trace>
-  <inkml:trace contextRef="#ctx0" brushRef="#br2" timeOffset="461282">2417 14499 7353,'-10'-35'-360,"25"15"360,30 12 0,-13 12 0,1 2 0,6 3 0,1 0 0</inkml:trace>
-  <inkml:trace contextRef="#ctx0" brushRef="#br2" timeOffset="461467">3440 14041 7533,'16'-34'479,"1"1"1,4 14 0,3 3-705,13-11 0,4 5 225,3 16 0,3 4 0,1-5 0,2-2 0,-2-1 0,0 1 0</inkml:trace>
-  <inkml:trace contextRef="#ctx0" brushRef="#br2" timeOffset="461633">4445 13600 7533,'21'-30'389,"-1"1"1,-2 7 0,3 3-570,7 0 0,4 2 0,0 2 180,10 1 0,1 2 0,-9 2 0,1-1 0,-1-1 0,-3-1 0,0 1 0,0 0 0</inkml:trace>
-  <inkml:trace contextRef="#ctx0" brushRef="#br2" timeOffset="461818">5846 12912 7533,'23'-41'-248,"0"-1"1,3 15 0,5 1-1,2 3 8,6 3 0,4 3 1,2 1-581,-3 1 1,2-1 0,0 1 0,-1 0 787,3 0 1,-2 0-1,1-2 1,-11 2 0,1-2-1,0 0 1,-4 0-1,1-2 1,-1 1 0,0 0-1</inkml:trace>
-  <inkml:trace contextRef="#ctx0" brushRef="#br2" timeOffset="462000">7236 12136 7533,'40'-20'-203,"1"0"1,-12 7-1,1 1 1,2-4 202,3-3 0,1-4 0,2 0 0,0 2-638,2 2 1,1 1 0,1 0 0,0 0 547,3-1 0,1-2 0,-1 1 0,0 2-27,-5 3 1,0 2 0,-1 0-1,0-1 1,1-2 0,-1-1-1,0 0 1,-2 1 0,2-3-1,0 1 1,0 0 0</inkml:trace>
-  <inkml:trace contextRef="#ctx0" brushRef="#br2" timeOffset="462117">9008 11359 7533,'17'-43'809,"3"6"-1304,9 14 1,6 3 494,5 5 0,2 3 0,3-2 0,0 2 0,3 3 0,0 0 0</inkml:trace>
-  <inkml:trace contextRef="#ctx0" brushRef="#br2" timeOffset="462767">3739 10513 7533,'-7'-29'989,"-1"1"1,4-7-2789,4-1 1034,19 45 0,5 10 765,9 6 0,0-4 0,6 2 0,1-4 0,-8-9 0,0 0 0,0-1 0</inkml:trace>
-  <inkml:trace contextRef="#ctx0" brushRef="#br2" timeOffset="462925">4427 10918 8432,'18'18'180,"7"1"0,7 3-180,2 0 0,5 2 0,2 1-820,-3-1 1,2 1 0,1 1 0,1-1 566,-7-5 1,1 1 0,0-1 0,0-1 0,-3 1 0,3 0 0,-2 1 0,-2-2 0,0-1 0,-1-1 0,1 0 0,-1 0 0</inkml:trace>
-  <inkml:trace contextRef="#ctx0" brushRef="#br2" timeOffset="463116">5932 11906 7533,'37'12'269,"1"0"1,0 3 0,3 3 0,3 2-522,-9-4 0,2 1 0,1 2 1,1 0-1,-1 0-404,1 1 1,1 1-1,0 1 1,-1 0 0,0 1 574,-1 0 1,-1 2 0,0 0 0,-1 0 0,-1-2-1,1 1 1,-2-2 0,-2 1 0,0 0 0,4 9 0,1-1-1,-1 0 1</inkml:trace>
-  <inkml:trace contextRef="#ctx0" brushRef="#br2" timeOffset="463274">7531 12876 7533,'35'11'197,"0"1"1,-1-1 0,4 5 0,1 1 0,0 3-408,4 2 0,0 2 0,1 2 12,-6-1 1,0 3-1,0-1 1,1-3 0,0-5-1,0-2 1,0-1 0,1 1-1,1 1 1,0 1 0,1-1-1,-1 1 1</inkml:trace>
-  <inkml:trace contextRef="#ctx0" brushRef="#br2" timeOffset="463435">8971 13600 7533,'24'7'-270,"0"1"0,15 11 0,5 5 30,-2-1 0,3 3 1,-2-2 108,-8-4 0,-1-1 0,1 1 0,1 0 0,3 1 1,-1-1-1,-3-1 0,-5-3 0,0-1 0,0 1 0</inkml:trace>
-  <inkml:trace contextRef="#ctx0" brushRef="#br2" timeOffset="463617">10361 14323 7533,'40'12'-405,"0"-1"0,-6 1 0,2 0 1,4 2 381,0-1 1,5 0-1,0 1 1,-2 0-98,-5 0 0,-2-1 1,0 0-1,2 0 1,4 0-1,1 0 1,0 0-1,-2-1 0,3 3 1,1 0-1,-1 0 1</inkml:trace>
-  <inkml:trace contextRef="#ctx0" brushRef="#br2" timeOffset="463719">11272 14623 7533,'37'4'269,"0"-1"1,-5 1 0,-1 2-135,-1 6 0,0 2-405,4 3 0,-2 1 270,-5 0 0,0 1 0,10 6 0,2 1 0,-8-3 0,1-1 0</inkml:trace>
-  <inkml:trace contextRef="#ctx0" brushRef="#br2" timeOffset="464367">8676 18027 7533,'9'-35'-98,"0"1"1,0-1-1,6-10 1,4 0-1,6 8 1,4-1 0,1-1-1,-8 6 1,0 0-1,0-1 1,0 1-1</inkml:trace>
-  <inkml:trace contextRef="#ctx0" brushRef="#br2" timeOffset="464541">9525 16633 7533,'9'-36'389,"-1"-1"1,1 0 0,-1 0 0,6-2 0,1 2-1,2 0-1049,3-4 1,3 1-1,2 1 507,3 2 1,3 1 0,0 0 0,-2 0 0,1 0 0,-1-2 0,-3 2 0,0 1 0,0 0 0,0 0-1</inkml:trace>
-  <inkml:trace contextRef="#ctx0" brushRef="#br2" timeOffset="464700">10509 14781 7533,'13'-35'-26,"1"0"0,-1 0 0,0-1 1,7-4-1,1 2 0,2-1 1,-4 7-1,0-1 0,2 1 1,0 1-1,8-5 0,0 0 1,-1 1-1</inkml:trace>
-  <inkml:trace contextRef="#ctx0" brushRef="#br2" timeOffset="464883">11568 13070 7533,'16'-42'-171,"0"-1"0,1 1 0,-2-3 0,3 2 0,-1 13 0,2 0 0,1 2 0,3-6 1,1 1-1</inkml:trace>
-  <inkml:trace contextRef="#ctx0" brushRef="#br2" timeOffset="465000">12097 12065 7533,'-7'-32'-180,"0"-1"0,7-10 0,14 28 0</inkml:trace>
-  <inkml:trace contextRef="#ctx0" brushRef="#br3" timeOffset="569984">22201 12541 6633,'0'-10'-809,"0"-5"989,0 13-1,0-14 1,0 6 0,5 1-180,-4 1 0,4 8 180,-5 0-180,0 8 180,0 1-90,0 1-90,0-2 90,0-8-90,0 0 90,0 16-90,0 3 0,-5 9-90,4 5 450,-10-13-90,10-3-450,6-25 180,14-35-45,-6 19 0,0-1 90,0-6 0,-1 2-405,6-7 360,-12 19-90,-6 64 90,-6-10 45,2 4 0,1 2 45,-1-15 0,2-3 0,8 12 90,1-11-180,11-42 0,-3-5 0,-1-3 0,-3 0 0,0-1-90,4-2 0,-1 3-270,-2 6 360,1 26 0,-7 28 90,6 3 90,0 4 0,7-25-180,16-26 0,-2-12-45,-6-3 0,-1-5 0,-3 0 0,0 1 0,-1 7 0,-1 1-135,4-12 180,-25 62 90,-14 16-45,5-19 0,-1 1 0,0 1 0,2-1 45,7 6 0,2-15-90,28-20-90,4-20-90,-9 3 0,1-1 180,13-10-270,-7 11 450,-19 9-90,-6 16 0,-17 9-90,8 3 270,-8 5-90,16-15-180,8-18 90,6-11-1,-6-9 1,-2-3-90,3-10-45,-8 14 1,-7 3-226,-44 6 180,11 23 0,-3 6 90,-9 2 0,-3 3 90,8-1 0,0 0 0,4 0 134,4 1 1,3-4-180,-1-8 0,4-8 45,11-39-90,20-6-45,-6 14 0,0 1-404,2-3 269,-35 4 45,9 32 0,-5 7 105,-6 1 0,-6 2 0,2 3-61,5 2 1,1 3 0,0-1 120,-3-1 0,0 1 0,5-2 105,3 3 0,11-9 45,19-23-180,19-6 0,11-3-30,-3 1 0,3-2 0,0 0 30,0 1 0,0 0 0,0 0-60,2-1 0,0 1 0,-5 4 60,7-2-180,-30 24 135,-17 17 0,-12 8 180,-3 7 0,0 2-90,1 0 0,3 1 225,4-1 1,9-2-271,27 11 44,10-36 1,5-8-45,10-3 0,2-8-60,-8-3 0,2-5 1,-1-2 59,-2 0 0,-1-2 0,-1 2-45,9-5 0,-4 1 45,-4-2 0,-7 10-180,-13 24 225,-21 15 0,-7 5 0,0 0 0,1 3-45,0 3 0,1 5 0,3-2-90,1 6 0,6-2 0,7 1 0,10-4 90,7-12 0,7-8 0,3-14 0,2-8 90,8-14 0,-3-8-45,-10 3 0,-4-3 0,-1-3 0,-5-2-45,-8 4 0,-2 3-180,-2 2 180,-11 22 90,-14 37 0,7-6 0,-1 6 0,1-3-180,-2 3 0,1-1 224,1 9 1,6-6 315,13-13-540,23-58 0,-14 6 0,1-5 30,-1 1 0,1-4 0,-2 0 0,-3 1 0,-2 0 1,0 1 104,4-2 0,-3 4-315,0-4 360,-11 76-90,0-7 0,5 6 0,1 0 180,2-10 89,5-6 1,3-8-180,4-23-90,16-22 0,-19 0 0,-2-6-270,-1-6 0,-3-1 180,-1 0 1,-7 2 89,-8 13 0,-8 5-90,-16 8 0,-7 10 120,6 12 0,0 7 0,-1 2 0,-1 2 0,-1 2 0,2 1 29,3 1 1,1 1 0,5-2-60,3 1 0,6-2 360,8 1-270,17-40 0,6-13-180,-4 10 0,0-3 90,1-6 0,-1-4 0,-2 1-90,-3-1 0,-4 1 0,-3-8 0,-10 4-90,-12 16 1,-7 8 89,-20 7 0,-5 10 90,10 10 0,-1 8 0,1 2-24,2 1 1,1 3 0,3 0 23,8-2 0,2 0 0,8 0 0,6 2 0,13-7 359,35-28-359,2-13 0,4-7-30,-10 3 0,1-2 0,-2-2-103,-2-1 1,-1-3 0,-2 2 87,9-8 0,-11 4 45,-28-5-360,-29 46 360,4 8 0,1 7-30,7 3 0,2 5 0,2-1 105,-1 3 0,5 0 15,5 8 0,11-5 90,37-15-180,-14-15 0,2-6 0,5-12 0,2-7 0,-2-1 0,2 0 0,-2-1 204,10-7 0,-3 5-384,-2 13 180,-13 51 0,-20-6 0,-5 5-45,-2 6 0,-3 0 45,2-9 0,-1-4 360,-1 9-180,16-64-91,-3 14 1,10-33 90,-1 16-180,3 5-90,-7-13 90,-2 5 0,-22 1-269,-19-7-1,-13 19 0,-8 3 135,4 1 0,-2 2-13,4 2 0,-4 1 1,5 4 282,0 7 0,4 5-45,4 2 0,7 4 0,10 13-1,36 5-134,16-29 1,7-8-136,8-5 0,1-2 30,-13 3 0,-1 1 0,1-3 150,0-4 0,1-2 0,-9 10 0,-2 27 0,-8 9 0</inkml:trace>
-  <inkml:trace contextRef="#ctx0" brushRef="#br3" timeOffset="592487">22336 12577 6004,'-14'-18'359,"-8"8"-359,14 2 90,-4 8-90,1-8 270,4-1-90,0-1 0,-4-14-180,10 20 0,-5-11 0,6 15 0,6 15 90,0 5 45,7 1 0,3 1-135,0 1 0,1-1-45,9 4 0,3 1 45,6 7 0,2 1 60,-7-12 0,2 1 0,-1 1-211,1 6 0,0 3 0,0-3 211,-1-6 0,0-2 0,-1 4-90,-1 12 0,-1 5 0,-2-4 75,4 0 0,-1 1-45,-7-3 0,-1 3 0,1-1-44,-1-7 1,1-2-1,1 1 111,-1-2 1,1 1 0,0 0-1,1-1-67,4 3 0,1-2 0,0 1 0,3 4 0,0 2 0,0-3-30,-6-5 0,-1-2 0,1 1 60,4 3 0,2 1 0,-2 0-147,-4-2 0,0-1 0,1 1 207,7 1 0,2-1 0,-1 0-180,-5-4 0,-1-1 0,0-1 30,3 0 0,0-2 0,-1 2 30,-4 0 0,-1 2 0,1-1-69,1 0 1,0 0 0,-1 1 188,5 8 0,-1 2-60,-8-9 0,0 2 0,0-2 0,3-1 0,0-1 0,-2 2 0,-3 1 0,-3 1 0,3-1-30,4-2 0,2 0 0,-2-1 30,-3 0 0,-2 0 0,1 1-120,5 1 0,0 1 0,0 0 30,-2 0 0,-1 1 0,0 1 60,0 1 0,-1 1 0,1 0-60,3 4 0,0 1 0,-2-1 90,-4-8 0,0-2 0,0 1 90,1 3 0,2 1 0,-1-1-90,0-4 0,1-2 0,-2 1-30,6 14 0,-2 1 0,-5-12 0,1 1 0,-2-1-135,3 8 0,0-2 364,4 4 0,1-1-274,-4-6 0,-1-1-90,3 0 0,0 0 225,2 8 0,-1-1-90,-9-9 0,0-1 110,11 5 0,2 2-155,-7 5 0,-1-3 45,-3-16 0,1 1-30,2 6 0,2 3 0,-3-2 75,-2-4 0,-1-1-75,3 4 0,2 2 0,-1-2 165,0 1 0,0-1 144,4 6 1,1-1-325,-5-10 0,1-1 45,1-4 0,1 1-18,5 6 0,-1-1 18,-6-9 0,0-1-76,7 4 1,1 0-150,-4-4 0,0-3 45,18-1-270,3-2 450,-22-8 0,-8 0 0,-12 0 0</inkml:trace>
-  <inkml:trace contextRef="#ctx0" brushRef="#br3" timeOffset="594602">22570 12153 7533,'-13'-45'-1350,"1"18"1440,-6 11 90,-1 16 0,-6 0 0,1 0-90,5 0-90,-5 0 0,16-16-90,-8-3 0,14-9 90,2-13 0,2 20 180,3-13 90,-5 24 0,0 3-180,6 7 90,1 15 89,5-3 1,11 21-180,-8-21-90,13 10 0,6 3-90,-8-6 0,2 1-60,0 2 0,1 2 1,0 1 8,3 2 1,0 2-1,0 1 81,2 4 0,-1 2 1,0 0-245,-6-9 1,-1 1 0,1-1 0,0 1 325,-1 0 1,-1 1-1,0-1 1,3 0 44,5 3 1,2 0-1,0-1 1,-3-2-68,-5-1 0,-2-2 0,3 1 67,6 1 0,4 2 1,0-2-1,-5-2-203,4 3 0,0 1 136,-6-4 0,4 2 0,0 2 0,-1-2-30,4 1 0,-2 0 0,1 2-225,-3 0 1,0 3-1,0 1 1,-2-2 254,2 4 0,-2-1 0,2 2 18,-8-6 0,2 2 0,0 0 0,-1 0 0,-2-2 12,0 4 0,-2-2 0,2 1 15,2 0 0,3 3 0,0-1 0,-2-2-118,3 0 0,-1-3 0,0 0 103,1 2 0,1 1 0,1-1-165,-2-6 0,2-1 0,0 0 0,-2 1 135,3 5 0,-1 0 0,1 0-113,-5-8 1,2 0 0,0 0 0,-3 0 112,1 3 0,-2 0 0,2 1 0,1-3 0,3 1 0,1 0 0,-3-1 0,3 3 0,-2-1 0,1 0 149,3 2 1,1 0 0,1 2 7,-8-3 1,-1 2-1,1 0 1,-2-1-38,3 1 0,-1-2 0,1 2-98,-4-1 1,-1 1-1,2 1 1,0-1-68,3-1 0,0-1 0,1-1 0,-1 1-15,4 5 0,-1 1 0,2 0 15,-6-4 0,0 0 0,1 1 0,-1 0 22,1 1 1,-1 0-1,0 1 1,-2-1 89,-3-2 1,-1 0-1,0 0 1,0 0-46,2 0 1,0 1-1,0 0 1,0 0-1,1 5 1,0 0-1,0 1 1,-1-3 7,4 5 0,0-2 0,0 1 15,-3-3 0,0 1 0,1-1 0,0-2-15,2 1 0,1-2 0,0 0 15,-3-2 0,1 0 0,0 0 0,-1-2-135,3-1 0,-1-2 0,1 1 60,3 8 0,1 1 0,-2-2-180,-4-5 0,-1-2 0,0-1 276,7 4 0,0-2-291,1 1 1,0-5 224,-5-7 0,0-6 0,-6-8 0,0-2 0,23-2 0</inkml:trace>
-  <inkml:trace contextRef="#ctx0" brushRef="#br3" timeOffset="597217">22902 12506 7533,'6'-20'-540,"6"-3"810,-11 29-180,-23 35-60,7-14 0,-2 3 0,-2 3-241,1 0 1,-2 3 0,1 1 0,0 0 255,0-1 0,0 1 0,2-1 0,2 0-135,-1 8 0,3-1 0,11-6 223,12-9 0,10-9-43,14-14 0,8-14-45,-8-9 0,3-8 0,0-4 0,0 2-618,-1 2 0,1-1 0,-2 0 0,0 1 602,5-8 1,-2 1 0,-2 8-300,5 5 1,-13 16 224,-33 29 0,-12 13 67,3-4 1,-3 6-1,-2 1 1,0-1-99,0-4 0,-1-1 0,-1 1 1,1 2 110,0 0 1,-1 4 0,1-1 0,1-1 0,3-5 9,-5 12 0,8-6 45,11-3 0,10-11 180,39-37-180,-6-5 0,3-5-120,-10 3 0,1-1 0,0 0 60,-1 2 0,0 0 0,0 1-30,1-1 0,1 0 0,-3 5 1198,3 2 0,-3 8-1108,-7 10 0,-4 7 45,-8 9 0,-4 5-1,-2 5 1,-4 3-105,-2-1 0,-3 4 0,0-2-120,0 6 1,1-1 347,-1-9 0,1 2 0,6-6-303,15-4 0,5-9-45,18-2 90,-14-21 0,5-8 0,-2-2-45,10-8 0,-2-1 0,-2 0 0,-1 9 0,-7 17 0,-8 11 135,-22 22 0,-13 13-342,4-14 0,-4 5 1,-2 3-1,0 0 1,0-1 251,-2 5 0,-2-1 0,1 1 0,0-1-23,-1 2 1,-3 1-1,6-3 1,13-9-30,19-2 0,11-15 277,10-26 0,8-17-99,-14 6 0,4-4 0,1-3 0,1 0 0,-2 1-259,6-4 1,0-1 0,0 0 0,-2 3-48,4-2 0,-1 1 0,-1 8-45,10 3 0,-12 18-26,-33 38 1,-13 14 190,3-17 0,-3 1 0,0 1 90,-3 5 0,-1 2 0,3-3 1022,5 8 0,8-6-738,12-15 1,8-7-270,9-5 0,7-3-105,1 1 0,5 0 0,-3 1-330,-7 0 1,-3 2-1,0 2 242,-1 2 1,0 3-1,-1 2 1,-2-1 117,-1 3 0,-4 0 0,-2 2 90,-3 3 0,-3 1 0,-1-3 30,5-1 0,-3 1 289,-9-1 0,-4 3 0,3-4-244,4-4 0,4-1 450,9 10 1,7-4-586,3-12 0,4-6 0,6-9 0,3-1-60,-13 3 0,1 1 0,-2 1-255,8 3 1,-3 3 134,0 5 0,-6 5 45,-11 14 0,-9 7 225,-10-7 0,-5 3 0,-2 0 120,-2 1 0,-2 1 1,-2 1 36,1-5 0,-3 3 1,1-2-1,2-3 68,1 12 0,5-6-147,4-6 1,10-7-79,27-18 0,11-10-90,-18-5 0,1-2 0,1 0-210,7-1 0,1 1 0,-2 3-210,-4 3 0,-1 3 1,-3 4-31,3 10 1,-6 7 493,-5 3 1,-6 6 105,-10 0 0,-5 4 0,-3-3 210,-2 4 0,-2-1 89,-2 9 1,5-2 90,23-1-540,5-26 0,7-5-270,4-7 0,4-4 150,-6-2 0,3-2 0,-1 1-375,11-2 1,-3 2 179,-6 5 0,-4 6 315,-9 0 0,-6 7 45,-11 14 0,-9 5 270,-6-9 0,-2 0 90,2 4 0,1-3 134,-1 6 31,28-17-749,26-10-1,-22-9 0,0 2-540,7 11 1,-3 7 134,-11 6 0,-7 5 900,-9 14 0,-7 2 134,2-7 1,-3-3-90,-11-6 0,7-9 0,24-21-225,5-15 0,2-6-225,2 2 0,3-1-225,11-10 0,-1 9-404,-3 33 269,-17 19 225,-18 7 0,-10 5 45,-7-2 0,-1-2 135,12-10 0,2-3 225,0-1-90,40-42 90,3-13-270,-1 11 90,-14 29 0,-26 13 0,-7 7 0,-1 6 0,-1 0 0</inkml:trace>
-  <inkml:trace contextRef="#ctx0" brushRef="#br4" timeOffset="599991">23616 13547 11446,'6'-27'-553,"0"1"1,7-11 867,-7 3-358,-11 24-688,-31 26 1074,6 4 1,-3 5-273,6-1 0,-1 3 1,1 3-36,-1 4 0,2 3 0,5-3 52,1 2 1,13-3-18,19-4 1,13-9-64,15-23 1,10-12-113,-16 7 0,3-1 1,0-1-1,1 0 263,-1-1 0,1-1 0,0 0 0,-1 2-235,11-2 0,-1 2 0,-4 5 6,6 3 0,-10 11-85,-21 18 1,-13 7 153,-13 0 0,-10 3 0,0 0 88,4 0 0,0 0 0,-1 1 37,-4-1 0,0 0 0,5 0-278,9 12 1,9-4-24,4-13 0,8-5-86,18 6 0,10-7 156,-3-13 1,5-6 0,2-1-111,-8-3 0,2 0 0,0-2 0,0 1 233,-1 0 1,0 0-1,0 0 1,-2 0-8,11 2 1,-1 0-1,-4 4 286,2 6 1,-5 7-374,-8 8 1,-7 5 136,-6 0 1,-7 4 65,-10-3 1,-3 4 0,1-3-253,5 7 1,2 0-19,-3-8 1,0 1 0,6-3-235,12-1 1,5-3-1,1-4 205,1 2 0,3-5 134,5-4 0,4-1 0,-3-3 192,-6-1 0,-1 0 149,11 2 1,-5 5-235,-15 4 1,-8 5 90,-5 15 1,-10 6 23,-9-10 1,-6 2 0,-1 2 56,4-7 0,-2 2 0,1 0 0,0-2-179,-1 5 1,0-2 0,7-2-146,5 13 1,15-10 23,13-25 0,10-9 0,1-2 144,-2-3 0,1-2 0,3-2 12,-3-1 1,3-1-1,0-2 1,0-1 84,1-4 0,1-3 1,-1 0-1,-2 2-92,5-1 1,-2 2 0,-2 4-137,13 3 1,-13 14 69,-32 14 0,-12 8 53,-8 2 0,-7 3 0,-3 0-196,2-6 1,-3 0 0,0 0-1,2 0 142,-2 5 0,1-1 0,3 1-112,1 2 0,2 0 0,8-2-251,9 3 1,9-3 74,5 0-1,9-4 161,4-14 0,6-4 0,0-3 228,1 0 0,1-2 0,1-1-65,4-1 0,1-2 0,-1 0-92,-1 0 1,-1 0-1,-1 1-123,8 4 1,-5 6 56,-9 3 1,-8 7-4,-8 7 0,-8 4 310,-10 10 0,-3 2-107,2-13 0,0 0 1,0 0 126,-2-2 1,-1-1 0,6 0-504,16 8 1,9 1-1,0-7 58,-5-11 1,4-3 117,7 0 0,6-1 0,0-6 166,5-11 0,1-6 134,-9-2 1,2-1 0,-1 1-44,15-1 0,-3 0-214,-5-4 0,-5 2-755,4 8 930,-28 2 1,-51 22 0,10-14-1,1 0 1</inkml:trace>
-  <inkml:trace contextRef="#ctx0" brushRef="#br4" timeOffset="601166">24489 14499 9817,'-11'-25'-1823,"8"13"1471,-2-4 101,17 24 346,8 2 281,10 8-142,-4-1 49,-2 16-430,-12 5 213,-11-8 0,-4 5 0,0 0-9,-1 8 1,0 2-16,3-2 1,2 2 0,3-4-28,5-1 1,8-5-30,6-12 0,5-3 0,4-5 44,7-4 1,3-7-1,2-1-293,4-1 0,1-2 0,0-2 408,-1-1 0,0-1 0,-2 1 2,-6-1 0,-2 1 0,-6 8-326,-2 24 1,-8 7 133,-8-9 1,-7 3 101,-11 13 1,-8 8-1,-1-4 131,-2 1 1,1-2-279,2-8 0,0 0 1,6 0-229,11 9 0,12-6 85,10-10 0,8-7 172,8-4 0,5-7-105,-5-9 1,4-5 0,-1-2 414,-5 1 1,-2-2 0,3 0-130,-2 0 1,2-2-1,-1 1 1,-1 3 27,1 2 1,-2 2 0,-2 2-74,17 0 1,-11 11-100,-25 12 0,-9 9 1,-6 1 94,-9 0 0,-8 1 0,-1 1-68,2-3 1,0 2-1,-1 1 1,-1-1-119,-2-1 0,-1 1 0,0-2 0,3 0 82,1 2 0,3-2 1,5-1-29,6 12 0,12-5 61,19-12 0,10-9 245,-6-12 1,4-4-1,0-2 24,6 1 0,2-2 1,0 0-260,-9-1 0,1 0 0,0 1 0,-3 2-153,-1 2 0,-2 1 0,-3 5-129,1 7 0,-3 4 0,-10 4-272,-17 7 1,-13 6 0,-3 2 548,1-6 1,-3 3-1,-2 2 1,-3-2 0,0-2-1,-8 2 1,-3-3 0,-1-1-1,-1 2 1,2-4 0,1 0-1,-1 1 1,1-1 0,-1 0-1</inkml:trace>
-  <inkml:trace contextRef="#ctx0" brushRef="#br5" timeOffset="625198">2716 11800 8988,'4'-33'-465,"0"0"0,14-10 275,-3 12 0,5 3 36,5 12 1,3 6 166,6 5 0,3 1 0,2-8 0,2 0 0,3 2 0,0 0 0</inkml:trace>
-  <inkml:trace contextRef="#ctx0" brushRef="#br2" timeOffset="625541">3598 11236 7533,'17'-29'329,"0"-1"1,11-5 0,4-2-210,-6 3 0,1-3 0,3 2-436,-4 9 1,2 1 0,2 1 0,-1-1 180,3-3 0,0-1 0,1 1 0,2 1-517,1 3 0,1 3 0,1-1 0,2-1 382,-4-1 0,2-1 0,1-1 1,0 0-1,1 0 80,-5 3 1,2 2-1,0-1 1,0-1 0,1 0-1,-1-1 190,-2 1 0,0-2 0,1 0 0,-1 0 0,1-1 0,-1 0 0,1 0 0,-1 0 0,1-1 0,0 1 0,0-1 0,0 0 0,0 0 0,0 1 38,-1-1 1,2 1-1,-1-1 1,0 0 0,0 1-1,-1-1 1,1 1 25,-1-1 0,0 1 1,-1 0-1,1-1 0,-1 1 1,0 0-1,0-1-19,5-2 0,-1-1 0,0 0 0,0 1 0,0 0 0,0 0-30,0 1 0,0 1 0,0 1 0,0-1 0,-1 1 0,0-1-60,-1 2 0,-1 0 0,-1-1 0,1 1 0,0 1 0,-1 0 45,5-2 0,1 1 0,-1 0 0,-1 1 0,-1 1 0,1-1 0,-1 1 0,-2 1 0,0 1 0,4-5 0,0 1 0,0-1 0</inkml:trace>
-  <inkml:trace contextRef="#ctx0" brushRef="#br2" timeOffset="625750">8515 7708 7141,'30'-28'-13,"-1"0"0,1 0 0,-1 0 0,0 3 0,-2 0 0,2 0 1,4-1 12,3-1 0,4-2 0,3 0 0,0-1 0,-2 2 0,-3 2 0,-1-1 0,-3 2 0,-1 1 0,3-2 0,3-1 0,0 1 0,1-1 0,-1 0 0,0 1 0</inkml:trace>
-  <inkml:trace contextRef="#ctx0" brushRef="#br5" timeOffset="632650">27935 9684 22761,'-40'16'23,"0"0"0,0 1 0,0 4 0,-1 2 0,0 3 0,-1 0-41,6-3 0,-1 1 0,1 1 1,0 0-1,1-1-6,-1 2 1,1 0 0,1 0 0,3-2-74,-6 5 0,2-1 1,22-12-876,36-19 1,15-8 1635,4 1 1,5-2-784,-8 1 0,4-2 0,2-1 0,-2 0 262,-1-2 1,-1 0 0,0 0 0,-2 3-42,3 0 0,-2 1 0,-5 5-186,2 3 1,-15 8-147,-36 15 0,-22 10 1,-1 2 205,8-5 1,-2 3 0,0-1 0,-2 1 427,-6 0 1,-2 1-1,2-1 1,8 0-747,0 14 1,21-7-503,33-23 1,14-9 821,0-5 1,5-6-1,4-3 1,-3 1-154,-2 0 0,0-1 0,0 0 1,-1 0 240,1-1 0,1-1 1,-3 1-1,-5 1 353,4-3 1,-12 9 52,-20 27-618,-32 3 1,-19 4 0,-2 1 215,15-8 1,0 1-1,-1 1 1,-1 1 267,-1-1 0,-3 3 0,-1 0 0,4 0 0,6 0-512,0 5 1,7 0-1,6-1-376,3 1 0,13-2-46,19-6 1,11-3 0,1-4 19,2-6 0,2-2 292,4 4 1,3 4-1,-3-1 132,3 1 1,-3 1-129,-9-3 1,0 3 0,-2-1 157,4 3 1,-6 3-341,-12 4 0,-9 3 388,-15 3 0,-7 2 520,2 1 1,-2 1-355,-1-9 0,-3 0 0,6-1-474,5 2 1,11-5 239,35-14 0,15-10 469,-12-5 0,3-3 0,4-4-335,-5 0 1,5-3-1,1-1 1,-1-1 0,-2 1 507,-1 1 1,-1-1 0,-2 1 0,-1 1 86,8-5 0,-1 2 0,-12 6 229,-10 10-881,-52 11 0,-23 6 367,10 1 0,-4 4 0,-2-1-90,5-6 1,-2-1 0,0 0 0,4-1-4,-7 5 1,3-1 0,25-6-33,39-11-184,8-9 0,9-5 0,3-1 2,2 2 1,4-2 0,1 1 0,-1 1-74,-5 3 0,0 0 0,-1 1 1,-4 1 480,17-6 1,-15 13-1304,-30 42 461,-29-16 0,-16 2 1,-5 1 356,9-6 1,-5 1 0,-2 1 0,-2 1 0,1-1 0,3-1 261,-3 2 1,2 0 0,1 0 0,0-1 0,1 1-170,-12 4 0,-2 0 1,9-1-1,22-3-411,29-1 0,12-5 47,14-7 1,11-8 329,-11-3 0,8-3 0,4-2 0,1 0 0,-3 0 0,-5 1-259,9 2 0,-6 0 1,5 0 365,-9-3 0,5 0 1,3-1-1,-2 0 1,-3 1-1,-6 2-297,15 3 0,-6 4 165,4 4 1,-15 7-721,-39 24 1000,-6-6 0,-3 0 46,-2-10 0,6-1-558,18 4 1,9-3-348,9-5 1,6-3 491,6 5 0,0 2-507,-5 1 1,-5 4-226,-9 6 0,-6 3 230,-3 3 0,-4 0 365,-8 2 0,4-3-174,16-9 0,8-5 844,2-8 1,5-3 0,4-4-304,6-7 1,5-4-1,2-4 1,1 2 109,-7 1 0,2 0 0,0 0 0,0-1 0,0 0 5,-2-1 1,1-1-1,0 1 1,-2 0 0,-2 2 116,3 0 1,-1 2 0,-4 2 0,-6 5-5,5 12 0,-13 7-635,-18 16 1,-17 5 552,-10-13 1,-11 2-1,-4-1 1,4-1-70,0 0 0,2-1 0,-1 0-125,-1-4 1,-3 2 0,4-2-1,13-3 202,21 19-1599,27-17 1232,4-15 0,10-2 0,-3-4 304,0-5 0,1 0 234,-2 7 1,2 3-1,-3-1-502,-3-7 1,-4 3-349,-4 12 0,-9 3 644,-13 16-524,-22-8 0,-12 0 762,-1-7 0,-7-2 0,-3 1 0,2-1-459,0-1 1,1-1 0,-1 0 0,1-1 126,-3 1 0,-2 0 0,5-1 1,9-3 459,7 2-1168,46-22 0,20-9 866,-9 4 0,5-1 1,2-1-1,0 0-111,-7 1 0,1 1 0,1-1 1,-1 0-1,-1 1 200,7-2 1,-1 0 0,-1 1 0,-2 1-506,1-2 1,-2 2-1,-12 4 234,-11 6-127,-52 8 0,-26 4 126,19-1 1,-2 2 0,-1-2 554,6-5 1,-1-1-1,0-1 1,3 1-370,-2 2 1,2 1 0,8-8-143,-3-23-1445,54 9 1528,2-2 1,4-1-782,6 3 1,-3 2-282,-2 1 500,-23 3-30,-41 13 0,-23 7 307,15-7 0,-3-1 0,-2-1 82,9 1 0,-3 0 0,2-2 0,1-4 762,-6-7 0,2-5 0,10-4-862,9-9 0,11-3-625,13-2 1,9-1-121,12-2 0,8 4 331,1 7 1,1 3-346,-10 2 1,-1 0 604,5 2 0,-11 1-638,-50-9 415,-3 5 738,-6 7 1,-5 0 255,16 5 1,-1 0 0,-1-1-217,-10-2 1,-2 0-1,1-2-692,9-1 1,1-2-1,-1 1 126,-3 0 1,0 1 0,5-2-160,6-8 0,5-3-197,-4-6 0,4-3 251,7-7 1,3-4-28,5 8 0,2-2 1,2-3-64,3 7 0,2-2 0,2-1 0,2 0 232,1-4 0,2 0 0,1-1 1,0-1 49,1-2 1,0-1-1,1 0 1,-1-1-18,-1 10 0,0-1 1,1 1-1,-2-1 0,-2 1 22,-2-7 0,-1 0 1,-3 0-1,-4 2-14,-2 4 0,-3 0 0,-3 2 0,-2-1 68,-3 1 0,-2-1 1,-3 2-1,0 1 220,-1 3 1,-1 1 0,0 0 0,1-1-27,2-2 1,1-1 0,2-1 0,0 0-264,2 5 0,1-1 1,1 1-1,1-2 56,1-2 1,2-1 0,-1 0 0,-3 4 74,-10-3 0,-4 4 1,-3 1 88,4 5 1,-3-1-1,-1 3 1,-3 3 176,-7 6 0,-4 4 1,-1 3-1,0-1 66,0 0 1,0 0-1,1 0 1,0-1-62,4 1 1,1 1-1,1-1 1,6-2 637,-12-4 0,18-7-672,39-10 0,21-6 1,3 3 314,-5 10 1,5 3 0,6 0-441,-4 3 1,6-2 0,4-1-1,3 0 1,-1 0 0,-1 3 0,-3 2 130,1 0 0,-2 3 0,-1 2 0,0 0 0,2-1-208,-3 0 0,3-2 0,0 1 0,-2 1 0,-3 3 0,-4 5 39,22 3 0,-24 13-732,-49 18 0,-23 7 762,13-12 0,-5 1 0,-4 1 0,-2 1 0,-2 0-85,2-2 0,-4 1 0,-1 0 0,-2 1 1,1 0-1,1-1 0,3 0 33,1-1 0,1 0 0,2-1 0,0 1 0,3 0 1,1 0 57,-11 11 0,-1 1 0,11-1 0,19-6-894,35 1 1,19-7 722,-10-9 0,6-4 0,2 0 0,2-3 54,6 0 0,4-4 1,-1 1-1,0 2 493,-5 4 1,-1 3-1,-1 0 1,1 0-688,0-2 0,1-1 0,-2 2 0,-1 2 32,-5 3 1,-1 3 0,-1 0 0,-2 1-230,6 5 1,-2 0 0,-4 3 93,-7 1 1,-3 2 0,-2 2 419,-3 0 0,-3 1 1,-6 2-331,-9 5 0,-6 2 1,-4 1 422,0-10 1,-3 1 0,-1 0 0,-2 0-204,-3 5 1,-2 1 0,-1 0 0,3 0-81,2-4 0,2 1 1,2-1-1,4 0-89,2 5 1,5 0 0,11-4 90,12-8 0,10-1 1,5-4-1,1-3 259,3-5 0,3-4 0,3-2 0,1 1-51,-8-3 0,2 0 0,0 0 0,2 0 0,-1-1 0,-1 0 117,4 0 1,1 0-1,-1-2 1,-1 2 0,-2 0-58,2 3 1,-1-1 0,-3 3 0,-3 2-78,8 9 0,-4 4 0,-14 4-350,-17-2 1,-9 2-1,-7 3 353,-6-1 0,-8 2 0,-3 1 1,-3-1 17,1-5 1,-3 0-1,-1 0 1,-1 0 0,0 0-46,-1 2 0,-2 1 0,1-1 0,2 0 0,5 0 40,-7 9 0,5 0 1,14-2-433,16-5 1,11 0 0,7-8 310,13-9 0,10-9 0,1-2 407,-5 0 1,2-2 0,1 0 0,0 0 60,3 0 1,1 0 0,-1 0-1,-2-1-336,-1 1 1,-1-1 0,-3 4-199,-2 2 0,-1 2 0,-14 6-743,-22 21 1,-20 4 788,-7-11 1,-8-3 0,-4 1 377,3-1 0,-2 0 0,-2-1 1,-1-2-63,-3-2 0,-3-1 0,2-3 0,4-3 87,6-2 0,4-2 1,3-7 554,-10-8-1426,62-15 1,19-6 633,-13 7 1,1 0 0,0 0 398,3-1 1,1 1 0,-4 3-122,2 4 0,-15 4-475,-47 14-97,-9 7 1,-9 3 6,12-7 1,-5-1 0,-1 0 0,4-4 317,0 0 0,2-3 1,4-6 745,-6-9 0,15-7-996,39-7 1,23-4 0,3-1 8,-7 6 1,4-1 0,1 1 0,1 1-7,-6 4 0,2 1 1,0 0-1,0 2 0,-4 2-164,13-3 0,-3 4 0,-19 12-1087,-36 36 834,-11-7 1,-9 1 498,0-6 1,-4 0-1,4-2 190,2-2 1,13-5 336,50 1-520,-1-14 1,9-4-1,-5 1 1,5-1-1,3 0 1,-1-1-1,0 1 1,0-1-1,0 1 1,0-1-1</inkml:trace>
-  <inkml:trace contextRef="#ctx0" brushRef="#br5" timeOffset="649887">29916 9984 16320,'-24'-28'-3277,"10"11"1425,3 9 1753,11 8 1083,11-16-368,8-4 94,7-15-238,5 8-231,-29 9 181,-38 34-139,7 1 1,-8 8 0,-5 4 0,-3 2 0,1-2-540,8-6 0,-1 1 0,-1 0 0,-2 0 0,0 1 0,0 1 0,-2 1 300,3-2 0,-2 2 1,-1 2-1,-1-1 0,0 1 1,0 0-1,1-1 1,0 0-1,2-3 57,1 0 0,-1-1 0,2 0 0,-1-1 0,1 0 0,2-2 0,0 0 0,2-1-7,-8 4 1,1 1 0,2-2 0,4-4 0,3-6 509,-11-3 1,17-13-1192,43-29 1,23-14 718,-17 18 0,3-1 0,3-1 0,3-2-502,-1 3 0,4-3 0,2 0 0,1-2 0,2 1 0,-2 1 0,-1 2 352,-1 1 0,1 0 1,-2 2-1,1 0 1,0 0-1,0-1 5,3-1 1,1-2 0,0 0 0,-1 2 0,-3 1 0,-4 4-108,6-4 0,-4 4 0,-15 7-360,-16 10 211,-27 14 1,-15 13 552,11-1 1,-3 5 0,0 2 0,1-3 324,-5 1 0,1-1 1,1 3-599,4 1 0,-1 4 0,3 0 1,6-3-128,1 3 1,12-5 45,40 9 31,-4-34 0,7-10 0,2 0 96,4 0 0,3-1 0,3-3 483,-9 0 0,3-2 0,1-2 0,0 1 0,-3 3-611,0 2 0,-2 3 0,-1 1 1,1 0-54,3-3 0,0 0 1,-1 3-1,-7 8-400,1 12 0,-12 9-26,-22 19 1,-15 7 577,-2-11 1,-6 2 0,-4 2-21,2-6 1,-5 1 0,-1 1 0,0 0 0,3-2-61,1 1 0,3-3 1,1 1-1,0-1 12,-14 11 0,1-1 0,24-9-612,35-12 0,15-11 656,2-14 1,6-12 0,5-2 104,-13 6 1,2-2-1,3 0 1,0-2 0,0 1-1,-1 0-36,7-3 0,-1 0 0,0 0 1,-1 0-1,-1 1 7,2-3 1,-1 1 0,-2 2 0,-4 6-331,19 2 1,-22 16-36,-44 12 1,-18 11 0,-8 3-1,4-2 255,0 5 0,1-1 0,-7 5 202,8-12 0,-5 3 0,-3 3 0,-2 0 0,0 1 0,0-1 0,2-2 0,3-3-103,-2 1 1,2-3 0,2-1 0,-1 1 0,0 3-59,-2 2 1,-2 4-1,0 1 1,1-1-1,5-3 1,4-4 292,-8 11 1,17-5-757,27-4 0,15-7 230,4-17 1,8-7 0,1-2 265,6-1 0,2-1 0,1 0-55,-1 1 0,1 1 1,-1 2-282,-6 1 0,-1 2 0,-5 5-69,2 10 0,-10 8-168,-12 13 1,-12 8 558,-12-11 0,-8 5 1,-3 1-1,0-3 126,2-3 0,-1-2 0,-1 1 1,0 1-58,0 2 1,-2 1-1,1 2 1,2-3-1,4-3 26,3 1 1,4-3 0,6-1-555,14 18 1,15-10 253,0-25 0,8-9 0,4-2 73,2-3 1,5-5-1,2 0 1,-3-1 328,-3 1 1,-1-1 0,0 1-1,0-1-167,0 0 1,2-2-1,-3 3 1,-5 6-404,12 17 1,-14 11-261,-26 13 1,-14 5 625,-5-13 1,-6 1-1,-4-1 217,-6 4 1,-4-1 0,-1-6 440,-3-3 0,0-11 530,6-13 0,6-12-1254,18-21 1,11-14 0,1-3-29,-1 7 1,0-2 0,1-2-1,0 0-83,3-7 0,1-1 0,0 0 0,-2-1 284,-1 7 1,-1-1 0,0 1 0,-2 0 0,-2 2-461,-3-1 0,-1 2 0,-2 1 0,1 1 101,4-5 1,0 1 0,-8 2-592,-11 4 1,-8 1 0,-3 1 0,2 4 47,2 1 1,-1 4-1,-2-2 736,-5-4 0,-4-2 1,-1-1-1,1 1-57,4 3 0,1 0 1,0 0-1,1-2 229,-2-3 1,1-3 0,1 1 0,2 0-140,-2-1 0,3 1 0,2-3 49,8 2 1,1-3 0,3 0-1,6 2-41,5 2 0,6 1 0,2-1 159,3 2 1,2-3 0,2 1 0,1 0 38,4-9 0,1 1 0,0 1-67,2 1 1,0 0 0,-9 4-453,-13-2 1,-12 9 8,-17 15 1,-14 11 235,7 8 0,-8 7 0,-3 3 1,-1 2-1,2-1 331,1 1 0,1 1 1,-1 1-1,0 0 1,0-2-75,5-3 0,-1 0 1,0-1-1,0-1 0,3 0 1,2 0 848,-18 7 1,4-1 0,17-15-218,21-43-621,29 18 0,13-3 0,4 1 114,-2-1 0,4 0 0,3 1 1,1 2-32,-1 5 1,2 1 0,2 1-1,-1 3 1,-1 3-388,2 0 1,0 2 0,0 4 0,-2 6-243,9 7 0,-1 8 0,-8 10-75,-16 6 0,-5 7 0,-6 5 1,-5 0 195,-7-2 1,-6 1 0,-4 2 0,-1 1 0,0-1-78,0 0 1,1 0-1,-2 0 1,-3 0-1,-2 1 306,0-6 1,-3 0 0,-1 2 0,-2-1-1,-1-1 1,2-1 0,0-3-80,-6 8 0,-1-2 1,2-3-1,-1 2 34,1 1 0,-1 1 0,2-1 1,3-2 55,3-1 0,2-1 1,8-2 694,8-1 0,10-2-938,10-2 0,10-1 1,2-3 244,2-6 1,3-2 0,3-2 0,5 1-1,4-2 1,1 0 0,0-1 0,0-1-1,-1 1 1,0-1 0,1 0 0</inkml:trace>
-  <inkml:trace contextRef="#ctx0" brushRef="#br5" timeOffset="666741">24957 9895 13793,'6'-33'-563,"-1"0"0,0-1 1,3-2-1,-1 0 375,1 2 1,0-3-1,1 6-1,9-14 21,-17 19-497,-8 19 629,-15 17 1,-8 11-29,4-3 1,-3 3 0,-3 3-63,-4 2 0,-3 2 0,-2 2 0,-2 1-390,8-4 0,-1 1 1,-2 1-1,0-1 1,0 1-1,2-3 558,-3 0 0,1-1 0,1-2 0,-1 2 0,-2 1 46,6-1 0,-3 2 0,-1 0 1,0 1-1,2-1 0,3-2 1,5-3-25,-5 2 1,6-4 0,2 2 70,-5 8 1,3 2 0,18-11-118,28-20 0,20-12 0,8-4 0,-1 0 26,-3 4 0,2-2 1,3 0-1,0-2 1,0-1-224,-4-1 0,0-1 1,0-1-1,2 0 1,1-2-1,4-1 230,-11 6 0,2-1 0,2-2 1,2 1-1,0-1 0,1 0 0,0-1 1,0 2-1,-2-1 0,-2 1 0,-2 1-241,8-3 1,-3 0 0,-1 1 0,-1 0 0,0 1-1,2-1 1,2-1 218,-7 3 0,3-1 0,1 0 0,1 0 0,0-1 0,0 1 0,-1 1 1,-1 0-1,-3 2 0,-2 2 36,13-5 0,-4 1 0,-2 3 0,-2 2 1,-1 4 305,0 2 0,0 1 0,-6 5 1,-10 9-846,-10 17 1,-14 9 261,-11-2 0,-10 4 0,-11 3-65,6-15 1,-5 3 0,-6 1-1,-3 1 1,-2 0 0,-1 1-1,0-1 1,2-1 0,2-1 259,-3 3 0,0-1 0,1 0 0,1-1 0,-2 0 0,0 1 0,-1 1-6,3-3 0,-3 2 1,0 0-1,-2 1 1,1 0-1,2-1 1,1 0-1,3-1 1,4-2 178,-6 7 1,-1-1 0,5-1 0,10-1 0,13-4-320,26 15 1,23-9 190,0-22 0,10-8 1,5-5-1,2-2 159,-15-1 1,1-1 0,2-2-1,1-2 1,1-1 0,2-1 0,2-1-83,-10 2 1,2-1 0,2-1 0,1-1 0,1-1 0,0 0 0,1-1 0,-1 0 0,0 1 0,-1 0 0,-2 0-1,-1 1-252,3-1 0,-1 1 0,-2-1 0,0 1 0,-1 0 0,1 0 0,0-1 0,1 0 0,3 0 201,-1 0 0,2-2 0,1 0 0,2-1 0,0 1 1,0-1-1,-1 1 0,-1 1 0,-1 0 0,-4 3 0,-2 1-17,8-2 0,-4 3 0,-3 0 0,0 2 0,-2 2 0,0 0 1,16-3 0,1 0 1,-7 6-1,-14 12 422,-13 23 1,-19 9-556,-14-10 1,-12 3-1,-7 2 1,-4 0 42,4-7 0,-5 0 1,-4 1-1,-2 0 0,-2 1 1,-1 0-1,0 0 0,2-1-142,3-1 0,-1-1 0,1 1 0,-1 0 0,-1-1 0,0 1 0,0 0 0,0 0 0,-1-1 208,3-1 0,-2 0 0,-1 0 0,0 0 0,0 0 0,1 0 1,-1 0-1,2 0 0,0-1 0,2 1-12,-5 3 1,1 0 0,0 0-1,2 0 1,0-1 0,3 0-1,2-2 1,3-1 203,-7 6 0,3-3 0,6-1 0,7 1-346,-2 18 1,23-10 321,28-30 1,19-14 0,10-7-1,-2 1-47,-12 4 1,1-1 0,2-1 0,0-1 0,2-1 0,1-1-66,-6 2 1,2 0-1,0-1 1,2-1-1,0 0 1,0-1-1,0 1 1,1-1-2,-3 0 0,2 0 0,0-1 0,0 0 1,0 0-1,0 0 0,0 0 0,0 2 0,-1 0-3,3 0 0,0 1 0,-1 0 1,0 1-1,0 0 0,-1 1 1,-1 0-1,-1 1-51,6-2 0,0-2 0,-1 2 0,-2 2 0,-3 3 0,-2 5 8,4 5 1,1 4 0,-9 4 0,-16 8-370,-23 24 1,-25 10 301,4-22 1,-8 3 0,-4 2 0,-4 0-1,-2 1 1,1-2 126,6-5 0,-2 0 0,0-1 0,-2 1 0,0 0 0,-1 0 0,-1 2 0,0 1-139,5-4 0,-1 2 0,-1 1 0,-1 1 0,-1 0 0,1 1 0,0-1 0,1 0 0,1-1 0,1-1 0,2 0-7,-7 4 1,0 0 0,1-2 0,2 0 0,3 0 0,3 2 0,4 1-84,1 5 0,1 4 0,3 1 0,6-3 0,7-4 0,10-8-119,15-4 1,12-8 0,9-3 284,-6-7 1,6-2-1,6-2 1,3-2 0,4-1-1,0-1 1,1-1-1,-2-1 1,-3-1-95,2-1 0,-1-2 0,-1-1 0,0-2 0,1 0 0,1-1 0,2 1 0,2 1 140,-9 1 0,3 1 1,2 0-1,0 0 0,1-1 1,1 1-1,0 0 1,-1-1-1,0 1 0,-2 0 1,-1-1-1,-2 0 38,3-1 1,-2 0 0,-1-1 0,-1 0-1,-1 1 1,0 0 0,0 0 0,0 1 0,1 2-57,5 0 1,2 0-1,0 1 1,-1 1 0,0 1-1,-3 1 1,-4 1-1,-3 2-38,5 0 1,-5 1-1,-3 4 1,-5 9-103,-2 11 0,-2 9 0,-8 4 1,-11-2 94,-14-1 0,-14 0 1,-9 4-16,7-12 0,-5 3 0,-4 2 1,-4 2-1,-1 0 0,-2 0 1,1 0-1,0-2 0,3-3-37,-4 2 1,0-2-1,1-2 1,0 0-1,-2 0 1,0 2-1,-3 3-16,7-5 1,-3 3-1,-2 1 1,-1 2 0,0 0-1,0 0 1,0 0 0,2 0-1,2-1 1,2-2 0,3-1-41,-5 7 0,2-3 0,2-1 1,3 1-1,3 0 0,3 2-11,-2 8 1,1 5 0,4-1 0,10-4 0,14-9-226,16-9 0,12-8 1,10-4-1,3-1 415,-10-7 0,4-1 0,4-1 0,4-2 0,1-1 0,2-1 0,0-1 1,0 1-1,-2-1 0,-2 0-69,0 0 1,0 0 0,-2-1 0,0 0 0,1-1 0,0 0-1,2 0 1,1-1 0,2 0 15,-7 1 1,3-2-1,0 0 1,3 0 0,0-1-1,1 1 1,0-1 0,0 0-1,0 0 1,-1 0 0,0 1-1,-2 0 1,-2 0 0,-2 1 124,9-1 1,-2-1-1,-2 1 1,-1 0 0,-1 1-1,0 0 1,-1 2-1,1 0 1,1 2-126,0 1 1,2 2 0,1 0-1,0 1 1,-1 2 0,-2 0-1,-2 1 1,-4 0 0,-5 2-12,10 3 0,-4 0 0,-7 4 1,-9 9-35,-8 14 0,-9 10 0,-10 3 0,-10-4 182,-7-18 1,-7-3 0,-7-1 0,-3 0-1,-3 1 1,-1 3-130,10-6 1,-4 2 0,-1 2-1,-2 0 1,-1 1 0,-1 1-1,0 0 1,-1-1 0,1 1-1,1-2 1,2-1 0,1-1-53,-7 5 1,2-3-1,1 0 1,1-1 0,0 1-1,-1-1 1,1 2 0,-1 2-47,2-2 1,-2 2 0,-3 1-1,0 1 1,1 0 0,2 0-1,3-1 1,5-1 0,6-3 0,7-2-256,0 11 1,12-2 0,11-7-1,19-3 1,13-7-1,7-7 343,-7-8 1,5-4-1,3-4 1,2-3-1,0-3 1,-4 0-1,-3-3 1,-2-2-1,0-2 1,-1-2 0,1 0-1,1 0 1,0 0-1,-1 1 1,0 0-1,0-1 1,1 1-1,-1-1 1,0 1 0</inkml:trace>
-  <inkml:trace contextRef="#ctx0" brushRef="#br5" timeOffset="667637">25831 11448 11471,'-12'-33'-525,"1"0"0,0 1 0,-4-1 1,-2 1-1,-2-1 495,1 0 0,-1-3 1,-2 2-1,-2 3-201,-7 1 1,-3 3-1,-2 4 224,-2 2 0,-3 4 0,1 6 83,1 9 1,0 6 0,0 0-7,3-2 0,-1 0 0,7 6 120,3 9 0,13 1-69,44 2 5,4-17 0,12-5 1,6-2-1,1-1-466,-11 0 0,1 0 1,2-2-1,1 0 0,2 0 1,2 0 377,-8 2 1,3 0 0,1 0-1,1-1 1,0 1 0,1-1-1,0 1 1,-2 0 0,0 0-22,0 0 1,0-1 0,0 1-1,-1-1 1,0 1 0,0 1 0,1 1-1,-1 2-27,1 1 0,1 0 1,1 1-1,-1 0 0,-1 3 1,-1 2-1,-4 2 1,-3 4-238,7 6 0,-4 4 0,-3 4 0,-5 4 0,-7 3 176,-8 4 0,-5 5 1,-5 4-1,-6 0 1,-3 0 76,-5-2 0,-5 0 0,-4 1 0,-3 0 0,-1 1 0,-3 1-225,1-5 1,-3 1-1,-3 1 1,-1 1-1,-1-1 1,1-1-1,2-1 1,3-2 177,-1 0 0,1-1 0,1-1 1,2-1-1,4 1 0,3 1-53,2 3 1,2 4-1,2 0 1,6-2-1,5-4 1,10-5-120,9-6 1,9-6-1,8-4 1,4-2-1,3-2 1,3 0 193,-13-5 1,3-1 0,3 0-1,2-2 1,2 0 0,1-1-1,1-1 1,0 1 0,0-2-1,0 1 1,-1 0 0,-2 0 6,1 0 0,0 0 1,-1-1-1,0 0 0,0 0 1,0 0-1,1-1 0,0 1 1,1-1-1,1-1 0,1 1 48,-6-1 1,3 0 0,0-1 0,1 0 0,1 0 0,1 0-1,0 0 1,0 0 0,0-1 0,-1 1 0,-1 0 0,-1 0-1,-1 0 1,-2 1 0,-2 0-22,11 0 1,-3 1-1,-2 0 1,-2 0-1,0 1 1,0-1-1,-1 2 1,1-1-1,1 2 51,-2 0 1,1-1 0,1 2 0,-1-1 0,1 1-1,-1 1 1,-1 0 0,-2 1 0,-1 1 0,-3 0-58,8 5 1,-2 1 0,-2 1 0,-2 2 0,-2 1 0,-2 3-102,4 6 0,-1 3 0,-3 2 0,-5 1 1,-8 2-47,-9 2 1,-6 2-1,-6 1 1,-5-2 135,-4 1 0,-5-1 0,-5 0 0,-7-2 0,-3-6 0,-7-2 0,-4 0 0,-2-1 0,-2 0 1,2 0-1,1-5 0,1 1 0,-1 0 0,1-1 0,0 1 0,-1-1 0,1 1 0</inkml:trace>
-  <inkml:trace contextRef="#ctx0" brushRef="#br5" timeOffset="671488">21339 13811 26265,'2'-33'-820,"-1"0"1,1-1 0,-1-2 0,0 0-820,1-14 1,-4 6-1639,-22 8 2303,-6 45 0,-11 14 1088,7-5 0,-6 5 0,-3 2 0,-2 2 0,0 1-583,7-3 1,-2 1 0,-1 2 0,-1 0 0,0 1 0,-1-1 0,1 0 489,4-3 0,0 1 0,-1-1 0,1 0 0,-1 1 0,0-1 1,0 0-1,0 0-99,0 0 1,-1 1 0,0-1-1,0 0 1,0 0 0,2-1-1,2 0 1,2-2 503,-4 4 0,2-2 0,2 0 1,3-1-1,3-2 334,-21 18 1,26-14-626,50-27 0,21-13 104,-12 2 0,5-5 1,4-1-1,1-2 1,1 0-418,-10 4 0,1 0 0,0-1 1,2 0-1,0-1 0,1 0 0,2-1 203,-2 2 1,1-2 0,2-1-1,1 1 1,1-1 0,-1 0-1,-1 1 1,0 1 0,-2 1-176,2-1 0,0 2 0,-2 0 0,0 1 0,0 0 1,0 0-1,1-1 227,1 0 1,1-2-1,1-1 1,-1 2-1,-1 0 1,-3 3 0,-2 3 31,4-1 1,-1 2 0,-5 5-1,-8 8 506,-3 16 1,-15 8-384,-21 2 0,-17 6 0,-9 4 1,-2 1-295,9-10 0,-4 2 0,-3 1 0,-2 1 0,-2 1 0,0 0 0,-1 1 0,0-1-161,8-5 1,-1 0 0,-1 0 0,-1 1 0,0-1-1,0 1 1,-1 1 0,1-1 0,-1 0 0,0 0-1,1 1 170,0-3 1,1 1 0,-2 1 0,1-1 0,-1 0 0,0 1 0,1-1 0,0 0 0,0 1 0,2-2 0,0 1-1,2-1-46,-4 5 0,1-1 0,0 0 0,1 0 1,1 0-1,1-1 0,2 0 0,2-1 1,2 0 50,-8 9 1,1-1 0,4 0 0,7-3-1,8-1-678,7 20 1,22-12 777,15-29 1,12-9-1,8-6 1,-1-3 145,-9-1 1,2-4-1,1-2 1,2-2-1,0 0 1,1-1-90,-4 2 1,0 0 0,2-1-1,0 0 1,0-1 0,2-1-1,0-1 1,2 0-23,-6 0 0,1 0 0,2-1 1,0-1-1,1-1 0,0 0 0,0 0 1,0 1-1,-2-1 0,0 2 0,-2 0-3,2 0 1,-2 0 0,-1 0 0,-1 1-1,0 0 1,1 0 0,0 1 0,1-1-1,2 0 18,-1 1 1,2-1-1,3 0 1,0-1-1,0 1 1,1 0-1,-2 1 1,-1 1-1,-2 1 1,-4 1-1,-3 3 17,18-6 0,-6 3 0,-4 3 0,0 7-81,2 6 1,4 3 0,-10 6-1,-20 5-229,-27 6 1,-18 6 0,-10 3 0,-2 3 122,10-8 1,-3 2 0,-2 3-1,-3 0 1,-2 2 0,0 0-1,-1-1 1,-1 0 0,1-1-8,2-2 0,-1-1 0,-1 0 0,-1-1 0,0 1 1,0 0-1,-1-1 0,0 2 0,-1 0 0,0 0 36,3 0 0,-2 0 0,-1 1 0,0 0 0,-1 1 0,0 0 0,0 0 0,1-1 0,1 1 0,0-2 1,2 1-1,1-2-70,-2 2 0,0 0 0,1 0 0,0-2 0,2 1 0,1-1 0,1 0 0,1 0 0,2 0-28,-8 7 1,-1 0 0,2 0 0,5-1 0,7-2 0,13-3-228,14 18 0,22-12 150,10-21 1,13-11 0,7-7 378,-17-3 1,5-4-1,3-3 1,3-4 0,1 0-1,1-2 1,-1 0 0,0 0-182,-6 3 0,0-1 1,0 0-1,1-2 0,0 0 1,1 0-1,-1 0 0,1 0 1,0-1-1,1 1 73,-2 1 1,0-1 0,1 0-1,0 0 1,0 0 0,0 0-1,1-1 1,-1 1 0,1 0-1,0 0 1,-1-1 33,-2 2 0,1 0 0,0-1 0,1-1 0,0 1 0,-1 0 0,1 0 0,-2 1 0,-1 1 1,0 0-1,-3 2 0,-1 1 157,8-2 1,-3 1 0,-1 1-1,-2 2 1,0 0 0,-1 1-1,0 1-163,13-6 0,5-1 0,-4 2 1,-11 9-1,-18 13-254,-22 16 0,-15 13 0,-10 6 0,-3-2 186,3-10 1,-4 1 0,-4 0 0,-3 1 0,-1 0-1,-1 0 1,0 1-182,3-2 1,0 0 0,-2 1 0,-1-1 0,0 2 0,-1-1 0,-1 1 0,-1 1 0,-1-1 129,5-3 0,-2 1 0,-2 0 0,0 1 0,-1 0 0,0 0 0,0 0 0,0 0 0,1 0 0,0-1 0,2-1 0,2 0-128,-4 2 1,2-1-1,0 0 1,2-1-1,0 0 1,0-1-1,1 1 1,0 0-1,0 1 90,-4 3 0,-2 0 0,1 1 0,0 0 0,2 0 0,2-2 0,5 0 0,5-2-233,-5 10 1,5 0-1,8-5 1,17-7 37,21-6 1,18-8 0,3-7 544,-8-8 0,3-4 0,3-5 0,3-2 1,3-1-209,-9 3 0,3-2 0,3-2 0,1-1 0,2 0 0,0-1 1,1-1-1,-1 0 0,-1 1 0,-2-1-51,2-1 0,-2 0 1,0 0-1,-1-1 0,1 0 1,0 0-1,0-1 0,2 1 1,2-1 55,-5 3 0,2-1 0,0 0 1,2-1-1,1 1 0,0-1 0,-1 1 1,1 0-1,-1 0 0,-1 1 0,-1 1 1,-2 1 45,4-2 0,-1 1 0,-1 0 0,0 1 0,-1 1 0,-1 0 0,-1 1 1,0 0-1,-2 2 110,10-2 1,0-1 0,-2 3 0,-1 1 0,-4 2 0,-3 5-127,12 2 0,-6 6 0,-20 10-30,-28 5 0,-16 10 0,-10 5 0,-7 2 0,0 0 0,4-4-158,4-4 0,-1-2 0,-1-1 0,-1 1 0,-2 2 0,-2 1-7,5-3 0,-2 1 0,-3 2 1,-1 1-1,0 1 0,0-1 0,0 1 1,1-2-1,2-2 0,2-1-45,-7 4 0,2-3 0,2-1 1,1 0-1,1 1 0,1 3-171,-1 4 1,-2 4-1,2 0 1,4 0 0,6-3-1,9-5-208,8 11 0,18-7 202,12-12 0,13-3 0,7-5 0,0-7 345,-7-8 1,2-7 0,2-3 0,1-4-1,3 0 1,1 0 181,-5 3 0,3-1 0,2-1 0,1-1 0,1 0 0,0-1 0,-1 1 1,-1-1-1,-1 1-46,-1-1 0,0 0 0,-1-1 0,-1 0 0,0 1 0,0-1 0,0 1 0,0 1-1,5-1 0,1-1 0,1 0 1,-2 1-1,0 1 0,-4 3 0,-2 1 55,8-1 1,-1 1 0,-7 6-1,-9 9-160,-3 20 1,-16 11-161,-20 0 1,-13 6 0,-5 0 169,3-10 0,-3 1 0,-2 0 1,-2 0-1,1 0 43,-1 2 1,-1-1 0,-1 1 0,0 0 0,-1 1-356,2-3 1,-1 1 0,-1 1-1,1-1 1,2-1 0,3 0-50,-4 6 1,1-1 0,6-1-1,6 2-437,6 13 1,8 1 0,16-14 484,18-22 1,14-12-1,4-5 353,-7 0 0,3-3 1,2-3-1,3-3 1,0-3 84,-9-1 0,1-4 0,2-2 1,0-1-1,1-2 0,-1 0 1,0 0-1,0 2-96,-3 1 1,0 0-1,0-1 1,-1 1-1,1 0 1,0-1 0,1 0-1,1-1-6,-2 1 0,1-1 0,1 0 0,1-1 1,1 0-1,-2 0 0,1 0 0,-2 2 0,-1 0 1,-2 2-70,4-1 1,-2 1-1,0 1 1,-2 1-1,-1 1 1,0 0-1,0 0 5,11-6 1,3-2 0,-3 2 0,-7 8-1,-12 12-112,-9 18 1,-14 7 0,-30 8-1,-18 2 1,9-9 0,0 0 0,0 0-1,-1 0 1</inkml:trace>
-  <inkml:trace contextRef="#ctx0" brushRef="#br5" timeOffset="672807">25523 10478 16908,'-32'-13'-397,"-1"0"1,-3 8 0,-5 4-1,-1 3 620,1 4 1,-1 3 0,-2 3 0,-1 2-364,2 1 1,-2 2 0,0 1 0,0 2 0,0 2 85,8-1 1,-1 2 0,1 1 0,1 1-1,1 0 1,1 0-82,-1 4 1,2 0 0,1 0 0,2 0-1,2-1 360,-10 6 1,4-1 0,15-1-618,22 10 0,18-9 342,15-27 1,13-14 0,5-2-22,-11 6 1,2-1 0,3 0 0,2-2 0,2-3 152,-9 0 0,3-3 1,0-1-1,2-1 1,1-1-1,0 1 1,-1 0-1,0 1-224,0 1 0,0 1 0,0-1 1,0 1-1,0 0 0,0 1 1,0-1-1,-1 1 198,0 0 0,0-1 0,0 0 0,-1 1 0,1 0 0,-2 1 0,0 2 0,-3 3 2,6-1 1,0 0 0,-1 2 0,-2 4 0,-5 4 0,-6 8-284,0 12 1,-5 8 0,-8 7-1,-8 1 167,-12 2 0,-9 4 1,-7 2-1,-3 2 1,-2-1 13,2-8 1,-2 0-1,-2 0 1,-2 0-1,-2 1 1,-1 1-1,-1 0-156,2-5 1,-2 1 0,-2 1 0,-1 0 0,-1 0 0,0 1 0,0-1 0,2-1 0,1-1 0,2-1 82,-3 5 1,1-2 0,1-1 0,2 0 0,0-1 0,2 1 0,1 0-22,-4 7 0,-2 1 0,1 0 0,5-1 0,9-2 0,11-5-184,18 4 0,15-4 0,8-4 1,4-7 296,-5-11 0,4-5 0,4-3 1,2-3-1,1-1 0,0 1 146,-5-1 1,0-2-1,1 0 1,1-1-1,1 0 1,1-2 0,1 1-1,2-1-22,-6-1 0,2 0 0,1-1 0,1-1 1,0 1-1,1-1 0,0 0 0,0-1 1,0 1-1,-2 0 0,0 0-1,0 0 0,-1 0 0,0 0 0,-1-1 0,0 1 0,0 0 0,0 0 0,0 0 0,1 1 0,0 0-57,0 0 0,2 0 0,0 0 0,0 0 0,0 1 0,0 0 0,-1 2 0,-1 0 0,0 1 0,-2 2 6,4 1 0,0 0 0,1 1 0,-2 2 0,-2 1 0,-2 3 0,-4 2 1,-4 3-75,4 10 1,-4 3 0,-5 5 0,-5 2 0,-6 3 59,-8-1 1,-5 4 0,-4 2-1,-5 2 1,-4 0 0,-4-2-32,-3-5 1,-4 1-1,-5-1 1,-3 1-1,-2-1 1,-1 0-1,0 0 1,0 0-90,0-3 1,0 0 0,-2 0 0,0 0 0,-2 0-1,1-1 1,-1 1 0,1-2 0,0 1 55,0-2 1,0-1 0,-1 1 0,0-2 0,0 1 0,1 0 0,2 0 0,2 1 0,2 0-190,-2 6 1,0 2-1,1 0 1,4 0 0,3-1-1,6 0 1,7-3-118,9 12 0,10-1 1,9-3-1,6-3 193,-2-12 1,5-2 0,4-2 0,5-2 0,3-3 0,4-3 184,-8-8 0,3-2 0,4-2 0,2-2 0,3-2 0,1-1 0,2-1 0,0 0 0,0 0 0,-1-1 0,0 1 0,-2 1-25,-3 0 0,-1 0 0,0-1 1,0 0-1,0 0 0,1 0 1,-1-1-1,1 1 0,0 0 0,0-1 1,1 1-1,-1 0 0,2 1-9,-4-1 1,2 1 0,0 0-1,1 0 1,1 0 0,-1 0 0,1 0-1,-1 0 1,1 0 0,-2 0 0,0 1-1,-1-1 1,-1 0 0,-1 1 0,-2-1-37,12 1 1,-1-1 0,-1 0 0,-2 0 0,-1 1 0,-1 0 0,-1 2 0,-1 1 0,-2 2-1,3 2 1,0 2 0,-2 2 0,-1 1 0,-3 1 0,-2 0 0,-4 0 0,-1 7 0,0 1-1,0-1 1,0 0 0</inkml:trace>
-  <inkml:trace contextRef="#ctx0" brushRef="#br0" timeOffset="710753">9340 12771 6993,'-19'-10'1439,"1"2"-1259,11 8 0,2-8 180,5 6 269,0-6 1,0 8 180,0 0-91,0-8-269,0 6 0,0-5-180,0 7-540,0 0 450,11 15-450,13 13 764,1 6 1,5 8-540,-7-12 0,2 1 0,0 1 0,-1-1-45,1 0 0,-2-1 0,0 1 60,6 6 0,-1 1 0,-4-7-149,1-4-91,-13-9-180,-6-10-270,-6-8-2068,0-8 2788,0 6 0,-17 2 0,-3 10 0</inkml:trace>
-  <inkml:trace contextRef="#ctx0" brushRef="#br0" timeOffset="711204">9353 13282 5914,'-25'0'2788,"11"0"-1619,3 0 271,28-23-676,-1 6 1,5-4-376,5-9 1,3-6 0,1 0-698,-2 5 0,1 0 0,0-3 375,-2 1 1,2-2 0,-1-1-1,-4 3-247,4-11 0,-3 4-608,-3 7 0,-5 5-1820,-11 5-669,-12 38 3264,5-11 0,-15 28 0,2-13 1</inkml:trace>
-  <inkml:trace contextRef="#ctx0" brushRef="#br6" timeOffset="720133">2293 16792 21155,'0'-41'-1101,"13"21"1,5 1 1893,3-8 1,5 1-171,3 10 0,5 2 0,-1 1-535,13-6 1,1 3-30,1 2 1,0 0-1,-5-6 1,0-1 0,-3 2-1,0 1 1</inkml:trace>
-  <inkml:trace contextRef="#ctx0" brushRef="#br6" timeOffset="720549">3140 16369 13112,'20'-27'168,"0"0"0,0 1 0,13-11 0,5 3-4,-3 11 0,3 3 0,1 2-634,-3 4 0,1 3 0,1-1 379,9-5 1,1 0 0,-3 2 164,-3 4 1,0 0 4,-5-3 1,2-4 0,-1 1 39,4-1 0,0-1 67,-5 2 1,2-1 0,0 0 53,4 1 1,1 0 0,-1-2-171,-4 0 0,-1-2 0,2 1 12,-4 2 0,2 1 0,-1-1 0,-1 0-213,5-3 0,-2-1 1,1 0 223,-6 4 1,0-1-1,1-1 1,-1 1-29,0-1 1,-1 0 0,0 1-1,0 0-60,6-4 0,-1 2 0,1-2-23,-3 1 0,0-3 0,1 1 1,-3 3-59,1 1 0,-2 2 0,2-1 68,1-1 0,3-1 1,0-1-1,0 1 0,-1-1 1,-1 0-1,1 0 0,1-1 1,-1 2-1,0-1 1,1 1-1,-1-1 0,0 1 1</inkml:trace>
-  <inkml:trace contextRef="#ctx0" brushRef="#br6" timeOffset="720702">6030 14834 11312,'21'-28'159,"1"-1"0,-1 0 1,6-1-1,2 0 0,3 0-101,-2 5 1,3-1 0,0 2-1,1 1-758,5-3 1,0 2 0,4 1 530,1 3 0,4 0 0,-1 2 1,-5 2 174,-9 5 0,-3 2 1,2-2-1,10-5 0,4-3 1,1 0-1,-5 0 0,-3 0 1,0 0-1,-1 0 0</inkml:trace>
-  <inkml:trace contextRef="#ctx0" brushRef="#br6" timeOffset="721058">7777 13882 9726,'38'-26'-82,"0"1"0,-8 5 1,2-1-1,2-1 125,-1 2 1,3 0-1,1 0 1,-1 0-231,-2 0 0,0-1 0,1 1 0,0 0 145,1 2 1,0 1 0,1-1-1,-2 1 127,9-6 0,-2-1 0,2 2-137,-7 8 1,1 0-1,0 1 1,1-1-346,2-2 1,2-2 0,-1 0-1,-1 2 452,-4 2 0,-2 2 0,1-1 0,4-3-53,0-1 0,3-3 0,3-2 0,-1 0 1,-1 0-1,-4 1 19,4-2 0,-4 1 0,-1 0 0,4-3-90,-5 3 0,3-3 0,0 0 0,1-1 0,-3 2 0,-2 1 255,-1 1 1,-3 2 0,0 1 0,0-2-58,5-4 1,1-1-1,-1 0 1,0 3-462,-4 5 1,0 1-1,-1 2 1,1-2 159,4-1 1,0 0 0,0 0 0,-2 2 171,2-1 0,-1 3 0,-2 2 0,3 1 0,-3 4 0,13-1 0</inkml:trace>
-  <inkml:trace contextRef="#ctx0" brushRef="#br6" timeOffset="721783">2910 17339 14810,'-15'-33'-2863,"11"19"533,35-10 2630,-11 24 0,7-8 0,9-6 0,-3-3 0,0-7 0,0-1 0</inkml:trace>
-  <inkml:trace contextRef="#ctx0" brushRef="#br6" timeOffset="721958">3722 16739 15673,'26'-26'352,"0"-1"1,0 0 0,10 0 0,2 0 0,0 3-169,-4 2 1,0 1 0,2 1-550,-2 3 1,2 1 0,-1 1 0,-3 2 0,4-3 0,-3 3 0,-1 1 0,0 0 0</inkml:trace>
-  <inkml:trace contextRef="#ctx0" brushRef="#br6" timeOffset="722141">5501 15610 13381,'27'-28'139,"0"-1"0,1 0 0,2 4 1,1 0-1,4 1-231,1 0 0,3-1 1,1 1-1,-3 3-18,-3 1 1,-1 3 0,2-3-1,2-3 1,3-1 0,0-2 0,-4 1-1,-1-3 1,-1 0 0,1 0-1</inkml:trace>
-  <inkml:trace contextRef="#ctx0" brushRef="#br6" timeOffset="722533">7150 14446 12008,'26'-31'234,"-1"0"1,1-1 0,3-1 0,2 0-1,3-1-160,-1 4 1,4-2 0,1 1 0,0 1-527,-5 6 0,0 1 0,1 0 0,0 0 0,1 0 311,2-1 1,1 0 0,0 0-1,1 0 1,0-1-221,-4 2 1,0 0 0,1 0-1,-1 0 1,1-1 0,0 0 344,0 0 0,0-1 0,0 0 0,0-1 0,0 0 0,1 0 40,-1 0 1,0-1 0,1 0 0,0 0-1,-1 0 1,-1 1 0,-1 1 21,3-2 0,-1 1 0,-1 0 0,-1 1 0,2-2-25,3-3 0,1 0 0,-1-1 0,-1 1 1,-3 2 283,2-3 1,-3 1 0,3-1-190,-3 4 0,4-2 0,1-1 0,0 0 0,-2 1-38,1-2 1,-2 1 0,1 0-1,1-1-360,-5 7 1,1-2-1,2 1 1,-1-1-1,-1 2 1,-2 2 306,3 0 0,-4 2 0,1 0 1,3-2-40,4-3 0,3-3 0,1-1 0,0 1 0,-2 1 1,-6 5-1,-1 2 0,-1 0 0,2-1 0,1-2 1,6-5-1,-1 1 0,1-1 0,-1 0 0,1 0 1,-1 1-1</inkml:trace>
-  <inkml:trace contextRef="#ctx0" brushRef="#br6" timeOffset="722708">10977 11571 822,'8'-28'667,"0"-1"1,19-6 45,-8 11 0,6-3 0,1 4-1158,4 7 0,3 5 0,-1 0 456,10-2 0,2-1 0,-4-5 1,1-3-1,-2 0 0,-9 3 0,1-1 1,-1 0-1</inkml:trace>
-  <inkml:trace contextRef="#ctx0" brushRef="#br6" timeOffset="723366">2699 15769 9014,'0'-17'-117,"0"-1"-371,15 0 331,7 2 0,7-1 172,10 2 1,7 1-1,-1-2 1,-3-4-1,-1-1 1,3-1-1,-1 5 1,-1-1-1,1 0 1,0 1-1</inkml:trace>
-  <inkml:trace contextRef="#ctx0" brushRef="#br6" timeOffset="723566">5340 14570 9014,'39'-20'7,"-1"0"1,1 0 0,0 0 0,-1 0 0,5-3 0,-1 1 0,1 1 0,3 1-7,-5 5 1,3 1 0,2 1 0,0 1 0,-2 0 0,-5 1 0,10-3 0,-6 0 0,3 1-1,-3 1 1,-1-1 0,1 1 0,0 0 0</inkml:trace>
-  <inkml:trace contextRef="#ctx0" brushRef="#br6" timeOffset="723717">7482 13741 4528,'37'-26'-36,"-4"10"0,7-1 0,1-1 193,-9 3 0,1-2 1,2 1-1,3 0-263,4-1 1,5 1 0,1-1 0,1 2 0,-3-1 105,-7 3 1,0 1 0,-1 0 0,0 0 0,0-1 0,1-2 0,1 1-1,-1-2 1,-1 1 0,-2 0 0,-1-1 0,0 0 0,1 0 0,-1-1 0</inkml:trace>
-  <inkml:trace contextRef="#ctx0" brushRef="#br6" timeOffset="723908">10103 12735 9001,'33'-19'-28,"1"-1"0,0 0 0,-1 1 0,6-2 0,1 1 0,2 0 0,3 1-37,-8 4 1,2 1 0,1 1-1,1 0 1,1 0 0,-1 0-114,2 0 0,0 0 1,1-1-1,0 1 1,-1 1-1,0-1 1,5-2-1,0 1 1,0 0-1,-1 0 1,0 0-1,-1 0 1,0 0-1,0 0 1,0 0-1,0 0 1</inkml:trace>
-  <inkml:trace contextRef="#ctx0" brushRef="#br0" timeOffset="724083">12528 12012 6971,'34'-25'442,"0"0"0,0 1 1,-1 3-1,0 1 0,4 0-452,-4 2 1,4 0-1,2-1 1,0 2 0,-1 3-598,5 1 1,-1 4 0,1 1 0,-2 0 604,8-1 1,-2 0-1,-2 4 1,-5 3-1,-2 3 1,-4 0-1,-4-1 1,0 0-1</inkml:trace>
-  <inkml:trace contextRef="#ctx0" brushRef="#br0" timeOffset="754599">23923 13529 7173,'7'0'-720,"-2"0"1260,1-8-270,-5 6 90,4-13-180,-5 13 359,0-14-179,0 14 0,0-6-180,0 0-360,-5 6 0,-2-13 0,-10 13 90,-8-6 90,-1 8 0,-10 6 0,-2 4 180,-3 1-120,9 3 0,-5 3 0,4 1 30,4 0 0,3 3 89,-4 9 1,-2 5 0,5 0-90,4 4 0,4 1-30,2-7 0,2 3 0,7-1 30,15 10 0,8-4-45,-8-16 0,4-1-105,12 2 0,8 1 0,0-8 195,-4-9 0,3-4-45,7 2 0,5-2 0,-3-4 45,-5-8 0,0-8-105,3-8 0,2-8 0,-6 0 60,-8 0 0,-4-3-120,0-2 0,0-4 0,-6 3-15,-7 3 0,-9 2 180,-20-10 0,-9 5-135,9 19 0,-4 3 0,-19-5 0,-1 7-135,16 10 0,2 4-180,-4-4 0,2 4-225,2 7 1,3 5 89,-14 16 495,21 5 0,5 6 90,7-5 0,3 2 89,-1 10 1,6 0-135,11-2 0,6-3 45,-2-13 0,5-4 90,14 2 0,4-14-105,-11-23 0,1-10 0,0 0 60,9-5 0,-1-5-173,-7-4 1,-1-6 0,-5-1-68,-9 3 0,-4-2 0,-3 1-30,-3-10 0,-8 2 135,-6 0 0,-13 6-105,-6 22 0,-8 5 0,0 9-180,1 9 0,0 8 1,0 0-1,1-4 0,-1 1 0,3 6 15,2 12 0,1 8 0,3 3 1,5-3-5,7-2 1,5-1 0,1 0 198,-3 9 0,1 0 1,8-2 343,17 7 1,10-10-270,0-18 0,5-8 135,15-6 0,0-10-45,-9-17 0,-3-9-15,-8 6 0,1-2 0,-4-4-120,-3-9 0,-5-4 0,-4-1-51,-4 5 0,-3 0 1,-4 0-70,-3 2 0,-3 1 0,-7 5 152,-21-3 1,-7 17-33,-5 28 0,0 13 45,1-5 0,4 9-203,17 2 1,1 8 0,5 1 0,4-3 112,7 6 0,7 1 178,0 1 0,2 3 0,8-8-133,12-11 0,6-5 70,9 7 1,2-11 109,-8-23 0,0-12 89,0-6 1,2-7 0,-5-1-270,-5-1 0,-4-4-106,-4 1 0,-1-6 0,-2-1 1,-6 5 15,-9-8 0,-7 4 30,1 6 0,-4 0 0,-5 7-141,-24 1 0,-8 16 201,13 16 0,-1 8 0,0 5-30,-3 4 0,1 6 0,5 6-15,10-1 0,3 4 0,4 3 0,5-3-13,6 2 1,6-1 0,5-1 57,5 0 0,5-1 0,6-6-30,11-6 0,7-7 0,0-7 30,-1-9 0,1-7 0,-1-2 30,-1 1 0,-1-2 0,-3-7 0,0-17 0,-4-10 0,-7 2 60,-4 0 0,-9-1 30,-9 0 0,-6-3 0,-5 7 14,-10 10 1,-7 7-45,-6 7 0,-6 4 0,2 8-180,-4 15 0,2 10 72,6-3 1,1 5 0,4 2-193,9 1 0,5 3 0,7 0-15,10 15 0,11-3 491,1-13 0,9-6-236,8-9 0,8-7 0,-2-5 105,1-8 0,-1-8-45,7-6 0,-5-7 89,-17 1 1,-7-5 83,-7-4 1,-10 0-174,-8 8 0,-9 5-1,-18 6 1,-6 10-225,0 14 1,0 10 170,13-4 1,-1 4-1,6 3-351,-3 21 0,14 1 315,20-14 0,9-4 45,7-1 0,5-6 135,9-6 0,2-11 0,4-17 0,-5-9-135,-14 9 0,-5-3 0,-1-15 0,-11-3-45,-22 7 0,-9 5 180,-1 7 0,-3 5-91,-8 4 1,0 8-180,10 10 1,5 7-91,6 4 0,8 4-45,11 5 0,10 0 135,7-4 0,5-5 180,5 1 0,4-8 135,3-17 0,-1-10-90,-12-4 0,-3-5-90,-1-8 0,-10-3 0,-24-3 0,-11 3-1,8 15 1,-5 5 45,-19 3 0,-1 12-45,14 17 0,5 7-315,3 1 1,8 3 44,15 9 0,11-1 225,3-13 0,7-3 45,8 0 0,4-9 359,5-24 1,-4-9-360,-14 4 0,-3-4 90,4-20 0,-9-4-90,-14 16 0,-7 1-135,-9-5 0,-6 3 90,0 11 0,-4 7 90,-11 6 0,-1 10-405,6 13 0,5 9 0,4 4 1,6 3 179,5-2 0,11-2-180,16-5 0,8-6 585,2-8 0,2-5 0,4-6 0,-1-8 179,-1-10 1,-7-7-180,-12-1 0,-7-5-90,1-11 0,-11-2-510,-15 13 0,-10 1 0,2 3 240,3-2 0,-4 7 30,-6 10 0,-7 6 0,7 8-120,10 13 1,4 10-1,5 2 0,1 6 0,7 1 120,7-1 0,6 1 0,5-1 30,7-1 0,5-1 0,4-2-30,0-2 0,4-2 0,2-9 330,18-15 0,0-8-180,-19 11 0,-3-8 149,-4-17 1,-3-11 0,-7-1 300,-12-8 0,-7-2-570,6 9 0,0-2 0,-4 2 60,-7-1 0,-4 2 0,-9 7-150,-18 8 0,-11 11 0,5 4 30,9 5 0,0 6-164,2 1 0,-5 2 1,3 3-1,9 5-106,7 18 1,12 7 224,3 5 0,10 0 225,15-6 0,9-4 45,6-5 0,7-7-105,2-15 0,5-6 0,-3-7 150,-2-8 0,-3-7-121,-1 4 1,2-2 0,-11-7 270,-15-14 0,-10-8 0,-2 3-330,4 2 0,-8 2-90,-12-4 0,-11-2 0,-2 8-45,-9 6 0,-6 9-15,0 7 0,-6 4 0,4 8-56,11 7 1,2 6-1,3 3 116,-3 4 0,2 5 1,9 4 59,10 4 0,7 4 0,6-1 60,6-2 0,5-1 0,3-2-75,7 8 0,8-6 75,0-10 0,6-4 0,0-10 89,-1-13 1,1-8 0,-2-1-120,10 3 0,-3-7 180,-10-13 0,-3-9 0,-10 0-30,-16 6 0,-8-1 0,-2 1-90,0-2 0,-4 0 0,-4 3 36,-5 1 1,-5 2 0,-5 11-247,-9 13 0,-6 12 0,3 4-30,10 2 0,2 4 0,2 4-87,-4 11 1,2 5-1,9 0 312,12 9 0,12-2 0,9-2 0,9-5 395,18-11 0,5-7-305,-4-7 0,0-7-45,7-8 0,-2-11 45,-8-16 0,-7-9-90,-10-5 0,-7-4-77,-9 12 0,-4-1 0,-4 2-193,-10-9 1,-11 8-76,-4 20 0,-7 7 0,0 6 30,4 9 0,0 7 1,1 4 209,-6 6 0,1 5 0,6 3 30,8-2 0,4 2 0,8 1 179,11 3 1,9 1 0,1-5 30,3-4 0,5-5-90,11-2 0,8-2 0,-2-7 0,1-10 0,0-8-45,8-2 0,-4-9 135,-7-17 0,-8-9-120,-14 13 0,-3-3 0,-4-1-34,-3-1 0,-3 0 1,-5 1-237,-8 0 0,-4 2 0,-5 5-60,-16-2 1,-6 12 89,13 17 0,-3 6 0,3 7 30,-2 13 0,2 10 0,6 3-184,6 1 0,5 2 0,4 3 394,3 5 0,4 1 0,10-2 120,11-9 0,7-4 0,2-4-45,6 2 0,6-9 73,2-11 0,5-6 0,-3-11-88,-7-16 0,-3-12 0,-2 0-30,0 3 0,-1 0 0,-3-3 29,0-9 1,-4-2 0,-7-3 30,-8-2 0,-6-1 0,-7 3 0,-6 13 0,-4 2 0,-3 3-210,-5-1 0,-4 3 0,-3 10-390,-12 18 0,-5 13 0,3 6 420,3 4 0,2 7 0,6 5 30,8-2 0,2 6 0,7-1 0,14-9 0,22-7 0,14-7 0,7-7 0,0 1 0,1-1 0</inkml:trace>
-  <inkml:trace contextRef="#ctx0" brushRef="#br0" timeOffset="802416">20256 11218 6993,'-25'10'3276,"6"-2"-1875,7-8-321,1 0-361,10 0 1,12 0-450,20-8-945,1 7 1,3 0-451,0-3 1,1 0-181,-1 8 1,-1 0 1304,8-2 0,-52 22 0,-18-5 0</inkml:trace>
-  <inkml:trace contextRef="#ctx0" brushRef="#br0" timeOffset="802671">20231 11412 7533,'-31'-7'3276,"12"5"0,19-6-1013,24 8-2758,5 3 0,3 2-584,16-3 1079,-1 7 0,-1-3 0,-3-20 0,-11 9 0,0-1 0</inkml:trace>
-  <inkml:trace contextRef="#ctx0" brushRef="#br0" timeOffset="806305">20342 11271 7892,'-19'8'180,"-5"14"0,-2 5-90,4-3 0,1 3-120,2 1 0,-1 2 0,3-2 30,-3 2 0,10-5 450,21-5-180,11-32-150,4-12 0,5-10 0,-2 0 29,-8 5 1,-3 0 0,2-1-221,2-2 0,2-2 0,-1 0 0,-3 4 71,2-3 0,-12 8-450,-26 9 270,-8 41 0,-5 20 112,5-14 1,-2 3 0,0 1 0,3-1 67,-1 5 0,4-1 0,3 0 0,2-1 0,4-1 0,8-7-90,25 5 120,4-42 0,8-15 0,-1-1 59,-5 2 1,-2-1 0,1-3-78,0-2 1,1-4 0,-2 0 0,-2 1 137,-1-1 0,-3 1 0,-7 3 828,-18-17-844,-16 55 1,-9 14-15,-6 4 0,-3 7 0,3 2-345,4 2 1,4 3 0,0-2 164,-2-2 0,1-1 1,12-6-211,21 4 270,13-49 0,6-15-45,6-2 0,0-6-131,-5-1 0,-1-4 0,-4 2 221,0-4 0,-11 4 224,-15 12 1,-7 9-540,-25 23 180,4 22 0,3 10-90,12-7 1,8-1-1460,14 0 1,7-5 1459,9-13 0,17-18 0,4-10 0,-6-5 0,0-1 1</inkml:trace>
-  <inkml:trace contextRef="#ctx0" brushRef="#br0" timeOffset="833420">24981 5944 5824,'14'0'0,"-3"0"90,-11 0-90,0-8-90,0 7 90,0-7 0,0 0 0,0 6 180,5-6 179,-3 8 181,3 0-90,-5 0 269,0-8 1,0 6-270,6-6-180,-5 1 359,5 5-449,-6-6-180,0 8 270,0 0 90,-6 0 179,5 8-269,-5 17 0,6-1 0,0 5-240,0 9 0,0 6 0,0 1-250,0-5 1,0 1-1,0 1 1,0 0 398,0 2 1,0 0 0,0 0 0,0-2 60,0 5 0,0-2 0,0-5-150,0-3 0,0-8 0,0-11-90,0-26-270,0-4 180,0-5-90,0 9 609,0 8-2228,0 0 899,0-8 1,-5 6 899,3-14 0,2-25 0,4 13 0,-1-1 0</inkml:trace>
-  <inkml:trace contextRef="#ctx0" brushRef="#br0" timeOffset="834654">25031 5927 6543,'7'-10'450,"-2"2"-180,-5 8-90,-5 0 90,-2 0 89,0 0 361,-4 0-90,9 0-1,-3 0 91,5-8-270,0-2-360,5 1-1,8-7 451,33 14-495,-12 1 0,2 2-45,2 5 0,2 6-60,-8 0 0,1 2 0,-4 3 240,-2 4 0,-6 5 90,0 11 0,-12 2-180,-19-6 0,-10-1-1,2-3 1,-4 1 0,-2-3 0,0-4 0,-2-2 0,-1 0 60,-4 1 0,-2-1 0,3-3-105,2-3 0,1-3-360,-1-5 0,3-6-2023,7-11 539,12 0 1799,18 2 0,7 24 0,12 4 0</inkml:trace>
-  <inkml:trace contextRef="#ctx0" brushRef="#br0" timeOffset="838145">25720 5874 7892,'0'-10'180,"0"2"0,0 8-180,-5-8 0,3 6-90,-9-6 270,4 8 90,-11 8 0,-1 2 0,-5 23-90,-1-3-1,12 1 1,2 4-45,0-4 0,2 3-75,3 8 0,3 5 0,0-1-323,2-2 1,1-1 0,1 2 307,1-8 0,0 1 0,2 0 0,0 0 255,4 10 0,3-1 0,0-5-153,5-2 0,1-4-192,1 0 0,1-5 855,11-6-990,-10-15-180,-8-2-989,-7-8 870,-5 0-421,0 0 918,0-8 0,0-10 0,0-9 0</inkml:trace>
-  <inkml:trace contextRef="#ctx0" brushRef="#br0" timeOffset="844132">25547 6033 7533,'-22'-14'359,"0"0"1,-8-4 90,13-5-540,10 19-180,-11-12-45,-5 34 1,-5 11 89,-1-9 0,-3 3-92,3 6 1,-4 6 0,-1 1 0,1-2 428,3-8 1,0-2-1,0 0 1,2 0 216,-5 9 1,2 0 0,3-9 480,-10-8-765,59-37 0,18-13-90,-15 10 0,2-2 0,2-2 0,1 0-191,2 0 0,2-1 1,1 0-1,1 0 0,-3 3 213,3 0 1,-2 1 0,0 2-1,-1-1-37,7-11 0,0 1 1,-9 13-121,-7 19 135,-42 19 0,-15 9 284,7-6 1,-1 2 0,-2 2-215,-2 2 1,-2 3 0,-1 0 0,2-1-56,-7 4 0,2-2 1,1 0-1,3-2 0,1-1 0,7-1-195,4-1 0,13-7 135,56-26 67,-18-5 1,5-6-1,2-3 1,1-1-153,-3 2 0,2-3 1,1 0-1,-1-1 1,0 0 174,0-1 0,1 0 0,-1 0 0,-1 0 0,-3 1-120,15-16 0,-4 1 0,-22 24-50,-25 30 289,-13 8 1,-12 7 0,-4 4-108,5-4 1,-4 5 0,-3 2 0,-2 2 0,1 1 0,0-2 0,3-3-62,-2 5 0,2-3 1,1 0-1,0 0 1,-2 2 63,-1-3 0,-3 3 0,0 0 0,2-1 0,5-3 0,9-5-240,0 12 0,16-13 315,31-20-90,2-16 0,6-8 0,4-3 108,-4 2 0,4-2 1,2-1-1,-1-1 0,-1 2-131,2-4 1,-2 1 0,1 0 0,0 0-23,6 0 0,1-2 0,-2 4 0,-5 8 133,4 6 0,-13 12 452,-29 41-271,-14-8 1,-9 7 0,0-4-240,4-10 0,0-2 0,-1 1 638,-4 6 0,0 3 0,7-8-1748,10 4 1530,33-36-405,13-15 0,6-6 45,-14 6 0,1-1 0,1 0-120,3 0 0,1 1 0,-3 1-105,8-5 0,-10 13 1311,-18 37-952,-26-11 1,-10 1-195,2 4 0,-3 3 0,-3-2 90,-7-1 0,-3-1 0,2-3 150,-1 2 0,2-7-360,2-10 0,9-12-90,26-16 0,15-13 0,3-2 0,-3 0 0,3-4 0,3-1 1,1 0-161,0 3 1,3 0 0,1-1-1,0 0 1,-2-2 279,-5 2 0,0-1 0,0-2 0,-2 1 0,-2 2 0,-2 5 120,5-7 0,-4 5 0,-10 2-323,-16-16 0,-18 16 281,-1 35 0,-9 14 0,-5 9 0,-1 2 0,2-3 36,-1-2 0,0 1 0,0 0 0,0 1 0,0 0 35,-3 2 1,0 1 0,0 0 0,2-2 0,4-3 330,-4 3 0,4-3 0,8-10-510,4-14 0,39-20 0,17-12-45,-3 3 0,5-4 0,3-1 0,-1 3 207,-5 7 0,-1 2 0,0 1 0,1-2-275,3-7 1,1-4 0,-1 4 0,-6 12 667,8 13-330,-44 27 0,-13 11-75,2-4 0,-5 2 0,-1 3 142,-3 6 0,-3 4 1,0 0-1,3-5-232,6-7 0,2-4 0,-1 2-180,-12 12 0,0 1 0,21-18-59,36-29 359,-3-7 0,2-7-1,7-12 1,1-2-45,-2 7 0,-4 1 855,-10-15-691,-31 51 1,-14 17 0,-3 4-84,8-2 0,-3 4 0,-1 3 0,1 1 0,-1-1-782,0 1 1,-1 0-1,0 0 1,2 1 0,1-1 440,0 0 0,-2 0 1,2 0-1,8-2 0,13-6-862,21 8 1,14-13 581,15-31 1,10-15 494,-13 10 0,7-3 0,2 0 0,-5 2 0,-10 5 0,14 4 0,-21 8 0,0 0 0</inkml:trace>
+  <inkml:trace contextRef="#ctx0" brushRef="#br0" timeOffset="-213388.73">10091 17445 6813,'-12'-10'900,"5"2"-631,2 8-89,5-8 450,0 6 539,0-5-269,0-1 269,0 14-179,10-4-406,5 24 1,1 12-465,-1-7 0,2 3 0,1 1-517,-1 1 0,2 3 1,0 1-1,0-2 149,-3-3 1,0 1 0,0-2 0,0-2-23,3 3 0,0-2 0,-2-5-449,7 13-91,-13-33-359,-11-8-720,0-15 1889,0 3 0,-5-6 0,-2 10 0</inkml:trace>
+  <inkml:trace contextRef="#ctx0" brushRef="#br0" timeOffset="-212629.73">10005 18009 6633,'-14'0'-90,"3"8"360,11-6 989,0 6-629,0-8-450,0 0 270,0 8-1,0-6 1,0 6 1529,0-8 270,28-40-1830,-6 14 1,6-5 0,0 0-365,0-2 1,0-2-1,5-3-40,-7 10 0,4-4 0,1-1 0,1 1 0,-3 1 0,-2 3-645,2-5 1,-2 3-1,0-1-330,9-7 1,1-1 0,-8 8-30,-5 6 989,-17 9 0,-2 6 0,-5-7 0</inkml:trace>
+  <inkml:trace contextRef="#ctx0" brushRef="#br0" timeOffset="-211110.73">1923 11007 7263,'-20'-8'1529,"4"6"-1259,16-14 0,0 14 449,0 2 271,0 10-1,0 23-449,16 12-765,-8-14 0,4 1 90,11 8 0,5-1-180,-6-10 1,3-2-901,9 1 1,0-5 1214,5 3 0,-5-16 0,-26-3 0</inkml:trace>
+  <inkml:trace contextRef="#ctx0" brushRef="#br0" timeOffset="-210662.73">2417 10936 9152,'-10'-10'1439,"2"10"-450,-8 26-854,0 11 0,-3 10-90,2-13 0,-2 3 0,-2 2 0,0 2-492,2-6 0,0 2 0,-1 1 0,0 1 0,0-1 0,2-2 303,-1 2 0,2-1 0,-1-1 0,1-1 1,0 0-82,-5 5 0,-1 1 0,1-3 0,6-6-214,5-4 0,5-5-1989,6-6 2428,2-9 0,21-24 0,-3-3 0</inkml:trace>
+  <inkml:trace contextRef="#ctx0" brushRef="#br0" timeOffset="-204177.73">9451 9790 7533,'-19'0'3276,"1"-8"-1155,12 6-5398,0-6 3174,6 8 0,22 8 0,5 2 1</inkml:trace>
+  <inkml:trace contextRef="#ctx0" brushRef="#br0" timeOffset="-203996.73">9353 10054 7533,'-20'-10'3276,"2"-5"-1335,12 13-1941,11-14 0,25 22 0,16-4 0</inkml:trace>
+  <inkml:trace contextRef="#ctx0" brushRef="#br0" timeOffset="-199812.73">10522 9402 7713,'-14'0'1529,"-3"-8"-720,16 6 451,-10-14-181,10 14-180,-4-6-449,5 8 360,5 8-451,2 10-269,5 2 0,4 3-450,3 7 1,1 3-271,4 3 1,2 0-361,2 0 1,-1-1-406,-2-8 1,-1-1 629,-4-3 1,-1-3 764,10-1 0,-16-19 0,-8-19 0</inkml:trace>
+  <inkml:trace contextRef="#ctx0" brushRef="#br0" timeOffset="-199409.73">10940 9454 7533,'-19'-37'3276,"6"4"-346,2 23-3110,3 28 0,-1 11-45,-9 10 1,-1 6 201,7-9 1,-1 4-1,1 2 1,-1-1-224,-2 1 0,-1 1 0,0 0 1,1 0 312,0 0 0,1 0 1,1 0-1,-1-4 113,-1 0 0,0-3 0,1-1-121,-2 12 0,2-12-508,2-23-361,7-14-1259,16-25-809,2-1 2878,6 3 0,15 7 0,-1 0 0</inkml:trace>
+  <inkml:trace contextRef="#ctx0" brushRef="#br0" timeOffset="-199079.73">10977 9878 8162,'-12'-35'3276,"5"15"-255,2-4-2302,5 22-89,27-5-720,12 7-270,-1-1 0,4 2-629,1 2 0,1 1 224,-5-3 0,-1 0-719,0 3 0,-5 0 1484,-5 4 0,-34 14 0,-11 5 0,-10 6 0,-1 1 0</inkml:trace>
+  <inkml:trace contextRef="#ctx0" brushRef="#br0" timeOffset="-198845.73">11038 10072 7533,'-38'-16'3276,"20"4"0,40-13-1638,2 15 0,4 2-1560,11 2 0,3 2-1171,-8 1 1,1 0 0,-2 2 623,10-1 1,-1 4 0,2 4 0,-3 3 0,-11 1 0,0 0 0</inkml:trace>
+  <inkml:trace contextRef="#ctx0" brushRef="#br0" timeOffset="-195813.73">12122 10019 6813,'0'19'1259,"0"5"-809,-6-14-180,5 7 629,-5 1 181,6 0 89,0-8 360,0-3-449,0-7-181,0-7 1,0-11-361,-5-25-269,-1-1 0,-1-6-210,3 9 0,-1-1 0,0-3 153,1 6 1,-1-1 0,1-1-1,0 1 147,1-9 0,1 0 0,0 4-270,1 7 0,1 3 0,1 2-45,3-4 0,5 5-225,6 5 0,5 3-90,1 5 0,3 1-495,6-5 1,2 3 134,-4 9 1,0 2-271,-1-1 1,0 5-181,-1 10 1,-2 5-1305,14 18 945,-21-7 0,-4 3 1439,-1 21 0,-20-12 0,-6 0 0,-3 0 0,0-1 0</inkml:trace>
+  <inkml:trace contextRef="#ctx0" brushRef="#br0" timeOffset="-195546.73">12072 9825 7533,'-41'16'3276,"13"3"-346,-3 1-2210,42-5-181,22-22-539,-1 1 0,3 2-1639,10-1 1,2 0-1,-1 0 1,-2 2 1471,-6 2 0,-1 2 0,-1 2 0,-4 2 1,13 5-1</inkml:trace>
+  <inkml:trace contextRef="#ctx0" brushRef="#br0" timeOffset="-195169.73">12872 9366 7533,'-11'-35'2878,"3"15"-719,-31 13-1979,10 32-90,2 2 0,0 7-60,11-6 0,2 2 0,0 2-46,1 2 0,0 2 1,1 2 104,3-2 1,1 4 0,1-1 0,1-1-390,2 1 0,1-2 1,3 2-241,2 10 0,4 1 1,4-4-511,4-13 1,3-3 0,1-3 1049,8 13 0,2-9 0,-1-17 0,0-8 0,9-10 0</inkml:trace>
+  <inkml:trace contextRef="#ctx0" brushRef="#br0" timeOffset="-194779.73">13020 9613 7533,'-14'-2'3276,"14"28"-1638,10-5 0,5 5-1514,1 5 1,2 5 0,2-1-665,1-6 0,1-1 1,0 1-429,3 8 1,0 2 0,-1-3 67,2-3 1,-2-2 931,-1 4 0,-10-3 0,-23-3 0,-12 5 0</inkml:trace>
+  <inkml:trace contextRef="#ctx0" brushRef="#br0" timeOffset="-194477.73">12995 10178 7533,'-37'-18'3276,"12"0"0,18 1-474,31-17-2592,-1 13 0,7-2 0,0-1-390,2-1 0,1 0 0,1-2-241,3-4 1,1-2-1,-1 1-672,-4 5 1,0 1 0,-3 1-547,3-8 1,-3 3 1455,-6 11 1,-4 1 0,-8-13 0,-20 21-1</inkml:trace>
+  <inkml:trace contextRef="#ctx0" brushRef="#br0" timeOffset="-194128.73">13598 9243 9332,'-6'-28'3276,"6"11"-1676,16 30 0,7 13-1465,1 4 0,0 7-90,-5-7 0,0 5 0,0 2 0,-2 0-502,-2 1 0,-1 2 1,-2 1-1,-2 0 97,-3 3 0,-3 2 1,-2-1-1,-2-1 337,-3-5 1,-2 0-1,-3-1 1,-2-1 124,-2-1 0,-3 0 1,-2-2-1,-2-3-312,-6-1 0,-3-3 0,1-2-330,-7 7 1,3-3 539,7-12 0,6-1 0,12 10 0,20 1 0</inkml:trace>
+  <inkml:trace contextRef="#ctx0" brushRef="#br0" timeOffset="-192662.73">14386 9772 7533,'-19'0'1349,"1"0"-90,0 8-359,4-6-451,2 6 721,28-1-631,23 3-584,4-5 1,4 0-496,-4 3 0,1 0-390,-7-7 1,3-2 0,-4 3-421,-2 6 1,-2-1 1349,0-7 0,-11 2 0,-25 6 0,-18-8 0</inkml:trace>
+  <inkml:trace contextRef="#ctx0" brushRef="#br0" timeOffset="-192329.73">14386 10054 7533,'-37'0'3276,"11"0"-166,3 0-1041,32 0-630,29-8-1304,-9 7 0,5 0-585,2-3 0,4-3 1,-2 3-1190,12 2 1,-2 2 1389,3-4 1,-3 0-1,-19 4 1,-3 0 0,3 0-1</inkml:trace>
+  <inkml:trace contextRef="#ctx0" brushRef="#br0" timeOffset="-184861.73">16072 9701 9691,'7'-9'2429,"-2"1"-1529,-5 0-271,0 6-89,0-14-630,0 14-180,0-6 180,0 8 0,0-7 90,0 5-180,-5-14 180,-2 14-270,-6-6-179,-10 8 359,-8 0 0,-13 8 135,20-1 0,-1 4 0,-3 9 0,1 3 45,1-5 0,1 3 224,0 12 1,1 1-90,7-11 0,3 1-45,3 6 0,4 0 0,2 15 90,16-1-136,2-21 1,4-3 45,23 1 135,-6-13 0,2-8-135,-8-10 0,-2-7-90,10-14 0,-1-7-135,-8-2 0,-3-2 90,-4 1 0,-2-1 0,-3-2 0,-7 4 45,-19 9 359,-4-1-674,-5 42 1,-1 12 224,6 7 0,3 5-45,-2-5 0,3 2 134,2 19 1,7-2-90,9-23 0,3-1 0,-2 11 0,4-1-765,8-10 1,3-3-2513,15 6 0,-2-11 3139,-11-16 0,-13-16 0,-6-3 0</inkml:trace>
+  <inkml:trace contextRef="#ctx0" brushRef="#br0" timeOffset="-184529.73">16305 9948 10051,'0'-19'3148,"0"3"-809,0 16-2429,6 47-2518,1-4 2608,-1-4 0,0 1 0,1 5 0,-1-12 0</inkml:trace>
+  <inkml:trace contextRef="#ctx0" brushRef="#br0" timeOffset="-182842.73">16638 9419 6993,'-12'0'2339,"5"0"359,1-8-899,39 46-1349,-11-12 0,3 4-450,-5-2 0,1 3 0,2 2 0,-1-1-105,0 0 0,0-1 0,0 1 0,-1 0-195,6 10 0,-2 1 1,-2-4-601,4 3 1,-4-4-245,-6-7 0,-5-3 1144,-11-1 0,-8-9 0,-12-10 0</inkml:trace>
+  <inkml:trace contextRef="#ctx0" brushRef="#br0" timeOffset="-182544.73">16674 10160 8252,'-11'-10'720,"4"-13"809,9-1 0,7-3-630,7-5 1,7-4 0,2-2-987,-5 7 1,2-3 0,1 0-1,1-1 1,0 0 284,3-1 0,1-1 0,1 0 0,0 1 0,-1 0-234,0 3 0,0 0 0,0 0 0,-1 2 0,-2 0-254,6-9 1,-3 3 0,-1 3-1350,1 0 1,-3 7 1422,0-1 1,-7 13 0,-6 15 0</inkml:trace>
+  <inkml:trace contextRef="#ctx0" brushRef="#br0" timeOffset="-181896.73">17844 9613 7533,'0'-19'2069,"0"-5"-900,0 14 0,0 32-899,0 25-180,0-15 0,0 4 0,0 2-794,2 1 0,-1 0 0,1 0-16,0-2 0,0-1 1,1-1 719,4 11 0,-2-6 0,-4-2 0,-2-15 0</inkml:trace>
+  <inkml:trace contextRef="#ctx0" brushRef="#br0" timeOffset="-181662.73">17672 9931 7533,'-24'-26'3276,"15"7"0,14-15-1283,23 23-2053,4 2 0,9 1 0,1 1-1033,-6 3 1,-1 1 0,3 0 1021,10 0 0,3 0 0,-3-1 1,-9 0-1,-3-2 0,-1 1 1,8 0-1,-1 0 0</inkml:trace>
+  <inkml:trace contextRef="#ctx0" brushRef="#br0" timeOffset="-179228.73">19062 9701 9062,'-7'-17'3276,"1"-1"-2684,1 8-412,-1 2-360,-12 8 180,-18 0-90,-3 0 135,4 7 0,-2 2-90,8-4 0,0 2 45,-13 11 0,0 5 269,9-2 1,2 3 315,-7 5 0,3 5-226,13 4 1,5 2-135,-2-4 0,9 1-90,18 7 0,11-2-270,7-11 0,6-5-225,10 0 0,5-9 270,2-15 1,0-12 178,-9-7 1,-1-6 0,-4-5-47,-5-6 0,-4-4 0,-1 0 256,1-2 1,-1 0 0,-4 0-180,-7 7 0,-4 0 0,-5 3 1049,-8-4 0,-5 9-809,-7 21-135,-3 18 0,0 8-765,6 5 1,4 5-136,-3 14 0,4 2-404,7-7 0,5-2-226,9-2 1,2-2 89,-1-2 1,5-5 1297,8-9 1,3-10 0,8-25 0,-15-4-1,0 1 1</inkml:trace>
+  <inkml:trace contextRef="#ctx0" brushRef="#br0" timeOffset="-178863.73">19370 9984 10591,'-7'0'3276,"-4"-8"-1875,4-2-861,-11 16 359,-1 6-854,6 14 0,2 6-135,2-8 1,4 1-181,9 15 0,8-3-180,23-6 900,-6-22 0,3-10-46,-2-20 1,-4-11-225,-7-3 0,-5-4-90,-4-10 0,-9 2-1619,-13 12 0,-6 5 1529,-11-5 0,3 45 0,0 13 0,7 10 0,0 1 0</inkml:trace>
+  <inkml:trace contextRef="#ctx0" brushRef="#br0" timeOffset="-162226.73">22274 9984 6633,'-14'0'1529,"-2"0"-1349,15 0 90,-5 0 180,6 0 269,6 0-449,-5 0 180,4 0-90,-5-8-90,0 6 449,0-6 1,0 16-1,0 9-269,-2 10 0,-1 5-315,2 0 0,1 3-285,-4 5 0,0 5 0,0-3 150,1 2 0,0 0 120,0 4 0,1 5 0,0-5-437,-4 1 0,1-2 437,3-5 0,1 2 0,-3 0 149,-4 4 1,-2 0 0,0 1-240,2-3 0,1 0 0,0 1 37,0-8 1,1 0 0,0 1-1,0 1-22,1 6 0,0 2 0,1 0 0,1 0-68,2-3 1,1-1-1,0 1 1,0 1-329,-1-5 1,0 1 0,0 0 0,-1 0 0,2 0 260,-1 5 0,1 0 0,0-1 0,1 2-18,-1-7 0,0 1 0,0 1 0,0-1 0,0-2 130,0 4 1,0-2 0,0 1-1,0 3 23,-1-6 0,0 3 0,0 2 0,0 0 0,0-2 0,0-3-90,1 4 0,-1-3 0,1-1 0,0 4-9,-1 1 0,0 4 0,-1 0 0,1 0 0,0-3-191,1 0 1,0-3-1,0 1 1,0 1 280,0-2 0,1 1 0,-1 1 0,0 0 0,-1 0-1,0 0 1,-1-1 0,0 1 0,-1 0 0,1 1 9,-1-3 0,0 1 0,0 1 0,0 0 0,0-1 0,-2-1-153,0 3 1,-1-1-1,0-1 1,-1 1-1,0 1 183,1-2 0,0 1 0,0 0 0,-1 1 0,1-2 0,0-1-57,0 0 0,-1-1 0,1 0 0,0-1 0,0 1-36,-1 4 0,1 0 0,0 1 0,0 0 0,1 0-18,-1 1 0,1 0 0,0 1 0,1-1 0,-1-1 0,1-7 0,0-1 0,1-1 0,-1 1 0,0 1-54,-1 8 0,0 1 0,0 1 0,1-2 0,0-3 22,0-4 1,1-2 0,-1-2 0,1 3-77,-2 1 0,0 2 0,0 0 0,1-1 0,0-4 177,1 2 0,0-4 0,1 0-243,-2 9 0,0 0 1,1-4-511,3-4 1,0-4 213,0-1 1,0-3-1115,0 13 1883,0-17 1,5-17-1,1-1 1</inkml:trace>
+  <inkml:trace contextRef="#ctx0" brushRef="#br0" timeOffset="-160994.73">21770 16404 7263,'-19'0'899,"-5"0"-449,10 0 270,2 0 269,12 0 630,12 0-899,13 0-136,5 1 1,4-2-540,6-2 0,4-2-428,-1 2 0,5 1 0,0-2 158,-6-2 0,1 0 0,0-1 0,2 0-115,-7 2 0,2-1 0,0 1 0,1 0 1,-1-1 428,2-1 1,1 0 0,-1-1 0,0 1 0,0 0 90,6 0 0,-1 0 0,1 0 0,0 1 17,-4 1 1,1 2 0,0-1 0,-1 1 0,-1 0-86,0 1 1,-2-1-1,1 2 1,2-1-113,-4 2 0,3 0 0,0 0 0,2 0 0,-1 0 0,0 0 60,-3 0 0,1 0 0,-1 0 0,1 0 0,-1 0 0,2 0-383,2 0 1,2 0 0,-1 0 0,1 0-1,-1 0 1,0 0 307,-1 0 0,-1 0 0,0 0 0,0 0 0,0 0 0,-1 0 15,0 0 0,-1 0 0,0-1 0,0 1 0,0 0 0,-1 1-197,5 2 0,-2 0 1,1 0-1,0 1 1,1-1 210,-4-1 1,0 0 0,1 0 0,1 0 0,-1 0 0,0 0-45,-1 0 0,1 1 0,-1 0 0,1 0 0,-1 1 1,-1-2 29,5 2 0,-1-1 0,-1 0 0,1 0 0,0 0 35,4-1 1,0 0 0,0 0 0,0 0 0,0 0-15,0 1 1,0 1-1,0-1 1,0 1-1,1 0 39,-5-1 0,2 0 0,0 0 0,0 0 0,-2 0 0,-1-1-78,-2 0 0,-3 0 0,0 0 0,1 0 0,2 0 33,5 1 0,4 1 0,1 1 0,-1-1 0,-2 0 0,-6 0 15,8-1 0,-6 1 0,6 0-5,-13 0 1,4 1 0,3 0 0,1 1 0,0-1-1,-1 0 1,-3-1-26,8-1 0,-3-1 0,0 0 0,0 0 0,3 0-26,-8 1 0,2-1 1,1 1-1,0-1 0,0 1 1,-2-1-1,-1-1-38,4 0 1,-2-1-1,-1 0 1,0-1-1,2 1 34,-1 0 0,1 0 0,1 0 0,-1 0 0,-1 0 0,-2 0 120,5 0 0,-3 0 0,-1 0 0,3 0 36,-1 0 0,2 0 0,0 0 0,1 0 0,-2 0-18,-2 0 0,-1-1 0,1 1 0,-2 0 0,1 1-73,-2 1 1,0 2 0,0 0 0,-1-1 0,0 0 233,10-2 1,-1 0 0,0-1 0,-1 2-338,-2 1 1,-1 2-1,-1-1 1,0-1 201,-3-2 1,0-1-1,-1 0 1,-1-1-105,12 1 0,-2 0 0,-2 0 196,-11 0 1,-3 0 0,-1 0-227,7 0 0,-5 0 736,-4 0-2176,-19 8 1677,-11 2 1,-17 0 0,-3-2 0</inkml:trace>
+  <inkml:trace contextRef="#ctx0" brushRef="#br0" timeOffset="-154509.73">30642 16334 7353,'-6'-10'1529,"-5"-6"-1079,10 14-1,-5-6 181,6 0-270,6-1-180,-5-1 0,5 2 0,-6 0-91,0 6-178,0-6-91,0 8 180,-11 0 0,-3 8-180,-22 10 180,-2 1-90,14-7 0,-2 2 180,-4 6 0,1 1 134,2-6 1,1 1 0,0 11 0,3 5 180,3 7 0,4-1-585,3 7 270,12-7 0,7-4-90,15-14 90,6-5 0,4-5 0,-2-14 0,2-5-1,11-3 1,0-6-135,-8-14 1,-3-6 14,-6 7 0,0-2 0,-4 1 75,-5-11 0,-4 1-1,7 4 1,-11 6 675,-35 6-450,-1 52-180,3-1 0,0 5-180,5 0 0,3 4-270,3 12 0,9 1-854,15-9 0,8-2 584,-2-2 0,4-3-359,10-7 0,2-7 989,16-9 0,-6-16 0,2-2 0</inkml:trace>
+  <inkml:trace contextRef="#ctx0" brushRef="#br0" timeOffset="-153879.73">31000 16598 7353,'-20'0'1889,"2"-8"-990,6 6-359,0-5 359,-1-1-449,1 6 0,-6-6-180,0 24-360,-7 11 135,13-3 0,4 5-225,2 10 0,5 0 45,4-7 0,7-5 180,22-1 0,6-9 135,4-11 45,2-17 0,-3-11 179,-24-11 1,-7-3-90,3 10 0,-7-1-270,-16-14 0,-14 8-630,-7 27 0,-3 8 585,-3-3 0,7 6 0,10 14 0,50-3 0</inkml:trace>
+  <inkml:trace contextRef="#ctx0" brushRef="#br0" timeOffset="-151610.73">21795 9490 7533,'-20'-10'539,"8"-6"-89,1 14 90,10-6-450,-11 8 270,11-7-91,-4 5 181,5-14 90,0 6 89,-6-7-539,5-1 360,-10 0-360,4 8-90,-6-5 270,-4 13-180,-2-6-90,-6 8 0,-5 16-180,-1 3 135,15 1 0,0 3 0,-2 3 0,1 1 45,6 0 0,1 1 180,-2 6 0,1 1 45,5 0 0,5 0-90,5-2 0,3-1-135,1 4 0,5-3 0,6-12 0,4-5 0,4-7 0,1-8 89,-2-11 1,-1-8 0,7-14 0,-3-6 45,-5-2 0,-5-3 75,-6 7 0,-3-2 0,-1 1 149,2-7 1,-4 3 135,-5 4 0,-4 4-135,-10-1-540,-8 34-270,1 26-90,1 19 270,13-11 1,3 3-496,6 7 0,3 0 270,1-6 1,5-2-1145,9-3 1,4-5 893,-7-9 0,2-5 745,15-4 0,-12-26 0,-12-13 0</inkml:trace>
+  <inkml:trace contextRef="#ctx0" brushRef="#br0" timeOffset="-151322.73">22151 9648 7533,'-12'-19'3276,"5"3"0,-4 16-3082,10 32-3471,-5 15 3238,6 2 1,4-6-1,3 2 1,0-12-1,0 0 1</inkml:trace>
+  <inkml:trace contextRef="#ctx0" brushRef="#br0" timeOffset="-92375.73">13230 10918 6813,'-13'-19'1169,"6"3"-359,2 8-90,5 6 269,-6-13-359,5 13-810,-5-6 180,6 24 629,0 19-539,0-3 0,0 6 150,0 1 0,0 2 0,0 1-550,0-1 0,0-1 1,0 0 369,0 0 0,0-1 0,0-2-15,0 5 0,0-7-855,0-8-89,0-11 179,0-16-2518,6-24 3238,-5 3 0,4-14 0,1-5 0,-2 3 0,-1 0 0</inkml:trace>
+  <inkml:trace contextRef="#ctx0" brushRef="#br0" timeOffset="-91927.73">13205 10901 7533,'-25'-26'2788,"6"15"-2428,6-5 90,13 39 179,13 15-449,-5-9 0,3 4-90,1 2 0,2 3 0,1-1 90,4 8 0,2-2-90,-3-9 0,3 0 0,-1-6 134,2-2 1,2-9 135,3-7 0,-1-12 224,-5-18 1,-3-9-495,1 2 0,-2-4-120,-6-6 0,-3-4 0,-2-1-540,-1 2 1,-1 1-1,-1 0 150,-2 4 0,-2 1 1,1 1-436,0-5 1,-1 8-1845,-5 14 2699,1 18 0,3 45 0,-3 2 0</inkml:trace>
+  <inkml:trace contextRef="#ctx0" brushRef="#br0" timeOffset="-91479.73">13709 11183 7533,'-18'-18'3058,"4"-7"-2698,2 5-450,1-5 270,5 23-450,-12 20 720,-1 27-136,8-8 1,3 4-135,1 0 0,7 0-270,8-2 0,7-5 90,5-7 0,5-11 405,6-22 0,1-12-495,-7-3 0,-5-7-135,-4-14 0,-9-4 0,-14 4 0,-9 4-1414,-5 12 1,-3 5 1466,-17-3 0,19 36 0,4 10 0,6 25 0</inkml:trace>
+  <inkml:trace contextRef="#ctx0" brushRef="#br0" timeOffset="-90359.73">14399 10918 7533,'-6'-17'629,"5"-16"541,-10 3 89,9-5-899,-3 25 0,5 43-316,0 1 1,0 5-15,-1 0 0,1 3 0,1 0-196,0 1 1,1 0 0,0-1 374,0-2 1,1-1 0,-1-3-120,1 8 0,1-9 810,2-16-1170,-29-30-180,8-17 0,-2-5 360,-7 3 0,-3 3 90,3 3 0,-1 3 720,-17-3 179,10 40-291,20 7 1,5 5-384,4 8 0,6 3-225,7 2 0,4 0-360,1-9 0,3-3-1034,10-6 0,3-5 269,-6-10 1,2-4 1124,4-1 0,-1-6 0,-4-12 0,-2-6 0,-3-6 0,0-1 0</inkml:trace>
+  <inkml:trace contextRef="#ctx0" brushRef="#br0" timeOffset="-89930.73">14607 11254 7533,'-5'-26'3276,"-2"7"-526,-6-7-2120,-4 16-540,-13 26-1349,-3 21 539,13 0 0,3 5 540,2-1 1,6 0 224,5-8 0,6-1 134,2-4 1,6-7 450,27-27-270,-15-5 0,-1-6-181,8-12 1,-3-4-45,-5-4 0,-2 1 225,-1 6 0,-6 5 90,-12 7-990,-3 38-360,-2 9 1,-1 3 539,6 1-1279,14 5 1,5-5 1449,6-25 1,3-5 0,3-6-1,-9-17 1,0 0 0</inkml:trace>
+  <inkml:trace contextRef="#ctx0" brushRef="#br0" timeOffset="-89646.73">14853 10883 7533,'-19'-8'3276,"7"22"-2954,7 21-277,9 6 0,3 7-225,-5-13 0,1 1 0,0 2-314,0 0 0,2 1 0,-1 1 0,1-2-256,1 4 1,1-2 0,-2 0 419,-2-3 0,-1-1 0,1-4 330,5 1 0,-5-15 0,-14-41 0,4-2 0,1 1 0</inkml:trace>
+  <inkml:trace contextRef="#ctx0" brushRef="#br0" timeOffset="-89472.73">14780 11201 7533,'-8'-36'3276,"25"9"0,17 9-3629,14 9 0,3 3 353,-25 1 0,3 0 0,15-1 0,8 0 0,-2 0 0,-13 0 0,0 0 0,1 1 0</inkml:trace>
+  <inkml:trace contextRef="#ctx0" brushRef="#br0" timeOffset="-88209.73">15309 11324 7533,'-7'-8'2788,"2"6"-2428,5-13-180,0 13 180,0-14-990,0 6 360,-6-7 0,-1 7 360,-16 2 270,-14 8-225,12 13 0,-1 5 90,0-4 0,2 4-91,3 14 1,5 4-225,4 11 360,30-4-270,4-30 0,5-8 45,-1-6 0,1-6 45,13-15 0,-3-7 135,-18 4 0,-3-1 45,7-6 0,-11 11 449,-29 29-1258,1 39-946,3-8 1,6 3 1484,13 2 0,11-8 0,16-27 0,8-10 0,-5-5 0,0 0 0,0 0 0</inkml:trace>
+  <inkml:trace contextRef="#ctx0" brushRef="#br0" timeOffset="-87679.73">15740 11183 7533,'-19'-18'3276,"12"1"-796,30-1-2120,0 12 0,5 2-1620,11 0 1,2 1-135,-3 1 0,1 4 1394,3 4 0,-6 3 0,-13 3 0,-10 13 0</inkml:trace>
+  <inkml:trace contextRef="#ctx0" brushRef="#br0" timeOffset="-87445.73">15789 11324 7533,'-25'0'3276,"1"0"-975,10 0-952,36 0-1304,4-3 0,5-2-1305,15 0 1,3 1 1047,-16 0 1,1 0 0,-2 2-1,10 4 1,-3 4 0,-6 3-1,-1 1 1</inkml:trace>
+  <inkml:trace contextRef="#ctx0" brushRef="#br0" timeOffset="-85077.73">16774 10795 6453,'-14'-18'2069,"3"9"-2069,11 1 720,0 0-360,0 6-91,-6-6-179,5 8 270,-10 8-180,4-6-90,-5 21 180,-6-3 0,4 23-180,3-14 0,-1 3-90,2 11 0,1 2 44,2-3 1,0 0 45,2-6 0,1 2 0,2-2-90,7 6 0,1-2 45,-1 2 0,4-3-45,6-11 0,6-3 45,2-5 0,3-7 0,2-13 0,1-6 0,-1 3 0,0-6 0,8-20 0,-2-8-45,-9 5 0,-2-3-30,-3 5 0,1-3 0,-2 0 30,2-11 0,-5 0 90,-5-1 0,-3 2 180,-4 10 0,-3 1 134,-5-4 1,-4 5-405,-6 10 0,-3-3-449,10 24 89,2 0 540,5 8-90,0 25 314,0 0 1,0 5-315,-2-6 0,0 1 0,0 2-142,1 5 0,1 2 0,0-1 262,-2-1 0,1-1 0,4-2-360,5-2 0,5-2 0,0-3-300,0 1 1,4-7-586,14-8 1,2-9-2204,12-9 3238,-12-13 0,-17 13 0,-23-6 0</inkml:trace>
+  <inkml:trace contextRef="#ctx0" brushRef="#br0" timeOffset="-84629.73">17574 10777 7533,'0'-25'2698,"0"13"-2428,-6-4-270,-1 32 450,-11 4-181,6 3 1,-1 5 225,-7 2 0,-2 2-106,7 1 1,0 2 0,0 1-342,-2 2 0,-1 1 0,4 2-168,1 5 0,4 3 0,4-3-510,5-8 1,3 0-1,5-4-360,14 9 1,7-8 989,3-14 0,2-9 0,-2-9 0,-2-6 0,11-6 0</inkml:trace>
+  <inkml:trace contextRef="#ctx0" brushRef="#br0" timeOffset="-83271.73">17943 11201 6723,'0'-10'1080,"0"-6"-91,0 14-90,0-21-179,0 11-180,0-6 359,-6 3-629,-12 5-540,-8 0-269,-22 18 628,22 3 1,1 5 0,-1 9 0,2 3 180,4-1 0,3 1-90,5 2 0,7 1-135,9 0 0,8-1 0,5-9 0,4-3 90,6-2 0,3-7-1,2-9 1,-2-9 0,0-21 0,-5-7 45,-7 11 0,-3-1 90,0-20 0,-7 2 539,-8 6-539,-12 13-270,-7 44-180,8 6 0,2 5 0,2-2 1,2 3-361,2 16 0,6 0-719,7-16 0,3-2 44,-1 1 1,3-5 1214,28 0 0,-6-55 0,-19 11 0,1 0 0</inkml:trace>
+  <inkml:trace contextRef="#ctx0" brushRef="#br0" timeOffset="-82663.73">18238 11342 7173,'-14'-8'2429,"-2"6"-1800,9-6-89,0 8-180,-4 0 179,4 0-359,-5 8 180,-6 17-90,10 13-405,2-12 0,6 1-180,14-3 0,6-3 90,2-8 1,3-7 179,9-9 0,1-11 404,-4-13 1,-7-9 90,-5-8 0,-11-2-360,-14 7 0,-6 3-90,-3 7 0,-5 7-450,-8 17 0,1 10-2068,-5 31 2518,31 11 0,18-20 0,8-1 0,11-5 0,-1 1 0</inkml:trace>
+  <inkml:trace contextRef="#ctx0" brushRef="#br0" timeOffset="-82379.73">18607 11289 8342,'-5'-18'3276,"3"8"-1515,13 34-2390,9 15 89,-3-9 0,-2 3-360,-3 2 1,-5-2-1259,-18 15 1708,-5-21 0,-6-4 180,-3-7 0,-2-4 270,1-2 0,3-2 0,-2-1 0,15-7 0</inkml:trace>
+  <inkml:trace contextRef="#ctx0" brushRef="#br0" timeOffset="-81294.73">19197 11201 7533,'0'-20'719,"0"-3"-179,-5 13-90,3-8 89,-8 8-179,9 3 90,-10-1-270,4 6-270,-11-6-90,-1 8 180,-6 0 0,-10 8 270,2 2-270,-10 15 90,6 2 90,20-2 0,3 1-90,-5 14 44,11-12 1,5 2-45,14 2 0,5-3 180,13 4-225,-1-9 0,4-8 135,-1-23 0,0-10 135,1-3 0,-2-5-181,-5-5 1,-4-5 195,-8 5 0,-1-3 0,-3 2-195,-4 5 0,-3 1 449,-3-9 1,-4 12-315,-14 35-990,-1 9 90,9 9 1,4 6-810,5 0 0,4-1 719,7-3 0,5-1-135,3 0 1,5-6 854,1-12 0,4-8 0,3-14 0,0-8 0,-2-8 0,0-1 0</inkml:trace>
+  <inkml:trace contextRef="#ctx0" brushRef="#br0" timeOffset="-80877.73">19481 11324 7353,'-7'-17'3276,"-4"7"-1785,9 2-951,-3 16-180,5 9-1620,11 26-2017,2 5 2994,7-3 1,3-4-1,-4-14 1</inkml:trace>
+  <inkml:trace contextRef="#ctx0" brushRef="#br0" timeOffset="-80260.73">19739 10636 7533,'0'-17'2158,"0"7"-1438,5 2 359,24 39-809,-7 1 0,1 7-68,-7-8 1,1 5-1,-1 1 1,-1 0-398,-1-1 0,-1 0 0,0 1 0,-3 3 231,-3 2 0,-2 4 0,-1 1 0,-2-3 0,-1-4-96,-1 1 0,-3-5 0,-2 1 15,-3 2 0,-3 4 0,-2-3 0,-3-7-165,-12-2 1,-2-5-511,2 6 1,-1-3-451,3-14 1,4-3 1169,8 4 0,16-8 0,17 1 0</inkml:trace>
+  <inkml:trace contextRef="#ctx0" brushRef="#br1" timeOffset="-42260.73">4480 15363 6903,'-10'-9'540,"-5"-7"-360,13 14 269,-6-6 181,0 8-90,6 0 89,-13 0 1,13 0-90,-6 0-91,8 8-89,0 2-90,0 0 90,0-3 180,0 1-181,0 2 1,0 8-90,15-1-270,-6 7 0,2 1-90,12-1 0,5 1 0,-5 7 0,1 4 0,0-2 90,-3-8 0,1-1 0,1 1 30,5 8 0,2 2 0,-4-4 150,-1-6 0,-3-3 90,-3 0 0,-2-5 359,-2-10-179,-15-16-270,0 6-1080,0-6-1168,0 8-1209,0 0 2994,0-8 0,0-2 1,0-7-1</inkml:trace>
+  <inkml:trace contextRef="#ctx0" brushRef="#br1" timeOffset="-41491.73">4410 15928 6004,'-28'8'449,"3"2"-89,7-1 540,8 7 449,3-14-180,7 6 0,0-8 271,0-8-721,15-10 1,9-5-181,-5-1 1,3-4 0,1-1-696,4 0 0,2-3 1,1 0-1,0 0 66,0 0 0,-1 0 0,1 0 0,-1 1-113,-4 1 1,1 1 0,-2 0 0,0 3-1437,13-11 1,-4 3 623,-15 12 0,-2 1-874,13-12 1889,-15 21 0,-7-3 0,-9 15 0</inkml:trace>
+  <inkml:trace contextRef="#ctx0" brushRef="#br1" timeOffset="955.27">2134 15752 6183,'0'-28'2609,"0"3"-2609,0 7-540,0 0-1259,24 16 1799,-10-4 0,13 9 0,11 4 0,0-1 0,-2-3 0,-1 1 0,0-1 0</inkml:trace>
+  <inkml:trace contextRef="#ctx0" brushRef="#br1" timeOffset="1144.27">3122 15804 7533,'10'0'539,"37"0"-1439,-9 1 1,4-2 899,5-2 0,2-1 0,-7 1 0,2 0 0,-2-1 0,7-5 0,0 0 0</inkml:trace>
+  <inkml:trace contextRef="#ctx0" brushRef="#br1" timeOffset="1320.27">4374 15716 7533,'47'-9'30,"-1"1"0,-1-2 0,4 2-150,-5 4 0,4 1 0,-1 0-112,-6 0 0,-1 0 1,0 1-1,-5 4 1,-1 1-1,0 0 0,8 2 1,1 0-1</inkml:trace>
+  <inkml:trace contextRef="#ctx0" brushRef="#br1" timeOffset="1503.27">5673 15752 7533,'39'0'299,"0"0"1,6 0 0,3 0-660,-4 0 0,4 0 1,-1 0 31,-1-2 0,-1-1 0,0 0 1,-1 0-1,0 0 0,-2-1 1,-9-2-1,1 0 0,0 0 1</inkml:trace>
+  <inkml:trace contextRef="#ctx0" brushRef="#br1" timeOffset="1669.27">7186 15769 7533,'25'0'-360,"7"0"0,5 0 1349,1 0 1,3 0-1170,-4 0 0,2 0 0,2 0-21,-3 2 1,2 0 0,0 0-1,-3 0 1,2-1 0,-2-1 0,2 1-1,8 2 1,1-1 0,-1 1-1</inkml:trace>
+  <inkml:trace contextRef="#ctx0" brushRef="#br1" timeOffset="1845.27">8848 15769 7533,'41'-9'30,"0"1"0,5-2 0,4 2-450,-3 4 0,4 1 0,-3 0 55,-7 0 1,-2 0 0,-1 1 0,-1 2 0,0 0 0,-3 0 0,-2 0 0,1 0 0</inkml:trace>
+  <inkml:trace contextRef="#ctx0" brushRef="#br1" timeOffset="1986.27">9771 15752 7533,'36'-8'629,"2"6"-809,-9-6 1,2 0 179,-2 7 0,0 0 0,-4-3 0,0 0 0,16 4 0</inkml:trace>
+  <inkml:trace contextRef="#ctx0" brushRef="#br1" timeOffset="2803.27">2716 17762 7533,'-9'-33'1079,"-7"11"-2878,22-19 1799,4 30 0,9-18 0,5-5 0,3 4 0,1 1 0</inkml:trace>
+  <inkml:trace contextRef="#ctx0" brushRef="#br1" timeOffset="2970.27">3351 16986 7533,'11'-33'-72,"1"0"0,-1-1 0,4 4 0,3 2 0,2 0-288,2 1 0,3 1 1,0 3 120,11-6 0,1 1 1,-11 3-1,-1-1 0,0 0 1,6-5-1,1 0 1</inkml:trace>
+  <inkml:trace contextRef="#ctx0" brushRef="#br1" timeOffset="3169.27">4304 16051 7533,'13'-22'659,"-1"-1"1,1 1 0,2 1-1110,5 3 0,3 1-675,3-5 1,1 1 1124,12-9 0,-6 3 0,7-7 0,-1-1 0,-4 3 0,0 0 0,1 0 0</inkml:trace>
+  <inkml:trace contextRef="#ctx0" brushRef="#br1" timeOffset="3303.27">5132 15275 7533,'29'-34'-18,"1"-1"0,0 0 0,2 2 0,1 0 0,3-1-72,-2 4 0,1-1 0,1 1 0,0 0-238,-5 4 0,0 0 0,-1 2 1,-1 0-1,7-4 0,-1 1 1,-2 2-1,2-5 0,1 1 1</inkml:trace>
+  <inkml:trace contextRef="#ctx0" brushRef="#br1" timeOffset="3503.27">6817 13723 7533,'14'-41'809,"0"0"1,8 6-1,6-1-1574,-4 7 1,4-2-1,1 0 1,0 3 646,5-1 1,0 3-1,3-2 1,-7 4 0,2-2-1,1-2 1,0 0-1,-2 1 1,4-5 0,0-1-1,0 1 1,0 0-1</inkml:trace>
+  <inkml:trace contextRef="#ctx0" brushRef="#br1" timeOffset="3687.27">8221 12294 7533,'23'-28'-270,"1"-1"0,0 0 0,3-1 0,2 0 0,2 0 180,-3 4 0,1-1 0,1 0 1,1 1-209,0 1 0,1 0 0,-1 1 0,0 0 0,2-3 0,-2 0 0,0 1 0,-4 3 1,0 0-1,1 0 0</inkml:trace>
+  <inkml:trace contextRef="#ctx0" brushRef="#br1" timeOffset="3787.27">9008 11589 7533,'32'-36'314,"-17"11"1,-1 0-495,6-7 180,-8-1 0,-12 33 0,-7 10 0</inkml:trace>
+  <inkml:trace contextRef="#ctx0" brushRef="#br1" timeOffset="4570.27">5846 18274 7533,'-11'-43'1529,"2"13"-2878,-8 5 1349,10 17 0,-10-8 0,3-3 0</inkml:trace>
+  <inkml:trace contextRef="#ctx0" brushRef="#br1" timeOffset="4769.27">5587 17604 7533,'-16'-32'539,"0"1"1,0 0 0,-6-12-1,-1 1-1289,7 10 1,-1 0 0,1 0 749,-5-7 0,-1 0 0,5 6 0,-1-1 0,0-1 0,-1-2 0,0 1 0,0-1 0</inkml:trace>
+  <inkml:trace contextRef="#ctx0" brushRef="#br1" timeOffset="4971.27">5082 16528 7533,'-17'-26'479,"-1"0"1,-4-6 0,-1 0-480,2 5 0,1 1 0,-2-3-143,0-4 1,-1-2 0,1-1 0,0 3 232,-3-1 0,2 2 0,2 0-570,6-3 0,3 0 1,1 1 479,-4-11 0,4-1 0,6-1 0,3-2 0,2 5 0,0 0 0</inkml:trace>
+  <inkml:trace contextRef="#ctx0" brushRef="#br1" timeOffset="5136.27">4374 15187 7533,'-33'-25'1079,"7"-3"0,-1-3-719,-1 2 0,-1-1-720,8 2 0,0-1 1,3 0 359,2-3 0,4 1 0,-1-3 0,3-1 0,5 4 0,0 0 0</inkml:trace>
+  <inkml:trace contextRef="#ctx0" brushRef="#br1" timeOffset="5311.27">3933 14164 7533,'-26'-30'929,"0"-1"1,-5-8-1,1 0-1199,6 6 0,1-1 270,-3-7 0,1-2 0,3 4 0,1 0 0,6 9 0,0-1 0,0 1 0</inkml:trace>
+  <inkml:trace contextRef="#ctx0" brushRef="#br1" timeOffset="5486.27">3351 13123 7533,'-20'-28'427,"0"0"0,0 0 0,-4-6 1,1-1-548,3 3 0,-1-3 0,3 1 120,-1-11 0,1 1 0,-4 7 0,0 0 0,5-1 0,-1-1 0</inkml:trace>
+  <inkml:trace contextRef="#ctx0" brushRef="#br1" timeOffset="5669.27">2434 11942 7533,'-24'-25'809,"0"0"1,0 0-1,-4-1 1,1-1-810,1 2 0,-2-2 0,3 3 0,3 1 0,3 3 0,2-16 0</inkml:trace>
+  <inkml:trace contextRef="#ctx0" brushRef="#br2" timeOffset="31785.27">2417 14499 7353,'-10'-35'-360,"25"15"360,30 12 0,-13 12 0,1 2 0,6 3 0,1 0 0</inkml:trace>
+  <inkml:trace contextRef="#ctx0" brushRef="#br2" timeOffset="31970.27">3440 14041 7533,'16'-34'479,"1"1"1,4 14 0,3 3-705,13-11 0,4 5 225,3 16 0,3 4 0,1-5 0,2-2 0,-2-1 0,0 1 0</inkml:trace>
+  <inkml:trace contextRef="#ctx0" brushRef="#br2" timeOffset="32136.27">4445 13600 7533,'21'-30'389,"-1"1"1,-2 7 0,3 3-570,7 0 0,4 2 0,0 2 180,10 1 0,1 2 0,-9 2 0,1-1 0,-1-1 0,-3-1 0,0 1 0,0 0 0</inkml:trace>
+  <inkml:trace contextRef="#ctx0" brushRef="#br2" timeOffset="32321.27">5846 12912 7533,'23'-41'-248,"0"-1"1,3 15 0,5 1-1,2 3 8,6 3 0,4 3 1,2 1-581,-3 1 1,2-1 0,0 1 0,-1 0 787,3 0 1,-2 0-1,1-2 1,-11 2 0,1-2-1,0 0 1,-4 0-1,1-2 1,-1 1 0,0 0-1</inkml:trace>
+  <inkml:trace contextRef="#ctx0" brushRef="#br2" timeOffset="32503.27">7236 12136 7533,'40'-20'-203,"1"0"1,-12 7-1,1 1 1,2-4 202,3-3 0,1-4 0,2 0 0,0 2-638,2 2 1,1 1 0,1 0 0,0 0 547,3-1 0,1-2 0,-1 1 0,0 2-27,-5 3 1,0 2 0,-1 0-1,0-1 1,1-2 0,-1-1-1,0 0 1,-2 1 0,2-3-1,0 1 1,0 0 0</inkml:trace>
+  <inkml:trace contextRef="#ctx0" brushRef="#br2" timeOffset="32620.27">9008 11359 7533,'17'-43'809,"3"6"-1304,9 14 1,6 3 494,5 5 0,2 3 0,3-2 0,0 2 0,3 3 0,0 0 0</inkml:trace>
+  <inkml:trace contextRef="#ctx0" brushRef="#br2" timeOffset="33270.27">3739 10513 7533,'-7'-29'989,"-1"1"1,4-7-2789,4-1 1034,19 45 0,5 10 765,9 6 0,0-4 0,6 2 0,1-4 0,-8-9 0,0 0 0,0-1 0</inkml:trace>
+  <inkml:trace contextRef="#ctx0" brushRef="#br2" timeOffset="33428.27">4427 10918 8432,'18'18'180,"7"1"0,7 3-180,2 0 0,5 2 0,2 1-820,-3-1 1,2 1 0,1 1 0,1-1 566,-7-5 1,1 1 0,0-1 0,0-1 0,-3 1 0,3 0 0,-2 1 0,-2-2 0,0-1 0,-1-1 0,1 0 0,-1 0 0</inkml:trace>
+  <inkml:trace contextRef="#ctx0" brushRef="#br2" timeOffset="33619.27">5932 11906 7533,'37'12'269,"1"0"1,0 3 0,3 3 0,3 2-522,-9-4 0,2 1 0,1 2 1,1 0-1,-1 0-404,1 1 1,1 1-1,0 1 1,-1 0 0,0 1 574,-1 0 1,-1 2 0,0 0 0,-1 0 0,-1-2-1,1 1 1,-2-2 0,-2 1 0,0 0 0,4 9 0,1-1-1,-1 0 1</inkml:trace>
+  <inkml:trace contextRef="#ctx0" brushRef="#br2" timeOffset="33777.27">7531 12876 7533,'35'11'197,"0"1"1,-1-1 0,4 5 0,1 1 0,0 3-408,4 2 0,0 2 0,1 2 12,-6-1 1,0 3-1,0-1 1,1-3 0,0-5-1,0-2 1,0-1 0,1 1-1,1 1 1,0 1 0,1-1-1,-1 1 1</inkml:trace>
+  <inkml:trace contextRef="#ctx0" brushRef="#br2" timeOffset="33938.27">8971 13600 7533,'24'7'-270,"0"1"0,15 11 0,5 5 30,-2-1 0,3 3 1,-2-2 108,-8-4 0,-1-1 0,1 1 0,1 0 0,3 1 1,-1-1-1,-3-1 0,-5-3 0,0-1 0,0 1 0</inkml:trace>
+  <inkml:trace contextRef="#ctx0" brushRef="#br2" timeOffset="34120.27">10361 14323 7533,'40'12'-405,"0"-1"0,-6 1 0,2 0 1,4 2 381,0-1 1,5 0-1,0 1 1,-2 0-98,-5 0 0,-2-1 1,0 0-1,2 0 1,4 0-1,1 0 1,0 0-1,-2-1 0,3 3 1,1 0-1,-1 0 1</inkml:trace>
+  <inkml:trace contextRef="#ctx0" brushRef="#br2" timeOffset="34222.27">11272 14623 7533,'37'4'269,"0"-1"1,-5 1 0,-1 2-135,-1 6 0,0 2-405,4 3 0,-2 1 270,-5 0 0,0 1 0,10 6 0,2 1 0,-8-3 0,1-1 0</inkml:trace>
+  <inkml:trace contextRef="#ctx0" brushRef="#br2" timeOffset="34870.27">8676 18027 7533,'9'-35'-98,"0"1"1,0-1-1,6-10 1,4 0-1,6 8 1,4-1 0,1-1-1,-8 6 1,0 0-1,0-1 1,0 1-1</inkml:trace>
+  <inkml:trace contextRef="#ctx0" brushRef="#br2" timeOffset="35044.27">9525 16633 7533,'9'-36'389,"-1"-1"1,1 0 0,-1 0 0,6-2 0,1 2-1,2 0-1049,3-4 1,3 1-1,2 1 507,3 2 1,3 1 0,0 0 0,-2 0 0,1 0 0,-1-2 0,-3 2 0,0 1 0,0 0 0,0 0-1</inkml:trace>
+  <inkml:trace contextRef="#ctx0" brushRef="#br2" timeOffset="35203.27">10509 14781 7533,'13'-35'-26,"1"0"0,-1 0 0,0-1 1,7-4-1,1 2 0,2-1 1,-4 7-1,0-1 0,2 1 1,0 1-1,8-5 0,0 0 1,-1 1-1</inkml:trace>
+  <inkml:trace contextRef="#ctx0" brushRef="#br2" timeOffset="35386.27">11568 13070 7533,'16'-42'-171,"0"-1"0,1 1 0,-2-3 0,3 2 0,-1 13 0,2 0 0,1 2 0,3-6 1,1 1-1</inkml:trace>
+  <inkml:trace contextRef="#ctx0" brushRef="#br2" timeOffset="35503.27">12097 12065 7533,'-7'-32'-180,"0"-1"0,7-10 0,14 28 0</inkml:trace>
+  <inkml:trace contextRef="#ctx0" brushRef="#br3" timeOffset="140487.27">22201 12541 6633,'0'-10'-809,"0"-5"989,0 13-1,0-14 1,0 6 0,5 1-180,-4 1 0,4 8 180,-5 0-180,0 8 180,0 1-90,0 1-90,0-2 90,0-8-90,0 0 90,0 16-90,0 3 0,-5 9-90,4 5 450,-10-13-90,10-3-450,6-25 180,14-35-45,-6 19 0,0-1 90,0-6 0,-1 2-405,6-7 360,-12 19-90,-6 64 90,-6-10 45,2 4 0,1 2 45,-1-15 0,2-3 0,8 12 90,1-11-180,11-42 0,-3-5 0,-1-3 0,-3 0 0,0-1-90,4-2 0,-1 3-270,-2 6 360,1 26 0,-7 28 90,6 3 90,0 4 0,7-25-180,16-26 0,-2-12-45,-6-3 0,-1-5 0,-3 0 0,0 1 0,-1 7 0,-1 1-135,4-12 180,-25 62 90,-14 16-45,5-19 0,-1 1 0,0 1 0,2-1 45,7 6 0,2-15-90,28-20-90,4-20-90,-9 3 0,1-1 180,13-10-270,-7 11 450,-19 9-90,-6 16 0,-17 9-90,8 3 270,-8 5-90,16-15-180,8-18 90,6-11-1,-6-9 1,-2-3-90,3-10-45,-8 14 1,-7 3-226,-44 6 180,11 23 0,-3 6 90,-9 2 0,-3 3 90,8-1 0,0 0 0,4 0 134,4 1 1,3-4-180,-1-8 0,4-8 45,11-39-90,20-6-45,-6 14 0,0 1-404,2-3 269,-35 4 45,9 32 0,-5 7 105,-6 1 0,-6 2 0,2 3-61,5 2 1,1 3 0,0-1 120,-3-1 0,0 1 0,5-2 105,3 3 0,11-9 45,19-23-180,19-6 0,11-3-30,-3 1 0,3-2 0,0 0 30,0 1 0,0 0 0,0 0-60,2-1 0,0 1 0,-5 4 60,7-2-180,-30 24 135,-17 17 0,-12 8 180,-3 7 0,0 2-90,1 0 0,3 1 225,4-1 1,9-2-271,27 11 44,10-36 1,5-8-45,10-3 0,2-8-60,-8-3 0,2-5 1,-1-2 59,-2 0 0,-1-2 0,-1 2-45,9-5 0,-4 1 45,-4-2 0,-7 10-180,-13 24 225,-21 15 0,-7 5 0,0 0 0,1 3-45,0 3 0,1 5 0,3-2-90,1 6 0,6-2 0,7 1 0,10-4 90,7-12 0,7-8 0,3-14 0,2-8 90,8-14 0,-3-8-45,-10 3 0,-4-3 0,-1-3 0,-5-2-45,-8 4 0,-2 3-180,-2 2 180,-11 22 90,-14 37 0,7-6 0,-1 6 0,1-3-180,-2 3 0,1-1 224,1 9 1,6-6 315,13-13-540,23-58 0,-14 6 0,1-5 30,-1 1 0,1-4 0,-2 0 0,-3 1 0,-2 0 1,0 1 104,4-2 0,-3 4-315,0-4 360,-11 76-90,0-7 0,5 6 0,1 0 180,2-10 89,5-6 1,3-8-180,4-23-90,16-22 0,-19 0 0,-2-6-270,-1-6 0,-3-1 180,-1 0 1,-7 2 89,-8 13 0,-8 5-90,-16 8 0,-7 10 120,6 12 0,0 7 0,-1 2 0,-1 2 0,-1 2 0,2 1 29,3 1 1,1 1 0,5-2-60,3 1 0,6-2 360,8 1-270,17-40 0,6-13-180,-4 10 0,0-3 90,1-6 0,-1-4 0,-2 1-90,-3-1 0,-4 1 0,-3-8 0,-10 4-90,-12 16 1,-7 8 89,-20 7 0,-5 10 90,10 10 0,-1 8 0,1 2-24,2 1 1,1 3 0,3 0 23,8-2 0,2 0 0,8 0 0,6 2 0,13-7 359,35-28-359,2-13 0,4-7-30,-10 3 0,1-2 0,-2-2-103,-2-1 1,-1-3 0,-2 2 87,9-8 0,-11 4 45,-28-5-360,-29 46 360,4 8 0,1 7-30,7 3 0,2 5 0,2-1 105,-1 3 0,5 0 15,5 8 0,11-5 90,37-15-180,-14-15 0,2-6 0,5-12 0,2-7 0,-2-1 0,2 0 0,-2-1 204,10-7 0,-3 5-384,-2 13 180,-13 51 0,-20-6 0,-5 5-45,-2 6 0,-3 0 45,2-9 0,-1-4 360,-1 9-180,16-64-91,-3 14 1,10-33 90,-1 16-180,3 5-90,-7-13 90,-2 5 0,-22 1-269,-19-7-1,-13 19 0,-8 3 135,4 1 0,-2 2-13,4 2 0,-4 1 1,5 4 282,0 7 0,4 5-45,4 2 0,7 4 0,10 13-1,36 5-134,16-29 1,7-8-136,8-5 0,1-2 30,-13 3 0,-1 1 0,1-3 150,0-4 0,1-2 0,-9 10 0,-2 27 0,-8 9 0</inkml:trace>
+  <inkml:trace contextRef="#ctx0" brushRef="#br3" timeOffset="162990.27">22336 12577 6004,'-14'-18'359,"-8"8"-359,14 2 90,-4 8-90,1-8 270,4-1-90,0-1 0,-4-14-180,10 20 0,-5-11 0,6 15 0,6 15 90,0 5 45,7 1 0,3 1-135,0 1 0,1-1-45,9 4 0,3 1 45,6 7 0,2 1 60,-7-12 0,2 1 0,-1 1-211,1 6 0,0 3 0,0-3 211,-1-6 0,0-2 0,-1 4-90,-1 12 0,-1 5 0,-2-4 75,4 0 0,-1 1-45,-7-3 0,-1 3 0,1-1-44,-1-7 1,1-2-1,1 1 111,-1-2 1,1 1 0,0 0-1,1-1-67,4 3 0,1-2 0,0 1 0,3 4 0,0 2 0,0-3-30,-6-5 0,-1-2 0,1 1 60,4 3 0,2 1 0,-2 0-147,-4-2 0,0-1 0,1 1 207,7 1 0,2-1 0,-1 0-180,-5-4 0,-1-1 0,0-1 30,3 0 0,0-2 0,-1 2 30,-4 0 0,-1 2 0,1-1-69,1 0 1,0 0 0,-1 1 188,5 8 0,-1 2-60,-8-9 0,0 2 0,0-2 0,3-1 0,0-1 0,-2 2 0,-3 1 0,-3 1 0,3-1-30,4-2 0,2 0 0,-2-1 30,-3 0 0,-2 0 0,1 1-120,5 1 0,0 1 0,0 0 30,-2 0 0,-1 1 0,0 1 60,0 1 0,-1 1 0,1 0-60,3 4 0,0 1 0,-2-1 90,-4-8 0,0-2 0,0 1 90,1 3 0,2 1 0,-1-1-90,0-4 0,1-2 0,-2 1-30,6 14 0,-2 1 0,-5-12 0,1 1 0,-2-1-135,3 8 0,0-2 364,4 4 0,1-1-274,-4-6 0,-1-1-90,3 0 0,0 0 225,2 8 0,-1-1-90,-9-9 0,0-1 110,11 5 0,2 2-155,-7 5 0,-1-3 45,-3-16 0,1 1-30,2 6 0,2 3 0,-3-2 75,-2-4 0,-1-1-75,3 4 0,2 2 0,-1-2 165,0 1 0,0-1 144,4 6 1,1-1-325,-5-10 0,1-1 45,1-4 0,1 1-18,5 6 0,-1-1 18,-6-9 0,0-1-76,7 4 1,1 0-150,-4-4 0,0-3 45,18-1-270,3-2 450,-22-8 0,-8 0 0,-12 0 0</inkml:trace>
+  <inkml:trace contextRef="#ctx0" brushRef="#br3" timeOffset="165105.27">22570 12153 7533,'-13'-45'-1350,"1"18"1440,-6 11 90,-1 16 0,-6 0 0,1 0-90,5 0-90,-5 0 0,16-16-90,-8-3 0,14-9 90,2-13 0,2 20 180,3-13 90,-5 24 0,0 3-180,6 7 90,1 15 89,5-3 1,11 21-180,-8-21-90,13 10 0,6 3-90,-8-6 0,2 1-60,0 2 0,1 2 1,0 1 8,3 2 1,0 2-1,0 1 81,2 4 0,-1 2 1,0 0-245,-6-9 1,-1 1 0,1-1 0,0 1 325,-1 0 1,-1 1-1,0-1 1,3 0 44,5 3 1,2 0-1,0-1 1,-3-2-68,-5-1 0,-2-2 0,3 1 67,6 1 0,4 2 1,0-2-1,-5-2-203,4 3 0,0 1 136,-6-4 0,4 2 0,0 2 0,-1-2-30,4 1 0,-2 0 0,1 2-225,-3 0 1,0 3-1,0 1 1,-2-2 254,2 4 0,-2-1 0,2 2 18,-8-6 0,2 2 0,0 0 0,-1 0 0,-2-2 12,0 4 0,-2-2 0,2 1 15,2 0 0,3 3 0,0-1 0,-2-2-118,3 0 0,-1-3 0,0 0 103,1 2 0,1 1 0,1-1-165,-2-6 0,2-1 0,0 0 0,-2 1 135,3 5 0,-1 0 0,1 0-113,-5-8 1,2 0 0,0 0 0,-3 0 112,1 3 0,-2 0 0,2 1 0,1-3 0,3 1 0,1 0 0,-3-1 0,3 3 0,-2-1 0,1 0 149,3 2 1,1 0 0,1 2 7,-8-3 1,-1 2-1,1 0 1,-2-1-38,3 1 0,-1-2 0,1 2-98,-4-1 1,-1 1-1,2 1 1,0-1-68,3-1 0,0-1 0,1-1 0,-1 1-15,4 5 0,-1 1 0,2 0 15,-6-4 0,0 0 0,1 1 0,-1 0 22,1 1 1,-1 0-1,0 1 1,-2-1 89,-3-2 1,-1 0-1,0 0 1,0 0-46,2 0 1,0 1-1,0 0 1,0 0-1,1 5 1,0 0-1,0 1 1,-1-3 7,4 5 0,0-2 0,0 1 15,-3-3 0,0 1 0,1-1 0,0-2-15,2 1 0,1-2 0,0 0 15,-3-2 0,1 0 0,0 0 0,-1-2-135,3-1 0,-1-2 0,1 1 60,3 8 0,1 1 0,-2-2-180,-4-5 0,-1-2 0,0-1 276,7 4 0,0-2-291,1 1 1,0-5 224,-5-7 0,0-6 0,-6-8 0,0-2 0,23-2 0</inkml:trace>
+  <inkml:trace contextRef="#ctx0" brushRef="#br3" timeOffset="167720.27">22902 12506 7533,'6'-20'-540,"6"-3"810,-11 29-180,-23 35-60,7-14 0,-2 3 0,-2 3-241,1 0 1,-2 3 0,1 1 0,0 0 255,0-1 0,0 1 0,2-1 0,2 0-135,-1 8 0,3-1 0,11-6 223,12-9 0,10-9-43,14-14 0,8-14-45,-8-9 0,3-8 0,0-4 0,0 2-618,-1 2 0,1-1 0,-2 0 0,0 1 602,5-8 1,-2 1 0,-2 8-300,5 5 1,-13 16 224,-33 29 0,-12 13 67,3-4 1,-3 6-1,-2 1 1,0-1-99,0-4 0,-1-1 0,-1 1 1,1 2 110,0 0 1,-1 4 0,1-1 0,1-1 0,3-5 9,-5 12 0,8-6 45,11-3 0,10-11 180,39-37-180,-6-5 0,3-5-120,-10 3 0,1-1 0,0 0 60,-1 2 0,0 0 0,0 1-30,1-1 0,1 0 0,-3 5 1198,3 2 0,-3 8-1108,-7 10 0,-4 7 45,-8 9 0,-4 5-1,-2 5 1,-4 3-105,-2-1 0,-3 4 0,0-2-120,0 6 1,1-1 347,-1-9 0,1 2 0,6-6-303,15-4 0,5-9-45,18-2 90,-14-21 0,5-8 0,-2-2-45,10-8 0,-2-1 0,-2 0 0,-1 9 0,-7 17 0,-8 11 135,-22 22 0,-13 13-342,4-14 0,-4 5 1,-2 3-1,0 0 1,0-1 251,-2 5 0,-2-1 0,1 1 0,0-1-23,-1 2 1,-3 1-1,6-3 1,13-9-30,19-2 0,11-15 277,10-26 0,8-17-99,-14 6 0,4-4 0,1-3 0,1 0 0,-2 1-259,6-4 1,0-1 0,0 0 0,-2 3-48,4-2 0,-1 1 0,-1 8-45,10 3 0,-12 18-26,-33 38 1,-13 14 190,3-17 0,-3 1 0,0 1 90,-3 5 0,-1 2 0,3-3 1022,5 8 0,8-6-738,12-15 1,8-7-270,9-5 0,7-3-105,1 1 0,5 0 0,-3 1-330,-7 0 1,-3 2-1,0 2 242,-1 2 1,0 3-1,-1 2 1,-2-1 117,-1 3 0,-4 0 0,-2 2 90,-3 3 0,-3 1 0,-1-3 30,5-1 0,-3 1 289,-9-1 0,-4 3 0,3-4-244,4-4 0,4-1 450,9 10 1,7-4-586,3-12 0,4-6 0,6-9 0,3-1-60,-13 3 0,1 1 0,-2 1-255,8 3 1,-3 3 134,0 5 0,-6 5 45,-11 14 0,-9 7 225,-10-7 0,-5 3 0,-2 0 120,-2 1 0,-2 1 1,-2 1 36,1-5 0,-3 3 1,1-2-1,2-3 68,1 12 0,5-6-147,4-6 1,10-7-79,27-18 0,11-10-90,-18-5 0,1-2 0,1 0-210,7-1 0,1 1 0,-2 3-210,-4 3 0,-1 3 1,-3 4-31,3 10 1,-6 7 493,-5 3 1,-6 6 105,-10 0 0,-5 4 0,-3-3 210,-2 4 0,-2-1 89,-2 9 1,5-2 90,23-1-540,5-26 0,7-5-270,4-7 0,4-4 150,-6-2 0,3-2 0,-1 1-375,11-2 1,-3 2 179,-6 5 0,-4 6 315,-9 0 0,-6 7 45,-11 14 0,-9 5 270,-6-9 0,-2 0 90,2 4 0,1-3 134,-1 6 31,28-17-749,26-10-1,-22-9 0,0 2-540,7 11 1,-3 7 134,-11 6 0,-7 5 900,-9 14 0,-7 2 134,2-7 1,-3-3-90,-11-6 0,7-9 0,24-21-225,5-15 0,2-6-225,2 2 0,3-1-225,11-10 0,-1 9-404,-3 33 269,-17 19 225,-18 7 0,-10 5 45,-7-2 0,-1-2 135,12-10 0,2-3 225,0-1-90,40-42 90,3-13-270,-1 11 90,-14 29 0,-26 13 0,-7 7 0,-1 6 0,-1 0 0</inkml:trace>
+  <inkml:trace contextRef="#ctx0" brushRef="#br4" timeOffset="170494.27">23616 13547 11446,'6'-27'-553,"0"1"1,7-11 867,-7 3-358,-11 24-688,-31 26 1074,6 4 1,-3 5-273,6-1 0,-1 3 1,1 3-36,-1 4 0,2 3 0,5-3 52,1 2 1,13-3-18,19-4 1,13-9-64,15-23 1,10-12-113,-16 7 0,3-1 1,0-1-1,1 0 263,-1-1 0,1-1 0,0 0 0,-1 2-235,11-2 0,-1 2 0,-4 5 6,6 3 0,-10 11-85,-21 18 1,-13 7 153,-13 0 0,-10 3 0,0 0 88,4 0 0,0 0 0,-1 1 37,-4-1 0,0 0 0,5 0-278,9 12 1,9-4-24,4-13 0,8-5-86,18 6 0,10-7 156,-3-13 1,5-6 0,2-1-111,-8-3 0,2 0 0,0-2 0,0 1 233,-1 0 1,0 0-1,0 0 1,-2 0-8,11 2 1,-1 0-1,-4 4 286,2 6 1,-5 7-374,-8 8 1,-7 5 136,-6 0 1,-7 4 65,-10-3 1,-3 4 0,1-3-253,5 7 1,2 0-19,-3-8 1,0 1 0,6-3-235,12-1 1,5-3-1,1-4 205,1 2 0,3-5 134,5-4 0,4-1 0,-3-3 192,-6-1 0,-1 0 149,11 2 1,-5 5-235,-15 4 1,-8 5 90,-5 15 1,-10 6 23,-9-10 1,-6 2 0,-1 2 56,4-7 0,-2 2 0,1 0 0,0-2-179,-1 5 1,0-2 0,7-2-146,5 13 1,15-10 23,13-25 0,10-9 0,1-2 144,-2-3 0,1-2 0,3-2 12,-3-1 1,3-1-1,0-2 1,0-1 84,1-4 0,1-3 1,-1 0-1,-2 2-92,5-1 1,-2 2 0,-2 4-137,13 3 1,-13 14 69,-32 14 0,-12 8 53,-8 2 0,-7 3 0,-3 0-196,2-6 1,-3 0 0,0 0-1,2 0 142,-2 5 0,1-1 0,3 1-112,1 2 0,2 0 0,8-2-251,9 3 1,9-3 74,5 0-1,9-4 161,4-14 0,6-4 0,0-3 228,1 0 0,1-2 0,1-1-65,4-1 0,1-2 0,-1 0-92,-1 0 1,-1 0-1,-1 1-123,8 4 1,-5 6 56,-9 3 1,-8 7-4,-8 7 0,-8 4 310,-10 10 0,-3 2-107,2-13 0,0 0 1,0 0 126,-2-2 1,-1-1 0,6 0-504,16 8 1,9 1-1,0-7 58,-5-11 1,4-3 117,7 0 0,6-1 0,0-6 166,5-11 0,1-6 134,-9-2 1,2-1 0,-1 1-44,15-1 0,-3 0-214,-5-4 0,-5 2-755,4 8 930,-28 2 1,-51 22 0,10-14-1,1 0 1</inkml:trace>
+  <inkml:trace contextRef="#ctx0" brushRef="#br4" timeOffset="171669.27">24489 14499 9817,'-11'-25'-1823,"8"13"1471,-2-4 101,17 24 346,8 2 281,10 8-142,-4-1 49,-2 16-430,-12 5 213,-11-8 0,-4 5 0,0 0-9,-1 8 1,0 2-16,3-2 1,2 2 0,3-4-28,5-1 1,8-5-30,6-12 0,5-3 0,4-5 44,7-4 1,3-7-1,2-1-293,4-1 0,1-2 0,0-2 408,-1-1 0,0-1 0,-2 1 2,-6-1 0,-2 1 0,-6 8-326,-2 24 1,-8 7 133,-8-9 1,-7 3 101,-11 13 1,-8 8-1,-1-4 131,-2 1 1,1-2-279,2-8 0,0 0 1,6 0-229,11 9 0,12-6 85,10-10 0,8-7 172,8-4 0,5-7-105,-5-9 1,4-5 0,-1-2 414,-5 1 1,-2-2 0,3 0-130,-2 0 1,2-2-1,-1 1 1,-1 3 27,1 2 1,-2 2 0,-2 2-74,17 0 1,-11 11-100,-25 12 0,-9 9 1,-6 1 94,-9 0 0,-8 1 0,-1 1-68,2-3 1,0 2-1,-1 1 1,-1-1-119,-2-1 0,-1 1 0,0-2 0,3 0 82,1 2 0,3-2 1,5-1-29,6 12 0,12-5 61,19-12 0,10-9 245,-6-12 1,4-4-1,0-2 24,6 1 0,2-2 1,0 0-260,-9-1 0,1 0 0,0 1 0,-3 2-153,-1 2 0,-2 1 0,-3 5-129,1 7 0,-3 4 0,-10 4-272,-17 7 1,-13 6 0,-3 2 548,1-6 1,-3 3-1,-2 2 1,-3-2 0,0-2-1,-8 2 1,-3-3 0,-1-1-1,-1 2 1,2-4 0,1 0-1,-1 1 1,1-1 0,-1 0-1</inkml:trace>
+  <inkml:trace contextRef="#ctx0" brushRef="#br5" timeOffset="195701.27">2716 11800 8988,'4'-33'-465,"0"0"0,14-10 275,-3 12 0,5 3 36,5 12 1,3 6 166,6 5 0,3 1 0,2-8 0,2 0 0,3 2 0,0 0 0</inkml:trace>
+  <inkml:trace contextRef="#ctx0" brushRef="#br2" timeOffset="196044.27">3598 11236 7533,'17'-29'329,"0"-1"1,11-5 0,4-2-210,-6 3 0,1-3 0,3 2-436,-4 9 1,2 1 0,2 1 0,-1-1 180,3-3 0,0-1 0,1 1 0,2 1-517,1 3 0,1 3 0,1-1 0,2-1 382,-4-1 0,2-1 0,1-1 1,0 0-1,1 0 80,-5 3 1,2 2-1,0-1 1,0-1 0,1 0-1,-1-1 190,-2 1 0,0-2 0,1 0 0,-1 0 0,1-1 0,-1 0 0,1 0 0,-1 0 0,1-1 0,0 1 0,0-1 0,0 0 0,0 0 0,0 1 38,-1-1 1,2 1-1,-1-1 1,0 0 0,0 1-1,-1-1 1,1 1 25,-1-1 0,0 1 1,-1 0-1,1-1 0,-1 1 1,0 0-1,0-1-19,5-2 0,-1-1 0,0 0 0,0 1 0,0 0 0,0 0-30,0 1 0,0 1 0,0 1 0,0-1 0,-1 1 0,0-1-60,-1 2 0,-1 0 0,-1-1 0,1 1 0,0 1 0,-1 0 45,5-2 0,1 1 0,-1 0 0,-1 1 0,-1 1 0,1-1 0,-1 1 0,-2 1 0,0 1 0,4-5 0,0 1 0,0-1 0</inkml:trace>
+  <inkml:trace contextRef="#ctx0" brushRef="#br2" timeOffset="196253.27">8515 7708 7141,'30'-28'-13,"-1"0"0,1 0 0,-1 0 0,0 3 0,-2 0 0,2 0 1,4-1 12,3-1 0,4-2 0,3 0 0,0-1 0,-2 2 0,-3 2 0,-1-1 0,-3 2 0,-1 1 0,3-2 0,3-1 0,0 1 0,1-1 0,-1 0 0,0 1 0</inkml:trace>
+  <inkml:trace contextRef="#ctx0" brushRef="#br5" timeOffset="203153.27">27935 9684 22761,'-40'16'23,"0"0"0,0 1 0,0 4 0,-1 2 0,0 3 0,-1 0-41,6-3 0,-1 1 0,1 1 1,0 0-1,1-1-6,-1 2 1,1 0 0,1 0 0,3-2-74,-6 5 0,2-1 1,22-12-876,36-19 1,15-8 1635,4 1 1,5-2-784,-8 1 0,4-2 0,2-1 0,-2 0 262,-1-2 1,-1 0 0,0 0 0,-2 3-42,3 0 0,-2 1 0,-5 5-186,2 3 1,-15 8-147,-36 15 0,-22 10 1,-1 2 205,8-5 1,-2 3 0,0-1 0,-2 1 427,-6 0 1,-2 1-1,2-1 1,8 0-747,0 14 1,21-7-503,33-23 1,14-9 821,0-5 1,5-6-1,4-3 1,-3 1-154,-2 0 0,0-1 0,0 0 1,-1 0 240,1-1 0,1-1 1,-3 1-1,-5 1 353,4-3 1,-12 9 52,-20 27-618,-32 3 1,-19 4 0,-2 1 215,15-8 1,0 1-1,-1 1 1,-1 1 267,-1-1 0,-3 3 0,-1 0 0,4 0 0,6 0-512,0 5 1,7 0-1,6-1-376,3 1 0,13-2-46,19-6 1,11-3 0,1-4 19,2-6 0,2-2 292,4 4 1,3 4-1,-3-1 132,3 1 1,-3 1-129,-9-3 1,0 3 0,-2-1 157,4 3 1,-6 3-341,-12 4 0,-9 3 388,-15 3 0,-7 2 520,2 1 1,-2 1-355,-1-9 0,-3 0 0,6-1-474,5 2 1,11-5 239,35-14 0,15-10 469,-12-5 0,3-3 0,4-4-335,-5 0 1,5-3-1,1-1 1,-1-1 0,-2 1 507,-1 1 1,-1-1 0,-2 1 0,-1 1 86,8-5 0,-1 2 0,-12 6 229,-10 10-881,-52 11 0,-23 6 367,10 1 0,-4 4 0,-2-1-90,5-6 1,-2-1 0,0 0 0,4-1-4,-7 5 1,3-1 0,25-6-33,39-11-184,8-9 0,9-5 0,3-1 2,2 2 1,4-2 0,1 1 0,-1 1-74,-5 3 0,0 0 0,-1 1 1,-4 1 480,17-6 1,-15 13-1304,-30 42 461,-29-16 0,-16 2 1,-5 1 356,9-6 1,-5 1 0,-2 1 0,-2 1 0,1-1 0,3-1 261,-3 2 1,2 0 0,1 0 0,0-1 0,1 1-170,-12 4 0,-2 0 1,9-1-1,22-3-411,29-1 0,12-5 47,14-7 1,11-8 329,-11-3 0,8-3 0,4-2 0,1 0 0,-3 0 0,-5 1-259,9 2 0,-6 0 1,5 0 365,-9-3 0,5 0 1,3-1-1,-2 0 1,-3 1-1,-6 2-297,15 3 0,-6 4 165,4 4 1,-15 7-721,-39 24 1000,-6-6 0,-3 0 46,-2-10 0,6-1-558,18 4 1,9-3-348,9-5 1,6-3 491,6 5 0,0 2-507,-5 1 1,-5 4-226,-9 6 0,-6 3 230,-3 3 0,-4 0 365,-8 2 0,4-3-174,16-9 0,8-5 844,2-8 1,5-3 0,4-4-304,6-7 1,5-4-1,2-4 1,1 2 109,-7 1 0,2 0 0,0 0 0,0-1 0,0 0 5,-2-1 1,1-1-1,0 1 1,-2 0 0,-2 2 116,3 0 1,-1 2 0,-4 2 0,-6 5-5,5 12 0,-13 7-635,-18 16 1,-17 5 552,-10-13 1,-11 2-1,-4-1 1,4-1-70,0 0 0,2-1 0,-1 0-125,-1-4 1,-3 2 0,4-2-1,13-3 202,21 19-1599,27-17 1232,4-15 0,10-2 0,-3-4 304,0-5 0,1 0 234,-2 7 1,2 3-1,-3-1-502,-3-7 1,-4 3-349,-4 12 0,-9 3 644,-13 16-524,-22-8 0,-12 0 762,-1-7 0,-7-2 0,-3 1 0,2-1-459,0-1 1,1-1 0,-1 0 0,1-1 126,-3 1 0,-2 0 0,5-1 1,9-3 459,7 2-1168,46-22 0,20-9 866,-9 4 0,5-1 1,2-1-1,0 0-111,-7 1 0,1 1 0,1-1 1,-1 0-1,-1 1 200,7-2 1,-1 0 0,-1 1 0,-2 1-506,1-2 1,-2 2-1,-12 4 234,-11 6-127,-52 8 0,-26 4 126,19-1 1,-2 2 0,-1-2 554,6-5 1,-1-1-1,0-1 1,3 1-370,-2 2 1,2 1 0,8-8-143,-3-23-1445,54 9 1528,2-2 1,4-1-782,6 3 1,-3 2-282,-2 1 500,-23 3-30,-41 13 0,-23 7 307,15-7 0,-3-1 0,-2-1 82,9 1 0,-3 0 0,2-2 0,1-4 762,-6-7 0,2-5 0,10-4-862,9-9 0,11-3-625,13-2 1,9-1-121,12-2 0,8 4 331,1 7 1,1 3-346,-10 2 1,-1 0 604,5 2 0,-11 1-638,-50-9 415,-3 5 738,-6 7 1,-5 0 255,16 5 1,-1 0 0,-1-1-217,-10-2 1,-2 0-1,1-2-692,9-1 1,1-2-1,-1 1 126,-3 0 1,0 1 0,5-2-160,6-8 0,5-3-197,-4-6 0,4-3 251,7-7 1,3-4-28,5 8 0,2-2 1,2-3-64,3 7 0,2-2 0,2-1 0,2 0 232,1-4 0,2 0 0,1-1 1,0-1 49,1-2 1,0-1-1,1 0 1,-1-1-18,-1 10 0,0-1 1,1 1-1,-2-1 0,-2 1 22,-2-7 0,-1 0 1,-3 0-1,-4 2-14,-2 4 0,-3 0 0,-3 2 0,-2-1 68,-3 1 0,-2-1 1,-3 2-1,0 1 220,-1 3 1,-1 1 0,0 0 0,1-1-27,2-2 1,1-1 0,2-1 0,0 0-264,2 5 0,1-1 1,1 1-1,1-2 56,1-2 1,2-1 0,-1 0 0,-3 4 74,-10-3 0,-4 4 1,-3 1 88,4 5 1,-3-1-1,-1 3 1,-3 3 176,-7 6 0,-4 4 1,-1 3-1,0-1 66,0 0 1,0 0-1,1 0 1,0-1-62,4 1 1,1 1-1,1-1 1,6-2 637,-12-4 0,18-7-672,39-10 0,21-6 1,3 3 314,-5 10 1,5 3 0,6 0-441,-4 3 1,6-2 0,4-1-1,3 0 1,-1 0 0,-1 3 0,-3 2 130,1 0 0,-2 3 0,-1 2 0,0 0 0,2-1-208,-3 0 0,3-2 0,0 1 0,-2 1 0,-3 3 0,-4 5 39,22 3 0,-24 13-732,-49 18 0,-23 7 762,13-12 0,-5 1 0,-4 1 0,-2 1 0,-2 0-85,2-2 0,-4 1 0,-1 0 0,-2 1 1,1 0-1,1-1 0,3 0 33,1-1 0,1 0 0,2-1 0,0 1 0,3 0 1,1 0 57,-11 11 0,-1 1 0,11-1 0,19-6-894,35 1 1,19-7 722,-10-9 0,6-4 0,2 0 0,2-3 54,6 0 0,4-4 1,-1 1-1,0 2 493,-5 4 1,-1 3-1,-1 0 1,1 0-688,0-2 0,1-1 0,-2 2 0,-1 2 32,-5 3 1,-1 3 0,-1 0 0,-2 1-230,6 5 1,-2 0 0,-4 3 93,-7 1 1,-3 2 0,-2 2 419,-3 0 0,-3 1 1,-6 2-331,-9 5 0,-6 2 1,-4 1 422,0-10 1,-3 1 0,-1 0 0,-2 0-204,-3 5 1,-2 1 0,-1 0 0,3 0-81,2-4 0,2 1 1,2-1-1,4 0-89,2 5 1,5 0 0,11-4 90,12-8 0,10-1 1,5-4-1,1-3 259,3-5 0,3-4 0,3-2 0,1 1-51,-8-3 0,2 0 0,0 0 0,2 0 0,-1-1 0,-1 0 117,4 0 1,1 0-1,-1-2 1,-1 2 0,-2 0-58,2 3 1,-1-1 0,-3 3 0,-3 2-78,8 9 0,-4 4 0,-14 4-350,-17-2 1,-9 2-1,-7 3 353,-6-1 0,-8 2 0,-3 1 1,-3-1 17,1-5 1,-3 0-1,-1 0 1,-1 0 0,0 0-46,-1 2 0,-2 1 0,1-1 0,2 0 0,5 0 40,-7 9 0,5 0 1,14-2-433,16-5 1,11 0 0,7-8 310,13-9 0,10-9 0,1-2 407,-5 0 1,2-2 0,1 0 0,0 0 60,3 0 1,1 0 0,-1 0-1,-2-1-336,-1 1 1,-1-1 0,-3 4-199,-2 2 0,-1 2 0,-14 6-743,-22 21 1,-20 4 788,-7-11 1,-8-3 0,-4 1 377,3-1 0,-2 0 0,-2-1 1,-1-2-63,-3-2 0,-3-1 0,2-3 0,4-3 87,6-2 0,4-2 1,3-7 554,-10-8-1426,62-15 1,19-6 633,-13 7 1,1 0 0,0 0 398,3-1 1,1 1 0,-4 3-122,2 4 0,-15 4-475,-47 14-97,-9 7 1,-9 3 6,12-7 1,-5-1 0,-1 0 0,4-4 317,0 0 0,2-3 1,4-6 745,-6-9 0,15-7-996,39-7 1,23-4 0,3-1 8,-7 6 1,4-1 0,1 1 0,1 1-7,-6 4 0,2 1 1,0 0-1,0 2 0,-4 2-164,13-3 0,-3 4 0,-19 12-1087,-36 36 834,-11-7 1,-9 1 498,0-6 1,-4 0-1,4-2 190,2-2 1,13-5 336,50 1-520,-1-14 1,9-4-1,-5 1 1,5-1-1,3 0 1,-1-1-1,0 1 1,0-1-1,0 1 1,0-1-1</inkml:trace>
+  <inkml:trace contextRef="#ctx0" brushRef="#br5" timeOffset="-209106.46">29916 9984 16320,'-24'-28'-3277,"10"11"1425,3 9 1753,11 8 1083,11-16-368,8-4 94,7-15-238,5 8-231,-29 9 181,-38 34-139,7 1 1,-8 8 0,-5 4 0,-3 2 0,1-2-540,8-6 0,-1 1 0,-1 0 0,-2 0 0,0 1 0,0 1 0,-2 1 300,3-2 0,-2 2 1,-1 2-1,-1-1 0,0 1 1,0 0-1,1-1 1,0 0-1,2-3 57,1 0 0,-1-1 0,2 0 0,-1-1 0,1 0 0,2-2 0,0 0 0,2-1-7,-8 4 1,1 1 0,2-2 0,4-4 0,3-6 509,-11-3 1,17-13-1192,43-29 1,23-14 718,-17 18 0,3-1 0,3-1 0,3-2-502,-1 3 0,4-3 0,2 0 0,1-2 0,2 1 0,-2 1 0,-1 2 352,-1 1 0,1 0 1,-2 2-1,1 0 1,0 0-1,0-1 5,3-1 1,1-2 0,0 0 0,-1 2 0,-3 1 0,-4 4-108,6-4 0,-4 4 0,-15 7-360,-16 10 211,-27 14 1,-15 13 552,11-1 1,-3 5 0,0 2 0,1-3 324,-5 1 0,1-1 1,1 3-599,4 1 0,-1 4 0,3 0 1,6-3-128,1 3 1,12-5 45,40 9 31,-4-34 0,7-10 0,2 0 96,4 0 0,3-1 0,3-3 483,-9 0 0,3-2 0,1-2 0,0 1 0,-3 3-611,0 2 0,-2 3 0,-1 1 1,1 0-54,3-3 0,0 0 1,-1 3-1,-7 8-400,1 12 0,-12 9-26,-22 19 1,-15 7 577,-2-11 1,-6 2 0,-4 2-21,2-6 1,-5 1 0,-1 1 0,0 0 0,3-2-61,1 1 0,3-3 1,1 1-1,0-1 12,-14 11 0,1-1 0,24-9-612,35-12 0,15-11 656,2-14 1,6-12 0,5-2 104,-13 6 1,2-2-1,3 0 1,0-2 0,0 1-1,-1 0-36,7-3 0,-1 0 0,0 0 1,-1 0-1,-1 1 7,2-3 1,-1 1 0,-2 2 0,-4 6-331,19 2 1,-22 16-36,-44 12 1,-18 11 0,-8 3-1,4-2 255,0 5 0,1-1 0,-7 5 202,8-12 0,-5 3 0,-3 3 0,-2 0 0,0 1 0,0-1 0,2-2 0,3-3-103,-2 1 1,2-3 0,2-1 0,-1 1 0,0 3-59,-2 2 1,-2 4-1,0 1 1,1-1-1,5-3 1,4-4 292,-8 11 1,17-5-757,27-4 0,15-7 230,4-17 1,8-7 0,1-2 265,6-1 0,2-1 0,1 0-55,-1 1 0,1 1 1,-1 2-282,-6 1 0,-1 2 0,-5 5-69,2 10 0,-10 8-168,-12 13 1,-12 8 558,-12-11 0,-8 5 1,-3 1-1,0-3 126,2-3 0,-1-2 0,-1 1 1,0 1-58,0 2 1,-2 1-1,1 2 1,2-3-1,4-3 26,3 1 1,4-3 0,6-1-555,14 18 1,15-10 253,0-25 0,8-9 0,4-2 73,2-3 1,5-5-1,2 0 1,-3-1 328,-3 1 1,-1-1 0,0 1-1,0-1-167,0 0 1,2-2-1,-3 3 1,-5 6-404,12 17 1,-14 11-261,-26 13 1,-14 5 625,-5-13 1,-6 1-1,-4-1 217,-6 4 1,-4-1 0,-1-6 440,-3-3 0,0-11 530,6-13 0,6-12-1254,18-21 1,11-14 0,1-3-29,-1 7 1,0-2 0,1-2-1,0 0-83,3-7 0,1-1 0,0 0 0,-2-1 284,-1 7 1,-1-1 0,0 1 0,-2 0 0,-2 2-461,-3-1 0,-1 2 0,-2 1 0,1 1 101,4-5 1,0 1 0,-8 2-592,-11 4 1,-8 1 0,-3 1 0,2 4 47,2 1 1,-1 4-1,-2-2 736,-5-4 0,-4-2 1,-1-1-1,1 1-57,4 3 0,1 0 1,0 0-1,1-2 229,-2-3 1,1-3 0,1 1 0,2 0-140,-2-1 0,3 1 0,2-3 49,8 2 1,1-3 0,3 0-1,6 2-41,5 2 0,6 1 0,2-1 159,3 2 1,2-3 0,2 1 0,1 0 38,4-9 0,1 1 0,0 1-67,2 1 1,0 0 0,-9 4-453,-13-2 1,-12 9 8,-17 15 1,-14 11 235,7 8 0,-8 7 0,-3 3 1,-1 2-1,2-1 331,1 1 0,1 1 1,-1 1-1,0 0 1,0-2-75,5-3 0,-1 0 1,0-1-1,0-1 0,3 0 1,2 0 848,-18 7 1,4-1 0,17-15-218,21-43-621,29 18 0,13-3 0,4 1 114,-2-1 0,4 0 0,3 1 1,1 2-32,-1 5 1,2 1 0,2 1-1,-1 3 1,-1 3-388,2 0 1,0 2 0,0 4 0,-2 6-243,9 7 0,-1 8 0,-8 10-75,-16 6 0,-5 7 0,-6 5 1,-5 0 195,-7-2 1,-6 1 0,-4 2 0,-1 1 0,0-1-78,0 0 1,1 0-1,-2 0 1,-3 0-1,-2 1 306,0-6 1,-3 0 0,-1 2 0,-2-1-1,-1-1 1,2-1 0,0-3-80,-6 8 0,-1-2 1,2-3-1,-1 2 34,1 1 0,-1 1 0,2-1 1,3-2 55,3-1 0,2-1 1,8-2 694,8-1 0,10-2-938,10-2 0,10-1 1,2-3 244,2-6 1,3-2 0,3-2 0,5 1-1,4-2 1,1 0 0,0-1 0,0-1-1,-1 1 1,0-1 0,1 0 0</inkml:trace>
+  <inkml:trace contextRef="#ctx0" brushRef="#br5" timeOffset="-192252.46">24957 9895 13793,'6'-33'-563,"-1"0"0,0-1 1,3-2-1,-1 0 375,1 2 1,0-3-1,1 6-1,9-14 21,-17 19-497,-8 19 629,-15 17 1,-8 11-29,4-3 1,-3 3 0,-3 3-63,-4 2 0,-3 2 0,-2 2 0,-2 1-390,8-4 0,-1 1 1,-2 1-1,0-1 1,0 1-1,2-3 558,-3 0 0,1-1 0,1-2 0,-1 2 0,-2 1 46,6-1 0,-3 2 0,-1 0 1,0 1-1,2-1 0,3-2 1,5-3-25,-5 2 1,6-4 0,2 2 70,-5 8 1,3 2 0,18-11-118,28-20 0,20-12 0,8-4 0,-1 0 26,-3 4 0,2-2 1,3 0-1,0-2 1,0-1-224,-4-1 0,0-1 1,0-1-1,2 0 1,1-2-1,4-1 230,-11 6 0,2-1 0,2-2 1,2 1-1,0-1 0,1 0 0,0-1 1,0 2-1,-2-1 0,-2 1 0,-2 1-241,8-3 1,-3 0 0,-1 1 0,-1 0 0,0 1-1,2-1 1,2-1 218,-7 3 0,3-1 0,1 0 0,1 0 0,0-1 0,0 1 0,-1 1 1,-1 0-1,-3 2 0,-2 2 36,13-5 0,-4 1 0,-2 3 0,-2 2 1,-1 4 305,0 2 0,0 1 0,-6 5 1,-10 9-846,-10 17 1,-14 9 261,-11-2 0,-10 4 0,-11 3-65,6-15 1,-5 3 0,-6 1-1,-3 1 1,-2 0 0,-1 1-1,0-1 1,2-1 0,2-1 259,-3 3 0,0-1 0,1 0 0,1-1 0,-2 0 0,0 1 0,-1 1-6,3-3 0,-3 2 1,0 0-1,-2 1 1,1 0-1,2-1 1,1 0-1,3-1 1,4-2 178,-6 7 1,-1-1 0,5-1 0,10-1 0,13-4-320,26 15 1,23-9 190,0-22 0,10-8 1,5-5-1,2-2 159,-15-1 1,1-1 0,2-2-1,1-2 1,1-1 0,2-1 0,2-1-83,-10 2 1,2-1 0,2-1 0,1-1 0,1-1 0,0 0 0,1-1 0,-1 0 0,0 1 0,-1 0 0,-2 0-1,-1 1-252,3-1 0,-1 1 0,-2-1 0,0 1 0,-1 0 0,1 0 0,0-1 0,1 0 0,3 0 201,-1 0 0,2-2 0,1 0 0,2-1 0,0 1 1,0-1-1,-1 1 0,-1 1 0,-1 0 0,-4 3 0,-2 1-17,8-2 0,-4 3 0,-3 0 0,0 2 0,-2 2 0,0 0 1,16-3 0,1 0 1,-7 6-1,-14 12 422,-13 23 1,-19 9-556,-14-10 1,-12 3-1,-7 2 1,-4 0 42,4-7 0,-5 0 1,-4 1-1,-2 0 0,-2 1 1,-1 0-1,0 0 0,2-1-142,3-1 0,-1-1 0,1 1 0,-1 0 0,-1-1 0,0 1 0,0 0 0,0 0 0,-1-1 208,3-1 0,-2 0 0,-1 0 0,0 0 0,0 0 0,1 0 1,-1 0-1,2 0 0,0-1 0,2 1-12,-5 3 1,1 0 0,0 0-1,2 0 1,0-1 0,3 0-1,2-2 1,3-1 203,-7 6 0,3-3 0,6-1 0,7 1-346,-2 18 1,23-10 321,28-30 1,19-14 0,10-7-1,-2 1-47,-12 4 1,1-1 0,2-1 0,0-1 0,2-1 0,1-1-66,-6 2 1,2 0-1,0-1 1,2-1-1,0 0 1,0-1-1,0 1 1,1-1-2,-3 0 0,2 0 0,0-1 0,0 0 1,0 0-1,0 0 0,0 0 0,0 2 0,-1 0-3,3 0 0,0 1 0,-1 0 1,0 1-1,0 0 0,-1 1 1,-1 0-1,-1 1-51,6-2 0,0-2 0,-1 2 0,-2 2 0,-3 3 0,-2 5 8,4 5 1,1 4 0,-9 4 0,-16 8-370,-23 24 1,-25 10 301,4-22 1,-8 3 0,-4 2 0,-4 0-1,-2 1 1,1-2 126,6-5 0,-2 0 0,0-1 0,-2 1 0,0 0 0,-1 0 0,-1 2 0,0 1-139,5-4 0,-1 2 0,-1 1 0,-1 1 0,-1 0 0,1 1 0,0-1 0,1 0 0,1-1 0,1-1 0,2 0-7,-7 4 1,0 0 0,1-2 0,2 0 0,3 0 0,3 2 0,4 1-84,1 5 0,1 4 0,3 1 0,6-3 0,7-4 0,10-8-119,15-4 1,12-8 0,9-3 284,-6-7 1,6-2-1,6-2 1,3-2 0,4-1-1,0-1 1,1-1-1,-2-1 1,-3-1-95,2-1 0,-1-2 0,-1-1 0,0-2 0,1 0 0,1-1 0,2 1 0,2 1 140,-9 1 0,3 1 1,2 0-1,0 0 0,1-1 1,1 1-1,0 0 1,-1-1-1,0 1 0,-2 0 1,-1-1-1,-2 0 38,3-1 1,-2 0 0,-1-1 0,-1 0-1,-1 1 1,0 0 0,0 0 0,0 1 0,1 2-57,5 0 1,2 0-1,0 1 1,-1 1 0,0 1-1,-3 1 1,-4 1-1,-3 2-38,5 0 1,-5 1-1,-3 4 1,-5 9-103,-2 11 0,-2 9 0,-8 4 1,-11-2 94,-14-1 0,-14 0 1,-9 4-16,7-12 0,-5 3 0,-4 2 1,-4 2-1,-1 0 0,-2 0 1,1 0-1,0-2 0,3-3-37,-4 2 1,0-2-1,1-2 1,0 0-1,-2 0 1,0 2-1,-3 3-16,7-5 1,-3 3-1,-2 1 1,-1 2 0,0 0-1,0 0 1,0 0 0,2 0-1,2-1 1,2-2 0,3-1-41,-5 7 0,2-3 0,2-1 1,3 1-1,3 0 0,3 2-11,-2 8 1,1 5 0,4-1 0,10-4 0,14-9-226,16-9 0,12-8 1,10-4-1,3-1 415,-10-7 0,4-1 0,4-1 0,4-2 0,1-1 0,2-1 0,0-1 1,0 1-1,-2-1 0,-2 0-69,0 0 1,0 0 0,-2-1 0,0 0 0,1-1 0,0 0-1,2 0 1,1-1 0,2 0 15,-7 1 1,3-2-1,0 0 1,3 0 0,0-1-1,1 1 1,0-1 0,0 0-1,0 0 1,-1 0 0,0 1-1,-2 0 1,-2 0 0,-2 1 124,9-1 1,-2-1-1,-2 1 1,-1 0 0,-1 1-1,0 0 1,-1 2-1,1 0 1,1 2-126,0 1 1,2 2 0,1 0-1,0 1 1,-1 2 0,-2 0-1,-2 1 1,-4 0 0,-5 2-12,10 3 0,-4 0 0,-7 4 1,-9 9-35,-8 14 0,-9 10 0,-10 3 0,-10-4 182,-7-18 1,-7-3 0,-7-1 0,-3 0-1,-3 1 1,-1 3-130,10-6 1,-4 2 0,-1 2-1,-2 0 1,-1 1 0,-1 1-1,0 0 1,-1-1 0,1 1-1,1-2 1,2-1 0,1-1-53,-7 5 1,2-3-1,1 0 1,1-1 0,0 1-1,-1-1 1,1 2 0,-1 2-47,2-2 1,-2 2 0,-3 1-1,0 1 1,1 0 0,2 0-1,3-1 1,5-1 0,6-3 0,7-2-256,0 11 1,12-2 0,11-7-1,19-3 1,13-7-1,7-7 343,-7-8 1,5-4-1,3-4 1,2-3-1,0-3 1,-4 0-1,-3-3 1,-2-2-1,0-2 1,-1-2 0,1 0-1,1 0 1,0 0-1,-1 1 1,0 0-1,0-1 1,1 1-1,-1-1 1,0 1 0</inkml:trace>
+  <inkml:trace contextRef="#ctx0" brushRef="#br5" timeOffset="-191356.46">25831 11448 11471,'-12'-33'-525,"1"0"0,0 1 0,-4-1 1,-2 1-1,-2-1 495,1 0 0,-1-3 1,-2 2-1,-2 3-201,-7 1 1,-3 3-1,-2 4 224,-2 2 0,-3 4 0,1 6 83,1 9 1,0 6 0,0 0-7,3-2 0,-1 0 0,7 6 120,3 9 0,13 1-69,44 2 5,4-17 0,12-5 1,6-2-1,1-1-466,-11 0 0,1 0 1,2-2-1,1 0 0,2 0 1,2 0 377,-8 2 1,3 0 0,1 0-1,1-1 1,0 1 0,1-1-1,0 1 1,-2 0 0,0 0-22,0 0 1,0-1 0,0 1-1,-1-1 1,0 1 0,0 1 0,1 1-1,-1 2-27,1 1 0,1 0 1,1 1-1,-1 0 0,-1 3 1,-1 2-1,-4 2 1,-3 4-238,7 6 0,-4 4 0,-3 4 0,-5 4 0,-7 3 176,-8 4 0,-5 5 1,-5 4-1,-6 0 1,-3 0 76,-5-2 0,-5 0 0,-4 1 0,-3 0 0,-1 1 0,-3 1-225,1-5 1,-3 1-1,-3 1 1,-1 1-1,-1-1 1,1-1-1,2-1 1,3-2 177,-1 0 0,1-1 0,1-1 1,2-1-1,4 1 0,3 1-53,2 3 1,2 4-1,2 0 1,6-2-1,5-4 1,10-5-120,9-6 1,9-6-1,8-4 1,4-2-1,3-2 1,3 0 193,-13-5 1,3-1 0,3 0-1,2-2 1,2 0 0,1-1-1,1-1 1,0 1 0,0-2-1,0 1 1,-1 0 0,-2 0 6,1 0 0,0 0 1,-1-1-1,0 0 0,0 0 1,0 0-1,1-1 0,0 1 1,1-1-1,1-1 0,1 1 48,-6-1 1,3 0 0,0-1 0,1 0 0,1 0 0,1 0-1,0 0 1,0 0 0,0-1 0,-1 1 0,-1 0 0,-1 0-1,-1 0 1,-2 1 0,-2 0-22,11 0 1,-3 1-1,-2 0 1,-2 0-1,0 1 1,0-1-1,-1 2 1,1-1-1,1 2 51,-2 0 1,1-1 0,1 2 0,-1-1 0,1 1-1,-1 1 1,-1 0 0,-2 1 0,-1 1 0,-3 0-58,8 5 1,-2 1 0,-2 1 0,-2 2 0,-2 1 0,-2 3-102,4 6 0,-1 3 0,-3 2 0,-5 1 1,-8 2-47,-9 2 1,-6 2-1,-6 1 1,-5-2 135,-4 1 0,-5-1 0,-5 0 0,-7-2 0,-3-6 0,-7-2 0,-4 0 0,-2-1 0,-2 0 1,2 0-1,1-5 0,1 1 0,-1 0 0,1-1 0,0 1 0,-1-1 0,1 1 0</inkml:trace>
+  <inkml:trace contextRef="#ctx0" brushRef="#br5" timeOffset="-187505.46">21339 13811 26265,'2'-33'-820,"-1"0"1,1-1 0,-1-2 0,0 0-820,1-14 1,-4 6-1639,-22 8 2303,-6 45 0,-11 14 1088,7-5 0,-6 5 0,-3 2 0,-2 2 0,0 1-583,7-3 1,-2 1 0,-1 2 0,-1 0 0,0 1 0,-1-1 0,1 0 489,4-3 0,0 1 0,-1-1 0,1 0 0,-1 1 0,0-1 1,0 0-1,0 0-99,0 0 1,-1 1 0,0-1-1,0 0 1,0 0 0,2-1-1,2 0 1,2-2 503,-4 4 0,2-2 0,2 0 1,3-1-1,3-2 334,-21 18 1,26-14-626,50-27 0,21-13 104,-12 2 0,5-5 1,4-1-1,1-2 1,1 0-418,-10 4 0,1 0 0,0-1 1,2 0-1,0-1 0,1 0 0,2-1 203,-2 2 1,1-2 0,2-1-1,1 1 1,1-1 0,-1 0-1,-1 1 1,0 1 0,-2 1-176,2-1 0,0 2 0,-2 0 0,0 1 0,0 0 1,0 0-1,1-1 227,1 0 1,1-2-1,1-1 1,-1 2-1,-1 0 1,-3 3 0,-2 3 31,4-1 1,-1 2 0,-5 5-1,-8 8 506,-3 16 1,-15 8-384,-21 2 0,-17 6 0,-9 4 1,-2 1-295,9-10 0,-4 2 0,-3 1 0,-2 1 0,-2 1 0,0 0 0,-1 1 0,0-1-161,8-5 1,-1 0 0,-1 0 0,-1 1 0,0-1-1,0 1 1,-1 1 0,1-1 0,-1 0 0,0 0-1,1 1 170,0-3 1,1 1 0,-2 1 0,1-1 0,-1 0 0,0 1 0,1-1 0,0 0 0,0 1 0,2-2 0,0 1-1,2-1-46,-4 5 0,1-1 0,0 0 0,1 0 1,1 0-1,1-1 0,2 0 0,2-1 1,2 0 50,-8 9 1,1-1 0,4 0 0,7-3-1,8-1-678,7 20 1,22-12 777,15-29 1,12-9-1,8-6 1,-1-3 145,-9-1 1,2-4-1,1-2 1,2-2-1,0 0 1,1-1-90,-4 2 1,0 0 0,2-1-1,0 0 1,0-1 0,2-1-1,0-1 1,2 0-23,-6 0 0,1 0 0,2-1 1,0-1-1,1-1 0,0 0 0,0 0 1,0 1-1,-2-1 0,0 2 0,-2 0-3,2 0 1,-2 0 0,-1 0 0,-1 1-1,0 0 1,1 0 0,0 1 0,1-1-1,2 0 18,-1 1 1,2-1-1,3 0 1,0-1-1,0 1 1,1 0-1,-2 1 1,-1 1-1,-2 1 1,-4 1-1,-3 3 17,18-6 0,-6 3 0,-4 3 0,0 7-81,2 6 1,4 3 0,-10 6-1,-20 5-229,-27 6 1,-18 6 0,-10 3 0,-2 3 122,10-8 1,-3 2 0,-2 3-1,-3 0 1,-2 2 0,0 0-1,-1-1 1,-1 0 0,1-1-8,2-2 0,-1-1 0,-1 0 0,-1-1 0,0 1 1,0 0-1,-1-1 0,0 2 0,-1 0 0,0 0 36,3 0 0,-2 0 0,-1 1 0,0 0 0,-1 1 0,0 0 0,0 0 0,1-1 0,1 1 0,0-2 1,2 1-1,1-2-70,-2 2 0,0 0 0,1 0 0,0-2 0,2 1 0,1-1 0,1 0 0,1 0 0,2 0-28,-8 7 1,-1 0 0,2 0 0,5-1 0,7-2 0,13-3-228,14 18 0,22-12 150,10-21 1,13-11 0,7-7 378,-17-3 1,5-4-1,3-3 1,3-4 0,1 0-1,1-2 1,-1 0 0,0 0-182,-6 3 0,0-1 1,0 0-1,1-2 0,0 0 1,1 0-1,-1 0 0,1 0 1,0-1-1,1 1 73,-2 1 1,0-1 0,1 0-1,0 0 1,0 0 0,0 0-1,1-1 1,-1 1 0,1 0-1,0 0 1,-1-1 33,-2 2 0,1 0 0,0-1 0,1-1 0,0 1 0,-1 0 0,1 0 0,-2 1 0,-1 1 1,0 0-1,-3 2 0,-1 1 157,8-2 1,-3 1 0,-1 1-1,-2 2 1,0 0 0,-1 1-1,0 1-163,13-6 0,5-1 0,-4 2 1,-11 9-1,-18 13-254,-22 16 0,-15 13 0,-10 6 0,-3-2 186,3-10 1,-4 1 0,-4 0 0,-3 1 0,-1 0-1,-1 0 1,0 1-182,3-2 1,0 0 0,-2 1 0,-1-1 0,0 2 0,-1-1 0,-1 1 0,-1 1 0,-1-1 129,5-3 0,-2 1 0,-2 0 0,0 1 0,-1 0 0,0 0 0,0 0 0,0 0 0,1 0 0,0-1 0,2-1 0,2 0-128,-4 2 1,2-1-1,0 0 1,2-1-1,0 0 1,0-1-1,1 1 1,0 0-1,0 1 90,-4 3 0,-2 0 0,1 1 0,0 0 0,2 0 0,2-2 0,5 0 0,5-2-233,-5 10 1,5 0-1,8-5 1,17-7 37,21-6 1,18-8 0,3-7 544,-8-8 0,3-4 0,3-5 0,3-2 1,3-1-209,-9 3 0,3-2 0,3-2 0,1-1 0,2 0 0,0-1 1,1-1-1,-1 0 0,-1 1 0,-2-1-51,2-1 0,-2 0 1,0 0-1,-1-1 0,1 0 1,0 0-1,0-1 0,2 1 1,2-1 55,-5 3 0,2-1 0,0 0 1,2-1-1,1 1 0,0-1 0,-1 1 1,1 0-1,-1 0 0,-1 1 0,-1 1 1,-2 1 45,4-2 0,-1 1 0,-1 0 0,0 1 0,-1 1 0,-1 0 0,-1 1 1,0 0-1,-2 2 110,10-2 1,0-1 0,-2 3 0,-1 1 0,-4 2 0,-3 5-127,12 2 0,-6 6 0,-20 10-30,-28 5 0,-16 10 0,-10 5 0,-7 2 0,0 0 0,4-4-158,4-4 0,-1-2 0,-1-1 0,-1 1 0,-2 2 0,-2 1-7,5-3 0,-2 1 0,-3 2 1,-1 1-1,0 1 0,0-1 0,0 1 1,1-2-1,2-2 0,2-1-45,-7 4 0,2-3 0,2-1 1,1 0-1,1 1 0,1 3-171,-1 4 1,-2 4-1,2 0 1,4 0 0,6-3-1,9-5-208,8 11 0,18-7 202,12-12 0,13-3 0,7-5 0,0-7 345,-7-8 1,2-7 0,2-3 0,1-4-1,3 0 1,1 0 181,-5 3 0,3-1 0,2-1 0,1-1 0,1 0 0,0-1 0,-1 1 1,-1-1-1,-1 1-46,-1-1 0,0 0 0,-1-1 0,-1 0 0,0 1 0,0-1 0,0 1 0,0 1-1,5-1 0,1-1 0,1 0 1,-2 1-1,0 1 0,-4 3 0,-2 1 55,8-1 1,-1 1 0,-7 6-1,-9 9-160,-3 20 1,-16 11-161,-20 0 1,-13 6 0,-5 0 169,3-10 0,-3 1 0,-2 0 1,-2 0-1,1 0 43,-1 2 1,-1-1 0,-1 1 0,0 0 0,-1 1-356,2-3 1,-1 1 0,-1 1-1,1-1 1,2-1 0,3 0-50,-4 6 1,1-1 0,6-1-1,6 2-437,6 13 1,8 1 0,16-14 484,18-22 1,14-12-1,4-5 353,-7 0 0,3-3 1,2-3-1,3-3 1,0-3 84,-9-1 0,1-4 0,2-2 1,0-1-1,1-2 0,-1 0 1,0 0-1,0 2-96,-3 1 1,0 0-1,0-1 1,-1 1-1,1 0 1,0-1 0,1 0-1,1-1-6,-2 1 0,1-1 0,1 0 0,1-1 1,1 0-1,-2 0 0,1 0 0,-2 2 0,-1 0 1,-2 2-70,4-1 1,-2 1-1,0 1 1,-2 1-1,-1 1 1,0 0-1,0 0 5,11-6 1,3-2 0,-3 2 0,-7 8-1,-12 12-112,-9 18 1,-14 7 0,-30 8-1,-18 2 1,9-9 0,0 0 0,0 0-1,-1 0 1</inkml:trace>
+  <inkml:trace contextRef="#ctx0" brushRef="#br5" timeOffset="-186186.46">25523 10478 16908,'-32'-13'-397,"-1"0"1,-3 8 0,-5 4-1,-1 3 620,1 4 1,-1 3 0,-2 3 0,-1 2-364,2 1 1,-2 2 0,0 1 0,0 2 0,0 2 85,8-1 1,-1 2 0,1 1 0,1 1-1,1 0 1,1 0-82,-1 4 1,2 0 0,1 0 0,2 0-1,2-1 360,-10 6 1,4-1 0,15-1-618,22 10 0,18-9 342,15-27 1,13-14 0,5-2-22,-11 6 1,2-1 0,3 0 0,2-2 0,2-3 152,-9 0 0,3-3 1,0-1-1,2-1 1,1-1-1,0 1 1,-1 0-1,0 1-224,0 1 0,0 1 0,0-1 1,0 1-1,0 0 0,0 1 1,0-1-1,-1 1 198,0 0 0,0-1 0,0 0 0,-1 1 0,1 0 0,-2 1 0,0 2 0,-3 3 2,6-1 1,0 0 0,-1 2 0,-2 4 0,-5 4 0,-6 8-284,0 12 1,-5 8 0,-8 7-1,-8 1 167,-12 2 0,-9 4 1,-7 2-1,-3 2 1,-2-1 13,2-8 1,-2 0-1,-2 0 1,-2 0-1,-2 1 1,-1 1-1,-1 0-156,2-5 1,-2 1 0,-2 1 0,-1 0 0,-1 0 0,0 1 0,0-1 0,2-1 0,1-1 0,2-1 82,-3 5 1,1-2 0,1-1 0,2 0 0,0-1 0,2 1 0,1 0-22,-4 7 0,-2 1 0,1 0 0,5-1 0,9-2 0,11-5-184,18 4 0,15-4 0,8-4 1,4-7 296,-5-11 0,4-5 0,4-3 1,2-3-1,1-1 0,0 1 146,-5-1 1,0-2-1,1 0 1,1-1-1,1 0 1,1-2 0,1 1-1,2-1-22,-6-1 0,2 0 0,1-1 0,1-1 1,0 1-1,1-1 0,0 0 0,0-1 1,0 1-1,-2 0 0,0 0-1,0 0 0,-1 0 0,0 0 0,-1-1 0,0 1 0,0 0 0,0 0 0,0 0 0,1 1 0,0 0-57,0 0 0,2 0 0,0 0 0,0 0 0,0 1 0,0 0 0,-1 2 0,-1 0 0,0 1 0,-2 2 6,4 1 0,0 0 0,1 1 0,-2 2 0,-2 1 0,-2 3 0,-4 2 1,-4 3-75,4 10 1,-4 3 0,-5 5 0,-5 2 0,-6 3 59,-8-1 1,-5 4 0,-4 2-1,-5 2 1,-4 0 0,-4-2-32,-3-5 1,-4 1-1,-5-1 1,-3 1-1,-2-1 1,-1 0-1,0 0 1,0 0-90,0-3 1,0 0 0,-2 0 0,0 0 0,-2 0-1,1-1 1,-1 1 0,1-2 0,0 1 55,0-2 1,0-1 0,-1 1 0,0-2 0,0 1 0,1 0 0,2 0 0,2 1 0,2 0-190,-2 6 1,0 2-1,1 0 1,4 0 0,3-1-1,6 0 1,7-3-118,9 12 0,10-1 1,9-3-1,6-3 193,-2-12 1,5-2 0,4-2 0,5-2 0,3-3 0,4-3 184,-8-8 0,3-2 0,4-2 0,2-2 0,3-2 0,1-1 0,2-1 0,0 0 0,0 0 0,-1-1 0,0 1 0,-2 1-25,-3 0 0,-1 0 0,0-1 1,0 0-1,0 0 0,1 0 1,-1-1-1,1 1 0,0 0 0,0-1 1,1 1-1,-1 0 0,2 1-9,-4-1 1,2 1 0,0 0-1,1 0 1,1 0 0,-1 0 0,1 0-1,-1 0 1,1 0 0,-2 0 0,0 1-1,-1-1 1,-1 0 0,-1 1 0,-2-1-37,12 1 1,-1-1 0,-1 0 0,-2 0 0,-1 1 0,-1 0 0,-1 2 0,-1 1 0,-2 2-1,3 2 1,0 2 0,-2 2 0,-1 1 0,-3 1 0,-2 0 0,-4 0 0,-1 7 0,0 1-1,0-1 1,0 0 0</inkml:trace>
+  <inkml:trace contextRef="#ctx0" brushRef="#br0" timeOffset="-148240.46">9340 12771 6993,'-19'-10'1439,"1"2"-1259,11 8 0,2-8 180,5 6 269,0-6 1,0 8 180,0 0-91,0-8-269,0 6 0,0-5-180,0 7-540,0 0 450,11 15-450,13 13 764,1 6 1,5 8-540,-7-12 0,2 1 0,0 1 0,-1-1-45,1 0 0,-2-1 0,0 1 60,6 6 0,-1 1 0,-4-7-149,1-4-91,-13-9-180,-6-10-270,-6-8-2068,0-8 2788,0 6 0,-17 2 0,-3 10 0</inkml:trace>
+  <inkml:trace contextRef="#ctx0" brushRef="#br0" timeOffset="-147789.46">9353 13282 5914,'-25'0'2788,"11"0"-1619,3 0 271,28-23-676,-1 6 1,5-4-376,5-9 1,3-6 0,1 0-698,-2 5 0,1 0 0,0-3 375,-2 1 1,2-2 0,-1-1-1,-4 3-247,4-11 0,-3 4-608,-3 7 0,-5 5-1820,-11 5-669,-12 38 3264,5-11 0,-15 28 0,2-13 1</inkml:trace>
+  <inkml:trace contextRef="#ctx0" brushRef="#br6" timeOffset="-138860.46">2293 16792 21155,'0'-41'-1101,"13"21"1,5 1 1893,3-8 1,5 1-171,3 10 0,5 2 0,-1 1-535,13-6 1,1 3-30,1 2 1,0 0-1,-5-6 1,0-1 0,-3 2-1,0 1 1</inkml:trace>
+  <inkml:trace contextRef="#ctx0" brushRef="#br6" timeOffset="-138444.46">3140 16369 13112,'20'-27'168,"0"0"0,0 1 0,13-11 0,5 3-4,-3 11 0,3 3 0,1 2-634,-3 4 0,1 3 0,1-1 379,9-5 1,1 0 0,-3 2 164,-3 4 1,0 0 4,-5-3 1,2-4 0,-1 1 39,4-1 0,0-1 67,-5 2 1,2-1 0,0 0 53,4 1 1,1 0 0,-1-2-171,-4 0 0,-1-2 0,2 1 12,-4 2 0,2 1 0,-1-1 0,-1 0-213,5-3 0,-2-1 1,1 0 223,-6 4 1,0-1-1,1-1 1,-1 1-29,0-1 1,-1 0 0,0 1-1,0 0-60,6-4 0,-1 2 0,1-2-23,-3 1 0,0-3 0,1 1 1,-3 3-59,1 1 0,-2 2 0,2-1 68,1-1 0,3-1 1,0-1-1,0 1 0,-1-1 1,-1 0-1,1 0 0,1-1 1,-1 2-1,0-1 1,1 1-1,-1-1 0,0 1 1</inkml:trace>
+  <inkml:trace contextRef="#ctx0" brushRef="#br6" timeOffset="-138291.46">6030 14834 11312,'21'-28'159,"1"-1"0,-1 0 1,6-1-1,2 0 0,3 0-101,-2 5 1,3-1 0,0 2-1,1 1-758,5-3 1,0 2 0,4 1 530,1 3 0,4 0 0,-1 2 1,-5 2 174,-9 5 0,-3 2 1,2-2-1,10-5 0,4-3 1,1 0-1,-5 0 0,-3 0 1,0 0-1,-1 0 0</inkml:trace>
+  <inkml:trace contextRef="#ctx0" brushRef="#br6" timeOffset="-137935.46">7777 13882 9726,'38'-26'-82,"0"1"0,-8 5 1,2-1-1,2-1 125,-1 2 1,3 0-1,1 0 1,-1 0-231,-2 0 0,0-1 0,1 1 0,0 0 145,1 2 1,0 1 0,1-1-1,-2 1 127,9-6 0,-2-1 0,2 2-137,-7 8 1,1 0-1,0 1 1,1-1-346,2-2 1,2-2 0,-1 0-1,-1 2 452,-4 2 0,-2 2 0,1-1 0,4-3-53,0-1 0,3-3 0,3-2 0,-1 0 1,-1 0-1,-4 1 19,4-2 0,-4 1 0,-1 0 0,4-3-90,-5 3 0,3-3 0,0 0 0,1-1 0,-3 2 0,-2 1 255,-1 1 1,-3 2 0,0 1 0,0-2-58,5-4 1,1-1-1,-1 0 1,0 3-462,-4 5 1,0 1-1,-1 2 1,1-2 159,4-1 1,0 0 0,0 0 0,-2 2 171,2-1 0,-1 3 0,-2 2 0,3 1 0,-3 4 0,13-1 0</inkml:trace>
+  <inkml:trace contextRef="#ctx0" brushRef="#br6" timeOffset="-137210.46">2910 17339 14810,'-15'-33'-2863,"11"19"533,35-10 2630,-11 24 0,7-8 0,9-6 0,-3-3 0,0-7 0,0-1 0</inkml:trace>
+  <inkml:trace contextRef="#ctx0" brushRef="#br6" timeOffset="-137035.46">3722 16739 15673,'26'-26'352,"0"-1"1,0 0 0,10 0 0,2 0 0,0 3-169,-4 2 1,0 1 0,2 1-550,-2 3 1,2 1 0,-1 1 0,-3 2 0,4-3 0,-3 3 0,-1 1 0,0 0 0</inkml:trace>
+  <inkml:trace contextRef="#ctx0" brushRef="#br6" timeOffset="-136852.46">5501 15610 13381,'27'-28'139,"0"-1"0,1 0 0,2 4 1,1 0-1,4 1-231,1 0 0,3-1 1,1 1-1,-3 3-18,-3 1 1,-1 3 0,2-3-1,2-3 1,3-1 0,0-2 0,-4 1-1,-1-3 1,-1 0 0,1 0-1</inkml:trace>
+  <inkml:trace contextRef="#ctx0" brushRef="#br6" timeOffset="-136460.46">7150 14446 12008,'26'-31'234,"-1"0"1,1-1 0,3-1 0,2 0-1,3-1-160,-1 4 1,4-2 0,1 1 0,0 1-527,-5 6 0,0 1 0,1 0 0,0 0 0,1 0 311,2-1 1,1 0 0,0 0-1,1 0 1,0-1-221,-4 2 1,0 0 0,1 0-1,-1 0 1,1-1 0,0 0 344,0 0 0,0-1 0,0 0 0,0-1 0,0 0 0,1 0 40,-1 0 1,0-1 0,1 0 0,0 0-1,-1 0 1,-1 1 0,-1 1 21,3-2 0,-1 1 0,-1 0 0,-1 1 0,2-2-25,3-3 0,1 0 0,-1-1 0,-1 1 1,-3 2 283,2-3 1,-3 1 0,3-1-190,-3 4 0,4-2 0,1-1 0,0 0 0,-2 1-38,1-2 1,-2 1 0,1 0-1,1-1-360,-5 7 1,1-2-1,2 1 1,-1-1-1,-1 2 1,-2 2 306,3 0 0,-4 2 0,1 0 1,3-2-40,4-3 0,3-3 0,1-1 0,0 1 0,-2 1 1,-6 5-1,-1 2 0,-1 0 0,2-1 0,1-2 1,6-5-1,-1 1 0,1-1 0,-1 0 0,1 0 1,-1 1-1</inkml:trace>
+  <inkml:trace contextRef="#ctx0" brushRef="#br6" timeOffset="-136285.46">10977 11571 822,'8'-28'667,"0"-1"1,19-6 45,-8 11 0,6-3 0,1 4-1158,4 7 0,3 5 0,-1 0 456,10-2 0,2-1 0,-4-5 1,1-3-1,-2 0 0,-9 3 0,1-1 1,-1 0-1</inkml:trace>
+  <inkml:trace contextRef="#ctx0" brushRef="#br6" timeOffset="-135627.46">2699 15769 9014,'0'-17'-117,"0"-1"-371,15 0 331,7 2 0,7-1 172,10 2 1,7 1-1,-1-2 1,-3-4-1,-1-1 1,3-1-1,-1 5 1,-1-1-1,1 0 1,0 1-1</inkml:trace>
+  <inkml:trace contextRef="#ctx0" brushRef="#br6" timeOffset="-135427.46">5340 14570 9014,'39'-20'7,"-1"0"1,1 0 0,0 0 0,-1 0 0,5-3 0,-1 1 0,1 1 0,3 1-7,-5 5 1,3 1 0,2 1 0,0 1 0,-2 0 0,-5 1 0,10-3 0,-6 0 0,3 1-1,-3 1 1,-1-1 0,1 1 0,0 0 0</inkml:trace>
+  <inkml:trace contextRef="#ctx0" brushRef="#br6" timeOffset="-135276.46">7482 13741 4528,'37'-26'-36,"-4"10"0,7-1 0,1-1 193,-9 3 0,1-2 1,2 1-1,3 0-263,4-1 1,5 1 0,1-1 0,1 2 0,-3-1 105,-7 3 1,0 1 0,-1 0 0,0 0 0,0-1 0,1-2 0,1 1-1,-1-2 1,-1 1 0,-2 0 0,-1-1 0,0 0 0,1 0 0,-1-1 0</inkml:trace>
+  <inkml:trace contextRef="#ctx0" brushRef="#br6" timeOffset="-135085.46">10103 12735 9001,'33'-19'-28,"1"-1"0,0 0 0,-1 1 0,6-2 0,1 1 0,2 0 0,3 1-37,-8 4 1,2 1 0,1 1-1,1 0 1,1 0 0,-1 0-114,2 0 0,0 0 1,1-1-1,0 1 1,-1 1-1,0-1 1,5-2-1,0 1 1,0 0-1,-1 0 1,0 0-1,-1 0 1,0 0-1,0 0 1,0 0-1,0 0 1</inkml:trace>
+  <inkml:trace contextRef="#ctx0" brushRef="#br0" timeOffset="-134910.46">12528 12012 6971,'34'-25'442,"0"0"0,0 1 1,-1 3-1,0 1 0,4 0-452,-4 2 1,4 0-1,2-1 1,0 2 0,-1 3-598,5 1 1,-1 4 0,1 1 0,-2 0 604,8-1 1,-2 0-1,-2 4 1,-5 3-1,-2 3 1,-4 0-1,-4-1 1,0 0-1</inkml:trace>
+  <inkml:trace contextRef="#ctx0" brushRef="#br0" timeOffset="-104394.46">23923 13529 7173,'7'0'-720,"-2"0"1260,1-8-270,-5 6 90,4-13-180,-5 13 359,0-14-179,0 14 0,0-6-180,0 0-360,-5 6 0,-2-13 0,-10 13 90,-8-6 90,-1 8 0,-10 6 0,-2 4 180,-3 1-120,9 3 0,-5 3 0,4 1 30,4 0 0,3 3 89,-4 9 1,-2 5 0,5 0-90,4 4 0,4 1-30,2-7 0,2 3 0,7-1 30,15 10 0,8-4-45,-8-16 0,4-1-105,12 2 0,8 1 0,0-8 195,-4-9 0,3-4-45,7 2 0,5-2 0,-3-4 45,-5-8 0,0-8-105,3-8 0,2-8 0,-6 0 60,-8 0 0,-4-3-120,0-2 0,0-4 0,-6 3-15,-7 3 0,-9 2 180,-20-10 0,-9 5-135,9 19 0,-4 3 0,-19-5 0,-1 7-135,16 10 0,2 4-180,-4-4 0,2 4-225,2 7 1,3 5 89,-14 16 495,21 5 0,5 6 90,7-5 0,3 2 89,-1 10 1,6 0-135,11-2 0,6-3 45,-2-13 0,5-4 90,14 2 0,4-14-105,-11-23 0,1-10 0,0 0 60,9-5 0,-1-5-173,-7-4 1,-1-6 0,-5-1-68,-9 3 0,-4-2 0,-3 1-30,-3-10 0,-8 2 135,-6 0 0,-13 6-105,-6 22 0,-8 5 0,0 9-180,1 9 0,0 8 1,0 0-1,1-4 0,-1 1 0,3 6 15,2 12 0,1 8 0,3 3 1,5-3-5,7-2 1,5-1 0,1 0 198,-3 9 0,1 0 1,8-2 343,17 7 1,10-10-270,0-18 0,5-8 135,15-6 0,0-10-45,-9-17 0,-3-9-15,-8 6 0,1-2 0,-4-4-120,-3-9 0,-5-4 0,-4-1-51,-4 5 0,-3 0 1,-4 0-70,-3 2 0,-3 1 0,-7 5 152,-21-3 1,-7 17-33,-5 28 0,0 13 45,1-5 0,4 9-203,17 2 1,1 8 0,5 1 0,4-3 112,7 6 0,7 1 178,0 1 0,2 3 0,8-8-133,12-11 0,6-5 70,9 7 1,2-11 109,-8-23 0,0-12 89,0-6 1,2-7 0,-5-1-270,-5-1 0,-4-4-106,-4 1 0,-1-6 0,-2-1 1,-6 5 15,-9-8 0,-7 4 30,1 6 0,-4 0 0,-5 7-141,-24 1 0,-8 16 201,13 16 0,-1 8 0,0 5-30,-3 4 0,1 6 0,5 6-15,10-1 0,3 4 0,4 3 0,5-3-13,6 2 1,6-1 0,5-1 57,5 0 0,5-1 0,6-6-30,11-6 0,7-7 0,0-7 30,-1-9 0,1-7 0,-1-2 30,-1 1 0,-1-2 0,-3-7 0,0-17 0,-4-10 0,-7 2 60,-4 0 0,-9-1 30,-9 0 0,-6-3 0,-5 7 14,-10 10 1,-7 7-45,-6 7 0,-6 4 0,2 8-180,-4 15 0,2 10 72,6-3 1,1 5 0,4 2-193,9 1 0,5 3 0,7 0-15,10 15 0,11-3 491,1-13 0,9-6-236,8-9 0,8-7 0,-2-5 105,1-8 0,-1-8-45,7-6 0,-5-7 89,-17 1 1,-7-5 83,-7-4 1,-10 0-174,-8 8 0,-9 5-1,-18 6 1,-6 10-225,0 14 1,0 10 170,13-4 1,-1 4-1,6 3-351,-3 21 0,14 1 315,20-14 0,9-4 45,7-1 0,5-6 135,9-6 0,2-11 0,4-17 0,-5-9-135,-14 9 0,-5-3 0,-1-15 0,-11-3-45,-22 7 0,-9 5 180,-1 7 0,-3 5-91,-8 4 1,0 8-180,10 10 1,5 7-91,6 4 0,8 4-45,11 5 0,10 0 135,7-4 0,5-5 180,5 1 0,4-8 135,3-17 0,-1-10-90,-12-4 0,-3-5-90,-1-8 0,-10-3 0,-24-3 0,-11 3-1,8 15 1,-5 5 45,-19 3 0,-1 12-45,14 17 0,5 7-315,3 1 1,8 3 44,15 9 0,11-1 225,3-13 0,7-3 45,8 0 0,4-9 359,5-24 1,-4-9-360,-14 4 0,-3-4 90,4-20 0,-9-4-90,-14 16 0,-7 1-135,-9-5 0,-6 3 90,0 11 0,-4 7 90,-11 6 0,-1 10-405,6 13 0,5 9 0,4 4 1,6 3 179,5-2 0,11-2-180,16-5 0,8-6 585,2-8 0,2-5 0,4-6 0,-1-8 179,-1-10 1,-7-7-180,-12-1 0,-7-5-90,1-11 0,-11-2-510,-15 13 0,-10 1 0,2 3 240,3-2 0,-4 7 30,-6 10 0,-7 6 0,7 8-120,10 13 1,4 10-1,5 2 0,1 6 0,7 1 120,7-1 0,6 1 0,5-1 30,7-1 0,5-1 0,4-2-30,0-2 0,4-2 0,2-9 330,18-15 0,0-8-180,-19 11 0,-3-8 149,-4-17 1,-3-11 0,-7-1 300,-12-8 0,-7-2-570,6 9 0,0-2 0,-4 2 60,-7-1 0,-4 2 0,-9 7-150,-18 8 0,-11 11 0,5 4 30,9 5 0,0 6-164,2 1 0,-5 2 1,3 3-1,9 5-106,7 18 1,12 7 224,3 5 0,10 0 225,15-6 0,9-4 45,6-5 0,7-7-105,2-15 0,5-6 0,-3-7 150,-2-8 0,-3-7-121,-1 4 1,2-2 0,-11-7 270,-15-14 0,-10-8 0,-2 3-330,4 2 0,-8 2-90,-12-4 0,-11-2 0,-2 8-45,-9 6 0,-6 9-15,0 7 0,-6 4 0,4 8-56,11 7 1,2 6-1,3 3 116,-3 4 0,2 5 1,9 4 59,10 4 0,7 4 0,6-1 60,6-2 0,5-1 0,3-2-75,7 8 0,8-6 75,0-10 0,6-4 0,0-10 89,-1-13 1,1-8 0,-2-1-120,10 3 0,-3-7 180,-10-13 0,-3-9 0,-10 0-30,-16 6 0,-8-1 0,-2 1-90,0-2 0,-4 0 0,-4 3 36,-5 1 1,-5 2 0,-5 11-247,-9 13 0,-6 12 0,3 4-30,10 2 0,2 4 0,2 4-87,-4 11 1,2 5-1,9 0 312,12 9 0,12-2 0,9-2 0,9-5 395,18-11 0,5-7-305,-4-7 0,0-7-45,7-8 0,-2-11 45,-8-16 0,-7-9-90,-10-5 0,-7-4-77,-9 12 0,-4-1 0,-4 2-193,-10-9 1,-11 8-76,-4 20 0,-7 7 0,0 6 30,4 9 0,0 7 1,1 4 209,-6 6 0,1 5 0,6 3 30,8-2 0,4 2 0,8 1 179,11 3 1,9 1 0,1-5 30,3-4 0,5-5-90,11-2 0,8-2 0,-2-7 0,1-10 0,0-8-45,8-2 0,-4-9 135,-7-17 0,-8-9-120,-14 13 0,-3-3 0,-4-1-34,-3-1 0,-3 0 1,-5 1-237,-8 0 0,-4 2 0,-5 5-60,-16-2 1,-6 12 89,13 17 0,-3 6 0,3 7 30,-2 13 0,2 10 0,6 3-184,6 1 0,5 2 0,4 3 394,3 5 0,4 1 0,10-2 120,11-9 0,7-4 0,2-4-45,6 2 0,6-9 73,2-11 0,5-6 0,-3-11-88,-7-16 0,-3-12 0,-2 0-30,0 3 0,-1 0 0,-3-3 29,0-9 1,-4-2 0,-7-3 30,-8-2 0,-6-1 0,-7 3 0,-6 13 0,-4 2 0,-3 3-210,-5-1 0,-4 3 0,-3 10-390,-12 18 0,-5 13 0,3 6 420,3 4 0,2 7 0,6 5 30,8-2 0,2 6 0,7-1 0,14-9 0,22-7 0,14-7 0,7-7 0,0 1 0,1-1 0</inkml:trace>
+  <inkml:trace contextRef="#ctx0" brushRef="#br0" timeOffset="-56577.46">20256 11218 6993,'-25'10'3276,"6"-2"-1875,7-8-321,1 0-361,10 0 1,12 0-450,20-8-945,1 7 1,3 0-451,0-3 1,1 0-181,-1 8 1,-1 0 1304,8-2 0,-52 22 0,-18-5 0</inkml:trace>
+  <inkml:trace contextRef="#ctx0" brushRef="#br0" timeOffset="-56322.46">20231 11412 7533,'-31'-7'3276,"12"5"0,19-6-1013,24 8-2758,5 3 0,3 2-584,16-3 1079,-1 7 0,-1-3 0,-3-20 0,-11 9 0,0-1 0</inkml:trace>
+  <inkml:trace contextRef="#ctx0" brushRef="#br0" timeOffset="-52688.46">20342 11271 7892,'-19'8'180,"-5"14"0,-2 5-90,4-3 0,1 3-120,2 1 0,-1 2 0,3-2 30,-3 2 0,10-5 450,21-5-180,11-32-150,4-12 0,5-10 0,-2 0 29,-8 5 1,-3 0 0,2-1-221,2-2 0,2-2 0,-1 0 0,-3 4 71,2-3 0,-12 8-450,-26 9 270,-8 41 0,-5 20 112,5-14 1,-2 3 0,0 1 0,3-1 67,-1 5 0,4-1 0,3 0 0,2-1 0,4-1 0,8-7-90,25 5 120,4-42 0,8-15 0,-1-1 59,-5 2 1,-2-1 0,1-3-78,0-2 1,1-4 0,-2 0 0,-2 1 137,-1-1 0,-3 1 0,-7 3 828,-18-17-844,-16 55 1,-9 14-15,-6 4 0,-3 7 0,3 2-345,4 2 1,4 3 0,0-2 164,-2-2 0,1-1 1,12-6-211,21 4 270,13-49 0,6-15-45,6-2 0,0-6-131,-5-1 0,-1-4 0,-4 2 221,0-4 0,-11 4 224,-15 12 1,-7 9-540,-25 23 180,4 22 0,3 10-90,12-7 1,8-1-1460,14 0 1,7-5 1459,9-13 0,17-18 0,4-10 0,-6-5 0,0-1 1</inkml:trace>
+  <inkml:trace contextRef="#ctx0" brushRef="#br0" timeOffset="-25573.46">24981 5944 5824,'14'0'0,"-3"0"90,-11 0-90,0-8-90,0 7 90,0-7 0,0 0 0,0 6 180,5-6 179,-3 8 181,3 0-90,-5 0 269,0-8 1,0 6-270,6-6-180,-5 1 359,5 5-449,-6-6-180,0 8 270,0 0 90,-6 0 179,5 8-269,-5 17 0,6-1 0,0 5-240,0 9 0,0 6 0,0 1-250,0-5 1,0 1-1,0 1 1,0 0 398,0 2 1,0 0 0,0 0 0,0-2 60,0 5 0,0-2 0,0-5-150,0-3 0,0-8 0,0-11-90,0-26-270,0-4 180,0-5-90,0 9 609,0 8-2228,0 0 899,0-8 1,-5 6 899,3-14 0,2-25 0,4 13 0,-1-1 0</inkml:trace>
+  <inkml:trace contextRef="#ctx0" brushRef="#br0" timeOffset="-24339.46">25031 5927 6543,'7'-10'450,"-2"2"-180,-5 8-90,-5 0 90,-2 0 89,0 0 361,-4 0-90,9 0-1,-3 0 91,5-8-270,0-2-360,5 1-1,8-7 451,33 14-495,-12 1 0,2 2-45,2 5 0,2 6-60,-8 0 0,1 2 0,-4 3 240,-2 4 0,-6 5 90,0 11 0,-12 2-180,-19-6 0,-10-1-1,2-3 1,-4 1 0,-2-3 0,0-4 0,-2-2 0,-1 0 60,-4 1 0,-2-1 0,3-3-105,2-3 0,1-3-360,-1-5 0,3-6-2023,7-11 539,12 0 1799,18 2 0,7 24 0,12 4 0</inkml:trace>
+  <inkml:trace contextRef="#ctx0" brushRef="#br0" timeOffset="-20848.46">25720 5874 7892,'0'-10'180,"0"2"0,0 8-180,-5-8 0,3 6-90,-9-6 270,4 8 90,-11 8 0,-1 2 0,-5 23-90,-1-3-1,12 1 1,2 4-45,0-4 0,2 3-75,3 8 0,3 5 0,0-1-323,2-2 1,1-1 0,1 2 307,1-8 0,0 1 0,2 0 0,0 0 255,4 10 0,3-1 0,0-5-153,5-2 0,1-4-192,1 0 0,1-5 855,11-6-990,-10-15-180,-8-2-989,-7-8 870,-5 0-421,0 0 918,0-8 0,0-10 0,0-9 0</inkml:trace>
+  <inkml:trace contextRef="#ctx0" brushRef="#br0" timeOffset="-14861.46">25547 6033 7533,'-22'-14'359,"0"0"1,-8-4 90,13-5-540,10 19-180,-11-12-45,-5 34 1,-5 11 89,-1-9 0,-3 3-92,3 6 1,-4 6 0,-1 1 0,1-2 428,3-8 1,0-2-1,0 0 1,2 0 216,-5 9 1,2 0 0,3-9 480,-10-8-765,59-37 0,18-13-90,-15 10 0,2-2 0,2-2 0,1 0-191,2 0 0,2-1 1,1 0-1,1 0 0,-3 3 213,3 0 1,-2 1 0,0 2-1,-1-1-37,7-11 0,0 1 1,-9 13-121,-7 19 135,-42 19 0,-15 9 284,7-6 1,-1 2 0,-2 2-215,-2 2 1,-2 3 0,-1 0 0,2-1-56,-7 4 0,2-2 1,1 0-1,3-2 0,1-1 0,7-1-195,4-1 0,13-7 135,56-26 67,-18-5 1,5-6-1,2-3 1,1-1-153,-3 2 0,2-3 1,1 0-1,-1-1 1,0 0 174,0-1 0,1 0 0,-1 0 0,-1 0 0,-3 1-120,15-16 0,-4 1 0,-22 24-50,-25 30 289,-13 8 1,-12 7 0,-4 4-108,5-4 1,-4 5 0,-3 2 0,-2 2 0,1 1 0,0-2 0,3-3-62,-2 5 0,2-3 1,1 0-1,0 0 1,-2 2 63,-1-3 0,-3 3 0,0 0 0,2-1 0,5-3 0,9-5-240,0 12 0,16-13 315,31-20-90,2-16 0,6-8 0,4-3 108,-4 2 0,4-2 1,2-1-1,-1-1 0,-1 2-131,2-4 1,-2 1 0,1 0 0,0 0-23,6 0 0,1-2 0,-2 4 0,-5 8 133,4 6 0,-13 12 452,-29 41-271,-14-8 1,-9 7 0,0-4-240,4-10 0,0-2 0,-1 1 638,-4 6 0,0 3 0,7-8-1748,10 4 1530,33-36-405,13-15 0,6-6 45,-14 6 0,1-1 0,1 0-120,3 0 0,1 1 0,-3 1-105,8-5 0,-10 13 1311,-18 37-952,-26-11 1,-10 1-195,2 4 0,-3 3 0,-3-2 90,-7-1 0,-3-1 0,2-3 150,-1 2 0,2-7-360,2-10 0,9-12-90,26-16 0,15-13 0,3-2 0,-3 0 0,3-4 0,3-1 1,1 0-161,0 3 1,3 0 0,1-1-1,0 0 1,-2-2 279,-5 2 0,0-1 0,0-2 0,-2 1 0,-2 2 0,-2 5 120,5-7 0,-4 5 0,-10 2-323,-16-16 0,-18 16 281,-1 35 0,-9 14 0,-5 9 0,-1 2 0,2-3 36,-1-2 0,0 1 0,0 0 0,0 1 0,0 0 35,-3 2 1,0 1 0,0 0 0,2-2 0,4-3 330,-4 3 0,4-3 0,8-10-510,4-14 0,39-20 0,17-12-45,-3 3 0,5-4 0,3-1 0,-1 3 207,-5 7 0,-1 2 0,0 1 0,1-2-275,3-7 1,1-4 0,-1 4 0,-6 12 667,8 13-330,-44 27 0,-13 11-75,2-4 0,-5 2 0,-1 3 142,-3 6 0,-3 4 1,0 0-1,3-5-232,6-7 0,2-4 0,-1 2-180,-12 12 0,0 1 0,21-18-59,36-29 359,-3-7 0,2-7-1,7-12 1,1-2-45,-2 7 0,-4 1 855,-10-15-691,-31 51 1,-14 17 0,-3 4-84,8-2 0,-3 4 0,-1 3 0,1 1 0,-1-1-782,0 1 1,-1 0-1,0 0 1,2 1 0,1-1 440,0 0 0,-2 0 1,2 0-1,8-2 0,13-6-862,21 8 1,14-13 581,15-31 1,10-15 494,-13 10 0,7-3 0,2 0 0,-5 2 0,-10 5 0,14 4 0,-21 8 0,0 0 0</inkml:trace>
 </inkml:ink>
 </file>
 
@@ -2402,100 +1954,100 @@
   <inkml:trace contextRef="#ctx0" brushRef="#br0" timeOffset="213116">9291 13494 7533,'-12'-45'3276,"-6"9"-2325,5 11-1131,-16 15-449,-14 10 269,10 16 0,-2 9 330,3 3 0,0 5 0,3 2-20,3 1 0,4 3 0,3 0 349,3 2 1,4 2 0,10-4-435,14 5 0,14-9-180,17-15 1,7-13 134,-15-10 0,2-6 0,-1-4 120,4-7 0,0-6 0,-4-1 90,-8 3 0,-2-1 0,-3-2 30,2-6 0,-3-3 0,-5 5 300,-2-10 180,-11 31-451,-6 30 1,-4 15-60,2-4 0,0 4 0,2-1-210,3 13 1,3-2-91,-3-8 0,4-6-90,13-5 630,-4-50 435,0-1 0,1-4-481,-3-8 1,2-1-90,2 0 0,5 6-225,8 11 0,6 6-90,4 5 1,4 5 179,-5 3 0,2 3 0,0 0 179,-3 0 1,-1 0 0,-1-3 899,14-10 1,-6-8-361,-17-8 1,-9-6-810,-7-4 0,-9-1 270,-14-5 0,-10 10-1169,-23 22 1213,16 21 1,4 11-345,8 9 0,6 8 1,5 1-481,6 4 0,6 1 1,6 0-221,4-8 1,5 0 0,4-1 0,2-3 766,1-4 0,3-2 0,3-4 0,1-4 0,6-6 0,4-5 0,0-4 0,-1-3 0,-3-7 0,0 0 0,0 0 0,0 0 0</inkml:trace>
   <inkml:trace contextRef="#ctx0" brushRef="#br0" timeOffset="213942">11765 13335 7533,'-25'-5'449,"0"0"1,-3 20 0,2 9-90,-2 6 0,5 7-680,6 1 0,4 4 0,5 2 380,4-2 0,5 1 0,6-3-150,3-7 0,5-1 0,5-5 93,9-1 1,5-4 0,1-11 146,-1-14 0,1-10 0,-1-3 0,4-2 0,0-4 0,-5-4 119,-6-5 1,-5-3 0,-1-1-30,-1 2 0,-2 0 0,-3 3 199,-2-5 1,-7 15 729,-6 26-944,0 18 0,-2 9-270,-5 3 0,2 4-15,7-4 0,4 2 0,3-4-930,7 1 1,5-3-650,11 8 1,5-10 1620,0-22 0,2-12 1,0-14-1,-4-11 1,-15-4-1,0-1 0,0 1 1</inkml:trace>
   <inkml:trace contextRef="#ctx0" brushRef="#br0" timeOffset="214289">12491 13529 9961,'-20'-20'3276,"8"28"-2954,23 22-1357,2-4 1,6 1 674,9-6 1,5-5 359,1-3 0,2-9 584,10-14 1,-2-13-76,-18 2 1,-3-5 0,-1 1 389,8-10 1,-4 1-495,-10 2 0,-3 5-225,-2 12-990,-3 38 1,2 16-830,7 0 1,2 1 1551,-8-10 1,-1 2 0,4 0 0,12 5 0,5-1 0,2-3 0,-4-12 0,-1 1 0,1-1 0</inkml:trace>
-  <inkml:trace contextRef="#ctx0" brushRef="#br0" timeOffset="215266">13943 12718 7533,'-13'-10'1619,"1"26"-1305,5 16 1,2 12 75,0 0 0,0 4 0,3 3-311,1-5 1,2 1 0,1 2 0,0-1-350,-1 0 0,1 1 1,0-2-1,1-3 239,2 2 1,2-4 0,0-4-15,2-1 0,-6-15 320,-14-32-365,-7-11 0,-6-3-210,-1 3 0,-2-1 0,-2 2 120,-12-6 1,-2 5-200,9 9 1,-1 3-1,2 4 559,-2 6 0,1 8 120,3 8 0,-1 6 0,5 4 88,8 1 1,3 3 0,3 2-209,-1 5 0,3 2 0,11 0-61,16 0 1,12-1 0,5-5-270,3-5 0,4-6 1,3-2-276,1-3 0,3-2 0,1-7 267,-6-7 1,1-5 0,1-3-1,-4-3 8,1-5 0,-2-5 1,-1-3 41,-5 2 0,0-2 1,-2-2-1,-3 0 108,1-3 0,-3-1 0,-9 1 1112,-11-7 1,-11 7-843,-12 17-56,-7 26 1,0 11-170,7 4 0,8 5 90,8 12 0,6 0-135,0-14 0,6-3 315,23 3 0,8-9 179,-10-19 1,2-9 44,5-9 1,2-9 0,-1-4-240,-5-6 0,-2-4 0,1-3-405,-7 8 0,1-3 0,0-1 1,0 2-1,-1 2-435,1 1 0,-2 1 1,1 2-1,1 5 540,7 1 0,1 5 0,-2 7 0,1 11 0,-4 10 0,-7 17 0,0 0 0</inkml:trace>
-  <inkml:trace contextRef="#ctx0" brushRef="#br0" timeOffset="216606">16749 13317 7533,'-13'-37'270,"-5"12"359,-22 25-404,12 3 0,-2 3-180,-12 6 0,-2 2 105,8-4 0,-1 1 0,0 3-174,-4 8 1,-1 5-1,1 1 204,1-2 0,0 1 0,5 4 149,5 4 1,4 4 0,7 1-129,9-5 0,5 1 0,9-2-141,11-1 0,9-2 0,4-4-120,8-5 0,4-4 0,3-4 15,-7-4 0,1-2 0,1-3 0,2-4-196,7-5 1,2-5 0,0-4 0,-2-2 127,-4-2 1,0-3-1,-2-1 1,-1-2 22,1 0 0,0-2 0,-3-1 0,-4-1 0,2-8 0,-5-2 0,-11 3 0,-13-1 1,-13 7 493,-17 15 1,-7 8-225,-6 7 0,-1 8 59,5 7 1,-1 7 0,5 2 120,1 13 0,6 4-330,8-8 0,2 2 0,10-1-240,12 2 0,10-1 0,5-6-90,7-11 0,5-6 1,2-7 179,8-7 0,2-8 0,-3-4 90,-9-1 0,-2-4 0,-4-6 180,2-10 0,-5-7 0,-5 6 465,-1-10-165,-5 10 0,-8 4 117,-21 18-477,-3-4-34,-11 32-56,6 11 899,12 11-179,8-13 0,5 1-91,19 11-314,-8-14 0,2-3-585,20 0-675,-12-31 1,-1-10-46,-8 1 1,-2-3 629,4-12 1,-4 0 89,-4-1 270,-7 21 449,-5 22-179,0 11 90,0-6-90,6 4 180,1-24-180,16-10-1710,-2-9-718,9 7 2158,-11 4 0,-1 32 0,-6 4 0</inkml:trace>
-  <inkml:trace contextRef="#ctx0" brushRef="#br0" timeOffset="217139">18213 12788 7533,'-5'-19'3276,"9"66"-2929,-5-13 0,-1 5 0,1 5-934,1-5 0,0 2 0,0 3 0,0 1 0,0 0 407,-1 3 0,0 0 0,-1 2 1,0-1-1,1-1-396,0-2 0,-1 0 1,1 0-1,-1-2 0,1-3 236,0 11 1,-1-4-1,0-5 25,-3 1 1,-2-13 314,-1-23 0,-12-26 0,-5-13 0,2-3 0,0 1 0</inkml:trace>
-  <inkml:trace contextRef="#ctx0" brushRef="#br0" timeOffset="217287">18016 13600 7533,'-4'-49'655,"0"0"0,0 0 1,8 6-1,5 2 0,11 5 164,9 11 0,10 5 0,4 3 0,1 3-1475,-6 4 1,2 3-1,1 2 1,0 1 0,-1-2 381,8-2 1,1-2 0,-1 2 0,0 3 0,1 4 0,0 3 0,-1 2 0,-3-1 0,-2 0 0,-1 0 0,0 1 0</inkml:trace>
-  <inkml:trace contextRef="#ctx0" brushRef="#br0" timeOffset="217926">19001 13494 7533,'-25'-26'2608,"-10"15"-2473,9 0 0,-3 6-90,-13 20 0,-2 9-15,12-11 0,0-1 0,0 4-108,-3 10 1,2 4 0,2 0 346,7-4 1,2 1 0,6 1 399,3 16 1,12 0-805,10-13 0,10-5-255,9-10 0,8-4 1,0-7 269,-1-8 0,0-6 0,1-4 57,-1-1 0,1-3 1,0-2-1,-4-2 243,3-7 0,-3-4 0,-3 0 119,-2 1 1,-3 0 0,-8 3 780,-9-17 139,-29 39-859,-11 41-720,19-10 0,5 3 360,5 7 0,8 1-1639,7-6 1,6-4-1,12 0 1,4-8 1429,-8-11 1,0-7 0,12-12 0,-5-9 0,-16-2 0,0-1 0</inkml:trace>
-  <inkml:trace contextRef="#ctx0" brushRef="#br0" timeOffset="218125">19358 13564 7533,'0'-43'3276,"0"22"-436,-12-3-2120,4 55-2339,-10 9 584,15-6 1,5 2 1034,6 2 0,7-5 0,10-15 0,6-5 0,10-2 0,1 0 0</inkml:trace>
-  <inkml:trace contextRef="#ctx0" brushRef="#br0" timeOffset="218508">19603 13600 8792,'-29'5'3276,"8"23"-2935,10-2 0,5 3-296,13 7 0,7-2-315,-2-7 0,5-7-45,19-12 0,4-14 285,-11-11 0,-2-9 0,-1-1 90,-1 2 0,-1-1 0,0-4 10,-2-3 1,1-4 0,-1-1-1,-3 5 515,3-4 0,-3 4 134,2-9 1,1 15-270,6 43-1440,-12 12 1,-2 9-31,-2-6 1,-1 3 0,-1 0 89,1 2 1,0 1-1,-1-4 930,1 2 0,-5-5 0,-22 11 0,-11-33 0</inkml:trace>
-  <inkml:trace contextRef="#ctx0" brushRef="#br0" timeOffset="218683">19493 13070 7533,'-29'-8'655,"1"-1"0,-9-1 1,47 10-1,24 10 0</inkml:trace>
-  <inkml:trace contextRef="#ctx0" brushRef="#br0" timeOffset="219866">21868 13247 7892,'0'-37'3276,"-11"3"-2414,-19 24-1132,-3 18 0,-6 8 150,2-1 0,-3 3 1,-1 4-16,5 0 0,-1 4 1,0 2-1,2 2 270,0 3 0,0 3 0,2 0 0,4 0 74,-4 1 1,4 0 0,10 2 210,12 7 0,11 2 0,10-8-792,21-10 0,13-9-416,-11-8 1,6 0 0,1-4 0,-2-3 637,5-5 0,-1-6 1,0-1 100,3 0 1,1-1 0,-7-7 0,-13-5 0,-5-5 0,-1 0 0,-1-1 0,-1 0 0,0 1 0</inkml:trace>
-  <inkml:trace contextRef="#ctx0" brushRef="#br0" timeOffset="220038">22065 13317 7533,'-18'-19'3276,"5"19"-1638,5 20 0,3 11-1946,1 8 0,3 4-262,4-10 1,4 1-1,-1-1 286,2 13 1,5-4-1,11-13 1,5-5 0,0-7-1,0-1 1</inkml:trace>
-  <inkml:trace contextRef="#ctx0" brushRef="#br0" timeOffset="220657">22557 13635 7533,'-37'33'2248,"6"4"-988,12 1-811,8-21 181,11-42-450,0-4 0,0-5-60,3-3 0,1-5 0,0 0-390,-2-6 0,0 0 0,2-1 180,0 10 0,1 0 0,2 1 0,0 1-90,3-8 0,1 2 1,4 7-271,2 7 0,5 11-360,12 18 1,4 12 809,0 13 0,-1 7 0,1-1 0,0 0 0,1-5 0,0-1 0</inkml:trace>
-  <inkml:trace contextRef="#ctx0" brushRef="#br0" timeOffset="221016">23222 13264 7533,'-12'-25'3276,"-1"5"-2505,-5 3-861,-1 9-179,-22 31 224,16-6 0,-1 4 75,0 4 0,-1 5 0,1 1 269,3-4 1,1 1 0,2 1-60,0 3 0,2 0 0,7 0-240,5 5 0,12-3-585,13-5 0,11-5-584,14-8 0,4-5 764,-11-1 0,1-4 405,-1-9 0,2-3 0,-7-1 0,7-5 0,-10 0 0,-1-1 0</inkml:trace>
-  <inkml:trace contextRef="#ctx0" brushRef="#br0" timeOffset="221416">23394 13441 7533,'0'-26'1484,"0"1"0,0-22-764,-6 2-451,-11 27-449,4 36 1,0 13 313,-1 2 1,2 3-75,3-3 0,2 4 0,5-1-150,8 14 0,10-4-315,11-13 1,7-10 494,7-11 0,3-14 149,-8-10 1,0-8 0,-4-3-300,3-13 0,-6-4 240,-9 12 0,-2-1 0,-4 0 989,-1-16 0,-7 5 270,-4 13-2068,-5 21-1010,1 37 1,3 18 1395,0-13 1,6-1-1,8-6 1,5 0-1,2-5 1,11-6-1,0 0 1</inkml:trace>
-  <inkml:trace contextRef="#ctx0" brushRef="#br0" timeOffset="222266">24083 13441 7533,'-14'0'1979,"-2"0"-810,4 23 180,4 22-989,1-9 0,3 1-136,7-3 1,5-3-314,16 4-361,15-61 315,-14-6 0,-2-8-15,-6 6 0,-3-3 0,-1 0 30,-1-2 0,-1 0 0,-2 1 390,1-6 0,-2 6 360,-3 11-270,-10 56-91,1 5 1,1 5-45,-1 0 0,1 2-135,2-7 0,2 2 0,4-4-315,10 1 0,6-5-90,1-5 0,2-11 90,13-31 1,-1-15 134,-9 9 0,-2-5 180,-8-3 0,-1-5 0,-1 3 764,4 1 1,-3 4-1,-8 2 1,0 7-136,3 13-854,-15 35 0,-5 16-645,5-10 1,1 1 0,2 1-314,1 2 1,1 0 0,3-3-193,6 5 0,6-7 565,7-12 1,4-7 719,6-12 0,0-10 0,-2-9 0,-3-7 0,5-7 0,0-1 0</inkml:trace>
-  <inkml:trace contextRef="#ctx0" brushRef="#br0" timeOffset="222599">24908 13458 7533,'4'-45'1092,"0"0"0,-2 8 0,-5 4 546,-14 3 0,-7 9-1182,-2 15 1,-1 8-322,0 4 0,3 7-45,1 22 0,10 9-270,14 1 0,9 2-30,0-9 0,3 2 1,2-4 164,7 2 0,3-2-135,3 3 0,-3-3 810,-10 1 359,-38-10-405,-13-16 1,-9-6-1080,-3-4 1,-2-2-1145,1 1 1,5 0 1519,2 0 1,65 0 0,3 0 0,1 0 0</inkml:trace>
-  <inkml:trace contextRef="#ctx0" brushRef="#br0" timeOffset="223066">25449 12894 7533,'-3'-27'1638,"-1"-1"0,4 1-507,-4 68-652,4-8 1,0 7 0,-1 3-188,-3 0 1,-1 3-1,0 3 1,1 1-730,1-3 1,2 3-1,-1 1 1,1-1-1,0-1-121,-1-7 0,0 0 1,1-1-1,0-1 1,1-2-403,3 16 1,1-2 0,2-9 1,0-6 0,1-17 958,6-37 0,-14-11 0,-4-5 0,-2-8 0,0 0 0</inkml:trace>
-  <inkml:trace contextRef="#ctx0" brushRef="#br0" timeOffset="223228">25314 13335 7533,'-16'-26'1092,"0"-1"0,13-3 0,9-1 546,18-1 0,12 2-1455,-6 11 1,5 1-1,3 1 1,1 0-368,3 2 0,3 0 0,1 1 0,0 0 0,-2 2 0,4-2 1,-2 3-1,0-1 0,0 1 0,2 1 0,1 0 0,-1 0 1,0-1-1</inkml:trace>
-  <inkml:trace contextRef="#ctx0" brushRef="#br0" timeOffset="224016">26052 13547 7533,'-19'-26'1799,"7"7"-1260,17-15-269,9 15 180,5-22 180,-12 19-271,-20-1 1,-8 5-225,-6 16 0,-5 8-405,-13-4 0,-3 7 360,10 12 0,1 6 0,2 2 90,8-5 0,2 1 0,4 2 59,1 9 1,5 4 0,7-4-285,11-1 1,10-3-46,7 1 0,10-8-45,12-18 0,5-12 75,-14-2 0,1-5 0,0-4 120,6-7 0,1-4 0,-3-3-297,-8 0 0,-2-1 0,-3 0 507,6-11 0,-10 3 1079,-21-4-1259,-19 51-315,2 18 0,3 9-360,2 5 1,3 4-316,3-8 1,1 1 0,5-4-496,6-2 1,6-5 404,5-2 1,3-9 989,20-31 0,-6-9 0,1-9 0,-14 6 0,1 0 0,-1 0 0</inkml:trace>
-  <inkml:trace contextRef="#ctx0" brushRef="#br0" timeOffset="224458">26421 13370 7533,'-5'-25'2518,"4"-3"-989,-10 9-539,4 34-676,-2 6 1,0 5-90,4 17 0,2 3-720,-2-8 1,4-2-136,9 4 0,7-11 181,24-33 539,-6-15 0,0-9 134,-5-4 1,-2-5-45,-2 2 0,1-2 0,-4 1 359,-3 1 1,-2 4 1799,14-8-1170,-30 50-1124,-3 14 0,-2 7-255,-1 5 0,0 4 1,0-1-691,1 8 1,4 0-194,2-12 1,2 0 0,4-2-547,6 4 1,5-8 1516,16-10 0,-3-28 0,1-10 0,-6-10 0,-1 0 0</inkml:trace>
-  <inkml:trace contextRef="#ctx0" brushRef="#br0" timeOffset="225083">27185 13335 7533,'12'-43'3276,"-5"13"-1785,-2-11-861,-16 30-361,-13-5-314,1 21 1,-4 6 44,-6 1 0,-2 3 269,6 1 1,0 2 0,1 1-135,-6 7 0,2 3-15,6-3 0,2 3 0,4 0 104,7 7 1,4 3-315,-2 9 1,6 0-46,11-15 0,6-2-135,11 6 0,7-7-45,8-15 0,6-9 225,-2-6 0,5-5 1,-2-5-415,-9-3 0,-1-3 1,0-2-1,-1 0 594,6-3 0,-2-2 0,-2-1-60,-1-6 0,-2-1 0,-8 1-30,-8 7 0,-6-1-90,-1-6 0,-9 0 674,-25-3 1,-10 5-135,10 9 0,-3 6-61,-7 8 1,-3 4 0,2 7-300,0 13 0,4 9-480,8 5 0,4 6 1,5 1-361,9-3 1,5 1-1,4-1-150,4 3 1,5 0 0,5-4-194,8-6 1,5-4 0,-1-4 981,-3 0 1,2-9 0,18-18 0,0-13 0,-16-7 0,-1 1 0</inkml:trace>
-  <inkml:trace contextRef="#ctx0" brushRef="#br0" timeOffset="225428">27812 13441 7533,'10'-39'1092,"-1"-1"0,-1 3 0,-3 2 546,-6 6 0,-4 3-545,-14 1-1093,-13 50-180,20 3 1,4 7-91,1 11 0,8 6-449,8-7 0,4 4 0,1-4 629,-5-12 0,1-1 0,1 1-210,6 12 0,3 1 0,-5-6 30,-7-13 1,-7-3-136,-10 4 0,-10-5-405,-16-11 1,-7-8 809,9-2 0,-2-3 0,1 0 0,-1-1 0,0-1 0,1 0 0,-9-2 0,1 0 0</inkml:trace>
-  <inkml:trace contextRef="#ctx0" brushRef="#br0" timeOffset="226166">22114 13000 7533,'-9'-37'269,"0"-1"1,1 8 0,10 2 0,22 2 0,14 3 0,2-1 0,0-1-1,0-1 1,-1 1 0</inkml:trace>
-  <inkml:trace contextRef="#ctx0" brushRef="#br0" timeOffset="226649">28575 14129 7533,'-12'-29'468,"1"1"0,17 8 0,12 2 0,7 5 0,17 23 0,0 0 0</inkml:trace>
-  <inkml:trace contextRef="#ctx0" brushRef="#br0" timeOffset="236991">5217 14923 6903,'-13'-10'90,"3"2"180,10 0 90,0 6-91,0-14 361,-6 14-270,5-5-90,-5 7 539,1 0-179,-2 0-360,0 0 180,1 0-91,1 7 1,-2-5-450,0 6 90,2-8 0,-1 0 180,5 0 0,-5 0 180,6 0 179,0 0-89,6 0 360,6 8-451,2 11 1,2 3-315,3-3 0,0 3-15,2 12 0,1 7 0,1 0-97,0-4 1,0-1-1,1 3-91,-5-4 1,0 1 0,-1 1 0,1-2 37,2 3 0,1-2 0,-3-2-15,-3-2 0,-1-4-585,7 4-449,-21-30-990,10 6 90,-9-8 450,3 0 1619,-5 0 0,-5-8 0,-2-2 0</inkml:trace>
-  <inkml:trace contextRef="#ctx0" brushRef="#br0" timeOffset="237450">5181 15734 7533,'-19'0'809,"-5"0"630,16 0-89,-8-8-271,26-17 0,11-7-225,2-3 1,6-6-1001,-7 11 0,4-4 0,3-2 0,1-2 1,0 1-1,-1 2 92,2-1 0,0 1 0,0 1 0,0-1 0,0-1-441,-2 1 0,0-1 1,0-1-1,-1 0 0,0 3 1,-4 3-321,10-8 0,-4 3 1,-5 5-356,-8 3 1,-5 7-270,-6 13 1439,-6 16 0,-6 2 0,-1 8 0</inkml:trace>
-  <inkml:trace contextRef="#ctx0" brushRef="#br0" timeOffset="239348">6375 15434 8432,'0'-10'1080,"0"2"629,0 8-720,11 24-179,8 13-496,-8 0 1,-2 5-1035,0-1 1,-6 0 44,-8-3 1,-7-4 179,-5-9 0,-5-7-450,-8-7 1,-1-6 944,-4-5 0,35-16 0,40-3 0</inkml:trace>
-  <inkml:trace contextRef="#ctx0" brushRef="#br0" timeOffset="240567">6448 15134 8702,'-19'-8'2159,"7"6"-1350,6-5-449,6 7-180,11 0-90,-3-8-270,10-10 360,-16-9 314,-18 2 1,-8 6-1934,-20 29 1394,16-16 0,6 4 45,17 37 0,15 3 0,20-20 0,0 1 0,0 1 0</inkml:trace>
-  <inkml:trace contextRef="#ctx0" brushRef="#br0" timeOffset="241233">6411 15505 7533,'-31'-20'3276,"12"4"-1425,8 16-1132,11 0-179,6 8-450,1 10 360,5-6-180,-5 3-360,3-15 0,-13-15 0,-10 3 0,-13-6 0,-11 18-630,11 26 181,19 11 718,21 8 451,23-18 180,-5-27-361,-1-19 46,-37-7 0,-9 1-135,-4 9-1755,-12 14 1,9 6 1394,39 12 0,9-32 0,14-13 0,0-1 0</inkml:trace>
-  <inkml:trace contextRef="#ctx0" brushRef="#br0" timeOffset="242550">7334 14693 7623,'-7'-19'1529,"-3"-13"-630,8 28-359,-3-19 90,5 29 359,5 35-1019,1-8 0,0 7 0,0 1-30,-1-4 0,0 0 0,0 6-487,0-2 1,1 7 0,1 4 0,-1-1 0,0-4 0,-2-8-1093,1 11 1,0-2 1617,0-4 0,3 11 0,-1 0 1,-3-13-1,-6-24 0,-13-40 1,0 13-1</inkml:trace>
-  <inkml:trace contextRef="#ctx0" brushRef="#br0" timeOffset="242980">7261 15240 9422,'-9'-12'-270,"38"-1"90,-2 16 0,5 1 60,-1-8 0,3-4 0,-1-3-291,1-1 0,0-3 1,-2-3 110,2-9 0,-3-3 0,-3-1 233,3-6 0,-5-3 366,-9-2 1,-4-4 0,-3 3 195,-5 2 0,-3 1-16,0 6 1,0-3 0,-1 5-63,-1 2 0,0 7 1023,0 5-946,8 56 1,1 20-315,-5-9-384,-1-17 1,2 8 0,1 4 0,-1 0-1,-2-4 24,-2 8 0,-1-3 1,0 3-204,1 0 1,1 3 0,-1 0 0,1-3 40,-1-7 0,0-2 0,1-1 0,-1-3-1053,2 16 1,1-8 1394,9-10 0,-1-41 0,1-11 0</inkml:trace>
-  <inkml:trace contextRef="#ctx0" brushRef="#br0" timeOffset="243349">7876 15399 9781,'-9'-20'3276,"49"4"-2684,-11 16-502,7-5 0,9-4 0,-3 0 45,-5 0 0,-2-4-75,2-5 0,2-5 0,-5-2-15,-1-6 0,-10-3-135,-17-7 0,-11 2 90,-6 12 0,-6 7-45,-7 7 0,-3 10 0,-1 15 0,3 11 195,9 4 0,4 6 0,2 1-420,-2 0 0,2 0 0,6 2-636,7 8 0,7 2 0,4-4-264,10 2 1,7-6 1169,4-8 0,6-9 0,-8-16 0,3-7 0,-1-1 0,10-7 0,0 0 0</inkml:trace>
-  <inkml:trace contextRef="#ctx0" brushRef="#br0" timeOffset="243895">8651 15187 8162,'-7'-10'3276,"1"2"-2684,6 16-592,0 2-900,4 26 1,3 8 899,7-3 0,3-1 0,1 0 0,3-4 0,7-13 0,-1-1 0</inkml:trace>
-  <inkml:trace contextRef="#ctx0" brushRef="#br0" timeOffset="244467">8934 15222 7533,'-24'-19'2248,"-7"3"-1888,11 32 0,11 14 0,6 6-270,6 3 0,6 1-330,1-5 0,2 2 0,3-3 105,6 1 0,3-8 225,3-13 0,1-10 270,5-16-135,-14-17 0,-4-8 89,-11-7 1,-6-3-195,1 11 0,-1-1 0,-2 1 15,-1-14 0,-4 10-135,-15 12 0,26 53 0,6 19 150,-1-1 0,2 6 0,1 4-392,-2-11 0,1 3 0,1 2 0,-1 1 0,0-1 206,0 1 0,1 2 0,-1-1 0,-1-1 0,0 0-72,-2-5 0,1 1 0,-1-2 0,-2-1 0,-3-3 617,-2 8 1,-4-4 0,-5-7 164,-4-4 1,-6-15-375,-8-25 0,-6-18 0,1-1-240,6 1 0,0-1 0,1-4-353,0 1 0,-2-3 0,2-1 0,3 2 263,3 1 0,3 2 0,3 0-1410,-4-14 1,12 6-1838,36 8 1638,2 12 1,4 3 1623,-3 6 1,2 0-1,11-6 1,1-3-1,-13-1 1,1 1-1</inkml:trace>
-  <inkml:trace contextRef="#ctx0" brushRef="#br0" timeOffset="244962">9279 14870 7533,'0'-28'2518,"0"-5"-1708,0 29 269,11 37-630,-6-3 1,-1 7 0,0 2-240,2 8 0,0 2 0,1 2-472,0-6 1,0 3 0,1-1 0,-1-3 201,1 5 0,1-3 0,0-4-390,6 7 0,2-9 141,7-9 354,-9-52 0,-1-15-90,-3-1 0,-2-2 165,2 6 0,0-2 0,-2 3 599,-2-6 1,0 5 179,4 0-629,-11 64-900,4-8 1,2 3 47,4 14 0,5 1-511,3-9 1,4 0 0,3-10 969,11-16 0,1-10 0,-6 3 0,-3-8 0,-9-35 0,0 0 0</inkml:trace>
-  <inkml:trace contextRef="#ctx0" brushRef="#br0" timeOffset="245212">9894 14764 7533,'0'-34'3276,"-5"21"-1335,14 28-1582,-4 13 1,-1 9-1016,2-3 1,3 7-1,0 4 1,0-2 0,-2-4-438,0 0 1,-2-3 0,1 5 436,2 1 1,0 5-1,1 3 1,-1-4 0,-3-6 718,-2 7 0,-3-6 1,2-5-1,-4-5 1,-12-4-1</inkml:trace>
-  <inkml:trace contextRef="#ctx0" brushRef="#br0" timeOffset="245419">9869 15134 7533,'0'-25'1092,"0"-1"0,11-1 0,6-1 508,7-5 0,8 4-1600,-2 13 0,5 4 0,0 2-1093,3 0 1,0 2 0,-1 3 888,7 4 1,-4 2 0,-11-1-1,-6 0 1,-12 0 0</inkml:trace>
-  <inkml:trace contextRef="#ctx0" brushRef="#br0" timeOffset="245625">8725 14958 7533,'-25'0'0,"0"0"0,9 0 0,20 0 0</inkml:trace>
-  <inkml:trace contextRef="#ctx0" brushRef="#br0" timeOffset="247466">13253 14658 8072,'-13'0'1170,"-3"0"-91,9 0 0,-5 0 271,-1-8-361,6 6 270,2 10-179,21 19-676,-2-2 1,4 3-525,6 2 0,4 3 1,3-2-974,2-2 1,2-1 0,-1 2-1,1 5 1,0 2 0,-2-6-39,6-5 1,-5-4 1130,-12 2 0,-5-9 0,3-37 0,4 1 0</inkml:trace>
-  <inkml:trace contextRef="#ctx0" brushRef="#br0" timeOffset="247826">13782 14711 7533,'-10'-43'3276,"7"13"-1155,-7 5-952,4 48-1079,-1 17 90,-1-7 0,-2 8 0,-1 2-479,2-5 0,0 2 0,0 1 0,-2 1 317,0-1 0,-2 2 0,0 1 0,0 0 0,1-1 54,1-2 0,1 0 0,-1-1 0,1 0 0,0-2-16,-1 4 1,0-1-1,1-2 1,0-4 168,-3 8 0,3-7-2654,3-3-539,18-41 1079,10-4 1889,15-13 0,1 7 0,1 1 0</inkml:trace>
-  <inkml:trace contextRef="#ctx0" brushRef="#br0" timeOffset="248711">14140 15046 7533,'-25'-10'3276,"6"2"-4663,7 8-412,17 0 1799,3 8 0,5 25 0,-8 15 0</inkml:trace>
-  <inkml:trace contextRef="#ctx0" brushRef="#br0" timeOffset="248858">14053 15293 7533,'-13'10'2428,"2"-2"-2608,17-8 180,17-8 0,7 0 0,5-2 0,10-4 0,0 1 0</inkml:trace>
-  <inkml:trace contextRef="#ctx0" brushRef="#br0" timeOffset="249766">14841 15363 7533,'-14'30'1049,"-1"-1"0,7 8 1,0-1-780,-5-10 0,3-1 269,10 22-449,7-71-150,-3-11 0,0-12 0,0 6 15,0 11 0,-1-1 22,-1-10 1,-1-10 0,0 1-1,1 10 248,-2 11 0,5 3 194,8-4 1,6-1 0,5 6-480,9 10 0,6 7 1,1 3-601,3 1 0,2 2 1,0 2-430,-1 2 1,1 1 0,-6 2 1088,0 0 0,-12 6 0,-26 38 0,-12-16 0,0 0 0</inkml:trace>
-  <inkml:trace contextRef="#ctx0" brushRef="#br0" timeOffset="250183">15297 15328 10501,'34'-17'2878,"0"-1"-2833,2 6 0,4-2-90,-1-6 0,-1-3-315,4 1 1,-2-3 134,-7-8 0,-10-2 90,-15 6 0,-9 3 45,-14 5 0,-8 5 45,-13 2 0,-3 12 495,-3 21 0,1 11-211,15-8 1,0 3 0,5 2-120,4 4 0,3 3 0,6 1 0,6 5 0,6 2 0,5-4-390,16 3 0,8-6-750,-5-9 1,4-2 0,2-5-61,0-7 1,3-4 0,-3-3 946,9 2 0,-4-6 1,-7-10-1,-3-5 0,6-16 1</inkml:trace>
-  <inkml:trace contextRef="#ctx0" brushRef="#br0" timeOffset="250666">16047 15258 7533,'5'-43'3276,"8"13"-1155,1-11-1672,-2 29-629,-28-3-359,-23 22 449,6 4 0,-2 4 90,6 0 0,0 2 0,1 4-921,-3 9 0,1 4 1,3-2 1054,-3-2 1,7 3 135,6 17 0,17-4-180,44-23-135,-9-2 0,5-9-135,-1-21 0,3-12 0,-2-3 929,-7-1 1,-2-2 0,-1 0-660,-2 0 0,-1 0 0,-3 3-540,-2-2 0,-6 13-1189,-6 36 1,-2 14 1553,7-3 1,2 1 0,4 5-1,2-2 1,1-12 0,1-1 0</inkml:trace>
-  <inkml:trace contextRef="#ctx0" brushRef="#br0" timeOffset="251846">16822 14393 7533,'-25'-9'2338,"2"40"-1708,12 5 0,4 8-248,3-7 0,2 4 0,0 3 1,1 1-399,1 0 0,1 4 1,0 0-1,1 0 0,0-2-322,1 1 1,0-1 0,2-2 0,-1-1 395,3-1 1,2 2-1,-4-6 1,-7-15 121,-14-16-467,-2-32-163,-12-1 0,-11-3 1,0 7 853,-1 13 1,-2 6-135,3-6 0,-2 1 0,4 10 119,6 20 1,5 11 0,5 1-120,-1 8 0,15 3-225,19-10 0,12 3 0,5-1 0,1-6-15,3-6 0,3-6 0,5-4-326,-1-5 0,4-2 0,3-3 1,-1-4-1,-2-6 3,6-10 1,-2-9 0,-2-3-1,-3 1 533,0 1 0,-3 0 0,-3-3 179,-3-5 1,-2-4 0,-13 6 876,-19 3 144,-22-6-1980,3 36 90,20 19 0,7 7 405,2 2 1,6 1-286,4 2 0,4 3 0,3-6 442,9-2 0,2-11 248,-6-13 0,-1-8-90,-1-9 0,-4-7 44,-12-7 1,-5-3-180,-1 2 0,0 3-135,-1 4-180,1 36-180,16-4 1,6-1 224,-3 2 0,1-6 225,20-14 0,-2-13 89,-12-10 1,-6-5 1214,-3 0 1,-4 5-1575,-6 11-1979,-9 32 720,-7 15 0,0 5-200,11-5 1,1-1 1494,-6 1 1,4-3-1,13-9 1,5-5 0,14 5-1</inkml:trace>
-  <inkml:trace contextRef="#ctx0" brushRef="#br0" timeOffset="252379">18016 15275 7533,'-3'-29'1638,"0"-1"0,-9-11 1638,-7-2-2902,-5 28-104,-12 46-495,21-6 0,3 5-225,-3 9 0,5 4-180,3 6 1,8-2 134,8-12 1,6-5-316,18-3 1035,-8-31 0,-1-11 269,-2-20 1,-6-9-75,-4 10 0,-2-3 0,-2 0 209,1-12 1,-5 4 359,-6 11 1,-2 15-406,-3 40 1,0 17-945,2 2 0,0 7 1,2 3-297,0-7 1,2 3-1,0 1 1,0 1 0,1-2 614,0-5 0,1-1 0,-1-1 0,1 2 0,-2 2-109,1 2 0,0 5 0,0 0 0,-2 0 0,-1-3 0,-2-5 330,-5 8 0,-4-5 0,-5-3-225,0-7 0,-5 2 0,-2-7 0,-2-14-1005,-12-23 1,-5-19 0,3-4-44,4 0 1,3-4 0,3-2 1001,2-5 0,4-2 0,7 5 0,10 10 0,7 3 0,9 2 0</inkml:trace>
-  <inkml:trace contextRef="#ctx0" brushRef="#br0" timeOffset="252562">17328 15028 7533,'-27'-29'1638,"1"0"0,0-5-1034,7 12 0,9 3 0,35 3 0,20 7 0</inkml:trace>
-  <inkml:trace contextRef="#ctx0" brushRef="#br0" timeOffset="253813">19247 15311 7533,'-18'-44'1304,"4"22"0,-2-1-719,-1-1 0,-4 3-316,-9 3 1,-6 9 90,2 12 0,-4 8 0,2 6-91,3 9 1,1 7 0,2-2-180,-3-7 0,1-1 0,10 5-120,16 15 0,11 6 0,7-14-510,22-15-280,-1-21 1,9-7 0,2-3 0,-9-1 177,-8 1 0,-3-5 619,7-17 1,5-12-1,-6 4 1,-16 25 2451,-27 41-2339,18-52 29,-4 56 1,1 30 0,11-18-930,16-37 1,8-13 0,0 2 584,9 19 0,-3-12 270,-19-20 0,0-14 0,-1-8 0,-1-5 0,-3 0 0,-4 4-63,-3 0 1,-4 1 0,-3-1 0,-1 0 0,1-2 316,1 3 1,0-2 0,0-1 0,-1 0 0,-2 3 0,-1 4 149,-1-20 1,-3 5 0,-8 24 2226,-31 51-2736,26 11 0,6 13 1,1 4 184,0-7 1,-1 4 0,1 3 0,3 1 0,5-1-382,4-2 0,5 1 0,2 2 0,2-2 0,0-3 0,0-4 166,-1 0 0,-1-3 0,3-5 0,5-6 689,13-4 1,5-8 0,-6-15-16,-8-37 1,-14-20-720,-10 14 0,-6-6 0,-5 0 0,-1 9-1504,-5 3 1,-4 6 1531,-9-10 1,11 17 0,40 50-1,12-4 1,1 0 0</inkml:trace>
-  <inkml:trace contextRef="#ctx0" brushRef="#br0" timeOffset="254236">19997 15134 7533,'-7'-17'3058,"-4"-9"-899,5 14-990,-6 51-1709,7-7 1,3 5-554,7 3 1,4 4 0,-1-4 981,-5-3 1,6-6 0,21-1 0,7-13 0,-11-22 0,1 0 0</inkml:trace>
-  <inkml:trace contextRef="#ctx0" brushRef="#br0" timeOffset="254762">20403 14587 7533,'-6'-27'3276,"-5"9"-796,15 50-2300,-3-7 225,5 12 0,0 8-255,-1-5 0,-1 2 0,0 4-806,-1-8 1,1 3-1,-1 2 1,1 0 0,0-2-72,0 4 0,1-1 0,-1-1 0,2 1 299,0 3 1,0 1 0,2-4 0,2-9-904,4-8 0,3-8 1331,20 4 0,-11-31 0,-2-2 0</inkml:trace>
-  <inkml:trace contextRef="#ctx0" brushRef="#br0" timeOffset="254999">20674 15240 7533,'-3'-26'1638,"-1"-1"0,-7-10 842,10 19-2659,-5 28-91,6 33-765,3-16 1,0 1-605,0 7 1,1 1 848,4-8 0,2-2 790,4 10 0,25-44 0,0-22 0</inkml:trace>
-  <inkml:trace contextRef="#ctx0" brushRef="#br0" timeOffset="255495">21007 14623 7533,'-9'-27'1484,"0"1"0,1-12-405,-9 5-449,16 23 270,-5 18-226,5 15 1,2 5-495,-1 0 0,0 3-1,1 7 1,-1 6 0,-1-1-233,0-1 0,-2 0 1,2 2-61,1-5 1,1 1-1,1 1 1,-1-1-136,0 1 1,1-1 0,0 0 0,0-2 7,2 6 0,0-2 0,2-2 195,5 11 0,1-6-315,1 0-2158,5-30-271,-6-32 2789,-5-3 0,-12-13 0,-9 5 0</inkml:trace>
-  <inkml:trace contextRef="#ctx0" brushRef="#br0" timeOffset="256145">20933 15117 7533,'-23'-44'3276,"8"7"-796,8-6-1581,21 24 1,7 3-675,6 0 0,5 4-765,15 2 1,3 3-1035,-7 0 0,-2 6-65,-2 9 1,-10 7-572,-26 23 2210,-10-12 0,-6 2 539,-5 2 1,-4 2 0,2-1-91,5-2 1,3 2-270,3 1 0,2 3 0,7-2 45,13 5 0,8-3-225,3 1 0,4-7 224,3-14 1,2-11 180,2-23 0,-4-15-195,-14-1 0,-6-6 0,-1 0 599,-1-9 1,-1 1-1,-6 26-180,-6 45 1,-4 17-510,1-8 0,0 4 0,-1 7-381,2-6 0,1 6 1,-1 5-1,0 1 1,0 0-1,0-2 1,0-4 26,-1 1 0,1-2 0,-1-2 0,-1-1 0,-1-1 9,-2 9 0,-1 0 1,-4-5-1,-5-11-645,-10-13 1,-5-9-1,0-6 870,-6-5 0,1-9 0,-2-12 0,8-5 0,21 7 0,0 1 0</inkml:trace>
-  <inkml:trace contextRef="#ctx0" brushRef="#br0" timeOffset="256384">20711 14887 7533,'-23'-25'89,"8"13"1,2 4 0,15 18 0</inkml:trace>
-  <inkml:trace contextRef="#ctx0" brushRef="#br0" timeOffset="256573">19997 14728 7533,'-32'-17'0,"36"15"0,24 4 0</inkml:trace>
-  <inkml:trace contextRef="#ctx0" brushRef="#br0" timeOffset="313600">24576 14676 7263,'6'-10'180,"-1"2"899,-21 8-449,7 0 269,-20 0-89,10 0-450,5 0 269,-2 0-89,9 0-270,0 0 180,1 0 359,23 0-494,6 0 0,7 0 14,14 0 1,9-1 0,-1 2-330,-13 0 0,-1 1 0,1 1 0,1-1-219,6 0 0,3 0 1,-3 0-1,-4 2 339,-5 1 0,-4 0 0,-4 2 60,1 1 0,-8 2-90,-10 7-540,-23 17-180,-2-12 1,-5 1-91,-9 10 1,-2 4 329,5-4 0,0 2 0,-2 1 7,3-4 1,-1 1-1,-1 1 1,0 1 404,-1 2 1,-1 1-1,0 1 1,1-1 224,-1 1 0,-1-1 1,2 0-1,0-2 721,-5 5 0,2-1 0,3-5-699,1-1 1,6-5-180,3 2 360,28-39 0,9 0 0,4-1 89,6-8 1,2-2-480,0 4 0,2 0 0,1 0-98,1 2 0,1 1 1,-1 0-953,1 0 1,0 0 0,-2 3-46,7 1 1,-4 6 1037,-1 3 1,-11 6 0,-29 12 0,-9 17 0</inkml:trace>
-  <inkml:trace contextRef="#ctx0" brushRef="#br0" timeOffset="313909">24526 15117 7533,'-43'-8'3276,"17"6"0,48-14-2280,13 10 1,10 2-997,-8-1 0,5-2 0,1 0 0,1 1-820,1 0 1,1 1 0,1 1 0,0-1 653,-6 1 0,1-1 1,0 1-1,-2 1 1,-2 2-1,5 1 1,-3 3-1,-2 1 0,8 6 1,0 0-1</inkml:trace>
-  <inkml:trace contextRef="#ctx0" brushRef="#br0" timeOffset="314138">25547 15117 7533,'-12'-18'3276,"11"0"-1515,8 16-1761,6 4 0,-9 28 0,-6 13 0,-2 0 0,-1 0 0</inkml:trace>
-  <inkml:trace contextRef="#ctx0" brushRef="#br0" timeOffset="314304">25486 15328 7533,'-35'-10'3276,"18"3"-2983,23 7 1,15 0-1,8 0 1,12 0-1,0 0 1</inkml:trace>
-  <inkml:trace contextRef="#ctx0" brushRef="#br0" timeOffset="315450">26347 15469 7623,'-19'0'1889,"1"8"-990,6-6-269,6 6-271,6-24-448,17-11 44,1-8 0,1-7 15,-1 6 0,1-2 0,0-3-481,-3 3 0,1-3 1,-1 0-1,-2 0 398,0 1 1,-1 0 0,-1-1 0,-1-1 201,1-4 1,-1-3 0,-1 1 0,-1 3-124,-2 2 0,-1 3 0,0 0 244,-2-2 0,0 0 0,0 6-165,-1 7 0,-1 5-45,4-1 180,-5 25 450,16 33-630,-14-17-78,4 17 1,4 13-1,-2-8 438,1 0-216,-3-6 0,1 10 0,1 6 0,-1-2 0,-1-7-267,-1-4 1,-1-4 0,1 3 158,0 5 0,1 5 0,0 3 0,1-1 0,-2-4 173,1 9 1,-2-3 0,2 0-270,1 1 0,0 0 0,1-4-255,3 7 1,0-8-1395,2-1-720,-4-27-359,-10-32 4078,0 4-1290,-16-13 0,-15-8 0,6 14 0,-1 0 0</inkml:trace>
-  <inkml:trace contextRef="#ctx0" brushRef="#br0" timeOffset="315683">26483 15275 7533,'-32'-8'3276,"8"6"-706,28-5-1850,33 7-1350,10 0-494,-2 0 0,4 0-515,-5 0 1,1 0 1540,0 0 1,0 0 0,0 0 0,-1 0-1,-13 0 1,0 0 0</inkml:trace>
-  <inkml:trace contextRef="#ctx0" brushRef="#br0" timeOffset="316374">27147 15187 7533,'0'-20'1979,"0"-11"-990,-5 19-359,-2-13-540,-11 15-720,-6 10 180,-13 26 450,17-9 0,2 3 180,-5 9 0,3 3 45,9-10 0,2 3 269,-2 11 1,6 2-495,10-9 0,6-1-180,2 9 0,5-4 90,8-9 0,4-10-360,4-16 1,1-12 404,-5-11 0,-3-7 0,-6-2 0,-5-6 15,-8-3 0,-4-4 0,-5 5 480,-7 11 0,-2 4-136,5-5 1,1 13 45,0 41 0,2 18-300,5-6 0,1 3 0,3 4-299,0 4 0,3 5 1,0 1-1,-2-1 239,-2-10 0,0 0 0,0 0 0,-1 0 0,-1 0 162,1 2 0,1 0 0,-2 0 0,0 0 0,-3-2-11,-2 4 1,-2 0 0,-2-2 0,-4-6-62,-12 12 0,-9-15-450,-8-22 0,-4-14-450,-1-16 1,3-10 509,14 5 0,1-4 1,3 0-286,-5-8 0,4 0-404,7 0 0,8 3 1203,19-4 0,8 18 0,6 4 0,10 7 0,-1-1 0</inkml:trace>
-  <inkml:trace contextRef="#ctx0" brushRef="#br0" timeOffset="316785">27369 15487 7533,'-11'-33'3276,"8"11"-1065,8-3-1897,15 15 1,8 4-630,17 1 1,3 0 179,-5-6 0,2-3-738,-2 1 0,2 0 0,-6-4 468,-5-9 0,-5-3 586,7-5 0,-11-3 268,-25 4 1,-11 3-45,-11 7 0,-8 9 344,-12 17 1,-8 12-1,4 6-90,10 5 1,4 5 0,6 6-503,10 0 1,3 5-1,7 1 1,7-4-428,12 3 0,10-4 0,7-4 242,3-7 0,7-2 0,3-6 0,-3-8 0,1-11 0,0-10 1,-1-3-1,-5-4 0,0 1 0,0 0 0</inkml:trace>
-  <inkml:trace contextRef="#ctx0" brushRef="#br0" timeOffset="421317">1111 16933 7892,'-10'-9'1350,"3"1"-451,-1 0 360,6 29-179,-6 9-960,12-2 0,5 8 0,1 2-120,2 1 0,1 3 0,2 1 0,-2-1-206,0-3 0,-2 0 0,2-1 0,1 1-447,6 7 1,2 1 0,0-2 0,-3-5-338,-3 5 1,-1-7 629,6-6 1,-1-5 359,-2-2 0,-8-7 0,-3-1 0</inkml:trace>
-  <inkml:trace contextRef="#ctx0" brushRef="#br0" timeOffset="421605">1111 17692 7533,'-32'-9'1092,"0"0"0,9-9 0,10-5-302,22-17 1,16-6-364,-4 9 0,5-2 1,3-2-1,0-1-726,-1 3 0,0 0 0,2-2 0,0 1 0,1-1 224,-2 5 0,1-1 0,1 0 0,-1 1 0,-1 1 0,-1 2-577,2-2 0,-2 1 0,-1 3 0,0 2 749,1-3 0,-1 3 0,-8 18 0,-11 44 0,-13-5 0,0 1 0</inkml:trace>
-  <inkml:trace contextRef="#ctx0" brushRef="#br0" timeOffset="421818">1711 17427 9242,'0'34'1214,"-3"-10"0,-2 4-2204,1 16 1,-2 1 989,-2-7 0,-1 0 0,-3 2 0,-2-3 0,0-16 0,1 1 0</inkml:trace>
-  <inkml:trace contextRef="#ctx0" brushRef="#br0" timeOffset="422267">2099 17180 7803,'-20'-10'2428,"5"3"-2788,32 16 1,13 5-451,-6-7 0,3 0 810,15 12 0,4-5 0,-13-16 0,2-7 0,-1-1 0,-1-1 0,0 1 0,1-1 0</inkml:trace>
-  <inkml:trace contextRef="#ctx0" brushRef="#br0" timeOffset="422543">2575 16898 7533,'-25'-37'3276,"-3"27"-2351,6 41 1,1 20-1264,7-18 1,1 3 0,0 2 0,0 2-319,3 2 1,0 2-1,1 1 1,1 2 0,-2-1 169,0 2 0,-1 1 0,0 0 0,1-1 0,1-3 283,3-3 1,1-2 0,1-1 0,0-1 350,-2 9 0,0 0 0,2-10-778,4 0 630,0-11 0,0-42 0,0-13 0</inkml:trace>
-  <inkml:trace contextRef="#ctx0" brushRef="#br0" timeOffset="424823">3528 17339 7173,'-10'-20'540,"2"5"-181,8 7-269,-8-2 0,6 0 0,-13 2 0,5 8-90,-23 16 90,-5 12 90,7-1 0,2 6-45,7 10 0,4 3 45,-4-5 0,3 2-31,14-10 1,5 3 0,3-3-240,7 5 0,6-4 90,1-7 0,5-7 0,12-5 0,1-14 135,-6-28 0,-4-13-45,-4 3 0,-4-4-60,-7 7 0,-2-2 0,-3 0-60,-5 1 0,-4 0 0,0 3 120,0 1 0,-1 3 90,-5-7 135,12 58 0,4 21-405,-1-6 0,2 6 0,0 3 0,1 0-560,-1-5 0,1 1 0,0 1 1,-1 0-1,0-1 492,1 8 1,-1-1 0,0 0-1,-1-3 128,2 4 0,-1-2 0,-7-8 570,-9-11 0,-5-5-46,-2-5 1,-5-5-585,-10-12 0,-5-6 0,1-5 90,-10-8 0,1-5 0,11 4 0,-1-2 0,5 0-135,5-3 1,5-1-1216,4-18 1350,38 21 0,14-5 0,-5 16 0,-1 0 0</inkml:trace>
-  <inkml:trace contextRef="#ctx0" brushRef="#br0" timeOffset="425900">3722 17604 7533,'-20'-10'2069,"-3"2"-1260,44 0-719,1-2-225,6-1 0,5-3 315,2-3 0,0-1 45,-5-3 0,-3-3 134,-2-6 1,-7-1-90,-10-16-450,-21 23 0,-7 5-179,-20 9 224,14 8 0,-1 6-180,4 12 0,3 9 225,8 8 0,5 4 90,-1-5 0,2 2 0,4 0 60,10 8 0,7 0 0,1-2-195,7 5 0,3-6 0,4-4 0,5-11 450,4-21 0,-4-14-90,-17-9 0,-4-5-1,8-6 1,-3-3 180,-12 3 0,-4 0 45,5-12-810,-16 48-360,6 25 45,1-3 1,2 1 494,9 9-269,31-14 1078,-10-46-179,-1 0 0,-1-7 809,-8-14 0,-5-2-719,-2 15 0,0 1-540,-2-4 0,-1 13-360,-1 45-2917,23 13 3259,-8-2 0,3 1 1,7-10-1,3-3 1,-9-7-1,0 0 0,1 1 1</inkml:trace>
-  <inkml:trace contextRef="#ctx0" brushRef="#br0" timeOffset="428084">4710 17604 6993,'-18'0'540,"8"7"-1,2 11 1,32 10 180,21-9-541,-11-16 1,2-6 45,8-10 0,-2-9-135,-16-1 0,-3-4 0,-3-2 45,2-8 0,-6-2-135,-7 3 0,-9 1 45,-14 8 0,-7 5-405,-24 11 225,19-1 0,1 8-225,-6 36 1,6 14 314,12-17 0,3 1 45,-1 5 0,1 5 0,6-3 269,13 7 1,7-4-180,1-9 0,5-5-90,9 0 0,4-7 90,2-10 0,0-10 45,-4-13 0,-3-7 45,2-9 0,-4-3-90,-8 4 0,-2 1-90,0 1 0,0 3 0,6 7 0,6 9-180,2 8 360,0 0 359,-13-8-449,-8-2 0,-28-15-90,8 13-899,-26 4-1,15 33 585,5 0 1,5 3 179,8 4 0,8 1-45,16 5 0,9-5 135,1-9 0,5-11 165,-2-16 0,3-10 0,-3-3 15,3-6 0,-4-8-173,-13 0 0,-1-6 0,-1-3 0,-3 0 105,-4 4 1,-1-1-1,-3 0 1,1-2-23,0-4 0,-1-1 0,0 0 0,-3 1 195,-3-6 0,-2 2 0,-2 5 74,-3-1 1,-4 13-675,-11 23-90,7 36 1,3 17 89,6-13 0,2 2 1,0 3-41,0 2 0,-1 3 0,1 1 0,4 0 422,4 2 1,3 2 0,2-1-1,3-4-112,4 4 0,4-4 0,2-3 0,-2-3 0,2-3 1,2-18 562,17-30 0,-4-23-174,-18 6 1,-5-7 0,-2-5-150,-4 6 0,-1-4 0,0-2 0,-2-3 0,0 1 0,0 2-521,-1-6 1,0 0 0,-1 1 0,0 0 0,-1 0 460,0 1 0,1-1 0,-2 2 0,0 1 0,-2 2 210,-3-11 0,-2 4 0,-1 10 59,-3 2-1258,-9 45 314,6 24 1,4 14 314,2-9 0,1 4 0,1 3 0,1 1 4,0-1 0,1 3 0,1 0 1,0 1-1,2-1 248,1-2 0,1 1 0,1-2 0,1 0 0,0-2 40,0 3 1,0-1-1,1-3 1,3-4 22,9 17 0,3-18 564,3-32-250,-6-8 2359,-7-39-2088,-1 6-900,-9 9-360,3 28 1918,1 20-1603,1 4 0,3 3-225,4 1 1,4-1 449,10-2 0,3-11 629,0-20 1,-2-12-45,1-16 0,-4-8 89,-9-1 1,-4 0-271,-6 1 1,-3 17 495,-4 64-900,0-15 0,0 5-281,1 8 1,0 7 0,1 4 0,-1-2 347,1-3 1,-1 1-1,1 0 1,0 1-104,0-2 0,2 1 0,-1 1 0,-1-2 0,-1-2 156,-1 11 0,-2-3 0,-5-5 509,-8 1 1,-8-16-585,-16-34 0,-7-15 165,11 3 0,1-3 0,0 0-240,3 1 0,1 0 0,2 0 120,-4-4 0,5 5 0,10 10 0,12 8 0</inkml:trace>
-  <inkml:trace contextRef="#ctx0" brushRef="#br0" timeOffset="430433">8122 16633 7533,'-18'-25'2248,"-1"13"-1888,0 12-270,11 24 0,4 11-90,0 2 0,3 5 0,0 3-463,3 1 0,0 3 0,2 2 0,-1-2 350,0-3 1,0-1 0,1-1-1,0 0 113,1-1 0,2 0 0,-1-2 0,0-5 140,1-2 1,0-6 39,4 4-180,-11-32-270,-22-8-449,-11-18 494,5 15 0,-5 1 785,-8-10 1,-3 6-246,-1 23 0,1 12-45,13-3 0,1 4 0,4 2-1,-4 13 1,9 5-60,15-6 0,6 3 0,6-6-75,5-11 0,7-3-315,6-1 0,7 0 0,1-5-45,15-5 0,2-6 75,-8-4 0,1-2 1,-1-6 238,-1-6 1,-2-6 0,-4-1 450,5-9 0,-8-4-360,-7-3 0,-8-1 179,-13 10 1,-6 1 270,-15-8-450,-8 10-990,0 19-225,12 31 1,5 11 854,8-1 1,6 2 59,1-1 0,2 3 0,3-2 210,8 12 0,7-6 89,8-6 1,4-7-45,-6-10 0,0-9 360,1-12 0,-4-11-136,-8-10 1,-5-7-135,-5-5 0,-4-1-270,-2 7 0,-4 6-315,-7 14-45,0 32 1,0 17 254,2-4 0,2 5 0,-1 2 10,0-5 0,0 2 0,0 0 0,1-1-190,5 9 0,1-1 0,0-4 645,0 9 0,1-21 584,12-70-944,-12 7 0,-3-8-240,0 7 1,0-6-1,0-2 1,0-2-1,1 2 303,0 1 0,0-1 0,1 0 0,0 0 0,-1 1 341,2-9 1,-1-1 0,1 2 0,2 3 119,2-6 1,1 3 0,7 19-30,31 32-360,-27 19 0,-1 11-510,1 4 0,2 5 1,-3-1-61,-6-8 0,0-2 1,-2 1 389,7 15 0,-7-2 681,-11-15 1,-8-5-142,-31-9-810,5-21 0,-2-5-360,5 1 1,1 0 1023,0 1 0,10 0 0,24 2 0,17 7 0</inkml:trace>
-  <inkml:trace contextRef="#ctx0" brushRef="#br0" timeOffset="431329">8996 17551 8612,'-1'9'990,"18"7"-361,27-14-224,-16-7 0,1-6-315,4-4 0,-4-7-135,-6-15 0,-8-4 45,-11 7 0,-7 1 0,-1 3 0,-8 7-45,-16 13 0,-3 12-225,6 26 0,4 11 180,-1 2 0,5 4 120,8-10 0,2 2 0,7-1-60,7 0 0,5-1 0,3-4-15,6 0 0,5-5 45,12 4 0,3-9 225,-8-20 0,-2-8 45,4-8 0,-4-7-136,-6-16 1,-6-5 45,-5 9 0,-2 2-270,-2 3 0,-3 7-180,-7 14-89,5 41-1,7 6 135,1-10 0,4-5 495,26-4 314,-6-41 1,-1-15 0,-7-2 0,-3-4-286,-7 6 1,0-1 0,-4 2 374,-5-6 1,-2 13-315,-3 26-1349,1 32-650,3 11 1,5 4 1630,3-9 1,4-3 0,8 0-1,4-6 1,1-15 0,1 0 0</inkml:trace>
-  <inkml:trace contextRef="#ctx0" brushRef="#br0" timeOffset="432692">10436 16792 7533,'-7'-10'270,"-4"-5"359,9 28-179,2 31-46,6 0 1,1 10-544,-2-11 1,-1 4 0,1 3 0,0 0 120,-1-10 0,0 1 0,0 0 0,-1 0 0,1 0-185,1 8 1,0 0 0,-1-1 0,0-4 312,0 0 0,0-3 0,-6-15-290,-8-18-179,-5-31 89,-7-13 0,-3-3 225,4 10 0,-3 1-45,-8-9 0,-3 4 225,4 13 0,-1 10 965,3 18 1,2 10-921,5 16 0,7 6-135,3 1 0,6 3 135,6-8 0,4 1 0,3-3 0,9 1 0,5-3-150,1-4 0,5 0 0,3-6-330,9-7 0,3-6 0,0-3-139,-4-1 0,-1-3 0,0-3 439,3-7 0,-1-5 0,-4-2 45,2-5 0,-7-5 315,-8-4 0,-6-2 179,-3 2 1,-7 3-450,-25-12-180,3 15-270,-18 46-449,20 15 613,5-12 0,6 3-389,13 2 0,7-2 46,8 1 674,6-17 0,2-11 44,-6-21 1,-3-11 180,2-2 0,-2-2 0,-6 1 0,-4-1 134,-4-5 1,-4 6 45,-6 19-900,0 6-180,5 36 45,2-3 1,4 2-91,10 2 0,6-3 315,4-2 1,3-10 493,9-20 1,0-12 135,-9-3 0,-4-9-333,-10 1 0,-1-7 0,-3-3 0,-1 0 220,-4 2 0,-3-1 1,0-1-1,-1-2-175,1 1 0,0-3 0,-1-1 0,0 1 0,-2 2 265,0-5 0,-2 1 1,0 2-1,-1 2 52,2-6 1,1 2 0,-9 21-210,-12 32-180,10 15 0,2 9-270,-3 1 0,-2 4 1,2 5 71,3 1 0,3 7 0,0 2 0,3 0 0,0-4-268,3-1 0,3-3 0,0 0 0,0 3 241,-1-4 0,-1 4 0,1 1 1,1-1-1,1-3 0,1-6-75,5 3 0,2-5 1,3-7-376,7-2 0,-2-15-2602,-4-46 3192,-4-5 0,-14-4 0,-6-6 0,0 3 0,0 0 0</inkml:trace>
-  <inkml:trace contextRef="#ctx0" brushRef="#br0" timeOffset="432855">11297 17198 7533,'-26'-29'3276,"41"5"-1676,18 21 0,8 6-2320,-8-3 1,3 0-1,0 0 720,6 0 0,0 0 0,3 0 0,-6 0 0,3 0 0,-1 0 0,1 0 0,0 0 0,0 0 0,-1 0 0,1 0 0</inkml:trace>
-  <inkml:trace contextRef="#ctx0" brushRef="#br0" timeOffset="433722">13328 17762 9062,'13'8'2518,"-2"10"-2158,-22 25-990,3-13 1,-3 3-945,-7 4 0,-1-2 1574,9-9 0,-1-5 0,-22-5 0,19-36 0</inkml:trace>
-  <inkml:trace contextRef="#ctx0" brushRef="#br0" timeOffset="435424">14472 16986 7533,'-6'-35'899,"-1"8"-449,-5 9 90,0 57-271,7-7 1,1 7 0,1 4-180,0 2 0,2 4 0,0 2 0,-1 2-420,1-12 0,0 2 0,0 1 0,0 0 0,0 0 1,1-2 203,0 6 0,0-1 0,1-1 0,1-1 0,0-3 186,2 12 0,1-3 0,4-13 665,17-7-905,0-72 30,-13 7 0,1-8 1,-1 0-1,-2 3 0,-1-1 0,1 0 240,3-4 1,0 0 0,2 4 628,6-5 1,4 18-90,-4 33 0,-1 13-540,-1 22 0,-7 13-293,-6-16 1,-2 6-1,-3 0 1,-3-4 618,-6 1 1,-3-4-1,-3 1-386,-3 4 0,-2 0 0,-6-11-75,-20-11 0,-4-10-315,14 1 1,2-7-529,3-9 0,9-7-11,22-16 89,25 10 1,10 1 539,-9 3 0,2-1 0,2 1 270,13-1 0,3 1 0,0-2 45,-10 1 0,0-1 0,0 0 0,-3 2 226,1 3 1,-3 1 0,-2 0 897,43-22 328,-74 32-597,-13 8-631,-12 10 1,6 9-630,12 16-629,30-5 359,6-3 543,4-25 0,4-10 87,-8-13 0,0-8 135,7-4 0,-3-6-45,-6-9 0,-5-1 135,-5 13 0,-9 9 134,-14 19-269,-3 32-225,-3 1 1,6 2 134,13-6 0,8-3-135,4 0 0,7-7 135,12-12 0,5-12 149,-12-8 1,0-8 0,-1-6-237,-3-3 1,-1-6 0,-2-4 0,-2-3 175,-4 3 1,-2-4 0,-2-1 0,0-2 0,0 0-553,0 1 0,0-2 0,0-1 0,-1 0 0,-1 2 0,-2 2 552,-1 2 1,-1 1 0,-2 2 0,0 1 0,-1 3 449,3-16 1,-2 3 0,-7 24 270,-9 31-511,-3 22 1,-2 16 0,2 2-323,5-10 1,2 1 0,2 2-1,0 4-333,1-1 0,2 5 1,0 2-1,1 1 0,1-1 1,2-2-59,1 2 0,3-1 0,1 0 1,1-1-1,1 0-242,2 3 1,0 2-1,2-1 1,1-6 0,2-8-41,9 6 0,1-21 696,7-40 0,-27-14 0,-10-10 0,-3 5 0,-5-3 0,1 1 0,1 5 0,-1 0 0,1 0 0</inkml:trace>
-  <inkml:trace contextRef="#ctx0" brushRef="#br0" timeOffset="435583">15887 17515 7329,'-7'-40'655,"0"-1"0,0 0 1,1 1-1,4 11 0,2 1 437,2-20 0,4-7 0,10 17-590,20 32 0,11 10-1200,-10-7 1,3-1 0,3-1 0,1 1 509,-2 1 0,2 0 0,1 0 0,1 0 0,-1-2 0,2-2 0,1-1 0,0-2 0,0 1 1,1-1-1,-4 1 0,0 0 0,-1 0 0,1 0 0,0 0 0,-1 0 0</inkml:trace>
-  <inkml:trace contextRef="#ctx0" brushRef="#br0" timeOffset="437050">17511 17551 7533,'7'-27'1484,"-1"1"0,6-19-315,-5 9-89,-12 27-451,-15 42-449,4 4 0,1 6-420,7-7 0,2 1 1,0 0 89,-3-2 0,2 0 0,7-5-660,15 4 1,8-15 179,13-45 697,-13 3 1,4-8-1,0-3 1,-4 1-126,-3-1 1,-4 0 0,0-2 207,8-11 0,0-1 0,-9 10 1109,-14 8-540,-9 48 1,-3 13-1305,0 4 1,0 3 134,3-4 0,0 2 1,7 0-946,13 13 1,10-6 584,3-16 1,8-5 449,4-6 0,5-3 1,0-7 359,-7-9 0,0-6 0,0-4 0,4-7 0,-1-4 0,-6-5 269,-9-2 1,-7-4 0,-4 1 1034,-5-9 1,-9 4-676,-8 8 1,-7 11 270,-27 28-900,13 5 90,16 17 0,7 5-45,4-7 0,6 1-645,7 3 0,5 2 1,3-4-121,11 3 0,4-7 315,4-4 1,-1-11 494,-5-16 0,-6-9 45,-12-10 0,-7-5 44,-3-6 1,-4-1 895,0 7 1,-3 1 903,-7-15-1979,11 43-180,35 4 90,-6 2 0,3-4 450,12-18 0,1-9-612,-12 4 0,-1-3 0,-2-4 252,-4-2 0,-1-4 0,-2-3 0,-1-1-23,-2-2 1,-2-3-1,-2 0 1,0-1-50,-4 5 0,0 0 0,-1-1 0,-2 0 0,-1 2 72,1-5 0,-2 0 0,-3 2 0,-3 5 1079,-7-16 1,-8 22-585,-3 39 0,-2 17-608,5 4 1,1 10-1,2 4 1,0 3-311,4-8 0,0 2 0,1 3 0,1 0 0,1 1 0,1 0-57,2 3 0,2 0 1,1 1-1,1 0 0,0-1 1,1-2 209,0 2 0,0-1 0,0-1 0,3-1 1,2-3-496,4 4 0,2 1 1,2-6-1,1-15-314,17-12 1079,-16-35 0,-6-15 0,-7 4 0,-5-5 0,-2-4 0,-1 0 188,-1-6 0,-2-2 1,-1-1-1,-1 0 467,2 10 0,0-1 1,-1 0-1,0 2 0,0 2 437,-4-7 0,0 2 0,7 7 84,11 6 1,8 11-1537,17 27 0,6 13 180,-8-7 0,2 1 1,3-2 223,7-2 1,4-2 0,3-2 0,0-4 0,-6-5 0,1-2 0,1-3 0,1 0 0,2 0 0,-5 2 0,1-1 0,0 1 0,-1-1 0,1 1 0,0-1 0,0 1 0</inkml:trace>
-  <inkml:trace contextRef="#ctx0" brushRef="#br0" timeOffset="437850">19961 17498 7533,'0'-28'2788,"-5"3"-1798,9 15-541,-3 18-359,16 27-270,-5-5 0,1 3-135,3 0 1,5-1-91,5-8 0,3-3 135,-6-6 1,0-7-1,2-13 0,-2-6 360,2 0 1349,-2 17-989,-4 15-270,3 12 0,3 3-180,-6-11 0,2-1 59,4-3 1,4 1 0,-1-6-150,5-7 1,0-7 44,8-9 0,-3-11-720,-6-18 0,-8-9-15,-10 13 1,-5-3 0,0 1 14,1-17 1,-4 4 764,-6 14 0,0 5 0,6-5 0,1 15 0</inkml:trace>
-  <inkml:trace contextRef="#ctx0" brushRef="#br0" timeOffset="438755">20859 16686 7533,'-5'-35'1638,"-1"0"0,-8-12-507,-21 53-861,21 19 0,4 13 0,1 3-210,-1 3 0,1 3 0,2 5-400,3-10 0,0 4 0,1 1 1,2 1-1,2 0 178,3 1 0,1 2 0,3-1 0,0-1 0,1-1-468,0-6 1,1-1-1,1-1 1,0-1-1,0-1 472,1 5 1,0 2 0,1-6 0,3-11 515,11-9 1,-2-15-270,-5-35 316,-12 0 0,-4 1 1484,-4 1-810,-1 13-1079,12 34 892,4 9-1387,13-4 1,7-3 404,-9-7 0,2-4-60,4-3 0,4-2 0,-3-7 240,2-11 0,-3-7 180,2-3 0,-8-7-1,-14-15 1,-11-2-135,-9 17 0,-3 2-90,-1-6 0,-4 11-135,-24 32-270,19 29 270,9-4 0,6 4-90,10-1 0,7 3 1,2-2 59,0-4 0,2 0 0,3-3 30,1-1 0,3-1 0,2-5 0,16 5 0,1-16 90,-10-31 0,-3-9 135,4 4 0,-3-3 15,-13-3 0,-5-4 0,-1 2 344,1-3 1,-4 5-315,-7 2-450,-1 32 180,1 24-180,18-3-359,24-7 629,-4-15 0,3-4 449,-1 1 1,0-2-135,0-6 0,-1-2 134,-11 3 1,-3 5 810,1 17-3599,-8 22 765,-14-2 0,-3 1 1574,-1 13 0,0 0 0,0-31 0</inkml:trace>
-  <inkml:trace contextRef="#ctx0" brushRef="#br0" timeOffset="440000">23025 17392 7533,'-30'-8'449,"4"-2"451,1 1-540,13 1 179,-10 16 1,8 13 0,2 7-315,-5 2 0,1 6-344,3 6 0,2 6 0,5-1 29,7-5 0,4-2 0,4 0 0,2-1 0,4-1 1,4-7 179,11-3 0,6-13-61,-2-18 1,5-11 0,-1-5-30,-2-6 0,-1-7 0,1-1-107,-2 5 0,0-2 0,1 0 0,-1 1 219,-2 2 0,-1-1 1,0 3-1,0 5-52,3 1 0,-1 5 0,-2 10-375,4 16 1,-8 13-136,-14 17 0,-12 8 240,-6-11 0,-4 1 1,-3-3 286,-9 2 1,-5-4-123,-10 3 0,-4-11 360,8-25 0,-1-8-46,-8 0 1,3-8 584,9-18 1,6-6-675,1 0 0,9 1-45,17 4 0,8 3 45,17-3-45,1 29 0,5 8-90,-1 3 0,1 4-90,4 4 0,2 5 165,-12-3 0,0 2 0,0-2 104,8 0 1,1-3-180,-4-2 0,-1-8 45,-10-14 0,-3-7 90,2-8 0,-3-3 179,-2 0 1,-3 1 180,-1 1 0,1 7 179,15 17-1079,-11 17 1,-1 7-946,-3 5 1,1 3 211,6-4 1,4 1 0,-3-4 948,9 9 1,7-14 0,3-5-1,-11-13 1,-1 0 0</inkml:trace>
-  <inkml:trace contextRef="#ctx0" brushRef="#br0" timeOffset="440858">24748 16722 7533,'-20'-20'899,"10"40"1,3 15-781,2 0 1,1 5 0,0 4-776,1-1 1,0 4-1,-1 3 1,1 0 0,-1-2 535,0-6 1,0-2-1,0 1 1,0 0-1,1 2 45,-1 3 0,1 3 0,-1 1 0,1-1 0,0-4 0,0-7 689,0 11 1,0-6-705,1 10 0,-1-22 210,-1-54 0,-3-17-345,-6 7 1,-5 0 268,-2-1 1,-5 7 0,-9 13 0,-3 10 360,-1 16 0,1 10 134,-2 6 1,7 8-510,13 2 0,5 5 0,9-2-75,12 1 0,10-4 45,3 4 0,9-9-90,6-21 0,6-7 0,-1-7 1016,-5-4 0,-1-6 0,1-1-866,8 0 0,2-2 0,-3-4-90,-3-5 0,-1-4 0,-4 0 210,-6 1 0,-3-1 0,-2 2 224,-3 1 1,-4 3 495,-6 7-720,-22 34-450,4 5 0,3 3-315,2 4 1,5 1-187,4 1 1,6-1-714,6 1 0,7-6 1484,5-14 0,3-14 0,-4-21 0,0-14 0,-2-4 0,-5 2 0,0 0 0,0-1 0,0 1 0</inkml:trace>
-  <inkml:trace contextRef="#ctx0" brushRef="#br0" timeOffset="441076">25387 16951 7533,'0'-35'2788,"-5"23"-1709,3 37-1019,0 4 0,0 7 0,1 3-218,3 1 1,3 2 0,0 2 0,-1 1-409,-1 2 0,-1 0 0,0 1 1,1 2-91,1-4 1,1 2-1,1 1 1,-1-3 0,-2-4 428,1 4 0,-2-5 0,-1 0 227,1 3 0,-2-1 0,-2-23 0,-5-35 0,1-10 0,0 1 0</inkml:trace>
-  <inkml:trace contextRef="#ctx0" brushRef="#br0" timeOffset="441223">25363 17674 7533,'-11'-40'546,"-1"1"0,0-1 0,1 0 0,3-7 0,3 0 0,11 8 964,17 9 0,10 7-1600,0 9 0,5 3 0,3 1-730,-4 2 1,3 1 0,0 1 0,-3 1 409,3 1 0,-3 1 1,0 1-1,1-1 1,0 0-1,-5 1 0,16 2 1</inkml:trace>
-  <inkml:trace contextRef="#ctx0" brushRef="#br0" timeOffset="441655">25745 17674 7533,'-28'-6'1214,"-1"0"0,-4 16-1709,19 13 1,6 7-181,8 6 1,6 1-136,1 0 1,4-2 809,5-3 0,5-11 0,24-27 0,-18-9 0,1-1 0</inkml:trace>
-  <inkml:trace contextRef="#ctx0" brushRef="#br0" timeOffset="442367">26064 17657 7533,'0'-26'1799,"-11"-1"-1260,-8-1-269,-18 34-360,5 31-45,13 5 0,7 4 90,10-3 0,9-1-135,15 1 1,9-8-1,-4-20 0,4-10 180,14-17 0,-2-12 180,-17-2 0,-6-6 29,-6 1 1,-2-3 0,-3 5 240,-2-13 180,-25 11-181,-4 64-584,6-7 1,2 3-136,4 7 0,8 1 135,14-3 0,9-5 90,6-15 0,4-9 45,11-14 0,0-9 0,-6 0 0,-4-5 405,-9-11 0,-5 1 1034,0 3-1169,-11 13-540,9 42-540,14 7 361,4 3 44,0-19 0,2-9 135,-11-14 0,-2-7 315,7-2 0,-5-5 585,-18-18 0,-12-3-361,-5 11 1,-7 4-90,-4 1 0,-5 10 225,-7 22 0,2 14-1035,12 8 0,10 7-1009,13 6 1,12 0 1592,13 0 0,9-10 1,-3-20-1,4-9 1,1-3-1,0-7 1,1 0-1,-1 1 0</inkml:trace>
-  <inkml:trace contextRef="#ctx0" brushRef="#br0" timeOffset="442751">27123 17145 7533,'0'-42'819,"0"-1"0,0 1 0,-3-12 0,-5 19 492,-11 41-1311,7 21 0,3 13-60,2 5 0,1 7 0,2 0-369,1-4 0,1 1 0,1 1 181,2-6 1,0 2 0,1 0-1,0-2-232,0 4 1,0-2-1,1-3-48,0 7 0,1-8 528,1 6 360,-21-90 224,4 18 1,-3-1 135,-7-9 0,-5 6 314,-1 16 0,0 12-838,6 21 1,4 11-1321,4 9 0,5 4 359,7 5 1,5-2 764,4-11 0,-1-5 0,-5-5 0,-2-11 0</inkml:trace>
-  <inkml:trace contextRef="#ctx0" brushRef="#br0" timeOffset="442950">25954 17427 7533,'-37'-25'472,"22"21"0,16-2 0,25 24 1</inkml:trace>
-  <inkml:trace contextRef="#ctx0" brushRef="#br0" timeOffset="443200">25093 17410 7533,'-38'-8'359,"18"6"1,43-12 0,20-4 0,-9 9 0,0-1-1,0 0 1</inkml:trace>
-  <inkml:trace contextRef="#ctx0" brushRef="#br0" timeOffset="444273">27947 17463 7533,'-5'-18'1619,"-2"0"-990,0 1-539,-9 7 180,-9 2-180,-8 19 0,-5 9 225,1 1 0,0 5-136,3 7 1,-1 5 0,7 3-180,10-2 0,5 1 0,9 1-180,10 0 0,8 0 1,7-6-316,13-1 0,10-13 195,0-17 0,5-9 1,-4-6 119,0-9 0,-5-9 390,-10 2 0,-1-5 0,-6-1 239,-6-8 1,-7 0 45,-2-1 0,-5 2-46,-7 6 1,-6 15-450,-10 35 0,-1 15-405,8-5 1,3 5 284,-2 2 0,1 3 0,5-2-105,7 3 0,9-5-45,13-5 0,8-9 630,8-14 0,5-12-31,-7-5 1,2-6 0,-3-4 60,-1-5 0,-1-4 0,-3-2 119,-5-3 1,-1-2 0,-3 9 479,15 7-629,-20 15-1395,-12 42 1,1 14-605,13-17 1,3-3 1552,-6 7 0,5-7 1,10-20-1,8-9 1,-1-4-1,-5-6 1,-1 1-1,1-1 1</inkml:trace>
-  <inkml:trace contextRef="#ctx0" brushRef="#br0" timeOffset="445017">29708 17357 7533,'0'-18'1259,"0"0"-449,0 9-541,-6-7 631,-12 6-181,-14-8-449,-3 11 0,-6 5-135,-3 3 0,-3 6-157,7 3 0,-2 4 1,1 5 141,3 6 0,3 5 0,2 3-571,5-1 1,2 3 0,5 0 480,3-2 0,2 0 0,9-1-300,9 6 0,12-8 225,8-16 1,7-8-856,10-10 1,4-10 929,-10-4 0,0-6 0,-1-4-49,-7 0 0,0-4 0,-3-1 0,-1 2 468,1 0 1,-1 1 0,-5 1 775,-3-8 0,-8 15-955,-22 52-585,-2 11 0,1 6 90,7-13 0,3 0-868,4 2 1,2 3 0,8-8 1238,9-10 1,6-6 0,13-6-1,6-9 1,-6-13 0,-1-1-1,1 0 1</inkml:trace>
-  <inkml:trace contextRef="#ctx0" brushRef="#br0" timeOffset="446006">30101 17357 7533,'-24'-34'1709,"-12"5"-180,3-6-810,-15 33-269,4 21-270,21 11 0,3 9-180,7-8 0,3 2 0,1 1-90,2 2 0,2 1 0,5 0-270,5 0 0,5 0 1,4-6-136,8 3 0,7-13 630,14-22 0,1-13 0,-13 0 0,-3-8 15,-2-11 0,-2-9 0,-5 2 74,-6-4 1,-4 2-45,6-7 0,-7 7 1349,-19 15-1664,-1 54 1,-2 22 21,4-13 1,-1 4-1,0 3 1,-1 1-395,3-1 1,-1 1 0,1 2 0,-1 0 0,-1 0 506,1-3 0,-1 0 0,0 1 0,0-1 0,0-1 0,0-2-23,-2 7 1,0-3-1,0-1 1,-2 0 67,-2 0 0,-1 2 0,-2-5 0,-1-10 90,-7-8 0,-2-10-135,-1-9 0,1-10 150,9-15 0,3-10 0,2-2 29,0-4 1,1-2 0,2 0 120,0-2 0,1 0 0,6 1 29,7 1 1,5 0 0,2 6-420,1 3 0,7 5-30,11 9 0,8 4 0,1 4-210,-3 4 1,1 4-1,2-1 17,1-1 0,3 0 0,1-2 1,-1-2 491,0-3 1,0-3 0,-1-1 0,0 0 247,-2 2 0,0-1 1,-1-1-1,-3-3 665,4-12 0,-4-3 0,-4-2-403,-6 5 1,-3-2 0,-5 1-825,-3-6 0,-4-2 15,-1 2 0,0-1 0,-5 4-330,-11-12 1080,-1 6 0,-5 11 539,-25 42-719,2 10-176,21 18 0,11 8-319,13-9 0,7 2-135,1-5 0,4 2 1,3-4-914,6-6 1,4-3 0,2-2 860,5-1 0,2-2 0,-3-7 0,0-10 0,-2-8 0,-5-8 0,-1 0 1</inkml:trace>
-  <inkml:trace contextRef="#ctx0" brushRef="#br0" timeOffset="446167">31258 17709 7533,'-25'0'819,"11"0"0,3 0 0,11 0 0</inkml:trace>
+  <inkml:trace contextRef="#ctx0" brushRef="#br0" timeOffset="-214230.73">13943 12718 7533,'-13'-10'1619,"1"26"-1305,5 16 1,2 12 75,0 0 0,0 4 0,3 3-311,1-5 1,2 1 0,1 2 0,0-1-350,-1 0 0,1 1 1,0-2-1,1-3 239,2 2 1,2-4 0,0-4-15,2-1 0,-6-15 320,-14-32-365,-7-11 0,-6-3-210,-1 3 0,-2-1 0,-2 2 120,-12-6 1,-2 5-200,9 9 1,-1 3-1,2 4 559,-2 6 0,1 8 120,3 8 0,-1 6 0,5 4 88,8 1 1,3 3 0,3 2-209,-1 5 0,3 2 0,11 0-61,16 0 1,12-1 0,5-5-270,3-5 0,4-6 1,3-2-276,1-3 0,3-2 0,1-7 267,-6-7 1,1-5 0,1-3-1,-4-3 8,1-5 0,-2-5 1,-1-3 41,-5 2 0,0-2 1,-2-2-1,-3 0 108,1-3 0,-3-1 0,-9 1 1112,-11-7 1,-11 7-843,-12 17-56,-7 26 1,0 11-170,7 4 0,8 5 90,8 12 0,6 0-135,0-14 0,6-3 315,23 3 0,8-9 179,-10-19 1,2-9 44,5-9 1,2-9 0,-1-4-240,-5-6 0,-2-4 0,1-3-405,-7 8 0,1-3 0,0-1 1,0 2-1,-1 2-435,1 1 0,-2 1 1,1 2-1,1 5 540,7 1 0,1 5 0,-2 7 0,1 11 0,-4 10 0,-7 17 0,0 0 0</inkml:trace>
+  <inkml:trace contextRef="#ctx0" brushRef="#br0" timeOffset="-212890.73">16749 13317 7533,'-13'-37'270,"-5"12"359,-22 25-404,12 3 0,-2 3-180,-12 6 0,-2 2 105,8-4 0,-1 1 0,0 3-174,-4 8 1,-1 5-1,1 1 204,1-2 0,0 1 0,5 4 149,5 4 1,4 4 0,7 1-129,9-5 0,5 1 0,9-2-141,11-1 0,9-2 0,4-4-120,8-5 0,4-4 0,3-4 15,-7-4 0,1-2 0,1-3 0,2-4-196,7-5 1,2-5 0,0-4 0,-2-2 127,-4-2 1,0-3-1,-2-1 1,-1-2 22,1 0 0,0-2 0,-3-1 0,-4-1 0,2-8 0,-5-2 0,-11 3 0,-13-1 1,-13 7 493,-17 15 1,-7 8-225,-6 7 0,-1 8 59,5 7 1,-1 7 0,5 2 120,1 13 0,6 4-330,8-8 0,2 2 0,10-1-240,12 2 0,10-1 0,5-6-90,7-11 0,5-6 1,2-7 179,8-7 0,2-8 0,-3-4 90,-9-1 0,-2-4 0,-4-6 180,2-10 0,-5-7 0,-5 6 465,-1-10-165,-5 10 0,-8 4 117,-21 18-477,-3-4-34,-11 32-56,6 11 899,12 11-179,8-13 0,5 1-91,19 11-314,-8-14 0,2-3-585,20 0-675,-12-31 1,-1-10-46,-8 1 1,-2-3 629,4-12 1,-4 0 89,-4-1 270,-7 21 449,-5 22-179,0 11 90,0-6-90,6 4 180,1-24-180,16-10-1710,-2-9-718,9 7 2158,-11 4 0,-1 32 0,-6 4 0</inkml:trace>
+  <inkml:trace contextRef="#ctx0" brushRef="#br0" timeOffset="-212357.73">18213 12788 7533,'-5'-19'3276,"9"66"-2929,-5-13 0,-1 5 0,1 5-934,1-5 0,0 2 0,0 3 0,0 1 0,0 0 407,-1 3 0,0 0 0,-1 2 1,0-1-1,1-1-396,0-2 0,-1 0 1,1 0-1,-1-2 0,1-3 236,0 11 1,-1-4-1,0-5 25,-3 1 1,-2-13 314,-1-23 0,-12-26 0,-5-13 0,2-3 0,0 1 0</inkml:trace>
+  <inkml:trace contextRef="#ctx0" brushRef="#br0" timeOffset="-212209.73">18016 13600 7533,'-4'-49'655,"0"0"0,0 0 1,8 6-1,5 2 0,11 5 164,9 11 0,10 5 0,4 3 0,1 3-1475,-6 4 1,2 3-1,1 2 1,0 1 0,-1-2 381,8-2 1,1-2 0,-1 2 0,0 3 0,1 4 0,0 3 0,-1 2 0,-3-1 0,-2 0 0,-1 0 0,0 1 0</inkml:trace>
+  <inkml:trace contextRef="#ctx0" brushRef="#br0" timeOffset="-211570.73">19001 13494 7533,'-25'-26'2608,"-10"15"-2473,9 0 0,-3 6-90,-13 20 0,-2 9-15,12-11 0,0-1 0,0 4-108,-3 10 1,2 4 0,2 0 346,7-4 1,2 1 0,6 1 399,3 16 1,12 0-805,10-13 0,10-5-255,9-10 0,8-4 1,0-7 269,-1-8 0,0-6 0,1-4 57,-1-1 0,1-3 1,0-2-1,-4-2 243,3-7 0,-3-4 0,-3 0 119,-2 1 1,-3 0 0,-8 3 780,-9-17 139,-29 39-859,-11 41-720,19-10 0,5 3 360,5 7 0,8 1-1639,7-6 1,6-4-1,12 0 1,4-8 1429,-8-11 1,0-7 0,12-12 0,-5-9 0,-16-2 0,0-1 0</inkml:trace>
+  <inkml:trace contextRef="#ctx0" brushRef="#br0" timeOffset="-211371.73">19358 13564 7533,'0'-43'3276,"0"22"-436,-12-3-2120,4 55-2339,-10 9 584,15-6 1,5 2 1034,6 2 0,7-5 0,10-15 0,6-5 0,10-2 0,1 0 0</inkml:trace>
+  <inkml:trace contextRef="#ctx0" brushRef="#br0" timeOffset="-210988.73">19603 13600 8792,'-29'5'3276,"8"23"-2935,10-2 0,5 3-296,13 7 0,7-2-315,-2-7 0,5-7-45,19-12 0,4-14 285,-11-11 0,-2-9 0,-1-1 90,-1 2 0,-1-1 0,0-4 10,-2-3 1,1-4 0,-1-1-1,-3 5 515,3-4 0,-3 4 134,2-9 1,1 15-270,6 43-1440,-12 12 1,-2 9-31,-2-6 1,-1 3 0,-1 0 89,1 2 1,0 1-1,-1-4 930,1 2 0,-5-5 0,-22 11 0,-11-33 0</inkml:trace>
+  <inkml:trace contextRef="#ctx0" brushRef="#br0" timeOffset="-210813.73">19493 13070 7533,'-29'-8'655,"1"-1"0,-9-1 1,47 10-1,24 10 0</inkml:trace>
+  <inkml:trace contextRef="#ctx0" brushRef="#br0" timeOffset="-209630.73">21868 13247 7892,'0'-37'3276,"-11"3"-2414,-19 24-1132,-3 18 0,-6 8 150,2-1 0,-3 3 1,-1 4-16,5 0 0,-1 4 1,0 2-1,2 2 270,0 3 0,0 3 0,2 0 0,4 0 74,-4 1 1,4 0 0,10 2 210,12 7 0,11 2 0,10-8-792,21-10 0,13-9-416,-11-8 1,6 0 0,1-4 0,-2-3 637,5-5 0,-1-6 1,0-1 100,3 0 1,1-1 0,-7-7 0,-13-5 0,-5-5 0,-1 0 0,-1-1 0,-1 0 0,0 1 0</inkml:trace>
+  <inkml:trace contextRef="#ctx0" brushRef="#br0" timeOffset="-209458.73">22065 13317 7533,'-18'-19'3276,"5"19"-1638,5 20 0,3 11-1946,1 8 0,3 4-262,4-10 1,4 1-1,-1-1 286,2 13 1,5-4-1,11-13 1,5-5 0,0-7-1,0-1 1</inkml:trace>
+  <inkml:trace contextRef="#ctx0" brushRef="#br0" timeOffset="-208839.73">22557 13635 7533,'-37'33'2248,"6"4"-988,12 1-811,8-21 181,11-42-450,0-4 0,0-5-60,3-3 0,1-5 0,0 0-390,-2-6 0,0 0 0,2-1 180,0 10 0,1 0 0,2 1 0,0 1-90,3-8 0,1 2 1,4 7-271,2 7 0,5 11-360,12 18 1,4 12 809,0 13 0,-1 7 0,1-1 0,0 0 0,1-5 0,0-1 0</inkml:trace>
+  <inkml:trace contextRef="#ctx0" brushRef="#br0" timeOffset="-208480.73">23222 13264 7533,'-12'-25'3276,"-1"5"-2505,-5 3-861,-1 9-179,-22 31 224,16-6 0,-1 4 75,0 4 0,-1 5 0,1 1 269,3-4 1,1 1 0,2 1-60,0 3 0,2 0 0,7 0-240,5 5 0,12-3-585,13-5 0,11-5-584,14-8 0,4-5 764,-11-1 0,1-4 405,-1-9 0,2-3 0,-7-1 0,7-5 0,-10 0 0,-1-1 0</inkml:trace>
+  <inkml:trace contextRef="#ctx0" brushRef="#br0" timeOffset="-208080.73">23394 13441 7533,'0'-26'1484,"0"1"0,0-22-764,-6 2-451,-11 27-449,4 36 1,0 13 313,-1 2 1,2 3-75,3-3 0,2 4 0,5-1-150,8 14 0,10-4-315,11-13 1,7-10 494,7-11 0,3-14 149,-8-10 1,0-8 0,-4-3-300,3-13 0,-6-4 240,-9 12 0,-2-1 0,-4 0 989,-1-16 0,-7 5 270,-4 13-2068,-5 21-1010,1 37 1,3 18 1395,0-13 1,6-1-1,8-6 1,5 0-1,2-5 1,11-6-1,0 0 1</inkml:trace>
+  <inkml:trace contextRef="#ctx0" brushRef="#br0" timeOffset="-207230.73">24083 13441 7533,'-14'0'1979,"-2"0"-810,4 23 180,4 22-989,1-9 0,3 1-136,7-3 1,5-3-314,16 4-361,15-61 315,-14-6 0,-2-8-15,-6 6 0,-3-3 0,-1 0 30,-1-2 0,-1 0 0,-2 1 390,1-6 0,-2 6 360,-3 11-270,-10 56-91,1 5 1,1 5-45,-1 0 0,1 2-135,2-7 0,2 2 0,4-4-315,10 1 0,6-5-90,1-5 0,2-11 90,13-31 1,-1-15 134,-9 9 0,-2-5 180,-8-3 0,-1-5 0,-1 3 764,4 1 1,-3 4-1,-8 2 1,0 7-136,3 13-854,-15 35 0,-5 16-645,5-10 1,1 1 0,2 1-314,1 2 1,1 0 0,3-3-193,6 5 0,6-7 565,7-12 1,4-7 719,6-12 0,0-10 0,-2-9 0,-3-7 0,5-7 0,0-1 0</inkml:trace>
+  <inkml:trace contextRef="#ctx0" brushRef="#br0" timeOffset="-206897.73">24908 13458 7533,'4'-45'1092,"0"0"0,-2 8 0,-5 4 546,-14 3 0,-7 9-1182,-2 15 1,-1 8-322,0 4 0,3 7-45,1 22 0,10 9-270,14 1 0,9 2-30,0-9 0,3 2 1,2-4 164,7 2 0,3-2-135,3 3 0,-3-3 810,-10 1 359,-38-10-405,-13-16 1,-9-6-1080,-3-4 1,-2-2-1145,1 1 1,5 0 1519,2 0 1,65 0 0,3 0 0,1 0 0</inkml:trace>
+  <inkml:trace contextRef="#ctx0" brushRef="#br0" timeOffset="-206430.73">25449 12894 7533,'-3'-27'1638,"-1"-1"0,4 1-507,-4 68-652,4-8 1,0 7 0,-1 3-188,-3 0 1,-1 3-1,0 3 1,1 1-730,1-3 1,2 3-1,-1 1 1,1-1-1,0-1-121,-1-7 0,0 0 1,1-1-1,0-1 1,1-2-403,3 16 1,1-2 0,2-9 1,0-6 0,1-17 958,6-37 0,-14-11 0,-4-5 0,-2-8 0,0 0 0</inkml:trace>
+  <inkml:trace contextRef="#ctx0" brushRef="#br0" timeOffset="-206268.73">25314 13335 7533,'-16'-26'1092,"0"-1"0,13-3 0,9-1 546,18-1 0,12 2-1455,-6 11 1,5 1-1,3 1 1,1 0-368,3 2 0,3 0 0,1 1 0,0 0 0,-2 2 0,4-2 1,-2 3-1,0-1 0,0 1 0,2 1 0,1 0 0,-1 0 1,0-1-1</inkml:trace>
+  <inkml:trace contextRef="#ctx0" brushRef="#br0" timeOffset="-205480.73">26052 13547 7533,'-19'-26'1799,"7"7"-1260,17-15-269,9 15 180,5-22 180,-12 19-271,-20-1 1,-8 5-225,-6 16 0,-5 8-405,-13-4 0,-3 7 360,10 12 0,1 6 0,2 2 90,8-5 0,2 1 0,4 2 59,1 9 1,5 4 0,7-4-285,11-1 1,10-3-46,7 1 0,10-8-45,12-18 0,5-12 75,-14-2 0,1-5 0,0-4 120,6-7 0,1-4 0,-3-3-297,-8 0 0,-2-1 0,-3 0 507,6-11 0,-10 3 1079,-21-4-1259,-19 51-315,2 18 0,3 9-360,2 5 1,3 4-316,3-8 1,1 1 0,5-4-496,6-2 1,6-5 404,5-2 1,3-9 989,20-31 0,-6-9 0,1-9 0,-14 6 0,1 0 0,-1 0 0</inkml:trace>
+  <inkml:trace contextRef="#ctx0" brushRef="#br0" timeOffset="-205038.73">26421 13370 7533,'-5'-25'2518,"4"-3"-989,-10 9-539,4 34-676,-2 6 1,0 5-90,4 17 0,2 3-720,-2-8 1,4-2-136,9 4 0,7-11 181,24-33 539,-6-15 0,0-9 134,-5-4 1,-2-5-45,-2 2 0,1-2 0,-4 1 359,-3 1 1,-2 4 1799,14-8-1170,-30 50-1124,-3 14 0,-2 7-255,-1 5 0,0 4 1,0-1-691,1 8 1,4 0-194,2-12 1,2 0 0,4-2-547,6 4 1,5-8 1516,16-10 0,-3-28 0,1-10 0,-6-10 0,-1 0 0</inkml:trace>
+  <inkml:trace contextRef="#ctx0" brushRef="#br0" timeOffset="-204413.73">27185 13335 7533,'12'-43'3276,"-5"13"-1785,-2-11-861,-16 30-361,-13-5-314,1 21 1,-4 6 44,-6 1 0,-2 3 269,6 1 1,0 2 0,1 1-135,-6 7 0,2 3-15,6-3 0,2 3 0,4 0 104,7 7 1,4 3-315,-2 9 1,6 0-46,11-15 0,6-2-135,11 6 0,7-7-45,8-15 0,6-9 225,-2-6 0,5-5 1,-2-5-415,-9-3 0,-1-3 1,0-2-1,-1 0 594,6-3 0,-2-2 0,-2-1-60,-1-6 0,-2-1 0,-8 1-30,-8 7 0,-6-1-90,-1-6 0,-9 0 674,-25-3 1,-10 5-135,10 9 0,-3 6-61,-7 8 1,-3 4 0,2 7-300,0 13 0,4 9-480,8 5 0,4 6 1,5 1-361,9-3 1,5 1-1,4-1-150,4 3 1,5 0 0,5-4-194,8-6 1,5-4 0,-1-4 981,-3 0 1,2-9 0,18-18 0,0-13 0,-16-7 0,-1 1 0</inkml:trace>
+  <inkml:trace contextRef="#ctx0" brushRef="#br0" timeOffset="-204068.73">27812 13441 7533,'10'-39'1092,"-1"-1"0,-1 3 0,-3 2 546,-6 6 0,-4 3-545,-14 1-1093,-13 50-180,20 3 1,4 7-91,1 11 0,8 6-449,8-7 0,4 4 0,1-4 629,-5-12 0,1-1 0,1 1-210,6 12 0,3 1 0,-5-6 30,-7-13 1,-7-3-136,-10 4 0,-10-5-405,-16-11 1,-7-8 809,9-2 0,-2-3 0,1 0 0,-1-1 0,0-1 0,1 0 0,-9-2 0,1 0 0</inkml:trace>
+  <inkml:trace contextRef="#ctx0" brushRef="#br0" timeOffset="-203330.73">22114 13000 7533,'-9'-37'269,"0"-1"1,1 8 0,10 2 0,22 2 0,14 3 0,2-1 0,0-1-1,0-1 1,-1 1 0</inkml:trace>
+  <inkml:trace contextRef="#ctx0" brushRef="#br0" timeOffset="-202847.73">28575 14129 7533,'-12'-29'468,"1"1"0,17 8 0,12 2 0,7 5 0,17 23 0,0 0 0</inkml:trace>
+  <inkml:trace contextRef="#ctx0" brushRef="#br0" timeOffset="-192505.73">5217 14923 6903,'-13'-10'90,"3"2"180,10 0 90,0 6-91,0-14 361,-6 14-270,5-5-90,-5 7 539,1 0-179,-2 0-360,0 0 180,1 0-91,1 7 1,-2-5-450,0 6 90,2-8 0,-1 0 180,5 0 0,-5 0 180,6 0 179,0 0-89,6 0 360,6 8-451,2 11 1,2 3-315,3-3 0,0 3-15,2 12 0,1 7 0,1 0-97,0-4 1,0-1-1,1 3-91,-5-4 1,0 1 0,-1 1 0,1-2 37,2 3 0,1-2 0,-3-2-15,-3-2 0,-1-4-585,7 4-449,-21-30-990,10 6 90,-9-8 450,3 0 1619,-5 0 0,-5-8 0,-2-2 0</inkml:trace>
+  <inkml:trace contextRef="#ctx0" brushRef="#br0" timeOffset="-192046.73">5181 15734 7533,'-19'0'809,"-5"0"630,16 0-89,-8-8-271,26-17 0,11-7-225,2-3 1,6-6-1001,-7 11 0,4-4 0,3-2 0,1-2 1,0 1-1,-1 2 92,2-1 0,0 1 0,0 1 0,0-1 0,0-1-441,-2 1 0,0-1 1,0-1-1,-1 0 0,0 3 1,-4 3-321,10-8 0,-4 3 1,-5 5-356,-8 3 1,-5 7-270,-6 13 1439,-6 16 0,-6 2 0,-1 8 0</inkml:trace>
+  <inkml:trace contextRef="#ctx0" brushRef="#br0" timeOffset="-190148.73">6375 15434 8432,'0'-10'1080,"0"2"629,0 8-720,11 24-179,8 13-496,-8 0 1,-2 5-1035,0-1 1,-6 0 44,-8-3 1,-7-4 179,-5-9 0,-5-7-450,-8-7 1,-1-6 944,-4-5 0,35-16 0,40-3 0</inkml:trace>
+  <inkml:trace contextRef="#ctx0" brushRef="#br0" timeOffset="-188929.73">6448 15134 8702,'-19'-8'2159,"7"6"-1350,6-5-449,6 7-180,11 0-90,-3-8-270,10-10 360,-16-9 314,-18 2 1,-8 6-1934,-20 29 1394,16-16 0,6 4 45,17 37 0,15 3 0,20-20 0,0 1 0,0 1 0</inkml:trace>
+  <inkml:trace contextRef="#ctx0" brushRef="#br0" timeOffset="-188263.73">6411 15505 7533,'-31'-20'3276,"12"4"-1425,8 16-1132,11 0-179,6 8-450,1 10 360,5-6-180,-5 3-360,3-15 0,-13-15 0,-10 3 0,-13-6 0,-11 18-630,11 26 181,19 11 718,21 8 451,23-18 180,-5-27-361,-1-19 46,-37-7 0,-9 1-135,-4 9-1755,-12 14 1,9 6 1394,39 12 0,9-32 0,14-13 0,0-1 0</inkml:trace>
+  <inkml:trace contextRef="#ctx0" brushRef="#br0" timeOffset="-186946.73">7334 14693 7623,'-7'-19'1529,"-3"-13"-630,8 28-359,-3-19 90,5 29 359,5 35-1019,1-8 0,0 7 0,0 1-30,-1-4 0,0 0 0,0 6-487,0-2 1,1 7 0,1 4 0,-1-1 0,0-4 0,-2-8-1093,1 11 1,0-2 1617,0-4 0,3 11 0,-1 0 1,-3-13-1,-6-24 0,-13-40 1,0 13-1</inkml:trace>
+  <inkml:trace contextRef="#ctx0" brushRef="#br0" timeOffset="-186516.73">7261 15240 9422,'-9'-12'-270,"38"-1"90,-2 16 0,5 1 60,-1-8 0,3-4 0,-1-3-291,1-1 0,0-3 1,-2-3 110,2-9 0,-3-3 0,-3-1 233,3-6 0,-5-3 366,-9-2 1,-4-4 0,-3 3 195,-5 2 0,-3 1-16,0 6 1,0-3 0,-1 5-63,-1 2 0,0 7 1023,0 5-946,8 56 1,1 20-315,-5-9-384,-1-17 1,2 8 0,1 4 0,-1 0-1,-2-4 24,-2 8 0,-1-3 1,0 3-204,1 0 1,1 3 0,-1 0 0,1-3 40,-1-7 0,0-2 0,1-1 0,-1-3-1053,2 16 1,1-8 1394,9-10 0,-1-41 0,1-11 0</inkml:trace>
+  <inkml:trace contextRef="#ctx0" brushRef="#br0" timeOffset="-186147.73">7876 15399 9781,'-9'-20'3276,"49"4"-2684,-11 16-502,7-5 0,9-4 0,-3 0 45,-5 0 0,-2-4-75,2-5 0,2-5 0,-5-2-15,-1-6 0,-10-3-135,-17-7 0,-11 2 90,-6 12 0,-6 7-45,-7 7 0,-3 10 0,-1 15 0,3 11 195,9 4 0,4 6 0,2 1-420,-2 0 0,2 0 0,6 2-636,7 8 0,7 2 0,4-4-264,10 2 1,7-6 1169,4-8 0,6-9 0,-8-16 0,3-7 0,-1-1 0,10-7 0,0 0 0</inkml:trace>
+  <inkml:trace contextRef="#ctx0" brushRef="#br0" timeOffset="-185601.73">8651 15187 8162,'-7'-10'3276,"1"2"-2684,6 16-592,0 2-900,4 26 1,3 8 899,7-3 0,3-1 0,1 0 0,3-4 0,7-13 0,-1-1 0</inkml:trace>
+  <inkml:trace contextRef="#ctx0" brushRef="#br0" timeOffset="-185029.73">8934 15222 7533,'-24'-19'2248,"-7"3"-1888,11 32 0,11 14 0,6 6-270,6 3 0,6 1-330,1-5 0,2 2 0,3-3 105,6 1 0,3-8 225,3-13 0,1-10 270,5-16-135,-14-17 0,-4-8 89,-11-7 1,-6-3-195,1 11 0,-1-1 0,-2 1 15,-1-14 0,-4 10-135,-15 12 0,26 53 0,6 19 150,-1-1 0,2 6 0,1 4-392,-2-11 0,1 3 0,1 2 0,-1 1 0,0-1 206,0 1 0,1 2 0,-1-1 0,-1-1 0,0 0-72,-2-5 0,1 1 0,-1-2 0,-2-1 0,-3-3 617,-2 8 1,-4-4 0,-5-7 164,-4-4 1,-6-15-375,-8-25 0,-6-18 0,1-1-240,6 1 0,0-1 0,1-4-353,0 1 0,-2-3 0,2-1 0,3 2 263,3 1 0,3 2 0,3 0-1410,-4-14 1,12 6-1838,36 8 1638,2 12 1,4 3 1623,-3 6 1,2 0-1,11-6 1,1-3-1,-13-1 1,1 1-1</inkml:trace>
+  <inkml:trace contextRef="#ctx0" brushRef="#br0" timeOffset="-184534.73">9279 14870 7533,'0'-28'2518,"0"-5"-1708,0 29 269,11 37-630,-6-3 1,-1 7 0,0 2-240,2 8 0,0 2 0,1 2-472,0-6 1,0 3 0,1-1 0,-1-3 201,1 5 0,1-3 0,0-4-390,6 7 0,2-9 141,7-9 354,-9-52 0,-1-15-90,-3-1 0,-2-2 165,2 6 0,0-2 0,-2 3 599,-2-6 1,0 5 179,4 0-629,-11 64-900,4-8 1,2 3 47,4 14 0,5 1-511,3-9 1,4 0 0,3-10 969,11-16 0,1-10 0,-6 3 0,-3-8 0,-9-35 0,0 0 0</inkml:trace>
+  <inkml:trace contextRef="#ctx0" brushRef="#br0" timeOffset="-184284.73">9894 14764 7533,'0'-34'3276,"-5"21"-1335,14 28-1582,-4 13 1,-1 9-1016,2-3 1,3 7-1,0 4 1,0-2 0,-2-4-438,0 0 1,-2-3 0,1 5 436,2 1 1,0 5-1,1 3 1,-1-4 0,-3-6 718,-2 7 0,-3-6 1,2-5-1,-4-5 1,-12-4-1</inkml:trace>
+  <inkml:trace contextRef="#ctx0" brushRef="#br0" timeOffset="-184077.73">9869 15134 7533,'0'-25'1092,"0"-1"0,11-1 0,6-1 508,7-5 0,8 4-1600,-2 13 0,5 4 0,0 2-1093,3 0 1,0 2 0,-1 3 888,7 4 1,-4 2 0,-11-1-1,-6 0 1,-12 0 0</inkml:trace>
+  <inkml:trace contextRef="#ctx0" brushRef="#br0" timeOffset="-183871.73">8725 14958 7533,'-25'0'0,"0"0"0,9 0 0,20 0 0</inkml:trace>
+  <inkml:trace contextRef="#ctx0" brushRef="#br0" timeOffset="-182030.73">13253 14658 8072,'-13'0'1170,"-3"0"-91,9 0 0,-5 0 271,-1-8-361,6 6 270,2 10-179,21 19-676,-2-2 1,4 3-525,6 2 0,4 3 1,3-2-974,2-2 1,2-1 0,-1 2-1,1 5 1,0 2 0,-2-6-39,6-5 1,-5-4 1130,-12 2 0,-5-9 0,3-37 0,4 1 0</inkml:trace>
+  <inkml:trace contextRef="#ctx0" brushRef="#br0" timeOffset="-181670.73">13782 14711 7533,'-10'-43'3276,"7"13"-1155,-7 5-952,4 48-1079,-1 17 90,-1-7 0,-2 8 0,-1 2-479,2-5 0,0 2 0,0 1 0,-2 1 317,0-1 0,-2 2 0,0 1 0,0 0 0,1-1 54,1-2 0,1 0 0,-1-1 0,1 0 0,0-2-16,-1 4 1,0-1-1,1-2 1,0-4 168,-3 8 0,3-7-2654,3-3-539,18-41 1079,10-4 1889,15-13 0,1 7 0,1 1 0</inkml:trace>
+  <inkml:trace contextRef="#ctx0" brushRef="#br0" timeOffset="-180785.73">14140 15046 7533,'-25'-10'3276,"6"2"-4663,7 8-412,17 0 1799,3 8 0,5 25 0,-8 15 0</inkml:trace>
+  <inkml:trace contextRef="#ctx0" brushRef="#br0" timeOffset="-180638.73">14053 15293 7533,'-13'10'2428,"2"-2"-2608,17-8 180,17-8 0,7 0 0,5-2 0,10-4 0,0 1 0</inkml:trace>
+  <inkml:trace contextRef="#ctx0" brushRef="#br0" timeOffset="-179730.73">14841 15363 7533,'-14'30'1049,"-1"-1"0,7 8 1,0-1-780,-5-10 0,3-1 269,10 22-449,7-71-150,-3-11 0,0-12 0,0 6 15,0 11 0,-1-1 22,-1-10 1,-1-10 0,0 1-1,1 10 248,-2 11 0,5 3 194,8-4 1,6-1 0,5 6-480,9 10 0,6 7 1,1 3-601,3 1 0,2 2 1,0 2-430,-1 2 1,1 1 0,-6 2 1088,0 0 0,-12 6 0,-26 38 0,-12-16 0,0 0 0</inkml:trace>
+  <inkml:trace contextRef="#ctx0" brushRef="#br0" timeOffset="-179313.73">15297 15328 10501,'34'-17'2878,"0"-1"-2833,2 6 0,4-2-90,-1-6 0,-1-3-315,4 1 1,-2-3 134,-7-8 0,-10-2 90,-15 6 0,-9 3 45,-14 5 0,-8 5 45,-13 2 0,-3 12 495,-3 21 0,1 11-211,15-8 1,0 3 0,5 2-120,4 4 0,3 3 0,6 1 0,6 5 0,6 2 0,5-4-390,16 3 0,8-6-750,-5-9 1,4-2 0,2-5-61,0-7 1,3-4 0,-3-3 946,9 2 0,-4-6 1,-7-10-1,-3-5 0,6-16 1</inkml:trace>
+  <inkml:trace contextRef="#ctx0" brushRef="#br0" timeOffset="-178830.73">16047 15258 7533,'5'-43'3276,"8"13"-1155,1-11-1672,-2 29-629,-28-3-359,-23 22 449,6 4 0,-2 4 90,6 0 0,0 2 0,1 4-921,-3 9 0,1 4 1,3-2 1054,-3-2 1,7 3 135,6 17 0,17-4-180,44-23-135,-9-2 0,5-9-135,-1-21 0,3-12 0,-2-3 929,-7-1 1,-2-2 0,-1 0-660,-2 0 0,-1 0 0,-3 3-540,-2-2 0,-6 13-1189,-6 36 1,-2 14 1553,7-3 1,2 1 0,4 5-1,2-2 1,1-12 0,1-1 0</inkml:trace>
+  <inkml:trace contextRef="#ctx0" brushRef="#br0" timeOffset="-177650.73">16822 14393 7533,'-25'-9'2338,"2"40"-1708,12 5 0,4 8-248,3-7 0,2 4 0,0 3 1,1 1-399,1 0 0,1 4 1,0 0-1,1 0 0,0-2-322,1 1 1,0-1 0,2-2 0,-1-1 395,3-1 1,2 2-1,-4-6 1,-7-15 121,-14-16-467,-2-32-163,-12-1 0,-11-3 1,0 7 853,-1 13 1,-2 6-135,3-6 0,-2 1 0,4 10 119,6 20 1,5 11 0,5 1-120,-1 8 0,15 3-225,19-10 0,12 3 0,5-1 0,1-6-15,3-6 0,3-6 0,5-4-326,-1-5 0,4-2 0,3-3 1,-1-4-1,-2-6 3,6-10 1,-2-9 0,-2-3-1,-3 1 533,0 1 0,-3 0 0,-3-3 179,-3-5 1,-2-4 0,-13 6 876,-19 3 144,-22-6-1980,3 36 90,20 19 0,7 7 405,2 2 1,6 1-286,4 2 0,4 3 0,3-6 442,9-2 0,2-11 248,-6-13 0,-1-8-90,-1-9 0,-4-7 44,-12-7 1,-5-3-180,-1 2 0,0 3-135,-1 4-180,1 36-180,16-4 1,6-1 224,-3 2 0,1-6 225,20-14 0,-2-13 89,-12-10 1,-6-5 1214,-3 0 1,-4 5-1575,-6 11-1979,-9 32 720,-7 15 0,0 5-200,11-5 1,1-1 1494,-6 1 1,4-3-1,13-9 1,5-5 0,14 5-1</inkml:trace>
+  <inkml:trace contextRef="#ctx0" brushRef="#br0" timeOffset="-177117.73">18016 15275 7533,'-3'-29'1638,"0"-1"0,-9-11 1638,-7-2-2902,-5 28-104,-12 46-495,21-6 0,3 5-225,-3 9 0,5 4-180,3 6 1,8-2 134,8-12 1,6-5-316,18-3 1035,-8-31 0,-1-11 269,-2-20 1,-6-9-75,-4 10 0,-2-3 0,-2 0 209,1-12 1,-5 4 359,-6 11 1,-2 15-406,-3 40 1,0 17-945,2 2 0,0 7 1,2 3-297,0-7 1,2 3-1,0 1 1,0 1 0,1-2 614,0-5 0,1-1 0,-1-1 0,1 2 0,-2 2-109,1 2 0,0 5 0,0 0 0,-2 0 0,-1-3 0,-2-5 330,-5 8 0,-4-5 0,-5-3-225,0-7 0,-5 2 0,-2-7 0,-2-14-1005,-12-23 1,-5-19 0,3-4-44,4 0 1,3-4 0,3-2 1001,2-5 0,4-2 0,7 5 0,10 10 0,7 3 0,9 2 0</inkml:trace>
+  <inkml:trace contextRef="#ctx0" brushRef="#br0" timeOffset="-176934.73">17328 15028 7533,'-27'-29'1638,"1"0"0,0-5-1034,7 12 0,9 3 0,35 3 0,20 7 0</inkml:trace>
+  <inkml:trace contextRef="#ctx0" brushRef="#br0" timeOffset="-175683.73">19247 15311 7533,'-18'-44'1304,"4"22"0,-2-1-719,-1-1 0,-4 3-316,-9 3 1,-6 9 90,2 12 0,-4 8 0,2 6-91,3 9 1,1 7 0,2-2-180,-3-7 0,1-1 0,10 5-120,16 15 0,11 6 0,7-14-510,22-15-280,-1-21 1,9-7 0,2-3 0,-9-1 177,-8 1 0,-3-5 619,7-17 1,5-12-1,-6 4 1,-16 25 2451,-27 41-2339,18-52 29,-4 56 1,1 30 0,11-18-930,16-37 1,8-13 0,0 2 584,9 19 0,-3-12 270,-19-20 0,0-14 0,-1-8 0,-1-5 0,-3 0 0,-4 4-63,-3 0 1,-4 1 0,-3-1 0,-1 0 0,1-2 316,1 3 1,0-2 0,0-1 0,-1 0 0,-2 3 0,-1 4 149,-1-20 1,-3 5 0,-8 24 2226,-31 51-2736,26 11 0,6 13 1,1 4 184,0-7 1,-1 4 0,1 3 0,3 1 0,5-1-382,4-2 0,5 1 0,2 2 0,2-2 0,0-3 0,0-4 166,-1 0 0,-1-3 0,3-5 0,5-6 689,13-4 1,5-8 0,-6-15-16,-8-37 1,-14-20-720,-10 14 0,-6-6 0,-5 0 0,-1 9-1504,-5 3 1,-4 6 1531,-9-10 1,11 17 0,40 50-1,12-4 1,1 0 0</inkml:trace>
+  <inkml:trace contextRef="#ctx0" brushRef="#br0" timeOffset="-175260.73">19997 15134 7533,'-7'-17'3058,"-4"-9"-899,5 14-990,-6 51-1709,7-7 1,3 5-554,7 3 1,4 4 0,-1-4 981,-5-3 1,6-6 0,21-1 0,7-13 0,-11-22 0,1 0 0</inkml:trace>
+  <inkml:trace contextRef="#ctx0" brushRef="#br0" timeOffset="-174734.73">20403 14587 7533,'-6'-27'3276,"-5"9"-796,15 50-2300,-3-7 225,5 12 0,0 8-255,-1-5 0,-1 2 0,0 4-806,-1-8 1,1 3-1,-1 2 1,1 0 0,0-2-72,0 4 0,1-1 0,-1-1 0,2 1 299,0 3 1,0 1 0,2-4 0,2-9-904,4-8 0,3-8 1331,20 4 0,-11-31 0,-2-2 0</inkml:trace>
+  <inkml:trace contextRef="#ctx0" brushRef="#br0" timeOffset="-174497.73">20674 15240 7533,'-3'-26'1638,"-1"-1"0,-7-10 842,10 19-2659,-5 28-91,6 33-765,3-16 1,0 1-605,0 7 1,1 1 848,4-8 0,2-2 790,4 10 0,25-44 0,0-22 0</inkml:trace>
+  <inkml:trace contextRef="#ctx0" brushRef="#br0" timeOffset="-174001.73">21007 14623 7533,'-9'-27'1484,"0"1"0,1-12-405,-9 5-449,16 23 270,-5 18-226,5 15 1,2 5-495,-1 0 0,0 3-1,1 7 1,-1 6 0,-1-1-233,0-1 0,-2 0 1,2 2-61,1-5 1,1 1-1,1 1 1,-1-1-136,0 1 1,1-1 0,0 0 0,0-2 7,2 6 0,0-2 0,2-2 195,5 11 0,1-6-315,1 0-2158,5-30-271,-6-32 2789,-5-3 0,-12-13 0,-9 5 0</inkml:trace>
+  <inkml:trace contextRef="#ctx0" brushRef="#br0" timeOffset="-173351.73">20933 15117 7533,'-23'-44'3276,"8"7"-796,8-6-1581,21 24 1,7 3-675,6 0 0,5 4-765,15 2 1,3 3-1035,-7 0 0,-2 6-65,-2 9 1,-10 7-572,-26 23 2210,-10-12 0,-6 2 539,-5 2 1,-4 2 0,2-1-91,5-2 1,3 2-270,3 1 0,2 3 0,7-2 45,13 5 0,8-3-225,3 1 0,4-7 224,3-14 1,2-11 180,2-23 0,-4-15-195,-14-1 0,-6-6 0,-1 0 599,-1-9 1,-1 1-1,-6 26-180,-6 45 1,-4 17-510,1-8 0,0 4 0,-1 7-381,2-6 0,1 6 1,-1 5-1,0 1 1,0 0-1,0-2 1,0-4 26,-1 1 0,1-2 0,-1-2 0,-1-1 0,-1-1 9,-2 9 0,-1 0 1,-4-5-1,-5-11-645,-10-13 1,-5-9-1,0-6 870,-6-5 0,1-9 0,-2-12 0,8-5 0,21 7 0,0 1 0</inkml:trace>
+  <inkml:trace contextRef="#ctx0" brushRef="#br0" timeOffset="-173112.73">20711 14887 7533,'-23'-25'89,"8"13"1,2 4 0,15 18 0</inkml:trace>
+  <inkml:trace contextRef="#ctx0" brushRef="#br0" timeOffset="-172923.73">19997 14728 7533,'-32'-17'0,"36"15"0,24 4 0</inkml:trace>
+  <inkml:trace contextRef="#ctx0" brushRef="#br0" timeOffset="-115896.73">24576 14676 7263,'6'-10'180,"-1"2"899,-21 8-449,7 0 269,-20 0-89,10 0-450,5 0 269,-2 0-89,9 0-270,0 0 180,1 0 359,23 0-494,6 0 0,7 0 14,14 0 1,9-1 0,-1 2-330,-13 0 0,-1 1 0,1 1 0,1-1-219,6 0 0,3 0 1,-3 0-1,-4 2 339,-5 1 0,-4 0 0,-4 2 60,1 1 0,-8 2-90,-10 7-540,-23 17-180,-2-12 1,-5 1-91,-9 10 1,-2 4 329,5-4 0,0 2 0,-2 1 7,3-4 1,-1 1-1,-1 1 1,0 1 404,-1 2 1,-1 1-1,0 1 1,1-1 224,-1 1 0,-1-1 1,2 0-1,0-2 721,-5 5 0,2-1 0,3-5-699,1-1 1,6-5-180,3 2 360,28-39 0,9 0 0,4-1 89,6-8 1,2-2-480,0 4 0,2 0 0,1 0-98,1 2 0,1 1 1,-1 0-953,1 0 1,0 0 0,-2 3-46,7 1 1,-4 6 1037,-1 3 1,-11 6 0,-29 12 0,-9 17 0</inkml:trace>
+  <inkml:trace contextRef="#ctx0" brushRef="#br0" timeOffset="-115587.73">24526 15117 7533,'-43'-8'3276,"17"6"0,48-14-2280,13 10 1,10 2-997,-8-1 0,5-2 0,1 0 0,1 1-820,1 0 1,1 1 0,1 1 0,0-1 653,-6 1 0,1-1 1,0 1-1,-2 1 1,-2 2-1,5 1 1,-3 3-1,-2 1 0,8 6 1,0 0-1</inkml:trace>
+  <inkml:trace contextRef="#ctx0" brushRef="#br0" timeOffset="-115358.73">25547 15117 7533,'-12'-18'3276,"11"0"-1515,8 16-1761,6 4 0,-9 28 0,-6 13 0,-2 0 0,-1 0 0</inkml:trace>
+  <inkml:trace contextRef="#ctx0" brushRef="#br0" timeOffset="-115192.73">25486 15328 7533,'-35'-10'3276,"18"3"-2983,23 7 1,15 0-1,8 0 1,12 0-1,0 0 1</inkml:trace>
+  <inkml:trace contextRef="#ctx0" brushRef="#br0" timeOffset="-114046.73">26347 15469 7623,'-19'0'1889,"1"8"-990,6-6-269,6 6-271,6-24-448,17-11 44,1-8 0,1-7 15,-1 6 0,1-2 0,0-3-481,-3 3 0,1-3 1,-1 0-1,-2 0 398,0 1 1,-1 0 0,-1-1 0,-1-1 201,1-4 1,-1-3 0,-1 1 0,-1 3-124,-2 2 0,-1 3 0,0 0 244,-2-2 0,0 0 0,0 6-165,-1 7 0,-1 5-45,4-1 180,-5 25 450,16 33-630,-14-17-78,4 17 1,4 13-1,-2-8 438,1 0-216,-3-6 0,1 10 0,1 6 0,-1-2 0,-1-7-267,-1-4 1,-1-4 0,1 3 158,0 5 0,1 5 0,0 3 0,1-1 0,-2-4 173,1 9 1,-2-3 0,2 0-270,1 1 0,0 0 0,1-4-255,3 7 1,0-8-1395,2-1-720,-4-27-359,-10-32 4078,0 4-1290,-16-13 0,-15-8 0,6 14 0,-1 0 0</inkml:trace>
+  <inkml:trace contextRef="#ctx0" brushRef="#br0" timeOffset="-113813.73">26483 15275 7533,'-32'-8'3276,"8"6"-706,28-5-1850,33 7-1350,10 0-494,-2 0 0,4 0-515,-5 0 1,1 0 1540,0 0 1,0 0 0,0 0 0,-1 0-1,-13 0 1,0 0 0</inkml:trace>
+  <inkml:trace contextRef="#ctx0" brushRef="#br0" timeOffset="-113122.73">27147 15187 7533,'0'-20'1979,"0"-11"-990,-5 19-359,-2-13-540,-11 15-720,-6 10 180,-13 26 450,17-9 0,2 3 180,-5 9 0,3 3 45,9-10 0,2 3 269,-2 11 1,6 2-495,10-9 0,6-1-180,2 9 0,5-4 90,8-9 0,4-10-360,4-16 1,1-12 404,-5-11 0,-3-7 0,-6-2 0,-5-6 15,-8-3 0,-4-4 0,-5 5 480,-7 11 0,-2 4-136,5-5 1,1 13 45,0 41 0,2 18-300,5-6 0,1 3 0,3 4-299,0 4 0,3 5 1,0 1-1,-2-1 239,-2-10 0,0 0 0,0 0 0,-1 0 0,-1 0 162,1 2 0,1 0 0,-2 0 0,0 0 0,-3-2-11,-2 4 1,-2 0 0,-2-2 0,-4-6-62,-12 12 0,-9-15-450,-8-22 0,-4-14-450,-1-16 1,3-10 509,14 5 0,1-4 1,3 0-286,-5-8 0,4 0-404,7 0 0,8 3 1203,19-4 0,8 18 0,6 4 0,10 7 0,-1-1 0</inkml:trace>
+  <inkml:trace contextRef="#ctx0" brushRef="#br0" timeOffset="-112711.73">27369 15487 7533,'-11'-33'3276,"8"11"-1065,8-3-1897,15 15 1,8 4-630,17 1 1,3 0 179,-5-6 0,2-3-738,-2 1 0,2 0 0,-6-4 468,-5-9 0,-5-3 586,7-5 0,-11-3 268,-25 4 1,-11 3-45,-11 7 0,-8 9 344,-12 17 1,-8 12-1,4 6-90,10 5 1,4 5 0,6 6-503,10 0 1,3 5-1,7 1 1,7-4-428,12 3 0,10-4 0,7-4 242,3-7 0,7-2 0,3-6 0,-3-8 0,1-11 0,0-10 1,-1-3-1,-5-4 0,0 1 0,0 0 0</inkml:trace>
+  <inkml:trace contextRef="#ctx0" brushRef="#br0" timeOffset="-8179.73">1111 16933 7892,'-10'-9'1350,"3"1"-451,-1 0 360,6 29-179,-6 9-960,12-2 0,5 8 0,1 2-120,2 1 0,1 3 0,2 1 0,-2-1-206,0-3 0,-2 0 0,2-1 0,1 1-447,6 7 1,2 1 0,0-2 0,-3-5-338,-3 5 1,-1-7 629,6-6 1,-1-5 359,-2-2 0,-8-7 0,-3-1 0</inkml:trace>
+  <inkml:trace contextRef="#ctx0" brushRef="#br0" timeOffset="-7891.73">1111 17692 7533,'-32'-9'1092,"0"0"0,9-9 0,10-5-302,22-17 1,16-6-364,-4 9 0,5-2 1,3-2-1,0-1-726,-1 3 0,0 0 0,2-2 0,0 1 0,1-1 224,-2 5 0,1-1 0,1 0 0,-1 1 0,-1 1 0,-1 2-577,2-2 0,-2 1 0,-1 3 0,0 2 749,1-3 0,-1 3 0,-8 18 0,-11 44 0,-13-5 0,0 1 0</inkml:trace>
+  <inkml:trace contextRef="#ctx0" brushRef="#br0" timeOffset="-7678.73">1711 17427 9242,'0'34'1214,"-3"-10"0,-2 4-2204,1 16 1,-2 1 989,-2-7 0,-1 0 0,-3 2 0,-2-3 0,0-16 0,1 1 0</inkml:trace>
+  <inkml:trace contextRef="#ctx0" brushRef="#br0" timeOffset="-7229.73">2099 17180 7803,'-20'-10'2428,"5"3"-2788,32 16 1,13 5-451,-6-7 0,3 0 810,15 12 0,4-5 0,-13-16 0,2-7 0,-1-1 0,-1-1 0,0 1 0,1-1 0</inkml:trace>
+  <inkml:trace contextRef="#ctx0" brushRef="#br0" timeOffset="-6953.73">2575 16898 7533,'-25'-37'3276,"-3"27"-2351,6 41 1,1 20-1264,7-18 1,1 3 0,0 2 0,0 2-319,3 2 1,0 2-1,1 1 1,1 2 0,-2-1 169,0 2 0,-1 1 0,0 0 0,1-1 0,1-3 283,3-3 1,1-2 0,1-1 0,0-1 350,-2 9 0,0 0 0,2-10-778,4 0 630,0-11 0,0-42 0,0-13 0</inkml:trace>
+  <inkml:trace contextRef="#ctx0" brushRef="#br0" timeOffset="-4673.73">3528 17339 7173,'-10'-20'540,"2"5"-181,8 7-269,-8-2 0,6 0 0,-13 2 0,5 8-90,-23 16 90,-5 12 90,7-1 0,2 6-45,7 10 0,4 3 45,-4-5 0,3 2-31,14-10 1,5 3 0,3-3-240,7 5 0,6-4 90,1-7 0,5-7 0,12-5 0,1-14 135,-6-28 0,-4-13-45,-4 3 0,-4-4-60,-7 7 0,-2-2 0,-3 0-60,-5 1 0,-4 0 0,0 3 120,0 1 0,-1 3 90,-5-7 135,12 58 0,4 21-405,-1-6 0,2 6 0,0 3 0,1 0-560,-1-5 0,1 1 0,0 1 1,-1 0-1,0-1 492,1 8 1,-1-1 0,0 0-1,-1-3 128,2 4 0,-1-2 0,-7-8 570,-9-11 0,-5-5-46,-2-5 1,-5-5-585,-10-12 0,-5-6 0,1-5 90,-10-8 0,1-5 0,11 4 0,-1-2 0,5 0-135,5-3 1,5-1-1216,4-18 1350,38 21 0,14-5 0,-5 16 0,-1 0 0</inkml:trace>
+  <inkml:trace contextRef="#ctx0" brushRef="#br0" timeOffset="-3596.73">3722 17604 7533,'-20'-10'2069,"-3"2"-1260,44 0-719,1-2-225,6-1 0,5-3 315,2-3 0,0-1 45,-5-3 0,-3-3 134,-2-6 1,-7-1-90,-10-16-450,-21 23 0,-7 5-179,-20 9 224,14 8 0,-1 6-180,4 12 0,3 9 225,8 8 0,5 4 90,-1-5 0,2 2 0,4 0 60,10 8 0,7 0 0,1-2-195,7 5 0,3-6 0,4-4 0,5-11 450,4-21 0,-4-14-90,-17-9 0,-4-5-1,8-6 1,-3-3 180,-12 3 0,-4 0 45,5-12-810,-16 48-360,6 25 45,1-3 1,2 1 494,9 9-269,31-14 1078,-10-46-179,-1 0 0,-1-7 809,-8-14 0,-5-2-719,-2 15 0,0 1-540,-2-4 0,-1 13-360,-1 45-2917,23 13 3259,-8-2 0,3 1 1,7-10-1,3-3 1,-9-7-1,0 0 0,1 1 1</inkml:trace>
+  <inkml:trace contextRef="#ctx0" brushRef="#br0" timeOffset="-1412.73">4710 17604 6993,'-18'0'540,"8"7"-1,2 11 1,32 10 180,21-9-541,-11-16 1,2-6 45,8-10 0,-2-9-135,-16-1 0,-3-4 0,-3-2 45,2-8 0,-6-2-135,-7 3 0,-9 1 45,-14 8 0,-7 5-405,-24 11 225,19-1 0,1 8-225,-6 36 1,6 14 314,12-17 0,3 1 45,-1 5 0,1 5 0,6-3 269,13 7 1,7-4-180,1-9 0,5-5-90,9 0 0,4-7 90,2-10 0,0-10 45,-4-13 0,-3-7 45,2-9 0,-4-3-90,-8 4 0,-2 1-90,0 1 0,0 3 0,6 7 0,6 9-180,2 8 360,0 0 359,-13-8-449,-8-2 0,-28-15-90,8 13-899,-26 4-1,15 33 585,5 0 1,5 3 179,8 4 0,8 1-45,16 5 0,9-5 135,1-9 0,5-11 165,-2-16 0,3-10 0,-3-3 15,3-6 0,-4-8-173,-13 0 0,-1-6 0,-1-3 0,-3 0 105,-4 4 1,-1-1-1,-3 0 1,1-2-23,0-4 0,-1-1 0,0 0 0,-3 1 195,-3-6 0,-2 2 0,-2 5 74,-3-1 1,-4 13-675,-11 23-90,7 36 1,3 17 89,6-13 0,2 2 1,0 3-41,0 2 0,-1 3 0,1 1 0,4 0 422,4 2 1,3 2 0,2-1-1,3-4-112,4 4 0,4-4 0,2-3 0,-2-3 0,2-3 1,2-18 562,17-30 0,-4-23-174,-18 6 1,-5-7 0,-2-5-150,-4 6 0,-1-4 0,0-2 0,-2-3 0,0 1 0,0 2-521,-1-6 1,0 0 0,-1 1 0,0 0 0,-1 0 460,0 1 0,1-1 0,-2 2 0,0 1 0,-2 2 210,-3-11 0,-2 4 0,-1 10 59,-3 2-1258,-9 45 314,6 24 1,4 14 314,2-9 0,1 4 0,1 3 0,1 1 4,0-1 0,1 3 0,1 0 1,0 1-1,2-1 248,1-2 0,1 1 0,1-2 0,1 0 0,0-2 40,0 3 1,0-1-1,1-3 1,3-4 22,9 17 0,3-18 564,3-32-250,-6-8 2359,-7-39-2088,-1 6-900,-9 9-360,3 28 1918,1 20-1603,1 4 0,3 3-225,4 1 1,4-1 449,10-2 0,3-11 629,0-20 1,-2-12-45,1-16 0,-4-8 89,-9-1 1,-4 0-271,-6 1 1,-3 17 495,-4 64-900,0-15 0,0 5-281,1 8 1,0 7 0,1 4 0,-1-2 347,1-3 1,-1 1-1,1 0 1,0 1-104,0-2 0,2 1 0,-1 1 0,-1-2 0,-1-2 156,-1 11 0,-2-3 0,-5-5 509,-8 1 1,-8-16-585,-16-34 0,-7-15 165,11 3 0,1-3 0,0 0-240,3 1 0,1 0 0,2 0 120,-4-4 0,5 5 0,10 10 0,12 8 0</inkml:trace>
+  <inkml:trace contextRef="#ctx0" brushRef="#br0" timeOffset="936.27">8122 16633 7533,'-18'-25'2248,"-1"13"-1888,0 12-270,11 24 0,4 11-90,0 2 0,3 5 0,0 3-463,3 1 0,0 3 0,2 2 0,-1-2 350,0-3 1,0-1 0,1-1-1,0 0 113,1-1 0,2 0 0,-1-2 0,0-5 140,1-2 1,0-6 39,4 4-180,-11-32-270,-22-8-449,-11-18 494,5 15 0,-5 1 785,-8-10 1,-3 6-246,-1 23 0,1 12-45,13-3 0,1 4 0,4 2-1,-4 13 1,9 5-60,15-6 0,6 3 0,6-6-75,5-11 0,7-3-315,6-1 0,7 0 0,1-5-45,15-5 0,2-6 75,-8-4 0,1-2 1,-1-6 238,-1-6 1,-2-6 0,-4-1 450,5-9 0,-8-4-360,-7-3 0,-8-1 179,-13 10 1,-6 1 270,-15-8-450,-8 10-990,0 19-225,12 31 1,5 11 854,8-1 1,6 2 59,1-1 0,2 3 0,3-2 210,8 12 0,7-6 89,8-6 1,4-7-45,-6-10 0,0-9 360,1-12 0,-4-11-136,-8-10 1,-5-7-135,-5-5 0,-4-1-270,-2 7 0,-4 6-315,-7 14-45,0 32 1,0 17 254,2-4 0,2 5 0,-1 2 10,0-5 0,0 2 0,0 0 0,1-1-190,5 9 0,1-1 0,0-4 645,0 9 0,1-21 584,12-70-944,-12 7 0,-3-8-240,0 7 1,0-6-1,0-2 1,0-2-1,1 2 303,0 1 0,0-1 0,1 0 0,0 0 0,-1 1 341,2-9 1,-1-1 0,1 2 0,2 3 119,2-6 1,1 3 0,7 19-30,31 32-360,-27 19 0,-1 11-510,1 4 0,2 5 1,-3-1-61,-6-8 0,0-2 1,-2 1 389,7 15 0,-7-2 681,-11-15 1,-8-5-142,-31-9-810,5-21 0,-2-5-360,5 1 1,1 0 1023,0 1 0,10 0 0,24 2 0,17 7 0</inkml:trace>
+  <inkml:trace contextRef="#ctx0" brushRef="#br0" timeOffset="1832.27">8996 17551 8612,'-1'9'990,"18"7"-361,27-14-224,-16-7 0,1-6-315,4-4 0,-4-7-135,-6-15 0,-8-4 45,-11 7 0,-7 1 0,-1 3 0,-8 7-45,-16 13 0,-3 12-225,6 26 0,4 11 180,-1 2 0,5 4 120,8-10 0,2 2 0,7-1-60,7 0 0,5-1 0,3-4-15,6 0 0,5-5 45,12 4 0,3-9 225,-8-20 0,-2-8 45,4-8 0,-4-7-136,-6-16 1,-6-5 45,-5 9 0,-2 2-270,-2 3 0,-3 7-180,-7 14-89,5 41-1,7 6 135,1-10 0,4-5 495,26-4 314,-6-41 1,-1-15 0,-7-2 0,-3-4-286,-7 6 1,0-1 0,-4 2 374,-5-6 1,-2 13-315,-3 26-1349,1 32-650,3 11 1,5 4 1630,3-9 1,4-3 0,8 0-1,4-6 1,1-15 0,1 0 0</inkml:trace>
+  <inkml:trace contextRef="#ctx0" brushRef="#br0" timeOffset="3195.27">10436 16792 7533,'-7'-10'270,"-4"-5"359,9 28-179,2 31-46,6 0 1,1 10-544,-2-11 1,-1 4 0,1 3 0,0 0 120,-1-10 0,0 1 0,0 0 0,-1 0 0,1 0-185,1 8 1,0 0 0,-1-1 0,0-4 312,0 0 0,0-3 0,-6-15-290,-8-18-179,-5-31 89,-7-13 0,-3-3 225,4 10 0,-3 1-45,-8-9 0,-3 4 225,4 13 0,-1 10 965,3 18 1,2 10-921,5 16 0,7 6-135,3 1 0,6 3 135,6-8 0,4 1 0,3-3 0,9 1 0,5-3-150,1-4 0,5 0 0,3-6-330,9-7 0,3-6 0,0-3-139,-4-1 0,-1-3 0,0-3 439,3-7 0,-1-5 0,-4-2 45,2-5 0,-7-5 315,-8-4 0,-6-2 179,-3 2 1,-7 3-450,-25-12-180,3 15-270,-18 46-449,20 15 613,5-12 0,6 3-389,13 2 0,7-2 46,8 1 674,6-17 0,2-11 44,-6-21 1,-3-11 180,2-2 0,-2-2 0,-6 1 0,-4-1 134,-4-5 1,-4 6 45,-6 19-900,0 6-180,5 36 45,2-3 1,4 2-91,10 2 0,6-3 315,4-2 1,3-10 493,9-20 1,0-12 135,-9-3 0,-4-9-333,-10 1 0,-1-7 0,-3-3 0,-1 0 220,-4 2 0,-3-1 1,0-1-1,-1-2-175,1 1 0,0-3 0,-1-1 0,0 1 0,-2 2 265,0-5 0,-2 1 1,0 2-1,-1 2 52,2-6 1,1 2 0,-9 21-210,-12 32-180,10 15 0,2 9-270,-3 1 0,-2 4 1,2 5 71,3 1 0,3 7 0,0 2 0,3 0 0,0-4-268,3-1 0,3-3 0,0 0 0,0 3 241,-1-4 0,-1 4 0,1 1 1,1-1-1,1-3 0,1-6-75,5 3 0,2-5 1,3-7-376,7-2 0,-2-15-2602,-4-46 3192,-4-5 0,-14-4 0,-6-6 0,0 3 0,0 0 0</inkml:trace>
+  <inkml:trace contextRef="#ctx0" brushRef="#br0" timeOffset="3358.27">11297 17198 7533,'-26'-29'3276,"41"5"-1676,18 21 0,8 6-2320,-8-3 1,3 0-1,0 0 720,6 0 0,0 0 0,3 0 0,-6 0 0,3 0 0,-1 0 0,1 0 0,0 0 0,0 0 0,-1 0 0,1 0 0</inkml:trace>
+  <inkml:trace contextRef="#ctx0" brushRef="#br0" timeOffset="4225.27">13328 17762 9062,'13'8'2518,"-2"10"-2158,-22 25-990,3-13 1,-3 3-945,-7 4 0,-1-2 1574,9-9 0,-1-5 0,-22-5 0,19-36 0</inkml:trace>
+  <inkml:trace contextRef="#ctx0" brushRef="#br0" timeOffset="5927.27">14472 16986 7533,'-6'-35'899,"-1"8"-449,-5 9 90,0 57-271,7-7 1,1 7 0,1 4-180,0 2 0,2 4 0,0 2 0,-1 2-420,1-12 0,0 2 0,0 1 0,0 0 0,0 0 1,1-2 203,0 6 0,0-1 0,1-1 0,1-1 0,0-3 186,2 12 0,1-3 0,4-13 665,17-7-905,0-72 30,-13 7 0,1-8 1,-1 0-1,-2 3 0,-1-1 0,1 0 240,3-4 1,0 0 0,2 4 628,6-5 1,4 18-90,-4 33 0,-1 13-540,-1 22 0,-7 13-293,-6-16 1,-2 6-1,-3 0 1,-3-4 618,-6 1 1,-3-4-1,-3 1-386,-3 4 0,-2 0 0,-6-11-75,-20-11 0,-4-10-315,14 1 1,2-7-529,3-9 0,9-7-11,22-16 89,25 10 1,10 1 539,-9 3 0,2-1 0,2 1 270,13-1 0,3 1 0,0-2 45,-10 1 0,0-1 0,0 0 0,-3 2 226,1 3 1,-3 1 0,-2 0 897,43-22 328,-74 32-597,-13 8-631,-12 10 1,6 9-630,12 16-629,30-5 359,6-3 543,4-25 0,4-10 87,-8-13 0,0-8 135,7-4 0,-3-6-45,-6-9 0,-5-1 135,-5 13 0,-9 9 134,-14 19-269,-3 32-225,-3 1 1,6 2 134,13-6 0,8-3-135,4 0 0,7-7 135,12-12 0,5-12 149,-12-8 1,0-8 0,-1-6-237,-3-3 1,-1-6 0,-2-4 0,-2-3 175,-4 3 1,-2-4 0,-2-1 0,0-2 0,0 0-553,0 1 0,0-2 0,0-1 0,-1 0 0,-1 2 0,-2 2 552,-1 2 1,-1 1 0,-2 2 0,0 1 0,-1 3 449,3-16 1,-2 3 0,-7 24 270,-9 31-511,-3 22 1,-2 16 0,2 2-323,5-10 1,2 1 0,2 2-1,0 4-333,1-1 0,2 5 1,0 2-1,1 1 0,1-1 1,2-2-59,1 2 0,3-1 0,1 0 1,1-1-1,1 0-242,2 3 1,0 2-1,2-1 1,1-6 0,2-8-41,9 6 0,1-21 696,7-40 0,-27-14 0,-10-10 0,-3 5 0,-5-3 0,1 1 0,1 5 0,-1 0 0,1 0 0</inkml:trace>
+  <inkml:trace contextRef="#ctx0" brushRef="#br0" timeOffset="6086.27">15887 17515 7329,'-7'-40'655,"0"-1"0,0 0 1,1 1-1,4 11 0,2 1 437,2-20 0,4-7 0,10 17-590,20 32 0,11 10-1200,-10-7 1,3-1 0,3-1 0,1 1 509,-2 1 0,2 0 0,1 0 0,1 0 0,-1-2 0,2-2 0,1-1 0,0-2 0,0 1 1,1-1-1,-4 1 0,0 0 0,-1 0 0,1 0 0,0 0 0,-1 0 0</inkml:trace>
+  <inkml:trace contextRef="#ctx0" brushRef="#br0" timeOffset="7553.27">17511 17551 7533,'7'-27'1484,"-1"1"0,6-19-315,-5 9-89,-12 27-451,-15 42-449,4 4 0,1 6-420,7-7 0,2 1 1,0 0 89,-3-2 0,2 0 0,7-5-660,15 4 1,8-15 179,13-45 697,-13 3 1,4-8-1,0-3 1,-4 1-126,-3-1 1,-4 0 0,0-2 207,8-11 0,0-1 0,-9 10 1109,-14 8-540,-9 48 1,-3 13-1305,0 4 1,0 3 134,3-4 0,0 2 1,7 0-946,13 13 1,10-6 584,3-16 1,8-5 449,4-6 0,5-3 1,0-7 359,-7-9 0,0-6 0,0-4 0,4-7 0,-1-4 0,-6-5 269,-9-2 1,-7-4 0,-4 1 1034,-5-9 1,-9 4-676,-8 8 1,-7 11 270,-27 28-900,13 5 90,16 17 0,7 5-45,4-7 0,6 1-645,7 3 0,5 2 1,3-4-121,11 3 0,4-7 315,4-4 1,-1-11 494,-5-16 0,-6-9 45,-12-10 0,-7-5 44,-3-6 1,-4-1 895,0 7 1,-3 1 903,-7-15-1979,11 43-180,35 4 90,-6 2 0,3-4 450,12-18 0,1-9-612,-12 4 0,-1-3 0,-2-4 252,-4-2 0,-1-4 0,-2-3 0,-1-1-23,-2-2 1,-2-3-1,-2 0 1,0-1-50,-4 5 0,0 0 0,-1-1 0,-2 0 0,-1 2 72,1-5 0,-2 0 0,-3 2 0,-3 5 1079,-7-16 1,-8 22-585,-3 39 0,-2 17-608,5 4 1,1 10-1,2 4 1,0 3-311,4-8 0,0 2 0,1 3 0,1 0 0,1 1 0,1 0-57,2 3 0,2 0 1,1 1-1,1 0 0,0-1 1,1-2 209,0 2 0,0-1 0,0-1 0,3-1 1,2-3-496,4 4 0,2 1 1,2-6-1,1-15-314,17-12 1079,-16-35 0,-6-15 0,-7 4 0,-5-5 0,-2-4 0,-1 0 188,-1-6 0,-2-2 1,-1-1-1,-1 0 467,2 10 0,0-1 1,-1 0-1,0 2 0,0 2 437,-4-7 0,0 2 0,7 7 84,11 6 1,8 11-1537,17 27 0,6 13 180,-8-7 0,2 1 1,3-2 223,7-2 1,4-2 0,3-2 0,0-4 0,-6-5 0,1-2 0,1-3 0,1 0 0,2 0 0,-5 2 0,1-1 0,0 1 0,-1-1 0,1 1 0,0-1 0,0 1 0</inkml:trace>
+  <inkml:trace contextRef="#ctx0" brushRef="#br0" timeOffset="8353.27">19961 17498 7533,'0'-28'2788,"-5"3"-1798,9 15-541,-3 18-359,16 27-270,-5-5 0,1 3-135,3 0 1,5-1-91,5-8 0,3-3 135,-6-6 1,0-7-1,2-13 0,-2-6 360,2 0 1349,-2 17-989,-4 15-270,3 12 0,3 3-180,-6-11 0,2-1 59,4-3 1,4 1 0,-1-6-150,5-7 1,0-7 44,8-9 0,-3-11-720,-6-18 0,-8-9-15,-10 13 1,-5-3 0,0 1 14,1-17 1,-4 4 764,-6 14 0,0 5 0,6-5 0,1 15 0</inkml:trace>
+  <inkml:trace contextRef="#ctx0" brushRef="#br0" timeOffset="9258.27">20859 16686 7533,'-5'-35'1638,"-1"0"0,-8-12-507,-21 53-861,21 19 0,4 13 0,1 3-210,-1 3 0,1 3 0,2 5-400,3-10 0,0 4 0,1 1 1,2 1-1,2 0 178,3 1 0,1 2 0,3-1 0,0-1 0,1-1-468,0-6 1,1-1-1,1-1 1,0-1-1,0-1 472,1 5 1,0 2 0,1-6 0,3-11 515,11-9 1,-2-15-270,-5-35 316,-12 0 0,-4 1 1484,-4 1-810,-1 13-1079,12 34 892,4 9-1387,13-4 1,7-3 404,-9-7 0,2-4-60,4-3 0,4-2 0,-3-7 240,2-11 0,-3-7 180,2-3 0,-8-7-1,-14-15 1,-11-2-135,-9 17 0,-3 2-90,-1-6 0,-4 11-135,-24 32-270,19 29 270,9-4 0,6 4-90,10-1 0,7 3 1,2-2 59,0-4 0,2 0 0,3-3 30,1-1 0,3-1 0,2-5 0,16 5 0,1-16 90,-10-31 0,-3-9 135,4 4 0,-3-3 15,-13-3 0,-5-4 0,-1 2 344,1-3 1,-4 5-315,-7 2-450,-1 32 180,1 24-180,18-3-359,24-7 629,-4-15 0,3-4 449,-1 1 1,0-2-135,0-6 0,-1-2 134,-11 3 1,-3 5 810,1 17-3599,-8 22 765,-14-2 0,-3 1 1574,-1 13 0,0 0 0,0-31 0</inkml:trace>
+  <inkml:trace contextRef="#ctx0" brushRef="#br0" timeOffset="10503.27">23025 17392 7533,'-30'-8'449,"4"-2"451,1 1-540,13 1 179,-10 16 1,8 13 0,2 7-315,-5 2 0,1 6-344,3 6 0,2 6 0,5-1 29,7-5 0,4-2 0,4 0 0,2-1 0,4-1 1,4-7 179,11-3 0,6-13-61,-2-18 1,5-11 0,-1-5-30,-2-6 0,-1-7 0,1-1-107,-2 5 0,0-2 0,1 0 0,-1 1 219,-2 2 0,-1-1 1,0 3-1,0 5-52,3 1 0,-1 5 0,-2 10-375,4 16 1,-8 13-136,-14 17 0,-12 8 240,-6-11 0,-4 1 1,-3-3 286,-9 2 1,-5-4-123,-10 3 0,-4-11 360,8-25 0,-1-8-46,-8 0 1,3-8 584,9-18 1,6-6-675,1 0 0,9 1-45,17 4 0,8 3 45,17-3-45,1 29 0,5 8-90,-1 3 0,1 4-90,4 4 0,2 5 165,-12-3 0,0 2 0,0-2 104,8 0 1,1-3-180,-4-2 0,-1-8 45,-10-14 0,-3-7 90,2-8 0,-3-3 179,-2 0 1,-3 1 180,-1 1 0,1 7 179,15 17-1079,-11 17 1,-1 7-946,-3 5 1,1 3 211,6-4 1,4 1 0,-3-4 948,9 9 1,7-14 0,3-5-1,-11-13 1,-1 0 0</inkml:trace>
+  <inkml:trace contextRef="#ctx0" brushRef="#br0" timeOffset="11361.27">24748 16722 7533,'-20'-20'899,"10"40"1,3 15-781,2 0 1,1 5 0,0 4-776,1-1 1,0 4-1,-1 3 1,1 0 0,-1-2 535,0-6 1,0-2-1,0 1 1,0 0-1,1 2 45,-1 3 0,1 3 0,-1 1 0,1-1 0,0-4 0,0-7 689,0 11 1,0-6-705,1 10 0,-1-22 210,-1-54 0,-3-17-345,-6 7 1,-5 0 268,-2-1 1,-5 7 0,-9 13 0,-3 10 360,-1 16 0,1 10 134,-2 6 1,7 8-510,13 2 0,5 5 0,9-2-75,12 1 0,10-4 45,3 4 0,9-9-90,6-21 0,6-7 0,-1-7 1016,-5-4 0,-1-6 0,1-1-866,8 0 0,2-2 0,-3-4-90,-3-5 0,-1-4 0,-4 0 210,-6 1 0,-3-1 0,-2 2 224,-3 1 1,-4 3 495,-6 7-720,-22 34-450,4 5 0,3 3-315,2 4 1,5 1-187,4 1 1,6-1-714,6 1 0,7-6 1484,5-14 0,3-14 0,-4-21 0,0-14 0,-2-4 0,-5 2 0,0 0 0,0-1 0,0 1 0</inkml:trace>
+  <inkml:trace contextRef="#ctx0" brushRef="#br0" timeOffset="11579.27">25387 16951 7533,'0'-35'2788,"-5"23"-1709,3 37-1019,0 4 0,0 7 0,1 3-218,3 1 1,3 2 0,0 2 0,-1 1-409,-1 2 0,-1 0 0,0 1 1,1 2-91,1-4 1,1 2-1,1 1 1,-1-3 0,-2-4 428,1 4 0,-2-5 0,-1 0 227,1 3 0,-2-1 0,-2-23 0,-5-35 0,1-10 0,0 1 0</inkml:trace>
+  <inkml:trace contextRef="#ctx0" brushRef="#br0" timeOffset="11726.27">25363 17674 7533,'-11'-40'546,"-1"1"0,0-1 0,1 0 0,3-7 0,3 0 0,11 8 964,17 9 0,10 7-1600,0 9 0,5 3 0,3 1-730,-4 2 1,3 1 0,0 1 0,-3 1 409,3 1 0,-3 1 1,0 1-1,1-1 1,0 0-1,-5 1 0,16 2 1</inkml:trace>
+  <inkml:trace contextRef="#ctx0" brushRef="#br0" timeOffset="12158.27">25745 17674 7533,'-28'-6'1214,"-1"0"0,-4 16-1709,19 13 1,6 7-181,8 6 1,6 1-136,1 0 1,4-2 809,5-3 0,5-11 0,24-27 0,-18-9 0,1-1 0</inkml:trace>
+  <inkml:trace contextRef="#ctx0" brushRef="#br0" timeOffset="12870.27">26064 17657 7533,'0'-26'1799,"-11"-1"-1260,-8-1-269,-18 34-360,5 31-45,13 5 0,7 4 90,10-3 0,9-1-135,15 1 1,9-8-1,-4-20 0,4-10 180,14-17 0,-2-12 180,-17-2 0,-6-6 29,-6 1 1,-2-3 0,-3 5 240,-2-13 180,-25 11-181,-4 64-584,6-7 1,2 3-136,4 7 0,8 1 135,14-3 0,9-5 90,6-15 0,4-9 45,11-14 0,0-9 0,-6 0 0,-4-5 405,-9-11 0,-5 1 1034,0 3-1169,-11 13-540,9 42-540,14 7 361,4 3 44,0-19 0,2-9 135,-11-14 0,-2-7 315,7-2 0,-5-5 585,-18-18 0,-12-3-361,-5 11 1,-7 4-90,-4 1 0,-5 10 225,-7 22 0,2 14-1035,12 8 0,10 7-1009,13 6 1,12 0 1592,13 0 0,9-10 1,-3-20-1,4-9 1,1-3-1,0-7 1,1 0-1,-1 1 0</inkml:trace>
+  <inkml:trace contextRef="#ctx0" brushRef="#br0" timeOffset="13254.27">27123 17145 7533,'0'-42'819,"0"-1"0,0 1 0,-3-12 0,-5 19 492,-11 41-1311,7 21 0,3 13-60,2 5 0,1 7 0,2 0-369,1-4 0,1 1 0,1 1 181,2-6 1,0 2 0,1 0-1,0-2-232,0 4 1,0-2-1,1-3-48,0 7 0,1-8 528,1 6 360,-21-90 224,4 18 1,-3-1 135,-7-9 0,-5 6 314,-1 16 0,0 12-838,6 21 1,4 11-1321,4 9 0,5 4 359,7 5 1,5-2 764,4-11 0,-1-5 0,-5-5 0,-2-11 0</inkml:trace>
+  <inkml:trace contextRef="#ctx0" brushRef="#br0" timeOffset="13453.27">25954 17427 7533,'-37'-25'472,"22"21"0,16-2 0,25 24 1</inkml:trace>
+  <inkml:trace contextRef="#ctx0" brushRef="#br0" timeOffset="13703.27">25093 17410 7533,'-38'-8'359,"18"6"1,43-12 0,20-4 0,-9 9 0,0-1-1,0 0 1</inkml:trace>
+  <inkml:trace contextRef="#ctx0" brushRef="#br0" timeOffset="14776.27">27947 17463 7533,'-5'-18'1619,"-2"0"-990,0 1-539,-9 7 180,-9 2-180,-8 19 0,-5 9 225,1 1 0,0 5-136,3 7 1,-1 5 0,7 3-180,10-2 0,5 1 0,9 1-180,10 0 0,8 0 1,7-6-316,13-1 0,10-13 195,0-17 0,5-9 1,-4-6 119,0-9 0,-5-9 390,-10 2 0,-1-5 0,-6-1 239,-6-8 1,-7 0 45,-2-1 0,-5 2-46,-7 6 1,-6 15-450,-10 35 0,-1 15-405,8-5 1,3 5 284,-2 2 0,1 3 0,5-2-105,7 3 0,9-5-45,13-5 0,8-9 630,8-14 0,5-12-31,-7-5 1,2-6 0,-3-4 60,-1-5 0,-1-4 0,-3-2 119,-5-3 1,-1-2 0,-3 9 479,15 7-629,-20 15-1395,-12 42 1,1 14-605,13-17 1,3-3 1552,-6 7 0,5-7 1,10-20-1,8-9 1,-1-4-1,-5-6 1,-1 1-1,1-1 1</inkml:trace>
+  <inkml:trace contextRef="#ctx0" brushRef="#br0" timeOffset="15520.27">29708 17357 7533,'0'-18'1259,"0"0"-449,0 9-541,-6-7 631,-12 6-181,-14-8-449,-3 11 0,-6 5-135,-3 3 0,-3 6-157,7 3 0,-2 4 1,1 5 141,3 6 0,3 5 0,2 3-571,5-1 1,2 3 0,5 0 480,3-2 0,2 0 0,9-1-300,9 6 0,12-8 225,8-16 1,7-8-856,10-10 1,4-10 929,-10-4 0,0-6 0,-1-4-49,-7 0 0,0-4 0,-3-1 0,-1 2 468,1 0 1,-1 1 0,-5 1 775,-3-8 0,-8 15-955,-22 52-585,-2 11 0,1 6 90,7-13 0,3 0-868,4 2 1,2 3 0,8-8 1238,9-10 1,6-6 0,13-6-1,6-9 1,-6-13 0,-1-1-1,1 0 1</inkml:trace>
+  <inkml:trace contextRef="#ctx0" brushRef="#br0" timeOffset="16509.27">30101 17357 7533,'-24'-34'1709,"-12"5"-180,3-6-810,-15 33-269,4 21-270,21 11 0,3 9-180,7-8 0,3 2 0,1 1-90,2 2 0,2 1 0,5 0-270,5 0 0,5 0 1,4-6-136,8 3 0,7-13 630,14-22 0,1-13 0,-13 0 0,-3-8 15,-2-11 0,-2-9 0,-5 2 74,-6-4 1,-4 2-45,6-7 0,-7 7 1349,-19 15-1664,-1 54 1,-2 22 21,4-13 1,-1 4-1,0 3 1,-1 1-395,3-1 1,-1 1 0,1 2 0,-1 0 0,-1 0 506,1-3 0,-1 0 0,0 1 0,0-1 0,0-1 0,0-2-23,-2 7 1,0-3-1,0-1 1,-2 0 67,-2 0 0,-1 2 0,-2-5 0,-1-10 90,-7-8 0,-2-10-135,-1-9 0,1-10 150,9-15 0,3-10 0,2-2 29,0-4 1,1-2 0,2 0 120,0-2 0,1 0 0,6 1 29,7 1 1,5 0 0,2 6-420,1 3 0,7 5-30,11 9 0,8 4 0,1 4-210,-3 4 1,1 4-1,2-1 17,1-1 0,3 0 0,1-2 1,-1-2 491,0-3 1,0-3 0,-1-1 0,0 0 247,-2 2 0,0-1 1,-1-1-1,-3-3 665,4-12 0,-4-3 0,-4-2-403,-6 5 1,-3-2 0,-5 1-825,-3-6 0,-4-2 15,-1 2 0,0-1 0,-5 4-330,-11-12 1080,-1 6 0,-5 11 539,-25 42-719,2 10-176,21 18 0,11 8-319,13-9 0,7 2-135,1-5 0,4 2 1,3-4-914,6-6 1,4-3 0,2-2 860,5-1 0,2-2 0,-3-7 0,0-10 0,-2-8 0,-5-8 0,-1 0 1</inkml:trace>
+  <inkml:trace contextRef="#ctx0" brushRef="#br0" timeOffset="16670.27">31258 17709 7533,'-25'0'819,"11"0"0,3 0 0,11 0 0</inkml:trace>
 </inkml:ink>
 </file>
 
@@ -2628,230 +2180,230 @@
   <inkml:trace contextRef="#ctx0" brushRef="#br1" timeOffset="199008">9636 7497 7263,'18'-10'3276,"6"25"-2531,-2 19 1,-1 9-1016,0-1 0,-3 4-144,-7-11 1,-1 4 0,-3 1 0,-3-1 173,-5 6 0,-5 0 0,-4 0 172,2-8 1,-3 0 0,-2-1 0,-1-3-203,-6 3 0,-3-3 0,1-2 270,-3 10 0,1-7 0,-5-7 0,17-1 0</inkml:trace>
   <inkml:trace contextRef="#ctx0" brushRef="#br1" timeOffset="208290">11974 6932 6633,'-20'0'3276,"3"0"-2594,5 0-52,5 0 179,23 8-269,28 2-630,0-5 0,4 0-315,-3 3 0,1-1-315,-3-6 1,3-1 0,-5 1-496,1 7 1,-3 0 1214,4-8 0,-14 2 0,-28 6 0,-29-8 0</inkml:trace>
   <inkml:trace contextRef="#ctx0" brushRef="#br1" timeOffset="208604">12036 7214 7533,'-26'0'1638,"1"0"0,-7-8 1638,38 7-2722,32-15-509,3 14 0,8 2-765,-9-3 0,3 0 1,-2 1 574,-2 1 0,-2 0 1,0 3-1,13 4 1,-5 4-1,-21 0 1,-1-1-1</inkml:trace>
-  <inkml:trace contextRef="#ctx0" brushRef="#br1" timeOffset="217657">14053 6262 7263,'-5'-18'899,"-2"1"-629,1-1 360,-5 8-180,10-6 269,-5 14-449,6-5-90,0 7 719,0 15-449,0 5 134,0 17 1,0 8-525,0-10 0,0 1 0,0 3-133,0 2 0,0 4 0,0 0 0,0 0-17,1-1 0,0 1 0,1-2 0,0-2 150,0 1 0,0-2 0,0-3 120,0 12 0,3-17 0,0-30-810,-10-4-629,4-16-1529,-10-7 2788,10-11 0,-5 7 0,6-4 0</inkml:trace>
-  <inkml:trace contextRef="#ctx0" brushRef="#br1" timeOffset="218107">13980 6279 7533,'-13'-29'1638,"0"0"0,-5-5-1163,14 4 1,8 3 244,19 16 359,15 3-494,-8 14 0,2 6-286,-2 2 1,2 4 0,-4 0-120,2 5 0,-2 3-240,-3 0 0,-1 3 0,-10 1-525,-19 9 1,-11 2-181,-1 5 1,-7-2 434,2-15 0,-5-2 0,1-2-210,-6 3 1,1-3-721,-11 0 541,24-17-1,29-16 720,9-2 0,3 2 0,2-1 0,1 0 0,-1 0 0</inkml:trace>
-  <inkml:trace contextRef="#ctx0" brushRef="#br1" timeOffset="218472">14595 6156 7533,'-11'-27'3276,"-8"9"-2685,-7 26-321,3 2 0,0 7 0,3 9 0,2 8 0,-1-2 59,0-3 1,-2-1 0,2 3-163,3 4 1,1 4-1,2 1 1,3-1-198,1 7 0,4 0 0,5-2-690,5-6 0,3 0 1,4-3-444,8 12 1,6-9 1162,7-17 0,1-9 0,-8-9 0,-1-4 0,23-1 0</inkml:trace>
-  <inkml:trace contextRef="#ctx0" brushRef="#br1" timeOffset="218872">14693 6368 11490,'11'35'1124,"-2"-7"1,1 3-1260,6 4 0,0 2-958,-3-5 1,-1 2 0,0-2-328,1 11 1,0-3 1419,0-8 0,-3-4 0,-9-2 0,-2-18 0</inkml:trace>
-  <inkml:trace contextRef="#ctx0" brushRef="#br1" timeOffset="219188">14607 6809 7533,'-24'-26'3148,"10"7"-1709,20-7-585,12 6 1,6-1-405,7-5 0,2-3-151,0-1 1,3-3 0,-2 0-390,-6 3 0,-2 0 0,-1-2-900,3-5 1,-1-1 0,-4 1-650,-4-5 1,-6 2 1555,-6 4 1,-9 9 0,-23 25 0,-13 34 0</inkml:trace>
-  <inkml:trace contextRef="#ctx0" brushRef="#br1" timeOffset="219467">15112 6579 13649,'19'8'810,"-1"18"-1845,-13-2 1,-3 5-605,-4 6 1,-2 2 443,1-4 0,-2-1 1195,-2-4 0,-4-5 0,-12-6 0,-3-9 0</inkml:trace>
-  <inkml:trace contextRef="#ctx0" brushRef="#br1" timeOffset="220450">15482 6315 8612,'-7'-10'990,"1"2"-181,12 0 1,11 6-1,15-6-539,-6 4 0,2 1 89,6 5 1,1 1-585,-3-2 1,0 0 44,-5 7 0,-5 2 270,-4 8-90,-41 15-270,4-15 0,-2 1-210,-5 5 0,-3 2 1,1 1 509,3-3 0,1 1 0,0 0 299,-1 2 1,-1 0 0,3 0-195,0 4 0,4-2 585,1 14-360,24-15-270,18-11-225,2-11 0,3-4 135,-1-1 0,2-2-720,5-1 0,2-1 1,-3 0-46,-7 3 1,-1-1 764,17-4 0,-12 2 0,-28 3 0,-6 0 0</inkml:trace>
-  <inkml:trace contextRef="#ctx0" brushRef="#br1" timeOffset="220719">15432 6526 7533,'-18'-17'3276,"4"-1"-1335,7 8-1132,20 10-1618,29 18 44,-9-8 1,3 0-875,5 3 1,0-1 1091,-8-6 1,-2-2 0,-1 0 0,-3 0 0,4-4 0</inkml:trace>
-  <inkml:trace contextRef="#ctx0" brushRef="#br1" timeOffset="221071">15912 6085 7982,'11'-9'3276,"8"24"-2036,4 12 1,2 7-1151,-5-1 0,-1 3 0,-1 3-626,-3-4 0,-2 3 0,0 1 0,-2 0 198,-1 0 1,0 2 0,-3-1 0,-3 0 112,-6-1 0,-3-1 0,-3 0 1,-1-2 37,-6 10 1,-4-1-1,-4-4-443,-4-6 1,-4-2-1,1-3 630,-2 4 0,-1-6 0,-7-8 0,0-6 0,14-10 0,0 0 0</inkml:trace>
-  <inkml:trace contextRef="#ctx0" brushRef="#br1" timeOffset="221989">13795 7355 7173,'-12'-9'1169,"5"-7"270,24 6-899,3 4 0,9 2-136,8 2 1,9 2 0,5 1 0,1 0-824,-10 0 1,1 0 0,2 1-1,1 0 1,2 0 0,1 0 328,-8 0 0,3 1 0,0 0 0,2 0 0,0 0 0,1 1 0,-1-1 0,-1-1 0,-1 1-320,2-1 0,0-1 1,-1 1-1,0-1 1,0 0-1,-1 0 0,-1 1 1,0-1 222,8 2 1,0 0-1,-1 1 1,-1-1-1,-3-1 1,-1-1 208,4-2 1,-3 0-1,-2-2 1,-4 0 786,10-1 1,-6-2-406,-8 3 1,-6-3 135,-5-10-1799,-9 6-1080,-14 0 2339,3 3 0,-16 7 0,-3 0 0</inkml:trace>
-  <inkml:trace contextRef="#ctx0" brushRef="#br1" timeOffset="222540">14041 7885 7533,'0'-26'3058,"0"14"-2608,0 5-91,5 31 1,1 16-180,-5-6 0,1 3-777,3 6 0,1 5 0,-1-2 477,-4-11 0,-1-2 1,1 1-808,1 3 0,1 0 0,-3-7 927,-5 1 0,3-43 0,-1-20 0,1 0 0</inkml:trace>
-  <inkml:trace contextRef="#ctx0" brushRef="#br1" timeOffset="222857">14128 7796 7533,'8'-36'1638,"0"0"0,7-9-983,9 28 1,4 10-341,-2 19 0,0 8-180,4 0 0,-3 7-405,-9 4 0,-4 5 0,-3 1 45,-4 6 0,-7 0-405,-9-8 1,-6 1-1,-2-5-45,-9-5 1,-3-5 314,-5-1 1,0-7-901,-9-21 1260,26-4 0,33-13 0,11 7 0</inkml:trace>
-  <inkml:trace contextRef="#ctx0" brushRef="#br1" timeOffset="223220">14669 7708 7533,'-12'-27'1799,"-12"9"-1979,-2 18 225,3 13 0,-2 7 314,-1 13 1,2 5 0,0 2 0,3 4-176,7-8 0,1 2 0,4 0-64,4-3 0,3 1 0,3-1-55,2 1 1,3 0 0,2 0-936,3-2 1,2-1 0,2-2-346,6 3 1,2-6 1214,14 6 0,-14-42 0,-10-12 0</inkml:trace>
-  <inkml:trace contextRef="#ctx0" brushRef="#br1" timeOffset="224293">14755 7902 9062,'0'-19'2069,"22"-13"-1530,22 28-449,-16-4 0,3 1-225,13 5 0,1 4 90,-17-2 0,-1 0 0,3-3 0,-8 6 135,-20 12-539,-23 21 494,3-18 0,-2 3-270,-9 15 0,-1 2 180,7-6 0,-1 1 225,4-4 0,-1 1 0,3-1 134,1 5 1,6-3-135,6 12-90,14-27-90,31-16-1529,3-8-45,-14 4 0,0-2 1574,-2-2 0,-3-2 0,-5-7 0,-22-1 0</inkml:trace>
-  <inkml:trace contextRef="#ctx0" brushRef="#br1" timeOffset="224555">14792 8061 7533,'-19'0'1169,"7"0"990,1 0-720,15 0-450,14 16-1168,25-5-766,-15-2 1,2 0-695,9 0 1,0-2 1501,3-5 1,-13-1 0,-2-2 0,-1-9 0</inkml:trace>
-  <inkml:trace contextRef="#ctx0" brushRef="#br1" timeOffset="224871">15247 7708 7533,'22'-21'3276,"16"46"-1638,-11 1 0,-2 7-1634,-2 5 1,-3 7 0,-2-1-614,-6-4 0,-3-1 1,-3 2 218,0 5 0,-4 2 0,-4-1 90,-7-4 1,-5-1-1,-1-4-15,-3 2 0,-4-5-224,-11-3 0,1-7 539,3-8 0,1-7 0,22-2 0</inkml:trace>
-  <inkml:trace contextRef="#ctx0" brushRef="#br1" timeOffset="226017">16626 7144 7533,'-31'0'2428,"16"0"-2428,10 0 0,24-10 0,14-4 0,3 0 0,0-1 0</inkml:trace>
-  <inkml:trace contextRef="#ctx0" brushRef="#br1" timeOffset="227389">17881 6368 8252,'-11'24'959,"1"1"1,0 12 0,4 6-841,7 1 1,4 4 0,0 1-705,-2-11 0,0 1 1,1 1-1,0-2 375,1 11 0,2 0 1,-1-4 209,4 3 0,-2-8-76,-1-6-1183,-1-36 13,-6-24 1246,0-1 0,0-1 0,0-3 0,0-1 0,0-1 0</inkml:trace>
-  <inkml:trace contextRef="#ctx0" brushRef="#br1" timeOffset="227776">17868 6315 7533,'3'-27'1169,"0"1"0,20-4 91,21 23-946,-6 20 1,4 9-195,-13-3 0,1 2 0,-1 2-90,0 0 0,-1 1 0,-3 1-120,8 13 0,-11 2-135,-21-3 0,-12-3-495,-11-4 1,-8-5 314,-7-1 1,-4-5 134,1-9 0,1-2-90,-5 7-1349,21-13 1709,23 6 0,40-16 0,-13 3 0,-1 1 0</inkml:trace>
-  <inkml:trace contextRef="#ctx0" brushRef="#br1" timeOffset="228156">18620 6297 7533,'-25'-29'1349,"-6"5"-1079,0 40 0,-6 11 44,15 4 1,2 7-15,6-8 0,1 3 0,2 2-121,-2 9 1,2 4 0,3 1-293,5-9 1,2 1 0,1 0 0,3-2-68,1 1 0,2-3 0,4-1-870,5 1 1,4-2 0,1-9 1049,22-6 0,4-20 0,-21-20 0</inkml:trace>
-  <inkml:trace contextRef="#ctx0" brushRef="#br1" timeOffset="229575">18791 6438 7533,'-13'0'1619,"-3"0"360,9 0-1080,0 0 1,7 0 179,17 24-1169,1-7 0,2 3-1549,9 18 1,3 2-1,-3-5 1,1-3 1545,-5-4 1,-1-3 0,5-2-1,-17-23 1</inkml:trace>
-  <inkml:trace contextRef="#ctx0" brushRef="#br1" timeOffset="229922">19185 6332 7533,'-19'-19'3276,"2"27"-526,4 37-3080,6-15 0,-1 6 1,0 2-459,-2 7 0,0 3 0,-1 2 653,-1-8 0,-1 2 0,0-1 0,1-2 244,0 2 0,2-3 0,-2-1-139,0-3 0,-1-1 0,4-8-1152,2-8-707,7-3 1889,12-16 0,13-16 0,7-3 0</inkml:trace>
-  <inkml:trace contextRef="#ctx0" brushRef="#br1" timeOffset="230172">19235 6809 8972,'0'-20'3276,"0"4"-1515,11 48-1761,-2-10 0,1 3-135,0 10 0,0 2-855,1 7 1,-4-2-650,-8-12 1,-4-3 1627,1 2 1,-5-7 0,-21-12 0,-2-12 0</inkml:trace>
-  <inkml:trace contextRef="#ctx0" brushRef="#br1" timeOffset="231267">19678 6456 7982,'-13'-10'2339,"7"-6"-1349,0 7-1,17-1 0,19-6-539,-1 14 0,3 2-225,11 0 0,2 0-270,-3 0 0,-1 2-45,-4 4 0,-6 4-450,-7 7-449,-42 19 539,-10-6 0,-5 0 540,8-5 0,-1-1 150,-4 3 0,-4 1 0,2 0 164,1 4 1,2 0-90,-4 4 0,2 1 89,9-6 1,8-1-135,21 5 90,19-17 0,11-11 90,5-7-360,8 0-1035,-14-3 1,0-1-695,-8 3 1,-1 0 353,1-7 0,-3 0 1285,-2 6 0,-37 2 0,-8 10 0</inkml:trace>
-  <inkml:trace contextRef="#ctx0" brushRef="#br1" timeOffset="231557">19665 6756 7533,'-38'-10'3276,"13"2"0,36 8-2183,27 0-1768,3 3 1,3 2-1,-7 0 1,0 0-965,11 0 1,-2-1 1483,-18 2 1,-4-4 0,19-25 0,-20-7 0</inkml:trace>
-  <inkml:trace contextRef="#ctx0" brushRef="#br1" timeOffset="231874">20157 6368 8162,'6'-28'3276,"1"11"-1515,27 32-1176,-12 1 0,1 5-346,1 4 1,2 5 0,-2 2-451,-2 4 0,-2 2 0,-3 3-59,-7-3 0,-2 3 1,-3 0-1,-2-2-60,-4 6 0,-4-1 0,-4-2-390,-5-1 1,-3-3 0,-3-5-249,-5-4 0,-1-7 968,-11 4 0,3-24 0,9-4 0</inkml:trace>
-  <inkml:trace contextRef="#ctx0" brushRef="#br1" timeOffset="232655">17659 7373 7353,'-19'-8'2069,"7"-2"-720,50 1-855,-1 4 1,8 2-959,-9 0 0,4-1 1,4 1-1,3 0 0,1 0 531,-5 2 1,2 0-1,3 1 1,1 0-1,1 0 1,0 0 0,-1-1-1,0 0-339,-2 0 1,0-2 0,-1 1 0,1-1 0,0 1 0,1 0 0,0 0-1,2 2 227,-3 0 0,1 0 0,1 1 0,1 1 0,1 0 0,-1 0 0,0 0 0,-1 0 1,-1 0-1,-2 0-214,1 0 0,0 0 1,-1 0-1,-1 0 1,-1 1-1,-1-1 0,-1 1 1,-1 1 366,6 1 0,-1 0 0,-1 1 0,-2 0 0,-1 1 0,-2-1 26,9 2 1,-1 0 0,-4 1 0,-8 1 675,-5 4 0,-10 0-181,-10 3-1781,-11-17-108,0-9-1618,0-25 2878,0 13 0,-22-5 0,-6 18 0</inkml:trace>
-  <inkml:trace contextRef="#ctx0" brushRef="#br1" timeOffset="233204">18312 7849 7533,'0'-9'2518,"0"16"-2068,2 19 0,1 7-181,1 7 1,-1 4-639,-1 0 0,1 4 0,-1 0 39,0-5 0,0 0 1,-1-2-526,0 11 1,-2-4-270,1-10 0,0-9 1124,0-20 0,-5-34 0,-2-22 0</inkml:trace>
-  <inkml:trace contextRef="#ctx0" brushRef="#br1" timeOffset="233567">18349 7779 7533,'5'-37'3276,"13"3"-1785,30 32-1176,-17 12 0,2 6-225,9 8 0,-3 7-675,-10 7 0,-7 4 90,-1-1 1,-12-2-181,-24-6 1,-11-3 134,-4-2 0,-5-5 495,-3-11 0,-2-4 90,-6 1 0,4-3-764,12-6 524,9 0 0,43-6 0,18-3 0,4-1 0,-1 0 0</inkml:trace>
-  <inkml:trace contextRef="#ctx0" brushRef="#br1" timeOffset="233934">18964 7708 7533,'0'-45'2698,"-6"18"-2878,-6 11 0,-13 32 180,7 3 0,-1 5 45,-6 13 0,1 6 345,6-4 0,1 2 0,2 3-422,1 3 1,2 1 0,5 0-239,3-5 0,4 0 0,4-2-270,3-4 1,4-1-1,4-5-57,10 3 0,6-7 597,-1-11 0,1-5 0,15 5 0,-6-16 0</inkml:trace>
-  <inkml:trace contextRef="#ctx0" brushRef="#br1" timeOffset="234501">19136 7832 7533,'7'-20'1079,"10"-3"630,2 21-1079,23-6-450,-12 10 0,1 4 134,2-3 1,-1 3-765,0 6 1,-3 2 89,3 5-270,-32 23 225,-21-20 1,-7 1 269,2 3 0,-2 3-75,-1-2 0,-2 2 0,2-1 435,-1 5 0,2 0 539,-2 7 1,5-1-270,11-11 0,9-3-226,17 2-269,10-11-90,2-14 0,4-4-45,-3-1 1,0-2-1306,9 1 1,1-2 1439,-4-2 0,-5-1 0,-5-1 0,-25 2 0</inkml:trace>
-  <inkml:trace contextRef="#ctx0" brushRef="#br1" timeOffset="234784">19111 8061 7533,'-20'0'3276,"25"8"-2936,16-3 1,7 0-881,17 4 1,4-1 224,-1-2 0,0-2-615,-11-3 1,1 0 0,-4-3 805,-3-1 1,-3-4-1,7-18 1,-31-3 0</inkml:trace>
-  <inkml:trace contextRef="#ctx0" brushRef="#br1" timeOffset="235140">19690 7655 7533,'18'-10'3276,"6"18"-2261,-6 7 1,1 6-657,7 18 1,-3 8 0,-8-8 0,-4 3 0,-2 2-731,-5-3 1,-2 1 0,-3 2 0,-3-2 100,-2-2 0,-3-1 0,-3 0 0,-1-2-330,-6 7 1,-2-1-1,-3-7-704,-7-1 0,0-9 1334,-5-3 0,18-30 0,12-3 0</inkml:trace>
-  <inkml:trace contextRef="#ctx0" brushRef="#br1" timeOffset="247940">1817 6791 7533,'8'-27'1259,"-6"1"-360,5 24-359,-7 43-420,0-10 0,0 5 0,0 3-278,0 4 1,0 4 0,0 2-1,0-2-361,0-3 1,0-2 0,0 1 0,0-1 158,0 0 0,-1 2 1,0-3-1,3-6-360,6 4 1,0-7 719,-4 1 0,4-41 0,-18-11 0</inkml:trace>
-  <inkml:trace contextRef="#ctx0" brushRef="#br1" timeOffset="248339">1887 6632 7533,'0'-39'2338,"32"8"-1933,-7 45 0,5 11-225,10-7 0,2 5-150,-13 4 0,-1 6 0,-5 1-120,1 10 0,-10 2-60,-14-11 0,-7 2 0,-4-3-60,-6-2 0,-4-1 0,-6-4-90,-10 1 0,-6-4 1,2-5 74,-8-3 0,2-5-90,0 0 0,7-8-1034,15-19 1349,19 14 0,45-13 0,0 5 0</inkml:trace>
-  <inkml:trace contextRef="#ctx0" brushRef="#br1" timeOffset="248656">2152 7355 7533,'-9'28'1529,"0"-1"0,0 9-899,9-21-990,9-54 360,0 9 0,0-5-180,-3 4 0,0-3 0,0-1 270,0-1 0,0 0 0,-1 3-405,-2-4 0,4 9-854,24 10 134,-12 33 1,0 8 1034,7 0 0,2 3 0,-5-2 0,0 2 0,0-2 0,8 3 0,1 1 0</inkml:trace>
-  <inkml:trace contextRef="#ctx0" brushRef="#br1" timeOffset="249000">2505 7197 7533,'-26'-36'3276,"-1"17"-2235,-8 11-681,7 41-900,17 4 1,4 5 224,5 0 0,4 2 270,3 3 0,8-6 405,10-14 0,5-11 269,21-24-674,-20-21 0,-5-10 0,-9 4 0,-5-1-360,-3-7 1,-6 0-271,-7 11 1,-3 5-1305,-3 6 1979,2 21 0,36 21 0,-3 1 0,1-1 0</inkml:trace>
-  <inkml:trace contextRef="#ctx0" brushRef="#br1" timeOffset="249456">2875 6720 7533,'-9'-41'1092,"1"0"0,3 8 0,0 5-860,-3 11-322,8 58 45,4-3 0,0 6-135,-4-2 0,0 3 0,2 1-55,2-5 0,3 0 1,0 2-1,-2-1 122,-1 1 1,-2 1 0,1-1-1,0-2 233,3 2 0,1-3 0,-2-2-208,-2 8 1,-6-17-273,-15-39-90,-6-8 0,-3-1 315,-1 2 1,-1 4 718,-3 2 1,1 6 1034,-4 23 630,19 25-2249,32 4 332,2-18 0,7-5-332,20-6 0,6-8 0,-7-8 0,0-4 0,-7-5 0,0 1 0,-1-1 0</inkml:trace>
-  <inkml:trace contextRef="#ctx0" brushRef="#br1" timeOffset="250856">3563 7461 7533,'-10'18'2158,"2"0"-1438,8-9-180,0-1-450,0-31-225,4-2 0,0-3-315,-3-11 0,0-5 90,3 7 0,2-2 1,0 2-91,2-3 0,2 3 315,0 3 1,7 10 44,11 23 0,3 9-90,-7 2 0,1 2 0,5 2 0,1-1 45,-4-3 0,-4-4 225,-1-6 360,2-8 809,-24-2-179,0 1-181,-8 1-539,-2 39-450,-8 0-90,12-5 0,2 1 90,6 3 0,4-1-315,5 4 1,6-3 44,7-7 0,5-5 90,-3-2 0,3-8 90,6-21 1,-2-10 44,-12 1 0,-3-3 449,9-8 1,-5-2 90,-14 3 0,-4 1 314,6 3 1,-4 1 539,-22-16-1978,4 33 449,-13 28 90,15 11 45,5-1 0,2 3 180,2-4 0,2 1 135,4 12 0,6-2-495,5-12 0,3-3 315,-5 1 0,4-7-360,13-15 1,2-11 89,6-19 450,-12 3 0,-1-3-45,-7 9 0,-2-1 179,-3-9 1,-3 1 45,-1-1-90,-18-6-360,-4 9-270,-13 16 180,15 2 0,-6 8 0,14 8 180,-5 10-179,7-6 179,0 11-1170,0-21 1170,0 14 0,7-22 0,3 4 0</inkml:trace>
-  <inkml:trace contextRef="#ctx0" brushRef="#br1" timeOffset="251567">4410 6720 7533,'0'-25'719,"-8"5"-179,6 3-450,-6 17 360,8 25-1,0 12-179,0-1 0,0 5-270,0 6 0,0 4 112,-1-15 1,-2 4-1,1 1 1,0-1-535,1-1 1,1 1-1,0-1 1,-1-1 421,-2 9 0,-1-1 0,3-3-120,5-7 0,1-2 0,2-4-420,13 15 90,15-18 360,8-27 0,-13-4 0,-6-13 1,1-5 268,12-7 1249,-15 4 0,1-3-709,0-2 1,-3-1-405,-8 4 0,-4-1-225,-6 0 0,-4 3-360,-18-2-45,-5 15 0,-1 8 765,-5 20-225,3 13 0,7 8-180,19 1 0,8 3-555,-3-4 0,3 2 1,4-2-584,8-5 1,4-2 0,1-3 925,4 3 0,3-6 1,6-4-1,2-6 1,-10-10-1,-1 0 1</inkml:trace>
-  <inkml:trace contextRef="#ctx0" brushRef="#br1" timeOffset="253372">1870 10089 8792,'0'35'287,"0"0"1,0-1 0,-1 14 0,1 2 0,1-1-258,1-1 0,1-1 0,0-1-60,-3 1 0,-1-1 0,4-5 75,6 3 0,-3-20-405,-12-32 135,9-15 1,0-8-1,-17-12 0,-3-5 22,12 13 1,2-4 0,1 0-1,-2 0 75,-4 1 0,-1 2 1,-1-1-1,4-1 218,2-4 0,3-2 0,2 1 0,1 3 89,1-1 1,3 2 0,2 3 0,8-6 0,6 8 45,2 16 0,5 9 254,3 10 1,3 8 0,-2 4 15,0 12 0,-2 7-642,0-2 0,-1 4 0,-6 0 416,-11 7 1,-9 0-233,-8 6 1,-9-2-623,-11-10 1,-5-5-226,-6 0 1,-3-5-226,-2-4 1,0-9 404,3-13 1,3-6 629,-3-4 0,13-23 0,24 7 0</inkml:trace>
-  <inkml:trace contextRef="#ctx0" brushRef="#br1" timeOffset="253806">1076 10195 7533,'-16'-25'2158,"12"5"-988,4 3-91,28 40-854,-6-9 0,1 3-135,-3 8 0,0 4 0,1 2-1080,4 3 1,2 2-1,-1 0 60,-3-2 1,-1 1 0,0-1 754,-1 2 1,0 0 0,-3-4 0,-3-4-1,-4-3 1,-3 9 0</inkml:trace>
-  <inkml:trace contextRef="#ctx0" brushRef="#br1" timeOffset="254040">1164 10601 7533,'-29'-33'3276,"37"-5"-2531,14 8 1,10 0-896,0 10 0,4 3 0,2-1 150,-2 1 0,3-1 0,-1 1 0,-2 0 0,1-1 0,-1 0 0,-1-1 0,4-1 0,-1 0 0,1 0 0</inkml:trace>
-  <inkml:trace contextRef="#ctx0" brushRef="#br1" timeOffset="254834">2611 9913 7533,'-10'-18'1169,"-6"1"-809,-2 7-90,-1 2-90,-14 16-90,5 10 44,2 18 1,1 10 45,8-7 0,3 2-277,-1 2 1,-1 4 0,6 0 66,5 0 0,5 0 0,3-1-60,0-7 0,3-2 0,2 0-270,2 0 1,2 0-1,4-7 45,4-5 0,5-7 315,8-7 0,0-6 0,1-5 0,15 0 0</inkml:trace>
-  <inkml:trace contextRef="#ctx0" brushRef="#br1" timeOffset="255422">2752 10231 7083,'9'-26'2788,"23"14"-2428,-11-11-360,23 21-180,-1-6 360,-14 16-90,-4 2 360,-25 15-990,-17 3 270,-3-1 135,0-7 0,-1 1-404,-8 16 674,6-11 0,3 1 134,0 18 91,4-1-180,16-17 0,8-2 90,10-15-360,17-2-270,2-8-539,6 0-271,-7 0-898,-1 0 2068,-15 0 0,-5 16 0,-15 3 0</inkml:trace>
-  <inkml:trace contextRef="#ctx0" brushRef="#br1" timeOffset="255705">2734 10425 7623,'-18'-10'2158,"9"-6"-2068,1 14-449,16-6 538,17 8-494,0 0 1,3 0-541,11 0 1,2 0 854,-4 1 0,1-2 0,8-5 0,0-3 0,-10-1 0,0 0 0</inkml:trace>
-  <inkml:trace contextRef="#ctx0" brushRef="#br1" timeOffset="255987">3193 9895 8162,'33'22'1638,"-7"2"0,1 7-1351,-5 5 0,0 7 1,-1 1-765,-4-6 1,0 2 0,-1 1 0,-4 1 48,-3 2 1,-3 2 0,-3-1 0,-1-2-323,-3 6 1,-2-3-1,-5-3 750,-2-9 0,-3-3 0,-1-2 0,-7 1 0,-1-4 0,4-7 0,0 0 0</inkml:trace>
-  <inkml:trace contextRef="#ctx0" brushRef="#br1" timeOffset="259292">7236 9772 6993,'-14'-10'2249,"-2"-6"-2069,14 15 0,-3-7-1,5 8 181,5 0 810,-3 23-541,3 14-494,-5-5 0,-1 9 0,-1 2 0,0-2-105,-1 6 0,1-1 0,0 2-850,0 0 1,0 3 0,1-1 0,-1-7 663,-2 6 0,2-7-159,3-6 1,4-10-1216,2-22 271,5 12-990,0-40 2249,1 11 0,-6-17 0,-2-5 0,1 7 0,1-1 0</inkml:trace>
-  <inkml:trace contextRef="#ctx0" brushRef="#br1" timeOffset="259674">7150 9807 7533,'-10'-35'869,"1"0"1,1-5-1,3 1-374,6 6 0,4 2-46,7 2 1,6 5 0,8 7 0,4 8-1,10 15 1,1 12-240,-9 3 0,0 6 0,-3 3-31,-2 7 1,-4 3 0,-2 3-721,-3 4 0,-3 2 0,-6-2 301,-5-9 0,-4-2 1,-5-2-976,-13 8 1,-7-8 224,3-18 1,-2-5 674,-1-1 0,1-4 315,-12-6 0,39-16 0,6-3 0</inkml:trace>
-  <inkml:trace contextRef="#ctx0" brushRef="#br1" timeOffset="260518">7925 9666 6813,'-5'-18'2789,"3"9"-2250,-3-7-449,-1 14-90,-6 2 0,-12 26 180,5-3 0,0 6-120,6 3 0,0 4 0,1 0-30,0 3 0,1 1 0,3 1-97,2 5 0,4 3 1,3-3 36,3-6 0,2-1 0,3-2-150,9 9 0,2-4 0,-4-14 0,1-3-360,5-2 1,1-5-2159,10-6 2698,0 3 0,-10-23 0,-18-1 0</inkml:trace>
-  <inkml:trace contextRef="#ctx0" brushRef="#br1" timeOffset="260924">8073 9825 7533,'-21'-20'2069,"5"5"-1440,21 30-89,8 5-360,1 7 0,2 5-90,2 2 0,2 4-780,-1-1 0,2 2 1,-1-1 89,-3-6 0,0-1 1,1 0-7,1-1 1,-1 0 0,0-4 605,0-2 0,-5-5 0,-6-1 0,-15-10 0</inkml:trace>
-  <inkml:trace contextRef="#ctx0" brushRef="#br1" timeOffset="261207">8023 10301 7533,'-24'-18'3276,"5"-7"-616,28-18-1985,10 13 0,6-3-496,1 2 1,4-1 0,2-1-568,2 0 1,2-1 0,0 1-706,0 0 1,0-1 0,-2 3-547,3-2 1,-4 3 1437,-9 8 1,-8 11 0,-16 19-1,-13 12 1</inkml:trace>
-  <inkml:trace contextRef="#ctx0" brushRef="#br1" timeOffset="261434">8540 10142 7892,'13'43'3276,"-1"-5"-1155,0 5-2930,-10 0-1980,-15-6 1350,-1-11 0,-3-1 1439,-10 5 0,-7 3 0,14-15 0</inkml:trace>
-  <inkml:trace contextRef="#ctx0" brushRef="#br1" timeOffset="262007">8873 9825 7533,'-30'-8'2338,"9"6"-2068,3 2 630,24 10-541,24 23-359,-7-14 0,5-1-750,-2 0 1,4 0 0,-2-1 749,9 5 0,-1-6 0,-2-12 0,-1-6 0,8-20 0</inkml:trace>
-  <inkml:trace contextRef="#ctx0" brushRef="#br1" timeOffset="262258">9254 9772 7533,'-11'-35'3276,"3"15"-1155,-15 20-1897,7 27 1,2 13-765,-1 0 1,0 6-1,1 1-280,2-9 1,1 2 0,-1 0 0,2 1 581,-1 2 0,2 3 0,0-2 0,1-3-152,0 0 1,2-2-1,2-3-452,0 2 0,2-6 842,8 2 0,6-34 0,7-10 0</inkml:trace>
-  <inkml:trace contextRef="#ctx0" brushRef="#br1" timeOffset="262434">9377 10231 9961,'-19'-2'-1709,"-10"27"1709,14 6 0,5 5 0,2 3 0,5-7 0,1 1 0</inkml:trace>
-  <inkml:trace contextRef="#ctx0" brushRef="#br1" timeOffset="263524">9685 9825 6723,'-6'-10'900,"0"2"-91,6 0 1,-6 6-91,5-13 181,-4 13-361,5-6 91,5 8-90,18 0-540,21 0 0,-11 0 0,2 0-45,0 0 0,0 0 0,-3-1 0,-3 2 135,8 7-90,-19 9 90,-18 11-90,-11 0 0,-7 3-135,-8 8 0,-4 2 15,9-11 0,-1 1 0,0 0-110,-3 2 1,0 1 0,2-5 319,3-5 0,2-1 314,-3 6 1,2-3 225,-1-4-450,1 13 180,13-10 179,29-15-359,10-2 419,5-8-1004,-7-3 0,1-2-360,-2-3 1,-1-1-586,9 3 1,-1 0 1349,-2-7 0,-8 2 0,-18 9 0,-20-6 0</inkml:trace>
-  <inkml:trace contextRef="#ctx0" brushRef="#br1" timeOffset="263824">9685 10089 7533,'-24'-17'3276,"10"-1"-1875,3 8-501,38 3-990,13 14-900,6-2 1,3 0-586,-11 0 1,0 0 1574,6 0 0,-5-2 0,-8-3 0,-14 0 0</inkml:trace>
-  <inkml:trace contextRef="#ctx0" brushRef="#br1" timeOffset="264184">10115 9648 7533,'18'-19'3276,"13"11"-2415,7 34-411,-7 7 0,-2 10-241,-13-10 1,-3 4 0,-1 3-446,-2 2 1,0 5 0,-3 0-1,-4-1 56,-4-5 0,-3-2 0,-2 1 1,-1-1-46,1 0 0,-1 0 0,-2-2 0,-3-3-260,-14 9 0,-3-8-550,10-16 1,0-5 1034,-16 2 0,26-14 0,5 6 0</inkml:trace>
-  <inkml:trace contextRef="#ctx0" brushRef="#br1" timeOffset="265084">11322 10054 7173,'-20'-10'2968,"8"-5"-1798,6 13-1,6-22-270,11 20-179,12-4 0,6 1-945,8 5 0,4 4-45,-6 2 0,1 2 0,0-1-810,15-4 1,-4 2-270,-7 9 0,-5 0 1349,3-2 0,-76 7 0,0-8 0,1 0 0</inkml:trace>
-  <inkml:trace contextRef="#ctx0" brushRef="#br1" timeOffset="265285">11371 10178 8612,'-33'0'3276,"21"0"-76,53 0-2750,0 11 0,5 1-1543,-12-9 1,1-3 0,0 3 827,0 6 0,0 4 0,-1-4 0,6-3 0,-2-2 1,-8 5-1,1 0 0</inkml:trace>
-  <inkml:trace contextRef="#ctx0" brushRef="#br1" timeOffset="269651">13549 9402 7083,'-21'-20'2878,"5"-4"-2068,16 22 359,0 2-449,5 26-91,8 19-629,-10-14 0,-1 4 0,1 1-210,1-2 0,0 1 1,-1 0 29,-2 4 0,-2 1 0,1-4-315,0 2 1,0-5-586,0 0-1618,5-41 1708,2 5 990,6-29 0,-1 13 0,0-17 0</inkml:trace>
-  <inkml:trace contextRef="#ctx0" brushRef="#br1" timeOffset="270050">13574 9260 7533,'-7'-32'1092,"0"0"0,-2-1 0,7 7 309,18 14-142,16 30-1034,-5 10 0,2 7-225,-7-7 0,-1 2 0,-1 2-150,-3-1 0,-2 2 0,-2 1-210,-3 1 0,-2 1 1,-8-3-181,-15 2 1,-6-4 224,2-2 0,-4-7-360,-12-10 1,-1-8-945,2-12 269,10 6 811,31-6 539,7 8 0,9 0 0,4 0 0,0 0 0,0 0 0</inkml:trace>
-  <inkml:trace contextRef="#ctx0" brushRef="#br1" timeOffset="270508">14115 9243 7533,'-12'-18'2968,"-1"1"-2248,7-1-181,-5 8-269,4 2-630,-11 8 1,-7 0 493,5 13 1,-2 6 45,-1 2 0,1 5 0,-2 12 0,4 4 0,6-3 0,4 2-30,7-7 0,3 0 0,3 0-510,9 13 0,6-2-270,0-2 1,4-3 404,-2-8 0,3-6-1934,18-8 270,-15-10 1889,-1-8 0,-13-16 0,-7-3 0</inkml:trace>
-  <inkml:trace contextRef="#ctx0" brushRef="#br1" timeOffset="270908">14251 9296 7533,'-7'-10'2158,"-4"-6"-1348,9 14 269,2 10-449,7 12-270,4 4 0,2 3-270,-1-1 0,1 3-765,8 13 0,1 2-899,0-10 0,0-2 809,-6 0 1,0-3 764,3-3 0,-9-11 0,-20-19 0,-4 0 0</inkml:trace>
-  <inkml:trace contextRef="#ctx0" brushRef="#br1" timeOffset="271257">14152 9701 7533,'-13'-17'3276,"7"-1"-1245,35-15-1087,-3 8 1,4-3-586,-3 3 1,3-2 0,0-1-390,2-4 0,0-1 0,-2 0-930,-1 0 1,-1 0 0,-3 1-391,-1-6 1,-5 3-1619,-2-8 2968,-24 43 0,-11 20 0,-1 15 0</inkml:trace>
-  <inkml:trace contextRef="#ctx0" brushRef="#br1" timeOffset="271451">14682 9525 9062,'-16'22'779,"0"-1"1,-3 5-1,2 1-779,3 4 0,2 1 0,-2 15 0,10-6 0</inkml:trace>
-  <inkml:trace contextRef="#ctx0" brushRef="#br1" timeOffset="272584">14940 9313 7623,'0'-9'1799,"0"1"-630,0 8 0,0 0 1,-5 0-451,3 0 91,8 0-271,24-8-404,-4 7 0,3 0-180,9-3 0,0 0 0,-3 4 0,-1 0-45,-5-1 0,-3 2 1,4 7-1,-23 2-180,-30 15-270,7-4 0,-3 1 180,-10 5 1,-1 1 224,9-1 0,2 1-90,-8 9 0,2 1 360,8-6 0,1 0 270,-1 1 0,2-1 44,3-1 1,6-3-270,12-9 450,19-3-271,18-24-359,3-2-90,-17 6 0,0-1-899,-6-8 0,-1 2-2288,28 7 3106,-24-19 1,-26 21 0,-21-6 0</inkml:trace>
-  <inkml:trace contextRef="#ctx0" brushRef="#br1" timeOffset="272874">14989 9578 7533,'-38'0'3276,"8"0"-1965,17 0-411,19 0-271,24 0-809,15 0-1459,3 0 1,4 0 38,-13 0 1,-2 0 1599,4 1 0,-2-2 0,6-15 0,-26-3 0</inkml:trace>
-  <inkml:trace contextRef="#ctx0" brushRef="#br1" timeOffset="273223">15432 9084 7533,'6'-18'3276,"11"16"-706,15 36-2030,-4-5 0,-1 6-480,-11 0 0,-4 4 0,0 1-30,1 1 0,-1 1 0,-7 1-525,-8-6 0,-5 1 0,-4 0 1,1-3 224,-2 2 0,0-2 0,-5-3-570,-4 0 1,-4-3 0,2-5-196,1-9 1,2-5 1034,-4-2 0,14-8 0,11 0 0</inkml:trace>
-  <inkml:trace contextRef="#ctx0" brushRef="#br1" timeOffset="274007">15899 9260 7533,'0'-25'2428,"0"13"-1438,6 4-406,-2 29 1,-1 15-315,0 4 0,0 4-403,0 1 1,-1 3 0,-1 1-116,-1-12 1,0 2-1,0-1 1,0-2-83,0 4 0,0-3 1,0-2 29,-2 7 0,4-7-1859,9-12 2159,3-39 0,-6-10 0,-2-6 0,-1-10 0,1-1 0</inkml:trace>
-  <inkml:trace contextRef="#ctx0" brushRef="#br1" timeOffset="274400">15924 9172 7533,'-1'-43'3276,"8"22"-1875,33 13-907,-14 18 1,1 7-255,-3 3 0,1 4 0,-1 1-15,8 10 0,-6 4-495,-7 9 0,-12 0-270,-20-5 1,-10-5-316,-3-12 1,-4-5 494,-4-2 0,0-7-1259,-12-12 270,26 0 1349,30 0 0,28 8 0,-3-3 0,0 0 0</inkml:trace>
-  <inkml:trace contextRef="#ctx0" brushRef="#br1" timeOffset="274858">16613 9190 7533,'-5'-41'2698,"-2"17"-1708,-5-17-271,-6 31-359,-12 26-90,7 7 0,2 7-270,5-1 0,1 4 0,1 3-202,3 2 0,1 3 0,1 2 0,2-1-383,3 0 0,1 0 1,2 0-1,2-1-207,2 0 1,1 1 0,2-1 0,0-4 791,6 16 0,4-10 0,19-10 0,-10-35 0</inkml:trace>
-  <inkml:trace contextRef="#ctx0" brushRef="#br1" timeOffset="275507">16822 9296 7533,'0'-20'2698,"6"4"-1169,12 32-989,13 4-360,-7 8 0,1 2-900,-2-9 1,0 0-676,0 10 1,2-4 1394,17-7 0,-15-28 0,2-21 0</inkml:trace>
-  <inkml:trace contextRef="#ctx0" brushRef="#br1" timeOffset="275774">17192 9260 7533,'0'-29'3276,"-11"6"-1335,-3 54-1492,-3-6 1,-1 5-360,6 1 0,1 5 0,1 3-383,-1-4 1,0 3 0,0 1 0,1-2-288,2 5 1,2-1 0,0-1 39,-1 0 0,1-1 1,3-6-1186,8 10 1725,12-27 0,10-56 0,-9 16 0,0-1 0</inkml:trace>
-  <inkml:trace contextRef="#ctx0" brushRef="#br1" timeOffset="275967">17290 9613 7533,'-12'-2'3276,"5"12"-4843,-9 25 1567,13-9 0,3 1 0,-4 0 0,2 1 0,6 2 0,-1 1 0</inkml:trace>
-  <inkml:trace contextRef="#ctx0" brushRef="#br1" timeOffset="276773">17511 9243 7533,'-13'-20'3276,"13"5"-1245,30 15-1717,-6-1 1,3 2-405,9 6 0,1 1 90,-7-7 0,-1 2-180,4 14 1,-7 5-181,-11 16 360,-20-8 0,-7 2 45,-7-1 0,-4 1-15,2-4 0,-2 0 0,0 0-30,-3 5 0,2 1 45,3 6 0,5-2-135,-2 7-90,18-11 360,13-25-180,22-1-180,10-16 90,0 7-360,-16-7 0,0 0 1,10-2-1190,-14 5 1,-1 0 979,2-3 1,-20 8-1,-20 0 1</inkml:trace>
-  <inkml:trace contextRef="#ctx0" brushRef="#br1" timeOffset="277156">17474 9613 7533,'-24'-8'2968,"5"-1"-2158,7-1-451,28-6-449,22 14-135,-2-2 1,2 0-631,0 8 1,1 0 854,9-2 0,0-2 0,-17 1 0,-2-2 0,3-4 0,0 0 0</inkml:trace>
-  <inkml:trace contextRef="#ctx0" brushRef="#br1" timeOffset="277523">18004 9172 8162,'24'0'3276,"7"16"-2306,-12 6 1,-2 7-521,1 13 0,-3 6-616,-4-8 1,-2 2-1,-4 1-14,-7 5 0,-4 0 1,-2-2-91,0-11 0,-1-1 0,-3-2-54,-11 15 1,-3-9 323,-12-11 0,19-19 0,8-18 0</inkml:trace>
-  <inkml:trace contextRef="#ctx0" brushRef="#br1" timeOffset="279151">13365 10266 7533,'-19'0'1889,"50"-8"-1530,-6 4 1,4-2 0,16-6 0,5-1-121,-7 5 1,2 2 0,2 0-748,-9 1 0,1 0 0,0 1 1,1 0 507,4 2 0,0-1 0,1 2 0,0 0 67,0 0 0,2 1 1,-1 0-1,-1 1 23,-3-1 0,-1 0 0,0 0 0,-1 0-119,9-3 0,-2 0 0,1 1 89,-1 1 0,1 1 0,-2-1-30,-10-2 0,-1 0 0,0 1 0,0 4 0,-1 1 0,-2 0 229,1-3 0,-2 2-214,10 6 0,1-1 269,-3-5 1,2-2-165,6 5 0,4 1 0,0-1-38,-14-3 1,0-2-1,1 0 1,1 0-256,8 0 0,2 0 1,1 0-1,-2 0 165,-4 0 1,0 0 0,-1-1-1,-2 0 38,6-1 0,-2-1 0,3 0-105,-2 3 0,4 0 0,-1 0 0,-3 0-45,0 0 0,-3 0 0,4 0 54,-9 0 0,1 1 0,3-1 0,-1 0 1,1-1-1,1 0 0,1 0 0,0-1 0,-1 0 0,0 0 72,-2 1 0,0-1 0,-1 0 0,1 0 0,-1 0 8,9-2 1,1-1 0,-1 1 0,0-1 22,-3 0 1,0 1 0,0-1-1,-4 1-67,1 1 0,-3-1 0,1 2 85,-3-1 0,0 1 0,1 0 0,-2 1-115,3 0 0,-2 1 0,2 1 0,5-1 0,2 0 0,-3 0 90,-7-3 0,-2 0 0,-1 1-15,16 1 0,-2 0 348,-8-3 1,-4 0-34,-2 4-540,-4 16-449,-19-4 120,-33 21-2459,-5-6 3086,-6-7 0,-7-12 1,14-18-1</inkml:trace>
-  <inkml:trace contextRef="#ctx0" brushRef="#br1" timeOffset="280251">15112 10530 7533,'5'-25'1799,"2"-2"-1080,0-1 810,4 10-809,-10 11-270,5 30-1,-8 12 1,-2 7-540,1 4 0,-1 4-495,0-3 0,0 4 0,0-2 435,1-12 0,1 0 0,0-2-240,1 1 1,1 0-1,1-4-330,2-2 1,1-5-1080,8 8 180,-5-33 1619,4-9 0,-9-17 0,3-1 0</inkml:trace>
-  <inkml:trace contextRef="#ctx0" brushRef="#br1" timeOffset="280609">15112 10513 7533,'5'-34'1979,"13"13"-1215,4 6 1,4 4 134,22 11-539,-11 13 0,-3 8-46,-15 0 1,-4 5-90,1 8 0,-9 2-495,-17-3 0,-8-3-360,-1-6 1,-4-3-46,-7-2 1,-1-5-1755,-13-4 630,20-2 1799,18-16 0,40-2 0,13-7 0</inkml:trace>
-  <inkml:trace contextRef="#ctx0" brushRef="#br1" timeOffset="281001">15653 10407 7533,'-18'-18'2338,"-1"9"-1708,-5 9 180,-12 17-226,19 5 1,2 7-136,-2 5 1,0 5 0,3 0-270,4-6 0,4-1 0,0 3-428,1 1 1,0 4 0,3-1-1,3-3-112,9 8 1,4-4-541,1 1 1,3-4 44,0-12 1,1-7 854,17 0 0,-16-18 0,3-10 0</inkml:trace>
-  <inkml:trace contextRef="#ctx0" brushRef="#br1" timeOffset="282134">15751 10583 8342,'-13'-8'990,"3"7"-271,10-7-539,0 0 720,5 6 89,29-6-539,12 8-270,-10-4 0,2 0-315,2 3 0,-1 0 180,-3-2 0,-2-2 90,-5 1 0,-2 1 224,14 1-179,-27-6-270,-9 23-1079,-33 13 899,11-3 0,-1 3 225,-6 4 0,0-1 0,4-8 0,2 1 45,2 8 0,3 0 0,2-8 0,2-1 0,2 5 0,2-1 360,-1 16-270,12-25-90,-5-10 180,5-8 180,5 0-360,8 0-900,23-8-90,-17 7 1,1 0 989,6-8 0,-3 2 0,6 21 0,-8-2 0</inkml:trace>
-  <inkml:trace contextRef="#ctx0" brushRef="#br1" timeOffset="282558">15801 10813 7533,'-26'-10'3276,"8"2"-1785,12 0-771,17 6-181,25-6-854,-11 7 1,2 2-631,15 3 1,1 0 134,-7 1 1,-1 0 809,4 4 0,0 0 0,-10-4 0,-2-1 0,0 0 0,1 0 0</inkml:trace>
-  <inkml:trace contextRef="#ctx0" brushRef="#br1" timeOffset="282972">16380 10513 9781,'43'13'1638,"-17"6"0,-4 8-661,-10 1 0,-3 6 0,-2 2-1547,1 2 0,0 1 1,-6 1-524,-10 5 1,-5 0 0,-1-4 918,0 4 1,-3-5-1,-9-7 1,-2-7 0,-2-11-1</inkml:trace>
-  <inkml:trace contextRef="#ctx0" brushRef="#br1" timeOffset="300784">847 11959 7533,'-38'-10'3276,"13"18"-2055,17 12-1041,16 7-540,10-1-90,1-16 1,7-18-541,-17-4-539,-9-6-360,-9 10 1889,-1 8 0,2 47 0,8-17 0,0-1 0</inkml:trace>
-  <inkml:trace contextRef="#ctx0" brushRef="#br1" timeOffset="301735">547 12294 7533,'-18'-17'1619,"1"7"180,7-6 989,41 6-2608,-5 1 314,17 0 1,12 2-675,-10 1 0,3 0 1,-2 0-301,-10 2 0,-2 1 1,2-1-241,10-4 0,2-2 1,-11 4 179,-10 4 540,-19 33 0,-18-13 0,2 7 0,-1-1 0</inkml:trace>
-  <inkml:trace contextRef="#ctx0" brushRef="#br1" timeOffset="302217">811 12506 8432,'-19'0'2519,"3"0"-1800,16 0-899,24-8-359,-18-17-1,9 3 900,-40 4-540,3 36-1619,5 4 1799,18 3 0,27-34 0,9-13 0,1-3 0,1 1 0</inkml:trace>
-  <inkml:trace contextRef="#ctx0" brushRef="#br1" timeOffset="305988">1799 11853 7892,'-19'16'1079,"8"23"1,6 12-870,5-9 0,4 2 0,0 1-1303,-1 5 1,0 1 0,1-3 760,-2-8 1,1-2 0,1-4 640,4 2 0,0-7-848,2-8 29,0-19-1649,-10-23 2159,-4-4 0,-2-3 0,-6-6 0,-2-1 0,1-1 0,-1 0 0</inkml:trace>
-  <inkml:trace contextRef="#ctx0" brushRef="#br1" timeOffset="306308">1782 11818 7533,'4'-40'929,"1"0"1,5 10-1,4 5-434,6 8 0,3 8 134,1 18 1,1 8-360,15 11 0,-4 7-360,-16 4 0,-8 4-405,0 5 0,-9 0-90,-17-6 1,-7-4 449,8-8 0,-5-5-540,-18-5 1,-1-7-46,12-5-719,-16-8 1439,56 0 0,12-6 0,7-3 0,12-1 0,0 0 0</inkml:trace>
-  <inkml:trace contextRef="#ctx0" brushRef="#br1" timeOffset="306609">2364 11695 7533,'-26'-18'3276,"-1"8"-3134,-9 18-367,18 13 0,1 9-45,4-1 0,0 5 0,4 1 180,2 6 0,3 2 1,3 0-504,1 5 0,3 0 1,4-3 412,2-7 0,4-2 0,2-2 164,4-2 1,2-2-1,0-6 1,18 6-1,2-16 1</inkml:trace>
-  <inkml:trace contextRef="#ctx0" brushRef="#br1" timeOffset="306990">2452 11853 9691,'23'43'90,"7"-13"-1169,-4-9 0,1-1 1079,10 0 0,4-18 0,-14-14 0</inkml:trace>
-  <inkml:trace contextRef="#ctx0" brushRef="#br1" timeOffset="307259">2769 11712 7533,'-17'0'3276,"-1"16"-2306,8 7 1,2 5-1196,3 3 0,1 4 75,-2 5 0,0 4 0,2 0-450,3-6 1,1-2-1,-1 2-493,-2 1 1,0 1 0,1-4 617,2 2 0,0-5 475,0 0 0,8-49 0,2-13 0</inkml:trace>
-  <inkml:trace contextRef="#ctx0" brushRef="#br1" timeOffset="307474">2858 12118 9781,'4'29'1124,"1"1"1,3 19-2764,-14-10 1,-4-2 1501,-1 2 1,-11-19 0,-5-6 0,-20-6 0</inkml:trace>
-  <inkml:trace contextRef="#ctx0" brushRef="#br1" timeOffset="308602">3140 11818 8882,'-8'-20'2159,"6"5"-1530,-6 7 271,8 6-181,8-14-629,2 14 180,31-13-270,-10 13 45,-6-3 0,1 2-405,17 19 270,-13-13 0,3 29 180,-23-20-90,-10 13-359,-10-7-91,-15 7-180,-3 10 630,7-9 0,-1 1 45,3 4 0,1 1 270,-4 3 0,1 1 44,6-4 1,2-2-180,0-6 0,1-3 0,2 13-270,10-24 270,2-3 180,29-7-270,-9 0-360,21 0-1439,0-7-1169,-6 5 2878,6-6 0,-39-8 0,-8-4 0</inkml:trace>
-  <inkml:trace contextRef="#ctx0" brushRef="#br1" timeOffset="308854">3157 12065 8342,'-25'-18'3276,"13"1"-2954,-4 7-322,32 2-1079,19 8 404,-5 0 1,3 0 674,8 1 0,-2-2 0,-9-2 0,-3-2 0,22-5 0</inkml:trace>
-  <inkml:trace contextRef="#ctx0" brushRef="#br1" timeOffset="309134">3422 11642 9242,'0'-20'2069,"16"20"-540,11 28-1170,-5-8 1,1 5-240,1 8 0,1 6 0,-5 4-638,-9-3 1,-4 2 0,-2 2 0,-3 1 438,-1-6 0,-2 2 0,-2 1 0,-3-1 0,-2 0 0,-5 0 1,-3 1-1,-3-1 0,-2-1 0,-3-3 0,-4-6 0,-1 0 0,1 0 1,-1 0-1,0 0 0</inkml:trace>
-  <inkml:trace contextRef="#ctx0" brushRef="#br1" timeOffset="311544">7273 11606 6004,'-5'-19'1349,"3"-5"989,-3 7-988,5-3-271,5-5-809,-3 23 179,3 27 1,1 14-540,-5 2-105,0-9 0,1 10 0,0 6 1,0 1-1,0-3 0,0-8 45,0-2 0,1-6 0,-1 4-188,1 14 1,-1 8 0,2-3 0,-1-12 67,4 0-3007,-2-72 3194,0 13 1,-4-13 0,0-2 0,4-5 0</inkml:trace>
-  <inkml:trace contextRef="#ctx0" brushRef="#br1" timeOffset="311918">7310 11518 7533,'-18'-43'3276,"27"-2"-1515,16 23-1267,10 18 1,4 10-735,-6 15 0,-1 11 1,-3 0 89,-2-7 0,-3 0 0,-8 5-480,-11 5 0,-9 7 1,-3-2-1,-2-6 180,-1-4 1,-7-3-1,-12 2 0,-8 0 1,6-9-1260,2-10 1709,11 0 0,48-10 0,-4-5 0,0 0 0</inkml:trace>
-  <inkml:trace contextRef="#ctx0" brushRef="#br1" timeOffset="312285">7938 11465 7533,'-6'-25'1889,"-6"-10"-540,-24 36-989,-3 21-127,22 6 1,0 13 0,1 6 0,2 1 0,1-6-234,0 1 0,1-2 0,4 4-162,3 1 0,-1 6 0,4 2 0,5-5 0,7-11 162,14-9 0,8-8 0,0-2 0,9 9 0,2-7 0,-8-22 0,0 1 0,-1-1 0</inkml:trace>
-  <inkml:trace contextRef="#ctx0" brushRef="#br1" timeOffset="313102">8221 11571 7533,'-6'-18'2968,"-1"1"-2158,1 7-316,7 32 1,3 11-585,-1-2 0,4 5 0,5 7 0,1 0-570,1-9 1,2 0-1,-2-2 165,4 8 1,1 0 494,6-3 0,2 2 0,-12-11 0,-19-12 0,10 15 0</inkml:trace>
-  <inkml:trace contextRef="#ctx0" brushRef="#br1" timeOffset="313337">8146 12030 7533,'-27'-41'1092,"48"9"0,19-4 0,-2 2-617,-11-1 1,3 1-533,3 9 0,9-2 0,3-1 1,-2 5-1,-8 5 0,0 4 0,-3 4 1,1 0-1,0-1 0,-1 1 0</inkml:trace>
-  <inkml:trace contextRef="#ctx0" brushRef="#br1" timeOffset="313519">8676 11748 10321,'0'36'179,"0"1"1,0-1 0,0 8 0,0 0 0,0-4 0,0 0 0,0 0 0</inkml:trace>
-  <inkml:trace contextRef="#ctx0" brushRef="#br1" timeOffset="314200">9045 11624 7533,'-12'-10'539,"-6"-5"-269,5 5-270,0 0 180,8 2 2069,16 8-1170,13 16-989,7 8 0,4 3-1080,-8-6 1,2 1 989,-1-1 0,3 1 0,-3-6 0,13-7 0,5-10 0</inkml:trace>
-  <inkml:trace contextRef="#ctx0" brushRef="#br1" timeOffset="314467">9451 11518 8162,'-18'-19'3276,"-12"3"-2629,10 32 0,-3 15 0,1 0-1007,-1-3 0,0 1 1,2 4-361,-1 8 1,1 6-1,1 2 1,3-3 134,5-8 0,2 0 1,2-2-1,0-1 285,0 0 0,2-1 0,4-3 300,5 3 0,6-13 0,16-37 0,6-4 0</inkml:trace>
-  <inkml:trace contextRef="#ctx0" brushRef="#br1" timeOffset="314743">9513 11906 7533,'-13'-35'3276,"7"55"-1785,-6-3-1491,7 14 0,0 10 0,-2-5 0,-5-12 0,-2-1 0,-4 13 0,-1 1 0</inkml:trace>
-  <inkml:trace contextRef="#ctx0" brushRef="#br1" timeOffset="315417">9857 11571 8342,'-7'-19'3058,"-4"-13"-449,10 20-2159,23-13 179,7 23-1079,4 11 1,-1 7 44,-13 5 0,-7 5 0,-4 19 1,-11 5 554,-12-9 0,-9 1 0,1-2-61,4-6 1,0-2 0,0 0 180,-7 6 0,1 0 0,12-6-270,28 5-630,20-19 90,0-16 1,4-6-1100,5-8 1,-3-2 1198,2 2 0,-15-3 0,-48 15 0</inkml:trace>
-  <inkml:trace contextRef="#ctx0" brushRef="#br1" timeOffset="315634">9832 11818 7533,'-31'-18'3276,"7"9"-1605,28 1-2616,21 13 1,9 5 944,-1-6 0,3-4 0,13-1 0,0-5 0,-13-9 0,0 0 0</inkml:trace>
-  <inkml:trace contextRef="#ctx0" brushRef="#br1" timeOffset="315905">10165 11342 7533,'0'-26'3276,"11"30"-1638,11 24 0,2 11-1586,-3-1 0,-3 6-484,-6-7 0,1 6 0,-1 4 1,-2-1-1,-4-3-388,-4-3 1,-4-1 0,-2-1 0,-1 2 631,-1 4 0,0 3 0,-3-2 0,-4-5 0,-8-1 0,-5-5 0,-2-5 0,-12-4 0,-1 1 0</inkml:trace>
-  <inkml:trace contextRef="#ctx0" brushRef="#br1" timeOffset="316588">7409 12488 7533,'-37'-5'539,"1"1"1,6-3 0,6 6 449,10 16-607,30-8 0,22-5 1,10 0-1,4-1-382,-17 1 0,3-1 0,5 0 0,2 1 0,2-1 0,1 0 0,2-1 0,0 1 0,-1 0 0,0-1 0,-2 0-298,-1 0 0,0 0 0,0-1 0,0 0 0,0 1 0,0-1 0,1-1 0,0 1 1,1 0-1,1 0 0,2-1 240,-6 1 0,1-1 0,2 0 1,1 0-1,0 0 0,2 0 0,-1 0 1,0 0-1,1 0 0,-1 0 0,-1 0 1,-1 0-1,-1 0 0,-1 1 0,-2 0 58,8 0 0,-2 0 0,0 0 0,-1 1 0,-1 0 0,-2 0 0,0 0 0,-1-1 0,-1 1 0,-1 0 202,6-1 1,-1 0 0,-2 0-1,-1 0 1,-1 1 0,-1-1-1,-2 2 453,5 1 0,-1 2 1,-2 0-1,-4-2 0,-4-4-1034,12-13 1,-11-4 108,0-6-1369,-16 3 1,-7 3 1429,-13 11 1,-33 39 0,12-11 0,0-1 0</inkml:trace>
-  <inkml:trace contextRef="#ctx0" brushRef="#br1" timeOffset="317434">7974 13000 7533,'-12'-26'869,"15"50"1,7 24-1,-2-6-869,-7-3 22,5 1 1,4 14-1,0-1 1,-3-14-23,-6-1-405,-14-60 1,4-19 799,20 9 1,13-7 0,4-2 0,-1-1-1,-9 2-440,-12 0 0,-9 0 0,3 2 1,10 5 201,21-1 0,15 3 1,-1 9-1,-17 17-517,-20 46-720,-22-5 1,-10 6 0,0-6 1079,1-10 0,0-3 0,-6 1 0,12-3 0,42-9 0,0-1 0</inkml:trace>
-  <inkml:trace contextRef="#ctx0" brushRef="#br1" timeOffset="317685">8627 12823 7533,'-19'-17'3148,"-27"7"-2339,11 2-584,-1 18 0,0 12-765,16 6 1,4 9-1,1-1 330,0-5 0,2-1 0,2 4-38,4 6 1,3 7 0,4-1 0,6-5-473,10-6 1,6-4-1,-1-1 720,0 14 0,4-8 0,8-17 0,-2-14 0,-7-25 0</inkml:trace>
-  <inkml:trace contextRef="#ctx0" brushRef="#br1" timeOffset="318334">8762 12912 7533,'-19'0'3276,"18"15"-2595,20 13-1940,8-6 0,6 1 1259,2 5 0,1-3 0,-4-13 0,0-3 0,-6-2 0,0 0 0</inkml:trace>
-  <inkml:trace contextRef="#ctx0" brushRef="#br1" timeOffset="318589">9094 12876 7533,'-30'-9'3276,"15"9"-3319,-5 25 0,-2 18 1,4 0-678,3 1 1,2 2 233,3-10 0,-3 4 0,1 3 1,1-3-1,4-5 486,3 14 0,7-9 0,18 3 0,22-67 0</inkml:trace>
-  <inkml:trace contextRef="#ctx0" brushRef="#br1" timeOffset="318754">9192 13229 11221,'-15'23'-45,"1"-1"0,-7-8 45,7 29 0,5 2 0,2-21 0,2 17 0</inkml:trace>
-  <inkml:trace contextRef="#ctx0" brushRef="#br1" timeOffset="319684">9500 12912 7533,'-12'-18'3276,"16"8"-975,26-13-2212,10 15 1,5 4-450,-7-7 1,0 4 269,8 14 0,-13 10 90,-32 7 0,-12 7-90,-7 5 0,-7 3 0,-2-1 449,1-5 1,-2-2 0,0 1 0,-2 6 0,1 1 0,5-6-270,-6 6-180,30 1 0,30-38-630,2 2 1,3-1-920,-2-6 1,1-1 1537,7 5 1,-10-4 0,-27-13 0,-22 6 0</inkml:trace>
-  <inkml:trace contextRef="#ctx0" brushRef="#br1" timeOffset="319953">9513 13141 7533,'-25'-10'3276,"11"2"0,42 16-3172,14-6-1197,-9-1 1,5-2 0,-2 1 888,0 1 1,-2-4-1,3-7 1,-4-3 0,-4-7-1</inkml:trace>
-  <inkml:trace contextRef="#ctx0" brushRef="#br1" timeOffset="320269">9894 12753 7533,'17'-22'1638,"11"42"0,3 17-38,-9 4 0,-3 8-1780,-3-10 0,2 5 0,-3 1 0,-7 0-203,-9-2 1,-5 0 0,-4 0 0,0-4-128,-1 2 1,0-2-1,-4-3 510,-4 0 0,-3-1 0,1-8 0,-10-2 0,14-7 0</inkml:trace>
-  <inkml:trace contextRef="#ctx0" brushRef="#br1" timeOffset="321034">11261 12418 7533,'-14'-20'3276,"14"5"-1856,22 9 0,8 4-1240,4 0-1020,8 0 1,10 1 0,-7 4-691,-14 4 1,-1 3 1529,5 0 0,4 1 0,-14 4 0,-23 22 0,-17-16 0,1 1 0</inkml:trace>
-  <inkml:trace contextRef="#ctx0" brushRef="#br1" timeOffset="321260">11284 12629 7533,'-8'-7'819,"28"2"0,25 2 0,7 2 0,-8 0-566,-4-1 1,0 2 0,3 0 0,8 0 0,-3 2 0,-12 6 0,-3 19 0</inkml:trace>
-  <inkml:trace contextRef="#ctx0" brushRef="#br1" timeOffset="322368">13278 11730 7533,'-3'-31'1619,"1"1"0,0-9-1349,2 13 314,0 58 1,2 25-923,0-18 1,1 4 0,0 2 0,0 0-226,-2-1 1,0 1 0,1 0 0,0-3-235,4 11 1,0-1 0,0-11 796,3-4 0,-3-55 0,-1-13 0,-5 2 0,0 1 0</inkml:trace>
-  <inkml:trace contextRef="#ctx0" brushRef="#br1" timeOffset="322676">13340 11571 7533,'0'-39'1638,"33"26"0,5 10 1638,-9 15-2942,0-3 1,6 1-1,-3 4-244,-3 13 0,-4 5-1214,0 0 0,-8 3-515,-17 9 1,-8 0 1407,-4 3-699,-16-28 1,-12-3-1,7-4 930,-2 0 0,5 3 0,3 3 0,9 10 0</inkml:trace>
-  <inkml:trace contextRef="#ctx0" brushRef="#br1" timeOffset="323534">13992 11606 7533,'0'-25'1169,"0"-3"-629,-5 9-270,-19 19 329,-1 26 1,-5 18 0,4 0-481,7-15 1,3-1 0,0 5-120,0 2 0,-2 6 0,1 2 0,5-1 0,7-3-330,11 6 0,10-2 1,1-2-331,-2-5 1,1-1-1,4-4 660,5-3 0,3-4 0,-2-11 0,18-29 0,-15-14 0</inkml:trace>
-  <inkml:trace contextRef="#ctx0" brushRef="#br1" timeOffset="323904">14115 11730 7533,'-12'-20'3276,"10"12"-1766,13 26 0,7 13-1990,-3-3 0,3 3 1,1 1-614,9 4 1,2 2 0,-2-1 904,-8-3 1,-2 0 0,-1-4 0,4-1 0,-8-7 0,-21-6 0</inkml:trace>
-  <inkml:trace contextRef="#ctx0" brushRef="#br1" timeOffset="324268">14066 12188 7533,'-25'-25'1638,"25"2"0,8-5-546,11-4 0,9-3 0,2-2-707,1 2 1,3-2 0,1 0 0,0 1-1206,-3 4 1,1 0 0,-1 1 0,-1 3 645,5-5 1,0 3 0,-10 8-1,-9 9 1,-24 30 0</inkml:trace>
-  <inkml:trace contextRef="#ctx0" brushRef="#br1" timeOffset="324557">14693 11942 7533,'-30'-4'3276,"16"-8"-2621,-1 29 1,2 13-2185,5 0 0,2 3 314,-2 4 1,2 2 1214,3-1 0,6-5 0,22-8 0,14-27 0</inkml:trace>
-  <inkml:trace contextRef="#ctx0" brushRef="#br1" timeOffset="325734">14940 11712 7623,'-14'-10'1979,"3"-5"1079,11-3-1799,11-1-495,11 4 1,8 4-585,15 11 0,5 6-420,-17-4 0,1 1 0,-2 4 240,17 10 0,-18 9-810,-41 1 1,-18 4 0,0 3 869,3 4 0,-1 3 0,-2-1 682,-2-3 0,-4 0 0,1 0 0,7-3-443,4-1 1,4-1 0,11-4 285,14 0 0,11-9-945,18-30 0,7-12-1279,0 12 1,0-1 545,-12-2 1,1-2 0,-3 5 481,14 9 1,-43 19 0,-27 21 0</inkml:trace>
-  <inkml:trace contextRef="#ctx0" brushRef="#br1" timeOffset="326201">14952 11977 7173,'-33'0'3276,"10"0"-885,23-16-682,12 4-180,35-5-1349,-21 9-855,12 7 0,7 2-964,-1-1 1,0 0 1091,-5 0 1,0 0 0,6 0 0,-4 0 0,-11 0 0</inkml:trace>
-  <inkml:trace contextRef="#ctx0" brushRef="#br1" timeOffset="326701">15407 11589 7533,'0'-26'2878,"0"7"-1709,11 1-225,15 13 1,6 10-405,-1 15 0,0 9-331,0-1 1,0 5 0,-6 4-435,-13-1 0,-6 5 1,-4 1-1,-1 0-180,-1 1 0,-4 2 0,-1-2 1,-2-2 404,-2 2 0,-3-4 0,-2-1-1050,-6-2 1,-3-2 0,4-8-1020,2-5 2069,-12 13 0,24-25 0,5-1 0</inkml:trace>
-  <inkml:trace contextRef="#ctx0" brushRef="#br1" timeOffset="327656">13094 12541 7533,'-36'0'0,"20"0"1259,27-15-697,15 9 0,15 6 0,10 1 1,3 0-490,-17-2 1,6 0-1,3 0 1,3 0 0,2 0-1,1 0 1,0 0-1,0 0 1,-3 1 0,-1 0-1,-5 0-264,6 0 0,-4 1 1,-3 1-1,1-1 1,0 1-1,4 0 0,4 0 299,-11-1 0,4 0 0,4 0 0,2 0 0,2 0 0,1 0 0,1 1 0,0-1 0,-2 1 0,-1-1 0,-3 1 0,-3 0 0,-3 1 0,-6 0 0,-5 0 184,19 6 0,-12 0 0,5 1-23,0-4 1,7-1 0,3 0 0,-2 1 0,-6 0 0,-12 1 359,13 12-1168,-6-19-2738,-15-11 2904,-11-7 0,-20 26 1,-14 11-1</inkml:trace>
-  <inkml:trace contextRef="#ctx0" brushRef="#br1" timeOffset="329027">13512 12859 7533,'-7'-20'1889,"2"4"-180,0 16-810,3 8-330,3 22 1,1 15 0,0 0-750,2-5 0,1 0 0,0 3 54,-1-3 0,1 4 0,0 1 1,0-2-1,0-5-84,2 1 0,-1-5 0,1-3-1409,2 4 0,0-15-1079,3-55 2698,-5 11 0,-6-10 0,-2-3 0,-6-12 0</inkml:trace>
-  <inkml:trace contextRef="#ctx0" brushRef="#br1" timeOffset="329388">13549 12859 7533,'3'-34'819,"0"1"0,1 0 0,2-6 0,8 15 273,18 32 0,8 20 0,-13 7-2137,-33 8 0,-16 7 1,9 0 924,27-5 0,10-1 0,-17-2-285,-33-4 0,-18 0 1,2-6-1,25-15 405,56-22 0,-35 10 0,29-7 0,1-1 0,0 1 0</inkml:trace>
-  <inkml:trace contextRef="#ctx0" brushRef="#br1" timeOffset="329870">14140 12788 7533,'0'-33'3276,"-11"11"-1965,-25 20-1071,11 19 0,-3 10 0,2 6 142,4 0 0,2 5 0,2 2 1,3 2-181,1 2 0,3 3 1,3 0-1,6-1-1022,6-2 1,6 1 0,3-3 0,1-5 644,4-3 1,1-4 0,3-5 0,12 0-1,-5-11 1,-18-14 0</inkml:trace>
-  <inkml:trace contextRef="#ctx0" brushRef="#br1" timeOffset="331155">13586 12876 6993,'-19'-25'180,"6"5"180,8-5 89,5 7 631,-6 8 629,-6 3-90,-1-1-360,0 6-269,30-6-1,13 8 1,5 8-721,8 9 1,0 7-270,-10-8 0,-1 2 0,-8 5-300,-9 9 0,-8 5 1,-8-2-646,-19 5 1,-12-4 1004,3-8 0,-4-1 0,-2-6 329,-1-7 1,0-6 0,3-2-1290,3 0 1,7-4-2378,9-12 3118,39 0 1,1 9-1,2 2 1,1 4 0,-1 0-1</inkml:trace>
-  <inkml:trace contextRef="#ctx0" brushRef="#br1" timeOffset="332578">14251 13000 6723,'-11'-28'2429,"8"11"-360,-8 1-1620,11 14 2070,22-14-1755,12 13 1,8 5-645,-1-1 0,3 2 0,-1 0-90,-7 0 0,-1-1 0,-3 5-480,11 9 0,-17 9 112,-34 1 1,-17 6 0,-7 2 0,4-2 696,2 1 1,0-1 0,-2 1-68,-1-1 1,-3 3-1,4-1 1,11-6 1146,17 13-1469,29-34 0,17-11 0,-4-1 75,-7 1 0,2-2-518,2-1 1,8-3 0,-3 0 0,-13 6-1237,-13 6-1568,24-16 1337,-49 24 1940,-4-2 0,-12-16 0,-9-2 0</inkml:trace>
-  <inkml:trace contextRef="#ctx0" brushRef="#br1" timeOffset="333323">14336 13194 6813,'-31'-8'1169,"12"6"990,3-14-630,15 14 360,6-5-90,41 14-1799,-4-5 0,4-2-270,-8 3 0,1 1 1,-1-3-496,10-5 1,-6 0 314,5 10-1799,-50-4-1028,-11 8 3174,3-2 0,17-16 1,0-2-1</inkml:trace>
-  <inkml:trace contextRef="#ctx0" brushRef="#br1" timeOffset="333887">14915 12823 8252,'0'-19'3276,"11"3"-1638,6 29 0,2 13-1064,-1-1 1,1 5 0,-4 4-890,-7 5 0,-3 7 0,-4 0 0,-2-1-135,-1 5 1,-4-1-1,-3-1-225,-2-10 1,-2 0-1,-3-2 1,1-5 674,-12 2 0,6-7 0,15-7 0,20-3 0</inkml:trace>
-  <inkml:trace contextRef="#ctx0" brushRef="#br1" timeOffset="336421">8011 12947 7443,'-14'0'1169,"-2"-8"-539,9-2 89,1-15 720,-5 5-629,-1 10-720,3 28 225,3 9 0,1 7-46,4 8 1,2 6-68,0-8 1,0 6-1,1-1 1,0-6-113,1 4 0,1-3 224,-2 18 1,3-22-584,0-48-991,-5-13 451,0 7 359,0 8 360,-5 2 630,-2-7-360,0 3-90,-2-17 0,1-7-135,6 4 0,1-2 164,-1-5 1,-1-4 0,3 3 15,4-4 0,4 2 135,2-3 0,5 6-135,2 14 0,3 6 404,12 0-359,15 3 90,-9 40-180,-17-8 0,-3 5-180,0 12 0,-6 5-405,-15-2 1,-4 0 449,7-8 0,-5-1 629,-25 14 1,-7-10-495,-2-21-90,14 11 0,1-5-90,-9-31 0,25 5-1619,-9 0 90,10 2-1658,12 8 3196,4 0 1,19 0 0,-2 0 0</inkml:trace>
-  <inkml:trace contextRef="#ctx0" brushRef="#br1" timeOffset="377041">794 14323 7173,'-18'-18'899,"0"8"271,9 3-721,1 22 271,8 28-405,0-2 0,0 6-255,0-7 0,0 3 0,0 0-267,0 2 0,0 0 0,0 0-33,0-3 0,0 0 0,0-2-300,0 10 1,0-4 359,0-17 0,0-3-360,0 15-629,8-32 1169,1-1 0,9-39 0,0-8 0</inkml:trace>
-  <inkml:trace contextRef="#ctx0" brushRef="#br1" timeOffset="377417">670 14305 7533,'-10'-37'2518,"3"4"-1978,22 23 359,28 18-809,-16 0 0,3 3 0,3 2 0,3 2 0,-3 0-90,-1 2 0,-3 4-45,7 11 0,-13 2-270,-30-9 1,-10-1-226,-7 12 0,-9-3 330,3-18 0,-4-4 1,0 0-466,-12 11 0,2-3 450,11-13 1,4 0-1306,-5 25 1530,50-19 0,21 21 0,-6-19 0,1 0 0</inkml:trace>
-  <inkml:trace contextRef="#ctx0" brushRef="#br1" timeOffset="378017">1023 14905 9691,'0'27'3276,"0"-9"-3583,0-65-503,0 10 270,-1-9 1,2 0-1530,15-1 720,-5 11 449,38 36 451,-17 20 359,-3-10 0,1-1 899,7 7 900,-2-16 540,-9-16-630,-32 13-989,-6-21-271,-15 30-1708,-7 12 540,22 27 359,13-10 0,6 0 495,13-5 0,5-3 180,-1-1 0,1-9 134,7-19 1,-5-12-180,-7-25-990,-11 5 1,-3-2-675,-5 3 0,-2 3 495,1-7 989,0 5 0,24 38 0,5-4 0</inkml:trace>
-  <inkml:trace contextRef="#ctx0" brushRef="#br1" timeOffset="378467">1570 14340 7533,'-9'-40'1019,"0"0"0,5 11 1,-2 3-121,-9-7-629,13 41-315,4 14 0,4 7 0,3 13 0,1 6-225,-1-8 0,0 2 1,1 1-58,1 2 1,1 0-1,-2-1 237,-3-9 0,-1-2 0,1-2 585,3 8 0,-3-9 404,-7-20-899,-25-30-270,-5-9 585,9 11 0,-1 3 584,-13 5-279,8 18-395,19 14 0,6 7-1170,4-1 1,6 2-149,5 2 1,5 2 0,1-6 751,1-5 1,2-4 340,2 4 0,3-7 0,4-20 0,2-8 0,1 2 0,-1 1 0</inkml:trace>
-  <inkml:trace contextRef="#ctx0" brushRef="#br1" timeOffset="380334">2152 14887 9691,'-10'0'1350,"-6"0"-631,15 8-629,-7-6-809,8 6-181,8-32 450,9-13 675,4 6 0,1-1-135,-7 4 0,2 2 135,7 2 0,1 4 135,2 3 539,8 9-809,-15 8 90,-4 8-270,-16 9-360,-8 3-449,-2 13 359,0-5 450,2-9-90,8 13 540,0-21-270,0 15 90,0-16 180,16-2 89,-12-8 181,19 0-540,-21 0 270,6 0-90,-8 0-810,0 0 450,0 7 180,0-5-270,0 6-90,0-8-359,8 0 179,-6 8 450,14-6 0,-14 6 90,13-8-90,-5 0 180,23 0-90,-3-16 179,5-3-89,-17-1 180,-3-11 0,-13 19-180,6-14-450,-8 17-540,-8 1 361,6 8 359,-5 0 0,7 8 90,0-6-180,0 13-180,7-5 180,-5 0 90,14-2 270,2-40 90,-5 3 0,1-4-225,0 0 0,0-3 15,-5 2 0,0-4 0,-2 2 75,-1-6 0,-2 2 44,0 1 1,0 3 360,-4-7-1889,0 61 1259,0 14 0,0 6 90,0 3 0,0 3-166,-1-8 1,1 3 0,1-3 30,1 10 0,4-1 225,3 4 0,7-2 0,11-8 0,7-6-90,6-10 0,2-9 134,-4-6 1,-1-10 0,7-17 0,-6-13-45,-20-2 0,-5-4 90,10-7 0,-5 0 180,-13 2 0,-8 5 629,-6 1 856,-27 63-2340,24 1 1,3 4-406,-3 5 1,8 1-540,19 5 0,11-2 1439,4-10 0,5-3 0,-7-6 0,3 1 0,0-2 0,1-3 0,0 0 0,0 0 0</inkml:trace>
-  <inkml:trace contextRef="#ctx0" brushRef="#br1" timeOffset="384390">6657 14252 8072,'-6'-10'360,"1"3"0,5 7 989,0 0-809,5 7-270,-4 11-360,4-6 450,-5 27 89,6-17-89,-5 21 0,2-12 0,-1 4-360,-1 9 0,-2 2 149,1-6 1,0 3 0,0 0-180,0 4 0,0 2 1,0-4 73,0 4 1,0-4-45,1-8 0,-2-7 90,-4-15-449,4-22-1260,-5-3-720,1-16 2339,4-1 0,1-16 0,6-2 0</inkml:trace>
-  <inkml:trace contextRef="#ctx0" brushRef="#br1" timeOffset="385064">6633 14270 7533,'-19'-26'1709,"7"7"-360,6-7-450,17-7-269,13 19 270,15-9-361,-7 30 1,1 9-225,-2 4 0,-3 5-270,6 9 0,-6 5-195,-15-6 0,-5 3 0,-3-1-75,-2 7 0,-7 0-270,-9 3 1,-6-4 269,-4-12 0,-3-5 135,-4-4 0,-2-5 45,6-4 0,0-4-405,-16 1-719,19-16-2108,33 6 3133,-1-6 1,14 7-1,6 2 1,-3-1 0,0 0-1</inkml:trace>
-  <inkml:trace contextRef="#ctx0" brushRef="#br1" timeOffset="385734">7273 14217 7533,'0'-20'2608,"0"5"-1708,0 7-361,0 6 451,-5-6-630,-2 8-450,-11 0-630,-1 8 450,-6 10-269,-11 9 449,17-3 0,0 3 90,-3 3 0,1 3 209,3-1 1,2 3 0,2 1 150,3 3 0,2 0 0,1 1-181,-1 1 1,1 1 0,2 1 150,5 5 0,3 2 0,3-3-777,3 2 0,3-2 402,-3-1 0,4-6-810,7-20 1,2-7-1305,0-5-180,21-16 2339,-22 6 0,-2-6 0,-12 8 0</inkml:trace>
-  <inkml:trace contextRef="#ctx0" brushRef="#br1" timeOffset="386947">7346 14429 8522,'-13'-18'3276,"7"8"-1638,23 29 0,12 17-1064,-2-3 1,3 5-1,0 1-1394,-6-8 1,0 1 0,0-1 0,-1 0 630,4 6 1,-1-1 0,-6-5-1,1 8 1,-40-39 0</inkml:trace>
-  <inkml:trace contextRef="#ctx0" brushRef="#br1" timeOffset="387371">7371 14975 7533,'19'-39'204,"0"0"1,0 0 0,0 0 0,1-3-1,0 1 1,2 0 0,3 2 0,1 8 0,3 2-1,1 0 1,0 2 0,-3 0 0,7-7 0,0 0-1,-1 0 1</inkml:trace>
-  <inkml:trace contextRef="#ctx0" brushRef="#br1" timeOffset="389614">8048 14288 7353,'-14'0'3276,"3"0"0,11 0-3262,11 0 616,-8 31-473,0 1 0,0 10 1,0 4-1,-1-2-180,0 1 1,-1 0 0,0 0-1,1 1 59,-1-6 0,0 3 0,1-1 0,-1-2 0,1-5-126,0 23 0,3-26-3187,6-54 3219,-10-17 0,-1 21 1,-7 30-1</inkml:trace>
-  <inkml:trace contextRef="#ctx0" brushRef="#br1" timeOffset="390619">8331 14411 7353,'-13'0'3276,"-4"0"-1875,16 0 38,12 16-89,31 3-1261,-8 6 1,2 1-1034,-1-6 0,1-1-695,4 7 1,-3-1 1265,2 3 0,-3-26 1,-19-14-1</inkml:trace>
-  <inkml:trace contextRef="#ctx0" brushRef="#br1" timeOffset="391120">8774 14358 7533,'-12'-18'3276,"6"9"-975,0 1-2032,6 16 901,0 1-721,-5 25-584,-10 7 1,-5 10 44,6-9 0,0 5 0,-1 2 0,1-3 90,1-9 0,0-1 0,1 0 0,0 0 45,-1 6 0,0 2 0,2-3 0,3-11-1035,3-5-1888,-1-27-399,5-7 3129,-5 1 0,12 8 1,1 0-1</inkml:trace>
-  <inkml:trace contextRef="#ctx0" brushRef="#br1" timeOffset="391968">9008 14781 7982,'-12'-17'3276,"-6"54"-4483,4-25 1207,4 16 0,0 11 0,1-10 0,0-17 0,-8 25 0</inkml:trace>
-  <inkml:trace contextRef="#ctx0" brushRef="#br1" timeOffset="392771">9168 14446 7892,'-25'-17'2519,"12"7"-450,13-14-1709,8 20 629,32-11-420,-9 10 1,5 3 0,2 1-630,5 2 0,2 1 0,-1 1-90,1-3 0,-1 0 0,-8 10-30,-8 15 1,-15 8 119,-24-2 0,-16 2 0,0 1 105,4-1 0,-1 1 0,0 1 0,1-1 45,-4 6 0,0 1 0,8-3 539,3 5 1,15-7 719,23-20 0,9-9-1484,9-13 0,4-6-958,-6 6 1,3-1 0,-3 1-547,4-4 1,-4 2 982,-2 2 1,-15 4-1,-37 10 1,-18 2 0</inkml:trace>
-  <inkml:trace contextRef="#ctx0" brushRef="#br1" timeOffset="393171">9279 14658 7533,'-41'-10'3276,"57"2"-1638,25 6 0,12 4-2731,-12 0 1,1 2 0,0-2 971,-2-2 0,-1 0 0,-6 2 0,-4 5 0,-10 2 0,-16 1 0</inkml:trace>
-  <inkml:trace contextRef="#ctx0" brushRef="#br1" timeOffset="393779">9882 14199 7533,'3'-31'1638,"-1"0"0,0-7 1472,25 23-1941,0 45 1,1 20-923,-11-20 0,-1 3 1,-1 3-1,-2 2-337,-2 7 0,-1 4 0,-3 2 0,-3 1 0,-1-2-252,-3-4 0,-3 0 1,-1-1-1,-3-1 0,-2-1-131,-5 6 1,-3 0 0,-3-3 0,1-6-621,-1-7 1,0-4 0,0-7 562,-19 2 0,44-32 0,9-2 1</inkml:trace>
-  <inkml:trace contextRef="#ctx0" brushRef="#br1" timeOffset="395204">10411 14411 7533,'-7'-10'3276,"2"2"-1856,3 34 0,4 19-1150,-2-2 0,0 6 0,0 2-450,0-9 0,0 2 0,0 0 0,0-2-510,-1 9 1,0-2-1,3-13-2587,3-15 3033,-4-56 0,7 2 0,1-1 0,5-1 0</inkml:trace>
-  <inkml:trace contextRef="#ctx0" brushRef="#br1" timeOffset="395684">10386 14305 7533,'-4'-32'1092,"0"-1"0,45 14 0,13 19 0,-24 14 0,-1 11 0,-8 4-1148,-9 9 1,-9 4 0,-5 0-305,-4-5 0,-4 0 1,-6-5 359,-10-5 0,-7-4 0,7-9 0,7-10 0,52-11 0,1-1 0</inkml:trace>
-  <inkml:trace contextRef="#ctx0" brushRef="#br1" timeOffset="396405">11014 14217 9062,'-14'-20'2249,"-7"13"-2205,6 22 1,-1 11 525,-6 2 0,-4 5 0,2 2-151,1 0 1,2 2 0,2 4-115,5-5 1,-1 4 0,2 1 0,4-1 0,5-3-906,10 8 0,8-3 1,1-1-494,-5-1 1,-1 0 0,7-7 973,16-1 1,0-16 0,-14-24 0,-13-2 0</inkml:trace>
-  <inkml:trace contextRef="#ctx0" brushRef="#br1" timeOffset="397375">11100 14499 7533,'-12'-17'3276,"5"7"0,40 18-4394,0 12 1,3 3 442,-7-10 1,1-1 674,16 15 0,-8-15 0,-27-51 0,0 15 0,0-1 0</inkml:trace>
-  <inkml:trace contextRef="#ctx0" brushRef="#br1" timeOffset="397738">11420 14393 7533,'3'-28'1638,"1"-1"0,-10 12 0,-7 40 0,-4 22-1438,5-11 1,-1 5 0,-1 3 0,0 1-1,0-3-223,-2 5 1,-2-2 0,2-1-1,-1 1-45,2 1 1,-1 3 0,2-5 0,3-10-2812,0-3-359,26-60 3238,-1 7 0,3 4 0,7 11 0,0 11 0</inkml:trace>
-  <inkml:trace contextRef="#ctx0" brushRef="#br1" timeOffset="398078">11568 14746 7533,'5'-27'3276,"2"33"-2576,-9 16 1,-6 8-2340,-3 8 1,-3 1 1465,-6 0 1,0-6 0,-6-7 0,16-38 0</inkml:trace>
-  <inkml:trace contextRef="#ctx0" brushRef="#br1" timeOffset="399555">11790 14411 8342,'-25'-8'3276,"11"-2"-1638,47 3 0,21 5-776,-7 5 0,2 1-1042,-2-3 0,2-2 0,-7 5-135,-7 6 0,-15 4-1034,-36 11 989,-16 9 0,-5 1 405,13-14 0,0 3 202,4 5 1,-1 8-1,1 0 1,3-5 381,2-2 1,4-1 359,-2 17 1,13-6-1,25-27 1,12-10-1920,-2-6 1,5-5-1,-1-1-163,-3 0 1,0-1 0,-2 2 470,10-1 0,-18 8 0,-32 11 1,-33 17-1</inkml:trace>
-  <inkml:trace contextRef="#ctx0" brushRef="#br1" timeOffset="399976">11863 14623 7533,'34'0'371,"0"0"0,-1 0 0,8 7 0,3-4 0,9-2 0,-14 5 0,-21 12 0</inkml:trace>
-  <inkml:trace contextRef="#ctx0" brushRef="#br1" timeOffset="400474">12269 14288 7533,'25'32'468,"-1"0"0,1 1 0,0-1 0,-24 9 0,-10 3 0,-3 2 0,7 1-980,11-2 1,7 1 0,2 1 0,-4-1-1,-8-2 512,-11 4 0,-8 0 0,-2-4 0,1-10 0,-10 7 0,41-33 0</inkml:trace>
-  <inkml:trace contextRef="#ctx0" brushRef="#br1" timeOffset="403033">6486 15505 7533,'-7'-18'2428,"-4"0"-790,33 8 0,9 3-146,-6-3-1492,7 4 0,15 1 0,7 0 0,-2 1 0,-9 0-90,1 2 0,3 0-320,-12 2 0,8-1 1,6 1-1,2 0 1,0 0-1,-3 0 0,-6 1 1,-8-1-423,7 2 0,0 0 742,-7 0 0,10 1 0,7 0 1,4 0-1,1 0 0,-1 0 1,-4 0-1,-5-1 0,-10 0 120,0-1 0,-8-1 0,9 1 15,-4-1 1,8 1 0,6-1 0,5 0 0,3 1 0,2-1 0,1 0 0,-2 0 0,-2 0-1,-5-1 1,-5 1 0,-7-1-1,5-1 0,-9 0 0,0-1 0,10 0-72,-9 0 1,4 0 0,4 0 0,4-1 0,3 0-1,2-1 1,2 1 0,0-1 0,0 1 0,0-1-1,-2 0 1,-2 1 0,-3 0 0,-3 0 48,10-1 1,-4 1-1,-2-1 1,-2 1-1,1 0 1,0-1-1,4 1 1,2 0-88,-10 1 1,3-1 0,0 0 0,3 1-1,0-1 1,1 0 0,1 1 0,-1-1-1,1 1 1,-1 0 0,0 0 0,-1 1-1,-1 0 1,-2 1 113,3 0 0,1 1 0,-1 0 0,0 0 0,-1 1 0,-1 0 0,-1 1 1,0-1-1,-1 1 0,-1 0 0,-2 0 186,10 0 1,-2 1-1,-2 1 1,0-1-1,-2 0 1,1 1 0,1-2-95,2 0 0,3 0 1,0-1-1,-1 1 0,-3-1 1,-6 0-1,-7 0-231,3 2 0,0-2 120,-1-3 0,10-2 0,4-1 0,0 0 0,-6 0 0,-9 2-30,-5 2 0,-2 0-158,10 1 1,8 0 0,0 0-1,-12 0 158,1 2 405,13 10 0,-4 0-405,-30-8 2196,28 11-2196,-41-15 2385,3-7-1666,-5 5-393,0-6-1495,0 8 1169,0-16 0,-27 20 0,-7-10 0</inkml:trace>
-  <inkml:trace contextRef="#ctx0" brushRef="#br1" timeOffset="404195">8221 15804 10591,'0'45'409,"0"0"1,0 0-1,0-1 1,0 1-1,0-2 1,-1-1 0,1-2-1,1 0-812,2 7 1,1 0 0,-1-10-2117,0 0 540,13-72 1979,-14-2 0,3-7 0,-5 9 0</inkml:trace>
-  <inkml:trace contextRef="#ctx0" brushRef="#br1" timeOffset="405134">8245 15822 7803,'-25'-25'3276,"18"-11"-1638,27 23 0,10 5-1047,14 3 1,3 10-652,-9 8 0,-2 8 0,-10 6-390,-15 3 1,-11 6-1,-6-3 315,-15 10 0,-14-7-495,1-12 1,-7-5-1,3-5 315,-2-7 1,13-8 314,27-7 0,40 0 0,-6 3 0,0 0 0</inkml:trace>
-  <inkml:trace contextRef="#ctx0" brushRef="#br1" timeOffset="406106">8959 15752 8252,'-13'-18'2789,"1"0"-2789,-16 8-45,1 21 0,-1 10 494,2 4 1,1 8 0,5 5 17,10-2 1,4 7 0,3 2 0,1-1 0,2-2-588,1 9 0,3-3 0,5 0-700,3-6 1,4 2 0,2-4 0,2-12 772,5-10 1,-1-12 0,3-22 0,-20-3 0</inkml:trace>
-  <inkml:trace contextRef="#ctx0" brushRef="#br1" timeOffset="407035">9144 15840 7982,'-14'-20'3276,"14"12"-1638,21 32 0,10 17-2890,-4-10 0,2 1 159,-1-7 1,2 0 0,-3-3 840,-3 4 1,-3-13-1,-2-27 1,-4-11 0,-9 1-1,1-1 1</inkml:trace>
-  <inkml:trace contextRef="#ctx0" brushRef="#br1" timeOffset="407461">9513 15804 7533,'-6'-35'3276,"-1"47"-2599,-8 18 0,-5 13 0,-1 2-737,5-5 0,-1 1 0,-1 3 262,-1 1 0,-4 3 1,1-1-1,2-7-1012,-4 4 1,3-7-830,2-12 1,9-9 1557,16-16 1,12-10 0,14-8 0</inkml:trace>
-  <inkml:trace contextRef="#ctx0" brushRef="#br1" timeOffset="407835">9623 16122 13379,'1'27'-1093,"0"1"1,-22 13 0,-3 2 436,15-6 1,0-1-1,-40 34 1,49-70 0</inkml:trace>
-  <inkml:trace contextRef="#ctx0" brushRef="#br1" timeOffset="409085">9955 15875 7443,'-20'-37'3276,"26"11"-1638,31 19 0,13 6-1047,-4-1 1,0 4-592,2 9 0,-13 10-765,-35 7 1,-14 7 644,-7 3 0,-8 4 0,-2 1 390,6-9 0,-3 1 0,0 0 0,3-2-31,-3 5 1,3 0 0,10-4 749,10 0 1,14-9-495,25-20 0,13-12-1588,-8-1 1,4-2 0,-2 0-1,-7 3 1,0-1 0,-4 4 729,6 2 1,-16 4 0,-28 2 0,-17 11-1</inkml:trace>
-  <inkml:trace contextRef="#ctx0" brushRef="#br1" timeOffset="409724">9919 16104 6903,'-40'0'3276,"22"-8"-1638,43 7 0,19 1-764,-8-2 0,3-1 1,2 0-1968,6-3 1,2-1 0,-3 4 558,-7 7 1,-2 2 0,-8-4 0,0-14 0,-51 28 0</inkml:trace>
-  <inkml:trace contextRef="#ctx0" brushRef="#br1" timeOffset="410427">10546 15610 7173,'-13'-37'3276,"18"43"-2184,10 22 0,6 19 0,-4 3-568,-7-10 1,-1 3-1,-3 2 1,-2 1 0,-4 0-480,-4-4 0,-3 2 0,-3 1 0,-1-1 0,-1-1 0,2-2-865,-2 10 1,2-1 0,-3-4 0,-6-5 446,-92 55 0,111-96 1,35-10-1</inkml:trace>
-  <inkml:trace contextRef="#ctx0" brushRef="#br1" timeOffset="412221">13192 15117 7353,'-25'-8'3276,"6"-2"0,7-8 0,39 8-2524,16 2 1,10 1-1846,-10 3 1,2 0 0,-1 2 623,-5 1 1,-1 0 0,-4 1 0,2-1 0,-15 4 0,-44 15 0</inkml:trace>
-  <inkml:trace contextRef="#ctx0" brushRef="#br1" timeOffset="412685">13168 15275 7803,'-27'-8'3276,"48"6"-1638,12 6 0,9 0-1334,3-4 1,5-2-1,-1 0-304,-5 1 0,0 0 0,-6 1 0,2 2 0,-17 0 0,-32 2 0</inkml:trace>
-  <inkml:trace contextRef="#ctx0" brushRef="#br1" timeOffset="414226">15051 14411 6903,'-13'-10'2339,"1"-21"-181,5 9-1888,1-5 2339,6 58-2250,2 9 1,-1 12 0,2 1-585,0-8 0,0 1 0,0 0 1,0-1-496,0-3 0,0 0 1,0-2-1,2-5 720,6 16 0,2-23 0,0-58 0,-4 4 0,-1-1 0</inkml:trace>
-  <inkml:trace contextRef="#ctx0" brushRef="#br1" timeOffset="414740">15001 14323 7533,'-4'-38'1092,"0"-1"0,23 10 0,12 7 0,7 14 0,7 9 0,-3 10 0,-5 14 0,-3 11 0,-8 3-2000,-8 2 1,-7 3 0,-10-1 367,-12-2 0,-10-1 1,-5-8-1100,-13-2 1,1-13 1254,8-17 1,55-6 0,19-3-1,-1-1 1,-1 0 0</inkml:trace>
-  <inkml:trace contextRef="#ctx0" brushRef="#br1" timeOffset="416139">15567 14340 8432,'7'-27'3276,"-1"-6"-1605,-12 21-861,-6-4-180,-2 32-181,-4-12 91,6 19-90,-1-21-630,7 6 0,-5 0 180,4-6 135,-13 32 0,1 18 164,10-7 1,5 4 0,3 2 104,1-5 1,1 2 0,3 1 0,1-4-653,2-5 1,2-1 0,1-3 0,3-6-1392,11 5 1,2-15 818,2-26 1,-28-25 0,0 21 0</inkml:trace>
-  <inkml:trace contextRef="#ctx0" brushRef="#br1" timeOffset="416888">15751 14499 7623,'-6'-43'2248,"1"21"1028,10-17-345,-4 35-2661,4-11 1798,12 38-1393,9 12 0,7 7-1335,-8-9 0,2 2 1,0 1 359,3 1 0,1 1 0,-3-4-690,1 4 1,-3-7-2288,1-8 3219,-20-38 0,-5 11 1,-4-12-1</inkml:trace>
-  <inkml:trace contextRef="#ctx0" brushRef="#br1" timeOffset="417477">15776 14870 7263,'-14'0'3276,"9"0"-1638,18-17 0,8-6 715,-1-2-1994,0-2 1,8-8 0,2-4 0,-3 3-428,-4 4 1,-2 0-1,1 1 1,1 0-473,3-1 0,1 1 1,-1 0-1,-1 2-553,-1-4 1,-2 3 0,-4 12 272,-3 20 1,-26 16 0,4 0 0</inkml:trace>
-  <inkml:trace contextRef="#ctx0" brushRef="#br1" timeOffset="418358">16539 14323 7533,'7'-35'3276,"4"7"-1638,-9 46 0,-3 17-1140,1-3 0,0 7 0,0 1 1,0 0-1219,2-2 0,0 1 1,1-1-1,0 0-330,0 11 1,0 0 0,5-10 1049,3-11 0,4-13 0,15-31 0,-5 16 0</inkml:trace>
-  <inkml:trace contextRef="#ctx0" brushRef="#br1" timeOffset="420053">16897 14429 8432,'-20'-10'3276,"13"-6"0,25 6-2594,15-3 0,11 1-975,-7 10 1,7 4 0,0 0-1,-5 0 338,7-8 0,-6 8-270,7 25 1,-20 11-136,-43-10 0,-21 2 0,1 2 570,3 4 0,-1 2 0,2-1 509,1 0 1,2-1 0,4-3-675,4-4 0,12-5 494,44 0-629,-1-24 0,9-8 0,0 0-1003,-5 3 1,0 1 0,0 1 738,1 1 1,0 2 0,-8 0 0,-5 4 0,-52 22-1</inkml:trace>
-  <inkml:trace contextRef="#ctx0" brushRef="#br1" timeOffset="420824">16970 14676 7713,'-14'0'1889,"-2"0"1259,9-8 128,23 6-2621,22-2 1,11 0-1496,-7 1 1,3 1 0,-1-1-254,-3 0 1,0 0 0,-3-1 668,15 1 0,-15-4 0,-33 0 0,-12 7 0</inkml:trace>
-  <inkml:trace contextRef="#ctx0" brushRef="#br1" timeOffset="421871">17561 14182 7803,'33'-30'3276,"-20"15"-1638,18 29 0,0 21-1114,-20-2 1,-5 12-1,-4 4 1,-3 1-1,1-4-1176,-2-1 0,-1-2 0,-2 0 0,0 2 148,0 3 0,1 5 1,-1-1-1,-3-4 0,-3-9 504,-17 8 0,0-20 0,10-29 0,27-25 0</inkml:trace>
-  <inkml:trace contextRef="#ctx0" brushRef="#br1" timeOffset="422818">18090 14376 7533,'-1'4'3276,"-3"-6"-2457,2 25 0,6 26 0,1 10 0,-1-8-575,-3-11 1,-1-3 0,0 4-740,2 4 0,-1 6 0,2-2 1,2-12-2783,13 4 2612,-9-49 0,7-33 0,-16 23 0</inkml:trace>
-  <inkml:trace contextRef="#ctx0" brushRef="#br1" timeOffset="423309">18041 14323 7533,'-3'-26'1638,"0"1"0,18-14 0,11 20 0,7 10-546,4 21 0,5 13 0,-2 3-621,-1-4 1,-2 2 0,-9 6-1565,-11 10 1,-9 5 0,-11-5 325,-13-11 1,-8-4-1,-3-4-193,-4-5 1,-2-4 0,3-3 959,-3-1 0,15-4 0,46-6 0,0 0 0,0 0 0</inkml:trace>
-  <inkml:trace contextRef="#ctx0" brushRef="#br1" timeOffset="424792">18755 14252 7533,'5'-35'1349,"-3"0"-1079,3 15-270,-5 4 450,-16 32-271,6-4 361,-19 21 179,8 0 1,1 1-360,-4 3 67,10-1 0,0 11 1,2 5-1,7-5-315,7-9 1,6-1-1,0 0 1,-2 0-158,-7 4 0,-3 0 0,2 0 0,6-3-45,15 13 0,8-2 0,-2-22-3187,1-31 2904,17 8 1,-43-29-1,-21 7 1</inkml:trace>
-  <inkml:trace contextRef="#ctx0" brushRef="#br1" timeOffset="425971">18951 14446 7803,'-30'-17'3276,"15"7"-2055,10 2 218,41 0-675,-5 2 1,6 2-465,-2 5 0,3 2 0,0-1-420,-2-4 0,0-2 0,-5 6-330,3 10 0,-14 8-405,-27 7 1,-13 4 1004,-5-1 0,-6 1 0,1 1 389,1 1 1,0 2 0,3-2-45,-5 8 0,10-3 1124,21 11-450,25-37-719,2-3 0,6-3-1440,7-7 1,2-6-316,3-1 1,-2-1-335,-6 4 1,-5-2 1310,-2-9 1,-48 40-1,-22 5 1</inkml:trace>
-  <inkml:trace contextRef="#ctx0" brushRef="#br1" timeOffset="426522">18951 14693 7173,'-19'-17'3276,"2"-25"-1638,41 32 0,16 5-2354,-7-2 0,5 0 0,2 1 0,-2 2 716,2 3 0,-2 2 0,0 1 0,11 2 0,1 1 0,-26 2 0,-33 3 0</inkml:trace>
-  <inkml:trace contextRef="#ctx0" brushRef="#br1" timeOffset="427320">19579 14164 7713,'5'-22'1638,"11"38"0,3 17-819,-7-1 0,0 6 0,-1 3 0,0-1-231,1 0 0,0 0 0,-2 2 1,-3 1-787,-4 1 0,-3 3 0,-2 1 0,-3-2 0,-2-4 78,-7 8 0,-4-4 0,-4-2-420,0-10 1,-2 1-1,-1-3 1,3-2-1100,-6 8 1,2-6 1285,2-10 1,10-10 0,30-28 0,5-13 0</inkml:trace>
-  <inkml:trace contextRef="#ctx0" brushRef="#br1" timeOffset="429406">14669 15452 7533,'-5'-26'1638,"32"18"0,16 4-901,-7-3 0,4-2 0,5 2-423,-8 5 1,4 1 0,2 2 0,3 0 0,1-1-1,2-1-526,-8-2 1,2 0 0,2-1 0,1-1 0,0 0 0,1 0 0,1 0 0,0 0 0,0 1 139,0 0 0,1-1 0,0 1 0,0 0 0,1 0 0,0 0 0,1 0 0,0 0 0,-1 1 0,1 0-18,-3 0 0,1 0 0,-1 1 0,1 0 0,0-1 0,0 1 0,1 1 0,-1-1 1,0 0-1,0 0 0,-1 0 90,0 0 0,0-1 0,1 1 0,-1-1 0,1 0 0,-1 0 0,0 1 0,-1 1 0,0 0 0,-1 1 0,-1 0 179,3 2 1,-2 1 0,0 1 0,-2 1 0,1 0 0,0 0 0,0 1 0,0 0 0,2 0-508,1 0 0,1 0 0,1 1 1,2 0-1,-1 0 0,-1 1 1,-1-1-1,-2 0 0,-2 0 1,-4-1 231,9 2 0,-5-1 0,-2 1 1,0-1-1,5 0 84,-5 0 1,4 1 0,1 0 0,2 0-1,-1 0 1,-1-1 0,-3-2 0,-4-1 458,10-2 0,-5-3 1,-1 0-1,3 1-462,-6 3 0,1 1 0,2 1 0,0-1 0,0 1 0,0-2-120,1-2 0,2 0 0,-1-1 0,0 0 1,-3 1-1,-4 2 674,13 4 1,-5 2 0,-3-2-308,14 1 1,-20-8-3510,-37-6 2781,-26 12 0,-22-14 0,20 8 0,0 0 0</inkml:trace>
-  <inkml:trace contextRef="#ctx0" brushRef="#br1" timeOffset="430568">16528 15804 7533,'-13'-9'2968,"6"9"-2249,0 28 1,3 16-450,3-2 0,1 5 0,0-1-270,0 0 0,-1 0 0,2 0-240,0 2 0,2 0 0,0-9-479,4-4-811,4-37-1747,-10-41 3268,10 4 1,-10 3-1,-1-3 1,2 7 0,1 0-1</inkml:trace>
-  <inkml:trace contextRef="#ctx0" brushRef="#br1" timeOffset="430988">16503 15769 7533,'5'-36'1092,"1"0"0,19 15 0,7 12 0,-3 20 0,3 12 0,-2 2-428,1 2 0,-2 2 1,-8 5-1385,-9 9 1,-9 5-1,-10-7-90,-17-5 1,-11-8-830,-7-7 1,5-10 1609,20-13 1,53-14 0,4 11 0,0 0 0</inkml:trace>
-  <inkml:trace contextRef="#ctx0" brushRef="#br1" timeOffset="431420">17180 15663 7533,'0'-45'3276,"-33"10"0,-3 41-2666,12 13 1,-3 12 0,0 6 0,5-1-409,7 1 0,3 1 1,4 2-1,1 2-652,3-2 0,0 3 1,4 1-1,2-3 0,4-3 450,10 9 0,6-5 0,4-8 0,12-3 0,2-13 0,-12-19 0,0 0 0</inkml:trace>
-  <inkml:trace contextRef="#ctx0" brushRef="#br1" timeOffset="432747">17413 15822 7713,'-13'-10'1889,"-4"-13"-990,16 11 1080,-5-13-450,6 15 450,33 2-1440,-9 7 1,4 2-495,6 2 0,7 3 0,1 0 0,-6 2-495,6 4 1,-7 6-631,-4 13 1,-17 6 1348,-30-3 1,-19 2 0,-2-2 359,8-7 1,-4-1 0,1-1 0,3 1-450,-2 6 0,4 0 0,16-6 449,47 8-1289,-4-31 1,8-6-1,-1-1-433,1 1 1,0-1 0,-2 1 506,8-1 0,-9 2 0,-20 2 1,-31-10-1</inkml:trace>
-  <inkml:trace contextRef="#ctx0" brushRef="#br1" timeOffset="433263">17462 15998 7803,'-39'-9'3276,"59"-7"-2929,18 16 0,13 8 0,-2-2-1277,-14-7 1,-1-2 0,1 3 838,18 4 0,2 3 1,-15-3-1,-21-4 1,-15 0-1</inkml:trace>
-  <inkml:trace contextRef="#ctx0" brushRef="#br1" timeOffset="433737">17980 15681 7533,'5'-41'1638,"14"53"0,2 15-546,-11 3 0,-4 7 0,-2 4-504,0 4 0,-2 4 0,-2 3 1,-5-2-1147,-2-9 0,-3 1 1,-3-1-1,-1-2 0,-1-2-535,-7 9 1,-3-5 0,-1-7 991,-8-2 1,8-17 0,20-23 0,26-1 0</inkml:trace>
-  <inkml:trace contextRef="#ctx0" brushRef="#br1" timeOffset="439264">7605 17515 6004,'7'0'1888,"-2"-7"-1168,-5-3 180,0 0 89,-5-6-449,3 14 539,-3-13-179,-1 5-451,5 0-449,-5 2 90,1 16 0,4 2 450,-10 15-315,9 19 0,3 10-46,-3-10 1,0 3 0,1 1-113,0-4 1,1 2 0,0 1-1,1-1-180,0-1 1,0 1 0,1-2-1,-1-5 23,-1 7 1,1-8 1258,4 2-629,-5-44-1440,-5-12-1888,4 16-181,-4 0 2969,10-16 0,5-7 0,3-5 0,3-9 0,1 0 0</inkml:trace>
-  <inkml:trace contextRef="#ctx0" brushRef="#br1" timeOffset="439851">7531 17533 7533,'-17'-33'3276,"8"-4"-76,20-1-1716,27 30 0,12 14-1005,-9 7 1,2 8 0,-8 6-1140,-12 6 1,-7 5 0,-9 1 359,-8-3 0,-7 0 0,-8-4 90,-16-2 0,-10-4 0,2-6 210,-5-4 0,20-8 0,32-8 0,30 0 0,1 0 0</inkml:trace>
-  <inkml:trace contextRef="#ctx0" brushRef="#br1" timeOffset="441526">8233 17410 6903,'7'-28'3058,"-2"11"-2068,-5 9-630,-5 31 179,-2-9 271,-5 19-810,-1-23-90,7-2 180,-5 0 180,4-6-180,-11 29 359,-12-2-269,14 1 0,4 9 45,7 0 0,4 7 0,2 3 0,2-1 224,1-6 1,3 1 0,2 1 0,0-2-1,0-3-1542,5 11 1,0-3 0,1-1-1,1 5 1,1-1 0,-3-27 437,2-63 0,-3 25 0,6-5 0</inkml:trace>
-  <inkml:trace contextRef="#ctx0" brushRef="#br1" timeOffset="442470">8540 17674 9242,'-12'-10'2968,"-6"-5"-2248,5 5 719,-5 0-135,30 31 0,13 13-884,1-7 0,5 1 0,0 3-600,-8-2 0,-1 2 0,1 0 0,0-2-270,8 0 0,1-2 1,-6-3-2789,1 15-39,-27-39 2720,0 0 0,0 0 0</inkml:trace>
-  <inkml:trace contextRef="#ctx0" brushRef="#br1" timeOffset="443138">8503 18168 10591,'-13'0'2519,"2"-16"-1080,27-11-784,2 1 0,7-10 1,5-4-1,0-1 0,-3 6-575,0 2 1,-1 3-1,1 0 1,1-3-231,-3 1 0,2-4 0,1-1 0,0 1 0,-2 2 0,-3 5-943,6-1 1,-3 4 0,-5 4-2185,4-11 2936,-3 17 1,-8 14 0,4-6 0</inkml:trace>
-  <inkml:trace contextRef="#ctx0" brushRef="#br1" timeOffset="444058">9451 17498 8162,'-14'-37'3276,"9"27"-2081,6 27 1,4 17-949,-1 6 1,-1 10-1,0 4 1,0-4-204,-1-10 1,0-2 0,-1 1 0,1 2 9,-1 3 0,0 4 0,1 0 0,-1-4 0,-1-8-234,0 0 0,0-7-2338,0 0 2518,0-47 0,28-15 0,-11 14 0,0 1 0</inkml:trace>
-  <inkml:trace contextRef="#ctx0" brushRef="#br1" timeOffset="445506">9882 17551 8162,'-7'-10'1080,"1"2"2196,1 0-2954,3 6 1027,15 23 0,13 13-2399,-1-11 1,4 0 0,-1 2 509,2 14 1,1-2 539,19-4 0,-12-19 0,-34-24 0,13-7 0</inkml:trace>
-  <inkml:trace contextRef="#ctx0" brushRef="#br1" timeOffset="445927">10276 17551 7533,'1'-49'3276,"-24"88"0,5-12-2788,7 2 1,-1 12-1,-1 6 1,0 0 0,0-5-714,0-1 0,0-2 0,1-1 0,-1 1-338,-1 2 1,1 2 0,-1-2 0,1-3-531,-4 2 1,0-2 0,10-20 1011,18-32 1,11-21 0,20 9 0</inkml:trace>
-  <inkml:trace contextRef="#ctx0" brushRef="#br1" timeOffset="446417">10386 17974 8522,'15'4'3276,"2"41"-2845,-12-8 0,-6 2-2070,-12 4 1,-7-5 1591,-1-14 1,-2-5 0,-6-3 0,38-16 0</inkml:trace>
-  <inkml:trace contextRef="#ctx0" brushRef="#br1" timeOffset="448158">10743 17692 7533,'-19'-10'-450,"2"2"3328,10 8 398,1-16-1676,30 10 1,7 1-1601,-6-13-60,15 12 0,13 3 0,-7 4 60,-19 3 0,-1 0-495,18 0 0,-6 2 405,-17 4-899,-43 29 719,1-8 315,4-1 0,-5 8 0,-2 3 0,1-3 674,-1 1 1,1-2 0,-1 1-600,-2 4 0,0 1 0,3-3-300,-4 11 0,10-15 719,15-31-449,2 19 1529,46-32-1919,-10 3 0,6 0 1,0-3-794,-2-2 1,0-3 0,-1 1 55,2 4 1,0 2 0,-7-1 1036,10-9 0,-62 18 0,-8 6 0</inkml:trace>
-  <inkml:trace contextRef="#ctx0" brushRef="#br1" timeOffset="448667">10707 17956 8342,'-34'-17'3276,"17"7"-1638,39 8 0,17 4 0,7 3 0,7 0-2458,-12-5 1,5-1 0,1-2 0,-4 1 350,1-2 1,-4 0 0,-2 0 0,12 0 0,-18 4 0,-30 4 0</inkml:trace>
-  <inkml:trace contextRef="#ctx0" brushRef="#br1" timeOffset="449553">11396 17515 7533,'0'-35'1259,"0"8"-180,0 1 810,22 16-251,7 35 0,2 21-1124,-17-13 0,-3 7 0,-1 4 1,-1 2-1,-2-1-724,-1-5 0,0 2 0,-2 0 0,-1 1 0,-1-1 1,-2 0-277,-1 6 0,0 2 0,-3-1 1,-2-3-1,-2-4-504,-8 9 1,-4-5 0,0-14 989,-11-16 0,37-16 0,14 0 0</inkml:trace>
-  <inkml:trace contextRef="#ctx0" brushRef="#br1" timeOffset="450790">12872 17956 7533,'-24'-15'3276,"10"11"0,3-28 0,60 29-1231,-20-13-2585,6 16 0,12 6 1,4 1-1,-5-4-553,-4-10 1,-3-2 0,-1 5 623,3 13 1,0 6 0,-7-6 0,9-11 0,-71 24 0,1-1 0</inkml:trace>
-  <inkml:trace contextRef="#ctx0" brushRef="#br1" timeOffset="451186">12872 18203 7533,'-30'0'3276,"15"0"-1638,48 0 0,22 0-764,-23 0 0,2 0 0,2 0-874,7 1 0,4 0 0,0-1 0,-6-2 0,8-4 0,-8-3 0,-13-1 0,-1 0 0</inkml:trace>
-  <inkml:trace contextRef="#ctx0" brushRef="#br1" timeOffset="452271">14644 17833 7173,'-12'-28'3276,"0"3"-1425,5 39-1192,5 17 1,3 13 0,0 4-413,-1-2 0,0 3 1,0 2-1,1-1-562,0-1 0,1 0 1,0-1-1,-1-2-778,-3 15 1,0-3 0,6-28 991,1-30 1,8-31 0,-4 0 0,1 1 0</inkml:trace>
-  <inkml:trace contextRef="#ctx0" brushRef="#br1" timeOffset="452751">14582 17674 7533,'13'-45'1092,"-1"0"0,26 22 0,11 15-273,-15 12 0,3 7 0,0 6 0,-3 4-164,-2 5 1,-1 5 0,-5 5-1,-7 0-948,-8 2 1,-5 2 0,-5 0 0,-8-3-308,-15 4 1,-10-5-1,-3-5-420,-1-10 1,-3-4 0,3-6 1019,-6-5 0,18-7 0,49-6 0,8 7 0,0 0 0</inkml:trace>
-  <inkml:trace contextRef="#ctx0" brushRef="#br1" timeOffset="453643">15518 17639 7533,'3'-45'2338,"-44"57"-1918,11 7 0,-3 9 0,1 5 83,9-3 1,-1 4 0,2 3-1,4 1 1,6 1-905,7 3 1,7 3-1,4 0 1,0-1-1,-2-2 401,-6-2 0,-2 0 0,3-3 0,10-3-820,19 1 1,13-2 0,2-4 0,-11-7 414,3 6 0,11-24 0,-42-8 0</inkml:trace>
-  <inkml:trace contextRef="#ctx0" brushRef="#br1" timeOffset="454143">15740 17798 7533,'-7'-36'1889,"2"17"629,15 42-1214,1 13 1,3 9-1961,0-13 1,4 6-1,2 1 1,-1-1 0,-3-3 30,0 3 0,-3-2 1,4 0-173,2-1 0,5 3 0,-1-5 0,-6-12-1632,-3-13 2429,-2-8 0,-17 0 0,-9 0 0</inkml:trace>
-  <inkml:trace contextRef="#ctx0" brushRef="#br1" timeOffset="454587">15628 18292 6903,'-25'0'1638,"35"-26"0,17-11-983,-4 13 0,6-2 1,3-1-1,2-1 0,-2 0-257,3-5 1,0-1 0,1-1-1,0 0 1,0 1-1055,1 1 1,1-1-1,-1 1 1,-1 1 0,-4 3 361,4-2 1,-3 2 0,-10 5 0,-6 1-1,-17 23 1</inkml:trace>
-  <inkml:trace contextRef="#ctx0" brushRef="#br1" timeOffset="455406">16528 17727 7533,'5'-41'2608,"1"10"668,6 11-2036,-7 40 1,-3 19-927,1-3 1,-2 8 0,1 3 0,-2 0-477,-1-6 0,-2 1 0,0 0 0,1 0 1,0-1-357,1 5 1,0 0 0,1-3 0,-1-4-743,-5 17 1,6-23 1259,18-45 0,-5-11 0,1-5 0,4 0 0,1 1 0</inkml:trace>
-  <inkml:trace contextRef="#ctx0" brushRef="#br1" timeOffset="456501">17057 17833 6993,'-14'-20'2698,"-3"-11"-719,16 19 0,12-21-809,26 21-631,8 6 1,6 4-360,-15 6 0,2 3 0,-2 0-360,0-1 0,-1 0 0,-3 2 45,5 2 0,-15 5-180,-33 4 0,-13 3-15,-2 2 1,-4 3-1,-2 1 487,3-4 1,-2 1-1,-1 1 1,2 0 201,-1 1 1,0 0 0,2 0 0,2 0-240,1 3 0,3-1 0,4-2 104,1 2 1,12-5 1215,47 4-1306,-13-18 1,5-4-315,7-8 0,5-5 1,-1 0-751,-4 3 1,0 0-1,-2 0-163,0-2 1,-1 0 0,-4 0-547,1 2 1,-9 1 1275,-15 3 0,-34-8 1,-2-2-1</inkml:trace>
-  <inkml:trace contextRef="#ctx0" brushRef="#br1" timeOffset="456972">17032 18045 7533,'-41'-8'3276,"23"6"-1638,52 1 0,24 2-1874,-19-1 1,2 1 0,3 0-585,-1 0 1,2 2 0,1-1 0,-4 0 555,0-1 1,-3-1 0,-7-1 0,-3-7-1,-25-2 1</inkml:trace>
-  <inkml:trace contextRef="#ctx0" brushRef="#br1" timeOffset="457718">17782 17515 7533,'6'-47'1092,"15"66"0,10 23 0,-5-3 546,-10-17 0,-2 5-1715,-5 4 1,1 10 0,-1 8 0,0 4 0,-2 1 0,-1-3 0,-2-6 0,-2-10-14,-4 9 0,-7-2-379,-1-7 1,-4 8 0,-4 5 0,0 1 0,-1-4 0,1-7 0,3-12-2587,-18 6 3215,2-9 1,-6 3-1,18-3 1,35 3-1,4 1 1</inkml:trace>
-  <inkml:trace contextRef="#ctx0" brushRef="#br1" timeOffset="462851">6867 17110 7533,'-7'-28'-1170,"13"11"1170,23 9 90,-2 11 0,3 2 90,13-4 0,5 0-90,-3 1 0,3 1 0,-1-1-366,-7-1 0,-1-1 0,2-1 343,3 1 1,4 0-1,0 0 1,-2 0-181,1 1 1,-1-1-1,4-1 149,-6 0 0,4 0 0,2-1 0,1 0 0,-2 1-190,-2 0 1,-2 1 0,0 0 0,3 0 0,4-1 133,-8-1 0,2-1 0,3-1 0,2 0 0,1 0 0,0 0 0,0 0 0,-1 0 0,-1 1-165,-4 1 0,0 1 0,-1-1 0,0 1 1,0 0-1,0 0 0,2 0 0,0-1 1,2 0 184,-6-1 0,1 0 0,1 0 0,1 0 0,0-1 0,1 1 0,0-1 0,1 0 0,-1 0 0,1 1 0,0-1 0,0 0 41,-1 1 1,1 0-1,0-1 1,0 1-1,0-1 1,1 1-1,-1-1 1,1 1-1,0 0 1,0-1-1,1 1 1,-1 0-1,0 0-29,-2 1 1,0-1 0,1 1 0,-1-1 0,1 1 0,0 0 0,0 0 0,-1 0 0,1 0 0,0 0 0,0 0-1,0-1 1,0 1 0,1 0-20,0 0 1,0-1-1,1 0 1,1 1 0,-1-1-1,1 0 1,-1 1 0,0-1-1,0 1 1,-1-1-1,-1 1 1,-1 0 0,-1 0-1,-1 1 7,4-1 0,-2 1 0,-1 0 0,-1 0 0,-1 0 0,0 1 0,0-1 0,0 1 0,1-1 0,1 1 9,2-1 0,1 1 0,0 0 0,0 1 0,1-1 0,0 0 0,-1 0 0,0 0 0,0 0 0,0 0-18,-4-1 0,0 1 0,0-1 0,-1 0 0,0 0 0,1 0 0,0 0 0,0 0 0,2 1 0,1-1-5,-4 1 0,1-1 0,0 1 0,0 0 1,1 0-1,1-1 0,0 1 0,0 0 1,2 0-1,0 0 0,0 0 0,1 0 0,1 0 14,-6 0 0,0 0 0,2 0 0,0-1 0,1 1 0,0 0 0,1 0 0,1 0 0,-1-1 0,1 1 0,-1 0 0,0 0 0,0 0 0,0 0 0,-2 1 0,0-1 0,-1 0 0,-1 1-142,8 0 1,-1 0-1,-1 0 1,-1 0-1,-1 1 1,0-1-1,0 0 1,0 1-1,-1 0 1,1-1 0,1 1-1,0-1 1,0 1 141,-3-1 0,0 0 0,1 0 0,-1 0 0,1 0 0,1 1 0,-1-1 0,0 0 0,0 0 0,0 0 0,0 1 0,-1-1 0,-1 1 0,0-1 0,-1 1 0,6 1 0,-1-1 0,-1 1 0,1 0 0,-2 0 0,1 0 0,-1 0 0,-1 0 0,0 0 0,0 0 0,-1-1 0,0 1-82,3-1 1,0 0 0,-2 0 0,0 0 0,0 0 0,-1-1 0,1 1 0,-1 0 0,1 0 0,0 0 81,2 0 0,0 1 0,-1-1 0,1 1 0,0-1 0,0 1 0,0 0 0,-1-1 0,0 1 0,0 0-37,1-1 0,1 1 0,0 0 1,-1 0-1,0 0 0,-1 0 0,0 0 1,-1-1-1,-1 1 88,5 0 0,-2 0 1,0-1-1,-1 1 1,-1 0-1,1 0 1,0 0 52,0 0 0,2 0 1,-1 1-1,0-1 1,-2 1-1,-1 0 1,-4 0-83,10 2 1,-4 1-1,-2-1 1,-3 1 449,1-2 0,-2 0 0,-7 4-1552,-5 11 1,-9 1 1079,-8 1 0,-3 3 0,-3-17 0</inkml:trace>
-  <inkml:trace contextRef="#ctx0" brushRef="#br1" timeOffset="465796">18718 17163 6183,'-20'-26'0,"8"14"810,7-27-90,10 25-451,2-19-808,5 23 1168,-5 42-359,-3 2 0,-2 12-219,-4-9 0,-2 7 1,-1 6-1,-1 3 1,0 1-1,0-1 1,2-5-82,1-2 0,1-3 0,1-1 0,-1 1 0,0 2 0,-2 3-79,0-3 1,-1 4 0,-1 3 0,-1 1-1,1 1 1,0-2 0,1-1 0,1-4 0,2-3 0,3 3 0,2-3 0,0-3 0,1 0 0,-1-1-140,-2 10 1,-2 0 0,2-4 0,3-6 426,7 0 1,2-7 720,4 8 179,-16-33-1618,5-8 179,-17 0 540,-24 0 114,4 2 1,-6 1 0,-8 0-183,7-3 0,-6 0 1,-5-1-1,-3 0 1,-2-1-1,0 1 1,1 0-1,2 1-112,4 0 0,1 1 0,0 0 0,0 0 0,-1 0 0,0 0 0,-3-1 0,-1 1-178,6-1 1,-1-1 0,-3 1 0,0-1 0,-2 0 0,1 0 0,-2 0-1,2 0 1,-1 1 0,2-1 0,1 0 0,1 1 227,-4 0 0,0-1 0,1 1 0,2 0 0,-1 0 0,1 0 0,0 0 0,0 0 0,-2 1-68,5-1 0,0 1 0,0-1 0,-1 1 0,1 0 0,0-1 0,-1 1 0,1 0 0,0 0 0,0 1-93,-4-1 1,1 1 0,1 0 0,-1-1 0,0 1 0,0 1 0,0-1 0,-1 0 0,-1 0 77,4 1 0,0-1 1,-1 0-1,0 1 0,0-1 1,-1 1-1,0-1 0,0 1 1,1 0-1,0-1 0,0 1 24,-2 0 0,0-1 0,1 1 0,-1 0 0,1 0 0,0-1 0,-1 1 0,1 0 0,-1 0 0,-1-1-73,3 1 0,-1-1 0,-1 1 0,0-1 0,1 0 0,-1 1 1,0-1-1,0 0 0,0 1 0,1-1 0,0 0 122,2 0 1,1-1 0,0 1 0,1 0 0,0 0 0,-1-1 0,0 1 0,0-1 0,-2 1 0,0-1 0,-2 0-47,5 0 0,-1 0 0,-1 0 0,-1 0 0,-1 0 0,-1-1 0,0 1 0,0-1 0,0 1 0,1-1 0,0 1 0,0-1 0,2 1 0,0 0 0,2-1-3,-5 1 1,2 0 0,1 0 0,1 0 0,1 0 0,0 0 0,-1-1-1,-1 1 1,-1 0 0,-2-1 0,-3 0 48,9 0 0,-3-1 0,-1 1 0,-3-1 0,0 0 0,-1 0 0,-2 0 0,1 0 0,-1 0 0,0 0 0,1 0 0,0 0 0,1 0 0,2 0 0,1 0 0,1 0 0,3 0 0,2 0-70,-14 1 0,3-1 0,4 1 0,2 0 0,0-1 0,0 1 0,-1 0 0,-2-1 0,-3 0 23,8 1 1,-1-1-1,-3-1 1,0 1-1,-2-1 1,0 1 0,0-1-1,-1 1 1,1 0-1,1-1 1,1 1 0,1 1-1,3-1 1,1 1 6,-6 0 0,4 0 0,1 1 0,2 0 0,0 0 0,0 1 0,-1-1 0,-3 0 0,-2 0 25,6-1 1,-2 0 0,-3 0-1,0 0 1,-2 1 0,0-1 0,-1 0-1,0 0 1,1 0 0,0 0-1,2 0 1,1 0 0,1 0 0,3 0-46,-7 1 0,3 0 0,2 0 0,1 0 0,0 0 0,1 0 0,-2 0 0,-1 0 0,-3-1 6,6 0 0,-3 0 0,-1 0 0,-2-1 0,-1 0 1,0 1-1,0-1 0,1 0 0,1 0 0,2 0 0,2 1 1,2-1-1,4 0 41,-10 1 1,4 0-1,3 0 1,2-1-1,-1 1 1,-2 0-58,-5-2 0,-1 1 0,-1-1 0,1 1 0,1 0 0,4 0-60,-2 0 0,4 1 0,0 0 0,-4 1-112,2 0 0,-5 0 0,-2 0 0,1 1 0,3-1 0,6 1 202,-5-2 0,6 1 0,-4-1 177,-4 2 0,-8 0 0,-1 0 0,7-1 0,14 0 93,4-1 386,-3 2 1,5-4-927,18-6 15,11 7 705,-6-15 2312,-1 6-2851,-11 0-1,-1 2 90,0 8 449,6 0-898,8 0 359,5 0 1349,0 0-2069,-5 0 1350,4-7-225,-2-17 0,1-9-225,3-1 0,1-5 0,0-4-252,-4 3 0,0-3 0,-2-3 0,1 0 0,-1 2 297,-1-5 0,0 1 0,0 1 0,-1-1-46,0 5 1,0-2 0,-1 1 0,0 2 0,0 4-90,-1-4 0,-1 5 0,1 0 30,2 2 0,0 0 0,2 1 60,0-6 0,1 0-45,-3-3 0,0 0 45,2 3 0,1-1-90,4 2 0,1-2 0,1 2-135,-2-2 0,0 2-315,3 4 1,0 0-1,-1 5 450,-3-8 0,22 21 0,6 19 0</inkml:trace>
+  <inkml:trace contextRef="#ctx0" brushRef="#br1" timeOffset="-211839.73">14053 6262 7263,'-5'-18'899,"-2"1"-629,1-1 360,-5 8-180,10-6 269,-5 14-449,6-5-90,0 7 719,0 15-449,0 5 134,0 17 1,0 8-525,0-10 0,0 1 0,0 3-133,0 2 0,0 4 0,0 0 0,0 0-17,1-1 0,0 1 0,1-2 0,0-2 150,0 1 0,0-2 0,0-3 120,0 12 0,3-17 0,0-30-810,-10-4-629,4-16-1529,-10-7 2788,10-11 0,-5 7 0,6-4 0</inkml:trace>
+  <inkml:trace contextRef="#ctx0" brushRef="#br1" timeOffset="-211389.73">13980 6279 7533,'-13'-29'1638,"0"0"0,-5-5-1163,14 4 1,8 3 244,19 16 359,15 3-494,-8 14 0,2 6-286,-2 2 1,2 4 0,-4 0-120,2 5 0,-2 3-240,-3 0 0,-1 3 0,-10 1-525,-19 9 1,-11 2-181,-1 5 1,-7-2 434,2-15 0,-5-2 0,1-2-210,-6 3 1,1-3-721,-11 0 541,24-17-1,29-16 720,9-2 0,3 2 0,2-1 0,1 0 0,-1 0 0</inkml:trace>
+  <inkml:trace contextRef="#ctx0" brushRef="#br1" timeOffset="-211024.73">14595 6156 7533,'-11'-27'3276,"-8"9"-2685,-7 26-321,3 2 0,0 7 0,3 9 0,2 8 0,-1-2 59,0-3 1,-2-1 0,2 3-163,3 4 1,1 4-1,2 1 1,3-1-198,1 7 0,4 0 0,5-2-690,5-6 0,3 0 1,4-3-444,8 12 1,6-9 1162,7-17 0,1-9 0,-8-9 0,-1-4 0,23-1 0</inkml:trace>
+  <inkml:trace contextRef="#ctx0" brushRef="#br1" timeOffset="-210624.73">14693 6368 11490,'11'35'1124,"-2"-7"1,1 3-1260,6 4 0,0 2-958,-3-5 1,-1 2 0,0-2-328,1 11 1,0-3 1419,0-8 0,-3-4 0,-9-2 0,-2-18 0</inkml:trace>
+  <inkml:trace contextRef="#ctx0" brushRef="#br1" timeOffset="-210308.73">14607 6809 7533,'-24'-26'3148,"10"7"-1709,20-7-585,12 6 1,6-1-405,7-5 0,2-3-151,0-1 1,3-3 0,-2 0-390,-6 3 0,-2 0 0,-1-2-900,3-5 1,-1-1 0,-4 1-650,-4-5 1,-6 2 1555,-6 4 1,-9 9 0,-23 25 0,-13 34 0</inkml:trace>
+  <inkml:trace contextRef="#ctx0" brushRef="#br1" timeOffset="-210029.73">15112 6579 13649,'19'8'810,"-1"18"-1845,-13-2 1,-3 5-605,-4 6 1,-2 2 443,1-4 0,-2-1 1195,-2-4 0,-4-5 0,-12-6 0,-3-9 0</inkml:trace>
+  <inkml:trace contextRef="#ctx0" brushRef="#br1" timeOffset="-209046.73">15482 6315 8612,'-7'-10'990,"1"2"-181,12 0 1,11 6-1,15-6-539,-6 4 0,2 1 89,6 5 1,1 1-585,-3-2 1,0 0 44,-5 7 0,-5 2 270,-4 8-90,-41 15-270,4-15 0,-2 1-210,-5 5 0,-3 2 1,1 1 509,3-3 0,1 1 0,0 0 299,-1 2 1,-1 0 0,3 0-195,0 4 0,4-2 585,1 14-360,24-15-270,18-11-225,2-11 0,3-4 135,-1-1 0,2-2-720,5-1 0,2-1 1,-3 0-46,-7 3 1,-1-1 764,17-4 0,-12 2 0,-28 3 0,-6 0 0</inkml:trace>
+  <inkml:trace contextRef="#ctx0" brushRef="#br1" timeOffset="-208777.73">15432 6526 7533,'-18'-17'3276,"4"-1"-1335,7 8-1132,20 10-1618,29 18 44,-9-8 1,3 0-875,5 3 1,0-1 1091,-8-6 1,-2-2 0,-1 0 0,-3 0 0,4-4 0</inkml:trace>
+  <inkml:trace contextRef="#ctx0" brushRef="#br1" timeOffset="-208425.73">15912 6085 7982,'11'-9'3276,"8"24"-2036,4 12 1,2 7-1151,-5-1 0,-1 3 0,-1 3-626,-3-4 0,-2 3 0,0 1 0,-2 0 198,-1 0 1,0 2 0,-3-1 0,-3 0 112,-6-1 0,-3-1 0,-3 0 1,-1-2 37,-6 10 1,-4-1-1,-4-4-443,-4-6 1,-4-2-1,1-3 630,-2 4 0,-1-6 0,-7-8 0,0-6 0,14-10 0,0 0 0</inkml:trace>
+  <inkml:trace contextRef="#ctx0" brushRef="#br1" timeOffset="-207507.73">13795 7355 7173,'-12'-9'1169,"5"-7"270,24 6-899,3 4 0,9 2-136,8 2 1,9 2 0,5 1 0,1 0-824,-10 0 1,1 0 0,2 1-1,1 0 1,2 0 0,1 0 328,-8 0 0,3 1 0,0 0 0,2 0 0,0 0 0,1 1 0,-1-1 0,-1-1 0,-1 1-320,2-1 0,0-1 1,-1 1-1,0-1 1,0 0-1,-1 0 0,-1 1 1,0-1 222,8 2 1,0 0-1,-1 1 1,-1-1-1,-3-1 1,-1-1 208,4-2 1,-3 0-1,-2-2 1,-4 0 786,10-1 1,-6-2-406,-8 3 1,-6-3 135,-5-10-1799,-9 6-1080,-14 0 2339,3 3 0,-16 7 0,-3 0 0</inkml:trace>
+  <inkml:trace contextRef="#ctx0" brushRef="#br1" timeOffset="-206956.73">14041 7885 7533,'0'-26'3058,"0"14"-2608,0 5-91,5 31 1,1 16-180,-5-6 0,1 3-777,3 6 0,1 5 0,-1-2 477,-4-11 0,-1-2 1,1 1-808,1 3 0,1 0 0,-3-7 927,-5 1 0,3-43 0,-1-20 0,1 0 0</inkml:trace>
+  <inkml:trace contextRef="#ctx0" brushRef="#br1" timeOffset="-206639.73">14128 7796 7533,'8'-36'1638,"0"0"0,7-9-983,9 28 1,4 10-341,-2 19 0,0 8-180,4 0 0,-3 7-405,-9 4 0,-4 5 0,-3 1 45,-4 6 0,-7 0-405,-9-8 1,-6 1-1,-2-5-45,-9-5 1,-3-5 314,-5-1 1,0-7-901,-9-21 1260,26-4 0,33-13 0,11 7 0</inkml:trace>
+  <inkml:trace contextRef="#ctx0" brushRef="#br1" timeOffset="-206276.73">14669 7708 7533,'-12'-27'1799,"-12"9"-1979,-2 18 225,3 13 0,-2 7 314,-1 13 1,2 5 0,0 2 0,3 4-176,7-8 0,1 2 0,4 0-64,4-3 0,3 1 0,3-1-55,2 1 1,3 0 0,2 0-936,3-2 1,2-1 0,2-2-346,6 3 1,2-6 1214,14 6 0,-14-42 0,-10-12 0</inkml:trace>
+  <inkml:trace contextRef="#ctx0" brushRef="#br1" timeOffset="-205203.73">14755 7902 9062,'0'-19'2069,"22"-13"-1530,22 28-449,-16-4 0,3 1-225,13 5 0,1 4 90,-17-2 0,-1 0 0,3-3 0,-8 6 135,-20 12-539,-23 21 494,3-18 0,-2 3-270,-9 15 0,-1 2 180,7-6 0,-1 1 225,4-4 0,-1 1 0,3-1 134,1 5 1,6-3-135,6 12-90,14-27-90,31-16-1529,3-8-45,-14 4 0,0-2 1574,-2-2 0,-3-2 0,-5-7 0,-22-1 0</inkml:trace>
+  <inkml:trace contextRef="#ctx0" brushRef="#br1" timeOffset="-204941.73">14792 8061 7533,'-19'0'1169,"7"0"990,1 0-720,15 0-450,14 16-1168,25-5-766,-15-2 1,2 0-695,9 0 1,0-2 1501,3-5 1,-13-1 0,-2-2 0,-1-9 0</inkml:trace>
+  <inkml:trace contextRef="#ctx0" brushRef="#br1" timeOffset="-204625.73">15247 7708 7533,'22'-21'3276,"16"46"-1638,-11 1 0,-2 7-1634,-2 5 1,-3 7 0,-2-1-614,-6-4 0,-3-1 1,-3 2 218,0 5 0,-4 2 0,-4-1 90,-7-4 1,-5-1-1,-1-4-15,-3 2 0,-4-5-224,-11-3 0,1-7 539,3-8 0,1-7 0,22-2 0</inkml:trace>
+  <inkml:trace contextRef="#ctx0" brushRef="#br1" timeOffset="-203479.73">16626 7144 7533,'-31'0'2428,"16"0"-2428,10 0 0,24-10 0,14-4 0,3 0 0,0-1 0</inkml:trace>
+  <inkml:trace contextRef="#ctx0" brushRef="#br1" timeOffset="-202107.73">17881 6368 8252,'-11'24'959,"1"1"1,0 12 0,4 6-841,7 1 1,4 4 0,0 1-705,-2-11 0,0 1 1,1 1-1,0-2 375,1 11 0,2 0 1,-1-4 209,4 3 0,-2-8-76,-1-6-1183,-1-36 13,-6-24 1246,0-1 0,0-1 0,0-3 0,0-1 0,0-1 0</inkml:trace>
+  <inkml:trace contextRef="#ctx0" brushRef="#br1" timeOffset="-201720.73">17868 6315 7533,'3'-27'1169,"0"1"0,20-4 91,21 23-946,-6 20 1,4 9-195,-13-3 0,1 2 0,-1 2-90,0 0 0,-1 1 0,-3 1-120,8 13 0,-11 2-135,-21-3 0,-12-3-495,-11-4 1,-8-5 314,-7-1 1,-4-5 134,1-9 0,1-2-90,-5 7-1349,21-13 1709,23 6 0,40-16 0,-13 3 0,-1 1 0</inkml:trace>
+  <inkml:trace contextRef="#ctx0" brushRef="#br1" timeOffset="-201340.73">18620 6297 7533,'-25'-29'1349,"-6"5"-1079,0 40 0,-6 11 44,15 4 1,2 7-15,6-8 0,1 3 0,2 2-121,-2 9 1,2 4 0,3 1-293,5-9 1,2 1 0,1 0 0,3-2-68,1 1 0,2-3 0,4-1-870,5 1 1,4-2 0,1-9 1049,22-6 0,4-20 0,-21-20 0</inkml:trace>
+  <inkml:trace contextRef="#ctx0" brushRef="#br1" timeOffset="-199921.73">18791 6438 7533,'-13'0'1619,"-3"0"360,9 0-1080,0 0 1,7 0 179,17 24-1169,1-7 0,2 3-1549,9 18 1,3 2-1,-3-5 1,1-3 1545,-5-4 1,-1-3 0,5-2-1,-17-23 1</inkml:trace>
+  <inkml:trace contextRef="#ctx0" brushRef="#br1" timeOffset="-199574.73">19185 6332 7533,'-19'-19'3276,"2"27"-526,4 37-3080,6-15 0,-1 6 1,0 2-459,-2 7 0,0 3 0,-1 2 653,-1-8 0,-1 2 0,0-1 0,1-2 244,0 2 0,2-3 0,-2-1-139,0-3 0,-1-1 0,4-8-1152,2-8-707,7-3 1889,12-16 0,13-16 0,7-3 0</inkml:trace>
+  <inkml:trace contextRef="#ctx0" brushRef="#br1" timeOffset="-199324.73">19235 6809 8972,'0'-20'3276,"0"4"-1515,11 48-1761,-2-10 0,1 3-135,0 10 0,0 2-855,1 7 1,-4-2-650,-8-12 1,-4-3 1627,1 2 1,-5-7 0,-21-12 0,-2-12 0</inkml:trace>
+  <inkml:trace contextRef="#ctx0" brushRef="#br1" timeOffset="-198229.73">19678 6456 7982,'-13'-10'2339,"7"-6"-1349,0 7-1,17-1 0,19-6-539,-1 14 0,3 2-225,11 0 0,2 0-270,-3 0 0,-1 2-45,-4 4 0,-6 4-450,-7 7-449,-42 19 539,-10-6 0,-5 0 540,8-5 0,-1-1 150,-4 3 0,-4 1 0,2 0 164,1 4 1,2 0-90,-4 4 0,2 1 89,9-6 1,8-1-135,21 5 90,19-17 0,11-11 90,5-7-360,8 0-1035,-14-3 1,0-1-695,-8 3 1,-1 0 353,1-7 0,-3 0 1285,-2 6 0,-37 2 0,-8 10 0</inkml:trace>
+  <inkml:trace contextRef="#ctx0" brushRef="#br1" timeOffset="-197939.73">19665 6756 7533,'-38'-10'3276,"13"2"0,36 8-2183,27 0-1768,3 3 1,3 2-1,-7 0 1,0 0-965,11 0 1,-2-1 1483,-18 2 1,-4-4 0,19-25 0,-20-7 0</inkml:trace>
+  <inkml:trace contextRef="#ctx0" brushRef="#br1" timeOffset="-197622.73">20157 6368 8162,'6'-28'3276,"1"11"-1515,27 32-1176,-12 1 0,1 5-346,1 4 1,2 5 0,-2 2-451,-2 4 0,-2 2 0,-3 3-59,-7-3 0,-2 3 1,-3 0-1,-2-2-60,-4 6 0,-4-1 0,-4-2-390,-5-1 1,-3-3 0,-3-5-249,-5-4 0,-1-7 968,-11 4 0,3-24 0,9-4 0</inkml:trace>
+  <inkml:trace contextRef="#ctx0" brushRef="#br1" timeOffset="-196841.73">17659 7373 7353,'-19'-8'2069,"7"-2"-720,50 1-855,-1 4 1,8 2-959,-9 0 0,4-1 1,4 1-1,3 0 0,1 0 531,-5 2 1,2 0-1,3 1 1,1 0-1,1 0 1,0 0 0,-1-1-1,0 0-339,-2 0 1,0-2 0,-1 1 0,1-1 0,0 1 0,1 0 0,0 0-1,2 2 227,-3 0 0,1 0 0,1 1 0,1 1 0,1 0 0,-1 0 0,0 0 0,-1 0 1,-1 0-1,-2 0-214,1 0 0,0 0 1,-1 0-1,-1 0 1,-1 1-1,-1-1 0,-1 1 1,-1 1 366,6 1 0,-1 0 0,-1 1 0,-2 0 0,-1 1 0,-2-1 26,9 2 1,-1 0 0,-4 1 0,-8 1 675,-5 4 0,-10 0-181,-10 3-1781,-11-17-108,0-9-1618,0-25 2878,0 13 0,-22-5 0,-6 18 0</inkml:trace>
+  <inkml:trace contextRef="#ctx0" brushRef="#br1" timeOffset="-196292.73">18312 7849 7533,'0'-9'2518,"0"16"-2068,2 19 0,1 7-181,1 7 1,-1 4-639,-1 0 0,1 4 0,-1 0 39,0-5 0,0 0 1,-1-2-526,0 11 1,-2-4-270,1-10 0,0-9 1124,0-20 0,-5-34 0,-2-22 0</inkml:trace>
+  <inkml:trace contextRef="#ctx0" brushRef="#br1" timeOffset="-195929.73">18349 7779 7533,'5'-37'3276,"13"3"-1785,30 32-1176,-17 12 0,2 6-225,9 8 0,-3 7-675,-10 7 0,-7 4 90,-1-1 1,-12-2-181,-24-6 1,-11-3 134,-4-2 0,-5-5 495,-3-11 0,-2-4 90,-6 1 0,4-3-764,12-6 524,9 0 0,43-6 0,18-3 0,4-1 0,-1 0 0</inkml:trace>
+  <inkml:trace contextRef="#ctx0" brushRef="#br1" timeOffset="-195562.73">18964 7708 7533,'0'-45'2698,"-6"18"-2878,-6 11 0,-13 32 180,7 3 0,-1 5 45,-6 13 0,1 6 345,6-4 0,1 2 0,2 3-422,1 3 1,2 1 0,5 0-239,3-5 0,4 0 0,4-2-270,3-4 1,4-1-1,4-5-57,10 3 0,6-7 597,-1-11 0,1-5 0,15 5 0,-6-16 0</inkml:trace>
+  <inkml:trace contextRef="#ctx0" brushRef="#br1" timeOffset="-194995.73">19136 7832 7533,'7'-20'1079,"10"-3"630,2 21-1079,23-6-450,-12 10 0,1 4 134,2-3 1,-1 3-765,0 6 1,-3 2 89,3 5-270,-32 23 225,-21-20 1,-7 1 269,2 3 0,-2 3-75,-1-2 0,-2 2 0,2-1 435,-1 5 0,2 0 539,-2 7 1,5-1-270,11-11 0,9-3-226,17 2-269,10-11-90,2-14 0,4-4-45,-3-1 1,0-2-1306,9 1 1,1-2 1439,-4-2 0,-5-1 0,-5-1 0,-25 2 0</inkml:trace>
+  <inkml:trace contextRef="#ctx0" brushRef="#br1" timeOffset="-194712.73">19111 8061 7533,'-20'0'3276,"25"8"-2936,16-3 1,7 0-881,17 4 1,4-1 224,-1-2 0,0-2-615,-11-3 1,1 0 0,-4-3 805,-3-1 1,-3-4-1,7-18 1,-31-3 0</inkml:trace>
+  <inkml:trace contextRef="#ctx0" brushRef="#br1" timeOffset="-194356.73">19690 7655 7533,'18'-10'3276,"6"18"-2261,-6 7 1,1 6-657,7 18 1,-3 8 0,-8-8 0,-4 3 0,-2 2-731,-5-3 1,-2 1 0,-3 2 0,-3-2 100,-2-2 0,-3-1 0,-3 0 0,-1-2-330,-6 7 1,-2-1-1,-3-7-704,-7-1 0,0-9 1334,-5-3 0,18-30 0,12-3 0</inkml:trace>
+  <inkml:trace contextRef="#ctx0" brushRef="#br1" timeOffset="-181556.73">1817 6791 7533,'8'-27'1259,"-6"1"-360,5 24-359,-7 43-420,0-10 0,0 5 0,0 3-278,0 4 1,0 4 0,0 2-1,0-2-361,0-3 1,0-2 0,0 1 0,0-1 158,0 0 0,-1 2 1,0-3-1,3-6-360,6 4 1,0-7 719,-4 1 0,4-41 0,-18-11 0</inkml:trace>
+  <inkml:trace contextRef="#ctx0" brushRef="#br1" timeOffset="-181157.73">1887 6632 7533,'0'-39'2338,"32"8"-1933,-7 45 0,5 11-225,10-7 0,2 5-150,-13 4 0,-1 6 0,-5 1-120,1 10 0,-10 2-60,-14-11 0,-7 2 0,-4-3-60,-6-2 0,-4-1 0,-6-4-90,-10 1 0,-6-4 1,2-5 74,-8-3 0,2-5-90,0 0 0,7-8-1034,15-19 1349,19 14 0,45-13 0,0 5 0</inkml:trace>
+  <inkml:trace contextRef="#ctx0" brushRef="#br1" timeOffset="-180840.73">2152 7355 7533,'-9'28'1529,"0"-1"0,0 9-899,9-21-990,9-54 360,0 9 0,0-5-180,-3 4 0,0-3 0,0-1 270,0-1 0,0 0 0,-1 3-405,-2-4 0,4 9-854,24 10 134,-12 33 1,0 8 1034,7 0 0,2 3 0,-5-2 0,0 2 0,0-2 0,8 3 0,1 1 0</inkml:trace>
+  <inkml:trace contextRef="#ctx0" brushRef="#br1" timeOffset="-180496.73">2505 7197 7533,'-26'-36'3276,"-1"17"-2235,-8 11-681,7 41-900,17 4 1,4 5 224,5 0 0,4 2 270,3 3 0,8-6 405,10-14 0,5-11 269,21-24-674,-20-21 0,-5-10 0,-9 4 0,-5-1-360,-3-7 1,-6 0-271,-7 11 1,-3 5-1305,-3 6 1979,2 21 0,36 21 0,-3 1 0,1-1 0</inkml:trace>
+  <inkml:trace contextRef="#ctx0" brushRef="#br1" timeOffset="-180040.73">2875 6720 7533,'-9'-41'1092,"1"0"0,3 8 0,0 5-860,-3 11-322,8 58 45,4-3 0,0 6-135,-4-2 0,0 3 0,2 1-55,2-5 0,3 0 1,0 2-1,-2-1 122,-1 1 1,-2 1 0,1-1-1,0-2 233,3 2 0,1-3 0,-2-2-208,-2 8 1,-6-17-273,-15-39-90,-6-8 0,-3-1 315,-1 2 1,-1 4 718,-3 2 1,1 6 1034,-4 23 630,19 25-2249,32 4 332,2-18 0,7-5-332,20-6 0,6-8 0,-7-8 0,0-4 0,-7-5 0,0 1 0,-1-1 0</inkml:trace>
+  <inkml:trace contextRef="#ctx0" brushRef="#br1" timeOffset="-178640.73">3563 7461 7533,'-10'18'2158,"2"0"-1438,8-9-180,0-1-450,0-31-225,4-2 0,0-3-315,-3-11 0,0-5 90,3 7 0,2-2 1,0 2-91,2-3 0,2 3 315,0 3 1,7 10 44,11 23 0,3 9-90,-7 2 0,1 2 0,5 2 0,1-1 45,-4-3 0,-4-4 225,-1-6 360,2-8 809,-24-2-179,0 1-181,-8 1-539,-2 39-450,-8 0-90,12-5 0,2 1 90,6 3 0,4-1-315,5 4 1,6-3 44,7-7 0,5-5 90,-3-2 0,3-8 90,6-21 1,-2-10 44,-12 1 0,-3-3 449,9-8 1,-5-2 90,-14 3 0,-4 1 314,6 3 1,-4 1 539,-22-16-1978,4 33 449,-13 28 90,15 11 45,5-1 0,2 3 180,2-4 0,2 1 135,4 12 0,6-2-495,5-12 0,3-3 315,-5 1 0,4-7-360,13-15 1,2-11 89,6-19 450,-12 3 0,-1-3-45,-7 9 0,-2-1 179,-3-9 1,-3 1 45,-1-1-90,-18-6-360,-4 9-270,-13 16 180,15 2 0,-6 8 0,14 8 180,-5 10-179,7-6 179,0 11-1170,0-21 1170,0 14 0,7-22 0,3 4 0</inkml:trace>
+  <inkml:trace contextRef="#ctx0" brushRef="#br1" timeOffset="-177929.73">4410 6720 7533,'0'-25'719,"-8"5"-179,6 3-450,-6 17 360,8 25-1,0 12-179,0-1 0,0 5-270,0 6 0,0 4 112,-1-15 1,-2 4-1,1 1 1,0-1-535,1-1 1,1 1-1,0-1 1,-1-1 421,-2 9 0,-1-1 0,3-3-120,5-7 0,1-2 0,2-4-420,13 15 90,15-18 360,8-27 0,-13-4 0,-6-13 1,1-5 268,12-7 1249,-15 4 0,1-3-709,0-2 1,-3-1-405,-8 4 0,-4-1-225,-6 0 0,-4 3-360,-18-2-45,-5 15 0,-1 8 765,-5 20-225,3 13 0,7 8-180,19 1 0,8 3-555,-3-4 0,3 2 1,4-2-584,8-5 1,4-2 0,1-3 925,4 3 0,3-6 1,6-4-1,2-6 1,-10-10-1,-1 0 1</inkml:trace>
+  <inkml:trace contextRef="#ctx0" brushRef="#br1" timeOffset="-176124.73">1870 10089 8792,'0'35'287,"0"0"1,0-1 0,-1 14 0,1 2 0,1-1-258,1-1 0,1-1 0,0-1-60,-3 1 0,-1-1 0,4-5 75,6 3 0,-3-20-405,-12-32 135,9-15 1,0-8-1,-17-12 0,-3-5 22,12 13 1,2-4 0,1 0-1,-2 0 75,-4 1 0,-1 2 1,-1-1-1,4-1 218,2-4 0,3-2 0,2 1 0,1 3 89,1-1 1,3 2 0,2 3 0,8-6 0,6 8 45,2 16 0,5 9 254,3 10 1,3 8 0,-2 4 15,0 12 0,-2 7-642,0-2 0,-1 4 0,-6 0 416,-11 7 1,-9 0-233,-8 6 1,-9-2-623,-11-10 1,-5-5-226,-6 0 1,-3-5-226,-2-4 1,0-9 404,3-13 1,3-6 629,-3-4 0,13-23 0,24 7 0</inkml:trace>
+  <inkml:trace contextRef="#ctx0" brushRef="#br1" timeOffset="-175690.73">1076 10195 7533,'-16'-25'2158,"12"5"-988,4 3-91,28 40-854,-6-9 0,1 3-135,-3 8 0,0 4 0,1 2-1080,4 3 1,2 2-1,-1 0 60,-3-2 1,-1 1 0,0-1 754,-1 2 1,0 0 0,-3-4 0,-3-4-1,-4-3 1,-3 9 0</inkml:trace>
+  <inkml:trace contextRef="#ctx0" brushRef="#br1" timeOffset="-175456.73">1164 10601 7533,'-29'-33'3276,"37"-5"-2531,14 8 1,10 0-896,0 10 0,4 3 0,2-1 150,-2 1 0,3-1 0,-1 1 0,-2 0 0,1-1 0,-1 0 0,-1-1 0,4-1 0,-1 0 0,1 0 0</inkml:trace>
+  <inkml:trace contextRef="#ctx0" brushRef="#br1" timeOffset="-174662.73">2611 9913 7533,'-10'-18'1169,"-6"1"-809,-2 7-90,-1 2-90,-14 16-90,5 10 44,2 18 1,1 10 45,8-7 0,3 2-277,-1 2 1,-1 4 0,6 0 66,5 0 0,5 0 0,3-1-60,0-7 0,3-2 0,2 0-270,2 0 1,2 0-1,4-7 45,4-5 0,5-7 315,8-7 0,0-6 0,1-5 0,15 0 0</inkml:trace>
+  <inkml:trace contextRef="#ctx0" brushRef="#br1" timeOffset="-174074.73">2752 10231 7083,'9'-26'2788,"23"14"-2428,-11-11-360,23 21-180,-1-6 360,-14 16-90,-4 2 360,-25 15-990,-17 3 270,-3-1 135,0-7 0,-1 1-404,-8 16 674,6-11 0,3 1 134,0 18 91,4-1-180,16-17 0,8-2 90,10-15-360,17-2-270,2-8-539,6 0-271,-7 0-898,-1 0 2068,-15 0 0,-5 16 0,-15 3 0</inkml:trace>
+  <inkml:trace contextRef="#ctx0" brushRef="#br1" timeOffset="-173791.73">2734 10425 7623,'-18'-10'2158,"9"-6"-2068,1 14-449,16-6 538,17 8-494,0 0 1,3 0-541,11 0 1,2 0 854,-4 1 0,1-2 0,8-5 0,0-3 0,-10-1 0,0 0 0</inkml:trace>
+  <inkml:trace contextRef="#ctx0" brushRef="#br1" timeOffset="-173509.73">3193 9895 8162,'33'22'1638,"-7"2"0,1 7-1351,-5 5 0,0 7 1,-1 1-765,-4-6 1,0 2 0,-1 1 0,-4 1 48,-3 2 1,-3 2 0,-3-1 0,-1-2-323,-3 6 1,-2-3-1,-5-3 750,-2-9 0,-3-3 0,-1-2 0,-7 1 0,-1-4 0,4-7 0,0 0 0</inkml:trace>
+  <inkml:trace contextRef="#ctx0" brushRef="#br1" timeOffset="-170204.73">7236 9772 6993,'-14'-10'2249,"-2"-6"-2069,14 15 0,-3-7-1,5 8 181,5 0 810,-3 23-541,3 14-494,-5-5 0,-1 9 0,-1 2 0,0-2-105,-1 6 0,1-1 0,0 2-850,0 0 1,0 3 0,1-1 0,-1-7 663,-2 6 0,2-7-159,3-6 1,4-10-1216,2-22 271,5 12-990,0-40 2249,1 11 0,-6-17 0,-2-5 0,1 7 0,1-1 0</inkml:trace>
+  <inkml:trace contextRef="#ctx0" brushRef="#br1" timeOffset="-169822.73">7150 9807 7533,'-10'-35'869,"1"0"1,1-5-1,3 1-374,6 6 0,4 2-46,7 2 1,6 5 0,8 7 0,4 8-1,10 15 1,1 12-240,-9 3 0,0 6 0,-3 3-31,-2 7 1,-4 3 0,-2 3-721,-3 4 0,-3 2 0,-6-2 301,-5-9 0,-4-2 1,-5-2-976,-13 8 1,-7-8 224,3-18 1,-2-5 674,-1-1 0,1-4 315,-12-6 0,39-16 0,6-3 0</inkml:trace>
+  <inkml:trace contextRef="#ctx0" brushRef="#br1" timeOffset="-168978.73">7925 9666 6813,'-5'-18'2789,"3"9"-2250,-3-7-449,-1 14-90,-6 2 0,-12 26 180,5-3 0,0 6-120,6 3 0,0 4 0,1 0-30,0 3 0,1 1 0,3 1-97,2 5 0,4 3 1,3-3 36,3-6 0,2-1 0,3-2-150,9 9 0,2-4 0,-4-14 0,1-3-360,5-2 1,1-5-2159,10-6 2698,0 3 0,-10-23 0,-18-1 0</inkml:trace>
+  <inkml:trace contextRef="#ctx0" brushRef="#br1" timeOffset="-168572.73">8073 9825 7533,'-21'-20'2069,"5"5"-1440,21 30-89,8 5-360,1 7 0,2 5-90,2 2 0,2 4-780,-1-1 0,2 2 1,-1-1 89,-3-6 0,0-1 1,1 0-7,1-1 1,-1 0 0,0-4 605,0-2 0,-5-5 0,-6-1 0,-15-10 0</inkml:trace>
+  <inkml:trace contextRef="#ctx0" brushRef="#br1" timeOffset="-168289.73">8023 10301 7533,'-24'-18'3276,"5"-7"-616,28-18-1985,10 13 0,6-3-496,1 2 1,4-1 0,2-1-568,2 0 1,2-1 0,0 1-706,0 0 1,0-1 0,-2 3-547,3-2 1,-4 3 1437,-9 8 1,-8 11 0,-16 19-1,-13 12 1</inkml:trace>
+  <inkml:trace contextRef="#ctx0" brushRef="#br1" timeOffset="-168062.73">8540 10142 7892,'13'43'3276,"-1"-5"-1155,0 5-2930,-10 0-1980,-15-6 1350,-1-11 0,-3-1 1439,-10 5 0,-7 3 0,14-15 0</inkml:trace>
+  <inkml:trace contextRef="#ctx0" brushRef="#br1" timeOffset="-167489.73">8873 9825 7533,'-30'-8'2338,"9"6"-2068,3 2 630,24 10-541,24 23-359,-7-14 0,5-1-750,-2 0 1,4 0 0,-2-1 749,9 5 0,-1-6 0,-2-12 0,-1-6 0,8-20 0</inkml:trace>
+  <inkml:trace contextRef="#ctx0" brushRef="#br1" timeOffset="-167238.73">9254 9772 7533,'-11'-35'3276,"3"15"-1155,-15 20-1897,7 27 1,2 13-765,-1 0 1,0 6-1,1 1-280,2-9 1,1 2 0,-1 0 0,2 1 581,-1 2 0,2 3 0,0-2 0,1-3-152,0 0 1,2-2-1,2-3-452,0 2 0,2-6 842,8 2 0,6-34 0,7-10 0</inkml:trace>
+  <inkml:trace contextRef="#ctx0" brushRef="#br1" timeOffset="-167062.73">9377 10231 9961,'-19'-2'-1709,"-10"27"1709,14 6 0,5 5 0,2 3 0,5-7 0,1 1 0</inkml:trace>
+  <inkml:trace contextRef="#ctx0" brushRef="#br1" timeOffset="-165972.73">9685 9825 6723,'-6'-10'900,"0"2"-91,6 0 1,-6 6-91,5-13 181,-4 13-361,5-6 91,5 8-90,18 0-540,21 0 0,-11 0 0,2 0-45,0 0 0,0 0 0,-3-1 0,-3 2 135,8 7-90,-19 9 90,-18 11-90,-11 0 0,-7 3-135,-8 8 0,-4 2 15,9-11 0,-1 1 0,0 0-110,-3 2 1,0 1 0,2-5 319,3-5 0,2-1 314,-3 6 1,2-3 225,-1-4-450,1 13 180,13-10 179,29-15-359,10-2 419,5-8-1004,-7-3 0,1-2-360,-2-3 1,-1-1-586,9 3 1,-1 0 1349,-2-7 0,-8 2 0,-18 9 0,-20-6 0</inkml:trace>
+  <inkml:trace contextRef="#ctx0" brushRef="#br1" timeOffset="-165672.73">9685 10089 7533,'-24'-17'3276,"10"-1"-1875,3 8-501,38 3-990,13 14-900,6-2 1,3 0-586,-11 0 1,0 0 1574,6 0 0,-5-2 0,-8-3 0,-14 0 0</inkml:trace>
+  <inkml:trace contextRef="#ctx0" brushRef="#br1" timeOffset="-165312.73">10115 9648 7533,'18'-19'3276,"13"11"-2415,7 34-411,-7 7 0,-2 10-241,-13-10 1,-3 4 0,-1 3-446,-2 2 1,0 5 0,-3 0-1,-4-1 56,-4-5 0,-3-2 0,-2 1 1,-1-1-46,1 0 0,-1 0 0,-2-2 0,-3-3-260,-14 9 0,-3-8-550,10-16 1,0-5 1034,-16 2 0,26-14 0,5 6 0</inkml:trace>
+  <inkml:trace contextRef="#ctx0" brushRef="#br1" timeOffset="-164412.73">11322 10054 7173,'-20'-10'2968,"8"-5"-1798,6 13-1,6-22-270,11 20-179,12-4 0,6 1-945,8 5 0,4 4-45,-6 2 0,1 2 0,0-1-810,15-4 1,-4 2-270,-7 9 0,-5 0 1349,3-2 0,-76 7 0,0-8 0,1 0 0</inkml:trace>
+  <inkml:trace contextRef="#ctx0" brushRef="#br1" timeOffset="-164211.73">11371 10178 8612,'-33'0'3276,"21"0"-76,53 0-2750,0 11 0,5 1-1543,-12-9 1,1-3 0,0 3 827,0 6 0,0 4 0,-1-4 0,6-3 0,-2-2 1,-8 5-1,1 0 0</inkml:trace>
+  <inkml:trace contextRef="#ctx0" brushRef="#br1" timeOffset="-159845.73">13549 9402 7083,'-21'-20'2878,"5"-4"-2068,16 22 359,0 2-449,5 26-91,8 19-629,-10-14 0,-1 4 0,1 1-210,1-2 0,0 1 1,-1 0 29,-2 4 0,-2 1 0,1-4-315,0 2 1,0-5-586,0 0-1618,5-41 1708,2 5 990,6-29 0,-1 13 0,0-17 0</inkml:trace>
+  <inkml:trace contextRef="#ctx0" brushRef="#br1" timeOffset="-159446.73">13574 9260 7533,'-7'-32'1092,"0"0"0,-2-1 0,7 7 309,18 14-142,16 30-1034,-5 10 0,2 7-225,-7-7 0,-1 2 0,-1 2-150,-3-1 0,-2 2 0,-2 1-210,-3 1 0,-2 1 1,-8-3-181,-15 2 1,-6-4 224,2-2 0,-4-7-360,-12-10 1,-1-8-945,2-12 269,10 6 811,31-6 539,7 8 0,9 0 0,4 0 0,0 0 0,0 0 0</inkml:trace>
+  <inkml:trace contextRef="#ctx0" brushRef="#br1" timeOffset="-158988.73">14115 9243 7533,'-12'-18'2968,"-1"1"-2248,7-1-181,-5 8-269,4 2-630,-11 8 1,-7 0 493,5 13 1,-2 6 45,-1 2 0,1 5 0,-2 12 0,4 4 0,6-3 0,4 2-30,7-7 0,3 0 0,3 0-510,9 13 0,6-2-270,0-2 1,4-3 404,-2-8 0,3-6-1934,18-8 270,-15-10 1889,-1-8 0,-13-16 0,-7-3 0</inkml:trace>
+  <inkml:trace contextRef="#ctx0" brushRef="#br1" timeOffset="-158588.73">14251 9296 7533,'-7'-10'2158,"-4"-6"-1348,9 14 269,2 10-449,7 12-270,4 4 0,2 3-270,-1-1 0,1 3-765,8 13 0,1 2-899,0-10 0,0-2 809,-6 0 1,0-3 764,3-3 0,-9-11 0,-20-19 0,-4 0 0</inkml:trace>
+  <inkml:trace contextRef="#ctx0" brushRef="#br1" timeOffset="-158239.73">14152 9701 7533,'-13'-17'3276,"7"-1"-1245,35-15-1087,-3 8 1,4-3-586,-3 3 1,3-2 0,0-1-390,2-4 0,0-1 0,-2 0-930,-1 0 1,-1 0 0,-3 1-391,-1-6 1,-5 3-1619,-2-8 2968,-24 43 0,-11 20 0,-1 15 0</inkml:trace>
+  <inkml:trace contextRef="#ctx0" brushRef="#br1" timeOffset="-158045.73">14682 9525 9062,'-16'22'779,"0"-1"1,-3 5-1,2 1-779,3 4 0,2 1 0,-2 15 0,10-6 0</inkml:trace>
+  <inkml:trace contextRef="#ctx0" brushRef="#br1" timeOffset="-156912.73">14940 9313 7623,'0'-9'1799,"0"1"-630,0 8 0,0 0 1,-5 0-451,3 0 91,8 0-271,24-8-404,-4 7 0,3 0-180,9-3 0,0 0 0,-3 4 0,-1 0-45,-5-1 0,-3 2 1,4 7-1,-23 2-180,-30 15-270,7-4 0,-3 1 180,-10 5 1,-1 1 224,9-1 0,2 1-90,-8 9 0,2 1 360,8-6 0,1 0 270,-1 1 0,2-1 44,3-1 1,6-3-270,12-9 450,19-3-271,18-24-359,3-2-90,-17 6 0,0-1-899,-6-8 0,-1 2-2288,28 7 3106,-24-19 1,-26 21 0,-21-6 0</inkml:trace>
+  <inkml:trace contextRef="#ctx0" brushRef="#br1" timeOffset="-156622.73">14989 9578 7533,'-38'0'3276,"8"0"-1965,17 0-411,19 0-271,24 0-809,15 0-1459,3 0 1,4 0 38,-13 0 1,-2 0 1599,4 1 0,-2-2 0,6-15 0,-26-3 0</inkml:trace>
+  <inkml:trace contextRef="#ctx0" brushRef="#br1" timeOffset="-156273.73">15432 9084 7533,'6'-18'3276,"11"16"-706,15 36-2030,-4-5 0,-1 6-480,-11 0 0,-4 4 0,0 1-30,1 1 0,-1 1 0,-7 1-525,-8-6 0,-5 1 0,-4 0 1,1-3 224,-2 2 0,0-2 0,-5-3-570,-4 0 1,-4-3 0,2-5-196,1-9 1,2-5 1034,-4-2 0,14-8 0,11 0 0</inkml:trace>
+  <inkml:trace contextRef="#ctx0" brushRef="#br1" timeOffset="-155489.73">15899 9260 7533,'0'-25'2428,"0"13"-1438,6 4-406,-2 29 1,-1 15-315,0 4 0,0 4-403,0 1 1,-1 3 0,-1 1-116,-1-12 1,0 2-1,0-1 1,0-2-83,0 4 0,0-3 1,0-2 29,-2 7 0,4-7-1859,9-12 2159,3-39 0,-6-10 0,-2-6 0,-1-10 0,1-1 0</inkml:trace>
+  <inkml:trace contextRef="#ctx0" brushRef="#br1" timeOffset="-155096.73">15924 9172 7533,'-1'-43'3276,"8"22"-1875,33 13-907,-14 18 1,1 7-255,-3 3 0,1 4 0,-1 1-15,8 10 0,-6 4-495,-7 9 0,-12 0-270,-20-5 1,-10-5-316,-3-12 1,-4-5 494,-4-2 0,0-7-1259,-12-12 270,26 0 1349,30 0 0,28 8 0,-3-3 0,0 0 0</inkml:trace>
+  <inkml:trace contextRef="#ctx0" brushRef="#br1" timeOffset="-154638.73">16613 9190 7533,'-5'-41'2698,"-2"17"-1708,-5-17-271,-6 31-359,-12 26-90,7 7 0,2 7-270,5-1 0,1 4 0,1 3-202,3 2 0,1 3 0,1 2 0,2-1-383,3 0 0,1 0 1,2 0-1,2-1-207,2 0 1,1 1 0,2-1 0,0-4 791,6 16 0,4-10 0,19-10 0,-10-35 0</inkml:trace>
+  <inkml:trace contextRef="#ctx0" brushRef="#br1" timeOffset="-153989.73">16822 9296 7533,'0'-20'2698,"6"4"-1169,12 32-989,13 4-360,-7 8 0,1 2-900,-2-9 1,0 0-676,0 10 1,2-4 1394,17-7 0,-15-28 0,2-21 0</inkml:trace>
+  <inkml:trace contextRef="#ctx0" brushRef="#br1" timeOffset="-153722.73">17192 9260 7533,'0'-29'3276,"-11"6"-1335,-3 54-1492,-3-6 1,-1 5-360,6 1 0,1 5 0,1 3-383,-1-4 1,0 3 0,0 1 0,1-2-288,2 5 1,2-1 0,0-1 39,-1 0 0,1-1 1,3-6-1186,8 10 1725,12-27 0,10-56 0,-9 16 0,0-1 0</inkml:trace>
+  <inkml:trace contextRef="#ctx0" brushRef="#br1" timeOffset="-153529.73">17290 9613 7533,'-12'-2'3276,"5"12"-4843,-9 25 1567,13-9 0,3 1 0,-4 0 0,2 1 0,6 2 0,-1 1 0</inkml:trace>
+  <inkml:trace contextRef="#ctx0" brushRef="#br1" timeOffset="-152723.73">17511 9243 7533,'-13'-20'3276,"13"5"-1245,30 15-1717,-6-1 1,3 2-405,9 6 0,1 1 90,-7-7 0,-1 2-180,4 14 1,-7 5-181,-11 16 360,-20-8 0,-7 2 45,-7-1 0,-4 1-15,2-4 0,-2 0 0,0 0-30,-3 5 0,2 1 45,3 6 0,5-2-135,-2 7-90,18-11 360,13-25-180,22-1-180,10-16 90,0 7-360,-16-7 0,0 0 1,10-2-1190,-14 5 1,-1 0 979,2-3 1,-20 8-1,-20 0 1</inkml:trace>
+  <inkml:trace contextRef="#ctx0" brushRef="#br1" timeOffset="-152340.73">17474 9613 7533,'-24'-8'2968,"5"-1"-2158,7-1-451,28-6-449,22 14-135,-2-2 1,2 0-631,0 8 1,1 0 854,9-2 0,0-2 0,-17 1 0,-2-2 0,3-4 0,0 0 0</inkml:trace>
+  <inkml:trace contextRef="#ctx0" brushRef="#br1" timeOffset="-151973.73">18004 9172 8162,'24'0'3276,"7"16"-2306,-12 6 1,-2 7-521,1 13 0,-3 6-616,-4-8 1,-2 2-1,-4 1-14,-7 5 0,-4 0 1,-2-2-91,0-11 0,-1-1 0,-3-2-54,-11 15 1,-3-9 323,-12-11 0,19-19 0,8-18 0</inkml:trace>
+  <inkml:trace contextRef="#ctx0" brushRef="#br1" timeOffset="-150345.73">13365 10266 7533,'-19'0'1889,"50"-8"-1530,-6 4 1,4-2 0,16-6 0,5-1-121,-7 5 1,2 2 0,2 0-748,-9 1 0,1 0 0,0 1 1,1 0 507,4 2 0,0-1 0,1 2 0,0 0 67,0 0 0,2 1 1,-1 0-1,-1 1 23,-3-1 0,-1 0 0,0 0 0,-1 0-119,9-3 0,-2 0 0,1 1 89,-1 1 0,1 1 0,-2-1-30,-10-2 0,-1 0 0,0 1 0,0 4 0,-1 1 0,-2 0 229,1-3 0,-2 2-214,10 6 0,1-1 269,-3-5 1,2-2-165,6 5 0,4 1 0,0-1-38,-14-3 1,0-2-1,1 0 1,1 0-256,8 0 0,2 0 1,1 0-1,-2 0 165,-4 0 1,0 0 0,-1-1-1,-2 0 38,6-1 0,-2-1 0,3 0-105,-2 3 0,4 0 0,-1 0 0,-3 0-45,0 0 0,-3 0 0,4 0 54,-9 0 0,1 1 0,3-1 0,-1 0 1,1-1-1,1 0 0,1 0 0,0-1 0,-1 0 0,0 0 72,-2 1 0,0-1 0,-1 0 0,1 0 0,-1 0 8,9-2 1,1-1 0,-1 1 0,0-1 22,-3 0 1,0 1 0,0-1-1,-4 1-67,1 1 0,-3-1 0,1 2 85,-3-1 0,0 1 0,1 0 0,-2 1-115,3 0 0,-2 1 0,2 1 0,5-1 0,2 0 0,-3 0 90,-7-3 0,-2 0 0,-1 1-15,16 1 0,-2 0 348,-8-3 1,-4 0-34,-2 4-540,-4 16-449,-19-4 120,-33 21-2459,-5-6 3086,-6-7 0,-7-12 1,14-18-1</inkml:trace>
+  <inkml:trace contextRef="#ctx0" brushRef="#br1" timeOffset="-149245.73">15112 10530 7533,'5'-25'1799,"2"-2"-1080,0-1 810,4 10-809,-10 11-270,5 30-1,-8 12 1,-2 7-540,1 4 0,-1 4-495,0-3 0,0 4 0,0-2 435,1-12 0,1 0 0,0-2-240,1 1 1,1 0-1,1-4-330,2-2 1,1-5-1080,8 8 180,-5-33 1619,4-9 0,-9-17 0,3-1 0</inkml:trace>
+  <inkml:trace contextRef="#ctx0" brushRef="#br1" timeOffset="-148887.73">15112 10513 7533,'5'-34'1979,"13"13"-1215,4 6 1,4 4 134,22 11-539,-11 13 0,-3 8-46,-15 0 1,-4 5-90,1 8 0,-9 2-495,-17-3 0,-8-3-360,-1-6 1,-4-3-46,-7-2 1,-1-5-1755,-13-4 630,20-2 1799,18-16 0,40-2 0,13-7 0</inkml:trace>
+  <inkml:trace contextRef="#ctx0" brushRef="#br1" timeOffset="-148495.73">15653 10407 7533,'-18'-18'2338,"-1"9"-1708,-5 9 180,-12 17-226,19 5 1,2 7-136,-2 5 1,0 5 0,3 0-270,4-6 0,4-1 0,0 3-428,1 1 1,0 4 0,3-1-1,3-3-112,9 8 1,4-4-541,1 1 1,3-4 44,0-12 1,1-7 854,17 0 0,-16-18 0,3-10 0</inkml:trace>
+  <inkml:trace contextRef="#ctx0" brushRef="#br1" timeOffset="-147362.73">15751 10583 8342,'-13'-8'990,"3"7"-271,10-7-539,0 0 720,5 6 89,29-6-539,12 8-270,-10-4 0,2 0-315,2 3 0,-1 0 180,-3-2 0,-2-2 90,-5 1 0,-2 1 224,14 1-179,-27-6-270,-9 23-1079,-33 13 899,11-3 0,-1 3 225,-6 4 0,0-1 0,4-8 0,2 1 45,2 8 0,3 0 0,2-8 0,2-1 0,2 5 0,2-1 360,-1 16-270,12-25-90,-5-10 180,5-8 180,5 0-360,8 0-900,23-8-90,-17 7 1,1 0 989,6-8 0,-3 2 0,6 21 0,-8-2 0</inkml:trace>
+  <inkml:trace contextRef="#ctx0" brushRef="#br1" timeOffset="-146938.73">15801 10813 7533,'-26'-10'3276,"8"2"-1785,12 0-771,17 6-181,25-6-854,-11 7 1,2 2-631,15 3 1,1 0 134,-7 1 1,-1 0 809,4 4 0,0 0 0,-10-4 0,-2-1 0,0 0 0,1 0 0</inkml:trace>
+  <inkml:trace contextRef="#ctx0" brushRef="#br1" timeOffset="-146524.73">16380 10513 9781,'43'13'1638,"-17"6"0,-4 8-661,-10 1 0,-3 6 0,-2 2-1547,1 2 0,0 1 1,-6 1-524,-10 5 1,-5 0 0,-1-4 918,0 4 1,-3-5-1,-9-7 1,-2-7 0,-2-11-1</inkml:trace>
+  <inkml:trace contextRef="#ctx0" brushRef="#br1" timeOffset="-128712.73">847 11959 7533,'-38'-10'3276,"13"18"-2055,17 12-1041,16 7-540,10-1-90,1-16 1,7-18-541,-17-4-539,-9-6-360,-9 10 1889,-1 8 0,2 47 0,8-17 0,0-1 0</inkml:trace>
+  <inkml:trace contextRef="#ctx0" brushRef="#br1" timeOffset="-127761.73">547 12294 7533,'-18'-17'1619,"1"7"180,7-6 989,41 6-2608,-5 1 314,17 0 1,12 2-675,-10 1 0,3 0 1,-2 0-301,-10 2 0,-2 1 1,2-1-241,10-4 0,2-2 1,-11 4 179,-10 4 540,-19 33 0,-18-13 0,2 7 0,-1-1 0</inkml:trace>
+  <inkml:trace contextRef="#ctx0" brushRef="#br1" timeOffset="-127279.73">811 12506 8432,'-19'0'2519,"3"0"-1800,16 0-899,24-8-359,-18-17-1,9 3 900,-40 4-540,3 36-1619,5 4 1799,18 3 0,27-34 0,9-13 0,1-3 0,1 1 0</inkml:trace>
+  <inkml:trace contextRef="#ctx0" brushRef="#br1" timeOffset="-123508.73">1799 11853 7892,'-19'16'1079,"8"23"1,6 12-870,5-9 0,4 2 0,0 1-1303,-1 5 1,0 1 0,1-3 760,-2-8 1,1-2 0,1-4 640,4 2 0,0-7-848,2-8 29,0-19-1649,-10-23 2159,-4-4 0,-2-3 0,-6-6 0,-2-1 0,1-1 0,-1 0 0</inkml:trace>
+  <inkml:trace contextRef="#ctx0" brushRef="#br1" timeOffset="-123188.73">1782 11818 7533,'4'-40'929,"1"0"1,5 10-1,4 5-434,6 8 0,3 8 134,1 18 1,1 8-360,15 11 0,-4 7-360,-16 4 0,-8 4-405,0 5 0,-9 0-90,-17-6 1,-7-4 449,8-8 0,-5-5-540,-18-5 1,-1-7-46,12-5-719,-16-8 1439,56 0 0,12-6 0,7-3 0,12-1 0,0 0 0</inkml:trace>
+  <inkml:trace contextRef="#ctx0" brushRef="#br1" timeOffset="-122887.73">2364 11695 7533,'-26'-18'3276,"-1"8"-3134,-9 18-367,18 13 0,1 9-45,4-1 0,0 5 0,4 1 180,2 6 0,3 2 1,3 0-504,1 5 0,3 0 1,4-3 412,2-7 0,4-2 0,2-2 164,4-2 1,2-2-1,0-6 1,18 6-1,2-16 1</inkml:trace>
+  <inkml:trace contextRef="#ctx0" brushRef="#br1" timeOffset="-122506.73">2452 11853 9691,'23'43'90,"7"-13"-1169,-4-9 0,1-1 1079,10 0 0,4-18 0,-14-14 0</inkml:trace>
+  <inkml:trace contextRef="#ctx0" brushRef="#br1" timeOffset="-122237.73">2769 11712 7533,'-17'0'3276,"-1"16"-2306,8 7 1,2 5-1196,3 3 0,1 4 75,-2 5 0,0 4 0,2 0-450,3-6 1,1-2-1,-1 2-493,-2 1 1,0 1 0,1-4 617,2 2 0,0-5 475,0 0 0,8-49 0,2-13 0</inkml:trace>
+  <inkml:trace contextRef="#ctx0" brushRef="#br1" timeOffset="-122022.73">2858 12118 9781,'4'29'1124,"1"1"1,3 19-2764,-14-10 1,-4-2 1501,-1 2 1,-11-19 0,-5-6 0,-20-6 0</inkml:trace>
+  <inkml:trace contextRef="#ctx0" brushRef="#br1" timeOffset="-120894.73">3140 11818 8882,'-8'-20'2159,"6"5"-1530,-6 7 271,8 6-181,8-14-629,2 14 180,31-13-270,-10 13 45,-6-3 0,1 2-405,17 19 270,-13-13 0,3 29 180,-23-20-90,-10 13-359,-10-7-91,-15 7-180,-3 10 630,7-9 0,-1 1 45,3 4 0,1 1 270,-4 3 0,1 1 44,6-4 1,2-2-180,0-6 0,1-3 0,2 13-270,10-24 270,2-3 180,29-7-270,-9 0-360,21 0-1439,0-7-1169,-6 5 2878,6-6 0,-39-8 0,-8-4 0</inkml:trace>
+  <inkml:trace contextRef="#ctx0" brushRef="#br1" timeOffset="-120642.73">3157 12065 8342,'-25'-18'3276,"13"1"-2954,-4 7-322,32 2-1079,19 8 404,-5 0 1,3 0 674,8 1 0,-2-2 0,-9-2 0,-3-2 0,22-5 0</inkml:trace>
+  <inkml:trace contextRef="#ctx0" brushRef="#br1" timeOffset="-120362.73">3422 11642 9242,'0'-20'2069,"16"20"-540,11 28-1170,-5-8 1,1 5-240,1 8 0,1 6 0,-5 4-638,-9-3 1,-4 2 0,-2 2 0,-3 1 438,-1-6 0,-2 2 0,-2 1 0,-3-1 0,-2 0 0,-5 0 1,-3 1-1,-3-1 0,-2-1 0,-3-3 0,-4-6 0,-1 0 0,1 0 1,-1 0-1,0 0 0</inkml:trace>
+  <inkml:trace contextRef="#ctx0" brushRef="#br1" timeOffset="-117952.73">7273 11606 6004,'-5'-19'1349,"3"-5"989,-3 7-988,5-3-271,5-5-809,-3 23 179,3 27 1,1 14-540,-5 2-105,0-9 0,1 10 0,0 6 1,0 1-1,0-3 0,0-8 45,0-2 0,1-6 0,-1 4-188,1 14 1,-1 8 0,2-3 0,-1-12 67,4 0-3007,-2-72 3194,0 13 1,-4-13 0,0-2 0,4-5 0</inkml:trace>
+  <inkml:trace contextRef="#ctx0" brushRef="#br1" timeOffset="-117578.73">7310 11518 7533,'-18'-43'3276,"27"-2"-1515,16 23-1267,10 18 1,4 10-735,-6 15 0,-1 11 1,-3 0 89,-2-7 0,-3 0 0,-8 5-480,-11 5 0,-9 7 1,-3-2-1,-2-6 180,-1-4 1,-7-3-1,-12 2 0,-8 0 1,6-9-1260,2-10 1709,11 0 0,48-10 0,-4-5 0,0 0 0</inkml:trace>
+  <inkml:trace contextRef="#ctx0" brushRef="#br1" timeOffset="-117211.73">7938 11465 7533,'-6'-25'1889,"-6"-10"-540,-24 36-989,-3 21-127,22 6 1,0 13 0,1 6 0,2 1 0,1-6-234,0 1 0,1-2 0,4 4-162,3 1 0,-1 6 0,4 2 0,5-5 0,7-11 162,14-9 0,8-8 0,0-2 0,9 9 0,2-7 0,-8-22 0,0 1 0,-1-1 0</inkml:trace>
+  <inkml:trace contextRef="#ctx0" brushRef="#br1" timeOffset="-116394.73">8221 11571 7533,'-6'-18'2968,"-1"1"-2158,1 7-316,7 32 1,3 11-585,-1-2 0,4 5 0,5 7 0,1 0-570,1-9 1,2 0-1,-2-2 165,4 8 1,1 0 494,6-3 0,2 2 0,-12-11 0,-19-12 0,10 15 0</inkml:trace>
+  <inkml:trace contextRef="#ctx0" brushRef="#br1" timeOffset="-116159.73">8146 12030 7533,'-27'-41'1092,"48"9"0,19-4 0,-2 2-617,-11-1 1,3 1-533,3 9 0,9-2 0,3-1 1,-2 5-1,-8 5 0,0 4 0,-3 4 1,1 0-1,0-1 0,-1 1 0</inkml:trace>
+  <inkml:trace contextRef="#ctx0" brushRef="#br1" timeOffset="-115977.73">8676 11748 10321,'0'36'179,"0"1"1,0-1 0,0 8 0,0 0 0,0-4 0,0 0 0,0 0 0</inkml:trace>
+  <inkml:trace contextRef="#ctx0" brushRef="#br1" timeOffset="-115296.73">9045 11624 7533,'-12'-10'539,"-6"-5"-269,5 5-270,0 0 180,8 2 2069,16 8-1170,13 16-989,7 8 0,4 3-1080,-8-6 1,2 1 989,-1-1 0,3 1 0,-3-6 0,13-7 0,5-10 0</inkml:trace>
+  <inkml:trace contextRef="#ctx0" brushRef="#br1" timeOffset="-115029.73">9451 11518 8162,'-18'-19'3276,"-12"3"-2629,10 32 0,-3 15 0,1 0-1007,-1-3 0,0 1 1,2 4-361,-1 8 1,1 6-1,1 2 1,3-3 134,5-8 0,2 0 1,2-2-1,0-1 285,0 0 0,2-1 0,4-3 300,5 3 0,6-13 0,16-37 0,6-4 0</inkml:trace>
+  <inkml:trace contextRef="#ctx0" brushRef="#br1" timeOffset="-114753.73">9513 11906 7533,'-13'-35'3276,"7"55"-1785,-6-3-1491,7 14 0,0 10 0,-2-5 0,-5-12 0,-2-1 0,-4 13 0,-1 1 0</inkml:trace>
+  <inkml:trace contextRef="#ctx0" brushRef="#br1" timeOffset="-114079.73">9857 11571 8342,'-7'-19'3058,"-4"-13"-449,10 20-2159,23-13 179,7 23-1079,4 11 1,-1 7 44,-13 5 0,-7 5 0,-4 19 1,-11 5 554,-12-9 0,-9 1 0,1-2-61,4-6 1,0-2 0,0 0 180,-7 6 0,1 0 0,12-6-270,28 5-630,20-19 90,0-16 1,4-6-1100,5-8 1,-3-2 1198,2 2 0,-15-3 0,-48 15 0</inkml:trace>
+  <inkml:trace contextRef="#ctx0" brushRef="#br1" timeOffset="-113862.73">9832 11818 7533,'-31'-18'3276,"7"9"-1605,28 1-2616,21 13 1,9 5 944,-1-6 0,3-4 0,13-1 0,0-5 0,-13-9 0,0 0 0</inkml:trace>
+  <inkml:trace contextRef="#ctx0" brushRef="#br1" timeOffset="-113591.73">10165 11342 7533,'0'-26'3276,"11"30"-1638,11 24 0,2 11-1586,-3-1 0,-3 6-484,-6-7 0,1 6 0,-1 4 1,-2-1-1,-4-3-388,-4-3 1,-4-1 0,-2-1 0,-1 2 631,-1 4 0,0 3 0,-3-2 0,-4-5 0,-8-1 0,-5-5 0,-2-5 0,-12-4 0,-1 1 0</inkml:trace>
+  <inkml:trace contextRef="#ctx0" brushRef="#br1" timeOffset="-112908.73">7409 12488 7533,'-37'-5'539,"1"1"1,6-3 0,6 6 449,10 16-607,30-8 0,22-5 1,10 0-1,4-1-382,-17 1 0,3-1 0,5 0 0,2 1 0,2-1 0,1 0 0,2-1 0,0 1 0,-1 0 0,0-1 0,-2 0-298,-1 0 0,0 0 0,0-1 0,0 0 0,0 1 0,0-1 0,1-1 0,0 1 1,1 0-1,1 0 0,2-1 240,-6 1 0,1-1 0,2 0 1,1 0-1,0 0 0,2 0 0,-1 0 1,0 0-1,1 0 0,-1 0 0,-1 0 1,-1 0-1,-1 0 0,-1 1 0,-2 0 58,8 0 0,-2 0 0,0 0 0,-1 1 0,-1 0 0,-2 0 0,0 0 0,-1-1 0,-1 1 0,-1 0 202,6-1 1,-1 0 0,-2 0-1,-1 0 1,-1 1 0,-1-1-1,-2 2 453,5 1 0,-1 2 1,-2 0-1,-4-2 0,-4-4-1034,12-13 1,-11-4 108,0-6-1369,-16 3 1,-7 3 1429,-13 11 1,-33 39 0,12-11 0,0-1 0</inkml:trace>
+  <inkml:trace contextRef="#ctx0" brushRef="#br1" timeOffset="-112062.73">7974 13000 7533,'-12'-26'869,"15"50"1,7 24-1,-2-6-869,-7-3 22,5 1 1,4 14-1,0-1 1,-3-14-23,-6-1-405,-14-60 1,4-19 799,20 9 1,13-7 0,4-2 0,-1-1-1,-9 2-440,-12 0 0,-9 0 0,3 2 1,10 5 201,21-1 0,15 3 1,-1 9-1,-17 17-517,-20 46-720,-22-5 1,-10 6 0,0-6 1079,1-10 0,0-3 0,-6 1 0,12-3 0,42-9 0,0-1 0</inkml:trace>
+  <inkml:trace contextRef="#ctx0" brushRef="#br1" timeOffset="-111811.73">8627 12823 7533,'-19'-17'3148,"-27"7"-2339,11 2-584,-1 18 0,0 12-765,16 6 1,4 9-1,1-1 330,0-5 0,2-1 0,2 4-38,4 6 1,3 7 0,4-1 0,6-5-473,10-6 1,6-4-1,-1-1 720,0 14 0,4-8 0,8-17 0,-2-14 0,-7-25 0</inkml:trace>
+  <inkml:trace contextRef="#ctx0" brushRef="#br1" timeOffset="-111162.73">8762 12912 7533,'-19'0'3276,"18"15"-2595,20 13-1940,8-6 0,6 1 1259,2 5 0,1-3 0,-4-13 0,0-3 0,-6-2 0,0 0 0</inkml:trace>
+  <inkml:trace contextRef="#ctx0" brushRef="#br1" timeOffset="-110907.73">9094 12876 7533,'-30'-9'3276,"15"9"-3319,-5 25 0,-2 18 1,4 0-678,3 1 1,2 2 233,3-10 0,-3 4 0,1 3 1,1-3-1,4-5 486,3 14 0,7-9 0,18 3 0,22-67 0</inkml:trace>
+  <inkml:trace contextRef="#ctx0" brushRef="#br1" timeOffset="-110742.73">9192 13229 11221,'-15'23'-45,"1"-1"0,-7-8 45,7 29 0,5 2 0,2-21 0,2 17 0</inkml:trace>
+  <inkml:trace contextRef="#ctx0" brushRef="#br1" timeOffset="-109812.73">9500 12912 7533,'-12'-18'3276,"16"8"-975,26-13-2212,10 15 1,5 4-450,-7-7 1,0 4 269,8 14 0,-13 10 90,-32 7 0,-12 7-90,-7 5 0,-7 3 0,-2-1 449,1-5 1,-2-2 0,0 1 0,-2 6 0,1 1 0,5-6-270,-6 6-180,30 1 0,30-38-630,2 2 1,3-1-920,-2-6 1,1-1 1537,7 5 1,-10-4 0,-27-13 0,-22 6 0</inkml:trace>
+  <inkml:trace contextRef="#ctx0" brushRef="#br1" timeOffset="-109543.73">9513 13141 7533,'-25'-10'3276,"11"2"0,42 16-3172,14-6-1197,-9-1 1,5-2 0,-2 1 888,0 1 1,-2-4-1,3-7 1,-4-3 0,-4-7-1</inkml:trace>
+  <inkml:trace contextRef="#ctx0" brushRef="#br1" timeOffset="-109227.73">9894 12753 7533,'17'-22'1638,"11"42"0,3 17-38,-9 4 0,-3 8-1780,-3-10 0,2 5 0,-3 1 0,-7 0-203,-9-2 1,-5 0 0,-4 0 0,0-4-128,-1 2 1,0-2-1,-4-3 510,-4 0 0,-3-1 0,1-8 0,-10-2 0,14-7 0</inkml:trace>
+  <inkml:trace contextRef="#ctx0" brushRef="#br1" timeOffset="-108462.73">11261 12418 7533,'-14'-20'3276,"14"5"-1856,22 9 0,8 4-1240,4 0-1020,8 0 1,10 1 0,-7 4-691,-14 4 1,-1 3 1529,5 0 0,4 1 0,-14 4 0,-23 22 0,-17-16 0,1 1 0</inkml:trace>
+  <inkml:trace contextRef="#ctx0" brushRef="#br1" timeOffset="-108236.73">11284 12629 7533,'-8'-7'819,"28"2"0,25 2 0,7 2 0,-8 0-566,-4-1 1,0 2 0,3 0 0,8 0 0,-3 2 0,-12 6 0,-3 19 0</inkml:trace>
+  <inkml:trace contextRef="#ctx0" brushRef="#br1" timeOffset="-107128.73">13278 11730 7533,'-3'-31'1619,"1"1"0,0-9-1349,2 13 314,0 58 1,2 25-923,0-18 1,1 4 0,0 2 0,0 0-226,-2-1 1,0 1 0,1 0 0,0-3-235,4 11 1,0-1 0,0-11 796,3-4 0,-3-55 0,-1-13 0,-5 2 0,0 1 0</inkml:trace>
+  <inkml:trace contextRef="#ctx0" brushRef="#br1" timeOffset="-106820.73">13340 11571 7533,'0'-39'1638,"33"26"0,5 10 1638,-9 15-2942,0-3 1,6 1-1,-3 4-244,-3 13 0,-4 5-1214,0 0 0,-8 3-515,-17 9 1,-8 0 1407,-4 3-699,-16-28 1,-12-3-1,7-4 930,-2 0 0,5 3 0,3 3 0,9 10 0</inkml:trace>
+  <inkml:trace contextRef="#ctx0" brushRef="#br1" timeOffset="-105962.73">13992 11606 7533,'0'-25'1169,"0"-3"-629,-5 9-270,-19 19 329,-1 26 1,-5 18 0,4 0-481,7-15 1,3-1 0,0 5-120,0 2 0,-2 6 0,1 2 0,5-1 0,7-3-330,11 6 0,10-2 1,1-2-331,-2-5 1,1-1-1,4-4 660,5-3 0,3-4 0,-2-11 0,18-29 0,-15-14 0</inkml:trace>
+  <inkml:trace contextRef="#ctx0" brushRef="#br1" timeOffset="-105592.73">14115 11730 7533,'-12'-20'3276,"10"12"-1766,13 26 0,7 13-1990,-3-3 0,3 3 1,1 1-614,9 4 1,2 2 0,-2-1 904,-8-3 1,-2 0 0,-1-4 0,4-1 0,-8-7 0,-21-6 0</inkml:trace>
+  <inkml:trace contextRef="#ctx0" brushRef="#br1" timeOffset="-105228.73">14066 12188 7533,'-25'-25'1638,"25"2"0,8-5-546,11-4 0,9-3 0,2-2-707,1 2 1,3-2 0,1 0 0,0 1-1206,-3 4 1,1 0 0,-1 1 0,-1 3 645,5-5 1,0 3 0,-10 8-1,-9 9 1,-24 30 0</inkml:trace>
+  <inkml:trace contextRef="#ctx0" brushRef="#br1" timeOffset="-104939.73">14693 11942 7533,'-30'-4'3276,"16"-8"-2621,-1 29 1,2 13-2185,5 0 0,2 3 314,-2 4 1,2 2 1214,3-1 0,6-5 0,22-8 0,14-27 0</inkml:trace>
+  <inkml:trace contextRef="#ctx0" brushRef="#br1" timeOffset="-103762.73">14940 11712 7623,'-14'-10'1979,"3"-5"1079,11-3-1799,11-1-495,11 4 1,8 4-585,15 11 0,5 6-420,-17-4 0,1 1 0,-2 4 240,17 10 0,-18 9-810,-41 1 1,-18 4 0,0 3 869,3 4 0,-1 3 0,-2-1 682,-2-3 0,-4 0 0,1 0 0,7-3-443,4-1 1,4-1 0,11-4 285,14 0 0,11-9-945,18-30 0,7-12-1279,0 12 1,0-1 545,-12-2 1,1-2 0,-3 5 481,14 9 1,-43 19 0,-27 21 0</inkml:trace>
+  <inkml:trace contextRef="#ctx0" brushRef="#br1" timeOffset="-103295.73">14952 11977 7173,'-33'0'3276,"10"0"-885,23-16-682,12 4-180,35-5-1349,-21 9-855,12 7 0,7 2-964,-1-1 1,0 0 1091,-5 0 1,0 0 0,6 0 0,-4 0 0,-11 0 0</inkml:trace>
+  <inkml:trace contextRef="#ctx0" brushRef="#br1" timeOffset="-102795.73">15407 11589 7533,'0'-26'2878,"0"7"-1709,11 1-225,15 13 1,6 10-405,-1 15 0,0 9-331,0-1 1,0 5 0,-6 4-435,-13-1 0,-6 5 1,-4 1-1,-1 0-180,-1 1 0,-4 2 0,-1-2 1,-2-2 404,-2 2 0,-3-4 0,-2-1-1050,-6-2 1,-3-2 0,4-8-1020,2-5 2069,-12 13 0,24-25 0,5-1 0</inkml:trace>
+  <inkml:trace contextRef="#ctx0" brushRef="#br1" timeOffset="-101840.73">13094 12541 7533,'-36'0'0,"20"0"1259,27-15-697,15 9 0,15 6 0,10 1 1,3 0-490,-17-2 1,6 0-1,3 0 1,3 0 0,2 0-1,1 0 1,0 0-1,0 0 1,-3 1 0,-1 0-1,-5 0-264,6 0 0,-4 1 1,-3 1-1,1-1 1,0 1-1,4 0 0,4 0 299,-11-1 0,4 0 0,4 0 0,2 0 0,2 0 0,1 0 0,1 1 0,0-1 0,-2 1 0,-1-1 0,-3 1 0,-3 0 0,-3 1 0,-6 0 0,-5 0 184,19 6 0,-12 0 0,5 1-23,0-4 1,7-1 0,3 0 0,-2 1 0,-6 0 0,-12 1 359,13 12-1168,-6-19-2738,-15-11 2904,-11-7 0,-20 26 1,-14 11-1</inkml:trace>
+  <inkml:trace contextRef="#ctx0" brushRef="#br1" timeOffset="-100469.73">13512 12859 7533,'-7'-20'1889,"2"4"-180,0 16-810,3 8-330,3 22 1,1 15 0,0 0-750,2-5 0,1 0 0,0 3 54,-1-3 0,1 4 0,0 1 1,0-2-1,0-5-84,2 1 0,-1-5 0,1-3-1409,2 4 0,0-15-1079,3-55 2698,-5 11 0,-6-10 0,-2-3 0,-6-12 0</inkml:trace>
+  <inkml:trace contextRef="#ctx0" brushRef="#br1" timeOffset="-100108.73">13549 12859 7533,'3'-34'819,"0"1"0,1 0 0,2-6 0,8 15 273,18 32 0,8 20 0,-13 7-2137,-33 8 0,-16 7 1,9 0 924,27-5 0,10-1 0,-17-2-285,-33-4 0,-18 0 1,2-6-1,25-15 405,56-22 0,-35 10 0,29-7 0,1-1 0,0 1 0</inkml:trace>
+  <inkml:trace contextRef="#ctx0" brushRef="#br1" timeOffset="-99626.73">14140 12788 7533,'0'-33'3276,"-11"11"-1965,-25 20-1071,11 19 0,-3 10 0,2 6 142,4 0 0,2 5 0,2 2 1,3 2-181,1 2 0,3 3 1,3 0-1,6-1-1022,6-2 1,6 1 0,3-3 0,1-5 644,4-3 1,1-4 0,3-5 0,12 0-1,-5-11 1,-18-14 0</inkml:trace>
+  <inkml:trace contextRef="#ctx0" brushRef="#br1" timeOffset="-98341.73">13586 12876 6993,'-19'-25'180,"6"5"180,8-5 89,5 7 631,-6 8 629,-6 3-90,-1-1-360,0 6-269,30-6-1,13 8 1,5 8-721,8 9 1,0 7-270,-10-8 0,-1 2 0,-8 5-300,-9 9 0,-8 5 1,-8-2-646,-19 5 1,-12-4 1004,3-8 0,-4-1 0,-2-6 329,-1-7 1,0-6 0,3-2-1290,3 0 1,7-4-2378,9-12 3118,39 0 1,1 9-1,2 2 1,1 4 0,-1 0-1</inkml:trace>
+  <inkml:trace contextRef="#ctx0" brushRef="#br1" timeOffset="-96918.73">14251 13000 6723,'-11'-28'2429,"8"11"-360,-8 1-1620,11 14 2070,22-14-1755,12 13 1,8 5-645,-1-1 0,3 2 0,-1 0-90,-7 0 0,-1-1 0,-3 5-480,11 9 0,-17 9 112,-34 1 1,-17 6 0,-7 2 0,4-2 696,2 1 1,0-1 0,-2 1-68,-1-1 1,-3 3-1,4-1 1,11-6 1146,17 13-1469,29-34 0,17-11 0,-4-1 75,-7 1 0,2-2-518,2-1 1,8-3 0,-3 0 0,-13 6-1237,-13 6-1568,24-16 1337,-49 24 1940,-4-2 0,-12-16 0,-9-2 0</inkml:trace>
+  <inkml:trace contextRef="#ctx0" brushRef="#br1" timeOffset="-96173.73">14336 13194 6813,'-31'-8'1169,"12"6"990,3-14-630,15 14 360,6-5-90,41 14-1799,-4-5 0,4-2-270,-8 3 0,1 1 1,-1-3-496,10-5 1,-6 0 314,5 10-1799,-50-4-1028,-11 8 3174,3-2 0,17-16 1,0-2-1</inkml:trace>
+  <inkml:trace contextRef="#ctx0" brushRef="#br1" timeOffset="-95609.73">14915 12823 8252,'0'-19'3276,"11"3"-1638,6 29 0,2 13-1064,-1-1 1,1 5 0,-4 4-890,-7 5 0,-3 7 0,-4 0 0,-2-1-135,-1 5 1,-4-1-1,-3-1-225,-2-10 1,-2 0-1,-3-2 1,1-5 674,-12 2 0,6-7 0,15-7 0,20-3 0</inkml:trace>
+  <inkml:trace contextRef="#ctx0" brushRef="#br1" timeOffset="-93075.73">8011 12947 7443,'-14'0'1169,"-2"-8"-539,9-2 89,1-15 720,-5 5-629,-1 10-720,3 28 225,3 9 0,1 7-46,4 8 1,2 6-68,0-8 1,0 6-1,1-1 1,0-6-113,1 4 0,1-3 224,-2 18 1,3-22-584,0-48-991,-5-13 451,0 7 359,0 8 360,-5 2 630,-2-7-360,0 3-90,-2-17 0,1-7-135,6 4 0,1-2 164,-1-5 1,-1-4 0,3 3 15,4-4 0,4 2 135,2-3 0,5 6-135,2 14 0,3 6 404,12 0-359,15 3 90,-9 40-180,-17-8 0,-3 5-180,0 12 0,-6 5-405,-15-2 1,-4 0 449,7-8 0,-5-1 629,-25 14 1,-7-10-495,-2-21-90,14 11 0,1-5-90,-9-31 0,25 5-1619,-9 0 90,10 2-1658,12 8 3196,4 0 1,19 0 0,-2 0 0</inkml:trace>
+  <inkml:trace contextRef="#ctx0" brushRef="#br1" timeOffset="-52455.73">794 14323 7173,'-18'-18'899,"0"8"271,9 3-721,1 22 271,8 28-405,0-2 0,0 6-255,0-7 0,0 3 0,0 0-267,0 2 0,0 0 0,0 0-33,0-3 0,0 0 0,0-2-300,0 10 1,0-4 359,0-17 0,0-3-360,0 15-629,8-32 1169,1-1 0,9-39 0,0-8 0</inkml:trace>
+  <inkml:trace contextRef="#ctx0" brushRef="#br1" timeOffset="-52079.73">670 14305 7533,'-10'-37'2518,"3"4"-1978,22 23 359,28 18-809,-16 0 0,3 3 0,3 2 0,3 2 0,-3 0-90,-1 2 0,-3 4-45,7 11 0,-13 2-270,-30-9 1,-10-1-226,-7 12 0,-9-3 330,3-18 0,-4-4 1,0 0-466,-12 11 0,2-3 450,11-13 1,4 0-1306,-5 25 1530,50-19 0,21 21 0,-6-19 0,1 0 0</inkml:trace>
+  <inkml:trace contextRef="#ctx0" brushRef="#br1" timeOffset="-51479.73">1023 14905 9691,'0'27'3276,"0"-9"-3583,0-65-503,0 10 270,-1-9 1,2 0-1530,15-1 720,-5 11 449,38 36 451,-17 20 359,-3-10 0,1-1 899,7 7 900,-2-16 540,-9-16-630,-32 13-989,-6-21-271,-15 30-1708,-7 12 540,22 27 359,13-10 0,6 0 495,13-5 0,5-3 180,-1-1 0,1-9 134,7-19 1,-5-12-180,-7-25-990,-11 5 1,-3-2-675,-5 3 0,-2 3 495,1-7 989,0 5 0,24 38 0,5-4 0</inkml:trace>
+  <inkml:trace contextRef="#ctx0" brushRef="#br1" timeOffset="-51029.73">1570 14340 7533,'-9'-40'1019,"0"0"0,5 11 1,-2 3-121,-9-7-629,13 41-315,4 14 0,4 7 0,3 13 0,1 6-225,-1-8 0,0 2 1,1 1-58,1 2 1,1 0-1,-2-1 237,-3-9 0,-1-2 0,1-2 585,3 8 0,-3-9 404,-7-20-899,-25-30-270,-5-9 585,9 11 0,-1 3 584,-13 5-279,8 18-395,19 14 0,6 7-1170,4-1 1,6 2-149,5 2 1,5 2 0,1-6 751,1-5 1,2-4 340,2 4 0,3-7 0,4-20 0,2-8 0,1 2 0,-1 1 0</inkml:trace>
+  <inkml:trace contextRef="#ctx0" brushRef="#br1" timeOffset="-49162.73">2152 14887 9691,'-10'0'1350,"-6"0"-631,15 8-629,-7-6-809,8 6-181,8-32 450,9-13 675,4 6 0,1-1-135,-7 4 0,2 2 135,7 2 0,1 4 135,2 3 539,8 9-809,-15 8 90,-4 8-270,-16 9-360,-8 3-449,-2 13 359,0-5 450,2-9-90,8 13 540,0-21-270,0 15 90,0-16 180,16-2 89,-12-8 181,19 0-540,-21 0 270,6 0-90,-8 0-810,0 0 450,0 7 180,0-5-270,0 6-90,0-8-359,8 0 179,-6 8 450,14-6 0,-14 6 90,13-8-90,-5 0 180,23 0-90,-3-16 179,5-3-89,-17-1 180,-3-11 0,-13 19-180,6-14-450,-8 17-540,-8 1 361,6 8 359,-5 0 0,7 8 90,0-6-180,0 13-180,7-5 180,-5 0 90,14-2 270,2-40 90,-5 3 0,1-4-225,0 0 0,0-3 15,-5 2 0,0-4 0,-2 2 75,-1-6 0,-2 2 44,0 1 1,0 3 360,-4-7-1889,0 61 1259,0 14 0,0 6 90,0 3 0,0 3-166,-1-8 1,1 3 0,1-3 30,1 10 0,4-1 225,3 4 0,7-2 0,11-8 0,7-6-90,6-10 0,2-9 134,-4-6 1,-1-10 0,7-17 0,-6-13-45,-20-2 0,-5-4 90,10-7 0,-5 0 180,-13 2 0,-8 5 629,-6 1 856,-27 63-2340,24 1 1,3 4-406,-3 5 1,8 1-540,19 5 0,11-2 1439,4-10 0,5-3 0,-7-6 0,3 1 0,0-2 0,1-3 0,0 0 0,0 0 0</inkml:trace>
+  <inkml:trace contextRef="#ctx0" brushRef="#br1" timeOffset="-45106.73">6657 14252 8072,'-6'-10'360,"1"3"0,5 7 989,0 0-809,5 7-270,-4 11-360,4-6 450,-5 27 89,6-17-89,-5 21 0,2-12 0,-1 4-360,-1 9 0,-2 2 149,1-6 1,0 3 0,0 0-180,0 4 0,0 2 1,0-4 73,0 4 1,0-4-45,1-8 0,-2-7 90,-4-15-449,4-22-1260,-5-3-720,1-16 2339,4-1 0,1-16 0,6-2 0</inkml:trace>
+  <inkml:trace contextRef="#ctx0" brushRef="#br1" timeOffset="-44432.73">6633 14270 7533,'-19'-26'1709,"7"7"-360,6-7-450,17-7-269,13 19 270,15-9-361,-7 30 1,1 9-225,-2 4 0,-3 5-270,6 9 0,-6 5-195,-15-6 0,-5 3 0,-3-1-75,-2 7 0,-7 0-270,-9 3 1,-6-4 269,-4-12 0,-3-5 135,-4-4 0,-2-5 45,6-4 0,0-4-405,-16 1-719,19-16-2108,33 6 3133,-1-6 1,14 7-1,6 2 1,-3-1 0,0 0-1</inkml:trace>
+  <inkml:trace contextRef="#ctx0" brushRef="#br1" timeOffset="-43762.73">7273 14217 7533,'0'-20'2608,"0"5"-1708,0 7-361,0 6 451,-5-6-630,-2 8-450,-11 0-630,-1 8 450,-6 10-269,-11 9 449,17-3 0,0 3 90,-3 3 0,1 3 209,3-1 1,2 3 0,2 1 150,3 3 0,2 0 0,1 1-181,-1 1 1,1 1 0,2 1 150,5 5 0,3 2 0,3-3-777,3 2 0,3-2 402,-3-1 0,4-6-810,7-20 1,2-7-1305,0-5-180,21-16 2339,-22 6 0,-2-6 0,-12 8 0</inkml:trace>
+  <inkml:trace contextRef="#ctx0" brushRef="#br1" timeOffset="-42549.73">7346 14429 8522,'-13'-18'3276,"7"8"-1638,23 29 0,12 17-1064,-2-3 1,3 5-1,0 1-1394,-6-8 1,0 1 0,0-1 0,-1 0 630,4 6 1,-1-1 0,-6-5-1,1 8 1,-40-39 0</inkml:trace>
+  <inkml:trace contextRef="#ctx0" brushRef="#br1" timeOffset="-42125.73">7371 14975 7533,'19'-39'204,"0"0"1,0 0 0,0 0 0,1-3-1,0 1 1,2 0 0,3 2 0,1 8 0,3 2-1,1 0 1,0 2 0,-3 0 0,7-7 0,0 0-1,-1 0 1</inkml:trace>
+  <inkml:trace contextRef="#ctx0" brushRef="#br1" timeOffset="-39882.73">8048 14288 7353,'-14'0'3276,"3"0"0,11 0-3262,11 0 616,-8 31-473,0 1 0,0 10 1,0 4-1,-1-2-180,0 1 1,-1 0 0,0 0-1,1 1 59,-1-6 0,0 3 0,1-1 0,-1-2 0,1-5-126,0 23 0,3-26-3187,6-54 3219,-10-17 0,-1 21 1,-7 30-1</inkml:trace>
+  <inkml:trace contextRef="#ctx0" brushRef="#br1" timeOffset="-38877.73">8331 14411 7353,'-13'0'3276,"-4"0"-1875,16 0 38,12 16-89,31 3-1261,-8 6 1,2 1-1034,-1-6 0,1-1-695,4 7 1,-3-1 1265,2 3 0,-3-26 1,-19-14-1</inkml:trace>
+  <inkml:trace contextRef="#ctx0" brushRef="#br1" timeOffset="-38376.73">8774 14358 7533,'-12'-18'3276,"6"9"-975,0 1-2032,6 16 901,0 1-721,-5 25-584,-10 7 1,-5 10 44,6-9 0,0 5 0,-1 2 0,1-3 90,1-9 0,0-1 0,1 0 0,0 0 45,-1 6 0,0 2 0,2-3 0,3-11-1035,3-5-1888,-1-27-399,5-7 3129,-5 1 0,12 8 1,1 0-1</inkml:trace>
+  <inkml:trace contextRef="#ctx0" brushRef="#br1" timeOffset="-37528.73">9008 14781 7982,'-12'-17'3276,"-6"54"-4483,4-25 1207,4 16 0,0 11 0,1-10 0,0-17 0,-8 25 0</inkml:trace>
+  <inkml:trace contextRef="#ctx0" brushRef="#br1" timeOffset="-36725.73">9168 14446 7892,'-25'-17'2519,"12"7"-450,13-14-1709,8 20 629,32-11-420,-9 10 1,5 3 0,2 1-630,5 2 0,2 1 0,-1 1-90,1-3 0,-1 0 0,-8 10-30,-8 15 1,-15 8 119,-24-2 0,-16 2 0,0 1 105,4-1 0,-1 1 0,0 1 0,1-1 45,-4 6 0,0 1 0,8-3 539,3 5 1,15-7 719,23-20 0,9-9-1484,9-13 0,4-6-958,-6 6 1,3-1 0,-3 1-547,4-4 1,-4 2 982,-2 2 1,-15 4-1,-37 10 1,-18 2 0</inkml:trace>
+  <inkml:trace contextRef="#ctx0" brushRef="#br1" timeOffset="-36325.73">9279 14658 7533,'-41'-10'3276,"57"2"-1638,25 6 0,12 4-2731,-12 0 1,1 2 0,0-2 971,-2-2 0,-1 0 0,-6 2 0,-4 5 0,-10 2 0,-16 1 0</inkml:trace>
+  <inkml:trace contextRef="#ctx0" brushRef="#br1" timeOffset="-35717.73">9882 14199 7533,'3'-31'1638,"-1"0"0,0-7 1472,25 23-1941,0 45 1,1 20-923,-11-20 0,-1 3 1,-1 3-1,-2 2-337,-2 7 0,-1 4 0,-3 2 0,-3 1 0,-1-2-252,-3-4 0,-3 0 1,-1-1-1,-3-1 0,-2-1-131,-5 6 1,-3 0 0,-3-3 0,1-6-621,-1-7 1,0-4 0,0-7 562,-19 2 0,44-32 0,9-2 1</inkml:trace>
+  <inkml:trace contextRef="#ctx0" brushRef="#br1" timeOffset="-34292.73">10411 14411 7533,'-7'-10'3276,"2"2"-1856,3 34 0,4 19-1150,-2-2 0,0 6 0,0 2-450,0-9 0,0 2 0,0 0 0,0-2-510,-1 9 1,0-2-1,3-13-2587,3-15 3033,-4-56 0,7 2 0,1-1 0,5-1 0</inkml:trace>
+  <inkml:trace contextRef="#ctx0" brushRef="#br1" timeOffset="-33812.73">10386 14305 7533,'-4'-32'1092,"0"-1"0,45 14 0,13 19 0,-24 14 0,-1 11 0,-8 4-1148,-9 9 1,-9 4 0,-5 0-305,-4-5 0,-4 0 1,-6-5 359,-10-5 0,-7-4 0,7-9 0,7-10 0,52-11 0,1-1 0</inkml:trace>
+  <inkml:trace contextRef="#ctx0" brushRef="#br1" timeOffset="-33091.73">11014 14217 9062,'-14'-20'2249,"-7"13"-2205,6 22 1,-1 11 525,-6 2 0,-4 5 0,2 2-151,1 0 1,2 2 0,2 4-115,5-5 1,-1 4 0,2 1 0,4-1 0,5-3-906,10 8 0,8-3 1,1-1-494,-5-1 1,-1 0 0,7-7 973,16-1 1,0-16 0,-14-24 0,-13-2 0</inkml:trace>
+  <inkml:trace contextRef="#ctx0" brushRef="#br1" timeOffset="-32121.73">11100 14499 7533,'-12'-17'3276,"5"7"0,40 18-4394,0 12 1,3 3 442,-7-10 1,1-1 674,16 15 0,-8-15 0,-27-51 0,0 15 0,0-1 0</inkml:trace>
+  <inkml:trace contextRef="#ctx0" brushRef="#br1" timeOffset="-31758.73">11420 14393 7533,'3'-28'1638,"1"-1"0,-10 12 0,-7 40 0,-4 22-1438,5-11 1,-1 5 0,-1 3 0,0 1-1,0-3-223,-2 5 1,-2-2 0,2-1-1,-1 1-45,2 1 1,-1 3 0,2-5 0,3-10-2812,0-3-359,26-60 3238,-1 7 0,3 4 0,7 11 0,0 11 0</inkml:trace>
+  <inkml:trace contextRef="#ctx0" brushRef="#br1" timeOffset="-31418.73">11568 14746 7533,'5'-27'3276,"2"33"-2576,-9 16 1,-6 8-2340,-3 8 1,-3 1 1465,-6 0 1,0-6 0,-6-7 0,16-38 0</inkml:trace>
+  <inkml:trace contextRef="#ctx0" brushRef="#br1" timeOffset="-29941.73">11790 14411 8342,'-25'-8'3276,"11"-2"-1638,47 3 0,21 5-776,-7 5 0,2 1-1042,-2-3 0,2-2 0,-7 5-135,-7 6 0,-15 4-1034,-36 11 989,-16 9 0,-5 1 405,13-14 0,0 3 202,4 5 1,-1 8-1,1 0 1,3-5 381,2-2 1,4-1 359,-2 17 1,13-6-1,25-27 1,12-10-1920,-2-6 1,5-5-1,-1-1-163,-3 0 1,0-1 0,-2 2 470,10-1 0,-18 8 0,-32 11 1,-33 17-1</inkml:trace>
+  <inkml:trace contextRef="#ctx0" brushRef="#br1" timeOffset="-29520.73">11863 14623 7533,'34'0'371,"0"0"0,-1 0 0,8 7 0,3-4 0,9-2 0,-14 5 0,-21 12 0</inkml:trace>
+  <inkml:trace contextRef="#ctx0" brushRef="#br1" timeOffset="-29022.73">12269 14288 7533,'25'32'468,"-1"0"0,1 1 0,0-1 0,-24 9 0,-10 3 0,-3 2 0,7 1-980,11-2 1,7 1 0,2 1 0,-4-1-1,-8-2 512,-11 4 0,-8 0 0,-2-4 0,1-10 0,-10 7 0,41-33 0</inkml:trace>
+  <inkml:trace contextRef="#ctx0" brushRef="#br1" timeOffset="-26463.73">6486 15505 7533,'-7'-18'2428,"-4"0"-790,33 8 0,9 3-146,-6-3-1492,7 4 0,15 1 0,7 0 0,-2 1 0,-9 0-90,1 2 0,3 0-320,-12 2 0,8-1 1,6 1-1,2 0 1,0 0-1,-3 0 0,-6 1 1,-8-1-423,7 2 0,0 0 742,-7 0 0,10 1 0,7 0 1,4 0-1,1 0 0,-1 0 1,-4 0-1,-5-1 0,-10 0 120,0-1 0,-8-1 0,9 1 15,-4-1 1,8 1 0,6-1 0,5 0 0,3 1 0,2-1 0,1 0 0,-2 0 0,-2 0-1,-5-1 1,-5 1 0,-7-1-1,5-1 0,-9 0 0,0-1 0,10 0-72,-9 0 1,4 0 0,4 0 0,4-1 0,3 0-1,2-1 1,2 1 0,0-1 0,0 1 0,0-1-1,-2 0 1,-2 1 0,-3 0 0,-3 0 48,10-1 1,-4 1-1,-2-1 1,-2 1-1,1 0 1,0-1-1,4 1 1,2 0-88,-10 1 1,3-1 0,0 0 0,3 1-1,0-1 1,1 0 0,1 1 0,-1-1-1,1 1 1,-1 0 0,0 0 0,-1 1-1,-1 0 1,-2 1 113,3 0 0,1 1 0,-1 0 0,0 0 0,-1 1 0,-1 0 0,-1 1 1,0-1-1,-1 1 0,-1 0 0,-2 0 186,10 0 1,-2 1-1,-2 1 1,0-1-1,-2 0 1,1 1 0,1-2-95,2 0 0,3 0 1,0-1-1,-1 1 0,-3-1 1,-6 0-1,-7 0-231,3 2 0,0-2 120,-1-3 0,10-2 0,4-1 0,0 0 0,-6 0 0,-9 2-30,-5 2 0,-2 0-158,10 1 1,8 0 0,0 0-1,-12 0 158,1 2 405,13 10 0,-4 0-405,-30-8 2196,28 11-2196,-41-15 2385,3-7-1666,-5 5-393,0-6-1495,0 8 1169,0-16 0,-27 20 0,-7-10 0</inkml:trace>
+  <inkml:trace contextRef="#ctx0" brushRef="#br1" timeOffset="-25301.73">8221 15804 10591,'0'45'409,"0"0"1,0 0-1,0-1 1,0 1-1,0-2 1,-1-1 0,1-2-1,1 0-812,2 7 1,1 0 0,-1-10-2117,0 0 540,13-72 1979,-14-2 0,3-7 0,-5 9 0</inkml:trace>
+  <inkml:trace contextRef="#ctx0" brushRef="#br1" timeOffset="-24362.73">8245 15822 7803,'-25'-25'3276,"18"-11"-1638,27 23 0,10 5-1047,14 3 1,3 10-652,-9 8 0,-2 8 0,-10 6-390,-15 3 1,-11 6-1,-6-3 315,-15 10 0,-14-7-495,1-12 1,-7-5-1,3-5 315,-2-7 1,13-8 314,27-7 0,40 0 0,-6 3 0,0 0 0</inkml:trace>
+  <inkml:trace contextRef="#ctx0" brushRef="#br1" timeOffset="-23390.73">8959 15752 8252,'-13'-18'2789,"1"0"-2789,-16 8-45,1 21 0,-1 10 494,2 4 1,1 8 0,5 5 17,10-2 1,4 7 0,3 2 0,1-1 0,2-2-588,1 9 0,3-3 0,5 0-700,3-6 1,4 2 0,2-4 0,2-12 772,5-10 1,-1-12 0,3-22 0,-20-3 0</inkml:trace>
+  <inkml:trace contextRef="#ctx0" brushRef="#br1" timeOffset="-22461.73">9144 15840 7982,'-14'-20'3276,"14"12"-1638,21 32 0,10 17-2890,-4-10 0,2 1 159,-1-7 1,2 0 0,-3-3 840,-3 4 1,-3-13-1,-2-27 1,-4-11 0,-9 1-1,1-1 1</inkml:trace>
+  <inkml:trace contextRef="#ctx0" brushRef="#br1" timeOffset="-22035.73">9513 15804 7533,'-6'-35'3276,"-1"47"-2599,-8 18 0,-5 13 0,-1 2-737,5-5 0,-1 1 0,-1 3 262,-1 1 0,-4 3 1,1-1-1,2-7-1012,-4 4 1,3-7-830,2-12 1,9-9 1557,16-16 1,12-10 0,14-8 0</inkml:trace>
+  <inkml:trace contextRef="#ctx0" brushRef="#br1" timeOffset="-21661.73">9623 16122 13379,'1'27'-1093,"0"1"1,-22 13 0,-3 2 436,15-6 1,0-1-1,-40 34 1,49-70 0</inkml:trace>
+  <inkml:trace contextRef="#ctx0" brushRef="#br1" timeOffset="-20411.73">9955 15875 7443,'-20'-37'3276,"26"11"-1638,31 19 0,13 6-1047,-4-1 1,0 4-592,2 9 0,-13 10-765,-35 7 1,-14 7 644,-7 3 0,-8 4 0,-2 1 390,6-9 0,-3 1 0,0 0 0,3-2-31,-3 5 1,3 0 0,10-4 749,10 0 1,14-9-495,25-20 0,13-12-1588,-8-1 1,4-2 0,-2 0-1,-7 3 1,0-1 0,-4 4 729,6 2 1,-16 4 0,-28 2 0,-17 11-1</inkml:trace>
+  <inkml:trace contextRef="#ctx0" brushRef="#br1" timeOffset="-19772.73">9919 16104 6903,'-40'0'3276,"22"-8"-1638,43 7 0,19 1-764,-8-2 0,3-1 1,2 0-1968,6-3 1,2-1 0,-3 4 558,-7 7 1,-2 2 0,-8-4 0,0-14 0,-51 28 0</inkml:trace>
+  <inkml:trace contextRef="#ctx0" brushRef="#br1" timeOffset="-19069.73">10546 15610 7173,'-13'-37'3276,"18"43"-2184,10 22 0,6 19 0,-4 3-568,-7-10 1,-1 3-1,-3 2 1,-2 1 0,-4 0-480,-4-4 0,-3 2 0,-3 1 0,-1-1 0,-1-1 0,2-2-865,-2 10 1,2-1 0,-3-4 0,-6-5 446,-92 55 0,111-96 1,35-10-1</inkml:trace>
+  <inkml:trace contextRef="#ctx0" brushRef="#br1" timeOffset="-17275.73">13192 15117 7353,'-25'-8'3276,"6"-2"0,7-8 0,39 8-2524,16 2 1,10 1-1846,-10 3 1,2 0 0,-1 2 623,-5 1 1,-1 0 0,-4 1 0,2-1 0,-15 4 0,-44 15 0</inkml:trace>
+  <inkml:trace contextRef="#ctx0" brushRef="#br1" timeOffset="-16811.73">13168 15275 7803,'-27'-8'3276,"48"6"-1638,12 6 0,9 0-1334,3-4 1,5-2-1,-1 0-304,-5 1 0,0 0 0,-6 1 0,2 2 0,-17 0 0,-32 2 0</inkml:trace>
+  <inkml:trace contextRef="#ctx0" brushRef="#br1" timeOffset="-15270.73">15051 14411 6903,'-13'-10'2339,"1"-21"-181,5 9-1888,1-5 2339,6 58-2250,2 9 1,-1 12 0,2 1-585,0-8 0,0 1 0,0 0 1,0-1-496,0-3 0,0 0 1,0-2-1,2-5 720,6 16 0,2-23 0,0-58 0,-4 4 0,-1-1 0</inkml:trace>
+  <inkml:trace contextRef="#ctx0" brushRef="#br1" timeOffset="-14756.73">15001 14323 7533,'-4'-38'1092,"0"-1"0,23 10 0,12 7 0,7 14 0,7 9 0,-3 10 0,-5 14 0,-3 11 0,-8 3-2000,-8 2 1,-7 3 0,-10-1 367,-12-2 0,-10-1 1,-5-8-1100,-13-2 1,1-13 1254,8-17 1,55-6 0,19-3-1,-1-1 1,-1 0 0</inkml:trace>
+  <inkml:trace contextRef="#ctx0" brushRef="#br1" timeOffset="-13357.73">15567 14340 8432,'7'-27'3276,"-1"-6"-1605,-12 21-861,-6-4-180,-2 32-181,-4-12 91,6 19-90,-1-21-630,7 6 0,-5 0 180,4-6 135,-13 32 0,1 18 164,10-7 1,5 4 0,3 2 104,1-5 1,1 2 0,3 1 0,1-4-653,2-5 1,2-1 0,1-3 0,3-6-1392,11 5 1,2-15 818,2-26 1,-28-25 0,0 21 0</inkml:trace>
+  <inkml:trace contextRef="#ctx0" brushRef="#br1" timeOffset="-12608.73">15751 14499 7623,'-6'-43'2248,"1"21"1028,10-17-345,-4 35-2661,4-11 1798,12 38-1393,9 12 0,7 7-1335,-8-9 0,2 2 1,0 1 359,3 1 0,1 1 0,-3-4-690,1 4 1,-3-7-2288,1-8 3219,-20-38 0,-5 11 1,-4-12-1</inkml:trace>
+  <inkml:trace contextRef="#ctx0" brushRef="#br1" timeOffset="-12019.73">15776 14870 7263,'-14'0'3276,"9"0"-1638,18-17 0,8-6 715,-1-2-1994,0-2 1,8-8 0,2-4 0,-3 3-428,-4 4 1,-2 0-1,1 1 1,1 0-473,3-1 0,1 1 1,-1 0-1,-1 2-553,-1-4 1,-2 3 0,-4 12 272,-3 20 1,-26 16 0,4 0 0</inkml:trace>
+  <inkml:trace contextRef="#ctx0" brushRef="#br1" timeOffset="-11138.73">16539 14323 7533,'7'-35'3276,"4"7"-1638,-9 46 0,-3 17-1140,1-3 0,0 7 0,0 1 1,0 0-1219,2-2 0,0 1 1,1-1-1,0 0-330,0 11 1,0 0 0,5-10 1049,3-11 0,4-13 0,15-31 0,-5 16 0</inkml:trace>
+  <inkml:trace contextRef="#ctx0" brushRef="#br1" timeOffset="-9443.73">16897 14429 8432,'-20'-10'3276,"13"-6"0,25 6-2594,15-3 0,11 1-975,-7 10 1,7 4 0,0 0-1,-5 0 338,7-8 0,-6 8-270,7 25 1,-20 11-136,-43-10 0,-21 2 0,1 2 570,3 4 0,-1 2 0,2-1 509,1 0 1,2-1 0,4-3-675,4-4 0,12-5 494,44 0-629,-1-24 0,9-8 0,0 0-1003,-5 3 1,0 1 0,0 1 738,1 1 1,0 2 0,-8 0 0,-5 4 0,-52 22-1</inkml:trace>
+  <inkml:trace contextRef="#ctx0" brushRef="#br1" timeOffset="-8672.73">16970 14676 7713,'-14'0'1889,"-2"0"1259,9-8 128,23 6-2621,22-2 1,11 0-1496,-7 1 1,3 1 0,-1-1-254,-3 0 1,0 0 0,-3-1 668,15 1 0,-15-4 0,-33 0 0,-12 7 0</inkml:trace>
+  <inkml:trace contextRef="#ctx0" brushRef="#br1" timeOffset="-7625.73">17561 14182 7803,'33'-30'3276,"-20"15"-1638,18 29 0,0 21-1114,-20-2 1,-5 12-1,-4 4 1,-3 1-1,1-4-1176,-2-1 0,-1-2 0,-2 0 0,0 2 148,0 3 0,1 5 1,-1-1-1,-3-4 0,-3-9 504,-17 8 0,0-20 0,10-29 0,27-25 0</inkml:trace>
+  <inkml:trace contextRef="#ctx0" brushRef="#br1" timeOffset="-6678.73">18090 14376 7533,'-1'4'3276,"-3"-6"-2457,2 25 0,6 26 0,1 10 0,-1-8-575,-3-11 1,-1-3 0,0 4-740,2 4 0,-1 6 0,2-2 1,2-12-2783,13 4 2612,-9-49 0,7-33 0,-16 23 0</inkml:trace>
+  <inkml:trace contextRef="#ctx0" brushRef="#br1" timeOffset="-6187.73">18041 14323 7533,'-3'-26'1638,"0"1"0,18-14 0,11 20 0,7 10-546,4 21 0,5 13 0,-2 3-621,-1-4 1,-2 2 0,-9 6-1565,-11 10 1,-9 5 0,-11-5 325,-13-11 1,-8-4-1,-3-4-193,-4-5 1,-2-4 0,3-3 959,-3-1 0,15-4 0,46-6 0,0 0 0,0 0 0</inkml:trace>
+  <inkml:trace contextRef="#ctx0" brushRef="#br1" timeOffset="-4704.73">18755 14252 7533,'5'-35'1349,"-3"0"-1079,3 15-270,-5 4 450,-16 32-271,6-4 361,-19 21 179,8 0 1,1 1-360,-4 3 67,10-1 0,0 11 1,2 5-1,7-5-315,7-9 1,6-1-1,0 0 1,-2 0-158,-7 4 0,-3 0 0,2 0 0,6-3-45,15 13 0,8-2 0,-2-22-3187,1-31 2904,17 8 1,-43-29-1,-21 7 1</inkml:trace>
+  <inkml:trace contextRef="#ctx0" brushRef="#br1" timeOffset="-3525.73">18951 14446 7803,'-30'-17'3276,"15"7"-2055,10 2 218,41 0-675,-5 2 1,6 2-465,-2 5 0,3 2 0,0-1-420,-2-4 0,0-2 0,-5 6-330,3 10 0,-14 8-405,-27 7 1,-13 4 1004,-5-1 0,-6 1 0,1 1 389,1 1 1,0 2 0,3-2-45,-5 8 0,10-3 1124,21 11-450,25-37-719,2-3 0,6-3-1440,7-7 1,2-6-316,3-1 1,-2-1-335,-6 4 1,-5-2 1310,-2-9 1,-48 40-1,-22 5 1</inkml:trace>
+  <inkml:trace contextRef="#ctx0" brushRef="#br1" timeOffset="-2974.73">18951 14693 7173,'-19'-17'3276,"2"-25"-1638,41 32 0,16 5-2354,-7-2 0,5 0 0,2 1 0,-2 2 716,2 3 0,-2 2 0,0 1 0,11 2 0,1 1 0,-26 2 0,-33 3 0</inkml:trace>
+  <inkml:trace contextRef="#ctx0" brushRef="#br1" timeOffset="-2176.73">19579 14164 7713,'5'-22'1638,"11"38"0,3 17-819,-7-1 0,0 6 0,-1 3 0,0-1-231,1 0 0,0 0 0,-2 2 1,-3 1-787,-4 1 0,-3 3 0,-2 1 0,-3-2 0,-2-4 78,-7 8 0,-4-4 0,-4-2-420,0-10 1,-2 1-1,-1-3 1,3-2-1100,-6 8 1,2-6 1285,2-10 1,10-10 0,30-28 0,5-13 0</inkml:trace>
+  <inkml:trace contextRef="#ctx0" brushRef="#br1" timeOffset="-90.73">14669 15452 7533,'-5'-26'1638,"32"18"0,16 4-901,-7-3 0,4-2 0,5 2-423,-8 5 1,4 1 0,2 2 0,3 0 0,1-1-1,2-1-526,-8-2 1,2 0 0,2-1 0,1-1 0,0 0 0,1 0 0,1 0 0,0 0 0,0 1 139,0 0 0,1-1 0,0 1 0,0 0 0,1 0 0,0 0 0,1 0 0,0 0 0,-1 1 0,1 0-18,-3 0 0,1 0 0,-1 1 0,1 0 0,0-1 0,0 1 0,1 1 0,-1-1 1,0 0-1,0 0 0,-1 0 90,0 0 0,0-1 0,1 1 0,-1-1 0,1 0 0,-1 0 0,0 1 0,-1 1 0,0 0 0,-1 1 0,-1 0 179,3 2 1,-2 1 0,0 1 0,-2 1 0,1 0 0,0 0 0,0 1 0,0 0 0,2 0-508,1 0 0,1 0 0,1 1 1,2 0-1,-1 0 0,-1 1 1,-1-1-1,-2 0 0,-2 0 1,-4-1 231,9 2 0,-5-1 0,-2 1 1,0-1-1,5 0 84,-5 0 1,4 1 0,1 0 0,2 0-1,-1 0 1,-1-1 0,-3-2 0,-4-1 458,10-2 0,-5-3 1,-1 0-1,3 1-462,-6 3 0,1 1 0,2 1 0,0-1 0,0 1 0,0-2-120,1-2 0,2 0 0,-1-1 0,0 0 1,-3 1-1,-4 2 674,13 4 1,-5 2 0,-3-2-308,14 1 1,-20-8-3510,-37-6 2781,-26 12 0,-22-14 0,20 8 0,0 0 0</inkml:trace>
+  <inkml:trace contextRef="#ctx0" brushRef="#br1" timeOffset="1071.27">16528 15804 7533,'-13'-9'2968,"6"9"-2249,0 28 1,3 16-450,3-2 0,1 5 0,0-1-270,0 0 0,-1 0 0,2 0-240,0 2 0,2 0 0,0-9-479,4-4-811,4-37-1747,-10-41 3268,10 4 1,-10 3-1,-1-3 1,2 7 0,1 0-1</inkml:trace>
+  <inkml:trace contextRef="#ctx0" brushRef="#br1" timeOffset="1491.27">16503 15769 7533,'5'-36'1092,"1"0"0,19 15 0,7 12 0,-3 20 0,3 12 0,-2 2-428,1 2 0,-2 2 1,-8 5-1385,-9 9 1,-9 5-1,-10-7-90,-17-5 1,-11-8-830,-7-7 1,5-10 1609,20-13 1,53-14 0,4 11 0,0 0 0</inkml:trace>
+  <inkml:trace contextRef="#ctx0" brushRef="#br1" timeOffset="1923.27">17180 15663 7533,'0'-45'3276,"-33"10"0,-3 41-2666,12 13 1,-3 12 0,0 6 0,5-1-409,7 1 0,3 1 1,4 2-1,1 2-652,3-2 0,0 3 1,4 1-1,2-3 0,4-3 450,10 9 0,6-5 0,4-8 0,12-3 0,2-13 0,-12-19 0,0 0 0</inkml:trace>
+  <inkml:trace contextRef="#ctx0" brushRef="#br1" timeOffset="3250.27">17413 15822 7713,'-13'-10'1889,"-4"-13"-990,16 11 1080,-5-13-450,6 15 450,33 2-1440,-9 7 1,4 2-495,6 2 0,7 3 0,1 0 0,-6 2-495,6 4 1,-7 6-631,-4 13 1,-17 6 1348,-30-3 1,-19 2 0,-2-2 359,8-7 1,-4-1 0,1-1 0,3 1-450,-2 6 0,4 0 0,16-6 449,47 8-1289,-4-31 1,8-6-1,-1-1-433,1 1 1,0-1 0,-2 1 506,8-1 0,-9 2 0,-20 2 1,-31-10-1</inkml:trace>
+  <inkml:trace contextRef="#ctx0" brushRef="#br1" timeOffset="3766.27">17462 15998 7803,'-39'-9'3276,"59"-7"-2929,18 16 0,13 8 0,-2-2-1277,-14-7 1,-1-2 0,1 3 838,18 4 0,2 3 1,-15-3-1,-21-4 1,-15 0-1</inkml:trace>
+  <inkml:trace contextRef="#ctx0" brushRef="#br1" timeOffset="4240.27">17980 15681 7533,'5'-41'1638,"14"53"0,2 15-546,-11 3 0,-4 7 0,-2 4-504,0 4 0,-2 4 0,-2 3 1,-5-2-1147,-2-9 0,-3 1 1,-3-1-1,-1-2 0,-1-2-535,-7 9 1,-3-5 0,-1-7 991,-8-2 1,8-17 0,20-23 0,26-1 0</inkml:trace>
+  <inkml:trace contextRef="#ctx0" brushRef="#br1" timeOffset="9767.27">7605 17515 6004,'7'0'1888,"-2"-7"-1168,-5-3 180,0 0 89,-5-6-449,3 14 539,-3-13-179,-1 5-451,5 0-449,-5 2 90,1 16 0,4 2 450,-10 15-315,9 19 0,3 10-46,-3-10 1,0 3 0,1 1-113,0-4 1,1 2 0,0 1-1,1-1-180,0-1 1,0 1 0,1-2-1,-1-5 23,-1 7 1,1-8 1258,4 2-629,-5-44-1440,-5-12-1888,4 16-181,-4 0 2969,10-16 0,5-7 0,3-5 0,3-9 0,1 0 0</inkml:trace>
+  <inkml:trace contextRef="#ctx0" brushRef="#br1" timeOffset="10354.27">7531 17533 7533,'-17'-33'3276,"8"-4"-76,20-1-1716,27 30 0,12 14-1005,-9 7 1,2 8 0,-8 6-1140,-12 6 1,-7 5 0,-9 1 359,-8-3 0,-7 0 0,-8-4 90,-16-2 0,-10-4 0,2-6 210,-5-4 0,20-8 0,32-8 0,30 0 0,1 0 0</inkml:trace>
+  <inkml:trace contextRef="#ctx0" brushRef="#br1" timeOffset="12029.27">8233 17410 6903,'7'-28'3058,"-2"11"-2068,-5 9-630,-5 31 179,-2-9 271,-5 19-810,-1-23-90,7-2 180,-5 0 180,4-6-180,-11 29 359,-12-2-269,14 1 0,4 9 45,7 0 0,4 7 0,2 3 0,2-1 224,1-6 1,3 1 0,2 1 0,0-2-1,0-3-1542,5 11 1,0-3 0,1-1-1,1 5 1,1-1 0,-3-27 437,2-63 0,-3 25 0,6-5 0</inkml:trace>
+  <inkml:trace contextRef="#ctx0" brushRef="#br1" timeOffset="12973.27">8540 17674 9242,'-12'-10'2968,"-6"-5"-2248,5 5 719,-5 0-135,30 31 0,13 13-884,1-7 0,5 1 0,0 3-600,-8-2 0,-1 2 0,1 0 0,0-2-270,8 0 0,1-2 1,-6-3-2789,1 15-39,-27-39 2720,0 0 0,0 0 0</inkml:trace>
+  <inkml:trace contextRef="#ctx0" brushRef="#br1" timeOffset="13641.27">8503 18168 10591,'-13'0'2519,"2"-16"-1080,27-11-784,2 1 0,7-10 1,5-4-1,0-1 0,-3 6-575,0 2 1,-1 3-1,1 0 1,1-3-231,-3 1 0,2-4 0,1-1 0,0 1 0,-2 2 0,-3 5-943,6-1 1,-3 4 0,-5 4-2185,4-11 2936,-3 17 1,-8 14 0,4-6 0</inkml:trace>
+  <inkml:trace contextRef="#ctx0" brushRef="#br1" timeOffset="14561.27">9451 17498 8162,'-14'-37'3276,"9"27"-2081,6 27 1,4 17-949,-1 6 1,-1 10-1,0 4 1,0-4-204,-1-10 1,0-2 0,-1 1 0,1 2 9,-1 3 0,0 4 0,1 0 0,-1-4 0,-1-8-234,0 0 0,0-7-2338,0 0 2518,0-47 0,28-15 0,-11 14 0,0 1 0</inkml:trace>
+  <inkml:trace contextRef="#ctx0" brushRef="#br1" timeOffset="16009.27">9882 17551 8162,'-7'-10'1080,"1"2"2196,1 0-2954,3 6 1027,15 23 0,13 13-2399,-1-11 1,4 0 0,-1 2 509,2 14 1,1-2 539,19-4 0,-12-19 0,-34-24 0,13-7 0</inkml:trace>
+  <inkml:trace contextRef="#ctx0" brushRef="#br1" timeOffset="16430.27">10276 17551 7533,'1'-49'3276,"-24"88"0,5-12-2788,7 2 1,-1 12-1,-1 6 1,0 0 0,0-5-714,0-1 0,0-2 0,1-1 0,-1 1-338,-1 2 1,1 2 0,-1-2 0,1-3-531,-4 2 1,0-2 0,10-20 1011,18-32 1,11-21 0,20 9 0</inkml:trace>
+  <inkml:trace contextRef="#ctx0" brushRef="#br1" timeOffset="16920.27">10386 17974 8522,'15'4'3276,"2"41"-2845,-12-8 0,-6 2-2070,-12 4 1,-7-5 1591,-1-14 1,-2-5 0,-6-3 0,38-16 0</inkml:trace>
+  <inkml:trace contextRef="#ctx0" brushRef="#br1" timeOffset="18661.27">10743 17692 7533,'-19'-10'-450,"2"2"3328,10 8 398,1-16-1676,30 10 1,7 1-1601,-6-13-60,15 12 0,13 3 0,-7 4 60,-19 3 0,-1 0-495,18 0 0,-6 2 405,-17 4-899,-43 29 719,1-8 315,4-1 0,-5 8 0,-2 3 0,1-3 674,-1 1 1,1-2 0,-1 1-600,-2 4 0,0 1 0,3-3-300,-4 11 0,10-15 719,15-31-449,2 19 1529,46-32-1919,-10 3 0,6 0 1,0-3-794,-2-2 1,0-3 0,-1 1 55,2 4 1,0 2 0,-7-1 1036,10-9 0,-62 18 0,-8 6 0</inkml:trace>
+  <inkml:trace contextRef="#ctx0" brushRef="#br1" timeOffset="19170.27">10707 17956 8342,'-34'-17'3276,"17"7"-1638,39 8 0,17 4 0,7 3 0,7 0-2458,-12-5 1,5-1 0,1-2 0,-4 1 350,1-2 1,-4 0 0,-2 0 0,12 0 0,-18 4 0,-30 4 0</inkml:trace>
+  <inkml:trace contextRef="#ctx0" brushRef="#br1" timeOffset="20056.27">11396 17515 7533,'0'-35'1259,"0"8"-180,0 1 810,22 16-251,7 35 0,2 21-1124,-17-13 0,-3 7 0,-1 4 1,-1 2-1,-2-1-724,-1-5 0,0 2 0,-2 0 0,-1 1 0,-1-1 1,-2 0-277,-1 6 0,0 2 0,-3-1 1,-2-3-1,-2-4-504,-8 9 1,-4-5 0,0-14 989,-11-16 0,37-16 0,14 0 0</inkml:trace>
+  <inkml:trace contextRef="#ctx0" brushRef="#br1" timeOffset="21293.27">12872 17956 7533,'-24'-15'3276,"10"11"0,3-28 0,60 29-1231,-20-13-2585,6 16 0,12 6 1,4 1-1,-5-4-553,-4-10 1,-3-2 0,-1 5 623,3 13 1,0 6 0,-7-6 0,9-11 0,-71 24 0,1-1 0</inkml:trace>
+  <inkml:trace contextRef="#ctx0" brushRef="#br1" timeOffset="21689.27">12872 18203 7533,'-30'0'3276,"15"0"-1638,48 0 0,22 0-764,-23 0 0,2 0 0,2 0-874,7 1 0,4 0 0,0-1 0,-6-2 0,8-4 0,-8-3 0,-13-1 0,-1 0 0</inkml:trace>
+  <inkml:trace contextRef="#ctx0" brushRef="#br1" timeOffset="22774.27">14644 17833 7173,'-12'-28'3276,"0"3"-1425,5 39-1192,5 17 1,3 13 0,0 4-413,-1-2 0,0 3 1,0 2-1,1-1-562,0-1 0,1 0 1,0-1-1,-1-2-778,-3 15 1,0-3 0,6-28 991,1-30 1,8-31 0,-4 0 0,1 1 0</inkml:trace>
+  <inkml:trace contextRef="#ctx0" brushRef="#br1" timeOffset="23254.27">14582 17674 7533,'13'-45'1092,"-1"0"0,26 22 0,11 15-273,-15 12 0,3 7 0,0 6 0,-3 4-164,-2 5 1,-1 5 0,-5 5-1,-7 0-948,-8 2 1,-5 2 0,-5 0 0,-8-3-308,-15 4 1,-10-5-1,-3-5-420,-1-10 1,-3-4 0,3-6 1019,-6-5 0,18-7 0,49-6 0,8 7 0,0 0 0</inkml:trace>
+  <inkml:trace contextRef="#ctx0" brushRef="#br1" timeOffset="24146.27">15518 17639 7533,'3'-45'2338,"-44"57"-1918,11 7 0,-3 9 0,1 5 83,9-3 1,-1 4 0,2 3-1,4 1 1,6 1-905,7 3 1,7 3-1,4 0 1,0-1-1,-2-2 401,-6-2 0,-2 0 0,3-3 0,10-3-820,19 1 1,13-2 0,2-4 0,-11-7 414,3 6 0,11-24 0,-42-8 0</inkml:trace>
+  <inkml:trace contextRef="#ctx0" brushRef="#br1" timeOffset="24646.27">15740 17798 7533,'-7'-36'1889,"2"17"629,15 42-1214,1 13 1,3 9-1961,0-13 1,4 6-1,2 1 1,-1-1 0,-3-3 30,0 3 0,-3-2 1,4 0-173,2-1 0,5 3 0,-1-5 0,-6-12-1632,-3-13 2429,-2-8 0,-17 0 0,-9 0 0</inkml:trace>
+  <inkml:trace contextRef="#ctx0" brushRef="#br1" timeOffset="25090.27">15628 18292 6903,'-25'0'1638,"35"-26"0,17-11-983,-4 13 0,6-2 1,3-1-1,2-1 0,-2 0-257,3-5 1,0-1 0,1-1-1,0 0 1,0 1-1055,1 1 1,1-1-1,-1 1 1,-1 1 0,-4 3 361,4-2 1,-3 2 0,-10 5 0,-6 1-1,-17 23 1</inkml:trace>
+  <inkml:trace contextRef="#ctx0" brushRef="#br1" timeOffset="25909.27">16528 17727 7533,'5'-41'2608,"1"10"668,6 11-2036,-7 40 1,-3 19-927,1-3 1,-2 8 0,1 3 0,-2 0-477,-1-6 0,-2 1 0,0 0 0,1 0 1,0-1-357,1 5 1,0 0 0,1-3 0,-1-4-743,-5 17 1,6-23 1259,18-45 0,-5-11 0,1-5 0,4 0 0,1 1 0</inkml:trace>
+  <inkml:trace contextRef="#ctx0" brushRef="#br1" timeOffset="27004.27">17057 17833 6993,'-14'-20'2698,"-3"-11"-719,16 19 0,12-21-809,26 21-631,8 6 1,6 4-360,-15 6 0,2 3 0,-2 0-360,0-1 0,-1 0 0,-3 2 45,5 2 0,-15 5-180,-33 4 0,-13 3-15,-2 2 1,-4 3-1,-2 1 487,3-4 1,-2 1-1,-1 1 1,2 0 201,-1 1 1,0 0 0,2 0 0,2 0-240,1 3 0,3-1 0,4-2 104,1 2 1,12-5 1215,47 4-1306,-13-18 1,5-4-315,7-8 0,5-5 1,-1 0-751,-4 3 1,0 0-1,-2 0-163,0-2 1,-1 0 0,-4 0-547,1 2 1,-9 1 1275,-15 3 0,-34-8 1,-2-2-1</inkml:trace>
+  <inkml:trace contextRef="#ctx0" brushRef="#br1" timeOffset="27475.27">17032 18045 7533,'-41'-8'3276,"23"6"-1638,52 1 0,24 2-1874,-19-1 1,2 1 0,3 0-585,-1 0 1,2 2 0,1-1 0,-4 0 555,0-1 1,-3-1 0,-7-1 0,-3-7-1,-25-2 1</inkml:trace>
+  <inkml:trace contextRef="#ctx0" brushRef="#br1" timeOffset="28221.27">17782 17515 7533,'6'-47'1092,"15"66"0,10 23 0,-5-3 546,-10-17 0,-2 5-1715,-5 4 1,1 10 0,-1 8 0,0 4 0,-2 1 0,-1-3 0,-2-6 0,-2-10-14,-4 9 0,-7-2-379,-1-7 1,-4 8 0,-4 5 0,0 1 0,-1-4 0,1-7 0,3-12-2587,-18 6 3215,2-9 1,-6 3-1,18-3 1,35 3-1,4 1 1</inkml:trace>
+  <inkml:trace contextRef="#ctx0" brushRef="#br1" timeOffset="33354.27">6867 17110 7533,'-7'-28'-1170,"13"11"1170,23 9 90,-2 11 0,3 2 90,13-4 0,5 0-90,-3 1 0,3 1 0,-1-1-366,-7-1 0,-1-1 0,2-1 343,3 1 1,4 0-1,0 0 1,-2 0-181,1 1 1,-1-1-1,4-1 149,-6 0 0,4 0 0,2-1 0,1 0 0,-2 1-190,-2 0 1,-2 1 0,0 0 0,3 0 0,4-1 133,-8-1 0,2-1 0,3-1 0,2 0 0,1 0 0,0 0 0,0 0 0,-1 0 0,-1 1-165,-4 1 0,0 1 0,-1-1 0,0 1 1,0 0-1,0 0 0,2 0 0,0-1 1,2 0 184,-6-1 0,1 0 0,1 0 0,1 0 0,0-1 0,1 1 0,0-1 0,1 0 0,-1 0 0,1 1 0,0-1 0,0 0 41,-1 1 1,1 0-1,0-1 1,0 1-1,0-1 1,1 1-1,-1-1 1,1 1-1,0 0 1,0-1-1,1 1 1,-1 0-1,0 0-29,-2 1 1,0-1 0,1 1 0,-1-1 0,1 1 0,0 0 0,0 0 0,-1 0 0,1 0 0,0 0 0,0 0-1,0-1 1,0 1 0,1 0-20,0 0 1,0-1-1,1 0 1,1 1 0,-1-1-1,1 0 1,-1 1 0,0-1-1,0 1 1,-1-1-1,-1 1 1,-1 0 0,-1 0-1,-1 1 7,4-1 0,-2 1 0,-1 0 0,-1 0 0,-1 0 0,0 1 0,0-1 0,0 1 0,1-1 0,1 1 9,2-1 0,1 1 0,0 0 0,0 1 0,1-1 0,0 0 0,-1 0 0,0 0 0,0 0 0,0 0-18,-4-1 0,0 1 0,0-1 0,-1 0 0,0 0 0,1 0 0,0 0 0,0 0 0,2 1 0,1-1-5,-4 1 0,1-1 0,0 1 0,0 0 1,1 0-1,1-1 0,0 1 0,0 0 1,2 0-1,0 0 0,0 0 0,1 0 0,1 0 14,-6 0 0,0 0 0,2 0 0,0-1 0,1 1 0,0 0 0,1 0 0,1 0 0,-1-1 0,1 1 0,-1 0 0,0 0 0,0 0 0,0 0 0,-2 1 0,0-1 0,-1 0 0,-1 1-142,8 0 1,-1 0-1,-1 0 1,-1 0-1,-1 1 1,0-1-1,0 0 1,0 1-1,-1 0 1,1-1 0,1 1-1,0-1 1,0 1 141,-3-1 0,0 0 0,1 0 0,-1 0 0,1 0 0,1 1 0,-1-1 0,0 0 0,0 0 0,0 0 0,0 1 0,-1-1 0,-1 1 0,0-1 0,-1 1 0,6 1 0,-1-1 0,-1 1 0,1 0 0,-2 0 0,1 0 0,-1 0 0,-1 0 0,0 0 0,0 0 0,-1-1 0,0 1-82,3-1 1,0 0 0,-2 0 0,0 0 0,0 0 0,-1-1 0,1 1 0,-1 0 0,1 0 0,0 0 81,2 0 0,0 1 0,-1-1 0,1 1 0,0-1 0,0 1 0,0 0 0,-1-1 0,0 1 0,0 0-37,1-1 0,1 1 0,0 0 1,-1 0-1,0 0 0,-1 0 0,0 0 1,-1-1-1,-1 1 88,5 0 0,-2 0 1,0-1-1,-1 1 1,-1 0-1,1 0 1,0 0 52,0 0 0,2 0 1,-1 1-1,0-1 1,-2 1-1,-1 0 1,-4 0-83,10 2 1,-4 1-1,-2-1 1,-3 1 449,1-2 0,-2 0 0,-7 4-1552,-5 11 1,-9 1 1079,-8 1 0,-3 3 0,-3-17 0</inkml:trace>
+  <inkml:trace contextRef="#ctx0" brushRef="#br1" timeOffset="36299.27">18718 17163 6183,'-20'-26'0,"8"14"810,7-27-90,10 25-451,2-19-808,5 23 1168,-5 42-359,-3 2 0,-2 12-219,-4-9 0,-2 7 1,-1 6-1,-1 3 1,0 1-1,0-1 1,2-5-82,1-2 0,1-3 0,1-1 0,-1 1 0,0 2 0,-2 3-79,0-3 1,-1 4 0,-1 3 0,-1 1-1,1 1 1,0-2 0,1-1 0,1-4 0,2-3 0,3 3 0,2-3 0,0-3 0,1 0 0,-1-1-140,-2 10 1,-2 0 0,2-4 0,3-6 426,7 0 1,2-7 720,4 8 179,-16-33-1618,5-8 179,-17 0 540,-24 0 114,4 2 1,-6 1 0,-8 0-183,7-3 0,-6 0 1,-5-1-1,-3 0 1,-2-1-1,0 1 1,1 0-1,2 1-112,4 0 0,1 1 0,0 0 0,0 0 0,-1 0 0,0 0 0,-3-1 0,-1 1-178,6-1 1,-1-1 0,-3 1 0,0-1 0,-2 0 0,1 0 0,-2 0-1,2 0 1,-1 1 0,2-1 0,1 0 0,1 1 227,-4 0 0,0-1 0,1 1 0,2 0 0,-1 0 0,1 0 0,0 0 0,0 0 0,-2 1-68,5-1 0,0 1 0,0-1 0,-1 1 0,1 0 0,0-1 0,-1 1 0,1 0 0,0 0 0,0 1-93,-4-1 1,1 1 0,1 0 0,-1-1 0,0 1 0,0 1 0,0-1 0,-1 0 0,-1 0 77,4 1 0,0-1 1,-1 0-1,0 1 0,0-1 1,-1 1-1,0-1 0,0 1 1,1 0-1,0-1 0,0 1 24,-2 0 0,0-1 0,1 1 0,-1 0 0,1 0 0,0-1 0,-1 1 0,1 0 0,-1 0 0,-1-1-73,3 1 0,-1-1 0,-1 1 0,0-1 0,1 0 0,-1 1 1,0-1-1,0 0 0,0 1 0,1-1 0,0 0 122,2 0 1,1-1 0,0 1 0,1 0 0,0 0 0,-1-1 0,0 1 0,0-1 0,-2 1 0,0-1 0,-2 0-47,5 0 0,-1 0 0,-1 0 0,-1 0 0,-1 0 0,-1-1 0,0 1 0,0-1 0,0 1 0,1-1 0,0 1 0,0-1 0,2 1 0,0 0 0,2-1-3,-5 1 1,2 0 0,1 0 0,1 0 0,1 0 0,0 0 0,-1-1-1,-1 1 1,-1 0 0,-2-1 0,-3 0 48,9 0 0,-3-1 0,-1 1 0,-3-1 0,0 0 0,-1 0 0,-2 0 0,1 0 0,-1 0 0,0 0 0,1 0 0,0 0 0,1 0 0,2 0 0,1 0 0,1 0 0,3 0 0,2 0-70,-14 1 0,3-1 0,4 1 0,2 0 0,0-1 0,0 1 0,-1 0 0,-2-1 0,-3 0 23,8 1 1,-1-1-1,-3-1 1,0 1-1,-2-1 1,0 1 0,0-1-1,-1 1 1,1 0-1,1-1 1,1 1 0,1 1-1,3-1 1,1 1 6,-6 0 0,4 0 0,1 1 0,2 0 0,0 0 0,0 1 0,-1-1 0,-3 0 0,-2 0 25,6-1 1,-2 0 0,-3 0-1,0 0 1,-2 1 0,0-1 0,-1 0-1,0 0 1,1 0 0,0 0-1,2 0 1,1 0 0,1 0 0,3 0-46,-7 1 0,3 0 0,2 0 0,1 0 0,0 0 0,1 0 0,-2 0 0,-1 0 0,-3-1 6,6 0 0,-3 0 0,-1 0 0,-2-1 0,-1 0 1,0 1-1,0-1 0,1 0 0,1 0 0,2 0 0,2 1 1,2-1-1,4 0 41,-10 1 1,4 0-1,3 0 1,2-1-1,-1 1 1,-2 0-58,-5-2 0,-1 1 0,-1-1 0,1 1 0,1 0 0,4 0-60,-2 0 0,4 1 0,0 0 0,-4 1-112,2 0 0,-5 0 0,-2 0 0,1 1 0,3-1 0,6 1 202,-5-2 0,6 1 0,-4-1 177,-4 2 0,-8 0 0,-1 0 0,7-1 0,14 0 93,4-1 386,-3 2 1,5-4-927,18-6 15,11 7 705,-6-15 2312,-1 6-2851,-11 0-1,-1 2 90,0 8 449,6 0-898,8 0 359,5 0 1349,0 0-2069,-5 0 1350,4-7-225,-2-17 0,1-9-225,3-1 0,1-5 0,0-4-252,-4 3 0,0-3 0,-2-3 0,1 0 0,-1 2 297,-1-5 0,0 1 0,0 1 0,-1-1-46,0 5 1,0-2 0,-1 1 0,0 2 0,0 4-90,-1-4 0,-1 5 0,1 0 30,2 2 0,0 0 0,2 1 60,0-6 0,1 0-45,-3-3 0,0 0 45,2 3 0,1-1-90,4 2 0,1-2 0,1 2-135,-2-2 0,0 2-315,3 4 1,0 0-1,-1 5 450,-3-8 0,22 21 0,6 19 0</inkml:trace>
 </inkml:ink>
 </file>
 
@@ -2937,7 +2489,7 @@
           <a:p>
             <a:fld id="{942376A3-60EE-9D4E-A7A1-CB0D7A163B62}" type="datetimeFigureOut">
               <a:rPr lang="en-US" smtClean="0"/>
-              <a:t>11/3/25</a:t>
+              <a:t>11/20/25</a:t>
             </a:fld>
             <a:endParaRPr lang="en-US"/>
           </a:p>
@@ -3295,7 +2847,7 @@
           <a:p>
             <a:fld id="{4C116C9C-3AD8-BF4F-8988-7C4865BA5A81}" type="slidenum">
               <a:rPr lang="en-US" smtClean="0"/>
-              <a:t>5</a:t>
+              <a:t>4</a:t>
             </a:fld>
             <a:endParaRPr lang="en-US"/>
           </a:p>
@@ -9450,72 +9002,12 @@
           <a:chExt cx="0" cy="0"/>
         </a:xfrm>
       </p:grpSpPr>
-      <p:pic>
-        <p:nvPicPr>
-          <p:cNvPr id="9" name="Picture 8">
-            <a:extLst>
-              <a:ext uri="{FF2B5EF4-FFF2-40B4-BE49-F238E27FC236}">
-                <a16:creationId xmlns:a16="http://schemas.microsoft.com/office/drawing/2014/main" id="{1EE68711-7769-3453-19DD-2CCC9433D1AE}"/>
-              </a:ext>
-            </a:extLst>
-          </p:cNvPr>
-          <p:cNvPicPr>
-            <a:picLocks noChangeAspect="1"/>
-          </p:cNvPicPr>
-          <p:nvPr/>
-        </p:nvPicPr>
-        <p:blipFill>
-          <a:blip r:embed="rId2"/>
-          <a:stretch>
-            <a:fillRect/>
-          </a:stretch>
-        </p:blipFill>
-        <p:spPr>
-          <a:xfrm>
-            <a:off x="3985985" y="1318985"/>
-            <a:ext cx="4220029" cy="4220029"/>
-          </a:xfrm>
-          <a:prstGeom prst="rect">
-            <a:avLst/>
-          </a:prstGeom>
-        </p:spPr>
-      </p:pic>
-    </p:spTree>
-    <p:extLst>
-      <p:ext uri="{BB962C8B-B14F-4D97-AF65-F5344CB8AC3E}">
-        <p14:creationId xmlns:p14="http://schemas.microsoft.com/office/powerpoint/2010/main" val="1861590098"/>
-      </p:ext>
-    </p:extLst>
-  </p:cSld>
-  <p:clrMapOvr>
-    <a:masterClrMapping/>
-  </p:clrMapOvr>
-</p:sld>
-</file>
-
-<file path=ppt/slides/slide10.xml><?xml version="1.0" encoding="utf-8"?>
-<p:sld xmlns:a="http://schemas.openxmlformats.org/drawingml/2006/main" xmlns:r="http://schemas.openxmlformats.org/officeDocument/2006/relationships" xmlns:p="http://schemas.openxmlformats.org/presentationml/2006/main">
-  <p:cSld>
-    <p:spTree>
-      <p:nvGrpSpPr>
-        <p:cNvPr id="1" name=""/>
-        <p:cNvGrpSpPr/>
-        <p:nvPr/>
-      </p:nvGrpSpPr>
-      <p:grpSpPr>
-        <a:xfrm>
-          <a:off x="0" y="0"/>
-          <a:ext cx="0" cy="0"/>
-          <a:chOff x="0" y="0"/>
-          <a:chExt cx="0" cy="0"/>
-        </a:xfrm>
-      </p:grpSpPr>
       <p:sp>
         <p:nvSpPr>
           <p:cNvPr id="2" name="Title 1">
             <a:extLst>
               <a:ext uri="{FF2B5EF4-FFF2-40B4-BE49-F238E27FC236}">
-                <a16:creationId xmlns:a16="http://schemas.microsoft.com/office/drawing/2014/main" id="{CB1FE586-309D-8744-0C5B-B06AF8DE16AC}"/>
+                <a16:creationId xmlns:a16="http://schemas.microsoft.com/office/drawing/2014/main" id="{EB5A895E-1EAA-44A2-FB0E-BBBFEE03B28B}"/>
               </a:ext>
             </a:extLst>
           </p:cNvPr>
@@ -9531,10 +9023,7 @@
           <a:bodyPr/>
           <a:lstStyle/>
           <a:p>
-            <a:r>
-              <a:rPr lang="en-US" dirty="0"/>
-              <a:t>Bayes Rule</a:t>
-            </a:r>
+            <a:endParaRPr lang="en-US"/>
           </a:p>
         </p:txBody>
       </p:sp>
@@ -9543,7 +9032,7 @@
           <p:cNvPr id="3" name="Text Placeholder 2">
             <a:extLst>
               <a:ext uri="{FF2B5EF4-FFF2-40B4-BE49-F238E27FC236}">
-                <a16:creationId xmlns:a16="http://schemas.microsoft.com/office/drawing/2014/main" id="{A09C2D87-C1F4-9022-AD15-FB19642BEBB5}"/>
+                <a16:creationId xmlns:a16="http://schemas.microsoft.com/office/drawing/2014/main" id="{A43D44EA-7AFB-5579-4377-75C08919BACF}"/>
               </a:ext>
             </a:extLst>
           </p:cNvPr>
@@ -9556,19 +9045,21 @@
         </p:nvSpPr>
         <p:spPr/>
         <p:txBody>
-          <a:bodyPr/>
+          <a:bodyPr>
+            <a:normAutofit fontScale="92500" lnSpcReduction="10000"/>
+          </a:bodyPr>
           <a:lstStyle/>
           <a:p>
-            <a:endParaRPr lang="en-US" dirty="0"/>
+            <a:endParaRPr lang="en-US"/>
           </a:p>
         </p:txBody>
       </p:sp>
       <p:sp>
         <p:nvSpPr>
-          <p:cNvPr id="4" name="Slide Number Placeholder 3">
+          <p:cNvPr id="4" name="Text Placeholder 3">
             <a:extLst>
               <a:ext uri="{FF2B5EF4-FFF2-40B4-BE49-F238E27FC236}">
-                <a16:creationId xmlns:a16="http://schemas.microsoft.com/office/drawing/2014/main" id="{BFD39F3B-2DCB-DEB2-0222-34AF3B45462F}"/>
+                <a16:creationId xmlns:a16="http://schemas.microsoft.com/office/drawing/2014/main" id="{A01EB055-0F82-6583-C82C-8FF0F4976EE6}"/>
               </a:ext>
             </a:extLst>
           </p:cNvPr>
@@ -9576,7 +9067,7 @@
             <a:spLocks noGrp="1"/>
           </p:cNvSpPr>
           <p:nvPr>
-            <p:ph type="sldNum" sz="quarter" idx="12"/>
+            <p:ph type="body" sz="quarter" idx="11"/>
           </p:nvPr>
         </p:nvSpPr>
         <p:spPr/>
@@ -9584,70 +9075,14 @@
           <a:bodyPr/>
           <a:lstStyle/>
           <a:p>
-            <a:fld id="{FE9C85F8-0BD3-7742-B238-5BE9A2749A8F}" type="slidenum">
-              <a:rPr lang="en-US" smtClean="0"/>
-              <a:pPr/>
-              <a:t>10</a:t>
-            </a:fld>
-            <a:endParaRPr lang="en-US" dirty="0"/>
+            <a:endParaRPr lang="en-US"/>
           </a:p>
         </p:txBody>
       </p:sp>
-      <mc:AlternateContent xmlns:mc="http://schemas.openxmlformats.org/markup-compatibility/2006">
-        <mc:Choice xmlns:p14="http://schemas.microsoft.com/office/powerpoint/2010/main" Requires="p14">
-          <p:contentPart p14:bwMode="auto" r:id="rId2">
-            <p14:nvContentPartPr>
-              <p14:cNvPr id="5" name="Ink 4">
-                <a:extLst>
-                  <a:ext uri="{FF2B5EF4-FFF2-40B4-BE49-F238E27FC236}">
-                    <a16:creationId xmlns:a16="http://schemas.microsoft.com/office/drawing/2014/main" id="{50E4995C-95F0-54EA-EB36-A5B2F5038B7E}"/>
-                  </a:ext>
-                </a:extLst>
-              </p14:cNvPr>
-              <p14:cNvContentPartPr/>
-              <p14:nvPr/>
-            </p14:nvContentPartPr>
-            <p14:xfrm>
-              <a:off x="679320" y="1276200"/>
-              <a:ext cx="10510200" cy="5382720"/>
-            </p14:xfrm>
-          </p:contentPart>
-        </mc:Choice>
-        <mc:Fallback>
-          <p:pic>
-            <p:nvPicPr>
-              <p:cNvPr id="5" name="Ink 4">
-                <a:extLst>
-                  <a:ext uri="{FF2B5EF4-FFF2-40B4-BE49-F238E27FC236}">
-                    <a16:creationId xmlns:a16="http://schemas.microsoft.com/office/drawing/2014/main" id="{50E4995C-95F0-54EA-EB36-A5B2F5038B7E}"/>
-                  </a:ext>
-                </a:extLst>
-              </p:cNvPr>
-              <p:cNvPicPr/>
-              <p:nvPr/>
-            </p:nvPicPr>
-            <p:blipFill>
-              <a:blip r:embed="rId3"/>
-              <a:stretch>
-                <a:fillRect/>
-              </a:stretch>
-            </p:blipFill>
-            <p:spPr>
-              <a:xfrm>
-                <a:off x="663120" y="1260000"/>
-                <a:ext cx="10542600" cy="5420520"/>
-              </a:xfrm>
-              <a:prstGeom prst="rect">
-                <a:avLst/>
-              </a:prstGeom>
-            </p:spPr>
-          </p:pic>
-        </mc:Fallback>
-      </mc:AlternateContent>
     </p:spTree>
     <p:extLst>
       <p:ext uri="{BB962C8B-B14F-4D97-AF65-F5344CB8AC3E}">
-        <p14:creationId xmlns:p14="http://schemas.microsoft.com/office/powerpoint/2010/main" val="2465979426"/>
+        <p14:creationId xmlns:p14="http://schemas.microsoft.com/office/powerpoint/2010/main" val="1861047447"/>
       </p:ext>
     </p:extLst>
   </p:cSld>
@@ -9657,7 +9092,7 @@
 </p:sld>
 </file>
 
-<file path=ppt/slides/slide11.xml><?xml version="1.0" encoding="utf-8"?>
+<file path=ppt/slides/slide10.xml><?xml version="1.0" encoding="utf-8"?>
 <p:sld xmlns:a="http://schemas.openxmlformats.org/drawingml/2006/main" xmlns:r="http://schemas.openxmlformats.org/officeDocument/2006/relationships" xmlns:p="http://schemas.openxmlformats.org/presentationml/2006/main">
   <p:cSld>
     <p:spTree>
@@ -9729,7 +9164,7 @@
             <a:fld id="{FE9C85F8-0BD3-7742-B238-5BE9A2749A8F}" type="slidenum">
               <a:rPr lang="en-US" smtClean="0"/>
               <a:pPr/>
-              <a:t>11</a:t>
+              <a:t>10</a:t>
             </a:fld>
             <a:endParaRPr lang="en-US" dirty="0"/>
           </a:p>
@@ -9748,7 +9183,7 @@
 </p:sld>
 </file>
 
-<file path=ppt/slides/slide12.xml><?xml version="1.0" encoding="utf-8"?>
+<file path=ppt/slides/slide11.xml><?xml version="1.0" encoding="utf-8"?>
 <p:sld xmlns:a="http://schemas.openxmlformats.org/drawingml/2006/main" xmlns:r="http://schemas.openxmlformats.org/officeDocument/2006/relationships" xmlns:p="http://schemas.openxmlformats.org/presentationml/2006/main">
   <p:cSld>
     <p:spTree>
@@ -9946,7 +9381,7 @@
             <a:fld id="{FE9C85F8-0BD3-7742-B238-5BE9A2749A8F}" type="slidenum">
               <a:rPr lang="en-US" smtClean="0"/>
               <a:pPr/>
-              <a:t>12</a:t>
+              <a:t>11</a:t>
             </a:fld>
             <a:endParaRPr lang="en-US" dirty="0"/>
           </a:p>
@@ -9965,7 +9400,7 @@
 </p:sld>
 </file>
 
-<file path=ppt/slides/slide13.xml><?xml version="1.0" encoding="utf-8"?>
+<file path=ppt/slides/slide12.xml><?xml version="1.0" encoding="utf-8"?>
 <p:sld xmlns:a="http://schemas.openxmlformats.org/drawingml/2006/main" xmlns:r="http://schemas.openxmlformats.org/officeDocument/2006/relationships" xmlns:p="http://schemas.openxmlformats.org/presentationml/2006/main">
   <p:cSld>
     <p:spTree>
@@ -10064,14 +9499,14 @@
             <a:fld id="{FE9C85F8-0BD3-7742-B238-5BE9A2749A8F}" type="slidenum">
               <a:rPr lang="en-US" smtClean="0"/>
               <a:pPr/>
-              <a:t>13</a:t>
+              <a:t>12</a:t>
             </a:fld>
             <a:endParaRPr lang="en-US" dirty="0"/>
           </a:p>
         </p:txBody>
       </p:sp>
-      <mc:AlternateContent xmlns:mc="http://schemas.openxmlformats.org/markup-compatibility/2006">
-        <mc:Choice xmlns:p14="http://schemas.microsoft.com/office/powerpoint/2010/main" Requires="p14">
+      <mc:AlternateContent xmlns:mc="http://schemas.openxmlformats.org/markup-compatibility/2006" xmlns:p14="http://schemas.microsoft.com/office/powerpoint/2010/main">
+        <mc:Choice Requires="p14">
           <p:contentPart p14:bwMode="auto" r:id="rId2">
             <p14:nvContentPartPr>
               <p14:cNvPr id="5" name="Ink 4">
@@ -10090,7 +9525,7 @@
             </p14:xfrm>
           </p:contentPart>
         </mc:Choice>
-        <mc:Fallback>
+        <mc:Fallback xmlns="">
           <p:pic>
             <p:nvPicPr>
               <p:cNvPr id="5" name="Ink 4">
@@ -10134,7 +9569,7 @@
 </p:sld>
 </file>
 
-<file path=ppt/slides/slide14.xml><?xml version="1.0" encoding="utf-8"?>
+<file path=ppt/slides/slide13.xml><?xml version="1.0" encoding="utf-8"?>
 <p:sld xmlns:a="http://schemas.openxmlformats.org/drawingml/2006/main" xmlns:r="http://schemas.openxmlformats.org/officeDocument/2006/relationships" xmlns:p="http://schemas.openxmlformats.org/presentationml/2006/main">
   <p:cSld>
     <p:spTree>
@@ -10239,14 +9674,14 @@
             <a:fld id="{FE9C85F8-0BD3-7742-B238-5BE9A2749A8F}" type="slidenum">
               <a:rPr lang="en-US" smtClean="0"/>
               <a:pPr/>
-              <a:t>14</a:t>
+              <a:t>13</a:t>
             </a:fld>
             <a:endParaRPr lang="en-US" dirty="0"/>
           </a:p>
         </p:txBody>
       </p:sp>
-      <mc:AlternateContent xmlns:mc="http://schemas.openxmlformats.org/markup-compatibility/2006">
-        <mc:Choice xmlns:p14="http://schemas.microsoft.com/office/powerpoint/2010/main" Requires="p14">
+      <mc:AlternateContent xmlns:mc="http://schemas.openxmlformats.org/markup-compatibility/2006" xmlns:p14="http://schemas.microsoft.com/office/powerpoint/2010/main">
+        <mc:Choice Requires="p14">
           <p:contentPart p14:bwMode="auto" r:id="rId2">
             <p14:nvContentPartPr>
               <p14:cNvPr id="5" name="Ink 4">
@@ -10265,7 +9700,7 @@
             </p14:xfrm>
           </p:contentPart>
         </mc:Choice>
-        <mc:Fallback>
+        <mc:Fallback xmlns="">
           <p:pic>
             <p:nvPicPr>
               <p:cNvPr id="5" name="Ink 4">
@@ -10309,7 +9744,7 @@
 </p:sld>
 </file>
 
-<file path=ppt/slides/slide15.xml><?xml version="1.0" encoding="utf-8"?>
+<file path=ppt/slides/slide14.xml><?xml version="1.0" encoding="utf-8"?>
 <p:sld xmlns:a="http://schemas.openxmlformats.org/drawingml/2006/main" xmlns:r="http://schemas.openxmlformats.org/officeDocument/2006/relationships" xmlns:p="http://schemas.openxmlformats.org/presentationml/2006/main">
   <p:cSld>
     <p:spTree>
@@ -10414,7 +9849,7 @@
             <a:fld id="{FE9C85F8-0BD3-7742-B238-5BE9A2749A8F}" type="slidenum">
               <a:rPr lang="en-US" smtClean="0"/>
               <a:pPr/>
-              <a:t>15</a:t>
+              <a:t>14</a:t>
             </a:fld>
             <a:endParaRPr lang="en-US" dirty="0"/>
           </a:p>
@@ -10433,7 +9868,7 @@
 </p:sld>
 </file>
 
-<file path=ppt/slides/slide16.xml><?xml version="1.0" encoding="utf-8"?>
+<file path=ppt/slides/slide15.xml><?xml version="1.0" encoding="utf-8"?>
 <p:sld xmlns:a="http://schemas.openxmlformats.org/drawingml/2006/main" xmlns:r="http://schemas.openxmlformats.org/officeDocument/2006/relationships" xmlns:p="http://schemas.openxmlformats.org/presentationml/2006/main">
   <p:cSld>
     <p:spTree>
@@ -10526,7 +9961,7 @@
             <a:fld id="{FE9C85F8-0BD3-7742-B238-5BE9A2749A8F}" type="slidenum">
               <a:rPr lang="en-US" smtClean="0"/>
               <a:pPr/>
-              <a:t>16</a:t>
+              <a:t>15</a:t>
             </a:fld>
             <a:endParaRPr lang="en-US" dirty="0"/>
           </a:p>
@@ -10567,7 +10002,7 @@
           <p:cNvPr id="2" name="Title 1">
             <a:extLst>
               <a:ext uri="{FF2B5EF4-FFF2-40B4-BE49-F238E27FC236}">
-                <a16:creationId xmlns:a16="http://schemas.microsoft.com/office/drawing/2014/main" id="{EB5A895E-1EAA-44A2-FB0E-BBBFEE03B28B}"/>
+                <a16:creationId xmlns:a16="http://schemas.microsoft.com/office/drawing/2014/main" id="{348F3CE4-0F52-90C9-A39B-8038F1F2B8D4}"/>
               </a:ext>
             </a:extLst>
           </p:cNvPr>
@@ -10578,12 +10013,20 @@
             <p:ph type="title"/>
           </p:nvPr>
         </p:nvSpPr>
-        <p:spPr/>
+        <p:spPr>
+          <a:xfrm>
+            <a:off x="838199" y="381419"/>
+            <a:ext cx="10969487" cy="632219"/>
+          </a:xfrm>
+        </p:spPr>
         <p:txBody>
           <a:bodyPr/>
           <a:lstStyle/>
           <a:p>
-            <a:endParaRPr lang="en-US"/>
+            <a:r>
+              <a:rPr lang="en-US" dirty="0"/>
+              <a:t>Introduction to Probabilistic Reasoning</a:t>
+            </a:r>
           </a:p>
         </p:txBody>
       </p:sp>
@@ -10592,7 +10035,7 @@
           <p:cNvPr id="3" name="Text Placeholder 2">
             <a:extLst>
               <a:ext uri="{FF2B5EF4-FFF2-40B4-BE49-F238E27FC236}">
-                <a16:creationId xmlns:a16="http://schemas.microsoft.com/office/drawing/2014/main" id="{A43D44EA-7AFB-5579-4377-75C08919BACF}"/>
+                <a16:creationId xmlns:a16="http://schemas.microsoft.com/office/drawing/2014/main" id="{9B9575F1-7E0C-85E9-02FA-D94661C6B1BB}"/>
               </a:ext>
             </a:extLst>
           </p:cNvPr>
@@ -10606,20 +10049,144 @@
         <p:spPr/>
         <p:txBody>
           <a:bodyPr>
-            <a:normAutofit fontScale="92500" lnSpcReduction="10000"/>
+            <a:normAutofit/>
           </a:bodyPr>
           <a:lstStyle/>
           <a:p>
-            <a:endParaRPr lang="en-US"/>
+            <a:pPr marL="285750" indent="-285750">
+              <a:buFont typeface="Arial" panose="020B0604020202020204" pitchFamily="34" charset="0"/>
+              <a:buChar char="•"/>
+            </a:pPr>
+            <a:r>
+              <a:rPr lang="en-US" sz="2400" dirty="0">
+                <a:solidFill>
+                  <a:schemeClr val="tx2"/>
+                </a:solidFill>
+              </a:rPr>
+              <a:t>Logic and Knowledge Graphs are about statements of fact</a:t>
+            </a:r>
+          </a:p>
+          <a:p>
+            <a:pPr marL="285750" indent="-285750">
+              <a:buFont typeface="Arial" panose="020B0604020202020204" pitchFamily="34" charset="0"/>
+              <a:buChar char="•"/>
+            </a:pPr>
+            <a:endParaRPr lang="en-US" sz="2400" dirty="0">
+              <a:solidFill>
+                <a:schemeClr val="tx2"/>
+              </a:solidFill>
+            </a:endParaRPr>
+          </a:p>
+          <a:p>
+            <a:pPr marL="285750" indent="-285750">
+              <a:buFont typeface="Arial" panose="020B0604020202020204" pitchFamily="34" charset="0"/>
+              <a:buChar char="•"/>
+            </a:pPr>
+            <a:r>
+              <a:rPr lang="en-US" sz="2400" dirty="0">
+                <a:solidFill>
+                  <a:schemeClr val="tx2"/>
+                </a:solidFill>
+                <a:latin typeface="Helvetica" pitchFamily="2" charset="0"/>
+              </a:rPr>
+              <a:t>Do we always have complete knowledge about the world?</a:t>
+            </a:r>
+          </a:p>
+          <a:p>
+            <a:pPr marL="285750" indent="-285750">
+              <a:buFont typeface="Arial" panose="020B0604020202020204" pitchFamily="34" charset="0"/>
+              <a:buChar char="•"/>
+            </a:pPr>
+            <a:endParaRPr lang="en-US" sz="2400" dirty="0">
+              <a:solidFill>
+                <a:schemeClr val="tx2"/>
+              </a:solidFill>
+              <a:latin typeface="Helvetica" pitchFamily="2" charset="0"/>
+            </a:endParaRPr>
+          </a:p>
+          <a:p>
+            <a:pPr marL="285750" indent="-285750">
+              <a:buFont typeface="Arial" panose="020B0604020202020204" pitchFamily="34" charset="0"/>
+              <a:buChar char="•"/>
+            </a:pPr>
+            <a:r>
+              <a:rPr lang="en-US" sz="2400" dirty="0">
+                <a:solidFill>
+                  <a:schemeClr val="tx2"/>
+                </a:solidFill>
+                <a:latin typeface="Helvetica" pitchFamily="2" charset="0"/>
+              </a:rPr>
+              <a:t>Are our “facts” always precise?</a:t>
+            </a:r>
+          </a:p>
+          <a:p>
+            <a:pPr marL="285750" indent="-285750">
+              <a:buFont typeface="Arial" panose="020B0604020202020204" pitchFamily="34" charset="0"/>
+              <a:buChar char="•"/>
+            </a:pPr>
+            <a:endParaRPr lang="en-US" sz="2400" dirty="0">
+              <a:solidFill>
+                <a:schemeClr val="tx2"/>
+              </a:solidFill>
+              <a:latin typeface="Helvetica" pitchFamily="2" charset="0"/>
+            </a:endParaRPr>
+          </a:p>
+          <a:p>
+            <a:pPr marL="285750" indent="-285750">
+              <a:buFont typeface="Arial" panose="020B0604020202020204" pitchFamily="34" charset="0"/>
+              <a:buChar char="•"/>
+            </a:pPr>
+            <a:r>
+              <a:rPr lang="en-US" sz="2400" dirty="0">
+                <a:solidFill>
+                  <a:schemeClr val="tx2"/>
+                </a:solidFill>
+                <a:latin typeface="Helvetica" pitchFamily="2" charset="0"/>
+              </a:rPr>
+              <a:t>Logic can handle incomplete knowledge</a:t>
+            </a:r>
+          </a:p>
+          <a:p>
+            <a:pPr marL="285750" indent="-285750">
+              <a:buFont typeface="Arial" panose="020B0604020202020204" pitchFamily="34" charset="0"/>
+              <a:buChar char="•"/>
+            </a:pPr>
+            <a:endParaRPr lang="en-US" sz="2400" dirty="0">
+              <a:solidFill>
+                <a:schemeClr val="tx2"/>
+              </a:solidFill>
+              <a:latin typeface="Helvetica" pitchFamily="2" charset="0"/>
+            </a:endParaRPr>
+          </a:p>
+          <a:p>
+            <a:pPr marL="285750" indent="-285750">
+              <a:buFont typeface="Arial" panose="020B0604020202020204" pitchFamily="34" charset="0"/>
+              <a:buChar char="•"/>
+            </a:pPr>
+            <a:r>
+              <a:rPr lang="en-US" sz="2400" dirty="0">
+                <a:solidFill>
+                  <a:schemeClr val="tx2"/>
+                </a:solidFill>
+                <a:latin typeface="Helvetica" pitchFamily="2" charset="0"/>
+              </a:rPr>
+              <a:t>It cannot handle uncertain knowledge</a:t>
+            </a:r>
+            <a:endParaRPr lang="en-US" sz="3200" dirty="0">
+              <a:solidFill>
+                <a:schemeClr val="tx2"/>
+              </a:solidFill>
+              <a:latin typeface="Helvetica" pitchFamily="2" charset="0"/>
+            </a:endParaRPr>
           </a:p>
         </p:txBody>
       </p:sp>
       <p:sp>
         <p:nvSpPr>
-          <p:cNvPr id="4" name="Text Placeholder 3">
+          <p:cNvPr id="4" name="Slide Number Placeholder 3">
             <a:extLst>
               <a:ext uri="{FF2B5EF4-FFF2-40B4-BE49-F238E27FC236}">
-                <a16:creationId xmlns:a16="http://schemas.microsoft.com/office/drawing/2014/main" id="{A01EB055-0F82-6583-C82C-8FF0F4976EE6}"/>
+                <a16:creationId xmlns:a16="http://schemas.microsoft.com/office/drawing/2014/main" id="{FACEF18B-A327-DC8A-86F1-4986E13DF250}"/>
               </a:ext>
             </a:extLst>
           </p:cNvPr>
@@ -10627,7 +10194,7 @@
             <a:spLocks noGrp="1"/>
           </p:cNvSpPr>
           <p:nvPr>
-            <p:ph type="body" sz="quarter" idx="11"/>
+            <p:ph type="sldNum" sz="quarter" idx="12"/>
           </p:nvPr>
         </p:nvSpPr>
         <p:spPr/>
@@ -10635,14 +10202,19 @@
           <a:bodyPr/>
           <a:lstStyle/>
           <a:p>
-            <a:endParaRPr lang="en-US"/>
+            <a:fld id="{FE9C85F8-0BD3-7742-B238-5BE9A2749A8F}" type="slidenum">
+              <a:rPr lang="en-US" smtClean="0"/>
+              <a:pPr/>
+              <a:t>2</a:t>
+            </a:fld>
+            <a:endParaRPr lang="en-US" dirty="0"/>
           </a:p>
         </p:txBody>
       </p:sp>
     </p:spTree>
     <p:extLst>
       <p:ext uri="{BB962C8B-B14F-4D97-AF65-F5344CB8AC3E}">
-        <p14:creationId xmlns:p14="http://schemas.microsoft.com/office/powerpoint/2010/main" val="1861047447"/>
+        <p14:creationId xmlns:p14="http://schemas.microsoft.com/office/powerpoint/2010/main" val="1644579463"/>
       </p:ext>
     </p:extLst>
   </p:cSld>
@@ -10697,250 +10269,6 @@
           <a:p>
             <a:r>
               <a:rPr lang="en-US" dirty="0"/>
-              <a:t>Introduction to Probabilistic Reasoning</a:t>
-            </a:r>
-          </a:p>
-        </p:txBody>
-      </p:sp>
-      <p:sp>
-        <p:nvSpPr>
-          <p:cNvPr id="3" name="Text Placeholder 2">
-            <a:extLst>
-              <a:ext uri="{FF2B5EF4-FFF2-40B4-BE49-F238E27FC236}">
-                <a16:creationId xmlns:a16="http://schemas.microsoft.com/office/drawing/2014/main" id="{9B9575F1-7E0C-85E9-02FA-D94661C6B1BB}"/>
-              </a:ext>
-            </a:extLst>
-          </p:cNvPr>
-          <p:cNvSpPr>
-            <a:spLocks noGrp="1"/>
-          </p:cNvSpPr>
-          <p:nvPr>
-            <p:ph type="body" sz="quarter" idx="10"/>
-          </p:nvPr>
-        </p:nvSpPr>
-        <p:spPr/>
-        <p:txBody>
-          <a:bodyPr>
-            <a:normAutofit/>
-          </a:bodyPr>
-          <a:lstStyle/>
-          <a:p>
-            <a:pPr marL="285750" indent="-285750">
-              <a:buFont typeface="Arial" panose="020B0604020202020204" pitchFamily="34" charset="0"/>
-              <a:buChar char="•"/>
-            </a:pPr>
-            <a:r>
-              <a:rPr lang="en-US" sz="2400" dirty="0">
-                <a:solidFill>
-                  <a:schemeClr val="tx2"/>
-                </a:solidFill>
-              </a:rPr>
-              <a:t>Logic and Knowledge Graphs are about statements of fact</a:t>
-            </a:r>
-          </a:p>
-          <a:p>
-            <a:pPr marL="285750" indent="-285750">
-              <a:buFont typeface="Arial" panose="020B0604020202020204" pitchFamily="34" charset="0"/>
-              <a:buChar char="•"/>
-            </a:pPr>
-            <a:endParaRPr lang="en-US" sz="2400" dirty="0">
-              <a:solidFill>
-                <a:schemeClr val="tx2"/>
-              </a:solidFill>
-            </a:endParaRPr>
-          </a:p>
-          <a:p>
-            <a:pPr marL="285750" indent="-285750">
-              <a:buFont typeface="Arial" panose="020B0604020202020204" pitchFamily="34" charset="0"/>
-              <a:buChar char="•"/>
-            </a:pPr>
-            <a:r>
-              <a:rPr lang="en-US" sz="2400" dirty="0">
-                <a:solidFill>
-                  <a:schemeClr val="tx2"/>
-                </a:solidFill>
-                <a:latin typeface="Helvetica" pitchFamily="2" charset="0"/>
-              </a:rPr>
-              <a:t>Do we always have complete knowledge about the world?</a:t>
-            </a:r>
-          </a:p>
-          <a:p>
-            <a:pPr marL="285750" indent="-285750">
-              <a:buFont typeface="Arial" panose="020B0604020202020204" pitchFamily="34" charset="0"/>
-              <a:buChar char="•"/>
-            </a:pPr>
-            <a:endParaRPr lang="en-US" sz="2400" dirty="0">
-              <a:solidFill>
-                <a:schemeClr val="tx2"/>
-              </a:solidFill>
-              <a:latin typeface="Helvetica" pitchFamily="2" charset="0"/>
-            </a:endParaRPr>
-          </a:p>
-          <a:p>
-            <a:pPr marL="285750" indent="-285750">
-              <a:buFont typeface="Arial" panose="020B0604020202020204" pitchFamily="34" charset="0"/>
-              <a:buChar char="•"/>
-            </a:pPr>
-            <a:r>
-              <a:rPr lang="en-US" sz="2400" dirty="0">
-                <a:solidFill>
-                  <a:schemeClr val="tx2"/>
-                </a:solidFill>
-                <a:latin typeface="Helvetica" pitchFamily="2" charset="0"/>
-              </a:rPr>
-              <a:t>Are our “facts” always precise?</a:t>
-            </a:r>
-          </a:p>
-          <a:p>
-            <a:pPr marL="285750" indent="-285750">
-              <a:buFont typeface="Arial" panose="020B0604020202020204" pitchFamily="34" charset="0"/>
-              <a:buChar char="•"/>
-            </a:pPr>
-            <a:endParaRPr lang="en-US" sz="2400" dirty="0">
-              <a:solidFill>
-                <a:schemeClr val="tx2"/>
-              </a:solidFill>
-              <a:latin typeface="Helvetica" pitchFamily="2" charset="0"/>
-            </a:endParaRPr>
-          </a:p>
-          <a:p>
-            <a:pPr marL="285750" indent="-285750">
-              <a:buFont typeface="Arial" panose="020B0604020202020204" pitchFamily="34" charset="0"/>
-              <a:buChar char="•"/>
-            </a:pPr>
-            <a:r>
-              <a:rPr lang="en-US" sz="2400" dirty="0">
-                <a:solidFill>
-                  <a:schemeClr val="tx2"/>
-                </a:solidFill>
-                <a:latin typeface="Helvetica" pitchFamily="2" charset="0"/>
-              </a:rPr>
-              <a:t>Logic can handle incomplete knowledge</a:t>
-            </a:r>
-          </a:p>
-          <a:p>
-            <a:pPr marL="285750" indent="-285750">
-              <a:buFont typeface="Arial" panose="020B0604020202020204" pitchFamily="34" charset="0"/>
-              <a:buChar char="•"/>
-            </a:pPr>
-            <a:endParaRPr lang="en-US" sz="2400" dirty="0">
-              <a:solidFill>
-                <a:schemeClr val="tx2"/>
-              </a:solidFill>
-              <a:latin typeface="Helvetica" pitchFamily="2" charset="0"/>
-            </a:endParaRPr>
-          </a:p>
-          <a:p>
-            <a:pPr marL="285750" indent="-285750">
-              <a:buFont typeface="Arial" panose="020B0604020202020204" pitchFamily="34" charset="0"/>
-              <a:buChar char="•"/>
-            </a:pPr>
-            <a:r>
-              <a:rPr lang="en-US" sz="2400" dirty="0">
-                <a:solidFill>
-                  <a:schemeClr val="tx2"/>
-                </a:solidFill>
-                <a:latin typeface="Helvetica" pitchFamily="2" charset="0"/>
-              </a:rPr>
-              <a:t>It cannot handle uncertain knowledge</a:t>
-            </a:r>
-            <a:endParaRPr lang="en-US" sz="3200" dirty="0">
-              <a:solidFill>
-                <a:schemeClr val="tx2"/>
-              </a:solidFill>
-              <a:latin typeface="Helvetica" pitchFamily="2" charset="0"/>
-            </a:endParaRPr>
-          </a:p>
-        </p:txBody>
-      </p:sp>
-      <p:sp>
-        <p:nvSpPr>
-          <p:cNvPr id="4" name="Slide Number Placeholder 3">
-            <a:extLst>
-              <a:ext uri="{FF2B5EF4-FFF2-40B4-BE49-F238E27FC236}">
-                <a16:creationId xmlns:a16="http://schemas.microsoft.com/office/drawing/2014/main" id="{FACEF18B-A327-DC8A-86F1-4986E13DF250}"/>
-              </a:ext>
-            </a:extLst>
-          </p:cNvPr>
-          <p:cNvSpPr>
-            <a:spLocks noGrp="1"/>
-          </p:cNvSpPr>
-          <p:nvPr>
-            <p:ph type="sldNum" sz="quarter" idx="12"/>
-          </p:nvPr>
-        </p:nvSpPr>
-        <p:spPr/>
-        <p:txBody>
-          <a:bodyPr/>
-          <a:lstStyle/>
-          <a:p>
-            <a:fld id="{FE9C85F8-0BD3-7742-B238-5BE9A2749A8F}" type="slidenum">
-              <a:rPr lang="en-US" smtClean="0"/>
-              <a:pPr/>
-              <a:t>3</a:t>
-            </a:fld>
-            <a:endParaRPr lang="en-US" dirty="0"/>
-          </a:p>
-        </p:txBody>
-      </p:sp>
-    </p:spTree>
-    <p:extLst>
-      <p:ext uri="{BB962C8B-B14F-4D97-AF65-F5344CB8AC3E}">
-        <p14:creationId xmlns:p14="http://schemas.microsoft.com/office/powerpoint/2010/main" val="1644579463"/>
-      </p:ext>
-    </p:extLst>
-  </p:cSld>
-  <p:clrMapOvr>
-    <a:masterClrMapping/>
-  </p:clrMapOvr>
-</p:sld>
-</file>
-
-<file path=ppt/slides/slide4.xml><?xml version="1.0" encoding="utf-8"?>
-<p:sld xmlns:a="http://schemas.openxmlformats.org/drawingml/2006/main" xmlns:r="http://schemas.openxmlformats.org/officeDocument/2006/relationships" xmlns:p="http://schemas.openxmlformats.org/presentationml/2006/main">
-  <p:cSld>
-    <p:spTree>
-      <p:nvGrpSpPr>
-        <p:cNvPr id="1" name=""/>
-        <p:cNvGrpSpPr/>
-        <p:nvPr/>
-      </p:nvGrpSpPr>
-      <p:grpSpPr>
-        <a:xfrm>
-          <a:off x="0" y="0"/>
-          <a:ext cx="0" cy="0"/>
-          <a:chOff x="0" y="0"/>
-          <a:chExt cx="0" cy="0"/>
-        </a:xfrm>
-      </p:grpSpPr>
-      <p:sp>
-        <p:nvSpPr>
-          <p:cNvPr id="2" name="Title 1">
-            <a:extLst>
-              <a:ext uri="{FF2B5EF4-FFF2-40B4-BE49-F238E27FC236}">
-                <a16:creationId xmlns:a16="http://schemas.microsoft.com/office/drawing/2014/main" id="{348F3CE4-0F52-90C9-A39B-8038F1F2B8D4}"/>
-              </a:ext>
-            </a:extLst>
-          </p:cNvPr>
-          <p:cNvSpPr>
-            <a:spLocks noGrp="1"/>
-          </p:cNvSpPr>
-          <p:nvPr>
-            <p:ph type="title"/>
-          </p:nvPr>
-        </p:nvSpPr>
-        <p:spPr>
-          <a:xfrm>
-            <a:off x="838199" y="381419"/>
-            <a:ext cx="10969487" cy="632219"/>
-          </a:xfrm>
-        </p:spPr>
-        <p:txBody>
-          <a:bodyPr/>
-          <a:lstStyle/>
-          <a:p>
-            <a:r>
-              <a:rPr lang="en-US" dirty="0"/>
               <a:t>Recap</a:t>
             </a:r>
           </a:p>
@@ -11102,7 +10430,7 @@
             <a:fld id="{FE9C85F8-0BD3-7742-B238-5BE9A2749A8F}" type="slidenum">
               <a:rPr lang="en-US" smtClean="0"/>
               <a:pPr/>
-              <a:t>4</a:t>
+              <a:t>3</a:t>
             </a:fld>
             <a:endParaRPr lang="en-US" dirty="0"/>
           </a:p>
@@ -11121,7 +10449,7 @@
 </p:sld>
 </file>
 
-<file path=ppt/slides/slide5.xml><?xml version="1.0" encoding="utf-8"?>
+<file path=ppt/slides/slide4.xml><?xml version="1.0" encoding="utf-8"?>
 <p:sld xmlns:a="http://schemas.openxmlformats.org/drawingml/2006/main" xmlns:r="http://schemas.openxmlformats.org/officeDocument/2006/relationships" xmlns:p="http://schemas.openxmlformats.org/presentationml/2006/main">
   <p:cSld>
     <p:spTree>
@@ -11195,7 +10523,7 @@
             <a:fld id="{FE9C85F8-0BD3-7742-B238-5BE9A2749A8F}" type="slidenum">
               <a:rPr lang="en-US" smtClean="0"/>
               <a:pPr/>
-              <a:t>5</a:t>
+              <a:t>4</a:t>
             </a:fld>
             <a:endParaRPr lang="en-US" dirty="0"/>
           </a:p>
@@ -11226,8 +10554,8 @@
           </a:p>
         </p:txBody>
       </p:sp>
-      <mc:AlternateContent xmlns:mc="http://schemas.openxmlformats.org/markup-compatibility/2006">
-        <mc:Choice xmlns:p14="http://schemas.microsoft.com/office/powerpoint/2010/main" Requires="p14">
+      <mc:AlternateContent xmlns:mc="http://schemas.openxmlformats.org/markup-compatibility/2006" xmlns:p14="http://schemas.microsoft.com/office/powerpoint/2010/main">
+        <mc:Choice Requires="p14">
           <p:contentPart p14:bwMode="auto" r:id="rId3">
             <p14:nvContentPartPr>
               <p14:cNvPr id="3" name="Ink 2">
@@ -11246,7 +10574,7 @@
             </p14:xfrm>
           </p:contentPart>
         </mc:Choice>
-        <mc:Fallback>
+        <mc:Fallback xmlns="">
           <p:pic>
             <p:nvPicPr>
               <p:cNvPr id="3" name="Ink 2">
@@ -11290,7 +10618,7 @@
 </p:sld>
 </file>
 
-<file path=ppt/slides/slide6.xml><?xml version="1.0" encoding="utf-8"?>
+<file path=ppt/slides/slide5.xml><?xml version="1.0" encoding="utf-8"?>
 <p:sld xmlns:a="http://schemas.openxmlformats.org/drawingml/2006/main" xmlns:r="http://schemas.openxmlformats.org/officeDocument/2006/relationships" xmlns:p="http://schemas.openxmlformats.org/presentationml/2006/main">
   <p:cSld>
     <p:spTree>
@@ -11384,14 +10712,14 @@
             <a:fld id="{FE9C85F8-0BD3-7742-B238-5BE9A2749A8F}" type="slidenum">
               <a:rPr lang="en-US" smtClean="0"/>
               <a:pPr/>
-              <a:t>6</a:t>
+              <a:t>5</a:t>
             </a:fld>
             <a:endParaRPr lang="en-US" dirty="0"/>
           </a:p>
         </p:txBody>
       </p:sp>
-      <mc:AlternateContent xmlns:mc="http://schemas.openxmlformats.org/markup-compatibility/2006">
-        <mc:Choice xmlns:p14="http://schemas.microsoft.com/office/powerpoint/2010/main" Requires="p14">
+      <mc:AlternateContent xmlns:mc="http://schemas.openxmlformats.org/markup-compatibility/2006" xmlns:p14="http://schemas.microsoft.com/office/powerpoint/2010/main">
+        <mc:Choice Requires="p14">
           <p:contentPart p14:bwMode="auto" r:id="rId2">
             <p14:nvContentPartPr>
               <p14:cNvPr id="5" name="Ink 4">
@@ -11410,7 +10738,7 @@
             </p14:xfrm>
           </p:contentPart>
         </mc:Choice>
-        <mc:Fallback>
+        <mc:Fallback xmlns="">
           <p:pic>
             <p:nvPicPr>
               <p:cNvPr id="5" name="Ink 4">
@@ -11454,7 +10782,7 @@
 </p:sld>
 </file>
 
-<file path=ppt/slides/slide7.xml><?xml version="1.0" encoding="utf-8"?>
+<file path=ppt/slides/slide6.xml><?xml version="1.0" encoding="utf-8"?>
 <p:sld xmlns:a="http://schemas.openxmlformats.org/drawingml/2006/main" xmlns:r="http://schemas.openxmlformats.org/officeDocument/2006/relationships" xmlns:p="http://schemas.openxmlformats.org/presentationml/2006/main">
   <p:cSld>
     <p:spTree>
@@ -11553,14 +10881,14 @@
             <a:fld id="{FE9C85F8-0BD3-7742-B238-5BE9A2749A8F}" type="slidenum">
               <a:rPr lang="en-US" smtClean="0"/>
               <a:pPr/>
-              <a:t>7</a:t>
+              <a:t>6</a:t>
             </a:fld>
             <a:endParaRPr lang="en-US" dirty="0"/>
           </a:p>
         </p:txBody>
       </p:sp>
-      <mc:AlternateContent xmlns:mc="http://schemas.openxmlformats.org/markup-compatibility/2006">
-        <mc:Choice xmlns:p14="http://schemas.microsoft.com/office/powerpoint/2010/main" Requires="p14">
+      <mc:AlternateContent xmlns:mc="http://schemas.openxmlformats.org/markup-compatibility/2006" xmlns:p14="http://schemas.microsoft.com/office/powerpoint/2010/main">
+        <mc:Choice Requires="p14">
           <p:contentPart p14:bwMode="auto" r:id="rId2">
             <p14:nvContentPartPr>
               <p14:cNvPr id="5" name="Ink 4">
@@ -11579,7 +10907,7 @@
             </p14:xfrm>
           </p:contentPart>
         </mc:Choice>
-        <mc:Fallback>
+        <mc:Fallback xmlns="">
           <p:pic>
             <p:nvPicPr>
               <p:cNvPr id="5" name="Ink 4">
@@ -11623,7 +10951,7 @@
 </p:sld>
 </file>
 
-<file path=ppt/slides/slide8.xml><?xml version="1.0" encoding="utf-8"?>
+<file path=ppt/slides/slide7.xml><?xml version="1.0" encoding="utf-8"?>
 <p:sld xmlns:a="http://schemas.openxmlformats.org/drawingml/2006/main" xmlns:r="http://schemas.openxmlformats.org/officeDocument/2006/relationships" xmlns:p="http://schemas.openxmlformats.org/presentationml/2006/main">
   <p:cSld>
     <p:spTree>
@@ -11717,14 +11045,14 @@
             <a:fld id="{FE9C85F8-0BD3-7742-B238-5BE9A2749A8F}" type="slidenum">
               <a:rPr lang="en-US" smtClean="0"/>
               <a:pPr/>
-              <a:t>8</a:t>
+              <a:t>7</a:t>
             </a:fld>
             <a:endParaRPr lang="en-US" dirty="0"/>
           </a:p>
         </p:txBody>
       </p:sp>
-      <mc:AlternateContent xmlns:mc="http://schemas.openxmlformats.org/markup-compatibility/2006">
-        <mc:Choice xmlns:p14="http://schemas.microsoft.com/office/powerpoint/2010/main" Requires="p14">
+      <mc:AlternateContent xmlns:mc="http://schemas.openxmlformats.org/markup-compatibility/2006" xmlns:p14="http://schemas.microsoft.com/office/powerpoint/2010/main">
+        <mc:Choice Requires="p14">
           <p:contentPart p14:bwMode="auto" r:id="rId2">
             <p14:nvContentPartPr>
               <p14:cNvPr id="5" name="Ink 4">
@@ -11743,7 +11071,7 @@
             </p14:xfrm>
           </p:contentPart>
         </mc:Choice>
-        <mc:Fallback>
+        <mc:Fallback xmlns="">
           <p:pic>
             <p:nvPicPr>
               <p:cNvPr id="5" name="Ink 4">
@@ -11787,7 +11115,7 @@
 </p:sld>
 </file>
 
-<file path=ppt/slides/slide9.xml><?xml version="1.0" encoding="utf-8"?>
+<file path=ppt/slides/slide8.xml><?xml version="1.0" encoding="utf-8"?>
 <p:sld xmlns:a="http://schemas.openxmlformats.org/drawingml/2006/main" xmlns:r="http://schemas.openxmlformats.org/officeDocument/2006/relationships" xmlns:p="http://schemas.openxmlformats.org/presentationml/2006/main">
   <p:cSld>
     <p:spTree>
@@ -11881,14 +11209,14 @@
             <a:fld id="{FE9C85F8-0BD3-7742-B238-5BE9A2749A8F}" type="slidenum">
               <a:rPr lang="en-US" smtClean="0"/>
               <a:pPr/>
-              <a:t>9</a:t>
+              <a:t>8</a:t>
             </a:fld>
             <a:endParaRPr lang="en-US" dirty="0"/>
           </a:p>
         </p:txBody>
       </p:sp>
-      <mc:AlternateContent xmlns:mc="http://schemas.openxmlformats.org/markup-compatibility/2006">
-        <mc:Choice xmlns:p14="http://schemas.microsoft.com/office/powerpoint/2010/main" Requires="p14">
+      <mc:AlternateContent xmlns:mc="http://schemas.openxmlformats.org/markup-compatibility/2006" xmlns:p14="http://schemas.microsoft.com/office/powerpoint/2010/main">
+        <mc:Choice Requires="p14">
           <p:contentPart p14:bwMode="auto" r:id="rId2">
             <p14:nvContentPartPr>
               <p14:cNvPr id="5" name="Ink 4">
@@ -11907,7 +11235,7 @@
             </p14:xfrm>
           </p:contentPart>
         </mc:Choice>
-        <mc:Fallback>
+        <mc:Fallback xmlns="">
           <p:pic>
             <p:nvPicPr>
               <p:cNvPr id="5" name="Ink 4">
@@ -11942,6 +11270,170 @@
     <p:extLst>
       <p:ext uri="{BB962C8B-B14F-4D97-AF65-F5344CB8AC3E}">
         <p14:creationId xmlns:p14="http://schemas.microsoft.com/office/powerpoint/2010/main" val="528797184"/>
+      </p:ext>
+    </p:extLst>
+  </p:cSld>
+  <p:clrMapOvr>
+    <a:masterClrMapping/>
+  </p:clrMapOvr>
+</p:sld>
+</file>
+
+<file path=ppt/slides/slide9.xml><?xml version="1.0" encoding="utf-8"?>
+<p:sld xmlns:a="http://schemas.openxmlformats.org/drawingml/2006/main" xmlns:r="http://schemas.openxmlformats.org/officeDocument/2006/relationships" xmlns:p="http://schemas.openxmlformats.org/presentationml/2006/main">
+  <p:cSld>
+    <p:spTree>
+      <p:nvGrpSpPr>
+        <p:cNvPr id="1" name=""/>
+        <p:cNvGrpSpPr/>
+        <p:nvPr/>
+      </p:nvGrpSpPr>
+      <p:grpSpPr>
+        <a:xfrm>
+          <a:off x="0" y="0"/>
+          <a:ext cx="0" cy="0"/>
+          <a:chOff x="0" y="0"/>
+          <a:chExt cx="0" cy="0"/>
+        </a:xfrm>
+      </p:grpSpPr>
+      <p:sp>
+        <p:nvSpPr>
+          <p:cNvPr id="2" name="Title 1">
+            <a:extLst>
+              <a:ext uri="{FF2B5EF4-FFF2-40B4-BE49-F238E27FC236}">
+                <a16:creationId xmlns:a16="http://schemas.microsoft.com/office/drawing/2014/main" id="{CB1FE586-309D-8744-0C5B-B06AF8DE16AC}"/>
+              </a:ext>
+            </a:extLst>
+          </p:cNvPr>
+          <p:cNvSpPr>
+            <a:spLocks noGrp="1"/>
+          </p:cNvSpPr>
+          <p:nvPr>
+            <p:ph type="title"/>
+          </p:nvPr>
+        </p:nvSpPr>
+        <p:spPr/>
+        <p:txBody>
+          <a:bodyPr/>
+          <a:lstStyle/>
+          <a:p>
+            <a:r>
+              <a:rPr lang="en-US" dirty="0"/>
+              <a:t>Bayes Rule</a:t>
+            </a:r>
+          </a:p>
+        </p:txBody>
+      </p:sp>
+      <p:sp>
+        <p:nvSpPr>
+          <p:cNvPr id="3" name="Text Placeholder 2">
+            <a:extLst>
+              <a:ext uri="{FF2B5EF4-FFF2-40B4-BE49-F238E27FC236}">
+                <a16:creationId xmlns:a16="http://schemas.microsoft.com/office/drawing/2014/main" id="{A09C2D87-C1F4-9022-AD15-FB19642BEBB5}"/>
+              </a:ext>
+            </a:extLst>
+          </p:cNvPr>
+          <p:cNvSpPr>
+            <a:spLocks noGrp="1"/>
+          </p:cNvSpPr>
+          <p:nvPr>
+            <p:ph type="body" sz="quarter" idx="10"/>
+          </p:nvPr>
+        </p:nvSpPr>
+        <p:spPr/>
+        <p:txBody>
+          <a:bodyPr/>
+          <a:lstStyle/>
+          <a:p>
+            <a:endParaRPr lang="en-US" dirty="0"/>
+          </a:p>
+        </p:txBody>
+      </p:sp>
+      <p:sp>
+        <p:nvSpPr>
+          <p:cNvPr id="4" name="Slide Number Placeholder 3">
+            <a:extLst>
+              <a:ext uri="{FF2B5EF4-FFF2-40B4-BE49-F238E27FC236}">
+                <a16:creationId xmlns:a16="http://schemas.microsoft.com/office/drawing/2014/main" id="{BFD39F3B-2DCB-DEB2-0222-34AF3B45462F}"/>
+              </a:ext>
+            </a:extLst>
+          </p:cNvPr>
+          <p:cNvSpPr>
+            <a:spLocks noGrp="1"/>
+          </p:cNvSpPr>
+          <p:nvPr>
+            <p:ph type="sldNum" sz="quarter" idx="12"/>
+          </p:nvPr>
+        </p:nvSpPr>
+        <p:spPr/>
+        <p:txBody>
+          <a:bodyPr/>
+          <a:lstStyle/>
+          <a:p>
+            <a:fld id="{FE9C85F8-0BD3-7742-B238-5BE9A2749A8F}" type="slidenum">
+              <a:rPr lang="en-US" smtClean="0"/>
+              <a:pPr/>
+              <a:t>9</a:t>
+            </a:fld>
+            <a:endParaRPr lang="en-US" dirty="0"/>
+          </a:p>
+        </p:txBody>
+      </p:sp>
+      <mc:AlternateContent xmlns:mc="http://schemas.openxmlformats.org/markup-compatibility/2006" xmlns:p14="http://schemas.microsoft.com/office/powerpoint/2010/main">
+        <mc:Choice Requires="p14">
+          <p:contentPart p14:bwMode="auto" r:id="rId2">
+            <p14:nvContentPartPr>
+              <p14:cNvPr id="5" name="Ink 4">
+                <a:extLst>
+                  <a:ext uri="{FF2B5EF4-FFF2-40B4-BE49-F238E27FC236}">
+                    <a16:creationId xmlns:a16="http://schemas.microsoft.com/office/drawing/2014/main" id="{50E4995C-95F0-54EA-EB36-A5B2F5038B7E}"/>
+                  </a:ext>
+                </a:extLst>
+              </p14:cNvPr>
+              <p14:cNvContentPartPr/>
+              <p14:nvPr/>
+            </p14:nvContentPartPr>
+            <p14:xfrm>
+              <a:off x="679320" y="1276200"/>
+              <a:ext cx="10510200" cy="5382720"/>
+            </p14:xfrm>
+          </p:contentPart>
+        </mc:Choice>
+        <mc:Fallback xmlns="">
+          <p:pic>
+            <p:nvPicPr>
+              <p:cNvPr id="5" name="Ink 4">
+                <a:extLst>
+                  <a:ext uri="{FF2B5EF4-FFF2-40B4-BE49-F238E27FC236}">
+                    <a16:creationId xmlns:a16="http://schemas.microsoft.com/office/drawing/2014/main" id="{50E4995C-95F0-54EA-EB36-A5B2F5038B7E}"/>
+                  </a:ext>
+                </a:extLst>
+              </p:cNvPr>
+              <p:cNvPicPr/>
+              <p:nvPr/>
+            </p:nvPicPr>
+            <p:blipFill>
+              <a:blip r:embed="rId3"/>
+              <a:stretch>
+                <a:fillRect/>
+              </a:stretch>
+            </p:blipFill>
+            <p:spPr>
+              <a:xfrm>
+                <a:off x="663120" y="1260000"/>
+                <a:ext cx="10542600" cy="5420520"/>
+              </a:xfrm>
+              <a:prstGeom prst="rect">
+                <a:avLst/>
+              </a:prstGeom>
+            </p:spPr>
+          </p:pic>
+        </mc:Fallback>
+      </mc:AlternateContent>
+    </p:spTree>
+    <p:extLst>
+      <p:ext uri="{BB962C8B-B14F-4D97-AF65-F5344CB8AC3E}">
+        <p14:creationId xmlns:p14="http://schemas.microsoft.com/office/powerpoint/2010/main" val="2465979426"/>
       </p:ext>
     </p:extLst>
   </p:cSld>

</xml_diff>